<commit_message>
docs: deck uses absolute root error, run-correct size ratios and the fix-vs-control cost (final check pending)
Co-Authored-By: Claude Opus 5.5 <noreply@anthropic.com>
Claude-Session: https://claude.ai/code/session_016LhpG4kT7Z7ppxbG4TW5S9
</commit_message>
<xml_diff>
--- a/docs/supervisor_update_2026-10-16.pptx
+++ b/docs/supervisor_update_2026-10-16.pptx
@@ -121,7 +121,7 @@
   <p:extLst>
     <p:ext uri="{521415D9-36F7-43E2-AB2F-B90AF26B5E84}">
       <p14:sectionLst xmlns:p14="http://schemas.microsoft.com/office/powerpoint/2010/main">
-        <p14:section name="Overview" id="{26521b96-4ffa-dd44-1c90-8aaf95ef36b4}">
+        <p14:section name="Overview" id="{011ac6ad-d168-f72e-c8a6-5e09215fe341}">
           <p14:sldIdLst>
             <p14:sldId id="256"/>
             <p14:sldId id="257"/>
@@ -129,21 +129,21 @@
             <p14:sldId id="259"/>
           </p14:sldIdLst>
         </p14:section>
-        <p14:section name="Findings" id="{de024711-7e90-87ce-bfee-28bd698646f4}">
+        <p14:section name="Findings" id="{eb439692-77bf-eb95-4cc7-5922b8ea262a}">
           <p14:sldIdLst>
             <p14:sldId id="260"/>
             <p14:sldId id="261"/>
             <p14:sldId id="262"/>
           </p14:sldIdLst>
         </p14:section>
-        <p14:section name="Bug" id="{9b3fb9db-4681-d2ed-1144-a934ce8e7b1e}">
+        <p14:section name="Bug" id="{209c6b04-c928-b23d-978c-68147d55c63a}">
           <p14:sldIdLst>
             <p14:sldId id="263"/>
             <p14:sldId id="264"/>
             <p14:sldId id="265"/>
           </p14:sldIdLst>
         </p14:section>
-        <p14:section name="Next" id="{044b9324-fb2b-7df7-7332-88adf2d9e751}">
+        <p14:section name="Next" id="{e4ab9d55-57b6-c468-18bf-d518cc113d96}">
           <p14:sldIdLst>
             <p14:sldId id="266"/>
             <p14:sldId id="267"/>
@@ -151,7 +151,7 @@
             <p14:sldId id="269"/>
           </p14:sldIdLst>
         </p14:section>
-        <p14:section name="Appendix" id="{c03c02c6-5e4b-66f0-f675-3e248793b042}">
+        <p14:section name="Appendix" id="{5d03344e-044c-2ec1-6ab2-59303d802763}">
           <p14:sldIdLst>
             <p14:sldId id="270"/>
           </p14:sldIdLst>
@@ -648,7 +648,7 @@
           <a:p>
             <a:r>
               <a:rPr lang="en-US" dirty="0"/>
-              <a:t>The fix is one switch: build the training targets at the head, the joint the model anchors. I compared it with a control run that has the same schedule, the switch off and the normal depth weight. In the slope row, 1 means perfect and 0 means everyone gets the same depth. After 10 epochs the head lands within 8 to 9 pixels on average, against 64 for the control; that is expected, because the target moved to the head. The depth error is nearly halved. The control does not improve; it drifts slightly worse, to 1.30 metres. With the depth loss five times stronger, depth error goes from 1.08 to 0.39 metres, and bodies are 84 percent of their true size instead of 63. The remaining shrinkage now shows at the pelvis, 31 to 38 pixels off. But the slope stays at about 0.4: near and far people still get almost the same depth. The stronger-loss runs have no control with the same weight, so that part is read against the plain fix. My best guess is that the model pulls everyone toward a typical training distance, about 2.5 to 2.8 metres, while the holdout people stand nearer, about 1.9 metres. The cost: in every fix run PVE is about 3 millimetres above the control and 4 to 5 above v5, and recall is 2 to 3 points below v5, or 1.6 to 2.4 below the control. A single pilot cannot resolve differences this small, so a small cost is not ruled out. Part of the recall drop may be a counting effect: the test counts people whose pelvis is visible, while training's own head-based count gives 92 to 94 percent. That is not tested. The run with the depth loss twenty times stronger for 10 epochs has no result yet, so I quote no number for it.</a:t>
+              <a:t>The fix is one switch, gt_center_joint person_center: build the training targets at the head, the joint the model anchors. Each fix run has a control with the same schedule and the switch off; the stronger-loss runs have no control at the same weight. I report the 3D root error. The mean signed depth offset fell from 1.08 to 0.39 metres, but after the fix near people are too far and far people too near, and these cancel in that mean, so it flatters the fix. The head now lands within about 8 pixels, as expected, because the target moved to the head. With the depth loss five times stronger for 10 epochs, the root error falls from 1.21 to 0.54 metres and bodies are drawn at 84 percent of their true size; twenty times for 2 epochs ties with it, and the controls stay at 1.11 to 1.44. But the slope stays near 0.4: predictions are pulled toward about 2.5 metres, and why the model cannot separate near from far, I do not know. Every fix run is worse than its control in PVE and recall, and the pelvis 2D error got worse too. Each difference is inside pilot noise, but all point the same way, so I count it as a likely cost. The twenty-times 10-epoch run has no result yet.</a:t>
             </a:r>
             <a:endParaRPr lang="en-US" dirty="0"/>
           </a:p>
@@ -736,7 +736,7 @@
           <a:p>
             <a:r>
               <a:rPr lang="en-US" dirty="0"/>
-              <a:t>All four experiments are done. Each ran next to a control with the main switch off, and all are evaluated on the same 100-image holdout and the same manifest, with helper bones masked. The stronger age loss and the stronger depth loss were not separately controlled: both children arms used the same age and height weights, and the depth runs at five and twenty times have no control at the same weight. Depth: the switch alone nearly halves the depth error; with the stronger depth loss it reaches 0.39 metres and a size of 0.84. But the slope is stuck, and PVE did not recover: 74.8 against 70.5. Children, neck and fingers: no measurable effect. The neck loss gave 11.3 degrees of head error, which passes the rule of below 12, but the two control runs gave 11.7 and 13.6, so that is inside the noise, and its PVE and recall guard failed. One warning: there is no fixed random seed, and two runs with identical settings differed by 7.6 millimetres PVE and 1.9 degrees of head error. So one pilot can only detect a difference of about 10 millimetres PVE, 3 degrees of head error or 2 points of recall. Restarting the fine-tune alone costs about 2.4 millimetres. A 2-epoch pilot trains in about 12 minutes, a 10-epoch run in about one hour. No new architecture, because the diagnostics do not justify one.</a:t>
+              <a:t>All four experiments are done. Each ran next to a control with the main switch off, on the same 100-image holdout and manifest, with helper bones masked. The stronger age loss and the stronger depth loss were not separately controlled: both children arms used the same age and height weights, and the depth runs at five and twenty times have no control at the same weight. Depth: by its own success rule the experiment failed. The slope did not move toward 1: it is 0.30 with the switch alone and 0.38 with the five-times depth loss. PVE is 74.8, against 72.2 for the control and 70.5 for v5. What clearly improved is outside the rule: the root error went from 1.21 to 0.54 metres and the drawn size from 0.63 to 0.84. I say that openly instead of changing the rule afterwards. Children, neck and fingers: no measurable effect. The neck loss gave 11.3 degrees of head error, which passes the rule of below 12, but the two controls gave 11.7 and 13.6, so that is inside the noise, and its PVE and recall guard failed. There is no fixed random seed: two identical runs differed by 7.6 millimetres PVE and 1.9 degrees of head error, so one pilot only detects about 10 millimetres, 3 degrees or 2 recall points. Restarting the fine-tune alone costs about 2.4 millimetres. A 2-epoch pilot trains in about 12 minutes, a 10-epoch run in about one hour. No new architecture, because the diagnostics do not justify one.</a:t>
             </a:r>
             <a:endParaRPr lang="en-US" dirty="0"/>
           </a:p>
@@ -824,7 +824,7 @@
           <a:p>
             <a:r>
               <a:rPr lang="en-US" dirty="0"/>
-              <a:t>Some corrections are already in. The headline AnnyOne number is 70.5 millimetres, measured with the helper bones masked as in the demos; the 74.3 in the thesis draft came from the unmasked evaluation. The demos now say that the fingers are the rest pose. The text no longer blames the rig. The Known-defects section in the README documents the depth bug, but its neck part still tells last week's story, that the long neck comes from weak supervision and from the depth bug. I will correct that, and the same text in the findings and handover documents. The repository is reorganised with everything scripted, so any of these numbers can be produced again.</a:t>
+              <a:t>Some corrections are already in. The headline AnnyOne number is 70.5 millimetres, measured with the helper bones masked, as in the demos. That is the evaluation setting V1, not the demo's own number: the demo setting gives 68.5 at a lower recall. The 74.3 in the thesis draft came from the unmasked evaluation. The demos now say that the fingers are the rest pose. The text no longer blames the rig. The Known-defects section in the README documents the depth bug. But the README, the findings and the handover documents still carry last week's neck story, that the long neck comes from weak supervision and from the depth bug, and some old depth wording, for example that the overlays look wrong and that no improvement is claimed yet. I will correct them this week. The repository is reorganised with everything scripted, so any of these numbers can be produced again.</a:t>
             </a:r>
             <a:endParaRPr lang="en-US" dirty="0"/>
           </a:p>
@@ -912,7 +912,7 @@
           <a:p>
             <a:r>
               <a:rPr lang="en-US" dirty="0"/>
-              <a:t>Six things are still open. First, why the v5 models are stuck on the neck. The next test is the error of each neck bone, split into twist and swing, an error on the neck skin only, and a trace of v3, trained before the neck boost, to see when the offset appeared. Second, why the depth slope stays near 0.4. The pull toward the typical training depth is only my guess; I will check whether the holdout depths match training, because the holdout is the last 100 images, not a random draw. Third, the cost of the depth fix: I will recount recall over people whose head is visible, measure the fix on 3DPW, and report the root depth error next to PVE in the thesis, because PVE cannot see placement. Fourth, pilot noise: I will fix the random seed or repeat the key run. Fifth, people very close to the camera who fill much of the image are missed by both the old and the fixed model. That is a separate detection problem. Sixth, the run with the depth loss twenty times stronger for 10 epochs has no result yet, so I do not quote any number for it.</a:t>
+              <a:t>Six things are still open. First, the neck: the error of each neck bone, split into twist and swing, an error on the neck skin only, and traces of checkpoint 299 and of v3, to see when the offset appeared. Second, the depth slope: why near and far are not separated is unknown. The training depths so far come from small samples, batch means of about 2.5 to 3.2 metres, so I will measure them properly, and measure the fix run's slope on training images; for v5 it was just as low there. Third, the cost of the fix: paired PVE on the same people, recall over people whose head is visible, the fix on 3DPW, and the root error next to PVE in the thesis. The twenty-times 10-epoch run has no result yet. Fourth, pilot noise: fix the seed or repeat the key run. Fifth, people very close to the camera: both models miss them in 4 of the 12 rendered images; likely a detection problem, not yet counted. Sixth, children and fingers: one 2-epoch test is not enough to close them. Next is a 10-epoch balanced-sampler run, and for the fingers training on larger hand crops. If those show nothing too, both go into the thesis as limitations.</a:t>
             </a:r>
             <a:endParaRPr lang="en-US" dirty="0"/>
           </a:p>
@@ -1000,7 +1000,7 @@
           <a:p>
             <a:r>
               <a:rPr lang="en-US" dirty="0"/>
-              <a:t>What is measured: the failures are not rig or decoding problems. A training-target bug puts people too far away in v5, v9 and v10; in v5 it is every one of the 222 holdout people. The fix brings the bodies much closer to their true size, but near and far people are still not separated well, and PVE and recall may be slightly worse. Test-time magnification does not help the fingers. In a short fine-tune, more synthetic children did not help on real photos. The neck is stuck in the v5 models, but v10 learns it, so the cause is still open. What I do not claim: any improvement in the neck, the fingers or the children. My question: should I fine-tune v9, our best model on 3DPW, with the corrected targets and the depth loss five times stronger, before the thesis numbers are final? That is a 10-epoch fine-tune like the pilots, about one hour of training. I expect bodies near their true size, at a possible cost of 3 to 5 millimetres PVE and 2 to 3 points of recall, and I do not know the effect on 3DPW yet. On the AnnyOne holdout v9 is not the best, 77.0 against 70.5 millimetres.</a:t>
+              <a:t>What is measured: the failures are not rig or decoding problems. A training-target bug puts people too far away in v5, v9 and v10; in v5 it is all 222 holdout people. The fix draws the bodies much closer to their true size, but near and far are still not separated well, and it likely costs 3 to 5 millimetres PVE and about 2 points of recall: each run alone is inside the noise, but all point the same way. I do not claim any improvement in the neck, the fingers or the children. My question: should I fine-tune v9, our best model on 3DPW, with the corrected targets and the depth loss five times stronger, before the thesis numbers are final? That is about one hour of training. From v5 I expect a drawn size of about 0.84 and a root error of about half a metre. Five, not twenty, because the twenty-times 10-epoch run has no result yet. A v9 fine-tune keeps the stuck neck; v10 learns the neck but has worse shoulders and arms. Either fine-tune should also mask the 3DPW finger labels, which are set to the rest pose, with mask_3dpw_hands. The ViT-S students use the same training code and are probably affected too; not measured. On the AnnyOne holdout v9 is not the best: 77.0 against 70.5.</a:t>
             </a:r>
             <a:endParaRPr lang="en-US" dirty="0"/>
           </a:p>
@@ -1088,7 +1088,7 @@
           <a:p>
             <a:r>
               <a:rPr lang="en-US" dirty="0"/>
-              <a:t>A second holdout example, in case there is a question. Before the fix the boy's real head sticks out above a shrunken mesh that floats. After the fix the mesh has his height. Here the fixed mesh is a little larger than the ground truth, so I do not call it an exact fit.</a:t>
+              <a:t>A second holdout example, in case there is a question. Before the fix the boy's real head sticks out above a shrunken mesh that floats. After the fix the mesh is close to his height, slightly larger; the after mesh is cut off at the bottom of the image, so I cannot measure its full height. Here the fixed mesh is a little larger and wider than the ground truth, so I do not call it an exact fit. The two large people in front have no ground-truth mesh either, so they are not counted as misses.</a:t>
             </a:r>
             <a:endParaRPr lang="en-US" dirty="0"/>
           </a:p>
@@ -1176,7 +1176,7 @@
           <a:p>
             <a:r>
               <a:rPr lang="en-US" dirty="0"/>
-              <a:t>These are the three failures we discussed last time. Until this week they were explained by guesses: a rig problem, too few pixels on the hands, or a shape head that does not learn age. None of these guesses had been tested on its own. That is what I did first. The last line on each card is what this week showed; the details follow.</a:t>
+              <a:t>These are the three failures we discussed last time. Until this week they were explained by guesses: a rig problem, too few pixels on the hands, or a shape head that does not learn age. None of these guesses had been tested on its own. That is what I did first. The last line on each card is what this week showed; the details follow. For the neck, I found a fixed rotation error in the v5 models, but I have not yet shown that it causes the look.</a:t>
             </a:r>
             <a:endParaRPr lang="en-US" dirty="0"/>
           </a:p>
@@ -1352,7 +1352,7 @@
           <a:p>
             <a:r>
               <a:rPr lang="en-US" dirty="0"/>
-              <a:t>This slide changes the story. The rig, the decoding and the body model are correct, and gradients reach every output. The overfit test shows the optimiser works for shape and 3D joints: on 40 training images the error falls by 36 percent. But the rotation loss barely moves there, from 44.6 to 40.8, which fits the stuck neck on the next slide. So the three failures are not rig or decoding problems, which is how the thesis described them until now, but training can still get stuck. One caveat on the ground-truth check: people who fill the frame lose joints at the image border. That is truncation, not a decoding error.</a:t>
+              <a:t>This slide changes the story. The rig, the decoding and the body model are correct, and gradients reach every bone and every shape output. Only two of the three camera outputs are unused and get no gradient. The overfit test shows the optimiser works for shape and 3D joints: on 40 training images the error falls by 36 percent. It has two warnings. First, even while the images were memorised, the translation loss and the 2D losses went up, from 1.67 to 1.89 and from 58 to 75. The network could not satisfy the position targets and the 2D projection at the same time. That was probably the first sign of the depth bug on slide 8; I have not repeated the overfit test with the fix. Second, the rotation loss barely moved, from 44.6 to 40.8. That is a sum over all 75 bones, so it does not isolate the neck; it may be related to the stuck neck on the next slide, but that is a guess. So the three failures are not rig or decoding problems, which is how the thesis described them until now, but training can still get stuck. One caveat on the ground-truth check: people who fill the frame lose joints at the image border. That is truncation, not a decoding error.</a:t>
             </a:r>
             <a:endParaRPr lang="en-US" dirty="0"/>
           </a:p>
@@ -1440,7 +1440,7 @@
           <a:p>
             <a:r>
               <a:rPr lang="en-US" dirty="0"/>
-              <a:t>The neck length is right, 99 percent of the truth. The problem is the rotation of the neck bones. In v5, in v9 and in all six children, neck and finger pilots, the three neck bones are on average 63 degrees off, and head and jaw together average 90 degrees. For v5 I checked every person: the offset is the same, plus or minus about 1.5 degrees, so it is fixed, not noise. The depth runs were not measured for this. Even 149 thousand more training steps in v9 did not change it. v10, which trained its heads from scratch, gets these bones right: 5 and 4 degrees. So the same loss can teach the neck. But v10 is not the answer: its shoulders are 50 degrees off, its arms 36, and its fingers are worse too. v10 also differs from v5 in three ways: it never had the four-times neck boost, its heads started fresh, and it saw 3DPW from the start. So I cannot yet say which of these matters, and large fixed offsets may simply land in different bones in different runs. I do not know the cause yet. My best guess is that the rotation loss compares the matrix numbers one by one and can get stuck near a 180-degree flip. 62.7 is a mean over three bones: one bone flipped by about 180 degrees and two almost right would give it. 89.5 is the mean of head and jaw: one of them flipped would give it. That fits, but I have not tested it. An idea that the rotation outputs were frozen was checked and is ruled out. The head still points roughly the right way, 12 degrees off. Last week I said the long-neck look comes from the depth bug. That is wrong: the neck montage and the real-photo demos place each body from its detection box, so the depth bug cannot reach them. It is likely, but not shown, that this offset is what makes the necks look wrong. v10's neck looks right in the demo montage, but that is one photo, and the head-neck surface error and the head direction are about the same for v5 and v10. The head-neck error cannot see the neck anyway, because 91 percent of its vertices are on the head. The next test is the error of each neck bone, split into twist and swing, an error on the neck skin only, and a trace of v3, which was trained before the neck boost, to see when the offset appeared.</a:t>
+              <a:t>The neck length is right, 99 percent of the truth, and with the true shape it is exact. The problem is the rotation of each neck bone relative to its parent. In v5, v9 and all six pilot runs, the three neck bones are on average 63 degrees off, head and jaw 90. In v5 that is the same for every person, within about 1.5 degrees: a fixed offset, not noise. 150 thousand more steps in v9 did not change it, and neither did a pilot that gave head and neck a third of the rotation loss. v10 gets these bones right, 5 and 4 degrees, so the loss can teach the neck, but v10 is worse elsewhere. Its history differs: v5 first trained on a frozen backbone with the helper bones unmasked; masking and the neck boost came later. The head points 12 degrees off on the holdout, 8.6 on the held-out test cases and about 20 on the 40 training test cases. I do not know the cause. My guess: the loss compares rotation matrices number by number and can stick near a 180-degree flip; a neck bone and the head flipped about the same axis would cancel, so the head can still point within 12 degrees. The depth bug cannot cause the neck look: the demos place each body from its detection box.</a:t>
             </a:r>
             <a:endParaRPr lang="en-US" dirty="0"/>
           </a:p>
@@ -1528,7 +1528,7 @@
           <a:p>
             <a:r>
               <a:rPr lang="en-US" dirty="0"/>
-              <a:t>With predicted fingers the error is 17.3 degrees. With the fingers simply left in the rest pose it is 15.1. So the hand prediction is worse than no prediction, which is why the demos zero the fingers and now say so. Hands are small: about two tokens at 672 pixels. I cropped around the person at test time, without retraining. That magnifies the hands by 1.6 times on median, and by 2.5 times or more for a quarter of the people. The finger error does not change: 17.2 against 17.3, and from 17.7 to 17.5 for the most magnified quarter. The body error nearly doubles on these crops, because the model never saw such a camera in training. So test-time magnification does not help; a model trained on larger hands is not tested. A rebalanced loss also changed nothing: 17.5 against 17.4 for its control. That loss cut the hands' share of the rotation loss from about 70 to 33 percent, so it does not test giving the fingers more weight; the earlier four-times hand boost did not help either. My best guess is supervision or model capacity, but that is not tested.</a:t>
+              <a:t>With predicted fingers the error is 17.3 degrees. With the fingers simply left in the rest pose it is 15.1. So the hand prediction is worse than no prediction, which is why the demos zero the fingers and now say so. Hands are small: about two tokens at 672 pixels. I cropped around the person at test time, without retraining. Per person that magnifies the hands by 1.6 times on median, and by 2.5 times or more for a quarter of the people; 26 percent of the people are not magnified at all. The table compares median hand sizes, so it shows a slightly larger factor. The finger error does not change: 17.2 against 17.3, and from 17.7 to 17.5 for the most magnified quarter. The body error nearly doubles on these crops, because the model never saw such a camera in training. So test-time magnification does not help; a model trained on larger hands is not tested. A rebalanced loss also changed nothing: 17.5 against 17.4 for its control. That loss cut the hands' share of the rotation loss from about 70 percent, which includes the four-times hand boost, to 33 percent; without the boost the share would be 40. So it does not test giving the fingers more weight, and the earlier four-times hand boost did not help either. My best guess is supervision or model capacity, but that is not tested.</a:t>
             </a:r>
             <a:endParaRPr lang="en-US" dirty="0"/>
           </a:p>
@@ -1616,7 +1616,7 @@
           <a:p>
             <a:r>
               <a:rPr lang="en-US" dirty="0"/>
-              <a:t>I checked in the code that the shape head is complete: all eleven shape values go into the body model and are trained, with no adult default. The model can make a child: for the youngest training people it predicts age 0.10 for a true 0.015. On Anny's age scale that is about 4 years instead of about 1.5, so too old but still clearly a child. The ten children in the training manifest also come out too old, by 0.078 on average. Only 2 percent of training people are children, so I tried a sampler that shows about 10 percent. In a 2-epoch fine-tune nothing changed, not for the training children and not on real photos, where five small people still get an adult age of about 0.6, which is about 22 years. That is a short run on few people, so it shows no effect, not that there can be none. My best guess is a gap between synthetic and real images, but that is not tested. There are no labelled real children, and the 3DPW labels fix age at one adult value, so this is a limitation for the thesis, not a fix for this week. The holdout has no children, so every synthetic child number is in-sample. The years assume Anny's default age scale.</a:t>
+              <a:t>I checked in the code that the shape head is complete: all eleven shape values go into the body model and are trained, with no adult default. The model can make a child: for the youngest training people it predicts age 0.10 for a true 0.015. If Anny's default age scale holds, that is about 4 years instead of about 1.5, so too old but still clearly a child. I have not yet checked that scale against the installed Anny, so the years are approximate. The ten children in the training manifest also come out too old, by 0.078 on average. With their true shape, their error falls from 47.8 to 41.6 millimetres, so 6.2 millimetres of it is shape. Only 2 percent of training people are children, so I tried a sampler that shows about 10 percent. In a 2-epoch fine-tune nothing changed, not for the training children and not on real photos: five small people still get an adult age, 0.57 to 0.67 across the two arms, which would be about 21 to 25 years. That is a short run on few people, so it shows no effect, not that there can be none. My best guess is a gap between synthetic and real images, plus an old-age bias that shows even on training children; neither is tested. There are no labelled real children, and the 3DPW labels fix age at one adult value. The next step is a 10-epoch balanced-sampler run; if that also shows nothing, it goes into the thesis as a limitation. The holdout has no children, so every synthetic child number is in-sample.</a:t>
             </a:r>
             <a:endParaRPr lang="en-US" dirty="0"/>
           </a:p>
@@ -1704,7 +1704,7 @@
           <a:p>
             <a:r>
               <a:rPr lang="en-US" dirty="0"/>
-              <a:t>This is the main result of the week. The model attaches the mesh to the detected pixel by its head joint and reports the head as its position. The training code built the position, distance, heat-map and offset targets at joint 0, the root joint at the pelvis. Those two can never agree. The cause is confirmed: with consistent targets the bodies grow back, and a control run with the same schedule does not. The likely mechanism is that the 2D losses solve the conflict by shrinking the body, which means predicting it farther away. Measured on the holdout for v5: predicted depth is 0.33 times the true depth plus 2.36 metres, all 222 people too far, and bodies about two thirds of their true size, a size ratio of 0.63. Our standard error is pelvis-centred, so it never saw this. That is why the thesis numbers looked normal. The real-photo demos did not show it either, because they place each body from its detection box. The synthetic demo and the trace panels use the model's own depth, and there you can see it, as on the next slide. The bug is in the training code, so v9 and v10 have it too: the same kind of depth fit and size ratio, and v10 is slightly worse.</a:t>
+              <a:t>This is the main result of the week. The model attaches the mesh to the detected pixel by its head joint and reports the head as its position. The training code built the position, distance, heat-map and offset targets at joint 0, the root joint at the pelvis. Those two can never agree. The cause is confirmed: with targets at the head the bodies are drawn much closer to the right size, and a control run with the same schedule does not improve; after 10 epochs its drawn size is 0.59 and its root error 1.44 metres. The likely mechanism is that the 2D losses solve the conflict by pushing the body farther away, so it is drawn smaller. Measured on the holdout for v5: predicted depth is 0.33 times the true depth plus 2.36 metres, all 222 people too far, and the bodies are drawn at about two thirds of their true size in the image, a size ratio of 0.63. Their 3D height is right, 1.405 against 1.409 metres; they are only placed too far away. Our standard error is pelvis-centred, so it never saw this. That is why the thesis numbers looked normal. The real-photo demos did not show it either, because they place each body from its detection box. The synthetic demo and the trace panels use the model's own depth, and there you can see it, as on the next slide. The bug is in the training code, so v9 and v10 have it too: the same kind of depth fit and size ratio, and v10 is slightly worse.</a:t>
             </a:r>
             <a:endParaRPr lang="en-US" dirty="0"/>
           </a:p>
@@ -1792,7 +1792,7 @@
           <a:p>
             <a:r>
               <a:rPr lang="en-US" dirty="0"/>
-              <a:t>This is what the bug looks like on a synthetic holdout image, using the model's own depth. On the left is the truth. In the middle is the old model: the bodies are too small, the real man's head sticks out above the mesh, and the mesh floats. On the right is the model after the fix, with the depth loss five times stronger, trained for 10 epochs. On this image the meshes cover the people at about their real size; the blue mesh is 95 percent of the true height. I chose this image because it has no people very close to the camera, so it is a good case, not a typical one. On the whole holdout the median body size is 84 percent of the truth, so bodies are still about 16 percent too small, and near and far people are still not separated well. I checked all 12 holdout images we rendered, and all three prediction settings show the same change, not only this one. Both models also miss people who stand very close to the camera and fill much of the image. That is a separate detection problem; the fix did not cause it and did not fix it. The mesh colours follow detection order, so they differ from the ground truth.</a:t>
+              <a:t>This is the bug on a synthetic holdout image, using the model's own depth, not the box placement of the real-photo demos. Left is the truth. In the middle, the old model: the bodies are drawn too small, the real man's head sticks out above the mesh, and the mesh floats. On the right, the fix with the depth loss five times stronger, trained for 10 epochs. The blue mesh is now 95 percent of the true height; the woman's mesh is closer to her size but still narrower. I chose this image because no person with a ground-truth mesh is missed, so it is a good case, not a typical one; the arm at the bottom left has no ground-truth mesh either. On the whole holdout the median drawn size is 84 percent of the truth, so bodies are still about 16 percent too small, and near and far people still get similar depths: in the slope, 1 means perfect and 0 means the same depth for everyone. All 12 holdout images we rendered, in all three prediction settings, show the same change. In 4 of them both models miss people very close to the camera; since both miss them, the fix did not cause it. It is likely a detection problem, but not yet counted. Mesh colours follow detection order.</a:t>
             </a:r>
             <a:endParaRPr lang="en-US" dirty="0"/>
           </a:p>
@@ -2008,8 +2008,8 @@
         </p:nvSpPr>
         <p:spPr>
           <a:xfrm>
-            <a:off x="548640" y="548640"/>
-            <a:ext cx="8046720" cy="914400"/>
+            <a:off x="548640" y="457200"/>
+            <a:ext cx="8046720" cy="822960"/>
           </a:xfrm>
           <a:prstGeom prst="rect">
             <a:avLst/>
@@ -2047,8 +2047,8 @@
         </p:nvSpPr>
         <p:spPr>
           <a:xfrm>
-            <a:off x="548640" y="1645920"/>
-            <a:ext cx="8046720" cy="3017520"/>
+            <a:off x="548640" y="1371600"/>
+            <a:ext cx="8046720" cy="1783080"/>
           </a:xfrm>
           <a:prstGeom prst="rect">
             <a:avLst/>
@@ -2073,6 +2073,51 @@
               <a:buNone/>
             </a:pPr>
             <a:endParaRPr lang="en-US" sz="1700" dirty="0"/>
+          </a:p>
+        </p:txBody>
+      </p:sp>
+      <p:sp>
+        <p:nvSpPr>
+          <p:cNvPr id="25" name="Slide Number Placeholder 0"/>
+          <p:cNvSpPr>
+            <a:spLocks noGrp="1"/>
+          </p:cNvSpPr>
+          <p:nvPr>
+            <p:ph type="sldNum" sz="quarter" idx="4294967295"/>
+          </p:nvPr>
+        </p:nvSpPr>
+        <p:spPr>
+          <a:xfrm>
+            <a:off x="8412480" y="4754880"/>
+            <a:ext cx="457200" cy="274320"/>
+          </a:xfrm>
+          <a:prstGeom prst="rect">
+            <a:avLst/>
+          </a:prstGeom>
+          <a:extLst>
+            <a:ext uri="{C572A759-6A51-4108-AA02-DFA0A04FC94B}">
+              <ma14:wrappingTextBoxFlag xmlns:ma14="http://schemas.microsoft.com/office/mac/drawingml/2011/main" val="0"/>
+            </a:ext>
+          </a:extLst>
+        </p:spPr>
+        <p:txBody>
+          <a:bodyPr/>
+          <a:lstStyle>
+            <a:lvl1pPr>
+              <a:defRPr sz="1000">
+                <a:solidFill>
+                  <a:srgbClr val="7B8794"/>
+                </a:solidFill>
+              </a:defRPr>
+            </a:lvl1pPr>
+          </a:lstStyle>
+          <a:p>
+            <a:pPr algn="l"/>
+            <a:fld id="{F7021451-1387-4CA6-816F-3879F97B5CBC}" type="slidenum">
+              <a:rPr b="0" lang="en-US"/>
+              <a:t>1003</a:t>
+            </a:fld>
+            <a:endParaRPr lang="en-US"/>
           </a:p>
         </p:txBody>
       </p:sp>
@@ -2760,7 +2805,7 @@
           </p:nvPr>
         </p:nvGraphicFramePr>
         <p:xfrm>
-          <a:off x="457200" y="1143000"/>
+          <a:off x="457200" y="1097280"/>
           <a:ext cx="8229600" cy="914400"/>
         </p:xfrm>
         <a:graphic>
@@ -2768,14 +2813,192 @@
             <a:tbl>
               <a:tblPr/>
               <a:tblGrid>
-                <a:gridCol w="2057400"/>
-                <a:gridCol w="1188720"/>
-                <a:gridCol w="1188720"/>
-                <a:gridCol w="1188720"/>
-                <a:gridCol w="1325880"/>
-                <a:gridCol w="1280160"/>
+                <a:gridCol w="1920240"/>
+                <a:gridCol w="1051560"/>
+                <a:gridCol w="1051560"/>
+                <a:gridCol w="1051560"/>
+                <a:gridCol w="1051560"/>
+                <a:gridCol w="1051560"/>
+                <a:gridCol w="1051560"/>
               </a:tblGrid>
-              <a:tr h="420624">
+              <a:tr h="210312">
+                <a:tc gridSpan="2">
+                  <a:txBody>
+                    <a:bodyPr/>
+                    <a:lstStyle/>
+                    <a:p>
+                      <a:pPr indent="0" marL="0">
+                        <a:buNone/>
+                      </a:pPr>
+                      <a:endParaRPr lang="en-US" sz="1100" dirty="0"/>
+                    </a:p>
+                  </a:txBody>
+                  <a:tcPr marL="54864" marR="54864" marT="18288" marB="18288" anchor="ctr">
+                    <a:lnL w="0" cap="flat" cmpd="sng" algn="ctr">
+                      <a:noFill/>
+                    </a:lnL>
+                    <a:lnR w="38100" cap="flat" cmpd="sng" algn="ctr">
+                      <a:solidFill>
+                        <a:srgbClr val="FFFFFF"/>
+                      </a:solidFill>
+                      <a:prstDash val="solid"/>
+                      <a:round/>
+                      <a:headEnd type="none" w="med" len="med"/>
+                      <a:tailEnd type="none" w="med" len="med"/>
+                    </a:lnR>
+                    <a:lnT w="0" cap="flat" cmpd="sng" algn="ctr">
+                      <a:noFill/>
+                    </a:lnT>
+                    <a:lnB w="12700" cap="flat" cmpd="sng" algn="ctr">
+                      <a:solidFill>
+                        <a:srgbClr val="FFFFFF"/>
+                      </a:solidFill>
+                      <a:prstDash val="solid"/>
+                      <a:round/>
+                      <a:headEnd type="none" w="med" len="med"/>
+                      <a:tailEnd type="none" w="med" len="med"/>
+                    </a:lnB>
+                    <a:solidFill>
+                      <a:srgbClr val="FFFFFF"/>
+                    </a:solidFill>
+                  </a:tcPr>
+                </a:tc>
+                <a:tc hMerge="1">
+                  <a:tcPr/>
+                </a:tc>
+                <a:tc gridSpan="3">
+                  <a:txBody>
+                    <a:bodyPr/>
+                    <a:lstStyle/>
+                    <a:p>
+                      <a:pPr algn="ctr" indent="0" marL="0">
+                        <a:buNone/>
+                      </a:pPr>
+                      <a:r>
+                        <a:rPr lang="en-US" sz="1000" b="1" dirty="0">
+                          <a:solidFill>
+                            <a:srgbClr val="FFFFFF"/>
+                          </a:solidFill>
+                        </a:rPr>
+                        <a:t>10-epoch fine-tunes</a:t>
+                      </a:r>
+                      <a:endParaRPr lang="en-US" sz="1000" dirty="0"/>
+                    </a:p>
+                  </a:txBody>
+                  <a:tcPr marL="54864" marR="54864" marT="18288" marB="18288" anchor="ctr">
+                    <a:lnL w="38100" cap="flat" cmpd="sng" algn="ctr">
+                      <a:solidFill>
+                        <a:srgbClr val="FFFFFF"/>
+                      </a:solidFill>
+                      <a:prstDash val="solid"/>
+                      <a:round/>
+                      <a:headEnd type="none" w="med" len="med"/>
+                      <a:tailEnd type="none" w="med" len="med"/>
+                    </a:lnL>
+                    <a:lnR w="38100" cap="flat" cmpd="sng" algn="ctr">
+                      <a:solidFill>
+                        <a:srgbClr val="FFFFFF"/>
+                      </a:solidFill>
+                      <a:prstDash val="solid"/>
+                      <a:round/>
+                      <a:headEnd type="none" w="med" len="med"/>
+                      <a:tailEnd type="none" w="med" len="med"/>
+                    </a:lnR>
+                    <a:lnT w="12700" cap="flat" cmpd="sng" algn="ctr">
+                      <a:solidFill>
+                        <a:srgbClr val="FFFFFF"/>
+                      </a:solidFill>
+                      <a:prstDash val="solid"/>
+                      <a:round/>
+                      <a:headEnd type="none" w="med" len="med"/>
+                      <a:tailEnd type="none" w="med" len="med"/>
+                    </a:lnT>
+                    <a:lnB w="12700" cap="flat" cmpd="sng" algn="ctr">
+                      <a:solidFill>
+                        <a:srgbClr val="FFFFFF"/>
+                      </a:solidFill>
+                      <a:prstDash val="solid"/>
+                      <a:round/>
+                      <a:headEnd type="none" w="med" len="med"/>
+                      <a:tailEnd type="none" w="med" len="med"/>
+                    </a:lnB>
+                    <a:solidFill>
+                      <a:srgbClr val="4A5568"/>
+                    </a:solidFill>
+                  </a:tcPr>
+                </a:tc>
+                <a:tc hMerge="1">
+                  <a:tcPr/>
+                </a:tc>
+                <a:tc hMerge="1">
+                  <a:tcPr/>
+                </a:tc>
+                <a:tc gridSpan="2">
+                  <a:txBody>
+                    <a:bodyPr/>
+                    <a:lstStyle/>
+                    <a:p>
+                      <a:pPr algn="ctr" indent="0" marL="0">
+                        <a:buNone/>
+                      </a:pPr>
+                      <a:r>
+                        <a:rPr lang="en-US" sz="1000" b="1" dirty="0">
+                          <a:solidFill>
+                            <a:srgbClr val="FFFFFF"/>
+                          </a:solidFill>
+                        </a:rPr>
+                        <a:t>2-epoch fine-tunes</a:t>
+                      </a:r>
+                      <a:endParaRPr lang="en-US" sz="1000" dirty="0"/>
+                    </a:p>
+                  </a:txBody>
+                  <a:tcPr marL="54864" marR="54864" marT="18288" marB="18288" anchor="ctr">
+                    <a:lnL w="38100" cap="flat" cmpd="sng" algn="ctr">
+                      <a:solidFill>
+                        <a:srgbClr val="FFFFFF"/>
+                      </a:solidFill>
+                      <a:prstDash val="solid"/>
+                      <a:round/>
+                      <a:headEnd type="none" w="med" len="med"/>
+                      <a:tailEnd type="none" w="med" len="med"/>
+                    </a:lnL>
+                    <a:lnR w="38100" cap="flat" cmpd="sng" algn="ctr">
+                      <a:solidFill>
+                        <a:srgbClr val="FFFFFF"/>
+                      </a:solidFill>
+                      <a:prstDash val="solid"/>
+                      <a:round/>
+                      <a:headEnd type="none" w="med" len="med"/>
+                      <a:tailEnd type="none" w="med" len="med"/>
+                    </a:lnR>
+                    <a:lnT w="12700" cap="flat" cmpd="sng" algn="ctr">
+                      <a:solidFill>
+                        <a:srgbClr val="FFFFFF"/>
+                      </a:solidFill>
+                      <a:prstDash val="solid"/>
+                      <a:round/>
+                      <a:headEnd type="none" w="med" len="med"/>
+                      <a:tailEnd type="none" w="med" len="med"/>
+                    </a:lnT>
+                    <a:lnB w="12700" cap="flat" cmpd="sng" algn="ctr">
+                      <a:solidFill>
+                        <a:srgbClr val="FFFFFF"/>
+                      </a:solidFill>
+                      <a:prstDash val="solid"/>
+                      <a:round/>
+                      <a:headEnd type="none" w="med" len="med"/>
+                      <a:tailEnd type="none" w="med" len="med"/>
+                    </a:lnB>
+                    <a:solidFill>
+                      <a:srgbClr val="4A5568"/>
+                    </a:solidFill>
+                  </a:tcPr>
+                </a:tc>
+                <a:tc hMerge="1">
+                  <a:tcPr/>
+                </a:tc>
+              </a:tr>
+              <a:tr h="246888">
                 <a:tc>
                   <a:txBody>
                     <a:bodyPr/>
@@ -2785,17 +3008,17 @@
                         <a:buNone/>
                       </a:pPr>
                       <a:r>
-                        <a:rPr lang="en-US" sz="1200" b="1" dirty="0">
+                        <a:rPr lang="en-US" sz="1100" b="1" dirty="0">
                           <a:solidFill>
                             <a:srgbClr val="FFFFFF"/>
                           </a:solidFill>
                         </a:rPr>
                         <a:t>holdout, 100 images</a:t>
                       </a:r>
-                      <a:endParaRPr lang="en-US" sz="1200" dirty="0"/>
+                      <a:endParaRPr lang="en-US" sz="1100" dirty="0"/>
                     </a:p>
                   </a:txBody>
-                  <a:tcPr marL="27432" marR="27432" marT="27432" marB="27432" anchor="ctr">
+                  <a:tcPr marL="54864" marR="54864" marT="18288" marB="18288" anchor="ctr">
                     <a:lnL w="12700" cap="flat" cmpd="sng" algn="ctr">
                       <a:solidFill>
                         <a:srgbClr val="FFFFFF"/>
@@ -2846,31 +3069,17 @@
                         <a:buNone/>
                       </a:pPr>
                       <a:r>
-                        <a:rPr lang="en-US" sz="1200" b="1" dirty="0">
+                        <a:rPr lang="en-US" sz="1100" b="1" dirty="0">
                           <a:solidFill>
                             <a:srgbClr val="FFFFFF"/>
                           </a:solidFill>
                         </a:rPr>
-                        <a:t>v5</a:t>
+                        <a:t>v5 baseline</a:t>
                       </a:r>
-                      <a:endParaRPr lang="en-US" sz="1200" dirty="0"/>
-                    </a:p>
-                    <a:p>
-                      <a:pPr algn="ctr" indent="0" marL="0">
-                        <a:buNone/>
-                      </a:pPr>
-                      <a:r>
-                        <a:rPr lang="en-US" sz="1200" b="1" dirty="0">
-                          <a:solidFill>
-                            <a:srgbClr val="FFFFFF"/>
-                          </a:solidFill>
-                        </a:rPr>
-                        <a:t>baseline</a:t>
-                      </a:r>
-                      <a:endParaRPr lang="en-US" sz="1200" dirty="0"/>
+                      <a:endParaRPr lang="en-US" sz="1100" dirty="0"/>
                     </a:p>
                   </a:txBody>
-                  <a:tcPr marL="27432" marR="27432" marT="27432" marB="27432" anchor="ctr">
+                  <a:tcPr marL="54864" marR="54864" marT="18288" marB="18288" anchor="ctr">
                     <a:lnL w="12700" cap="flat" cmpd="sng" algn="ctr">
                       <a:solidFill>
                         <a:srgbClr val="FFFFFF"/>
@@ -2880,7 +3089,7 @@
                       <a:headEnd type="none" w="med" len="med"/>
                       <a:tailEnd type="none" w="med" len="med"/>
                     </a:lnL>
-                    <a:lnR w="12700" cap="flat" cmpd="sng" algn="ctr">
+                    <a:lnR w="38100" cap="flat" cmpd="sng" algn="ctr">
                       <a:solidFill>
                         <a:srgbClr val="FFFFFF"/>
                       </a:solidFill>
@@ -2921,32 +3130,18 @@
                         <a:buNone/>
                       </a:pPr>
                       <a:r>
-                        <a:rPr lang="en-US" sz="1200" b="1" dirty="0">
+                        <a:rPr lang="en-US" sz="1100" b="1" dirty="0">
                           <a:solidFill>
                             <a:srgbClr val="FFFFFF"/>
                           </a:solidFill>
                         </a:rPr>
                         <a:t>control</a:t>
                       </a:r>
-                      <a:endParaRPr lang="en-US" sz="1200" dirty="0"/>
-                    </a:p>
-                    <a:p>
-                      <a:pPr algn="ctr" indent="0" marL="0">
-                        <a:buNone/>
-                      </a:pPr>
-                      <a:r>
-                        <a:rPr lang="en-US" sz="1200" b="1" dirty="0">
-                          <a:solidFill>
-                            <a:srgbClr val="FFFFFF"/>
-                          </a:solidFill>
-                        </a:rPr>
-                        <a:t>10 epochs</a:t>
-                      </a:r>
-                      <a:endParaRPr lang="en-US" sz="1200" dirty="0"/>
+                      <a:endParaRPr lang="en-US" sz="1100" dirty="0"/>
                     </a:p>
                   </a:txBody>
-                  <a:tcPr marL="27432" marR="27432" marT="27432" marB="27432" anchor="ctr">
-                    <a:lnL w="12700" cap="flat" cmpd="sng" algn="ctr">
+                  <a:tcPr marL="54864" marR="54864" marT="18288" marB="18288" anchor="ctr">
+                    <a:lnL w="38100" cap="flat" cmpd="sng" algn="ctr">
                       <a:solidFill>
                         <a:srgbClr val="FFFFFF"/>
                       </a:solidFill>
@@ -2996,31 +3191,17 @@
                         <a:buNone/>
                       </a:pPr>
                       <a:r>
-                        <a:rPr lang="en-US" sz="1200" b="1" dirty="0">
+                        <a:rPr lang="en-US" sz="1100" b="1" dirty="0">
                           <a:solidFill>
                             <a:srgbClr val="FFFFFF"/>
                           </a:solidFill>
                         </a:rPr>
                         <a:t>fix</a:t>
                       </a:r>
-                      <a:endParaRPr lang="en-US" sz="1200" dirty="0"/>
-                    </a:p>
-                    <a:p>
-                      <a:pPr algn="ctr" indent="0" marL="0">
-                        <a:buNone/>
-                      </a:pPr>
-                      <a:r>
-                        <a:rPr lang="en-US" sz="1200" b="1" dirty="0">
-                          <a:solidFill>
-                            <a:srgbClr val="FFFFFF"/>
-                          </a:solidFill>
-                        </a:rPr>
-                        <a:t>10 epochs</a:t>
-                      </a:r>
-                      <a:endParaRPr lang="en-US" sz="1200" dirty="0"/>
+                      <a:endParaRPr lang="en-US" sz="1100" dirty="0"/>
                     </a:p>
                   </a:txBody>
-                  <a:tcPr marL="27432" marR="27432" marT="27432" marB="27432" anchor="ctr">
+                  <a:tcPr marL="54864" marR="54864" marT="18288" marB="18288" anchor="ctr">
                     <a:lnL w="12700" cap="flat" cmpd="sng" algn="ctr">
                       <a:solidFill>
                         <a:srgbClr val="FFFFFF"/>
@@ -3071,32 +3252,79 @@
                         <a:buNone/>
                       </a:pPr>
                       <a:r>
-                        <a:rPr lang="en-US" sz="1200" b="1" dirty="0">
+                        <a:rPr lang="en-US" sz="1100" b="1" dirty="0">
                           <a:solidFill>
                             <a:srgbClr val="FFFFFF"/>
                           </a:solidFill>
                         </a:rPr>
-                        <a:t>fix + depth ×5</a:t>
+                        <a:t>fix + ×5</a:t>
                       </a:r>
-                      <a:endParaRPr lang="en-US" sz="1200" dirty="0"/>
+                      <a:endParaRPr lang="en-US" sz="1100" dirty="0"/>
                     </a:p>
+                  </a:txBody>
+                  <a:tcPr marL="54864" marR="54864" marT="18288" marB="18288" anchor="ctr">
+                    <a:lnL w="12700" cap="flat" cmpd="sng" algn="ctr">
+                      <a:solidFill>
+                        <a:srgbClr val="FFFFFF"/>
+                      </a:solidFill>
+                      <a:prstDash val="solid"/>
+                      <a:round/>
+                      <a:headEnd type="none" w="med" len="med"/>
+                      <a:tailEnd type="none" w="med" len="med"/>
+                    </a:lnL>
+                    <a:lnR w="38100" cap="flat" cmpd="sng" algn="ctr">
+                      <a:solidFill>
+                        <a:srgbClr val="FFFFFF"/>
+                      </a:solidFill>
+                      <a:prstDash val="solid"/>
+                      <a:round/>
+                      <a:headEnd type="none" w="med" len="med"/>
+                      <a:tailEnd type="none" w="med" len="med"/>
+                    </a:lnR>
+                    <a:lnT w="12700" cap="flat" cmpd="sng" algn="ctr">
+                      <a:solidFill>
+                        <a:srgbClr val="FFFFFF"/>
+                      </a:solidFill>
+                      <a:prstDash val="solid"/>
+                      <a:round/>
+                      <a:headEnd type="none" w="med" len="med"/>
+                      <a:tailEnd type="none" w="med" len="med"/>
+                    </a:lnT>
+                    <a:lnB w="12700" cap="flat" cmpd="sng" algn="ctr">
+                      <a:solidFill>
+                        <a:srgbClr val="FFFFFF"/>
+                      </a:solidFill>
+                      <a:prstDash val="solid"/>
+                      <a:round/>
+                      <a:headEnd type="none" w="med" len="med"/>
+                      <a:tailEnd type="none" w="med" len="med"/>
+                    </a:lnB>
+                    <a:solidFill>
+                      <a:srgbClr val="0E7C86"/>
+                    </a:solidFill>
+                  </a:tcPr>
+                </a:tc>
+                <a:tc>
+                  <a:txBody>
+                    <a:bodyPr/>
+                    <a:lstStyle/>
                     <a:p>
                       <a:pPr algn="ctr" indent="0" marL="0">
                         <a:buNone/>
                       </a:pPr>
                       <a:r>
-                        <a:rPr lang="en-US" sz="1200" b="1" dirty="0">
+                        <a:rPr lang="en-US" sz="1100" b="1" dirty="0">
                           <a:solidFill>
                             <a:srgbClr val="FFFFFF"/>
                           </a:solidFill>
                         </a:rPr>
-                        <a:t>10 epochs</a:t>
+                        <a:t>control</a:t>
                       </a:r>
-                      <a:endParaRPr lang="en-US" sz="1200" dirty="0"/>
+                      <a:endParaRPr lang="en-US" sz="1100" dirty="0"/>
                     </a:p>
                   </a:txBody>
-                  <a:tcPr marL="27432" marR="27432" marT="27432" marB="27432" anchor="ctr">
-                    <a:lnL w="12700" cap="flat" cmpd="sng" algn="ctr">
+                  <a:tcPr marL="54864" marR="54864" marT="18288" marB="18288" anchor="ctr">
+                    <a:lnL w="38100" cap="flat" cmpd="sng" algn="ctr">
                       <a:solidFill>
                         <a:srgbClr val="FFFFFF"/>
                       </a:solidFill>
@@ -3146,31 +3374,17 @@
                         <a:buNone/>
                       </a:pPr>
                       <a:r>
-                        <a:rPr lang="en-US" sz="1200" b="1" dirty="0">
+                        <a:rPr lang="en-US" sz="1100" b="1" dirty="0">
                           <a:solidFill>
                             <a:srgbClr val="FFFFFF"/>
                           </a:solidFill>
                         </a:rPr>
-                        <a:t>fix + depth ×20</a:t>
+                        <a:t>fix + ×20</a:t>
                       </a:r>
-                      <a:endParaRPr lang="en-US" sz="1200" dirty="0"/>
-                    </a:p>
-                    <a:p>
-                      <a:pPr algn="ctr" indent="0" marL="0">
-                        <a:buNone/>
-                      </a:pPr>
-                      <a:r>
-                        <a:rPr lang="en-US" sz="1200" b="1" dirty="0">
-                          <a:solidFill>
-                            <a:srgbClr val="FFFFFF"/>
-                          </a:solidFill>
-                        </a:rPr>
-                        <a:t>2 epochs</a:t>
-                      </a:r>
-                      <a:endParaRPr lang="en-US" sz="1200" dirty="0"/>
+                      <a:endParaRPr lang="en-US" sz="1100" dirty="0"/>
                     </a:p>
                   </a:txBody>
-                  <a:tcPr marL="27432" marR="27432" marT="27432" marB="27432" anchor="ctr">
+                  <a:tcPr marL="54864" marR="54864" marT="18288" marB="18288" anchor="ctr">
                     <a:lnL w="12700" cap="flat" cmpd="sng" algn="ctr">
                       <a:solidFill>
                         <a:srgbClr val="FFFFFF"/>
@@ -3213,7 +3427,7 @@
                   </a:tcPr>
                 </a:tc>
               </a:tr>
-              <a:tr h="246888">
+              <a:tr h="210312">
                 <a:tc>
                   <a:txBody>
                     <a:bodyPr/>
@@ -3223,17 +3437,17 @@
                         <a:buNone/>
                       </a:pPr>
                       <a:r>
-                        <a:rPr lang="en-US" sz="1200" b="1" dirty="0">
+                        <a:rPr lang="en-US" sz="1100" b="1" dirty="0">
                           <a:solidFill>
                             <a:srgbClr val="1B2233"/>
                           </a:solidFill>
                         </a:rPr>
-                        <a:t>depth error</a:t>
+                        <a:t>root error (3D)</a:t>
                       </a:r>
-                      <a:endParaRPr lang="en-US" sz="1200" dirty="0"/>
+                      <a:endParaRPr lang="en-US" sz="1100" dirty="0"/>
                     </a:p>
                   </a:txBody>
-                  <a:tcPr marL="27432" marR="27432" marT="27432" marB="27432" anchor="ctr">
+                  <a:tcPr marL="54864" marR="54864" marT="18288" marB="18288" anchor="ctr">
                     <a:lnL w="12700" cap="flat" cmpd="sng" algn="ctr">
                       <a:solidFill>
                         <a:srgbClr val="FFFFFF"/>
@@ -3284,17 +3498,17 @@
                         <a:buNone/>
                       </a:pPr>
                       <a:r>
-                        <a:rPr lang="en-US" sz="1200" dirty="0">
+                        <a:rPr lang="en-US" sz="1100" dirty="0">
                           <a:solidFill>
                             <a:srgbClr val="1B2233"/>
                           </a:solidFill>
                         </a:rPr>
-                        <a:t>1.08 m</a:t>
+                        <a:t>1.21 m</a:t>
                       </a:r>
-                      <a:endParaRPr lang="en-US" sz="1200" dirty="0"/>
+                      <a:endParaRPr lang="en-US" sz="1100" dirty="0"/>
                     </a:p>
                   </a:txBody>
-                  <a:tcPr marL="27432" marR="27432" marT="27432" marB="27432" anchor="ctr">
+                  <a:tcPr marL="54864" marR="54864" marT="18288" marB="18288" anchor="ctr">
                     <a:lnL w="12700" cap="flat" cmpd="sng" algn="ctr">
                       <a:solidFill>
                         <a:srgbClr val="FFFFFF"/>
@@ -3304,9 +3518,9 @@
                       <a:headEnd type="none" w="med" len="med"/>
                       <a:tailEnd type="none" w="med" len="med"/>
                     </a:lnL>
-                    <a:lnR w="12700" cap="flat" cmpd="sng" algn="ctr">
-                      <a:solidFill>
-                        <a:srgbClr val="FFFFFF"/>
+                    <a:lnR w="38100" cap="flat" cmpd="sng" algn="ctr">
+                      <a:solidFill>
+                        <a:srgbClr val="4A5568"/>
                       </a:solidFill>
                       <a:prstDash val="solid"/>
                       <a:round/>
@@ -3345,20 +3559,20 @@
                         <a:buNone/>
                       </a:pPr>
                       <a:r>
-                        <a:rPr lang="en-US" sz="1200" dirty="0">
+                        <a:rPr lang="en-US" sz="1100" dirty="0">
                           <a:solidFill>
                             <a:srgbClr val="1B2233"/>
                           </a:solidFill>
                         </a:rPr>
-                        <a:t>1.30 m</a:t>
+                        <a:t>1.44 m</a:t>
                       </a:r>
-                      <a:endParaRPr lang="en-US" sz="1200" dirty="0"/>
+                      <a:endParaRPr lang="en-US" sz="1100" dirty="0"/>
                     </a:p>
                   </a:txBody>
-                  <a:tcPr marL="27432" marR="27432" marT="27432" marB="27432" anchor="ctr">
-                    <a:lnL w="12700" cap="flat" cmpd="sng" algn="ctr">
-                      <a:solidFill>
-                        <a:srgbClr val="FFFFFF"/>
+                  <a:tcPr marL="54864" marR="54864" marT="18288" marB="18288" anchor="ctr">
+                    <a:lnL w="38100" cap="flat" cmpd="sng" algn="ctr">
+                      <a:solidFill>
+                        <a:srgbClr val="4A5568"/>
                       </a:solidFill>
                       <a:prstDash val="solid"/>
                       <a:round/>
@@ -3406,17 +3620,17 @@
                         <a:buNone/>
                       </a:pPr>
                       <a:r>
-                        <a:rPr lang="en-US" sz="1200" dirty="0">
+                        <a:rPr lang="en-US" sz="1100" dirty="0">
                           <a:solidFill>
                             <a:srgbClr val="1B2233"/>
                           </a:solidFill>
                         </a:rPr>
-                        <a:t>0.62 m</a:t>
+                        <a:t>0.73 m</a:t>
                       </a:r>
-                      <a:endParaRPr lang="en-US" sz="1200" dirty="0"/>
+                      <a:endParaRPr lang="en-US" sz="1100" dirty="0"/>
                     </a:p>
                   </a:txBody>
-                  <a:tcPr marL="27432" marR="27432" marT="27432" marB="27432" anchor="ctr">
+                  <a:tcPr marL="54864" marR="54864" marT="18288" marB="18288" anchor="ctr">
                     <a:lnL w="12700" cap="flat" cmpd="sng" algn="ctr">
                       <a:solidFill>
                         <a:srgbClr val="FFFFFF"/>
@@ -3467,20 +3681,81 @@
                         <a:buNone/>
                       </a:pPr>
                       <a:r>
-                        <a:rPr lang="en-US" sz="1200" dirty="0">
+                        <a:rPr lang="en-US" sz="1100" dirty="0">
                           <a:solidFill>
                             <a:srgbClr val="1B2233"/>
                           </a:solidFill>
                         </a:rPr>
-                        <a:t>0.39 m</a:t>
+                        <a:t>0.54 m</a:t>
                       </a:r>
-                      <a:endParaRPr lang="en-US" sz="1200" dirty="0"/>
+                      <a:endParaRPr lang="en-US" sz="1100" dirty="0"/>
                     </a:p>
                   </a:txBody>
-                  <a:tcPr marL="27432" marR="27432" marT="27432" marB="27432" anchor="ctr">
+                  <a:tcPr marL="54864" marR="54864" marT="18288" marB="18288" anchor="ctr">
                     <a:lnL w="12700" cap="flat" cmpd="sng" algn="ctr">
                       <a:solidFill>
                         <a:srgbClr val="FFFFFF"/>
+                      </a:solidFill>
+                      <a:prstDash val="solid"/>
+                      <a:round/>
+                      <a:headEnd type="none" w="med" len="med"/>
+                      <a:tailEnd type="none" w="med" len="med"/>
+                    </a:lnL>
+                    <a:lnR w="38100" cap="flat" cmpd="sng" algn="ctr">
+                      <a:solidFill>
+                        <a:srgbClr val="4A5568"/>
+                      </a:solidFill>
+                      <a:prstDash val="solid"/>
+                      <a:round/>
+                      <a:headEnd type="none" w="med" len="med"/>
+                      <a:tailEnd type="none" w="med" len="med"/>
+                    </a:lnR>
+                    <a:lnT w="12700" cap="flat" cmpd="sng" algn="ctr">
+                      <a:solidFill>
+                        <a:srgbClr val="FFFFFF"/>
+                      </a:solidFill>
+                      <a:prstDash val="solid"/>
+                      <a:round/>
+                      <a:headEnd type="none" w="med" len="med"/>
+                      <a:tailEnd type="none" w="med" len="med"/>
+                    </a:lnT>
+                    <a:lnB w="12700" cap="flat" cmpd="sng" algn="ctr">
+                      <a:solidFill>
+                        <a:srgbClr val="FFFFFF"/>
+                      </a:solidFill>
+                      <a:prstDash val="solid"/>
+                      <a:round/>
+                      <a:headEnd type="none" w="med" len="med"/>
+                      <a:tailEnd type="none" w="med" len="med"/>
+                    </a:lnB>
+                    <a:solidFill>
+                      <a:srgbClr val="D3ECEE"/>
+                    </a:solidFill>
+                  </a:tcPr>
+                </a:tc>
+                <a:tc>
+                  <a:txBody>
+                    <a:bodyPr/>
+                    <a:lstStyle/>
+                    <a:p>
+                      <a:pPr algn="ctr" indent="0" marL="0">
+                        <a:buNone/>
+                      </a:pPr>
+                      <a:r>
+                        <a:rPr lang="en-US" sz="1100" dirty="0">
+                          <a:solidFill>
+                            <a:srgbClr val="1B2233"/>
+                          </a:solidFill>
+                        </a:rPr>
+                        <a:t>1.11 m</a:t>
+                      </a:r>
+                      <a:endParaRPr lang="en-US" sz="1100" dirty="0"/>
+                    </a:p>
+                  </a:txBody>
+                  <a:tcPr marL="54864" marR="54864" marT="18288" marB="18288" anchor="ctr">
+                    <a:lnL w="38100" cap="flat" cmpd="sng" algn="ctr">
+                      <a:solidFill>
+                        <a:srgbClr val="4A5568"/>
                       </a:solidFill>
                       <a:prstDash val="solid"/>
                       <a:round/>
@@ -3528,17 +3803,17 @@
                         <a:buNone/>
                       </a:pPr>
                       <a:r>
-                        <a:rPr lang="en-US" sz="1200" dirty="0">
+                        <a:rPr lang="en-US" sz="1100" dirty="0">
                           <a:solidFill>
                             <a:srgbClr val="1B2233"/>
                           </a:solidFill>
                         </a:rPr>
-                        <a:t>0.34 m</a:t>
+                        <a:t>0.53 m</a:t>
                       </a:r>
-                      <a:endParaRPr lang="en-US" sz="1200" dirty="0"/>
+                      <a:endParaRPr lang="en-US" sz="1100" dirty="0"/>
                     </a:p>
                   </a:txBody>
-                  <a:tcPr marL="27432" marR="27432" marT="27432" marB="27432" anchor="ctr">
+                  <a:tcPr marL="54864" marR="54864" marT="18288" marB="18288" anchor="ctr">
                     <a:lnL w="12700" cap="flat" cmpd="sng" algn="ctr">
                       <a:solidFill>
                         <a:srgbClr val="FFFFFF"/>
@@ -3581,7 +3856,7 @@
                   </a:tcPr>
                 </a:tc>
               </a:tr>
-              <a:tr h="246888">
+              <a:tr h="210312">
                 <a:tc>
                   <a:txBody>
                     <a:bodyPr/>
@@ -3591,17 +3866,17 @@
                         <a:buNone/>
                       </a:pPr>
                       <a:r>
-                        <a:rPr lang="en-US" sz="1200" b="1" dirty="0">
+                        <a:rPr lang="en-US" sz="1100" b="1" dirty="0">
                           <a:solidFill>
                             <a:srgbClr val="1B2233"/>
                           </a:solidFill>
                         </a:rPr>
                         <a:t>depth slope (1 = perfect)</a:t>
                       </a:r>
-                      <a:endParaRPr lang="en-US" sz="1200" dirty="0"/>
+                      <a:endParaRPr lang="en-US" sz="1100" dirty="0"/>
                     </a:p>
                   </a:txBody>
-                  <a:tcPr marL="27432" marR="27432" marT="27432" marB="27432" anchor="ctr">
+                  <a:tcPr marL="54864" marR="54864" marT="18288" marB="18288" anchor="ctr">
                     <a:lnL w="12700" cap="flat" cmpd="sng" algn="ctr">
                       <a:solidFill>
                         <a:srgbClr val="FFFFFF"/>
@@ -3652,17 +3927,17 @@
                         <a:buNone/>
                       </a:pPr>
                       <a:r>
-                        <a:rPr lang="en-US" sz="1200" dirty="0">
+                        <a:rPr lang="en-US" sz="1100" dirty="0">
                           <a:solidFill>
                             <a:srgbClr val="1B2233"/>
                           </a:solidFill>
                         </a:rPr>
                         <a:t>0.33</a:t>
                       </a:r>
-                      <a:endParaRPr lang="en-US" sz="1200" dirty="0"/>
+                      <a:endParaRPr lang="en-US" sz="1100" dirty="0"/>
                     </a:p>
                   </a:txBody>
-                  <a:tcPr marL="27432" marR="27432" marT="27432" marB="27432" anchor="ctr">
+                  <a:tcPr marL="54864" marR="54864" marT="18288" marB="18288" anchor="ctr">
                     <a:lnL w="12700" cap="flat" cmpd="sng" algn="ctr">
                       <a:solidFill>
                         <a:srgbClr val="FFFFFF"/>
@@ -3672,9 +3947,9 @@
                       <a:headEnd type="none" w="med" len="med"/>
                       <a:tailEnd type="none" w="med" len="med"/>
                     </a:lnL>
-                    <a:lnR w="12700" cap="flat" cmpd="sng" algn="ctr">
-                      <a:solidFill>
-                        <a:srgbClr val="FFFFFF"/>
+                    <a:lnR w="38100" cap="flat" cmpd="sng" algn="ctr">
+                      <a:solidFill>
+                        <a:srgbClr val="4A5568"/>
                       </a:solidFill>
                       <a:prstDash val="solid"/>
                       <a:round/>
@@ -3713,20 +3988,20 @@
                         <a:buNone/>
                       </a:pPr>
                       <a:r>
-                        <a:rPr lang="en-US" sz="1200" dirty="0">
+                        <a:rPr lang="en-US" sz="1100" dirty="0">
                           <a:solidFill>
                             <a:srgbClr val="1B2233"/>
                           </a:solidFill>
                         </a:rPr>
                         <a:t>0.34</a:t>
                       </a:r>
-                      <a:endParaRPr lang="en-US" sz="1200" dirty="0"/>
+                      <a:endParaRPr lang="en-US" sz="1100" dirty="0"/>
                     </a:p>
                   </a:txBody>
-                  <a:tcPr marL="27432" marR="27432" marT="27432" marB="27432" anchor="ctr">
-                    <a:lnL w="12700" cap="flat" cmpd="sng" algn="ctr">
-                      <a:solidFill>
-                        <a:srgbClr val="FFFFFF"/>
+                  <a:tcPr marL="54864" marR="54864" marT="18288" marB="18288" anchor="ctr">
+                    <a:lnL w="38100" cap="flat" cmpd="sng" algn="ctr">
+                      <a:solidFill>
+                        <a:srgbClr val="4A5568"/>
                       </a:solidFill>
                       <a:prstDash val="solid"/>
                       <a:round/>
@@ -3774,17 +4049,17 @@
                         <a:buNone/>
                       </a:pPr>
                       <a:r>
-                        <a:rPr lang="en-US" sz="1200" dirty="0">
+                        <a:rPr lang="en-US" sz="1100" dirty="0">
                           <a:solidFill>
                             <a:srgbClr val="1B2233"/>
                           </a:solidFill>
                         </a:rPr>
                         <a:t>0.30</a:t>
                       </a:r>
-                      <a:endParaRPr lang="en-US" sz="1200" dirty="0"/>
+                      <a:endParaRPr lang="en-US" sz="1100" dirty="0"/>
                     </a:p>
                   </a:txBody>
-                  <a:tcPr marL="27432" marR="27432" marT="27432" marB="27432" anchor="ctr">
+                  <a:tcPr marL="54864" marR="54864" marT="18288" marB="18288" anchor="ctr">
                     <a:lnL w="12700" cap="flat" cmpd="sng" algn="ctr">
                       <a:solidFill>
                         <a:srgbClr val="FFFFFF"/>
@@ -3835,20 +4110,81 @@
                         <a:buNone/>
                       </a:pPr>
                       <a:r>
-                        <a:rPr lang="en-US" sz="1200" dirty="0">
+                        <a:rPr lang="en-US" sz="1100" dirty="0">
                           <a:solidFill>
                             <a:srgbClr val="1B2233"/>
                           </a:solidFill>
                         </a:rPr>
                         <a:t>0.38</a:t>
                       </a:r>
-                      <a:endParaRPr lang="en-US" sz="1200" dirty="0"/>
+                      <a:endParaRPr lang="en-US" sz="1100" dirty="0"/>
                     </a:p>
                   </a:txBody>
-                  <a:tcPr marL="27432" marR="27432" marT="27432" marB="27432" anchor="ctr">
+                  <a:tcPr marL="54864" marR="54864" marT="18288" marB="18288" anchor="ctr">
                     <a:lnL w="12700" cap="flat" cmpd="sng" algn="ctr">
                       <a:solidFill>
                         <a:srgbClr val="FFFFFF"/>
+                      </a:solidFill>
+                      <a:prstDash val="solid"/>
+                      <a:round/>
+                      <a:headEnd type="none" w="med" len="med"/>
+                      <a:tailEnd type="none" w="med" len="med"/>
+                    </a:lnL>
+                    <a:lnR w="38100" cap="flat" cmpd="sng" algn="ctr">
+                      <a:solidFill>
+                        <a:srgbClr val="4A5568"/>
+                      </a:solidFill>
+                      <a:prstDash val="solid"/>
+                      <a:round/>
+                      <a:headEnd type="none" w="med" len="med"/>
+                      <a:tailEnd type="none" w="med" len="med"/>
+                    </a:lnR>
+                    <a:lnT w="12700" cap="flat" cmpd="sng" algn="ctr">
+                      <a:solidFill>
+                        <a:srgbClr val="FFFFFF"/>
+                      </a:solidFill>
+                      <a:prstDash val="solid"/>
+                      <a:round/>
+                      <a:headEnd type="none" w="med" len="med"/>
+                      <a:tailEnd type="none" w="med" len="med"/>
+                    </a:lnT>
+                    <a:lnB w="12700" cap="flat" cmpd="sng" algn="ctr">
+                      <a:solidFill>
+                        <a:srgbClr val="FFFFFF"/>
+                      </a:solidFill>
+                      <a:prstDash val="solid"/>
+                      <a:round/>
+                      <a:headEnd type="none" w="med" len="med"/>
+                      <a:tailEnd type="none" w="med" len="med"/>
+                    </a:lnB>
+                    <a:solidFill>
+                      <a:srgbClr val="D3ECEE"/>
+                    </a:solidFill>
+                  </a:tcPr>
+                </a:tc>
+                <a:tc>
+                  <a:txBody>
+                    <a:bodyPr/>
+                    <a:lstStyle/>
+                    <a:p>
+                      <a:pPr algn="ctr" indent="0" marL="0">
+                        <a:buNone/>
+                      </a:pPr>
+                      <a:r>
+                        <a:rPr lang="en-US" sz="1100" dirty="0">
+                          <a:solidFill>
+                            <a:srgbClr val="1B2233"/>
+                          </a:solidFill>
+                        </a:rPr>
+                        <a:t>0.33</a:t>
+                      </a:r>
+                      <a:endParaRPr lang="en-US" sz="1100" dirty="0"/>
+                    </a:p>
+                  </a:txBody>
+                  <a:tcPr marL="54864" marR="54864" marT="18288" marB="18288" anchor="ctr">
+                    <a:lnL w="38100" cap="flat" cmpd="sng" algn="ctr">
+                      <a:solidFill>
+                        <a:srgbClr val="4A5568"/>
                       </a:solidFill>
                       <a:prstDash val="solid"/>
                       <a:round/>
@@ -3896,17 +4232,17 @@
                         <a:buNone/>
                       </a:pPr>
                       <a:r>
-                        <a:rPr lang="en-US" sz="1200" dirty="0">
+                        <a:rPr lang="en-US" sz="1100" dirty="0">
                           <a:solidFill>
                             <a:srgbClr val="1B2233"/>
                           </a:solidFill>
                         </a:rPr>
                         <a:t>0.43</a:t>
                       </a:r>
-                      <a:endParaRPr lang="en-US" sz="1200" dirty="0"/>
+                      <a:endParaRPr lang="en-US" sz="1100" dirty="0"/>
                     </a:p>
                   </a:txBody>
-                  <a:tcPr marL="27432" marR="27432" marT="27432" marB="27432" anchor="ctr">
+                  <a:tcPr marL="54864" marR="54864" marT="18288" marB="18288" anchor="ctr">
                     <a:lnL w="12700" cap="flat" cmpd="sng" algn="ctr">
                       <a:solidFill>
                         <a:srgbClr val="FFFFFF"/>
@@ -3949,7 +4285,7 @@
                   </a:tcPr>
                 </a:tc>
               </a:tr>
-              <a:tr h="246888">
+              <a:tr h="210312">
                 <a:tc>
                   <a:txBody>
                     <a:bodyPr/>
@@ -3959,17 +4295,17 @@
                         <a:buNone/>
                       </a:pPr>
                       <a:r>
-                        <a:rPr lang="en-US" sz="1200" b="1" dirty="0">
+                        <a:rPr lang="en-US" sz="1100" b="1" dirty="0">
                           <a:solidFill>
                             <a:srgbClr val="1B2233"/>
                           </a:solidFill>
                         </a:rPr>
-                        <a:t>body size (1 = right)</a:t>
+                        <a:t>drawn size (1 = right)</a:t>
                       </a:r>
-                      <a:endParaRPr lang="en-US" sz="1200" dirty="0"/>
+                      <a:endParaRPr lang="en-US" sz="1100" dirty="0"/>
                     </a:p>
                   </a:txBody>
-                  <a:tcPr marL="27432" marR="27432" marT="27432" marB="27432" anchor="ctr">
+                  <a:tcPr marL="54864" marR="54864" marT="18288" marB="18288" anchor="ctr">
                     <a:lnL w="12700" cap="flat" cmpd="sng" algn="ctr">
                       <a:solidFill>
                         <a:srgbClr val="FFFFFF"/>
@@ -4020,17 +4356,17 @@
                         <a:buNone/>
                       </a:pPr>
                       <a:r>
-                        <a:rPr lang="en-US" sz="1200" dirty="0">
+                        <a:rPr lang="en-US" sz="1100" dirty="0">
                           <a:solidFill>
                             <a:srgbClr val="1B2233"/>
                           </a:solidFill>
                         </a:rPr>
                         <a:t>0.63</a:t>
                       </a:r>
-                      <a:endParaRPr lang="en-US" sz="1200" dirty="0"/>
+                      <a:endParaRPr lang="en-US" sz="1100" dirty="0"/>
                     </a:p>
                   </a:txBody>
-                  <a:tcPr marL="27432" marR="27432" marT="27432" marB="27432" anchor="ctr">
+                  <a:tcPr marL="54864" marR="54864" marT="18288" marB="18288" anchor="ctr">
                     <a:lnL w="12700" cap="flat" cmpd="sng" algn="ctr">
                       <a:solidFill>
                         <a:srgbClr val="FFFFFF"/>
@@ -4040,9 +4376,9 @@
                       <a:headEnd type="none" w="med" len="med"/>
                       <a:tailEnd type="none" w="med" len="med"/>
                     </a:lnL>
-                    <a:lnR w="12700" cap="flat" cmpd="sng" algn="ctr">
-                      <a:solidFill>
-                        <a:srgbClr val="FFFFFF"/>
+                    <a:lnR w="38100" cap="flat" cmpd="sng" algn="ctr">
+                      <a:solidFill>
+                        <a:srgbClr val="4A5568"/>
                       </a:solidFill>
                       <a:prstDash val="solid"/>
                       <a:round/>
@@ -4081,20 +4417,20 @@
                         <a:buNone/>
                       </a:pPr>
                       <a:r>
-                        <a:rPr lang="en-US" sz="1200" dirty="0">
+                        <a:rPr lang="en-US" sz="1100" dirty="0">
                           <a:solidFill>
                             <a:srgbClr val="1B2233"/>
                           </a:solidFill>
                         </a:rPr>
                         <a:t>0.59</a:t>
                       </a:r>
-                      <a:endParaRPr lang="en-US" sz="1200" dirty="0"/>
+                      <a:endParaRPr lang="en-US" sz="1100" dirty="0"/>
                     </a:p>
                   </a:txBody>
-                  <a:tcPr marL="27432" marR="27432" marT="27432" marB="27432" anchor="ctr">
-                    <a:lnL w="12700" cap="flat" cmpd="sng" algn="ctr">
-                      <a:solidFill>
-                        <a:srgbClr val="FFFFFF"/>
+                  <a:tcPr marL="54864" marR="54864" marT="18288" marB="18288" anchor="ctr">
+                    <a:lnL w="38100" cap="flat" cmpd="sng" algn="ctr">
+                      <a:solidFill>
+                        <a:srgbClr val="4A5568"/>
                       </a:solidFill>
                       <a:prstDash val="solid"/>
                       <a:round/>
@@ -4142,17 +4478,17 @@
                         <a:buNone/>
                       </a:pPr>
                       <a:r>
-                        <a:rPr lang="en-US" sz="1200" dirty="0">
+                        <a:rPr lang="en-US" sz="1100" dirty="0">
                           <a:solidFill>
                             <a:srgbClr val="1B2233"/>
                           </a:solidFill>
                         </a:rPr>
                         <a:t>0.78</a:t>
                       </a:r>
-                      <a:endParaRPr lang="en-US" sz="1200" dirty="0"/>
+                      <a:endParaRPr lang="en-US" sz="1100" dirty="0"/>
                     </a:p>
                   </a:txBody>
-                  <a:tcPr marL="27432" marR="27432" marT="27432" marB="27432" anchor="ctr">
+                  <a:tcPr marL="54864" marR="54864" marT="18288" marB="18288" anchor="ctr">
                     <a:lnL w="12700" cap="flat" cmpd="sng" algn="ctr">
                       <a:solidFill>
                         <a:srgbClr val="FFFFFF"/>
@@ -4203,20 +4539,81 @@
                         <a:buNone/>
                       </a:pPr>
                       <a:r>
-                        <a:rPr lang="en-US" sz="1200" dirty="0">
+                        <a:rPr lang="en-US" sz="1100" dirty="0">
                           <a:solidFill>
                             <a:srgbClr val="1B2233"/>
                           </a:solidFill>
                         </a:rPr>
                         <a:t>0.84</a:t>
                       </a:r>
-                      <a:endParaRPr lang="en-US" sz="1200" dirty="0"/>
+                      <a:endParaRPr lang="en-US" sz="1100" dirty="0"/>
                     </a:p>
                   </a:txBody>
-                  <a:tcPr marL="27432" marR="27432" marT="27432" marB="27432" anchor="ctr">
+                  <a:tcPr marL="54864" marR="54864" marT="18288" marB="18288" anchor="ctr">
                     <a:lnL w="12700" cap="flat" cmpd="sng" algn="ctr">
                       <a:solidFill>
                         <a:srgbClr val="FFFFFF"/>
+                      </a:solidFill>
+                      <a:prstDash val="solid"/>
+                      <a:round/>
+                      <a:headEnd type="none" w="med" len="med"/>
+                      <a:tailEnd type="none" w="med" len="med"/>
+                    </a:lnL>
+                    <a:lnR w="38100" cap="flat" cmpd="sng" algn="ctr">
+                      <a:solidFill>
+                        <a:srgbClr val="4A5568"/>
+                      </a:solidFill>
+                      <a:prstDash val="solid"/>
+                      <a:round/>
+                      <a:headEnd type="none" w="med" len="med"/>
+                      <a:tailEnd type="none" w="med" len="med"/>
+                    </a:lnR>
+                    <a:lnT w="12700" cap="flat" cmpd="sng" algn="ctr">
+                      <a:solidFill>
+                        <a:srgbClr val="FFFFFF"/>
+                      </a:solidFill>
+                      <a:prstDash val="solid"/>
+                      <a:round/>
+                      <a:headEnd type="none" w="med" len="med"/>
+                      <a:tailEnd type="none" w="med" len="med"/>
+                    </a:lnT>
+                    <a:lnB w="12700" cap="flat" cmpd="sng" algn="ctr">
+                      <a:solidFill>
+                        <a:srgbClr val="FFFFFF"/>
+                      </a:solidFill>
+                      <a:prstDash val="solid"/>
+                      <a:round/>
+                      <a:headEnd type="none" w="med" len="med"/>
+                      <a:tailEnd type="none" w="med" len="med"/>
+                    </a:lnB>
+                    <a:solidFill>
+                      <a:srgbClr val="D3ECEE"/>
+                    </a:solidFill>
+                  </a:tcPr>
+                </a:tc>
+                <a:tc>
+                  <a:txBody>
+                    <a:bodyPr/>
+                    <a:lstStyle/>
+                    <a:p>
+                      <a:pPr algn="ctr" indent="0" marL="0">
+                        <a:buNone/>
+                      </a:pPr>
+                      <a:r>
+                        <a:rPr lang="en-US" sz="1100" dirty="0">
+                          <a:solidFill>
+                            <a:srgbClr val="1B2233"/>
+                          </a:solidFill>
+                        </a:rPr>
+                        <a:t>0.66</a:t>
+                      </a:r>
+                      <a:endParaRPr lang="en-US" sz="1100" dirty="0"/>
+                    </a:p>
+                  </a:txBody>
+                  <a:tcPr marL="54864" marR="54864" marT="18288" marB="18288" anchor="ctr">
+                    <a:lnL w="38100" cap="flat" cmpd="sng" algn="ctr">
+                      <a:solidFill>
+                        <a:srgbClr val="4A5568"/>
                       </a:solidFill>
                       <a:prstDash val="solid"/>
                       <a:round/>
@@ -4264,17 +4661,17 @@
                         <a:buNone/>
                       </a:pPr>
                       <a:r>
-                        <a:rPr lang="en-US" sz="1200" dirty="0">
+                        <a:rPr lang="en-US" sz="1100" dirty="0">
                           <a:solidFill>
                             <a:srgbClr val="1B2233"/>
                           </a:solidFill>
                         </a:rPr>
                         <a:t>0.87</a:t>
                       </a:r>
-                      <a:endParaRPr lang="en-US" sz="1200" dirty="0"/>
+                      <a:endParaRPr lang="en-US" sz="1100" dirty="0"/>
                     </a:p>
                   </a:txBody>
-                  <a:tcPr marL="27432" marR="27432" marT="27432" marB="27432" anchor="ctr">
+                  <a:tcPr marL="54864" marR="54864" marT="18288" marB="18288" anchor="ctr">
                     <a:lnL w="12700" cap="flat" cmpd="sng" algn="ctr">
                       <a:solidFill>
                         <a:srgbClr val="FFFFFF"/>
@@ -4317,7 +4714,7 @@
                   </a:tcPr>
                 </a:tc>
               </a:tr>
-              <a:tr h="246888">
+              <a:tr h="210312">
                 <a:tc>
                   <a:txBody>
                     <a:bodyPr/>
@@ -4327,17 +4724,17 @@
                         <a:buNone/>
                       </a:pPr>
                       <a:r>
-                        <a:rPr lang="en-US" sz="1200" b="1" dirty="0">
+                        <a:rPr lang="en-US" sz="1100" b="1" dirty="0">
                           <a:solidFill>
                             <a:srgbClr val="1B2233"/>
                           </a:solidFill>
                         </a:rPr>
                         <a:t>head pixel error</a:t>
                       </a:r>
-                      <a:endParaRPr lang="en-US" sz="1200" dirty="0"/>
+                      <a:endParaRPr lang="en-US" sz="1100" dirty="0"/>
                     </a:p>
                   </a:txBody>
-                  <a:tcPr marL="27432" marR="27432" marT="27432" marB="27432" anchor="ctr">
+                  <a:tcPr marL="54864" marR="54864" marT="18288" marB="18288" anchor="ctr">
                     <a:lnL w="12700" cap="flat" cmpd="sng" algn="ctr">
                       <a:solidFill>
                         <a:srgbClr val="FFFFFF"/>
@@ -4388,17 +4785,17 @@
                         <a:buNone/>
                       </a:pPr>
                       <a:r>
-                        <a:rPr lang="en-US" sz="1200" dirty="0">
+                        <a:rPr lang="en-US" sz="1100" dirty="0">
                           <a:solidFill>
                             <a:srgbClr val="1B2233"/>
                           </a:solidFill>
                         </a:rPr>
                         <a:t>64.5 px</a:t>
                       </a:r>
-                      <a:endParaRPr lang="en-US" sz="1200" dirty="0"/>
+                      <a:endParaRPr lang="en-US" sz="1100" dirty="0"/>
                     </a:p>
                   </a:txBody>
-                  <a:tcPr marL="27432" marR="27432" marT="27432" marB="27432" anchor="ctr">
+                  <a:tcPr marL="54864" marR="54864" marT="18288" marB="18288" anchor="ctr">
                     <a:lnL w="12700" cap="flat" cmpd="sng" algn="ctr">
                       <a:solidFill>
                         <a:srgbClr val="FFFFFF"/>
@@ -4408,9 +4805,9 @@
                       <a:headEnd type="none" w="med" len="med"/>
                       <a:tailEnd type="none" w="med" len="med"/>
                     </a:lnL>
-                    <a:lnR w="12700" cap="flat" cmpd="sng" algn="ctr">
-                      <a:solidFill>
-                        <a:srgbClr val="FFFFFF"/>
+                    <a:lnR w="38100" cap="flat" cmpd="sng" algn="ctr">
+                      <a:solidFill>
+                        <a:srgbClr val="4A5568"/>
                       </a:solidFill>
                       <a:prstDash val="solid"/>
                       <a:round/>
@@ -4449,20 +4846,20 @@
                         <a:buNone/>
                       </a:pPr>
                       <a:r>
-                        <a:rPr lang="en-US" sz="1200" dirty="0">
+                        <a:rPr lang="en-US" sz="1100" dirty="0">
                           <a:solidFill>
                             <a:srgbClr val="1B2233"/>
                           </a:solidFill>
                         </a:rPr>
                         <a:t>64.0 px</a:t>
                       </a:r>
-                      <a:endParaRPr lang="en-US" sz="1200" dirty="0"/>
+                      <a:endParaRPr lang="en-US" sz="1100" dirty="0"/>
                     </a:p>
                   </a:txBody>
-                  <a:tcPr marL="27432" marR="27432" marT="27432" marB="27432" anchor="ctr">
-                    <a:lnL w="12700" cap="flat" cmpd="sng" algn="ctr">
-                      <a:solidFill>
-                        <a:srgbClr val="FFFFFF"/>
+                  <a:tcPr marL="54864" marR="54864" marT="18288" marB="18288" anchor="ctr">
+                    <a:lnL w="38100" cap="flat" cmpd="sng" algn="ctr">
+                      <a:solidFill>
+                        <a:srgbClr val="4A5568"/>
                       </a:solidFill>
                       <a:prstDash val="solid"/>
                       <a:round/>
@@ -4510,17 +4907,17 @@
                         <a:buNone/>
                       </a:pPr>
                       <a:r>
-                        <a:rPr lang="en-US" sz="1200" dirty="0">
+                        <a:rPr lang="en-US" sz="1100" dirty="0">
                           <a:solidFill>
                             <a:srgbClr val="1B2233"/>
                           </a:solidFill>
                         </a:rPr>
                         <a:t>7.6 px</a:t>
                       </a:r>
-                      <a:endParaRPr lang="en-US" sz="1200" dirty="0"/>
+                      <a:endParaRPr lang="en-US" sz="1100" dirty="0"/>
                     </a:p>
                   </a:txBody>
-                  <a:tcPr marL="27432" marR="27432" marT="27432" marB="27432" anchor="ctr">
+                  <a:tcPr marL="54864" marR="54864" marT="18288" marB="18288" anchor="ctr">
                     <a:lnL w="12700" cap="flat" cmpd="sng" algn="ctr">
                       <a:solidFill>
                         <a:srgbClr val="FFFFFF"/>
@@ -4571,20 +4968,81 @@
                         <a:buNone/>
                       </a:pPr>
                       <a:r>
-                        <a:rPr lang="en-US" sz="1200" dirty="0">
+                        <a:rPr lang="en-US" sz="1100" dirty="0">
                           <a:solidFill>
                             <a:srgbClr val="1B2233"/>
                           </a:solidFill>
                         </a:rPr>
                         <a:t>7.2 px</a:t>
                       </a:r>
-                      <a:endParaRPr lang="en-US" sz="1200" dirty="0"/>
+                      <a:endParaRPr lang="en-US" sz="1100" dirty="0"/>
                     </a:p>
                   </a:txBody>
-                  <a:tcPr marL="27432" marR="27432" marT="27432" marB="27432" anchor="ctr">
+                  <a:tcPr marL="54864" marR="54864" marT="18288" marB="18288" anchor="ctr">
                     <a:lnL w="12700" cap="flat" cmpd="sng" algn="ctr">
                       <a:solidFill>
                         <a:srgbClr val="FFFFFF"/>
+                      </a:solidFill>
+                      <a:prstDash val="solid"/>
+                      <a:round/>
+                      <a:headEnd type="none" w="med" len="med"/>
+                      <a:tailEnd type="none" w="med" len="med"/>
+                    </a:lnL>
+                    <a:lnR w="38100" cap="flat" cmpd="sng" algn="ctr">
+                      <a:solidFill>
+                        <a:srgbClr val="4A5568"/>
+                      </a:solidFill>
+                      <a:prstDash val="solid"/>
+                      <a:round/>
+                      <a:headEnd type="none" w="med" len="med"/>
+                      <a:tailEnd type="none" w="med" len="med"/>
+                    </a:lnR>
+                    <a:lnT w="12700" cap="flat" cmpd="sng" algn="ctr">
+                      <a:solidFill>
+                        <a:srgbClr val="FFFFFF"/>
+                      </a:solidFill>
+                      <a:prstDash val="solid"/>
+                      <a:round/>
+                      <a:headEnd type="none" w="med" len="med"/>
+                      <a:tailEnd type="none" w="med" len="med"/>
+                    </a:lnT>
+                    <a:lnB w="12700" cap="flat" cmpd="sng" algn="ctr">
+                      <a:solidFill>
+                        <a:srgbClr val="FFFFFF"/>
+                      </a:solidFill>
+                      <a:prstDash val="solid"/>
+                      <a:round/>
+                      <a:headEnd type="none" w="med" len="med"/>
+                      <a:tailEnd type="none" w="med" len="med"/>
+                    </a:lnB>
+                    <a:solidFill>
+                      <a:srgbClr val="D3ECEE"/>
+                    </a:solidFill>
+                  </a:tcPr>
+                </a:tc>
+                <a:tc>
+                  <a:txBody>
+                    <a:bodyPr/>
+                    <a:lstStyle/>
+                    <a:p>
+                      <a:pPr algn="ctr" indent="0" marL="0">
+                        <a:buNone/>
+                      </a:pPr>
+                      <a:r>
+                        <a:rPr lang="en-US" sz="1100" dirty="0">
+                          <a:solidFill>
+                            <a:srgbClr val="1B2233"/>
+                          </a:solidFill>
+                        </a:rPr>
+                        <a:t>58.1 px</a:t>
+                      </a:r>
+                      <a:endParaRPr lang="en-US" sz="1100" dirty="0"/>
+                    </a:p>
+                  </a:txBody>
+                  <a:tcPr marL="54864" marR="54864" marT="18288" marB="18288" anchor="ctr">
+                    <a:lnL w="38100" cap="flat" cmpd="sng" algn="ctr">
+                      <a:solidFill>
+                        <a:srgbClr val="4A5568"/>
                       </a:solidFill>
                       <a:prstDash val="solid"/>
                       <a:round/>
@@ -4632,17 +5090,17 @@
                         <a:buNone/>
                       </a:pPr>
                       <a:r>
-                        <a:rPr lang="en-US" sz="1200" dirty="0">
+                        <a:rPr lang="en-US" sz="1100" dirty="0">
                           <a:solidFill>
                             <a:srgbClr val="1B2233"/>
                           </a:solidFill>
                         </a:rPr>
                         <a:t>8.8 px</a:t>
                       </a:r>
-                      <a:endParaRPr lang="en-US" sz="1200" dirty="0"/>
+                      <a:endParaRPr lang="en-US" sz="1100" dirty="0"/>
                     </a:p>
                   </a:txBody>
-                  <a:tcPr marL="27432" marR="27432" marT="27432" marB="27432" anchor="ctr">
+                  <a:tcPr marL="54864" marR="54864" marT="18288" marB="18288" anchor="ctr">
                     <a:lnL w="12700" cap="flat" cmpd="sng" algn="ctr">
                       <a:solidFill>
                         <a:srgbClr val="FFFFFF"/>
@@ -4685,7 +5143,7 @@
                   </a:tcPr>
                 </a:tc>
               </a:tr>
-              <a:tr h="246888">
+              <a:tr h="210312">
                 <a:tc>
                   <a:txBody>
                     <a:bodyPr/>
@@ -4695,17 +5153,17 @@
                         <a:buNone/>
                       </a:pPr>
                       <a:r>
-                        <a:rPr lang="en-US" sz="1200" b="1" dirty="0">
+                        <a:rPr lang="en-US" sz="1100" b="1" dirty="0">
                           <a:solidFill>
                             <a:srgbClr val="1B2233"/>
                           </a:solidFill>
                         </a:rPr>
                         <a:t>pelvis pixel error</a:t>
                       </a:r>
-                      <a:endParaRPr lang="en-US" sz="1200" dirty="0"/>
+                      <a:endParaRPr lang="en-US" sz="1100" dirty="0"/>
                     </a:p>
                   </a:txBody>
-                  <a:tcPr marL="27432" marR="27432" marT="27432" marB="27432" anchor="ctr">
+                  <a:tcPr marL="54864" marR="54864" marT="18288" marB="18288" anchor="ctr">
                     <a:lnL w="12700" cap="flat" cmpd="sng" algn="ctr">
                       <a:solidFill>
                         <a:srgbClr val="FFFFFF"/>
@@ -4756,17 +5214,17 @@
                         <a:buNone/>
                       </a:pPr>
                       <a:r>
-                        <a:rPr lang="en-US" sz="1200" dirty="0">
+                        <a:rPr lang="en-US" sz="1100" dirty="0">
                           <a:solidFill>
                             <a:srgbClr val="1B2233"/>
                           </a:solidFill>
                         </a:rPr>
                         <a:t>23.4 px</a:t>
                       </a:r>
-                      <a:endParaRPr lang="en-US" sz="1200" dirty="0"/>
+                      <a:endParaRPr lang="en-US" sz="1100" dirty="0"/>
                     </a:p>
                   </a:txBody>
-                  <a:tcPr marL="27432" marR="27432" marT="27432" marB="27432" anchor="ctr">
+                  <a:tcPr marL="54864" marR="54864" marT="18288" marB="18288" anchor="ctr">
                     <a:lnL w="12700" cap="flat" cmpd="sng" algn="ctr">
                       <a:solidFill>
                         <a:srgbClr val="FFFFFF"/>
@@ -4776,9 +5234,9 @@
                       <a:headEnd type="none" w="med" len="med"/>
                       <a:tailEnd type="none" w="med" len="med"/>
                     </a:lnL>
-                    <a:lnR w="12700" cap="flat" cmpd="sng" algn="ctr">
-                      <a:solidFill>
-                        <a:srgbClr val="FFFFFF"/>
+                    <a:lnR w="38100" cap="flat" cmpd="sng" algn="ctr">
+                      <a:solidFill>
+                        <a:srgbClr val="4A5568"/>
                       </a:solidFill>
                       <a:prstDash val="solid"/>
                       <a:round/>
@@ -4817,20 +5275,20 @@
                         <a:buNone/>
                       </a:pPr>
                       <a:r>
-                        <a:rPr lang="en-US" sz="1200" dirty="0">
+                        <a:rPr lang="en-US" sz="1100" dirty="0">
                           <a:solidFill>
                             <a:srgbClr val="1B2233"/>
                           </a:solidFill>
                         </a:rPr>
                         <a:t>24.3 px</a:t>
                       </a:r>
-                      <a:endParaRPr lang="en-US" sz="1200" dirty="0"/>
+                      <a:endParaRPr lang="en-US" sz="1100" dirty="0"/>
                     </a:p>
                   </a:txBody>
-                  <a:tcPr marL="27432" marR="27432" marT="27432" marB="27432" anchor="ctr">
-                    <a:lnL w="12700" cap="flat" cmpd="sng" algn="ctr">
-                      <a:solidFill>
-                        <a:srgbClr val="FFFFFF"/>
+                  <a:tcPr marL="54864" marR="54864" marT="18288" marB="18288" anchor="ctr">
+                    <a:lnL w="38100" cap="flat" cmpd="sng" algn="ctr">
+                      <a:solidFill>
+                        <a:srgbClr val="4A5568"/>
                       </a:solidFill>
                       <a:prstDash val="solid"/>
                       <a:round/>
@@ -4878,17 +5336,17 @@
                         <a:buNone/>
                       </a:pPr>
                       <a:r>
-                        <a:rPr lang="en-US" sz="1200" dirty="0">
+                        <a:rPr lang="en-US" sz="1100" dirty="0">
                           <a:solidFill>
                             <a:srgbClr val="1B2233"/>
                           </a:solidFill>
                         </a:rPr>
                         <a:t>38.5 px</a:t>
                       </a:r>
-                      <a:endParaRPr lang="en-US" sz="1200" dirty="0"/>
+                      <a:endParaRPr lang="en-US" sz="1100" dirty="0"/>
                     </a:p>
                   </a:txBody>
-                  <a:tcPr marL="27432" marR="27432" marT="27432" marB="27432" anchor="ctr">
+                  <a:tcPr marL="54864" marR="54864" marT="18288" marB="18288" anchor="ctr">
                     <a:lnL w="12700" cap="flat" cmpd="sng" algn="ctr">
                       <a:solidFill>
                         <a:srgbClr val="FFFFFF"/>
@@ -4939,20 +5397,81 @@
                         <a:buNone/>
                       </a:pPr>
                       <a:r>
-                        <a:rPr lang="en-US" sz="1200" dirty="0">
+                        <a:rPr lang="en-US" sz="1100" dirty="0">
                           <a:solidFill>
                             <a:srgbClr val="1B2233"/>
                           </a:solidFill>
                         </a:rPr>
                         <a:t>33.1 px</a:t>
                       </a:r>
-                      <a:endParaRPr lang="en-US" sz="1200" dirty="0"/>
+                      <a:endParaRPr lang="en-US" sz="1100" dirty="0"/>
                     </a:p>
                   </a:txBody>
-                  <a:tcPr marL="27432" marR="27432" marT="27432" marB="27432" anchor="ctr">
+                  <a:tcPr marL="54864" marR="54864" marT="18288" marB="18288" anchor="ctr">
                     <a:lnL w="12700" cap="flat" cmpd="sng" algn="ctr">
                       <a:solidFill>
                         <a:srgbClr val="FFFFFF"/>
+                      </a:solidFill>
+                      <a:prstDash val="solid"/>
+                      <a:round/>
+                      <a:headEnd type="none" w="med" len="med"/>
+                      <a:tailEnd type="none" w="med" len="med"/>
+                    </a:lnL>
+                    <a:lnR w="38100" cap="flat" cmpd="sng" algn="ctr">
+                      <a:solidFill>
+                        <a:srgbClr val="4A5568"/>
+                      </a:solidFill>
+                      <a:prstDash val="solid"/>
+                      <a:round/>
+                      <a:headEnd type="none" w="med" len="med"/>
+                      <a:tailEnd type="none" w="med" len="med"/>
+                    </a:lnR>
+                    <a:lnT w="12700" cap="flat" cmpd="sng" algn="ctr">
+                      <a:solidFill>
+                        <a:srgbClr val="FFFFFF"/>
+                      </a:solidFill>
+                      <a:prstDash val="solid"/>
+                      <a:round/>
+                      <a:headEnd type="none" w="med" len="med"/>
+                      <a:tailEnd type="none" w="med" len="med"/>
+                    </a:lnT>
+                    <a:lnB w="12700" cap="flat" cmpd="sng" algn="ctr">
+                      <a:solidFill>
+                        <a:srgbClr val="FFFFFF"/>
+                      </a:solidFill>
+                      <a:prstDash val="solid"/>
+                      <a:round/>
+                      <a:headEnd type="none" w="med" len="med"/>
+                      <a:tailEnd type="none" w="med" len="med"/>
+                    </a:lnB>
+                    <a:solidFill>
+                      <a:srgbClr val="D3ECEE"/>
+                    </a:solidFill>
+                  </a:tcPr>
+                </a:tc>
+                <a:tc>
+                  <a:txBody>
+                    <a:bodyPr/>
+                    <a:lstStyle/>
+                    <a:p>
+                      <a:pPr algn="ctr" indent="0" marL="0">
+                        <a:buNone/>
+                      </a:pPr>
+                      <a:r>
+                        <a:rPr lang="en-US" sz="1100" dirty="0">
+                          <a:solidFill>
+                            <a:srgbClr val="1B2233"/>
+                          </a:solidFill>
+                        </a:rPr>
+                        <a:t>23.3 px</a:t>
+                      </a:r>
+                      <a:endParaRPr lang="en-US" sz="1100" dirty="0"/>
+                    </a:p>
+                  </a:txBody>
+                  <a:tcPr marL="54864" marR="54864" marT="18288" marB="18288" anchor="ctr">
+                    <a:lnL w="38100" cap="flat" cmpd="sng" algn="ctr">
+                      <a:solidFill>
+                        <a:srgbClr val="4A5568"/>
                       </a:solidFill>
                       <a:prstDash val="solid"/>
                       <a:round/>
@@ -5000,17 +5519,17 @@
                         <a:buNone/>
                       </a:pPr>
                       <a:r>
-                        <a:rPr lang="en-US" sz="1200" dirty="0">
+                        <a:rPr lang="en-US" sz="1100" dirty="0">
                           <a:solidFill>
                             <a:srgbClr val="1B2233"/>
                           </a:solidFill>
                         </a:rPr>
                         <a:t>31.4 px</a:t>
                       </a:r>
-                      <a:endParaRPr lang="en-US" sz="1200" dirty="0"/>
+                      <a:endParaRPr lang="en-US" sz="1100" dirty="0"/>
                     </a:p>
                   </a:txBody>
-                  <a:tcPr marL="27432" marR="27432" marT="27432" marB="27432" anchor="ctr">
+                  <a:tcPr marL="54864" marR="54864" marT="18288" marB="18288" anchor="ctr">
                     <a:lnL w="12700" cap="flat" cmpd="sng" algn="ctr">
                       <a:solidFill>
                         <a:srgbClr val="FFFFFF"/>
@@ -5053,7 +5572,7 @@
                   </a:tcPr>
                 </a:tc>
               </a:tr>
-              <a:tr h="246888">
+              <a:tr h="210312">
                 <a:tc>
                   <a:txBody>
                     <a:bodyPr/>
@@ -5063,17 +5582,17 @@
                         <a:buNone/>
                       </a:pPr>
                       <a:r>
-                        <a:rPr lang="en-US" sz="1200" b="1" dirty="0">
+                        <a:rPr lang="en-US" sz="1100" b="1" dirty="0">
                           <a:solidFill>
                             <a:srgbClr val="1B2233"/>
                           </a:solidFill>
                         </a:rPr>
                         <a:t>PVE (pelvis-centred)</a:t>
                       </a:r>
-                      <a:endParaRPr lang="en-US" sz="1200" dirty="0"/>
+                      <a:endParaRPr lang="en-US" sz="1100" dirty="0"/>
                     </a:p>
                   </a:txBody>
-                  <a:tcPr marL="27432" marR="27432" marT="27432" marB="27432" anchor="ctr">
+                  <a:tcPr marL="54864" marR="54864" marT="18288" marB="18288" anchor="ctr">
                     <a:lnL w="12700" cap="flat" cmpd="sng" algn="ctr">
                       <a:solidFill>
                         <a:srgbClr val="FFFFFF"/>
@@ -5124,17 +5643,17 @@
                         <a:buNone/>
                       </a:pPr>
                       <a:r>
-                        <a:rPr lang="en-US" sz="1200" dirty="0">
+                        <a:rPr lang="en-US" sz="1100" dirty="0">
                           <a:solidFill>
                             <a:srgbClr val="1B2233"/>
                           </a:solidFill>
                         </a:rPr>
                         <a:t>70.5 mm</a:t>
                       </a:r>
-                      <a:endParaRPr lang="en-US" sz="1200" dirty="0"/>
+                      <a:endParaRPr lang="en-US" sz="1100" dirty="0"/>
                     </a:p>
                   </a:txBody>
-                  <a:tcPr marL="27432" marR="27432" marT="27432" marB="27432" anchor="ctr">
+                  <a:tcPr marL="54864" marR="54864" marT="18288" marB="18288" anchor="ctr">
                     <a:lnL w="12700" cap="flat" cmpd="sng" algn="ctr">
                       <a:solidFill>
                         <a:srgbClr val="FFFFFF"/>
@@ -5144,9 +5663,9 @@
                       <a:headEnd type="none" w="med" len="med"/>
                       <a:tailEnd type="none" w="med" len="med"/>
                     </a:lnL>
-                    <a:lnR w="12700" cap="flat" cmpd="sng" algn="ctr">
-                      <a:solidFill>
-                        <a:srgbClr val="FFFFFF"/>
+                    <a:lnR w="38100" cap="flat" cmpd="sng" algn="ctr">
+                      <a:solidFill>
+                        <a:srgbClr val="4A5568"/>
                       </a:solidFill>
                       <a:prstDash val="solid"/>
                       <a:round/>
@@ -5185,20 +5704,20 @@
                         <a:buNone/>
                       </a:pPr>
                       <a:r>
-                        <a:rPr lang="en-US" sz="1200" dirty="0">
+                        <a:rPr lang="en-US" sz="1100" dirty="0">
                           <a:solidFill>
                             <a:srgbClr val="1B2233"/>
                           </a:solidFill>
                         </a:rPr>
                         <a:t>72.2 mm</a:t>
                       </a:r>
-                      <a:endParaRPr lang="en-US" sz="1200" dirty="0"/>
+                      <a:endParaRPr lang="en-US" sz="1100" dirty="0"/>
                     </a:p>
                   </a:txBody>
-                  <a:tcPr marL="27432" marR="27432" marT="27432" marB="27432" anchor="ctr">
-                    <a:lnL w="12700" cap="flat" cmpd="sng" algn="ctr">
-                      <a:solidFill>
-                        <a:srgbClr val="FFFFFF"/>
+                  <a:tcPr marL="54864" marR="54864" marT="18288" marB="18288" anchor="ctr">
+                    <a:lnL w="38100" cap="flat" cmpd="sng" algn="ctr">
+                      <a:solidFill>
+                        <a:srgbClr val="4A5568"/>
                       </a:solidFill>
                       <a:prstDash val="solid"/>
                       <a:round/>
@@ -5246,17 +5765,17 @@
                         <a:buNone/>
                       </a:pPr>
                       <a:r>
-                        <a:rPr lang="en-US" sz="1200" dirty="0">
+                        <a:rPr lang="en-US" sz="1100" dirty="0">
                           <a:solidFill>
                             <a:srgbClr val="1B2233"/>
                           </a:solidFill>
                         </a:rPr>
                         <a:t>75.5 mm</a:t>
                       </a:r>
-                      <a:endParaRPr lang="en-US" sz="1200" dirty="0"/>
+                      <a:endParaRPr lang="en-US" sz="1100" dirty="0"/>
                     </a:p>
                   </a:txBody>
-                  <a:tcPr marL="27432" marR="27432" marT="27432" marB="27432" anchor="ctr">
+                  <a:tcPr marL="54864" marR="54864" marT="18288" marB="18288" anchor="ctr">
                     <a:lnL w="12700" cap="flat" cmpd="sng" algn="ctr">
                       <a:solidFill>
                         <a:srgbClr val="FFFFFF"/>
@@ -5307,20 +5826,81 @@
                         <a:buNone/>
                       </a:pPr>
                       <a:r>
-                        <a:rPr lang="en-US" sz="1200" dirty="0">
+                        <a:rPr lang="en-US" sz="1100" dirty="0">
                           <a:solidFill>
                             <a:srgbClr val="1B2233"/>
                           </a:solidFill>
                         </a:rPr>
                         <a:t>74.8 mm</a:t>
                       </a:r>
-                      <a:endParaRPr lang="en-US" sz="1200" dirty="0"/>
+                      <a:endParaRPr lang="en-US" sz="1100" dirty="0"/>
                     </a:p>
                   </a:txBody>
-                  <a:tcPr marL="27432" marR="27432" marT="27432" marB="27432" anchor="ctr">
+                  <a:tcPr marL="54864" marR="54864" marT="18288" marB="18288" anchor="ctr">
                     <a:lnL w="12700" cap="flat" cmpd="sng" algn="ctr">
                       <a:solidFill>
                         <a:srgbClr val="FFFFFF"/>
+                      </a:solidFill>
+                      <a:prstDash val="solid"/>
+                      <a:round/>
+                      <a:headEnd type="none" w="med" len="med"/>
+                      <a:tailEnd type="none" w="med" len="med"/>
+                    </a:lnL>
+                    <a:lnR w="38100" cap="flat" cmpd="sng" algn="ctr">
+                      <a:solidFill>
+                        <a:srgbClr val="4A5568"/>
+                      </a:solidFill>
+                      <a:prstDash val="solid"/>
+                      <a:round/>
+                      <a:headEnd type="none" w="med" len="med"/>
+                      <a:tailEnd type="none" w="med" len="med"/>
+                    </a:lnR>
+                    <a:lnT w="12700" cap="flat" cmpd="sng" algn="ctr">
+                      <a:solidFill>
+                        <a:srgbClr val="FFFFFF"/>
+                      </a:solidFill>
+                      <a:prstDash val="solid"/>
+                      <a:round/>
+                      <a:headEnd type="none" w="med" len="med"/>
+                      <a:tailEnd type="none" w="med" len="med"/>
+                    </a:lnT>
+                    <a:lnB w="12700" cap="flat" cmpd="sng" algn="ctr">
+                      <a:solidFill>
+                        <a:srgbClr val="FFFFFF"/>
+                      </a:solidFill>
+                      <a:prstDash val="solid"/>
+                      <a:round/>
+                      <a:headEnd type="none" w="med" len="med"/>
+                      <a:tailEnd type="none" w="med" len="med"/>
+                    </a:lnB>
+                    <a:solidFill>
+                      <a:srgbClr val="D3ECEE"/>
+                    </a:solidFill>
+                  </a:tcPr>
+                </a:tc>
+                <a:tc>
+                  <a:txBody>
+                    <a:bodyPr/>
+                    <a:lstStyle/>
+                    <a:p>
+                      <a:pPr algn="ctr" indent="0" marL="0">
+                        <a:buNone/>
+                      </a:pPr>
+                      <a:r>
+                        <a:rPr lang="en-US" sz="1100" dirty="0">
+                          <a:solidFill>
+                            <a:srgbClr val="1B2233"/>
+                          </a:solidFill>
+                        </a:rPr>
+                        <a:t>72.3 mm</a:t>
+                      </a:r>
+                      <a:endParaRPr lang="en-US" sz="1100" dirty="0"/>
+                    </a:p>
+                  </a:txBody>
+                  <a:tcPr marL="54864" marR="54864" marT="18288" marB="18288" anchor="ctr">
+                    <a:lnL w="38100" cap="flat" cmpd="sng" algn="ctr">
+                      <a:solidFill>
+                        <a:srgbClr val="4A5568"/>
                       </a:solidFill>
                       <a:prstDash val="solid"/>
                       <a:round/>
@@ -5368,17 +5948,17 @@
                         <a:buNone/>
                       </a:pPr>
                       <a:r>
-                        <a:rPr lang="en-US" sz="1200" dirty="0">
+                        <a:rPr lang="en-US" sz="1100" dirty="0">
                           <a:solidFill>
                             <a:srgbClr val="1B2233"/>
                           </a:solidFill>
                         </a:rPr>
                         <a:t>75.7 mm</a:t>
                       </a:r>
-                      <a:endParaRPr lang="en-US" sz="1200" dirty="0"/>
+                      <a:endParaRPr lang="en-US" sz="1100" dirty="0"/>
                     </a:p>
                   </a:txBody>
-                  <a:tcPr marL="27432" marR="27432" marT="27432" marB="27432" anchor="ctr">
+                  <a:tcPr marL="54864" marR="54864" marT="18288" marB="18288" anchor="ctr">
                     <a:lnL w="12700" cap="flat" cmpd="sng" algn="ctr">
                       <a:solidFill>
                         <a:srgbClr val="FFFFFF"/>
@@ -5421,7 +6001,7 @@
                   </a:tcPr>
                 </a:tc>
               </a:tr>
-              <a:tr h="246888">
+              <a:tr h="210312">
                 <a:tc>
                   <a:txBody>
                     <a:bodyPr/>
@@ -5431,17 +6011,17 @@
                         <a:buNone/>
                       </a:pPr>
                       <a:r>
-                        <a:rPr lang="en-US" sz="1200" b="1" dirty="0">
+                        <a:rPr lang="en-US" sz="1100" b="1" dirty="0">
                           <a:solidFill>
                             <a:srgbClr val="1B2233"/>
                           </a:solidFill>
                         </a:rPr>
                         <a:t>recall</a:t>
                       </a:r>
-                      <a:endParaRPr lang="en-US" sz="1200" dirty="0"/>
+                      <a:endParaRPr lang="en-US" sz="1100" dirty="0"/>
                     </a:p>
                   </a:txBody>
-                  <a:tcPr marL="27432" marR="27432" marT="27432" marB="27432" anchor="ctr">
+                  <a:tcPr marL="54864" marR="54864" marT="18288" marB="18288" anchor="ctr">
                     <a:lnL w="12700" cap="flat" cmpd="sng" algn="ctr">
                       <a:solidFill>
                         <a:srgbClr val="FFFFFF"/>
@@ -5492,17 +6072,17 @@
                         <a:buNone/>
                       </a:pPr>
                       <a:r>
-                        <a:rPr lang="en-US" sz="1200" dirty="0">
+                        <a:rPr lang="en-US" sz="1100" dirty="0">
                           <a:solidFill>
                             <a:srgbClr val="1B2233"/>
                           </a:solidFill>
                         </a:rPr>
                         <a:t>90.2%</a:t>
                       </a:r>
-                      <a:endParaRPr lang="en-US" sz="1200" dirty="0"/>
+                      <a:endParaRPr lang="en-US" sz="1100" dirty="0"/>
                     </a:p>
                   </a:txBody>
-                  <a:tcPr marL="27432" marR="27432" marT="27432" marB="27432" anchor="ctr">
+                  <a:tcPr marL="54864" marR="54864" marT="18288" marB="18288" anchor="ctr">
                     <a:lnL w="12700" cap="flat" cmpd="sng" algn="ctr">
                       <a:solidFill>
                         <a:srgbClr val="FFFFFF"/>
@@ -5512,9 +6092,9 @@
                       <a:headEnd type="none" w="med" len="med"/>
                       <a:tailEnd type="none" w="med" len="med"/>
                     </a:lnL>
-                    <a:lnR w="12700" cap="flat" cmpd="sng" algn="ctr">
-                      <a:solidFill>
-                        <a:srgbClr val="FFFFFF"/>
+                    <a:lnR w="38100" cap="flat" cmpd="sng" algn="ctr">
+                      <a:solidFill>
+                        <a:srgbClr val="4A5568"/>
                       </a:solidFill>
                       <a:prstDash val="solid"/>
                       <a:round/>
@@ -5553,20 +6133,20 @@
                         <a:buNone/>
                       </a:pPr>
                       <a:r>
-                        <a:rPr lang="en-US" sz="1200" dirty="0">
+                        <a:rPr lang="en-US" sz="1100" dirty="0">
                           <a:solidFill>
                             <a:srgbClr val="1B2233"/>
                           </a:solidFill>
                         </a:rPr>
                         <a:t>89.4%</a:t>
                       </a:r>
-                      <a:endParaRPr lang="en-US" sz="1200" dirty="0"/>
+                      <a:endParaRPr lang="en-US" sz="1100" dirty="0"/>
                     </a:p>
                   </a:txBody>
-                  <a:tcPr marL="27432" marR="27432" marT="27432" marB="27432" anchor="ctr">
-                    <a:lnL w="12700" cap="flat" cmpd="sng" algn="ctr">
-                      <a:solidFill>
-                        <a:srgbClr val="FFFFFF"/>
+                  <a:tcPr marL="54864" marR="54864" marT="18288" marB="18288" anchor="ctr">
+                    <a:lnL w="38100" cap="flat" cmpd="sng" algn="ctr">
+                      <a:solidFill>
+                        <a:srgbClr val="4A5568"/>
                       </a:solidFill>
                       <a:prstDash val="solid"/>
                       <a:round/>
@@ -5614,17 +6194,17 @@
                         <a:buNone/>
                       </a:pPr>
                       <a:r>
-                        <a:rPr lang="en-US" sz="1200" dirty="0">
+                        <a:rPr lang="en-US" sz="1100" dirty="0">
                           <a:solidFill>
                             <a:srgbClr val="1B2233"/>
                           </a:solidFill>
                         </a:rPr>
                         <a:t>87.0%</a:t>
                       </a:r>
-                      <a:endParaRPr lang="en-US" sz="1200" dirty="0"/>
+                      <a:endParaRPr lang="en-US" sz="1100" dirty="0"/>
                     </a:p>
                   </a:txBody>
-                  <a:tcPr marL="27432" marR="27432" marT="27432" marB="27432" anchor="ctr">
+                  <a:tcPr marL="54864" marR="54864" marT="18288" marB="18288" anchor="ctr">
                     <a:lnL w="12700" cap="flat" cmpd="sng" algn="ctr">
                       <a:solidFill>
                         <a:srgbClr val="FFFFFF"/>
@@ -5675,20 +6255,81 @@
                         <a:buNone/>
                       </a:pPr>
                       <a:r>
-                        <a:rPr lang="en-US" sz="1200" dirty="0">
+                        <a:rPr lang="en-US" sz="1100" dirty="0">
                           <a:solidFill>
                             <a:srgbClr val="1B2233"/>
                           </a:solidFill>
                         </a:rPr>
                         <a:t>87.8%</a:t>
                       </a:r>
-                      <a:endParaRPr lang="en-US" sz="1200" dirty="0"/>
+                      <a:endParaRPr lang="en-US" sz="1100" dirty="0"/>
                     </a:p>
                   </a:txBody>
-                  <a:tcPr marL="27432" marR="27432" marT="27432" marB="27432" anchor="ctr">
+                  <a:tcPr marL="54864" marR="54864" marT="18288" marB="18288" anchor="ctr">
                     <a:lnL w="12700" cap="flat" cmpd="sng" algn="ctr">
                       <a:solidFill>
                         <a:srgbClr val="FFFFFF"/>
+                      </a:solidFill>
+                      <a:prstDash val="solid"/>
+                      <a:round/>
+                      <a:headEnd type="none" w="med" len="med"/>
+                      <a:tailEnd type="none" w="med" len="med"/>
+                    </a:lnL>
+                    <a:lnR w="38100" cap="flat" cmpd="sng" algn="ctr">
+                      <a:solidFill>
+                        <a:srgbClr val="4A5568"/>
+                      </a:solidFill>
+                      <a:prstDash val="solid"/>
+                      <a:round/>
+                      <a:headEnd type="none" w="med" len="med"/>
+                      <a:tailEnd type="none" w="med" len="med"/>
+                    </a:lnR>
+                    <a:lnT w="12700" cap="flat" cmpd="sng" algn="ctr">
+                      <a:solidFill>
+                        <a:srgbClr val="FFFFFF"/>
+                      </a:solidFill>
+                      <a:prstDash val="solid"/>
+                      <a:round/>
+                      <a:headEnd type="none" w="med" len="med"/>
+                      <a:tailEnd type="none" w="med" len="med"/>
+                    </a:lnT>
+                    <a:lnB w="12700" cap="flat" cmpd="sng" algn="ctr">
+                      <a:solidFill>
+                        <a:srgbClr val="FFFFFF"/>
+                      </a:solidFill>
+                      <a:prstDash val="solid"/>
+                      <a:round/>
+                      <a:headEnd type="none" w="med" len="med"/>
+                      <a:tailEnd type="none" w="med" len="med"/>
+                    </a:lnB>
+                    <a:solidFill>
+                      <a:srgbClr val="D3ECEE"/>
+                    </a:solidFill>
+                  </a:tcPr>
+                </a:tc>
+                <a:tc>
+                  <a:txBody>
+                    <a:bodyPr/>
+                    <a:lstStyle/>
+                    <a:p>
+                      <a:pPr algn="ctr" indent="0" marL="0">
+                        <a:buNone/>
+                      </a:pPr>
+                      <a:r>
+                        <a:rPr lang="en-US" sz="1100" dirty="0">
+                          <a:solidFill>
+                            <a:srgbClr val="1B2233"/>
+                          </a:solidFill>
+                        </a:rPr>
+                        <a:t>89.8%</a:t>
+                      </a:r>
+                      <a:endParaRPr lang="en-US" sz="1100" dirty="0"/>
+                    </a:p>
+                  </a:txBody>
+                  <a:tcPr marL="54864" marR="54864" marT="18288" marB="18288" anchor="ctr">
+                    <a:lnL w="38100" cap="flat" cmpd="sng" algn="ctr">
+                      <a:solidFill>
+                        <a:srgbClr val="4A5568"/>
                       </a:solidFill>
                       <a:prstDash val="solid"/>
                       <a:round/>
@@ -5736,17 +6377,17 @@
                         <a:buNone/>
                       </a:pPr>
                       <a:r>
-                        <a:rPr lang="en-US" sz="1200" dirty="0">
+                        <a:rPr lang="en-US" sz="1100" dirty="0">
                           <a:solidFill>
                             <a:srgbClr val="1B2233"/>
                           </a:solidFill>
                         </a:rPr>
                         <a:t>87.4%</a:t>
                       </a:r>
-                      <a:endParaRPr lang="en-US" sz="1200" dirty="0"/>
+                      <a:endParaRPr lang="en-US" sz="1100" dirty="0"/>
                     </a:p>
                   </a:txBody>
-                  <a:tcPr marL="27432" marR="27432" marT="27432" marB="27432" anchor="ctr">
+                  <a:tcPr marL="54864" marR="54864" marT="18288" marB="18288" anchor="ctr">
                     <a:lnL w="12700" cap="flat" cmpd="sng" algn="ctr">
                       <a:solidFill>
                         <a:srgbClr val="FFFFFF"/>
@@ -5795,14 +6436,50 @@
       </p:graphicFrame>
       <p:sp>
         <p:nvSpPr>
-          <p:cNvPr id="4" name="fix text"/>
+          <p:cNvPr id="4" name="fix table note"/>
           <p:cNvSpPr txBox="1"/>
           <p:nvPr/>
         </p:nvSpPr>
         <p:spPr>
           <a:xfrm>
-            <a:off x="457200" y="3364992"/>
-            <a:ext cx="8229600" cy="1325880"/>
+            <a:off x="457200" y="3072384"/>
+            <a:ext cx="8229600" cy="347472"/>
+          </a:xfrm>
+          <a:prstGeom prst="rect">
+            <a:avLst/>
+          </a:prstGeom>
+          <a:noFill/>
+          <a:ln/>
+        </p:spPr>
+        <p:txBody>
+          <a:bodyPr wrap="square" lIns="0" tIns="0" rIns="0" bIns="0" rtlCol="0" anchor="t"/>
+          <a:lstStyle/>
+          <a:p>
+            <a:pPr indent="0" marL="0">
+              <a:buNone/>
+            </a:pPr>
+            <a:r>
+              <a:rPr lang="en-US" sz="1100" dirty="0">
+                <a:solidFill>
+                  <a:schemeClr val="tx2"/>
+                </a:solidFill>
+              </a:rPr>
+              <a:t>Fix: targets at the head; ×5 / ×20: depth loss weight. Controls: root targets, depth ×1, same schedule (none at ×5 / ×20). Root error: 3D distance of the predicted to the true root joint (pelvis). Drawn size: predicted / true head-to-pelvis px.</a:t>
+            </a:r>
+            <a:endParaRPr lang="en-US" sz="1100" dirty="0"/>
+          </a:p>
+        </p:txBody>
+      </p:sp>
+      <p:sp>
+        <p:nvSpPr>
+          <p:cNvPr id="5" name="fix text"/>
+          <p:cNvSpPr txBox="1"/>
+          <p:nvPr/>
+        </p:nvSpPr>
+        <p:spPr>
+          <a:xfrm>
+            <a:off x="457200" y="3474720"/>
+            <a:ext cx="8229600" cy="1207008"/>
           </a:xfrm>
           <a:prstGeom prst="rect">
             <a:avLst/>
@@ -5835,7 +6512,7 @@
                   <a:schemeClr val="tx1"/>
                 </a:solidFill>
               </a:rPr>
-              <a:t>mean head error 7–9 px vs 64 (expected after moving the target); depth error 0.34–0.39 m with a stronger depth loss. Remaining shrinkage shows at the pelvis (31–38 px).</a:t>
+              <a:t>head error 7–9 px (controls 58–64); root error 0.53–0.73 m in all five fix runs vs 1.11–1.44 m for the controls.</a:t>
             </a:r>
             <a:endParaRPr lang="en-US" sz="1200" dirty="0"/>
           </a:p>
@@ -5861,7 +6538,7 @@
                   <a:schemeClr val="tx1"/>
                 </a:solidFill>
               </a:rPr>
-              <a:t>slope near 0.4, so near and far people get similar depths. Best guess: a pull toward the typical training depth (2.5 to 2.8 m); holdout people stand nearer (1.9 m).</a:t>
+              <a:t>slope about 0.4: predictions are pulled toward about 2.5 m, near the estimated training average, while holdout people are nearer (1.9 m). Why near and far are not separated is unknown. Longer training lowers root error (×5: 0.66 → 0.54 m), not the slope (0.44 → 0.38).</a:t>
             </a:r>
             <a:endParaRPr lang="en-US" sz="1200" dirty="0"/>
           </a:p>
@@ -5879,7 +6556,7 @@
                   <a:schemeClr val="tx1"/>
                 </a:solidFill>
               </a:rPr>
-              <a:t>Cost not ruled out: </a:t>
+              <a:t>Likely cost: </a:t>
             </a:r>
             <a:r>
               <a:rPr lang="en-US" sz="1200" dirty="0">
@@ -5887,33 +6564,7 @@
                   <a:schemeClr val="tx1"/>
                 </a:solidFill>
               </a:rPr>
-              <a:t>every fix run has PVE about 3 mm above the control (4–5 above v5) and recall 2–3 points below v5. One pilot resolves only about 10 mm and 2 points.</a:t>
-            </a:r>
-            <a:endParaRPr lang="en-US" sz="1200" dirty="0"/>
-          </a:p>
-          <a:p>
-            <a:pPr marL="177800" indent="-177800">
-              <a:spcAft>
-                <a:spcPts val="200"/>
-              </a:spcAft>
-              <a:buSzPct val="100000"/>
-              <a:buChar char="•"/>
-            </a:pPr>
-            <a:r>
-              <a:rPr lang="en-US" sz="1200" b="1" dirty="0">
-                <a:solidFill>
-                  <a:schemeClr val="tx1"/>
-                </a:solidFill>
-              </a:rPr>
-              <a:t>Control </a:t>
-            </a:r>
-            <a:r>
-              <a:rPr lang="en-US" sz="1200" dirty="0">
-                <a:solidFill>
-                  <a:schemeClr val="tx1"/>
-                </a:solidFill>
-              </a:rPr>
-              <a:t>= same schedule, switch off, depth loss ×1; no control for ×5 / ×20. Depth ×20 for 10 epochs: no result yet.</a:t>
+              <a:t>every fix run is worse than its control (PVE +2.6 to +4.9 mm, recall −1.6 to −2.4 points). Each alone is inside pilot noise, but all point the same way.</a:t>
             </a:r>
             <a:endParaRPr lang="en-US" sz="1200" dirty="0"/>
           </a:p>
@@ -6042,7 +6693,7 @@
           </p:nvPr>
         </p:nvGraphicFramePr>
         <p:xfrm>
-          <a:off x="457200" y="1143000"/>
+          <a:off x="457200" y="1097280"/>
           <a:ext cx="8229600" cy="914400"/>
         </p:xfrm>
         <a:graphic>
@@ -6050,12 +6701,12 @@
             <a:tbl>
               <a:tblPr/>
               <a:tblGrid>
-                <a:gridCol w="1188720"/>
-                <a:gridCol w="1965960"/>
-                <a:gridCol w="1783080"/>
-                <a:gridCol w="3291840"/>
+                <a:gridCol w="1097280"/>
+                <a:gridCol w="1600200"/>
+                <a:gridCol w="1600200"/>
+                <a:gridCol w="3931920"/>
               </a:tblGrid>
-              <a:tr h="292608">
+              <a:tr h="274320">
                 <a:tc>
                   <a:txBody>
                     <a:bodyPr/>
@@ -6122,7 +6773,7 @@
                     <a:bodyPr/>
                     <a:lstStyle/>
                     <a:p>
-                      <a:pPr algn="ctr" indent="0" marL="0">
+                      <a:pPr algn="l" indent="0" marL="0">
                         <a:buNone/>
                       </a:pPr>
                       <a:r>
@@ -6183,7 +6834,7 @@
                     <a:bodyPr/>
                     <a:lstStyle/>
                     <a:p>
-                      <a:pPr algn="ctr" indent="0" marL="0">
+                      <a:pPr algn="l" indent="0" marL="0">
                         <a:buNone/>
                       </a:pPr>
                       <a:r>
@@ -6192,7 +6843,7 @@
                             <a:srgbClr val="FFFFFF"/>
                           </a:solidFill>
                         </a:rPr>
-                        <a:t>decides</a:t>
+                        <a:t>success rule</a:t>
                       </a:r>
                       <a:endParaRPr lang="en-US" sz="1100" dirty="0"/>
                     </a:p>
@@ -6244,7 +6895,7 @@
                     <a:bodyPr/>
                     <a:lstStyle/>
                     <a:p>
-                      <a:pPr algn="ctr" indent="0" marL="0">
+                      <a:pPr algn="l" indent="0" marL="0">
                         <a:buNone/>
                       </a:pPr>
                       <a:r>
@@ -6301,7 +6952,7 @@
                   </a:tcPr>
                 </a:tc>
               </a:tr>
-              <a:tr h="713232">
+              <a:tr h="566928">
                 <a:tc>
                   <a:txBody>
                     <a:bodyPr/>
@@ -6368,7 +7019,7 @@
                     <a:bodyPr/>
                     <a:lstStyle/>
                     <a:p>
-                      <a:pPr algn="ctr" indent="0" marL="0">
+                      <a:pPr algn="l" indent="0" marL="0">
                         <a:buNone/>
                       </a:pPr>
                       <a:r>
@@ -6377,7 +7028,7 @@
                             <a:srgbClr val="1B2233"/>
                           </a:solidFill>
                         </a:rPr>
-                        <a:t>targets at the head joint (+ depth loss ×5 or ×20)</a:t>
+                        <a:t>targets at the head joint (+ depth loss ×5 or ×20)</a:t>
                       </a:r>
                       <a:endParaRPr lang="en-US" sz="1100" dirty="0"/>
                     </a:p>
@@ -6429,7 +7080,7 @@
                     <a:bodyPr/>
                     <a:lstStyle/>
                     <a:p>
-                      <a:pPr algn="ctr" indent="0" marL="0">
+                      <a:pPr algn="l" indent="0" marL="0">
                         <a:buNone/>
                       </a:pPr>
                       <a:r>
@@ -6438,7 +7089,7 @@
                             <a:srgbClr val="1B2233"/>
                           </a:solidFill>
                         </a:rPr>
-                        <a:t>depth slope toward 1, PVE recovers</a:t>
+                        <a:t>depth slope toward 1, PVE stays near v5 (70.5 mm)</a:t>
                       </a:r>
                       <a:endParaRPr lang="en-US" sz="1100" dirty="0"/>
                     </a:p>
@@ -6490,7 +7141,7 @@
                     <a:bodyPr/>
                     <a:lstStyle/>
                     <a:p>
-                      <a:pPr algn="ctr" indent="0" marL="0">
+                      <a:pPr algn="l" indent="0" marL="0">
                         <a:buNone/>
                       </a:pPr>
                       <a:r>
@@ -6499,7 +7150,7 @@
                             <a:srgbClr val="1B2233"/>
                           </a:solidFill>
                         </a:rPr>
-                        <a:t>Partly. Switch alone: 1.08 → 0.62 m, size 0.78, slope 0.30. With depth ×5: 0.39 m, size 0.84, slope 0.38. PVE did not recover (74.8 vs 70.5 mm); recall −2.4</a:t>
+                        <a:t>Rule not met: slope 0.30 (switch alone) / 0.38 (×5), not near 1; PVE 74.8 mm (control 72.2, v5 70.5). Outside the rule, clearly better: root error 1.21 → 0.54 m, drawn size 0.63 → 0.84</a:t>
                       </a:r>
                       <a:endParaRPr lang="en-US" sz="1100" dirty="0"/>
                     </a:p>
@@ -6547,7 +7198,7 @@
                   </a:tcPr>
                 </a:tc>
               </a:tr>
-              <a:tr h="457200">
+              <a:tr h="411480">
                 <a:tc>
                   <a:txBody>
                     <a:bodyPr/>
@@ -6614,7 +7265,7 @@
                     <a:bodyPr/>
                     <a:lstStyle/>
                     <a:p>
-                      <a:pPr algn="ctr" indent="0" marL="0">
+                      <a:pPr algn="l" indent="0" marL="0">
                         <a:buNone/>
                       </a:pPr>
                       <a:r>
@@ -6623,7 +7274,7 @@
                             <a:srgbClr val="1B2233"/>
                           </a:solidFill>
                         </a:rPr>
-                        <a:t>age-balanced sampler (both arms: age loss ×3, height ×2)</a:t>
+                        <a:t>age-balanced sampler</a:t>
                       </a:r>
                       <a:endParaRPr lang="en-US" sz="1100" dirty="0"/>
                     </a:p>
@@ -6675,7 +7326,7 @@
                     <a:bodyPr/>
                     <a:lstStyle/>
                     <a:p>
-                      <a:pPr algn="ctr" indent="0" marL="0">
+                      <a:pPr algn="l" indent="0" marL="0">
                         <a:buNone/>
                       </a:pPr>
                       <a:r>
@@ -6736,7 +7387,7 @@
                     <a:bodyPr/>
                     <a:lstStyle/>
                     <a:p>
-                      <a:pPr algn="ctr" indent="0" marL="0">
+                      <a:pPr algn="l" indent="0" marL="0">
                         <a:buNone/>
                       </a:pPr>
                       <a:r>
@@ -6745,7 +7396,7 @@
                             <a:srgbClr val="1B2233"/>
                           </a:solidFill>
                         </a:rPr>
-                        <a:t>No effect in a 2-epoch fine-tune: training children and real photos unchanged</a:t>
+                        <a:t>No effect in a 2-epoch fine-tune: training children and real photos unchanged. Pilot and control both use age loss ×3, height ×2</a:t>
                       </a:r>
                       <a:endParaRPr lang="en-US" sz="1100" dirty="0"/>
                     </a:p>
@@ -6793,7 +7444,7 @@
                   </a:tcPr>
                 </a:tc>
               </a:tr>
-              <a:tr h="566928">
+              <a:tr h="411480">
                 <a:tc>
                   <a:txBody>
                     <a:bodyPr/>
@@ -6860,7 +7511,7 @@
                     <a:bodyPr/>
                     <a:lstStyle/>
                     <a:p>
-                      <a:pPr algn="ctr" indent="0" marL="0">
+                      <a:pPr algn="l" indent="0" marL="0">
                         <a:buNone/>
                       </a:pPr>
                       <a:r>
@@ -6921,7 +7572,7 @@
                     <a:bodyPr/>
                     <a:lstStyle/>
                     <a:p>
-                      <a:pPr algn="ctr" indent="0" marL="0">
+                      <a:pPr algn="l" indent="0" marL="0">
                         <a:buNone/>
                       </a:pPr>
                       <a:r>
@@ -6982,7 +7633,7 @@
                     <a:bodyPr/>
                     <a:lstStyle/>
                     <a:p>
-                      <a:pPr algn="ctr" indent="0" marL="0">
+                      <a:pPr algn="l" indent="0" marL="0">
                         <a:buNone/>
                       </a:pPr>
                       <a:r>
@@ -7039,7 +7690,7 @@
                   </a:tcPr>
                 </a:tc>
               </a:tr>
-              <a:tr h="365760">
+              <a:tr h="411480">
                 <a:tc>
                   <a:txBody>
                     <a:bodyPr/>
@@ -7106,7 +7757,7 @@
                     <a:bodyPr/>
                     <a:lstStyle/>
                     <a:p>
-                      <a:pPr algn="ctr" indent="0" marL="0">
+                      <a:pPr algn="l" indent="0" marL="0">
                         <a:buNone/>
                       </a:pPr>
                       <a:r>
@@ -7167,7 +7818,7 @@
                     <a:bodyPr/>
                     <a:lstStyle/>
                     <a:p>
-                      <a:pPr algn="ctr" indent="0" marL="0">
+                      <a:pPr algn="l" indent="0" marL="0">
                         <a:buNone/>
                       </a:pPr>
                       <a:r>
@@ -7176,7 +7827,7 @@
                             <a:srgbClr val="1B2233"/>
                           </a:solidFill>
                         </a:rPr>
-                        <a:t>finger error vs the 15.1° rest-pose floor</a:t>
+                        <a:t>finger error vs rest pose (15.2° in this evaluation)</a:t>
                       </a:r>
                       <a:endParaRPr lang="en-US" sz="1100" dirty="0"/>
                     </a:p>
@@ -7228,7 +7879,7 @@
                     <a:bodyPr/>
                     <a:lstStyle/>
                     <a:p>
-                      <a:pPr algn="ctr" indent="0" marL="0">
+                      <a:pPr algn="l" indent="0" marL="0">
                         <a:buNone/>
                       </a:pPr>
                       <a:r>
@@ -7297,12 +7948,12 @@
         </p:nvSpPr>
         <p:spPr>
           <a:xfrm>
-            <a:off x="457200" y="3794760"/>
-            <a:ext cx="8229600" cy="868680"/>
+            <a:off x="457200" y="3767328"/>
+            <a:ext cx="8229600" cy="896112"/>
           </a:xfrm>
           <a:prstGeom prst="roundRect">
             <a:avLst>
-              <a:gd name="adj" fmla="val 8421"/>
+              <a:gd name="adj" fmla="val 8163"/>
             </a:avLst>
           </a:prstGeom>
           <a:solidFill>
@@ -7324,8 +7975,8 @@
         </p:nvSpPr>
         <p:spPr>
           <a:xfrm>
-            <a:off x="640080" y="3840480"/>
-            <a:ext cx="7863840" cy="777240"/>
+            <a:off x="640080" y="3803904"/>
+            <a:ext cx="7863840" cy="822960"/>
           </a:xfrm>
           <a:prstGeom prst="rect">
             <a:avLst/>
@@ -7354,7 +8005,7 @@
                   <a:schemeClr val="tx1"/>
                 </a:solidFill>
               </a:rPr>
-              <a:t>No fixed random seed: two identical runs differed by 7.6 mm PVE and 1.9° head error. One pilot can only detect a difference of about 10 mm PVE, 3° head error or 2 recall points. Restarting the fine-tune alone costs about 2.4 mm (controls average 72.9 vs 70.5 mm). All runs: same holdout and manifest, helper bones masked.</a:t>
+              <a:t>No fixed random seed: two identical runs differed by 7.6 mm PVE and 1.9° head error, so one pilot only detects about 10 mm PVE, 3° head error or 2 recall points. Restarting the fine-tune alone costs about 2.4 mm (controls average 72.9 vs 70.5 mm). Root error of the fix runs (0.53–0.73 m vs 1.11–1.44 m for the controls) is far outside this noise. All runs: same holdout and manifest, helper bones masked.</a:t>
             </a:r>
             <a:endParaRPr lang="en-US" sz="1200" dirty="0"/>
           </a:p>
@@ -7462,7 +8113,7 @@
                   <a:schemeClr val="tx1"/>
                 </a:solidFill>
               </a:rPr>
-              <a:t>Corrections already made to numbers and demos</a:t>
+              <a:t>Corrections made, and still to make</a:t>
             </a:r>
             <a:endParaRPr lang="en-US" sz="2700" dirty="0"/>
           </a:p>
@@ -7476,12 +8127,12 @@
         </p:nvSpPr>
         <p:spPr>
           <a:xfrm>
-            <a:off x="457200" y="1280160"/>
-            <a:ext cx="4023360" cy="1554480"/>
+            <a:off x="457200" y="1234440"/>
+            <a:ext cx="4023360" cy="1600200"/>
           </a:xfrm>
           <a:prstGeom prst="roundRect">
             <a:avLst>
-              <a:gd name="adj" fmla="val 4706"/>
+              <a:gd name="adj" fmla="val 4571"/>
             </a:avLst>
           </a:prstGeom>
           <a:solidFill>
@@ -7503,7 +8154,7 @@
         </p:nvSpPr>
         <p:spPr>
           <a:xfrm>
-            <a:off x="640080" y="1463040"/>
+            <a:off x="640080" y="1417320"/>
             <a:ext cx="384048" cy="384048"/>
           </a:xfrm>
           <a:prstGeom prst="ellipse">
@@ -7528,7 +8179,7 @@
         </p:nvSpPr>
         <p:spPr>
           <a:xfrm>
-            <a:off x="1143000" y="1417320"/>
+            <a:off x="1143000" y="1371600"/>
             <a:ext cx="3200400" cy="457200"/>
           </a:xfrm>
           <a:prstGeom prst="rect">
@@ -7564,8 +8215,8 @@
         </p:nvSpPr>
         <p:spPr>
           <a:xfrm>
-            <a:off x="640080" y="1965960"/>
-            <a:ext cx="3657600" cy="731520"/>
+            <a:off x="640080" y="1920240"/>
+            <a:ext cx="3657600" cy="777240"/>
           </a:xfrm>
           <a:prstGeom prst="rect">
             <a:avLst/>
@@ -7586,7 +8237,7 @@
                   <a:schemeClr val="tx2"/>
                 </a:solidFill>
               </a:rPr>
-              <a:t>AnnyOne holdout PVE is 70.5 mm with helper bones masked, the setting the demos use. The 74.3 mm in the thesis draft is the unmasked evaluation (+3.8 mm paired).</a:t>
+              <a:t>AnnyOne holdout PVE is 70.5 mm with helper bones masked, as in the demos (V1). The 74.3 mm in the thesis draft is the unmasked evaluation (+3.8 mm paired).</a:t>
             </a:r>
             <a:endParaRPr lang="en-US" sz="1200" dirty="0"/>
           </a:p>
@@ -7600,12 +8251,12 @@
         </p:nvSpPr>
         <p:spPr>
           <a:xfrm>
-            <a:off x="4663440" y="1280160"/>
-            <a:ext cx="4023360" cy="1554480"/>
+            <a:off x="4663440" y="1234440"/>
+            <a:ext cx="4023360" cy="1600200"/>
           </a:xfrm>
           <a:prstGeom prst="roundRect">
             <a:avLst>
-              <a:gd name="adj" fmla="val 4706"/>
+              <a:gd name="adj" fmla="val 4571"/>
             </a:avLst>
           </a:prstGeom>
           <a:solidFill>
@@ -7627,7 +8278,131 @@
         </p:nvSpPr>
         <p:spPr>
           <a:xfrm>
-            <a:off x="4846320" y="1463040"/>
+            <a:off x="4846320" y="1417320"/>
+            <a:ext cx="384048" cy="384048"/>
+          </a:xfrm>
+          <a:prstGeom prst="ellipse">
+            <a:avLst/>
+          </a:prstGeom>
+          <a:solidFill>
+            <a:srgbClr val="3BA55D"/>
+          </a:solidFill>
+          <a:ln w="12700">
+            <a:solidFill>
+              <a:srgbClr val="3BA55D"/>
+            </a:solidFill>
+            <a:prstDash val="solid"/>
+          </a:ln>
+        </p:spPr>
+      </p:sp>
+      <p:sp>
+        <p:nvSpPr>
+          <p:cNvPr id="9" name="Demos head"/>
+          <p:cNvSpPr txBox="1"/>
+          <p:nvPr/>
+        </p:nvSpPr>
+        <p:spPr>
+          <a:xfrm>
+            <a:off x="5349240" y="1371600"/>
+            <a:ext cx="3200400" cy="457200"/>
+          </a:xfrm>
+          <a:prstGeom prst="rect">
+            <a:avLst/>
+          </a:prstGeom>
+          <a:noFill/>
+          <a:ln/>
+        </p:spPr>
+        <p:txBody>
+          <a:bodyPr wrap="square" lIns="0" tIns="0" rIns="0" bIns="0" rtlCol="0" anchor="ctr"/>
+          <a:lstStyle/>
+          <a:p>
+            <a:pPr indent="0" marL="0">
+              <a:buNone/>
+            </a:pPr>
+            <a:r>
+              <a:rPr lang="en-US" sz="1600" b="1" dirty="0">
+                <a:solidFill>
+                  <a:schemeClr val="tx1"/>
+                </a:solidFill>
+              </a:rPr>
+              <a:t>Demos</a:t>
+            </a:r>
+            <a:endParaRPr lang="en-US" sz="1600" dirty="0"/>
+          </a:p>
+        </p:txBody>
+      </p:sp>
+      <p:sp>
+        <p:nvSpPr>
+          <p:cNvPr id="10" name="Demos body"/>
+          <p:cNvSpPr txBox="1"/>
+          <p:nvPr/>
+        </p:nvSpPr>
+        <p:spPr>
+          <a:xfrm>
+            <a:off x="4846320" y="1920240"/>
+            <a:ext cx="3657600" cy="777240"/>
+          </a:xfrm>
+          <a:prstGeom prst="rect">
+            <a:avLst/>
+          </a:prstGeom>
+          <a:noFill/>
+          <a:ln/>
+        </p:spPr>
+        <p:txBody>
+          <a:bodyPr wrap="square" lIns="0" tIns="0" rIns="0" bIns="0" rtlCol="0" anchor="t"/>
+          <a:lstStyle/>
+          <a:p>
+            <a:pPr indent="0" marL="0">
+              <a:buNone/>
+            </a:pPr>
+            <a:r>
+              <a:rPr lang="en-US" sz="1200" dirty="0">
+                <a:solidFill>
+                  <a:schemeClr val="tx2"/>
+                </a:solidFill>
+              </a:rPr>
+              <a:t>All demo scripts zero the fingers and the README says so: finger renders are the rest pose, not predictions.</a:t>
+            </a:r>
+            <a:endParaRPr lang="en-US" sz="1200" dirty="0"/>
+          </a:p>
+        </p:txBody>
+      </p:sp>
+      <p:sp>
+        <p:nvSpPr>
+          <p:cNvPr id="11" name="Wording"/>
+          <p:cNvSpPr/>
+          <p:nvPr/>
+        </p:nvSpPr>
+        <p:spPr>
+          <a:xfrm>
+            <a:off x="457200" y="2999232"/>
+            <a:ext cx="4023360" cy="1664208"/>
+          </a:xfrm>
+          <a:prstGeom prst="roundRect">
+            <a:avLst>
+              <a:gd name="adj" fmla="val 4396"/>
+            </a:avLst>
+          </a:prstGeom>
+          <a:solidFill>
+            <a:schemeClr val="bg2"/>
+          </a:solidFill>
+          <a:ln w="12700">
+            <a:solidFill>
+              <a:schemeClr val="bg2"/>
+            </a:solidFill>
+            <a:prstDash val="solid"/>
+          </a:ln>
+        </p:spPr>
+      </p:sp>
+      <p:sp>
+        <p:nvSpPr>
+          <p:cNvPr id="12" name="Wording dot"/>
+          <p:cNvSpPr/>
+          <p:nvPr/>
+        </p:nvSpPr>
+        <p:spPr>
+          <a:xfrm>
+            <a:off x="640080" y="3182112"/>
             <a:ext cx="384048" cy="384048"/>
           </a:xfrm>
           <a:prstGeom prst="ellipse">
@@ -7646,13 +8421,13 @@
       </p:sp>
       <p:sp>
         <p:nvSpPr>
-          <p:cNvPr id="9" name="Demos head"/>
+          <p:cNvPr id="13" name="Wording head"/>
           <p:cNvSpPr txBox="1"/>
           <p:nvPr/>
         </p:nvSpPr>
         <p:spPr>
           <a:xfrm>
-            <a:off x="5349240" y="1417320"/>
+            <a:off x="1143000" y="3136392"/>
             <a:ext cx="3200400" cy="457200"/>
           </a:xfrm>
           <a:prstGeom prst="rect">
@@ -7674,7 +8449,7 @@
                   <a:schemeClr val="tx1"/>
                 </a:solidFill>
               </a:rPr>
-              <a:t>Demos</a:t>
+              <a:t>Wording</a:t>
             </a:r>
             <a:endParaRPr lang="en-US" sz="1600" dirty="0"/>
           </a:p>
@@ -7682,14 +8457,14 @@
       </p:sp>
       <p:sp>
         <p:nvSpPr>
-          <p:cNvPr id="10" name="Demos body"/>
+          <p:cNvPr id="14" name="Wording body"/>
           <p:cNvSpPr txBox="1"/>
           <p:nvPr/>
         </p:nvSpPr>
         <p:spPr>
           <a:xfrm>
-            <a:off x="4846320" y="1965960"/>
-            <a:ext cx="3657600" cy="731520"/>
+            <a:off x="640080" y="3685032"/>
+            <a:ext cx="3657600" cy="841248"/>
           </a:xfrm>
           <a:prstGeom prst="rect">
             <a:avLst/>
@@ -7710,7 +8485,7 @@
                   <a:schemeClr val="tx2"/>
                 </a:solidFill>
               </a:rPr>
-              <a:t>All demo scripts zero the fingers and the README says so: finger renders are the rest pose, not predictions.</a:t>
+              <a:t>Neck, fingers, children: no longer called rig or decoding problems. The README's Known-defects section documents the depth bug. README, findings and handover still carry last week's neck story; I correct them this week.</a:t>
             </a:r>
             <a:endParaRPr lang="en-US" sz="1200" dirty="0"/>
           </a:p>
@@ -7718,18 +8493,18 @@
       </p:sp>
       <p:sp>
         <p:nvSpPr>
-          <p:cNvPr id="11" name="Wording"/>
+          <p:cNvPr id="15" name="Repository"/>
           <p:cNvSpPr/>
           <p:nvPr/>
         </p:nvSpPr>
         <p:spPr>
           <a:xfrm>
-            <a:off x="457200" y="3017520"/>
-            <a:ext cx="4023360" cy="1554480"/>
+            <a:off x="4663440" y="2999232"/>
+            <a:ext cx="4023360" cy="1664208"/>
           </a:xfrm>
           <a:prstGeom prst="roundRect">
             <a:avLst>
-              <a:gd name="adj" fmla="val 4706"/>
+              <a:gd name="adj" fmla="val 4396"/>
             </a:avLst>
           </a:prstGeom>
           <a:solidFill>
@@ -7745,137 +8520,13 @@
       </p:sp>
       <p:sp>
         <p:nvSpPr>
-          <p:cNvPr id="12" name="Wording dot"/>
-          <p:cNvSpPr/>
-          <p:nvPr/>
-        </p:nvSpPr>
-        <p:spPr>
-          <a:xfrm>
-            <a:off x="640080" y="3200400"/>
-            <a:ext cx="384048" cy="384048"/>
-          </a:xfrm>
-          <a:prstGeom prst="ellipse">
-            <a:avLst/>
-          </a:prstGeom>
-          <a:solidFill>
-            <a:srgbClr val="3BA55D"/>
-          </a:solidFill>
-          <a:ln w="12700">
-            <a:solidFill>
-              <a:srgbClr val="3BA55D"/>
-            </a:solidFill>
-            <a:prstDash val="solid"/>
-          </a:ln>
-        </p:spPr>
-      </p:sp>
-      <p:sp>
-        <p:nvSpPr>
-          <p:cNvPr id="13" name="Wording head"/>
-          <p:cNvSpPr txBox="1"/>
-          <p:nvPr/>
-        </p:nvSpPr>
-        <p:spPr>
-          <a:xfrm>
-            <a:off x="1143000" y="3154680"/>
-            <a:ext cx="3200400" cy="457200"/>
-          </a:xfrm>
-          <a:prstGeom prst="rect">
-            <a:avLst/>
-          </a:prstGeom>
-          <a:noFill/>
-          <a:ln/>
-        </p:spPr>
-        <p:txBody>
-          <a:bodyPr wrap="square" lIns="0" tIns="0" rIns="0" bIns="0" rtlCol="0" anchor="ctr"/>
-          <a:lstStyle/>
-          <a:p>
-            <a:pPr indent="0" marL="0">
-              <a:buNone/>
-            </a:pPr>
-            <a:r>
-              <a:rPr lang="en-US" sz="1600" b="1" dirty="0">
-                <a:solidFill>
-                  <a:schemeClr val="tx1"/>
-                </a:solidFill>
-              </a:rPr>
-              <a:t>Wording</a:t>
-            </a:r>
-            <a:endParaRPr lang="en-US" sz="1600" dirty="0"/>
-          </a:p>
-        </p:txBody>
-      </p:sp>
-      <p:sp>
-        <p:nvSpPr>
-          <p:cNvPr id="14" name="Wording body"/>
-          <p:cNvSpPr txBox="1"/>
-          <p:nvPr/>
-        </p:nvSpPr>
-        <p:spPr>
-          <a:xfrm>
-            <a:off x="640080" y="3703320"/>
-            <a:ext cx="3657600" cy="731520"/>
-          </a:xfrm>
-          <a:prstGeom prst="rect">
-            <a:avLst/>
-          </a:prstGeom>
-          <a:noFill/>
-          <a:ln/>
-        </p:spPr>
-        <p:txBody>
-          <a:bodyPr wrap="square" lIns="0" tIns="0" rIns="0" bIns="0" rtlCol="0" anchor="t"/>
-          <a:lstStyle/>
-          <a:p>
-            <a:pPr indent="0" marL="0">
-              <a:buNone/>
-            </a:pPr>
-            <a:r>
-              <a:rPr lang="en-US" sz="1200" dirty="0">
-                <a:solidFill>
-                  <a:schemeClr val="tx2"/>
-                </a:solidFill>
-              </a:rPr>
-              <a:t>Neck, fingers and children are no longer described as rig or decoding problems. A Known-defects section documents the depth bug; its neck text still has the old story and will be corrected.</a:t>
-            </a:r>
-            <a:endParaRPr lang="en-US" sz="1200" dirty="0"/>
-          </a:p>
-        </p:txBody>
-      </p:sp>
-      <p:sp>
-        <p:nvSpPr>
-          <p:cNvPr id="15" name="Repository"/>
-          <p:cNvSpPr/>
-          <p:nvPr/>
-        </p:nvSpPr>
-        <p:spPr>
-          <a:xfrm>
-            <a:off x="4663440" y="3017520"/>
-            <a:ext cx="4023360" cy="1554480"/>
-          </a:xfrm>
-          <a:prstGeom prst="roundRect">
-            <a:avLst>
-              <a:gd name="adj" fmla="val 4706"/>
-            </a:avLst>
-          </a:prstGeom>
-          <a:solidFill>
-            <a:schemeClr val="bg2"/>
-          </a:solidFill>
-          <a:ln w="12700">
-            <a:solidFill>
-              <a:schemeClr val="bg2"/>
-            </a:solidFill>
-            <a:prstDash val="solid"/>
-          </a:ln>
-        </p:spPr>
-      </p:sp>
-      <p:sp>
-        <p:nvSpPr>
           <p:cNvPr id="16" name="Repository dot"/>
           <p:cNvSpPr/>
           <p:nvPr/>
         </p:nvSpPr>
         <p:spPr>
           <a:xfrm>
-            <a:off x="4846320" y="3200400"/>
+            <a:off x="4846320" y="3182112"/>
             <a:ext cx="384048" cy="384048"/>
           </a:xfrm>
           <a:prstGeom prst="ellipse">
@@ -7900,7 +8551,7 @@
         </p:nvSpPr>
         <p:spPr>
           <a:xfrm>
-            <a:off x="5349240" y="3154680"/>
+            <a:off x="5349240" y="3136392"/>
             <a:ext cx="3200400" cy="457200"/>
           </a:xfrm>
           <a:prstGeom prst="rect">
@@ -7936,8 +8587,8 @@
         </p:nvSpPr>
         <p:spPr>
           <a:xfrm>
-            <a:off x="4846320" y="3703320"/>
-            <a:ext cx="3657600" cy="731520"/>
+            <a:off x="4846320" y="3685032"/>
+            <a:ext cx="3657600" cy="841248"/>
           </a:xfrm>
           <a:prstGeom prst="rect">
             <a:avLst/>
@@ -8080,7 +8731,7 @@
         </p:nvSpPr>
         <p:spPr>
           <a:xfrm>
-            <a:off x="457200" y="1234440"/>
+            <a:off x="457200" y="1216152"/>
             <a:ext cx="457200" cy="457200"/>
           </a:xfrm>
           <a:prstGeom prst="ellipse">
@@ -8105,7 +8756,7 @@
         </p:nvSpPr>
         <p:spPr>
           <a:xfrm>
-            <a:off x="457200" y="1234440"/>
+            <a:off x="457200" y="1216152"/>
             <a:ext cx="457200" cy="457200"/>
           </a:xfrm>
           <a:prstGeom prst="rect">
@@ -8141,7 +8792,7 @@
         </p:nvSpPr>
         <p:spPr>
           <a:xfrm>
-            <a:off x="1097280" y="1188720"/>
+            <a:off x="1097280" y="1170432"/>
             <a:ext cx="3337560" cy="301752"/>
           </a:xfrm>
           <a:prstGeom prst="rect">
@@ -8177,8 +8828,8 @@
         </p:nvSpPr>
         <p:spPr>
           <a:xfrm>
-            <a:off x="1097280" y="1517904"/>
-            <a:ext cx="3337560" cy="749808"/>
+            <a:off x="1097280" y="1499616"/>
+            <a:ext cx="3337560" cy="777240"/>
           </a:xfrm>
           <a:prstGeom prst="rect">
             <a:avLst/>
@@ -8199,7 +8850,7 @@
                   <a:schemeClr val="tx2"/>
                 </a:solidFill>
               </a:rPr>
-              <a:t>Why stuck at 63° / 90°? Next: error per bone (neck01–03, head, jaw; twist, swing), a neck-skin error, and a trace of v3 (before the ×4 neck boost).</a:t>
+              <a:t>Why stuck at 63° / 90°? Next: error per bone (neck01–03, head, jaw; twist and swing), a neck-skin error, traces of checkpoint 00299 (before masking) and v3 (probably before the boost).</a:t>
             </a:r>
             <a:endParaRPr lang="en-US" sz="1200" dirty="0"/>
           </a:p>
@@ -8213,7 +8864,7 @@
         </p:nvSpPr>
         <p:spPr>
           <a:xfrm>
-            <a:off x="4709160" y="1234440"/>
+            <a:off x="4709160" y="1216152"/>
             <a:ext cx="457200" cy="457200"/>
           </a:xfrm>
           <a:prstGeom prst="ellipse">
@@ -8238,7 +8889,7 @@
         </p:nvSpPr>
         <p:spPr>
           <a:xfrm>
-            <a:off x="4709160" y="1234440"/>
+            <a:off x="4709160" y="1216152"/>
             <a:ext cx="457200" cy="457200"/>
           </a:xfrm>
           <a:prstGeom prst="rect">
@@ -8274,7 +8925,7 @@
         </p:nvSpPr>
         <p:spPr>
           <a:xfrm>
-            <a:off x="5349240" y="1188720"/>
+            <a:off x="5349240" y="1170432"/>
             <a:ext cx="3337560" cy="301752"/>
           </a:xfrm>
           <a:prstGeom prst="rect">
@@ -8310,8 +8961,8 @@
         </p:nvSpPr>
         <p:spPr>
           <a:xfrm>
-            <a:off x="5349240" y="1517904"/>
-            <a:ext cx="3337560" cy="749808"/>
+            <a:off x="5349240" y="1499616"/>
+            <a:ext cx="3337560" cy="777240"/>
           </a:xfrm>
           <a:prstGeom prst="rect">
             <a:avLst/>
@@ -8332,7 +8983,7 @@
                   <a:schemeClr val="tx2"/>
                 </a:solidFill>
               </a:rPr>
-              <a:t>The training-depth pull is a guess. Check whether holdout depths (1.9 m) match training (2.5 to 2.8 m); the holdout is the last 100 images.</a:t>
+              <a:t>Why near and far are not separated is unknown. Measure training depths properly (small samples so far: about 2.5–3.2 m) and the fix run's slope on training images (v5: just as low there).</a:t>
             </a:r>
             <a:endParaRPr lang="en-US" sz="1200" dirty="0"/>
           </a:p>
@@ -8346,7 +8997,7 @@
         </p:nvSpPr>
         <p:spPr>
           <a:xfrm>
-            <a:off x="457200" y="2377440"/>
+            <a:off x="457200" y="2368296"/>
             <a:ext cx="457200" cy="457200"/>
           </a:xfrm>
           <a:prstGeom prst="ellipse">
@@ -8371,7 +9022,7 @@
         </p:nvSpPr>
         <p:spPr>
           <a:xfrm>
-            <a:off x="457200" y="2377440"/>
+            <a:off x="457200" y="2368296"/>
             <a:ext cx="457200" cy="457200"/>
           </a:xfrm>
           <a:prstGeom prst="rect">
@@ -8407,7 +9058,7 @@
         </p:nvSpPr>
         <p:spPr>
           <a:xfrm>
-            <a:off x="1097280" y="2331720"/>
+            <a:off x="1097280" y="2322576"/>
             <a:ext cx="3337560" cy="301752"/>
           </a:xfrm>
           <a:prstGeom prst="rect">
@@ -8429,7 +9080,7 @@
                   <a:schemeClr val="tx1"/>
                 </a:solidFill>
               </a:rPr>
-              <a:t>Cost of the depth fix</a:t>
+              <a:t>Depth fix: cost and the ×20 run</a:t>
             </a:r>
             <a:endParaRPr lang="en-US" sz="1500" dirty="0"/>
           </a:p>
@@ -8443,8 +9094,8 @@
         </p:nvSpPr>
         <p:spPr>
           <a:xfrm>
-            <a:off x="1097280" y="2660904"/>
-            <a:ext cx="3337560" cy="749808"/>
+            <a:off x="1097280" y="2651760"/>
+            <a:ext cx="3337560" cy="777240"/>
           </a:xfrm>
           <a:prstGeom prst="rect">
             <a:avLst/>
@@ -8465,7 +9116,7 @@
                   <a:schemeClr val="tx2"/>
                 </a:solidFill>
               </a:rPr>
-              <a:t>Recount recall over head-visible people. Measure the fix on 3DPW. Report root depth error next to PVE, since PVE cannot see placement.</a:t>
+              <a:t>Paired PVE on the same people; recall over head-visible people; the fix on 3DPW; root error next to PVE in the thesis. The ×20 10-epoch run: no result yet.</a:t>
             </a:r>
             <a:endParaRPr lang="en-US" sz="1200" dirty="0"/>
           </a:p>
@@ -8479,7 +9130,7 @@
         </p:nvSpPr>
         <p:spPr>
           <a:xfrm>
-            <a:off x="4709160" y="2377440"/>
+            <a:off x="4709160" y="2368296"/>
             <a:ext cx="457200" cy="457200"/>
           </a:xfrm>
           <a:prstGeom prst="ellipse">
@@ -8504,7 +9155,7 @@
         </p:nvSpPr>
         <p:spPr>
           <a:xfrm>
-            <a:off x="4709160" y="2377440"/>
+            <a:off x="4709160" y="2368296"/>
             <a:ext cx="457200" cy="457200"/>
           </a:xfrm>
           <a:prstGeom prst="rect">
@@ -8540,7 +9191,7 @@
         </p:nvSpPr>
         <p:spPr>
           <a:xfrm>
-            <a:off x="5349240" y="2331720"/>
+            <a:off x="5349240" y="2322576"/>
             <a:ext cx="3337560" cy="301752"/>
           </a:xfrm>
           <a:prstGeom prst="rect">
@@ -8576,8 +9227,8 @@
         </p:nvSpPr>
         <p:spPr>
           <a:xfrm>
-            <a:off x="5349240" y="2660904"/>
-            <a:ext cx="3337560" cy="749808"/>
+            <a:off x="5349240" y="2651760"/>
+            <a:ext cx="3337560" cy="777240"/>
           </a:xfrm>
           <a:prstGeom prst="rect">
             <a:avLst/>
@@ -8612,7 +9263,7 @@
         </p:nvSpPr>
         <p:spPr>
           <a:xfrm>
-            <a:off x="457200" y="3474720"/>
+            <a:off x="457200" y="3520440"/>
             <a:ext cx="457200" cy="457200"/>
           </a:xfrm>
           <a:prstGeom prst="ellipse">
@@ -8637,7 +9288,7 @@
         </p:nvSpPr>
         <p:spPr>
           <a:xfrm>
-            <a:off x="457200" y="3474720"/>
+            <a:off x="457200" y="3520440"/>
             <a:ext cx="457200" cy="457200"/>
           </a:xfrm>
           <a:prstGeom prst="rect">
@@ -8673,7 +9324,7 @@
         </p:nvSpPr>
         <p:spPr>
           <a:xfrm>
-            <a:off x="1097280" y="3429000"/>
+            <a:off x="1097280" y="3474720"/>
             <a:ext cx="3337560" cy="301752"/>
           </a:xfrm>
           <a:prstGeom prst="rect">
@@ -8709,8 +9360,8 @@
         </p:nvSpPr>
         <p:spPr>
           <a:xfrm>
-            <a:off x="1097280" y="3758184"/>
-            <a:ext cx="3337560" cy="749808"/>
+            <a:off x="1097280" y="3803904"/>
+            <a:ext cx="3337560" cy="777240"/>
           </a:xfrm>
           <a:prstGeom prst="rect">
             <a:avLst/>
@@ -8731,7 +9382,7 @@
                   <a:schemeClr val="tx2"/>
                 </a:solidFill>
               </a:rPr>
-              <a:t>Both models miss people who fill much of the image. A detection problem, not caused or fixed by the depth fix.</a:t>
+              <a:t>Both models miss them (seen in 4 of 12 rendered images, not yet counted), so the fix did not cause it. Likely a detection problem.</a:t>
             </a:r>
             <a:endParaRPr lang="en-US" sz="1200" dirty="0"/>
           </a:p>
@@ -8745,7 +9396,7 @@
         </p:nvSpPr>
         <p:spPr>
           <a:xfrm>
-            <a:off x="4709160" y="3474720"/>
+            <a:off x="4709160" y="3520440"/>
             <a:ext cx="457200" cy="457200"/>
           </a:xfrm>
           <a:prstGeom prst="ellipse">
@@ -8770,7 +9421,7 @@
         </p:nvSpPr>
         <p:spPr>
           <a:xfrm>
-            <a:off x="4709160" y="3474720"/>
+            <a:off x="4709160" y="3520440"/>
             <a:ext cx="457200" cy="457200"/>
           </a:xfrm>
           <a:prstGeom prst="rect">
@@ -8806,7 +9457,7 @@
         </p:nvSpPr>
         <p:spPr>
           <a:xfrm>
-            <a:off x="5349240" y="3429000"/>
+            <a:off x="5349240" y="3474720"/>
             <a:ext cx="3337560" cy="301752"/>
           </a:xfrm>
           <a:prstGeom prst="rect">
@@ -8828,7 +9479,7 @@
                   <a:schemeClr val="tx1"/>
                 </a:solidFill>
               </a:rPr>
-              <a:t>Depth loss ×20 for 10 epochs</a:t>
+              <a:t>Children and fingers</a:t>
             </a:r>
             <a:endParaRPr lang="en-US" sz="1500" dirty="0"/>
           </a:p>
@@ -8842,8 +9493,8 @@
         </p:nvSpPr>
         <p:spPr>
           <a:xfrm>
-            <a:off x="5349240" y="3758184"/>
-            <a:ext cx="3337560" cy="749808"/>
+            <a:off x="5349240" y="3803904"/>
+            <a:ext cx="3337560" cy="777240"/>
           </a:xfrm>
           <a:prstGeom prst="rect">
             <a:avLst/>
@@ -8864,7 +9515,7 @@
                   <a:schemeClr val="tx2"/>
                 </a:solidFill>
               </a:rPr>
-              <a:t>No result yet, so no numbers quoted.</a:t>
+              <a:t>One 2-epoch test is not enough. Next: a 10-epoch balanced-sampler run; for fingers, training on larger hand crops. Otherwise both go into the thesis as limitations.</a:t>
             </a:r>
             <a:endParaRPr lang="en-US" sz="1200" dirty="0"/>
           </a:p>
@@ -8950,8 +9601,8 @@
         </p:nvSpPr>
         <p:spPr>
           <a:xfrm>
-            <a:off x="548640" y="548640"/>
-            <a:ext cx="8046720" cy="914400"/>
+            <a:off x="548640" y="457200"/>
+            <a:ext cx="8046720" cy="822960"/>
           </a:xfrm>
           <a:prstGeom prst="rect">
             <a:avLst/>
@@ -8988,8 +9639,8 @@
         </p:nvSpPr>
         <p:spPr>
           <a:xfrm>
-            <a:off x="548640" y="1645920"/>
-            <a:ext cx="8046720" cy="3017520"/>
+            <a:off x="548640" y="1371600"/>
+            <a:ext cx="8046720" cy="1783080"/>
           </a:xfrm>
           <a:prstGeom prst="rect">
             <a:avLst/>
@@ -9018,7 +9669,7 @@
                   <a:schemeClr val="bg2"/>
                 </a:solidFill>
               </a:rPr>
-              <a:t>the failures are not rig or decoding problems. A training-target bug puts people too far away in v5, v9 and v10 (v5: all 222 holdout people); the fix brings bodies much closer to their true size.</a:t>
+              <a:t>the failures are not rig or decoding problems. A training-target bug puts people too far away in v5, v9 and v10 (v5: all 222 holdout people); the fix draws bodies much closer to their true size.</a:t>
             </a:r>
             <a:endParaRPr lang="en-US" sz="1700" dirty="0"/>
           </a:p>
@@ -9040,31 +9691,157 @@
                   <a:schemeClr val="bg2"/>
                 </a:solidFill>
               </a:rPr>
-              <a:t>any improvement in neck, fingers or children; good near vs far depth; a fix without cost (PVE and recall may be slightly worse).</a:t>
+              <a:t>any improvement in neck, fingers or children; good near vs far depth; a fix without cost (likely 3–5 mm PVE and about 2 recall points worse, not yet confirmed).</a:t>
             </a:r>
             <a:endParaRPr lang="en-US" sz="1700" dirty="0"/>
           </a:p>
-          <a:p>
-            <a:pPr algn="l" indent="0" marL="0">
+        </p:txBody>
+      </p:sp>
+      <p:sp>
+        <p:nvSpPr>
+          <p:cNvPr id="4" name="question box"/>
+          <p:cNvSpPr/>
+          <p:nvPr/>
+        </p:nvSpPr>
+        <p:spPr>
+          <a:xfrm>
+            <a:off x="548640" y="3291840"/>
+            <a:ext cx="8046720" cy="1325880"/>
+          </a:xfrm>
+          <a:prstGeom prst="rect">
+            <a:avLst/>
+          </a:prstGeom>
+          <a:solidFill>
+            <a:srgbClr val="2B3550"/>
+          </a:solidFill>
+          <a:ln w="12700">
+            <a:solidFill>
+              <a:srgbClr val="2B3550"/>
+            </a:solidFill>
+            <a:prstDash val="solid"/>
+          </a:ln>
+        </p:spPr>
+      </p:sp>
+      <p:sp>
+        <p:nvSpPr>
+          <p:cNvPr id="5" name="question bar"/>
+          <p:cNvSpPr/>
+          <p:nvPr/>
+        </p:nvSpPr>
+        <p:spPr>
+          <a:xfrm>
+            <a:off x="548640" y="3291840"/>
+            <a:ext cx="73152" cy="1325880"/>
+          </a:xfrm>
+          <a:prstGeom prst="rect">
+            <a:avLst/>
+          </a:prstGeom>
+          <a:solidFill>
+            <a:srgbClr val="F4C95D"/>
+          </a:solidFill>
+          <a:ln w="12700">
+            <a:solidFill>
+              <a:srgbClr val="F4C95D"/>
+            </a:solidFill>
+            <a:prstDash val="solid"/>
+          </a:ln>
+        </p:spPr>
+      </p:sp>
+      <p:sp>
+        <p:nvSpPr>
+          <p:cNvPr id="6" name="question text"/>
+          <p:cNvSpPr txBox="1"/>
+          <p:nvPr/>
+        </p:nvSpPr>
+        <p:spPr>
+          <a:xfrm>
+            <a:off x="822960" y="3364992"/>
+            <a:ext cx="7635240" cy="1188720"/>
+          </a:xfrm>
+          <a:prstGeom prst="rect">
+            <a:avLst/>
+          </a:prstGeom>
+          <a:noFill/>
+          <a:ln/>
+        </p:spPr>
+        <p:txBody>
+          <a:bodyPr wrap="square" lIns="0" tIns="0" rIns="0" bIns="0" rtlCol="0" anchor="ctr"/>
+          <a:lstStyle/>
+          <a:p>
+            <a:pPr indent="0" marL="0">
+              <a:spcAft>
+                <a:spcPts val="400"/>
+              </a:spcAft>
               <a:buNone/>
             </a:pPr>
             <a:r>
-              <a:rPr lang="en-US" sz="1700" b="1" dirty="0">
+              <a:rPr lang="en-US" sz="1600" b="1" dirty="0">
                 <a:solidFill>
                   <a:srgbClr val="F4C95D"/>
                 </a:solidFill>
               </a:rPr>
-              <a:t>Question for you: </a:t>
-            </a:r>
-            <a:r>
-              <a:rPr lang="en-US" sz="1700" dirty="0">
-                <a:solidFill>
-                  <a:schemeClr val="bg2"/>
-                </a:solidFill>
-              </a:rPr>
-              <a:t>should I fine-tune v9 (our best on 3DPW) with the corrected targets and depth loss ×5, about one hour of training, before the thesis numbers are final? Expected: bodies near true size; possible cost 3–5 mm PVE and 2–3 recall points; 3DPW effect unknown.</a:t>
-            </a:r>
-            <a:endParaRPr lang="en-US" sz="1700" dirty="0"/>
+              <a:t>Question for you</a:t>
+            </a:r>
+            <a:endParaRPr lang="en-US" sz="1600" dirty="0"/>
+          </a:p>
+          <a:p>
+            <a:pPr indent="0" marL="0">
+              <a:buNone/>
+            </a:pPr>
+            <a:r>
+              <a:rPr lang="en-US" sz="1600" dirty="0">
+                <a:solidFill>
+                  <a:srgbClr val="EEF2F7"/>
+                </a:solidFill>
+              </a:rPr>
+              <a:t>Fine-tune v9 (best on 3DPW) with the fixed targets and depth ×5? Expected from v5: drawn size about 0.84, root error about 0.5 m; likely cost 3–5 mm PVE and 2 recall points. v9 keeps the stuck neck; v10 is the alternative.</a:t>
+            </a:r>
+            <a:endParaRPr lang="en-US" sz="1600" dirty="0"/>
+          </a:p>
+        </p:txBody>
+      </p:sp>
+      <p:sp>
+        <p:nvSpPr>
+          <p:cNvPr id="25" name="Slide Number Placeholder 0"/>
+          <p:cNvSpPr>
+            <a:spLocks noGrp="1"/>
+          </p:cNvSpPr>
+          <p:nvPr>
+            <p:ph type="sldNum" sz="quarter" idx="4294967295"/>
+          </p:nvPr>
+        </p:nvSpPr>
+        <p:spPr>
+          <a:xfrm>
+            <a:off x="8412480" y="4754880"/>
+            <a:ext cx="457200" cy="274320"/>
+          </a:xfrm>
+          <a:prstGeom prst="rect">
+            <a:avLst/>
+          </a:prstGeom>
+          <a:extLst>
+            <a:ext uri="{C572A759-6A51-4108-AA02-DFA0A04FC94B}">
+              <ma14:wrappingTextBoxFlag xmlns:ma14="http://schemas.microsoft.com/office/mac/drawingml/2011/main" val="0"/>
+            </a:ext>
+          </a:extLst>
+        </p:spPr>
+        <p:txBody>
+          <a:bodyPr/>
+          <a:lstStyle>
+            <a:lvl1pPr>
+              <a:defRPr sz="1000">
+                <a:solidFill>
+                  <a:srgbClr val="7B8794"/>
+                </a:solidFill>
+              </a:defRPr>
+            </a:lvl1pPr>
+          </a:lstStyle>
+          <a:p>
+            <a:pPr algn="l"/>
+            <a:fld id="{F7021451-1387-4CA6-816F-3879F97B5CBC}" type="slidenum">
+              <a:rPr b="0" lang="en-US"/>
+              <a:t>14</a:t>
+            </a:fld>
+            <a:endParaRPr lang="en-US"/>
           </a:p>
         </p:txBody>
       </p:sp>
@@ -9147,8 +9924,8 @@
         </p:blipFill>
         <p:spPr>
           <a:xfrm>
-            <a:off x="640080" y="1051560"/>
-            <a:ext cx="7863840" cy="2864356"/>
+            <a:off x="914400" y="1097280"/>
+            <a:ext cx="7315200" cy="2664517"/>
           </a:xfrm>
           <a:prstGeom prst="rect">
             <a:avLst/>
@@ -9163,8 +9940,8 @@
         </p:nvSpPr>
         <p:spPr>
           <a:xfrm>
-            <a:off x="640080" y="3970780"/>
-            <a:ext cx="2595002" cy="365760"/>
+            <a:off x="914400" y="3816661"/>
+            <a:ext cx="2413955" cy="365760"/>
           </a:xfrm>
           <a:prstGeom prst="rect">
             <a:avLst/>
@@ -9199,8 +9976,8 @@
         </p:nvSpPr>
         <p:spPr>
           <a:xfrm>
-            <a:off x="3274499" y="3970780"/>
-            <a:ext cx="2595002" cy="365760"/>
+            <a:off x="3365023" y="3816661"/>
+            <a:ext cx="2413955" cy="365760"/>
           </a:xfrm>
           <a:prstGeom prst="rect">
             <a:avLst/>
@@ -9235,8 +10012,8 @@
         </p:nvSpPr>
         <p:spPr>
           <a:xfrm>
-            <a:off x="5908918" y="3970780"/>
-            <a:ext cx="2595002" cy="365760"/>
+            <a:off x="5815645" y="3816661"/>
+            <a:ext cx="2413955" cy="365760"/>
           </a:xfrm>
           <a:prstGeom prst="rect">
             <a:avLst/>
@@ -9257,7 +10034,7 @@
                   <a:schemeClr val="tx1"/>
                 </a:solidFill>
               </a:rPr>
-              <a:t>Fix + depth loss ×5, 10 epochs: mesh height matches</a:t>
+              <a:t>Fix + depth loss ×5, 10 epochs: mesh height close to the truth (slightly larger)</a:t>
             </a:r>
             <a:endParaRPr lang="en-US" sz="1100" dirty="0"/>
           </a:p>
@@ -9271,8 +10048,8 @@
         </p:nvSpPr>
         <p:spPr>
           <a:xfrm>
-            <a:off x="640080" y="4373116"/>
-            <a:ext cx="7863840" cy="274320"/>
+            <a:off x="640080" y="4218997"/>
+            <a:ext cx="7863840" cy="365760"/>
           </a:xfrm>
           <a:prstGeom prst="rect">
             <a:avLst/>
@@ -9301,7 +10078,7 @@
                   <a:schemeClr val="tx2"/>
                 </a:solidFill>
               </a:rPr>
-              <a:t>here the fixed mesh is a little larger and wider than the ground truth. Colours follow detection order.</a:t>
+              <a:t>here the fixed mesh is a little larger and wider than the ground truth. The two people in front have no ground-truth mesh either, so they are not counted as misses. Colours follow detection order.</a:t>
             </a:r>
             <a:endParaRPr lang="en-US" sz="1100" dirty="0"/>
           </a:p>
@@ -9424,7 +10201,7 @@
         <p:spPr>
           <a:xfrm>
             <a:off x="457200" y="1280160"/>
-            <a:ext cx="2651760" cy="2743200"/>
+            <a:ext cx="2651760" cy="3017520"/>
           </a:xfrm>
           <a:prstGeom prst="roundRect">
             <a:avLst>
@@ -9512,7 +10289,7 @@
         <p:spPr>
           <a:xfrm>
             <a:off x="640080" y="1965960"/>
-            <a:ext cx="2286000" cy="1920240"/>
+            <a:ext cx="2286000" cy="2194560"/>
           </a:xfrm>
           <a:prstGeom prst="rect">
             <a:avLst/>
@@ -9551,7 +10328,7 @@
                   <a:schemeClr val="tx2"/>
                 </a:solidFill>
               </a:rPr>
-              <a:t>the rig is fine; the v5 models are stuck at a fixed neck-bone rotation error.</a:t>
+              <a:t>the rig is fine. The v5 models are stuck at a fixed neck-bone rotation error. Whether that causes the look is not yet shown.</a:t>
             </a:r>
             <a:endParaRPr lang="en-US" sz="1300" dirty="0"/>
           </a:p>
@@ -9566,7 +10343,7 @@
         <p:spPr>
           <a:xfrm>
             <a:off x="3246120" y="1280160"/>
-            <a:ext cx="2651760" cy="2743200"/>
+            <a:ext cx="2651760" cy="3017520"/>
           </a:xfrm>
           <a:prstGeom prst="roundRect">
             <a:avLst>
@@ -9654,7 +10431,7 @@
         <p:spPr>
           <a:xfrm>
             <a:off x="3429000" y="1965960"/>
-            <a:ext cx="2286000" cy="1920240"/>
+            <a:ext cx="2286000" cy="2194560"/>
           </a:xfrm>
           <a:prstGeom prst="rect">
             <a:avLst/>
@@ -9708,7 +10485,7 @@
         <p:spPr>
           <a:xfrm>
             <a:off x="6035040" y="1280160"/>
-            <a:ext cx="2651760" cy="2743200"/>
+            <a:ext cx="2651760" cy="3017520"/>
           </a:xfrm>
           <a:prstGeom prst="roundRect">
             <a:avLst>
@@ -9796,7 +10573,7 @@
         <p:spPr>
           <a:xfrm>
             <a:off x="6217920" y="1965960"/>
-            <a:ext cx="2286000" cy="1920240"/>
+            <a:ext cx="2286000" cy="2194560"/>
           </a:xfrm>
           <a:prstGeom prst="rect">
             <a:avLst/>
@@ -10849,7 +11626,7 @@
                   <a:schemeClr val="tx1"/>
                 </a:solidFill>
               </a:rPr>
-              <a:t>What is not the cause: every structural check passes</a:t>
+              <a:t>What is not the cause: the structural checks pass</a:t>
             </a:r>
             <a:endParaRPr lang="en-US" sz="2700" dirty="0"/>
           </a:p>
@@ -10863,7 +11640,7 @@
         </p:nvSpPr>
         <p:spPr>
           <a:xfrm>
-            <a:off x="457200" y="1325880"/>
+            <a:off x="457200" y="1280160"/>
             <a:ext cx="457200" cy="457200"/>
           </a:xfrm>
           <a:prstGeom prst="ellipse">
@@ -10888,7 +11665,7 @@
         </p:nvSpPr>
         <p:spPr>
           <a:xfrm>
-            <a:off x="457200" y="1325880"/>
+            <a:off x="457200" y="1280160"/>
             <a:ext cx="457200" cy="457200"/>
           </a:xfrm>
           <a:prstGeom prst="rect">
@@ -10924,7 +11701,7 @@
         </p:nvSpPr>
         <p:spPr>
           <a:xfrm>
-            <a:off x="1097280" y="1234440"/>
+            <a:off x="1097280" y="1188720"/>
             <a:ext cx="7589520" cy="320040"/>
           </a:xfrm>
           <a:prstGeom prst="rect">
@@ -10960,8 +11737,8 @@
         </p:nvSpPr>
         <p:spPr>
           <a:xfrm>
-            <a:off x="1097280" y="1581912"/>
-            <a:ext cx="7589520" cy="457200"/>
+            <a:off x="1097280" y="1536192"/>
+            <a:ext cx="7589520" cy="411480"/>
           </a:xfrm>
           <a:prstGeom prst="rect">
             <a:avLst/>
@@ -10996,7 +11773,7 @@
         </p:nvSpPr>
         <p:spPr>
           <a:xfrm>
-            <a:off x="457200" y="2194560"/>
+            <a:off x="457200" y="2103120"/>
             <a:ext cx="457200" cy="457200"/>
           </a:xfrm>
           <a:prstGeom prst="ellipse">
@@ -11021,7 +11798,7 @@
         </p:nvSpPr>
         <p:spPr>
           <a:xfrm>
-            <a:off x="457200" y="2194560"/>
+            <a:off x="457200" y="2103120"/>
             <a:ext cx="457200" cy="457200"/>
           </a:xfrm>
           <a:prstGeom prst="rect">
@@ -11057,7 +11834,7 @@
         </p:nvSpPr>
         <p:spPr>
           <a:xfrm>
-            <a:off x="1097280" y="2103120"/>
+            <a:off x="1097280" y="2011680"/>
             <a:ext cx="7589520" cy="320040"/>
           </a:xfrm>
           <a:prstGeom prst="rect">
@@ -11093,8 +11870,8 @@
         </p:nvSpPr>
         <p:spPr>
           <a:xfrm>
-            <a:off x="1097280" y="2450592"/>
-            <a:ext cx="7589520" cy="457200"/>
+            <a:off x="1097280" y="2359152"/>
+            <a:ext cx="7589520" cy="411480"/>
           </a:xfrm>
           <a:prstGeom prst="rect">
             <a:avLst/>
@@ -11129,7 +11906,7 @@
         </p:nvSpPr>
         <p:spPr>
           <a:xfrm>
-            <a:off x="457200" y="3063240"/>
+            <a:off x="457200" y="2926080"/>
             <a:ext cx="457200" cy="457200"/>
           </a:xfrm>
           <a:prstGeom prst="ellipse">
@@ -11154,7 +11931,7 @@
         </p:nvSpPr>
         <p:spPr>
           <a:xfrm>
-            <a:off x="457200" y="3063240"/>
+            <a:off x="457200" y="2926080"/>
             <a:ext cx="457200" cy="457200"/>
           </a:xfrm>
           <a:prstGeom prst="rect">
@@ -11190,7 +11967,7 @@
         </p:nvSpPr>
         <p:spPr>
           <a:xfrm>
-            <a:off x="1097280" y="2971800"/>
+            <a:off x="1097280" y="2834640"/>
             <a:ext cx="7589520" cy="320040"/>
           </a:xfrm>
           <a:prstGeom prst="rect">
@@ -11212,7 +11989,7 @@
                   <a:schemeClr val="tx1"/>
                 </a:solidFill>
               </a:rPr>
-              <a:t>Gradients reach every head</a:t>
+              <a:t>Gradients reach every bone and shape output</a:t>
             </a:r>
             <a:endParaRPr lang="en-US" sz="1600" dirty="0"/>
           </a:p>
@@ -11226,8 +12003,8 @@
         </p:nvSpPr>
         <p:spPr>
           <a:xfrm>
-            <a:off x="1097280" y="3319272"/>
-            <a:ext cx="7589520" cy="457200"/>
+            <a:off x="1097280" y="3182112"/>
+            <a:ext cx="7589520" cy="411480"/>
           </a:xfrm>
           <a:prstGeom prst="rect">
             <a:avLst/>
@@ -11262,18 +12039,18 @@
         </p:nvSpPr>
         <p:spPr>
           <a:xfrm>
-            <a:off x="457200" y="3931920"/>
+            <a:off x="457200" y="3749040"/>
             <a:ext cx="457200" cy="457200"/>
           </a:xfrm>
           <a:prstGeom prst="ellipse">
             <a:avLst/>
           </a:prstGeom>
           <a:solidFill>
-            <a:schemeClr val="accent3"/>
+            <a:schemeClr val="accent2"/>
           </a:solidFill>
           <a:ln w="12700">
             <a:solidFill>
-              <a:schemeClr val="accent3"/>
+              <a:schemeClr val="accent2"/>
             </a:solidFill>
             <a:prstDash val="solid"/>
           </a:ln>
@@ -11287,7 +12064,7 @@
         </p:nvSpPr>
         <p:spPr>
           <a:xfrm>
-            <a:off x="457200" y="3931920"/>
+            <a:off x="457200" y="3749040"/>
             <a:ext cx="457200" cy="457200"/>
           </a:xfrm>
           <a:prstGeom prst="rect">
@@ -11309,7 +12086,7 @@
                   <a:schemeClr val="bg1"/>
                 </a:solidFill>
               </a:rPr>
-              <a:t>✓</a:t>
+              <a:t>!</a:t>
             </a:r>
             <a:endParaRPr lang="en-US" sz="1800" dirty="0"/>
           </a:p>
@@ -11323,7 +12100,7 @@
         </p:nvSpPr>
         <p:spPr>
           <a:xfrm>
-            <a:off x="1097280" y="3840480"/>
+            <a:off x="1097280" y="3657600"/>
             <a:ext cx="7589520" cy="320040"/>
           </a:xfrm>
           <a:prstGeom prst="rect">
@@ -11345,7 +12122,7 @@
                   <a:schemeClr val="tx1"/>
                 </a:solidFill>
               </a:rPr>
-              <a:t>Optimiser works for shape and 3D joints</a:t>
+              <a:t>Optimiser works for shape and 3D joints, with two warnings</a:t>
             </a:r>
             <a:endParaRPr lang="en-US" sz="1600" dirty="0"/>
           </a:p>
@@ -11359,8 +12136,8 @@
         </p:nvSpPr>
         <p:spPr>
           <a:xfrm>
-            <a:off x="1097280" y="4187952"/>
-            <a:ext cx="7589520" cy="457200"/>
+            <a:off x="1097280" y="4005072"/>
+            <a:ext cx="7589520" cy="603504"/>
           </a:xfrm>
           <a:prstGeom prst="rect">
             <a:avLst/>
@@ -11381,7 +12158,7 @@
                   <a:schemeClr val="tx2"/>
                 </a:solidFill>
               </a:rPr>
-              <a:t>40 training images: error falls 36%; holdout error rises, as expected when memorising. But the rotation loss barely moves (44.6 → 40.8), which fits the stuck neck.</a:t>
+              <a:t>40 training images: error falls 36%; holdout error rises, as expected when memorising. But the translation and 2D losses rose while memorising (1.67 → 1.89; 58 → 75), probably the first sign of the depth bug (slide 8). The summed rotation loss over all bones barely moved (44.6 → 40.8).</a:t>
             </a:r>
             <a:endParaRPr lang="en-US" sz="1300" dirty="0"/>
           </a:p>
@@ -11497,14 +12274,14 @@
       </p:sp>
       <p:sp>
         <p:nvSpPr>
-          <p:cNvPr id="3" name="stat predicted neck length vs truth (holdout)"/>
+          <p:cNvPr id="3" name="stat predicted neck length vs truth (holdout); with the true shape it is exact"/>
           <p:cNvSpPr txBox="1"/>
           <p:nvPr/>
         </p:nvSpPr>
         <p:spPr>
           <a:xfrm>
-            <a:off x="457200" y="1188720"/>
-            <a:ext cx="2560320" cy="685800"/>
+            <a:off x="457200" y="1280160"/>
+            <a:ext cx="2560320" cy="822960"/>
           </a:xfrm>
           <a:prstGeom prst="rect">
             <a:avLst/>
@@ -11533,14 +12310,14 @@
       </p:sp>
       <p:sp>
         <p:nvSpPr>
-          <p:cNvPr id="4" name="label predicted neck length vs truth (holdout)"/>
+          <p:cNvPr id="4" name="label predicted neck length vs truth (holdout); with the true shape it is exact"/>
           <p:cNvSpPr txBox="1"/>
           <p:nvPr/>
         </p:nvSpPr>
         <p:spPr>
           <a:xfrm>
-            <a:off x="457200" y="1874520"/>
-            <a:ext cx="2560320" cy="566928"/>
+            <a:off x="457200" y="2103120"/>
+            <a:ext cx="2560320" cy="640080"/>
           </a:xfrm>
           <a:prstGeom prst="rect">
             <a:avLst/>
@@ -11556,27 +12333,27 @@
               <a:buNone/>
             </a:pPr>
             <a:r>
-              <a:rPr lang="en-US" sz="1200" dirty="0">
+              <a:rPr lang="en-US" sz="1300" dirty="0">
                 <a:solidFill>
                   <a:schemeClr val="tx2"/>
                 </a:solidFill>
               </a:rPr>
-              <a:t>predicted neck length vs truth (holdout)</a:t>
-            </a:r>
-            <a:endParaRPr lang="en-US" sz="1200" dirty="0"/>
-          </a:p>
-        </p:txBody>
-      </p:sp>
-      <p:sp>
-        <p:nvSpPr>
-          <p:cNvPr id="5" name="stat mean error, neck bones / head + jaw: v5, v9 and 6 pilots (v5: ±1.5° per person)"/>
+              <a:t>predicted neck length vs truth (holdout); with the true shape it is exact</a:t>
+            </a:r>
+            <a:endParaRPr lang="en-US" sz="1300" dirty="0"/>
+          </a:p>
+        </p:txBody>
+      </p:sp>
+      <p:sp>
+        <p:nvSpPr>
+          <p:cNvPr id="5" name="stat neck bones / head + jaw, rotation vs parent bone: v5, v9, all pilots (±1.5° per person)"/>
           <p:cNvSpPr txBox="1"/>
           <p:nvPr/>
         </p:nvSpPr>
         <p:spPr>
           <a:xfrm>
-            <a:off x="3200400" y="1188720"/>
-            <a:ext cx="2560320" cy="685800"/>
+            <a:off x="3200400" y="1280160"/>
+            <a:ext cx="2560320" cy="822960"/>
           </a:xfrm>
           <a:prstGeom prst="rect">
             <a:avLst/>
@@ -11605,14 +12382,14 @@
       </p:sp>
       <p:sp>
         <p:nvSpPr>
-          <p:cNvPr id="6" name="label mean error, neck bones / head + jaw: v5, v9 and 6 pilots (v5: ±1.5° per person)"/>
+          <p:cNvPr id="6" name="label neck bones / head + jaw, rotation vs parent bone: v5, v9, all pilots (±1.5° per person)"/>
           <p:cNvSpPr txBox="1"/>
           <p:nvPr/>
         </p:nvSpPr>
         <p:spPr>
           <a:xfrm>
-            <a:off x="3200400" y="1874520"/>
-            <a:ext cx="2560320" cy="566928"/>
+            <a:off x="3200400" y="2103120"/>
+            <a:ext cx="2560320" cy="640080"/>
           </a:xfrm>
           <a:prstGeom prst="rect">
             <a:avLst/>
@@ -11628,27 +12405,27 @@
               <a:buNone/>
             </a:pPr>
             <a:r>
-              <a:rPr lang="en-US" sz="1200" dirty="0">
+              <a:rPr lang="en-US" sz="1300" dirty="0">
                 <a:solidFill>
                   <a:schemeClr val="tx2"/>
                 </a:solidFill>
               </a:rPr>
-              <a:t>mean error, neck bones / head + jaw: v5, v9 and 6 pilots (v5: ±1.5° per person)</a:t>
-            </a:r>
-            <a:endParaRPr lang="en-US" sz="1200" dirty="0"/>
-          </a:p>
-        </p:txBody>
-      </p:sp>
-      <p:sp>
-        <p:nvSpPr>
-          <p:cNvPr id="7" name="stat v10: neck right, but shoulders 50° and arms 36° off"/>
+              <a:t>neck bones / head + jaw, rotation vs parent bone: v5, v9, all pilots (±1.5° per person)</a:t>
+            </a:r>
+            <a:endParaRPr lang="en-US" sz="1300" dirty="0"/>
+          </a:p>
+        </p:txBody>
+      </p:sp>
+      <p:sp>
+        <p:nvSpPr>
+          <p:cNvPr id="7" name="stat v10, same bones; but holdout PVE 74.1 vs 70.5 mm, shoulders 50°, arms 36°"/>
           <p:cNvSpPr txBox="1"/>
           <p:nvPr/>
         </p:nvSpPr>
         <p:spPr>
           <a:xfrm>
-            <a:off x="6035040" y="1188720"/>
-            <a:ext cx="2651760" cy="685800"/>
+            <a:off x="6035040" y="1280160"/>
+            <a:ext cx="2651760" cy="822960"/>
           </a:xfrm>
           <a:prstGeom prst="rect">
             <a:avLst/>
@@ -11677,14 +12454,14 @@
       </p:sp>
       <p:sp>
         <p:nvSpPr>
-          <p:cNvPr id="8" name="label v10: neck right, but shoulders 50° and arms 36° off"/>
+          <p:cNvPr id="8" name="label v10, same bones; but holdout PVE 74.1 vs 70.5 mm, shoulders 50°, arms 36°"/>
           <p:cNvSpPr txBox="1"/>
           <p:nvPr/>
         </p:nvSpPr>
         <p:spPr>
           <a:xfrm>
-            <a:off x="6035040" y="1874520"/>
-            <a:ext cx="2651760" cy="566928"/>
+            <a:off x="6035040" y="2103120"/>
+            <a:ext cx="2651760" cy="640080"/>
           </a:xfrm>
           <a:prstGeom prst="rect">
             <a:avLst/>
@@ -11700,14 +12477,14 @@
               <a:buNone/>
             </a:pPr>
             <a:r>
-              <a:rPr lang="en-US" sz="1200" dirty="0">
+              <a:rPr lang="en-US" sz="1300" dirty="0">
                 <a:solidFill>
                   <a:schemeClr val="tx2"/>
                 </a:solidFill>
               </a:rPr>
-              <a:t>v10: neck right, but shoulders 50° and arms 36° off</a:t>
-            </a:r>
-            <a:endParaRPr lang="en-US" sz="1200" dirty="0"/>
+              <a:t>v10, same bones; but holdout PVE 74.1 vs 70.5 mm, shoulders 50°, arms 36°</a:t>
+            </a:r>
+            <a:endParaRPr lang="en-US" sz="1300" dirty="0"/>
           </a:p>
         </p:txBody>
       </p:sp>
@@ -11719,12 +12496,12 @@
         </p:nvSpPr>
         <p:spPr>
           <a:xfrm>
-            <a:off x="457200" y="2560320"/>
-            <a:ext cx="8229600" cy="2103120"/>
+            <a:off x="457200" y="2880360"/>
+            <a:ext cx="8229600" cy="1783080"/>
           </a:xfrm>
           <a:prstGeom prst="roundRect">
             <a:avLst>
-              <a:gd name="adj" fmla="val 3478"/>
+              <a:gd name="adj" fmla="val 4103"/>
             </a:avLst>
           </a:prstGeom>
           <a:solidFill>
@@ -11746,8 +12523,8 @@
         </p:nvSpPr>
         <p:spPr>
           <a:xfrm>
-            <a:off x="640080" y="2651760"/>
-            <a:ext cx="7863840" cy="1920240"/>
+            <a:off x="640080" y="2926080"/>
+            <a:ext cx="7863840" cy="1691640"/>
           </a:xfrm>
           <a:prstGeom prst="rect">
             <a:avLst/>
@@ -11772,7 +12549,7 @@
                   <a:schemeClr val="tx1"/>
                 </a:solidFill>
               </a:rPr>
-              <a:t>v10 shows the loss can teach the neck, </a:t>
+              <a:t>v10 learns these bones with the same loss: </a:t>
             </a:r>
             <a:r>
               <a:rPr lang="en-US" sz="1200" dirty="0">
@@ -11780,7 +12557,7 @@
                   <a:schemeClr val="tx1"/>
                 </a:solidFill>
               </a:rPr>
-              <a:t>but is no better overall (shoulders 50°, arms 36°) and differs in three ways: no ×4 neck boost, fresh heads, 3DPW from the start.</a:t>
+              <a:t>it used the final recipe from the start (masked, no boost, 3DPW); v5 went through a frozen-backbone stage first.</a:t>
             </a:r>
             <a:endParaRPr lang="en-US" sz="1200" dirty="0"/>
           </a:p>
@@ -11798,7 +12575,7 @@
                   <a:schemeClr val="tx1"/>
                 </a:solidFill>
               </a:rPr>
-              <a:t>v5 and its fine-tunes (v9, pilots) are stuck: </a:t>
+              <a:t>v5 and its fine-tunes are stuck: </a:t>
             </a:r>
             <a:r>
               <a:rPr lang="en-US" sz="1200" dirty="0">
@@ -11806,7 +12583,7 @@
                   <a:schemeClr val="tx1"/>
                 </a:solidFill>
               </a:rPr>
-              <a:t>149,000 more steps in v9 changed nothing. Head direction is only 12° off.</a:t>
+              <a:t>150,000 more steps in v9 changed nothing, nor did a pilot that gave head and neck a third of the rotation loss. Head direction: 12° off on the holdout.</a:t>
             </a:r>
             <a:endParaRPr lang="en-US" sz="1200" dirty="0"/>
           </a:p>
@@ -11832,7 +12609,7 @@
                   <a:schemeClr val="tx1"/>
                 </a:solidFill>
               </a:rPr>
-              <a:t>the neck montage and real-photo demos place each body from its detection box (--anchor_to_box 1).</a:t>
+              <a:t>the neck montage and real-photo demos place each body from its detection box (--anchor_to_box 1).</a:t>
             </a:r>
             <a:endParaRPr lang="en-US" sz="1200" dirty="0"/>
           </a:p>
@@ -11858,7 +12635,7 @@
                   <a:schemeClr val="tx1"/>
                 </a:solidFill>
               </a:rPr>
-              <a:t>the loss compares rotation matrices number by number and can stick near a 180° flip. One of 3 neck bones flipped and two almost right gives a mean near 63°; head or jaw flipped gives near 90°.</a:t>
+              <a:t>the loss compares rotation matrices number by number and can stick near a 180° flip (one of 3 neck bones flipped: mean near 63°; head or jaw flipped: near 90°).</a:t>
             </a:r>
             <a:endParaRPr lang="en-US" sz="1200" dirty="0"/>
           </a:p>
@@ -11884,7 +12661,7 @@
                   <a:schemeClr val="tx1"/>
                 </a:solidFill>
               </a:rPr>
-              <a:t>that this offset makes necks look wrong. The head-neck surface error (PVE_hn) cannot tell: 91% of its vertices are on the head.</a:t>
+              <a:t>that this offset makes necks look wrong; PVE_hn cannot tell (91% of its vertices are on the head).</a:t>
             </a:r>
             <a:endParaRPr lang="en-US" sz="1200" dirty="0"/>
           </a:p>
@@ -12144,7 +12921,7 @@
       </p:sp>
       <p:sp>
         <p:nvSpPr>
-          <p:cNvPr id="7" name="stat change when the person is magnified at test time (median 1.6×, no retraining)"/>
+          <p:cNvPr id="7" name="stat change when the person is magnified at test time (no retraining)"/>
           <p:cNvSpPr txBox="1"/>
           <p:nvPr/>
         </p:nvSpPr>
@@ -12180,7 +12957,7 @@
       </p:sp>
       <p:sp>
         <p:nvSpPr>
-          <p:cNvPr id="8" name="label change when the person is magnified at test time (median 1.6×, no retraining)"/>
+          <p:cNvPr id="8" name="label change when the person is magnified at test time (no retraining)"/>
           <p:cNvSpPr txBox="1"/>
           <p:nvPr/>
         </p:nvSpPr>
@@ -12208,7 +12985,7 @@
                   <a:schemeClr val="tx2"/>
                 </a:solidFill>
               </a:rPr>
-              <a:t>change when the person is magnified at test time (median 1.6×, no retraining)</a:t>
+              <a:t>change when the person is magnified at test time (no retraining)</a:t>
             </a:r>
             <a:endParaRPr lang="en-US" sz="1300" dirty="0"/>
           </a:p>
@@ -12987,14 +13764,14 @@
       </p:graphicFrame>
       <p:sp>
         <p:nvSpPr>
-          <p:cNvPr id="10" name="finger text"/>
+          <p:cNvPr id="10" name="hand table note"/>
           <p:cNvSpPr txBox="1"/>
           <p:nvPr/>
         </p:nvSpPr>
         <p:spPr>
           <a:xfrm>
-            <a:off x="5852160" y="2971800"/>
-            <a:ext cx="2834640" cy="1691640"/>
+            <a:off x="457200" y="4334256"/>
+            <a:ext cx="5120640" cy="365760"/>
           </a:xfrm>
           <a:prstGeom prst="rect">
             <a:avLst/>
@@ -13010,6 +13787,42 @@
               <a:buNone/>
             </a:pPr>
             <a:r>
+              <a:rPr lang="en-US" sz="1100" dirty="0">
+                <a:solidFill>
+                  <a:schemeClr val="tx2"/>
+                </a:solidFill>
+              </a:rPr>
+              <a:t>Table: median hand size (2.3 → 4.2 tokens). Per person the median gain is 1.6×; 26% of people get no magnification, a quarter 2.5× or more.</a:t>
+            </a:r>
+            <a:endParaRPr lang="en-US" sz="1100" dirty="0"/>
+          </a:p>
+        </p:txBody>
+      </p:sp>
+      <p:sp>
+        <p:nvSpPr>
+          <p:cNvPr id="11" name="finger text"/>
+          <p:cNvSpPr txBox="1"/>
+          <p:nvPr/>
+        </p:nvSpPr>
+        <p:spPr>
+          <a:xfrm>
+            <a:off x="5852160" y="2971800"/>
+            <a:ext cx="2834640" cy="1737360"/>
+          </a:xfrm>
+          <a:prstGeom prst="rect">
+            <a:avLst/>
+          </a:prstGeom>
+          <a:noFill/>
+          <a:ln/>
+        </p:spPr>
+        <p:txBody>
+          <a:bodyPr wrap="square" lIns="0" tIns="0" rIns="0" bIns="0" rtlCol="0" anchor="t"/>
+          <a:lstStyle/>
+          <a:p>
+            <a:pPr indent="0" marL="0">
+              <a:buNone/>
+            </a:pPr>
+            <a:r>
               <a:rPr lang="en-US" sz="1200" b="1" dirty="0">
                 <a:solidFill>
                   <a:schemeClr val="tx1"/>
@@ -13023,7 +13836,7 @@
                   <a:schemeClr val="tx1"/>
                 </a:solidFill>
               </a:rPr>
-              <a:t>Predicting fingers is worse than not predicting them. Test-time zoom, no retraining: 17.2° vs 17.3°, while body error nearly doubles on these crops. A loss that cut the hands' share of the rotation loss from about 70% to 33%: 17.5° vs 17.4° for its control. Not tested: a model trained on larger hands.</a:t>
+              <a:t>Predicting fingers is worse than not predicting them. Test-time zoom, no retraining: 17.2° vs 17.3°, while body error nearly doubles on these crops. A loss that cut the hands' share of the rotation loss from about 70% (with the ×4 hand boost; 40% without) to 33%: 17.5° vs 17.4° for its control. Not tested: a model trained on larger hands.</a:t>
             </a:r>
             <a:endParaRPr lang="en-US" sz="1200" dirty="0"/>
           </a:p>
@@ -13139,7 +13952,7 @@
       </p:sp>
       <p:sp>
         <p:nvSpPr>
-          <p:cNvPr id="3" name="stat children among supervised training people, with the balanced sampler"/>
+          <p:cNvPr id="3" name="stat children in supervised training with the balanced sampler: no effect"/>
           <p:cNvSpPr txBox="1"/>
           <p:nvPr/>
         </p:nvSpPr>
@@ -13164,7 +13977,7 @@
             <a:r>
               <a:rPr lang="en-US" sz="4000" b="1" dirty="0">
                 <a:solidFill>
-                  <a:schemeClr val="accent1"/>
+                  <a:schemeClr val="accent5"/>
                 </a:solidFill>
               </a:rPr>
               <a:t>2% → 10%</a:t>
@@ -13175,7 +13988,7 @@
       </p:sp>
       <p:sp>
         <p:nvSpPr>
-          <p:cNvPr id="4" name="label children among supervised training people, with the balanced sampler"/>
+          <p:cNvPr id="4" name="label children in supervised training with the balanced sampler: no effect"/>
           <p:cNvSpPr txBox="1"/>
           <p:nvPr/>
         </p:nvSpPr>
@@ -13203,7 +14016,7 @@
                   <a:schemeClr val="tx2"/>
                 </a:solidFill>
               </a:rPr>
-              <a:t>children among supervised training people, with the balanced sampler</a:t>
+              <a:t>children in supervised training with the balanced sampler: no effect</a:t>
             </a:r>
             <a:endParaRPr lang="en-US" sz="1300" dirty="0"/>
           </a:p>
@@ -13211,7 +14024,7 @@
       </p:sp>
       <p:sp>
         <p:nvSpPr>
-          <p:cNvPr id="5" name="stat predicted age of training babies (about 4 y); true 0.015 (about 1.5 y)"/>
+          <p:cNvPr id="5" name="stat predicted age of training babies; true 0.015 (child-like, but too old)"/>
           <p:cNvSpPr txBox="1"/>
           <p:nvPr/>
         </p:nvSpPr>
@@ -13247,7 +14060,7 @@
       </p:sp>
       <p:sp>
         <p:nvSpPr>
-          <p:cNvPr id="6" name="label predicted age of training babies (about 4 y); true 0.015 (about 1.5 y)"/>
+          <p:cNvPr id="6" name="label predicted age of training babies; true 0.015 (child-like, but too old)"/>
           <p:cNvSpPr txBox="1"/>
           <p:nvPr/>
         </p:nvSpPr>
@@ -13275,7 +14088,7 @@
                   <a:schemeClr val="tx2"/>
                 </a:solidFill>
               </a:rPr>
-              <a:t>predicted age of training babies (about 4 y); true 0.015 (about 1.5 y)</a:t>
+              <a:t>predicted age of training babies; true 0.015 (child-like, but too old)</a:t>
             </a:r>
             <a:endParaRPr lang="en-US" sz="1300" dirty="0"/>
           </a:p>
@@ -13283,7 +14096,7 @@
       </p:sp>
       <p:sp>
         <p:nvSpPr>
-          <p:cNvPr id="7" name="stat predicted age of 5 small people in real photos (21–25 y): adult"/>
+          <p:cNvPr id="7" name="stat predicted age of 5 small people in real photos, both arms: adult range"/>
           <p:cNvSpPr txBox="1"/>
           <p:nvPr/>
         </p:nvSpPr>
@@ -13319,7 +14132,7 @@
       </p:sp>
       <p:sp>
         <p:nvSpPr>
-          <p:cNvPr id="8" name="label predicted age of 5 small people in real photos (21–25 y): adult"/>
+          <p:cNvPr id="8" name="label predicted age of 5 small people in real photos, both arms: adult range"/>
           <p:cNvSpPr txBox="1"/>
           <p:nvPr/>
         </p:nvSpPr>
@@ -13347,7 +14160,7 @@
                   <a:schemeClr val="tx2"/>
                 </a:solidFill>
               </a:rPr>
-              <a:t>predicted age of 5 small people in real photos (21–25 y): adult</a:t>
+              <a:t>predicted age of 5 small people in real photos, both arms: adult range</a:t>
             </a:r>
             <a:endParaRPr lang="en-US" sz="1300" dirty="0"/>
           </a:p>
@@ -13361,12 +14174,12 @@
         </p:nvSpPr>
         <p:spPr>
           <a:xfrm>
-            <a:off x="457200" y="3017520"/>
-            <a:ext cx="8229600" cy="1600200"/>
+            <a:off x="457200" y="2880360"/>
+            <a:ext cx="8229600" cy="1783080"/>
           </a:xfrm>
           <a:prstGeom prst="roundRect">
             <a:avLst>
-              <a:gd name="adj" fmla="val 4571"/>
+              <a:gd name="adj" fmla="val 4103"/>
             </a:avLst>
           </a:prstGeom>
           <a:solidFill>
@@ -13388,8 +14201,8 @@
         </p:nvSpPr>
         <p:spPr>
           <a:xfrm>
-            <a:off x="640080" y="3108960"/>
-            <a:ext cx="7863840" cy="1417320"/>
+            <a:off x="640080" y="2926080"/>
+            <a:ext cx="7863840" cy="1691640"/>
           </a:xfrm>
           <a:prstGeom prst="rect">
             <a:avLst/>
@@ -13422,7 +14235,7 @@
                   <a:schemeClr val="tx1"/>
                 </a:solidFill>
               </a:rPr>
-              <a:t>all eleven shape outputs are trained, none is clamped to an adult. Training babies come out child-like, but too old.</a:t>
+              <a:t>all eleven shape outputs are trained, none is clamped to an adult; training babies come out child-like, but too old. With the true shape, the 10 training children's error falls 47.8 → 41.6 mm.</a:t>
             </a:r>
             <a:endParaRPr lang="en-US" sz="1200" dirty="0"/>
           </a:p>
@@ -13474,7 +14287,7 @@
                   <a:schemeClr val="tx1"/>
                 </a:solidFill>
               </a:rPr>
-              <a:t>a gap between synthetic and real images. No fix this week; a limitation for the thesis.</a:t>
+              <a:t>a synthetic-to-real gap, plus an old-age bias even on training children. One 2-epoch test is not enough to call it a limitation.</a:t>
             </a:r>
             <a:endParaRPr lang="en-US" sz="1200" dirty="0"/>
           </a:p>
@@ -13500,7 +14313,7 @@
                   <a:schemeClr val="tx1"/>
                 </a:solidFill>
               </a:rPr>
-              <a:t>every synthetic child number is in-sample; the holdout has no children. Age scale (Anny default): 0 = 1 y, 0.33 = 11 y, 0.67 = 25 y.</a:t>
+              <a:t>every synthetic child number is in-sample; the holdout has no children. Years, if Anny's default age scale holds (not yet checked): 0 = 1 y, 0.33 = 11 y, 0.67 = 25 y.</a:t>
             </a:r>
             <a:endParaRPr lang="en-US" sz="1200" dirty="0"/>
           </a:p>
@@ -14054,7 +14867,7 @@
         </p:nvSpPr>
         <p:spPr>
           <a:xfrm>
-            <a:off x="6035040" y="1280160"/>
+            <a:off x="5943600" y="1280160"/>
             <a:ext cx="2743200" cy="731520"/>
           </a:xfrm>
           <a:prstGeom prst="rect">
@@ -14071,14 +14884,14 @@
               <a:buNone/>
             </a:pPr>
             <a:r>
-              <a:rPr lang="en-US" sz="2600" b="1" dirty="0">
+              <a:rPr lang="en-US" sz="2400" b="1" dirty="0">
                 <a:solidFill>
                   <a:schemeClr val="accent4"/>
                 </a:solidFill>
               </a:rPr>
               <a:t>0.33 × true + 2.36 m</a:t>
             </a:r>
-            <a:endParaRPr lang="en-US" sz="2600" dirty="0"/>
+            <a:endParaRPr lang="en-US" sz="2400" dirty="0"/>
           </a:p>
         </p:txBody>
       </p:sp>
@@ -14090,7 +14903,7 @@
         </p:nvSpPr>
         <p:spPr>
           <a:xfrm>
-            <a:off x="6035040" y="2011680"/>
+            <a:off x="5943600" y="2011680"/>
             <a:ext cx="2743200" cy="548640"/>
           </a:xfrm>
           <a:prstGeom prst="rect">
@@ -14126,8 +14939,8 @@
         </p:nvSpPr>
         <p:spPr>
           <a:xfrm>
-            <a:off x="6035040" y="2697480"/>
-            <a:ext cx="2743200" cy="1920240"/>
+            <a:off x="5943600" y="2697480"/>
+            <a:ext cx="2743200" cy="1965960"/>
           </a:xfrm>
           <a:prstGeom prst="rect">
             <a:avLst/>
@@ -14139,8 +14952,12 @@
           <a:bodyPr wrap="square" lIns="0" tIns="0" rIns="0" bIns="0" rtlCol="0" anchor="t"/>
           <a:lstStyle/>
           <a:p>
-            <a:pPr indent="0" marL="0">
-              <a:buNone/>
+            <a:pPr marL="177800" indent="-177800">
+              <a:spcAft>
+                <a:spcPts val="400"/>
+              </a:spcAft>
+              <a:buSzPct val="100000"/>
+              <a:buChar char="•"/>
             </a:pPr>
             <a:r>
               <a:rPr lang="en-US" sz="1200" b="1" dirty="0">
@@ -14148,7 +14965,7 @@
                   <a:schemeClr val="tx1"/>
                 </a:solidFill>
               </a:rPr>
-              <a:t>Effect. </a:t>
+              <a:t>Confirmed: </a:t>
             </a:r>
             <a:r>
               <a:rPr lang="en-US" sz="1200" dirty="0">
@@ -14156,7 +14973,59 @@
                   <a:schemeClr val="tx1"/>
                 </a:solidFill>
               </a:rPr>
-              <a:t>Confirmed: with consistent targets the bodies grow back. Likely mechanism: the 2D losses reconcile the two anchors by shrinking the body, i.e. pushing it away. Bodies come out about two thirds of true size (0.63), head 64 px off. Pelvis-centred PVE cannot see this; the real-photo demos hid it too (box placement). v9 and v10 have the same bug.</a:t>
+              <a:t>targets at the head make the bodies much closer to the right size; a same-schedule control does not improve (10 epochs: size 0.59, root error 1.44 m).</a:t>
+            </a:r>
+            <a:endParaRPr lang="en-US" sz="1200" dirty="0"/>
+          </a:p>
+          <a:p>
+            <a:pPr marL="177800" indent="-177800">
+              <a:spcAft>
+                <a:spcPts val="400"/>
+              </a:spcAft>
+              <a:buSzPct val="100000"/>
+              <a:buChar char="•"/>
+            </a:pPr>
+            <a:r>
+              <a:rPr lang="en-US" sz="1200" b="1" dirty="0">
+                <a:solidFill>
+                  <a:schemeClr val="tx1"/>
+                </a:solidFill>
+              </a:rPr>
+              <a:t>Size: </a:t>
+            </a:r>
+            <a:r>
+              <a:rPr lang="en-US" sz="1200" dirty="0">
+                <a:solidFill>
+                  <a:schemeClr val="tx1"/>
+                </a:solidFill>
+              </a:rPr>
+              <a:t>3D height right, but drawn at 0.63 of true size; head 64 px off.</a:t>
+            </a:r>
+            <a:endParaRPr lang="en-US" sz="1200" dirty="0"/>
+          </a:p>
+          <a:p>
+            <a:pPr marL="177800" indent="-177800">
+              <a:spcAft>
+                <a:spcPts val="400"/>
+              </a:spcAft>
+              <a:buSzPct val="100000"/>
+              <a:buChar char="•"/>
+            </a:pPr>
+            <a:r>
+              <a:rPr lang="en-US" sz="1200" b="1" dirty="0">
+                <a:solidFill>
+                  <a:schemeClr val="tx1"/>
+                </a:solidFill>
+              </a:rPr>
+              <a:t>Hidden </a:t>
+            </a:r>
+            <a:r>
+              <a:rPr lang="en-US" sz="1200" dirty="0">
+                <a:solidFill>
+                  <a:schemeClr val="tx1"/>
+                </a:solidFill>
+              </a:rPr>
+              <a:t>from pelvis-centred PVE and from the box-placed demos. v9 and v10 have it too.</a:t>
             </a:r>
             <a:endParaRPr lang="en-US" sz="1200" dirty="0"/>
           </a:p>
@@ -14264,7 +15133,7 @@
                   <a:schemeClr val="tx1"/>
                 </a:solidFill>
               </a:rPr>
-              <a:t>Depth fix: bodies much closer to their real size</a:t>
+              <a:t>Depth fix: bodies drawn much closer to true size</a:t>
             </a:r>
             <a:endParaRPr lang="en-US" sz="2700" dirty="0"/>
           </a:p>
@@ -14286,8 +15155,8 @@
         </p:blipFill>
         <p:spPr>
           <a:xfrm>
-            <a:off x="640080" y="1051560"/>
-            <a:ext cx="7863840" cy="2864356"/>
+            <a:off x="914400" y="1097280"/>
+            <a:ext cx="7315200" cy="2664517"/>
           </a:xfrm>
           <a:prstGeom prst="rect">
             <a:avLst/>
@@ -14302,8 +15171,8 @@
         </p:nvSpPr>
         <p:spPr>
           <a:xfrm>
-            <a:off x="640080" y="3970780"/>
-            <a:ext cx="2595002" cy="365760"/>
+            <a:off x="914400" y="3816661"/>
+            <a:ext cx="2413955" cy="365760"/>
           </a:xfrm>
           <a:prstGeom prst="rect">
             <a:avLst/>
@@ -14324,7 +15193,7 @@
                   <a:schemeClr val="tx2"/>
                 </a:solidFill>
               </a:rPr>
-              <a:t>Synthetic holdout image 579862. All 12 images checked show the same change.</a:t>
+              <a:t>Synthetic holdout image 579862, model's own depth (no box placement).</a:t>
             </a:r>
             <a:endParaRPr lang="en-US" sz="1100" dirty="0"/>
           </a:p>
@@ -14338,8 +15207,8 @@
         </p:nvSpPr>
         <p:spPr>
           <a:xfrm>
-            <a:off x="3274499" y="3970780"/>
-            <a:ext cx="2595002" cy="365760"/>
+            <a:off x="3365023" y="3816661"/>
+            <a:ext cx="2413955" cy="365760"/>
           </a:xfrm>
           <a:prstGeom prst="rect">
             <a:avLst/>
@@ -14360,10 +15229,32 @@
                   <a:schemeClr val="tx1"/>
                 </a:solidFill>
               </a:rPr>
-              <a:t>v5, whole holdout:</a:t>
+              <a:t>v5, whole holdout: root error 1.21 m, median drawn size 0.63</a:t>
             </a:r>
             <a:endParaRPr lang="en-US" sz="1100" dirty="0"/>
           </a:p>
+        </p:txBody>
+      </p:sp>
+      <p:sp>
+        <p:nvSpPr>
+          <p:cNvPr id="6" name="caption 2"/>
+          <p:cNvSpPr txBox="1"/>
+          <p:nvPr/>
+        </p:nvSpPr>
+        <p:spPr>
+          <a:xfrm>
+            <a:off x="5815645" y="3816661"/>
+            <a:ext cx="2413955" cy="365760"/>
+          </a:xfrm>
+          <a:prstGeom prst="rect">
+            <a:avLst/>
+          </a:prstGeom>
+          <a:noFill/>
+          <a:ln/>
+        </p:spPr>
+        <p:txBody>
+          <a:bodyPr wrap="square" lIns="0" tIns="0" rIns="0" bIns="0" rtlCol="0" anchor="t"/>
+          <a:lstStyle/>
           <a:p>
             <a:pPr indent="0" marL="0">
               <a:buNone/>
@@ -14374,7 +15265,7 @@
                   <a:schemeClr val="tx1"/>
                 </a:solidFill>
               </a:rPr>
-              <a:t>depth error 1.08 m; median size 0.63</a:t>
+              <a:t>Fix + depth ×5, 10 epochs, whole holdout: root error 0.54 m, median drawn size 0.84</a:t>
             </a:r>
             <a:endParaRPr lang="en-US" sz="1100" dirty="0"/>
           </a:p>
@@ -14382,14 +15273,14 @@
       </p:sp>
       <p:sp>
         <p:nvSpPr>
-          <p:cNvPr id="6" name="caption 2"/>
+          <p:cNvPr id="7" name="figure footnote"/>
           <p:cNvSpPr txBox="1"/>
           <p:nvPr/>
         </p:nvSpPr>
         <p:spPr>
           <a:xfrm>
-            <a:off x="5908918" y="3970780"/>
-            <a:ext cx="2595002" cy="365760"/>
+            <a:off x="640080" y="4218997"/>
+            <a:ext cx="7863840" cy="512064"/>
           </a:xfrm>
           <a:prstGeom prst="rect">
             <a:avLst/>
@@ -14405,70 +15296,20 @@
               <a:buNone/>
             </a:pPr>
             <a:r>
+              <a:rPr lang="en-US" sz="1100" b="1" dirty="0">
+                <a:solidFill>
+                  <a:srgbClr val="1B2233"/>
+                </a:solidFill>
+              </a:rPr>
+              <a:t>Not fully fixed: </a:t>
+            </a:r>
+            <a:r>
               <a:rPr lang="en-US" sz="1100" dirty="0">
                 <a:solidFill>
-                  <a:schemeClr val="tx1"/>
-                </a:solidFill>
-              </a:rPr>
-              <a:t>Fix + depth ×5, 10 epochs, whole holdout:</a:t>
-            </a:r>
-            <a:endParaRPr lang="en-US" sz="1100" dirty="0"/>
-          </a:p>
-          <a:p>
-            <a:pPr indent="0" marL="0">
-              <a:buNone/>
-            </a:pPr>
-            <a:r>
-              <a:rPr lang="en-US" sz="1100" dirty="0">
-                <a:solidFill>
-                  <a:schemeClr val="tx1"/>
-                </a:solidFill>
-              </a:rPr>
-              <a:t>depth error 0.39 m; median size 0.84</a:t>
-            </a:r>
-            <a:endParaRPr lang="en-US" sz="1100" dirty="0"/>
-          </a:p>
-        </p:txBody>
-      </p:sp>
-      <p:sp>
-        <p:nvSpPr>
-          <p:cNvPr id="7" name="figure footnote"/>
-          <p:cNvSpPr txBox="1"/>
-          <p:nvPr/>
-        </p:nvSpPr>
-        <p:spPr>
-          <a:xfrm>
-            <a:off x="640080" y="4373116"/>
-            <a:ext cx="7863840" cy="384048"/>
-          </a:xfrm>
-          <a:prstGeom prst="rect">
-            <a:avLst/>
-          </a:prstGeom>
-          <a:noFill/>
-          <a:ln/>
-        </p:spPr>
-        <p:txBody>
-          <a:bodyPr wrap="square" lIns="0" tIns="0" rIns="0" bIns="0" rtlCol="0" anchor="t"/>
-          <a:lstStyle/>
-          <a:p>
-            <a:pPr indent="0" marL="0">
-              <a:buNone/>
-            </a:pPr>
-            <a:r>
-              <a:rPr lang="en-US" sz="1100" b="1" dirty="0">
-                <a:solidFill>
-                  <a:srgbClr val="1B2233"/>
-                </a:solidFill>
-              </a:rPr>
-              <a:t>Not fully fixed: </a:t>
-            </a:r>
-            <a:r>
-              <a:rPr lang="en-US" sz="1100" dirty="0">
-                <a:solidFill>
                   <a:schemeClr val="tx2"/>
                 </a:solidFill>
               </a:rPr>
-              <a:t>depth slope still about 0.4; bodies still about 16% too small (holdout median). Chosen because it has no near-camera people; here the fixed blue mesh is 0.95 of true height. Colours follow detection order.</a:t>
+              <a:t>near and far people still get similar depths (depth slope 0.38; 1 = perfect, 0 = same depth for everyone), and bodies are still drawn about 16% too small (median). All 12 rendered images show the same change; this one has no missed ground-truth person. Blue mesh: 0.95 of true height. Colours follow detection order.</a:t>
             </a:r>
             <a:endParaRPr lang="en-US" sz="1100" dirty="0"/>
           </a:p>

</xml_diff>

<commit_message>
docs: final checked deck (15 slides) and speaker notes for 16 October
Co-Authored-By: Claude Opus 5.5 <noreply@anthropic.com>
Claude-Session: https://claude.ai/code/session_016LhpG4kT7Z7ppxbG4TW5S9
</commit_message>
<xml_diff>
--- a/docs/supervisor_update_2026-10-16.pptx
+++ b/docs/supervisor_update_2026-10-16.pptx
@@ -121,7 +121,7 @@
   <p:extLst>
     <p:ext uri="{521415D9-36F7-43E2-AB2F-B90AF26B5E84}">
       <p14:sectionLst xmlns:p14="http://schemas.microsoft.com/office/powerpoint/2010/main">
-        <p14:section name="Overview" id="{011ac6ad-d168-f72e-c8a6-5e09215fe341}">
+        <p14:section name="Overview" id="{3ab0dc66-0b24-cecf-0d4b-93bfcca7f0df}">
           <p14:sldIdLst>
             <p14:sldId id="256"/>
             <p14:sldId id="257"/>
@@ -129,21 +129,21 @@
             <p14:sldId id="259"/>
           </p14:sldIdLst>
         </p14:section>
-        <p14:section name="Findings" id="{eb439692-77bf-eb95-4cc7-5922b8ea262a}">
+        <p14:section name="Findings" id="{660c8e71-c403-227a-974d-2a1e8b5e2d74}">
           <p14:sldIdLst>
             <p14:sldId id="260"/>
             <p14:sldId id="261"/>
             <p14:sldId id="262"/>
           </p14:sldIdLst>
         </p14:section>
-        <p14:section name="Bug" id="{209c6b04-c928-b23d-978c-68147d55c63a}">
+        <p14:section name="Bug" id="{32727f8e-168b-97f3-5b65-36207d9c24d1}">
           <p14:sldIdLst>
             <p14:sldId id="263"/>
             <p14:sldId id="264"/>
             <p14:sldId id="265"/>
           </p14:sldIdLst>
         </p14:section>
-        <p14:section name="Next" id="{e4ab9d55-57b6-c468-18bf-d518cc113d96}">
+        <p14:section name="Next" id="{b2a67c55-b1f0-34d0-e5c2-d72678612956}">
           <p14:sldIdLst>
             <p14:sldId id="266"/>
             <p14:sldId id="267"/>
@@ -151,7 +151,7 @@
             <p14:sldId id="269"/>
           </p14:sldIdLst>
         </p14:section>
-        <p14:section name="Appendix" id="{5d03344e-044c-2ec1-6ab2-59303d802763}">
+        <p14:section name="Appendix" id="{17b6a086-e46e-6586-a837-9a9cb816292c}">
           <p14:sldIdLst>
             <p14:sldId id="270"/>
           </p14:sldIdLst>
@@ -648,7 +648,7 @@
           <a:p>
             <a:r>
               <a:rPr lang="en-US" dirty="0"/>
-              <a:t>The fix is one switch, gt_center_joint person_center: build the training targets at the head, the joint the model anchors. Each fix run has a control with the same schedule and the switch off; the stronger-loss runs have no control at the same weight. I report the 3D root error. The mean signed depth offset fell from 1.08 to 0.39 metres, but after the fix near people are too far and far people too near, and these cancel in that mean, so it flatters the fix. The head now lands within about 8 pixels, as expected, because the target moved to the head. With the depth loss five times stronger for 10 epochs, the root error falls from 1.21 to 0.54 metres and bodies are drawn at 84 percent of their true size; twenty times for 2 epochs ties with it, and the controls stay at 1.11 to 1.44. But the slope stays near 0.4: predictions are pulled toward about 2.5 metres, and why the model cannot separate near from far, I do not know. Every fix run is worse than its control in PVE and recall, and the pelvis 2D error got worse too. Each difference is inside pilot noise, but all point the same way, so I count it as a likely cost. The twenty-times 10-epoch run has no result yet.</a:t>
+              <a:t>The fix is one switch, gt_center_joint person_center: build the training targets at the head, the joint the model anchors. Each fix run has a control with the same schedule and the switch off; the stronger-loss runs have no control at the same weight. I report the 3D root error: the distance between the predicted and the true root joint, at the pelvis. Drawn size is the predicted over the true head-to-pelvis distance in pixels. The mean signed depth offset fell from 1.08 to 0.39 metres, but after the fix near people are too far and far people too near, and these cancel in that mean, so it flatters the fix. The head now lands within about 7 to 10 pixels, as expected, because the target moved to the head. With the depth loss five times stronger for 10 epochs, the root error falls from 1.21 to 0.54 metres and bodies are drawn at 84 percent of their true size; twenty times for 2 epochs ties with it, and the controls stay at 1.11 to 1.44. But the slope is 0.30 with the switch alone and 0.38 to 0.44 with the stronger depth loss. Predictions are pulled toward about 2.5 to 2.9 metres, close to the estimated training average; holdout people are nearer, 1.9 metres on average, so this pull becomes a large error here. Why the model cannot separate near from far, I do not know. Longer training is not clearly better: with five times, going from 2 to 10 epochs lowered the root error from 0.66 to 0.54 metres but did not improve the slope; with the switch alone neither improved, the root error went from 0.69 to 0.73 metres, and the control also got worse, from 1.11 to 1.44 metres. Root error has no measured noise floor, so I do not read a trend into this. Every fix run is worse than its control in PVE and recall. The PVE gaps, 2.6 to 4.9 millimetres, are inside pilot noise; the recall drops, 1.6 to 2.4 points, are at the edge of what one pilot can detect; and the five fix runs share only two controls, so they are not five independent tests. I count it as a likely cost. The pelvis 2D error clearly got worse, from about 23 pixels to between 31 and 39 pixels; probably because the body is still drawn too small while the head is now pinned, but I have not checked that. The twenty-times 10-epoch run has no result yet.</a:t>
             </a:r>
             <a:endParaRPr lang="en-US" dirty="0"/>
           </a:p>
@@ -736,7 +736,7 @@
           <a:p>
             <a:r>
               <a:rPr lang="en-US" dirty="0"/>
-              <a:t>All four experiments are done. Each ran next to a control with the main switch off, on the same 100-image holdout and manifest, with helper bones masked. The stronger age loss and the stronger depth loss were not separately controlled: both children arms used the same age and height weights, and the depth runs at five and twenty times have no control at the same weight. Depth: by its own success rule the experiment failed. The slope did not move toward 1: it is 0.30 with the switch alone and 0.38 with the five-times depth loss. PVE is 74.8, against 72.2 for the control and 70.5 for v5. What clearly improved is outside the rule: the root error went from 1.21 to 0.54 metres and the drawn size from 0.63 to 0.84. I say that openly instead of changing the rule afterwards. Children, neck and fingers: no measurable effect. The neck loss gave 11.3 degrees of head error, which passes the rule of below 12, but the two controls gave 11.7 and 13.6, so that is inside the noise, and its PVE and recall guard failed. There is no fixed random seed: two identical runs differed by 7.6 millimetres PVE and 1.9 degrees of head error, so one pilot only detects about 10 millimetres, 3 degrees or 2 recall points. Restarting the fine-tune alone costs about 2.4 millimetres. A 2-epoch pilot trains in about 12 minutes, a 10-epoch run in about one hour. No new architecture, because the diagnostics do not justify one.</a:t>
+              <a:t>All four experiments are done. Each ran next to a control with the main switch off, on the same 100-image holdout and manifest, with helper bones masked. The stronger age loss and the stronger depth loss were not separately controlled: both children arms used the same age and height weights, and the depth runs at five and twenty times have no control at the same weight. Depth: by its own success rule the experiment failed. The slope did not move toward 1: it is 0.30 with the switch alone and 0.38 with the five-times depth loss. PVE is 74.8, against 72.2 for the control and 70.5 for v5. What clearly improved is outside the rule: the root error went from 1.21 to 0.54 metres and the drawn size from 0.63 to 0.84. I say that openly instead of changing the rule afterwards. Children, neck and fingers: no measurable effect. The neck loss gave 11.3 degrees of head error, which passes the rule of below 12, but the two controls gave 11.7 and 13.6, so that is inside the noise. The experiments also have a safety limit: PVE at most 71.5 millimetres and recall at least 89.2 percent. The neck run just missed it, with 71.8 millimetres and 89.0 percent, but all five control runs miss it too, mostly because of the restart cost; its PVE is even 4.5 millimetres better than its own control, which is also inside the noise. Its neck bones stayed at 62.5 degrees. For the fingers, the rest-pose floor is 15.2 degrees in this evaluation and 15.1 on slide 6; the difference is only which people are matched. There is no fixed random seed: two identical runs differed by 7.6 millimetres PVE and 1.9 degrees of head error, so one pilot only detects about 10 millimetres, 3 degrees or 2 recall points. Restarting the fine-tune alone costs about 2.4 millimetres. A 2-epoch pilot trains in about 12 minutes, a 10-epoch run in about one hour. No new architecture, because the diagnostics do not justify one.</a:t>
             </a:r>
             <a:endParaRPr lang="en-US" dirty="0"/>
           </a:p>
@@ -824,7 +824,7 @@
           <a:p>
             <a:r>
               <a:rPr lang="en-US" dirty="0"/>
-              <a:t>Some corrections are already in. The headline AnnyOne number is 70.5 millimetres, measured with the helper bones masked, as in the demos. That is the evaluation setting V1, not the demo's own number: the demo setting gives 68.5 at a lower recall. The 74.3 in the thesis draft came from the unmasked evaluation. The demos now say that the fingers are the rest pose. The text no longer blames the rig. The Known-defects section in the README documents the depth bug. But the README, the findings and the handover documents still carry last week's neck story, that the long neck comes from weak supervision and from the depth bug, and some old depth wording, for example that the overlays look wrong and that no improvement is claimed yet. I will correct them this week. The repository is reorganised with everything scripted, so any of these numbers can be produced again.</a:t>
+              <a:t>Some corrections are already in. The headline AnnyOne number is 70.5 millimetres, measured with the helper bones masked, as in the demos. That is the evaluation setting V1, not the demo's own number: the demo setting gives 68.5 at a lower recall. The 74 millimetres in the thesis draft came from the unmasked evaluation; on the same people that adds 3.8 millimetres. The README already uses 70.5; the thesis draft I still have to change. The demos now say that the fingers are the rest pose. The text no longer blames the rig. The Known-defects section in the README documents the depth bug. But the README, the findings and the handover documents still carry last week's neck story, that the long neck comes from weak supervision and from the depth bug, and some old depth wording, for example that the overlays look wrong and that no improvement is claimed yet. I will correct them next week. The repository is reorganised with everything scripted, so any of these numbers can be produced again.</a:t>
             </a:r>
             <a:endParaRPr lang="en-US" dirty="0"/>
           </a:p>
@@ -912,7 +912,7 @@
           <a:p>
             <a:r>
               <a:rPr lang="en-US" dirty="0"/>
-              <a:t>Six things are still open. First, the neck: the error of each neck bone, split into twist and swing, an error on the neck skin only, and traces of checkpoint 299 and of v3, to see when the offset appeared. Second, the depth slope: why near and far are not separated is unknown. The training depths so far come from small samples, batch means of about 2.5 to 3.2 metres, so I will measure them properly, and measure the fix run's slope on training images; for v5 it was just as low there. Third, the cost of the fix: paired PVE on the same people, recall over people whose head is visible, the fix on 3DPW, and the root error next to PVE in the thesis. The twenty-times 10-epoch run has no result yet. Fourth, pilot noise: fix the seed or repeat the key run. Fifth, people very close to the camera: both models miss them in 4 of the 12 rendered images; likely a detection problem, not yet counted. Sixth, children and fingers: one 2-epoch test is not enough to close them. Next is a 10-epoch balanced-sampler run, and for the fingers training on larger hand crops. If those show nothing too, both go into the thesis as limitations.</a:t>
+              <a:t>Six things are still open. First, the neck: the error of each neck bone, split into twist and swing, an error on the neck skin only, and traces of checkpoint 299 and of v3, to see when the offset appeared. Second, the depth slope, stuck at 0.3 to 0.4: why near and far are not separated is unknown. The training depths so far come from small samples, batch means of about 2.5 to 3.2 metres, so I will measure them properly, and measure the fix run's slope on training images; for v5 it was just as low there. Third, the cost of the fix: paired PVE on the same people, recall over people whose head is visible, the fix on 3DPW, and the root error next to PVE in the thesis. The twenty-times 10-epoch run has no result yet. Fourth, pilot noise: fix the seed or repeat the key run. Fifth, people very close to the camera: both models miss them in 4 of the 12 rendered images; likely a detection problem, not yet counted. Sixth, children and fingers: one 2-epoch test is not enough to close them. Next is a 10-epoch balanced-sampler run, and for the fingers training on larger hand crops. If those show nothing too, both go into the thesis as limitations.</a:t>
             </a:r>
             <a:endParaRPr lang="en-US" dirty="0"/>
           </a:p>
@@ -1000,7 +1000,7 @@
           <a:p>
             <a:r>
               <a:rPr lang="en-US" dirty="0"/>
-              <a:t>What is measured: the failures are not rig or decoding problems. A training-target bug puts people too far away in v5, v9 and v10; in v5 it is all 222 holdout people. The fix draws the bodies much closer to their true size, but near and far are still not separated well, and it likely costs 3 to 5 millimetres PVE and about 2 points of recall: each run alone is inside the noise, but all point the same way. I do not claim any improvement in the neck, the fingers or the children. My question: should I fine-tune v9, our best model on 3DPW, with the corrected targets and the depth loss five times stronger, before the thesis numbers are final? That is about one hour of training. From v5 I expect a drawn size of about 0.84 and a root error of about half a metre. Five, not twenty, because the twenty-times 10-epoch run has no result yet. A v9 fine-tune keeps the stuck neck; v10 learns the neck but has worse shoulders and arms. Either fine-tune should also mask the 3DPW finger labels, which are set to the rest pose, with mask_3dpw_hands. The ViT-S students use the same training code and are probably affected too; not measured. On the AnnyOne holdout v9 is not the best: 77.0 against 70.5.</a:t>
+              <a:t>What is measured: the failures are not rig or decoding problems. A training-target bug puts people too far away in v5, v9 and v10; in v5 it is all 222 holdout people. The fix draws the bodies much closer to their true size, but near and far are still not separated well, and it likely has a cost: every fix run is worse than its control, by 2.6 to 4.9 millimetres PVE and 1.6 to 2.4 recall points. The PVE gaps are inside pilot noise, the recall drops are at the edge of what one pilot can detect, and the five runs share two controls, but all point the same way. I do not claim any improvement in the neck, the fingers or the children. My question: should I fine-tune v9, our best model on 3DPW, with the corrected targets and the depth loss five times stronger, before the thesis numbers are final? That is about one hour of training. From v5 I expect a drawn size of about 0.84 and a root error of about half a metre; on v5 that run cost 2.6 millimetres PVE and 1.6 recall points against its control. Five, not twenty, because the twenty-times 10-epoch run has no result yet. A v9 fine-tune keeps the stuck neck; v10 learns the neck but has worse shoulders and arms. Either fine-tune should also mask the 3DPW finger labels, which are set to the rest pose, with mask_3dpw_hands. The ViT-S students use the same training code and are probably affected too; not measured. On the AnnyOne holdout v9 is not the best: 77.0 against 70.5.</a:t>
             </a:r>
             <a:endParaRPr lang="en-US" dirty="0"/>
           </a:p>
@@ -1088,7 +1088,7 @@
           <a:p>
             <a:r>
               <a:rPr lang="en-US" dirty="0"/>
-              <a:t>A second holdout example, in case there is a question. Before the fix the boy's real head sticks out above a shrunken mesh that floats. After the fix the mesh is close to his height, slightly larger; the after mesh is cut off at the bottom of the image, so I cannot measure its full height. Here the fixed mesh is a little larger and wider than the ground truth, so I do not call it an exact fit. The two large people in front have no ground-truth mesh either, so they are not counted as misses.</a:t>
+              <a:t>A second holdout example, in case there is a question. Before the fix the boy's real head sticks out above a shrunken mesh that floats. After the fix the top of the head is level with the truth; the after mesh is cut off at the bottom of the image, so I cannot measure its full height. Here the fixed mesh is a little larger and wider than the ground truth, so I do not call it an exact fit. The two large people in front have no ground-truth mesh, so they are not counted as misses.</a:t>
             </a:r>
             <a:endParaRPr lang="en-US" dirty="0"/>
           </a:p>
@@ -1352,7 +1352,7 @@
           <a:p>
             <a:r>
               <a:rPr lang="en-US" dirty="0"/>
-              <a:t>This slide changes the story. The rig, the decoding and the body model are correct, and gradients reach every bone and every shape output. Only two of the three camera outputs are unused and get no gradient. The overfit test shows the optimiser works for shape and 3D joints: on 40 training images the error falls by 36 percent. It has two warnings. First, even while the images were memorised, the translation loss and the 2D losses went up, from 1.67 to 1.89 and from 58 to 75. The network could not satisfy the position targets and the 2D projection at the same time. That was probably the first sign of the depth bug on slide 8; I have not repeated the overfit test with the fix. Second, the rotation loss barely moved, from 44.6 to 40.8. That is a sum over all 75 bones, so it does not isolate the neck; it may be related to the stuck neck on the next slide, but that is a guess. So the three failures are not rig or decoding problems, which is how the thesis described them until now, but training can still get stuck. One caveat on the ground-truth check: people who fill the frame lose joints at the image border. That is truncation, not a decoding error.</a:t>
+              <a:t>This slide changes the story. The rig, the decoding and the body model are correct, and gradients reach every bone and every shape output. The one exception: two of the three camera outputs are unused and get no gradient. The overfit test shows the optimiser works for shape and 3D joints: on 40 training images the error falls by 36 percent. It has two warnings. First, even while the images were memorised, the translation loss and the 2D losses went up, from 1.67 to 1.89 and from 58 to 75. The network could not satisfy the position targets and the 2D projection at the same time. That was probably the first sign of the depth bug on slide 8; I have not repeated the overfit test with the fix. Second, the rotation loss barely moved, from 44.6 to 40.8. That is a sum over all 75 bones, so it does not isolate the neck; it may be related to the stuck neck on the next slide, but that is a guess. So the three failures are not rig or decoding problems, which is how the thesis described them until now, but training can still get stuck. One caveat on the ground-truth check: people who fill the frame lose joints at the image border. That is truncation, not a decoding error.</a:t>
             </a:r>
             <a:endParaRPr lang="en-US" dirty="0"/>
           </a:p>
@@ -1440,7 +1440,7 @@
           <a:p>
             <a:r>
               <a:rPr lang="en-US" dirty="0"/>
-              <a:t>The neck length is right, 99 percent of the truth, and with the true shape it is exact. The problem is the rotation of each neck bone relative to its parent. In v5, v9 and all six pilot runs, the three neck bones are on average 63 degrees off, head and jaw 90. In v5 that is the same for every person, within about 1.5 degrees: a fixed offset, not noise. 150 thousand more steps in v9 did not change it, and neither did a pilot that gave head and neck a third of the rotation loss. v10 gets these bones right, 5 and 4 degrees, so the loss can teach the neck, but v10 is worse elsewhere. Its history differs: v5 first trained on a frozen backbone with the helper bones unmasked; masking and the neck boost came later. The head points 12 degrees off on the holdout, 8.6 on the held-out test cases and about 20 on the 40 training test cases. I do not know the cause. My guess: the loss compares rotation matrices number by number and can stick near a 180-degree flip; a neck bone and the head flipped about the same axis would cancel, so the head can still point within 12 degrees. The depth bug cannot cause the neck look: the demos place each body from its detection box.</a:t>
+              <a:t>The neck length is right, 99 percent of the truth, and with the true shape it is exact. The problem is the rotation of each neck bone relative to its parent. In v5, v9 and all six pilot runs, the three neck bones are on average 63 degrees off, head and jaw 90. In v5 that is the same for every person, within about 1.5 degrees: a fixed offset, not noise. 150 thousand more steps in v9 did not change it, and neither did a pilot that gave head and neck a third of the rotation loss. v10 gets these bones right, 5 and 4 degrees, so the loss can teach the neck, but v10 is worse elsewhere. Its history differs: v10 was trained with the helper bones masked from the start, with no four-times neck boost and with 3DPW. v5 first trained on a frozen backbone with the helper bones unmasked; masking and the neck boost came later. The head points 12 degrees off on the holdout, 8.6 on the held-out test cases and about 20 on the 40 training test cases. I do not know the cause. My guess: the loss compares rotation matrices number by number and can stick near a 180-degree flip; a neck bone and the head flipped about the same axis would cancel, so the head can still point within 12 degrees. I have not shown that this offset makes the necks look wrong; the head-and-neck error PVE_hn cannot tell, because 91 percent of its vertices are on the head. The depth bug cannot cause the neck look in the montage or the photo demos: they place each body from its detection box.</a:t>
             </a:r>
             <a:endParaRPr lang="en-US" dirty="0"/>
           </a:p>
@@ -1616,7 +1616,7 @@
           <a:p>
             <a:r>
               <a:rPr lang="en-US" dirty="0"/>
-              <a:t>I checked in the code that the shape head is complete: all eleven shape values go into the body model and are trained, with no adult default. The model can make a child: for the youngest training people it predicts age 0.10 for a true 0.015. If Anny's default age scale holds, that is about 4 years instead of about 1.5, so too old but still clearly a child. I have not yet checked that scale against the installed Anny, so the years are approximate. The ten children in the training manifest also come out too old, by 0.078 on average. With their true shape, their error falls from 47.8 to 41.6 millimetres, so 6.2 millimetres of it is shape. Only 2 percent of training people are children, so I tried a sampler that shows about 10 percent. In a 2-epoch fine-tune nothing changed, not for the training children and not on real photos: five small people still get an adult age, 0.57 to 0.67 across the two arms, which would be about 21 to 25 years. That is a short run on few people, so it shows no effect, not that there can be none. My best guess is a gap between synthetic and real images, plus an old-age bias that shows even on training children; neither is tested. There are no labelled real children, and the 3DPW labels fix age at one adult value. The next step is a 10-epoch balanced-sampler run; if that also shows nothing, it goes into the thesis as a limitation. The holdout has no children, so every synthetic child number is in-sample.</a:t>
+              <a:t>I checked in the code that the shape head is complete: all eleven shape values go into the body model and are trained, with no adult default. The model can make a child: for the youngest training people it predicts age 0.10 for a true 0.015, too old but still clearly a child; the holdout adults lie mostly between 0.4 and 0.8. Anny's own age calibration puts 0.10 at about 2 years and 0.67 at about 16, while the labels in our code assume 0.33 is 11 years and 0.67 is 25; I have not settled which one the dataset follows. The ten children in the training manifest also come out too old, by 0.078 on average. With their true shape, their error falls from 47.8 to 41.6 millimetres, so 6.2 millimetres of it is shape. Only 2 percent of training people are children, so I tried a sampler that shows about 10 percent. In a 2-epoch fine-tune nothing changed, not for the training children and not on real photos: five small people still get the age of the holdout adults, 0.57 to 0.67 in the sampler and the control run. So I compare with the holdout adults rather than give years: 0.57 to 0.67 is about 14 to 16 years on Anny's calibration and 21 to 25 on our code's labels; either way far too old for people 0.6 to 1.1 metres tall. That is a short run on few people, so it shows no effect, not that there can be none. My best guess is a gap between synthetic and real images, plus an old-age bias that shows even on training children; neither is tested. There are no labelled real children, and the 3DPW labels fix age at one adult value. The next step is a 10-epoch balanced-sampler run; if that also shows nothing, it goes into the thesis as a limitation. The holdout has no children, so every synthetic child number is in-sample.</a:t>
             </a:r>
             <a:endParaRPr lang="en-US" dirty="0"/>
           </a:p>
@@ -1792,7 +1792,7 @@
           <a:p>
             <a:r>
               <a:rPr lang="en-US" dirty="0"/>
-              <a:t>This is the bug on a synthetic holdout image, using the model's own depth, not the box placement of the real-photo demos. Left is the truth. In the middle, the old model: the bodies are drawn too small, the real man's head sticks out above the mesh, and the mesh floats. On the right, the fix with the depth loss five times stronger, trained for 10 epochs. The blue mesh is now 95 percent of the true height; the woman's mesh is closer to her size but still narrower. I chose this image because no person with a ground-truth mesh is missed, so it is a good case, not a typical one; the arm at the bottom left has no ground-truth mesh either. On the whole holdout the median drawn size is 84 percent of the truth, so bodies are still about 16 percent too small, and near and far people still get similar depths: in the slope, 1 means perfect and 0 means the same depth for everyone. All 12 holdout images we rendered, in all three prediction settings, show the same change. In 4 of them both models miss people very close to the camera; since both miss them, the fix did not cause it. It is likely a detection problem, but not yet counted. Mesh colours follow detection order.</a:t>
+              <a:t>This is the bug on a synthetic holdout image, using the model's own depth, not the box placement of the real-photo demos. Left is the truth. In the middle, the old model: the bodies are drawn too small, the real man's head sticks out above the mesh, and the mesh floats. On the right, the fix with the depth loss five times stronger, trained for 10 epochs. The blue mesh is now 95 percent of the true height; the woman's mesh is closer to her size but still narrower. I chose this image because no person with a ground-truth mesh is missed, so it is a good case, not a typical one; the arm at the bottom left has no ground-truth mesh, so it is not counted as a miss. On the whole holdout the median drawn size is 84 percent of the truth, so bodies are still about 16 percent too small, and near and far people still get similar depths: in the slope, 1 means perfect and 0 means the same depth for everyone. All 12 holdout images we rendered, in all three prediction settings, show the same change. In 4 of them both models miss people very close to the camera; since both miss them, the fix did not cause it. It is likely a detection problem, but not yet counted. Mesh colours follow detection order.</a:t>
             </a:r>
             <a:endParaRPr lang="en-US" dirty="0"/>
           </a:p>
@@ -2813,15 +2813,17 @@
             <a:tbl>
               <a:tblPr/>
               <a:tblGrid>
-                <a:gridCol w="1920240"/>
-                <a:gridCol w="1051560"/>
-                <a:gridCol w="1051560"/>
-                <a:gridCol w="1051560"/>
-                <a:gridCol w="1051560"/>
-                <a:gridCol w="1051560"/>
-                <a:gridCol w="1051560"/>
+                <a:gridCol w="1828800"/>
+                <a:gridCol w="731520"/>
+                <a:gridCol w="809897"/>
+                <a:gridCol w="809897"/>
+                <a:gridCol w="809897"/>
+                <a:gridCol w="809897"/>
+                <a:gridCol w="809897"/>
+                <a:gridCol w="809897"/>
+                <a:gridCol w="809897"/>
               </a:tblGrid>
-              <a:tr h="210312">
+              <a:tr h="228600">
                 <a:tc gridSpan="2">
                   <a:txBody>
                     <a:bodyPr/>
@@ -2833,7 +2835,7 @@
                       <a:endParaRPr lang="en-US" sz="1100" dirty="0"/>
                     </a:p>
                   </a:txBody>
-                  <a:tcPr marL="54864" marR="54864" marT="18288" marB="18288" anchor="ctr">
+                  <a:tcPr marL="45720" marR="45720" marT="18288" marB="18288" anchor="ctr">
                     <a:lnL w="0" cap="flat" cmpd="sng" algn="ctr">
                       <a:noFill/>
                     </a:lnL>
@@ -2875,17 +2877,17 @@
                         <a:buNone/>
                       </a:pPr>
                       <a:r>
-                        <a:rPr lang="en-US" sz="1000" b="1" dirty="0">
+                        <a:rPr lang="en-US" sz="1100" b="1" dirty="0">
                           <a:solidFill>
                             <a:srgbClr val="FFFFFF"/>
                           </a:solidFill>
                         </a:rPr>
                         <a:t>10-epoch fine-tunes</a:t>
                       </a:r>
-                      <a:endParaRPr lang="en-US" sz="1000" dirty="0"/>
+                      <a:endParaRPr lang="en-US" sz="1100" dirty="0"/>
                     </a:p>
                   </a:txBody>
-                  <a:tcPr marL="54864" marR="54864" marT="18288" marB="18288" anchor="ctr">
+                  <a:tcPr marL="45720" marR="45720" marT="18288" marB="18288" anchor="ctr">
                     <a:lnL w="38100" cap="flat" cmpd="sng" algn="ctr">
                       <a:solidFill>
                         <a:srgbClr val="FFFFFF"/>
@@ -2933,7 +2935,7 @@
                 <a:tc hMerge="1">
                   <a:tcPr/>
                 </a:tc>
-                <a:tc gridSpan="2">
+                <a:tc gridSpan="4">
                   <a:txBody>
                     <a:bodyPr/>
                     <a:lstStyle/>
@@ -2942,17 +2944,17 @@
                         <a:buNone/>
                       </a:pPr>
                       <a:r>
-                        <a:rPr lang="en-US" sz="1000" b="1" dirty="0">
+                        <a:rPr lang="en-US" sz="1100" b="1" dirty="0">
                           <a:solidFill>
                             <a:srgbClr val="FFFFFF"/>
                           </a:solidFill>
                         </a:rPr>
                         <a:t>2-epoch fine-tunes</a:t>
                       </a:r>
-                      <a:endParaRPr lang="en-US" sz="1000" dirty="0"/>
+                      <a:endParaRPr lang="en-US" sz="1100" dirty="0"/>
                     </a:p>
                   </a:txBody>
-                  <a:tcPr marL="54864" marR="54864" marT="18288" marB="18288" anchor="ctr">
+                  <a:tcPr marL="45720" marR="45720" marT="18288" marB="18288" anchor="ctr">
                     <a:lnL w="38100" cap="flat" cmpd="sng" algn="ctr">
                       <a:solidFill>
                         <a:srgbClr val="FFFFFF"/>
@@ -2993,6 +2995,12 @@
                       <a:srgbClr val="4A5568"/>
                     </a:solidFill>
                   </a:tcPr>
+                </a:tc>
+                <a:tc hMerge="1">
+                  <a:tcPr/>
+                </a:tc>
+                <a:tc hMerge="1">
+                  <a:tcPr/>
                 </a:tc>
                 <a:tc hMerge="1">
                   <a:tcPr/>
@@ -3018,7 +3026,7 @@
                       <a:endParaRPr lang="en-US" sz="1100" dirty="0"/>
                     </a:p>
                   </a:txBody>
-                  <a:tcPr marL="54864" marR="54864" marT="18288" marB="18288" anchor="ctr">
+                  <a:tcPr marL="45720" marR="45720" marT="18288" marB="18288" anchor="ctr">
                     <a:lnL w="12700" cap="flat" cmpd="sng" algn="ctr">
                       <a:solidFill>
                         <a:srgbClr val="FFFFFF"/>
@@ -3074,12 +3082,12 @@
                             <a:srgbClr val="FFFFFF"/>
                           </a:solidFill>
                         </a:rPr>
-                        <a:t>v5 baseline</a:t>
+                        <a:t>v5</a:t>
                       </a:r>
                       <a:endParaRPr lang="en-US" sz="1100" dirty="0"/>
                     </a:p>
                   </a:txBody>
-                  <a:tcPr marL="54864" marR="54864" marT="18288" marB="18288" anchor="ctr">
+                  <a:tcPr marL="45720" marR="45720" marT="18288" marB="18288" anchor="ctr">
                     <a:lnL w="12700" cap="flat" cmpd="sng" algn="ctr">
                       <a:solidFill>
                         <a:srgbClr val="FFFFFF"/>
@@ -3140,7 +3148,7 @@
                       <a:endParaRPr lang="en-US" sz="1100" dirty="0"/>
                     </a:p>
                   </a:txBody>
-                  <a:tcPr marL="54864" marR="54864" marT="18288" marB="18288" anchor="ctr">
+                  <a:tcPr marL="45720" marR="45720" marT="18288" marB="18288" anchor="ctr">
                     <a:lnL w="38100" cap="flat" cmpd="sng" algn="ctr">
                       <a:solidFill>
                         <a:srgbClr val="FFFFFF"/>
@@ -3201,7 +3209,7 @@
                       <a:endParaRPr lang="en-US" sz="1100" dirty="0"/>
                     </a:p>
                   </a:txBody>
-                  <a:tcPr marL="54864" marR="54864" marT="18288" marB="18288" anchor="ctr">
+                  <a:tcPr marL="45720" marR="45720" marT="18288" marB="18288" anchor="ctr">
                     <a:lnL w="12700" cap="flat" cmpd="sng" algn="ctr">
                       <a:solidFill>
                         <a:srgbClr val="FFFFFF"/>
@@ -3262,7 +3270,7 @@
                       <a:endParaRPr lang="en-US" sz="1100" dirty="0"/>
                     </a:p>
                   </a:txBody>
-                  <a:tcPr marL="54864" marR="54864" marT="18288" marB="18288" anchor="ctr">
+                  <a:tcPr marL="45720" marR="45720" marT="18288" marB="18288" anchor="ctr">
                     <a:lnL w="12700" cap="flat" cmpd="sng" algn="ctr">
                       <a:solidFill>
                         <a:srgbClr val="FFFFFF"/>
@@ -3323,8 +3331,130 @@
                       <a:endParaRPr lang="en-US" sz="1100" dirty="0"/>
                     </a:p>
                   </a:txBody>
-                  <a:tcPr marL="54864" marR="54864" marT="18288" marB="18288" anchor="ctr">
+                  <a:tcPr marL="45720" marR="45720" marT="18288" marB="18288" anchor="ctr">
                     <a:lnL w="38100" cap="flat" cmpd="sng" algn="ctr">
+                      <a:solidFill>
+                        <a:srgbClr val="FFFFFF"/>
+                      </a:solidFill>
+                      <a:prstDash val="solid"/>
+                      <a:round/>
+                      <a:headEnd type="none" w="med" len="med"/>
+                      <a:tailEnd type="none" w="med" len="med"/>
+                    </a:lnL>
+                    <a:lnR w="12700" cap="flat" cmpd="sng" algn="ctr">
+                      <a:solidFill>
+                        <a:srgbClr val="FFFFFF"/>
+                      </a:solidFill>
+                      <a:prstDash val="solid"/>
+                      <a:round/>
+                      <a:headEnd type="none" w="med" len="med"/>
+                      <a:tailEnd type="none" w="med" len="med"/>
+                    </a:lnR>
+                    <a:lnT w="12700" cap="flat" cmpd="sng" algn="ctr">
+                      <a:solidFill>
+                        <a:srgbClr val="FFFFFF"/>
+                      </a:solidFill>
+                      <a:prstDash val="solid"/>
+                      <a:round/>
+                      <a:headEnd type="none" w="med" len="med"/>
+                      <a:tailEnd type="none" w="med" len="med"/>
+                    </a:lnT>
+                    <a:lnB w="12700" cap="flat" cmpd="sng" algn="ctr">
+                      <a:solidFill>
+                        <a:srgbClr val="FFFFFF"/>
+                      </a:solidFill>
+                      <a:prstDash val="solid"/>
+                      <a:round/>
+                      <a:headEnd type="none" w="med" len="med"/>
+                      <a:tailEnd type="none" w="med" len="med"/>
+                    </a:lnB>
+                    <a:solidFill>
+                      <a:srgbClr val="1B2233"/>
+                    </a:solidFill>
+                  </a:tcPr>
+                </a:tc>
+                <a:tc>
+                  <a:txBody>
+                    <a:bodyPr/>
+                    <a:lstStyle/>
+                    <a:p>
+                      <a:pPr algn="ctr" indent="0" marL="0">
+                        <a:buNone/>
+                      </a:pPr>
+                      <a:r>
+                        <a:rPr lang="en-US" sz="1100" b="1" dirty="0">
+                          <a:solidFill>
+                            <a:srgbClr val="FFFFFF"/>
+                          </a:solidFill>
+                        </a:rPr>
+                        <a:t>fix</a:t>
+                      </a:r>
+                      <a:endParaRPr lang="en-US" sz="1100" dirty="0"/>
+                    </a:p>
+                  </a:txBody>
+                  <a:tcPr marL="45720" marR="45720" marT="18288" marB="18288" anchor="ctr">
+                    <a:lnL w="12700" cap="flat" cmpd="sng" algn="ctr">
+                      <a:solidFill>
+                        <a:srgbClr val="FFFFFF"/>
+                      </a:solidFill>
+                      <a:prstDash val="solid"/>
+                      <a:round/>
+                      <a:headEnd type="none" w="med" len="med"/>
+                      <a:tailEnd type="none" w="med" len="med"/>
+                    </a:lnL>
+                    <a:lnR w="12700" cap="flat" cmpd="sng" algn="ctr">
+                      <a:solidFill>
+                        <a:srgbClr val="FFFFFF"/>
+                      </a:solidFill>
+                      <a:prstDash val="solid"/>
+                      <a:round/>
+                      <a:headEnd type="none" w="med" len="med"/>
+                      <a:tailEnd type="none" w="med" len="med"/>
+                    </a:lnR>
+                    <a:lnT w="12700" cap="flat" cmpd="sng" algn="ctr">
+                      <a:solidFill>
+                        <a:srgbClr val="FFFFFF"/>
+                      </a:solidFill>
+                      <a:prstDash val="solid"/>
+                      <a:round/>
+                      <a:headEnd type="none" w="med" len="med"/>
+                      <a:tailEnd type="none" w="med" len="med"/>
+                    </a:lnT>
+                    <a:lnB w="12700" cap="flat" cmpd="sng" algn="ctr">
+                      <a:solidFill>
+                        <a:srgbClr val="FFFFFF"/>
+                      </a:solidFill>
+                      <a:prstDash val="solid"/>
+                      <a:round/>
+                      <a:headEnd type="none" w="med" len="med"/>
+                      <a:tailEnd type="none" w="med" len="med"/>
+                    </a:lnB>
+                    <a:solidFill>
+                      <a:srgbClr val="1B2233"/>
+                    </a:solidFill>
+                  </a:tcPr>
+                </a:tc>
+                <a:tc>
+                  <a:txBody>
+                    <a:bodyPr/>
+                    <a:lstStyle/>
+                    <a:p>
+                      <a:pPr algn="ctr" indent="0" marL="0">
+                        <a:buNone/>
+                      </a:pPr>
+                      <a:r>
+                        <a:rPr lang="en-US" sz="1100" b="1" dirty="0">
+                          <a:solidFill>
+                            <a:srgbClr val="FFFFFF"/>
+                          </a:solidFill>
+                        </a:rPr>
+                        <a:t>fix + ×5</a:t>
+                      </a:r>
+                      <a:endParaRPr lang="en-US" sz="1100" dirty="0"/>
+                    </a:p>
+                  </a:txBody>
+                  <a:tcPr marL="45720" marR="45720" marT="18288" marB="18288" anchor="ctr">
+                    <a:lnL w="12700" cap="flat" cmpd="sng" algn="ctr">
                       <a:solidFill>
                         <a:srgbClr val="FFFFFF"/>
                       </a:solidFill>
@@ -3384,7 +3514,7 @@
                       <a:endParaRPr lang="en-US" sz="1100" dirty="0"/>
                     </a:p>
                   </a:txBody>
-                  <a:tcPr marL="54864" marR="54864" marT="18288" marB="18288" anchor="ctr">
+                  <a:tcPr marL="45720" marR="45720" marT="18288" marB="18288" anchor="ctr">
                     <a:lnL w="12700" cap="flat" cmpd="sng" algn="ctr">
                       <a:solidFill>
                         <a:srgbClr val="FFFFFF"/>
@@ -3427,7 +3557,7 @@
                   </a:tcPr>
                 </a:tc>
               </a:tr>
-              <a:tr h="210312">
+              <a:tr h="219456">
                 <a:tc>
                   <a:txBody>
                     <a:bodyPr/>
@@ -3442,12 +3572,12 @@
                             <a:srgbClr val="1B2233"/>
                           </a:solidFill>
                         </a:rPr>
-                        <a:t>root error (3D)</a:t>
+                        <a:t>root error, 3D (pelvis)</a:t>
                       </a:r>
                       <a:endParaRPr lang="en-US" sz="1100" dirty="0"/>
                     </a:p>
                   </a:txBody>
-                  <a:tcPr marL="54864" marR="54864" marT="18288" marB="18288" anchor="ctr">
+                  <a:tcPr marL="45720" marR="45720" marT="18288" marB="18288" anchor="ctr">
                     <a:lnL w="12700" cap="flat" cmpd="sng" algn="ctr">
                       <a:solidFill>
                         <a:srgbClr val="FFFFFF"/>
@@ -3508,7 +3638,7 @@
                       <a:endParaRPr lang="en-US" sz="1100" dirty="0"/>
                     </a:p>
                   </a:txBody>
-                  <a:tcPr marL="54864" marR="54864" marT="18288" marB="18288" anchor="ctr">
+                  <a:tcPr marL="45720" marR="45720" marT="18288" marB="18288" anchor="ctr">
                     <a:lnL w="12700" cap="flat" cmpd="sng" algn="ctr">
                       <a:solidFill>
                         <a:srgbClr val="FFFFFF"/>
@@ -3569,7 +3699,7 @@
                       <a:endParaRPr lang="en-US" sz="1100" dirty="0"/>
                     </a:p>
                   </a:txBody>
-                  <a:tcPr marL="54864" marR="54864" marT="18288" marB="18288" anchor="ctr">
+                  <a:tcPr marL="45720" marR="45720" marT="18288" marB="18288" anchor="ctr">
                     <a:lnL w="38100" cap="flat" cmpd="sng" algn="ctr">
                       <a:solidFill>
                         <a:srgbClr val="4A5568"/>
@@ -3630,7 +3760,7 @@
                       <a:endParaRPr lang="en-US" sz="1100" dirty="0"/>
                     </a:p>
                   </a:txBody>
-                  <a:tcPr marL="54864" marR="54864" marT="18288" marB="18288" anchor="ctr">
+                  <a:tcPr marL="45720" marR="45720" marT="18288" marB="18288" anchor="ctr">
                     <a:lnL w="12700" cap="flat" cmpd="sng" algn="ctr">
                       <a:solidFill>
                         <a:srgbClr val="FFFFFF"/>
@@ -3691,7 +3821,7 @@
                       <a:endParaRPr lang="en-US" sz="1100" dirty="0"/>
                     </a:p>
                   </a:txBody>
-                  <a:tcPr marL="54864" marR="54864" marT="18288" marB="18288" anchor="ctr">
+                  <a:tcPr marL="45720" marR="45720" marT="18288" marB="18288" anchor="ctr">
                     <a:lnL w="12700" cap="flat" cmpd="sng" algn="ctr">
                       <a:solidFill>
                         <a:srgbClr val="FFFFFF"/>
@@ -3752,10 +3882,132 @@
                       <a:endParaRPr lang="en-US" sz="1100" dirty="0"/>
                     </a:p>
                   </a:txBody>
-                  <a:tcPr marL="54864" marR="54864" marT="18288" marB="18288" anchor="ctr">
+                  <a:tcPr marL="45720" marR="45720" marT="18288" marB="18288" anchor="ctr">
                     <a:lnL w="38100" cap="flat" cmpd="sng" algn="ctr">
                       <a:solidFill>
                         <a:srgbClr val="4A5568"/>
+                      </a:solidFill>
+                      <a:prstDash val="solid"/>
+                      <a:round/>
+                      <a:headEnd type="none" w="med" len="med"/>
+                      <a:tailEnd type="none" w="med" len="med"/>
+                    </a:lnL>
+                    <a:lnR w="12700" cap="flat" cmpd="sng" algn="ctr">
+                      <a:solidFill>
+                        <a:srgbClr val="FFFFFF"/>
+                      </a:solidFill>
+                      <a:prstDash val="solid"/>
+                      <a:round/>
+                      <a:headEnd type="none" w="med" len="med"/>
+                      <a:tailEnd type="none" w="med" len="med"/>
+                    </a:lnR>
+                    <a:lnT w="12700" cap="flat" cmpd="sng" algn="ctr">
+                      <a:solidFill>
+                        <a:srgbClr val="FFFFFF"/>
+                      </a:solidFill>
+                      <a:prstDash val="solid"/>
+                      <a:round/>
+                      <a:headEnd type="none" w="med" len="med"/>
+                      <a:tailEnd type="none" w="med" len="med"/>
+                    </a:lnT>
+                    <a:lnB w="12700" cap="flat" cmpd="sng" algn="ctr">
+                      <a:solidFill>
+                        <a:srgbClr val="FFFFFF"/>
+                      </a:solidFill>
+                      <a:prstDash val="solid"/>
+                      <a:round/>
+                      <a:headEnd type="none" w="med" len="med"/>
+                      <a:tailEnd type="none" w="med" len="med"/>
+                    </a:lnB>
+                    <a:solidFill>
+                      <a:srgbClr val="FFFFFF"/>
+                    </a:solidFill>
+                  </a:tcPr>
+                </a:tc>
+                <a:tc>
+                  <a:txBody>
+                    <a:bodyPr/>
+                    <a:lstStyle/>
+                    <a:p>
+                      <a:pPr algn="ctr" indent="0" marL="0">
+                        <a:buNone/>
+                      </a:pPr>
+                      <a:r>
+                        <a:rPr lang="en-US" sz="1100" dirty="0">
+                          <a:solidFill>
+                            <a:srgbClr val="1B2233"/>
+                          </a:solidFill>
+                        </a:rPr>
+                        <a:t>0.69 m</a:t>
+                      </a:r>
+                      <a:endParaRPr lang="en-US" sz="1100" dirty="0"/>
+                    </a:p>
+                  </a:txBody>
+                  <a:tcPr marL="45720" marR="45720" marT="18288" marB="18288" anchor="ctr">
+                    <a:lnL w="12700" cap="flat" cmpd="sng" algn="ctr">
+                      <a:solidFill>
+                        <a:srgbClr val="FFFFFF"/>
+                      </a:solidFill>
+                      <a:prstDash val="solid"/>
+                      <a:round/>
+                      <a:headEnd type="none" w="med" len="med"/>
+                      <a:tailEnd type="none" w="med" len="med"/>
+                    </a:lnL>
+                    <a:lnR w="12700" cap="flat" cmpd="sng" algn="ctr">
+                      <a:solidFill>
+                        <a:srgbClr val="FFFFFF"/>
+                      </a:solidFill>
+                      <a:prstDash val="solid"/>
+                      <a:round/>
+                      <a:headEnd type="none" w="med" len="med"/>
+                      <a:tailEnd type="none" w="med" len="med"/>
+                    </a:lnR>
+                    <a:lnT w="12700" cap="flat" cmpd="sng" algn="ctr">
+                      <a:solidFill>
+                        <a:srgbClr val="FFFFFF"/>
+                      </a:solidFill>
+                      <a:prstDash val="solid"/>
+                      <a:round/>
+                      <a:headEnd type="none" w="med" len="med"/>
+                      <a:tailEnd type="none" w="med" len="med"/>
+                    </a:lnT>
+                    <a:lnB w="12700" cap="flat" cmpd="sng" algn="ctr">
+                      <a:solidFill>
+                        <a:srgbClr val="FFFFFF"/>
+                      </a:solidFill>
+                      <a:prstDash val="solid"/>
+                      <a:round/>
+                      <a:headEnd type="none" w="med" len="med"/>
+                      <a:tailEnd type="none" w="med" len="med"/>
+                    </a:lnB>
+                    <a:solidFill>
+                      <a:srgbClr val="FFFFFF"/>
+                    </a:solidFill>
+                  </a:tcPr>
+                </a:tc>
+                <a:tc>
+                  <a:txBody>
+                    <a:bodyPr/>
+                    <a:lstStyle/>
+                    <a:p>
+                      <a:pPr algn="ctr" indent="0" marL="0">
+                        <a:buNone/>
+                      </a:pPr>
+                      <a:r>
+                        <a:rPr lang="en-US" sz="1100" dirty="0">
+                          <a:solidFill>
+                            <a:srgbClr val="1B2233"/>
+                          </a:solidFill>
+                        </a:rPr>
+                        <a:t>0.66 m</a:t>
+                      </a:r>
+                      <a:endParaRPr lang="en-US" sz="1100" dirty="0"/>
+                    </a:p>
+                  </a:txBody>
+                  <a:tcPr marL="45720" marR="45720" marT="18288" marB="18288" anchor="ctr">
+                    <a:lnL w="12700" cap="flat" cmpd="sng" algn="ctr">
+                      <a:solidFill>
+                        <a:srgbClr val="FFFFFF"/>
                       </a:solidFill>
                       <a:prstDash val="solid"/>
                       <a:round/>
@@ -3813,7 +4065,7 @@
                       <a:endParaRPr lang="en-US" sz="1100" dirty="0"/>
                     </a:p>
                   </a:txBody>
-                  <a:tcPr marL="54864" marR="54864" marT="18288" marB="18288" anchor="ctr">
+                  <a:tcPr marL="45720" marR="45720" marT="18288" marB="18288" anchor="ctr">
                     <a:lnL w="12700" cap="flat" cmpd="sng" algn="ctr">
                       <a:solidFill>
                         <a:srgbClr val="FFFFFF"/>
@@ -3856,7 +4108,7 @@
                   </a:tcPr>
                 </a:tc>
               </a:tr>
-              <a:tr h="210312">
+              <a:tr h="219456">
                 <a:tc>
                   <a:txBody>
                     <a:bodyPr/>
@@ -3876,7 +4128,7 @@
                       <a:endParaRPr lang="en-US" sz="1100" dirty="0"/>
                     </a:p>
                   </a:txBody>
-                  <a:tcPr marL="54864" marR="54864" marT="18288" marB="18288" anchor="ctr">
+                  <a:tcPr marL="45720" marR="45720" marT="18288" marB="18288" anchor="ctr">
                     <a:lnL w="12700" cap="flat" cmpd="sng" algn="ctr">
                       <a:solidFill>
                         <a:srgbClr val="FFFFFF"/>
@@ -3937,7 +4189,7 @@
                       <a:endParaRPr lang="en-US" sz="1100" dirty="0"/>
                     </a:p>
                   </a:txBody>
-                  <a:tcPr marL="54864" marR="54864" marT="18288" marB="18288" anchor="ctr">
+                  <a:tcPr marL="45720" marR="45720" marT="18288" marB="18288" anchor="ctr">
                     <a:lnL w="12700" cap="flat" cmpd="sng" algn="ctr">
                       <a:solidFill>
                         <a:srgbClr val="FFFFFF"/>
@@ -3998,7 +4250,7 @@
                       <a:endParaRPr lang="en-US" sz="1100" dirty="0"/>
                     </a:p>
                   </a:txBody>
-                  <a:tcPr marL="54864" marR="54864" marT="18288" marB="18288" anchor="ctr">
+                  <a:tcPr marL="45720" marR="45720" marT="18288" marB="18288" anchor="ctr">
                     <a:lnL w="38100" cap="flat" cmpd="sng" algn="ctr">
                       <a:solidFill>
                         <a:srgbClr val="4A5568"/>
@@ -4059,7 +4311,7 @@
                       <a:endParaRPr lang="en-US" sz="1100" dirty="0"/>
                     </a:p>
                   </a:txBody>
-                  <a:tcPr marL="54864" marR="54864" marT="18288" marB="18288" anchor="ctr">
+                  <a:tcPr marL="45720" marR="45720" marT="18288" marB="18288" anchor="ctr">
                     <a:lnL w="12700" cap="flat" cmpd="sng" algn="ctr">
                       <a:solidFill>
                         <a:srgbClr val="FFFFFF"/>
@@ -4120,7 +4372,7 @@
                       <a:endParaRPr lang="en-US" sz="1100" dirty="0"/>
                     </a:p>
                   </a:txBody>
-                  <a:tcPr marL="54864" marR="54864" marT="18288" marB="18288" anchor="ctr">
+                  <a:tcPr marL="45720" marR="45720" marT="18288" marB="18288" anchor="ctr">
                     <a:lnL w="12700" cap="flat" cmpd="sng" algn="ctr">
                       <a:solidFill>
                         <a:srgbClr val="FFFFFF"/>
@@ -4181,10 +4433,132 @@
                       <a:endParaRPr lang="en-US" sz="1100" dirty="0"/>
                     </a:p>
                   </a:txBody>
-                  <a:tcPr marL="54864" marR="54864" marT="18288" marB="18288" anchor="ctr">
+                  <a:tcPr marL="45720" marR="45720" marT="18288" marB="18288" anchor="ctr">
                     <a:lnL w="38100" cap="flat" cmpd="sng" algn="ctr">
                       <a:solidFill>
                         <a:srgbClr val="4A5568"/>
+                      </a:solidFill>
+                      <a:prstDash val="solid"/>
+                      <a:round/>
+                      <a:headEnd type="none" w="med" len="med"/>
+                      <a:tailEnd type="none" w="med" len="med"/>
+                    </a:lnL>
+                    <a:lnR w="12700" cap="flat" cmpd="sng" algn="ctr">
+                      <a:solidFill>
+                        <a:srgbClr val="FFFFFF"/>
+                      </a:solidFill>
+                      <a:prstDash val="solid"/>
+                      <a:round/>
+                      <a:headEnd type="none" w="med" len="med"/>
+                      <a:tailEnd type="none" w="med" len="med"/>
+                    </a:lnR>
+                    <a:lnT w="12700" cap="flat" cmpd="sng" algn="ctr">
+                      <a:solidFill>
+                        <a:srgbClr val="FFFFFF"/>
+                      </a:solidFill>
+                      <a:prstDash val="solid"/>
+                      <a:round/>
+                      <a:headEnd type="none" w="med" len="med"/>
+                      <a:tailEnd type="none" w="med" len="med"/>
+                    </a:lnT>
+                    <a:lnB w="12700" cap="flat" cmpd="sng" algn="ctr">
+                      <a:solidFill>
+                        <a:srgbClr val="FFFFFF"/>
+                      </a:solidFill>
+                      <a:prstDash val="solid"/>
+                      <a:round/>
+                      <a:headEnd type="none" w="med" len="med"/>
+                      <a:tailEnd type="none" w="med" len="med"/>
+                    </a:lnB>
+                    <a:solidFill>
+                      <a:srgbClr val="EEF2F7"/>
+                    </a:solidFill>
+                  </a:tcPr>
+                </a:tc>
+                <a:tc>
+                  <a:txBody>
+                    <a:bodyPr/>
+                    <a:lstStyle/>
+                    <a:p>
+                      <a:pPr algn="ctr" indent="0" marL="0">
+                        <a:buNone/>
+                      </a:pPr>
+                      <a:r>
+                        <a:rPr lang="en-US" sz="1100" dirty="0">
+                          <a:solidFill>
+                            <a:srgbClr val="1B2233"/>
+                          </a:solidFill>
+                        </a:rPr>
+                        <a:t>0.30</a:t>
+                      </a:r>
+                      <a:endParaRPr lang="en-US" sz="1100" dirty="0"/>
+                    </a:p>
+                  </a:txBody>
+                  <a:tcPr marL="45720" marR="45720" marT="18288" marB="18288" anchor="ctr">
+                    <a:lnL w="12700" cap="flat" cmpd="sng" algn="ctr">
+                      <a:solidFill>
+                        <a:srgbClr val="FFFFFF"/>
+                      </a:solidFill>
+                      <a:prstDash val="solid"/>
+                      <a:round/>
+                      <a:headEnd type="none" w="med" len="med"/>
+                      <a:tailEnd type="none" w="med" len="med"/>
+                    </a:lnL>
+                    <a:lnR w="12700" cap="flat" cmpd="sng" algn="ctr">
+                      <a:solidFill>
+                        <a:srgbClr val="FFFFFF"/>
+                      </a:solidFill>
+                      <a:prstDash val="solid"/>
+                      <a:round/>
+                      <a:headEnd type="none" w="med" len="med"/>
+                      <a:tailEnd type="none" w="med" len="med"/>
+                    </a:lnR>
+                    <a:lnT w="12700" cap="flat" cmpd="sng" algn="ctr">
+                      <a:solidFill>
+                        <a:srgbClr val="FFFFFF"/>
+                      </a:solidFill>
+                      <a:prstDash val="solid"/>
+                      <a:round/>
+                      <a:headEnd type="none" w="med" len="med"/>
+                      <a:tailEnd type="none" w="med" len="med"/>
+                    </a:lnT>
+                    <a:lnB w="12700" cap="flat" cmpd="sng" algn="ctr">
+                      <a:solidFill>
+                        <a:srgbClr val="FFFFFF"/>
+                      </a:solidFill>
+                      <a:prstDash val="solid"/>
+                      <a:round/>
+                      <a:headEnd type="none" w="med" len="med"/>
+                      <a:tailEnd type="none" w="med" len="med"/>
+                    </a:lnB>
+                    <a:solidFill>
+                      <a:srgbClr val="EEF2F7"/>
+                    </a:solidFill>
+                  </a:tcPr>
+                </a:tc>
+                <a:tc>
+                  <a:txBody>
+                    <a:bodyPr/>
+                    <a:lstStyle/>
+                    <a:p>
+                      <a:pPr algn="ctr" indent="0" marL="0">
+                        <a:buNone/>
+                      </a:pPr>
+                      <a:r>
+                        <a:rPr lang="en-US" sz="1100" dirty="0">
+                          <a:solidFill>
+                            <a:srgbClr val="1B2233"/>
+                          </a:solidFill>
+                        </a:rPr>
+                        <a:t>0.44</a:t>
+                      </a:r>
+                      <a:endParaRPr lang="en-US" sz="1100" dirty="0"/>
+                    </a:p>
+                  </a:txBody>
+                  <a:tcPr marL="45720" marR="45720" marT="18288" marB="18288" anchor="ctr">
+                    <a:lnL w="12700" cap="flat" cmpd="sng" algn="ctr">
+                      <a:solidFill>
+                        <a:srgbClr val="FFFFFF"/>
                       </a:solidFill>
                       <a:prstDash val="solid"/>
                       <a:round/>
@@ -4242,7 +4616,7 @@
                       <a:endParaRPr lang="en-US" sz="1100" dirty="0"/>
                     </a:p>
                   </a:txBody>
-                  <a:tcPr marL="54864" marR="54864" marT="18288" marB="18288" anchor="ctr">
+                  <a:tcPr marL="45720" marR="45720" marT="18288" marB="18288" anchor="ctr">
                     <a:lnL w="12700" cap="flat" cmpd="sng" algn="ctr">
                       <a:solidFill>
                         <a:srgbClr val="FFFFFF"/>
@@ -4285,7 +4659,7 @@
                   </a:tcPr>
                 </a:tc>
               </a:tr>
-              <a:tr h="210312">
+              <a:tr h="219456">
                 <a:tc>
                   <a:txBody>
                     <a:bodyPr/>
@@ -4305,7 +4679,7 @@
                       <a:endParaRPr lang="en-US" sz="1100" dirty="0"/>
                     </a:p>
                   </a:txBody>
-                  <a:tcPr marL="54864" marR="54864" marT="18288" marB="18288" anchor="ctr">
+                  <a:tcPr marL="45720" marR="45720" marT="18288" marB="18288" anchor="ctr">
                     <a:lnL w="12700" cap="flat" cmpd="sng" algn="ctr">
                       <a:solidFill>
                         <a:srgbClr val="FFFFFF"/>
@@ -4366,7 +4740,7 @@
                       <a:endParaRPr lang="en-US" sz="1100" dirty="0"/>
                     </a:p>
                   </a:txBody>
-                  <a:tcPr marL="54864" marR="54864" marT="18288" marB="18288" anchor="ctr">
+                  <a:tcPr marL="45720" marR="45720" marT="18288" marB="18288" anchor="ctr">
                     <a:lnL w="12700" cap="flat" cmpd="sng" algn="ctr">
                       <a:solidFill>
                         <a:srgbClr val="FFFFFF"/>
@@ -4427,7 +4801,7 @@
                       <a:endParaRPr lang="en-US" sz="1100" dirty="0"/>
                     </a:p>
                   </a:txBody>
-                  <a:tcPr marL="54864" marR="54864" marT="18288" marB="18288" anchor="ctr">
+                  <a:tcPr marL="45720" marR="45720" marT="18288" marB="18288" anchor="ctr">
                     <a:lnL w="38100" cap="flat" cmpd="sng" algn="ctr">
                       <a:solidFill>
                         <a:srgbClr val="4A5568"/>
@@ -4488,7 +4862,7 @@
                       <a:endParaRPr lang="en-US" sz="1100" dirty="0"/>
                     </a:p>
                   </a:txBody>
-                  <a:tcPr marL="54864" marR="54864" marT="18288" marB="18288" anchor="ctr">
+                  <a:tcPr marL="45720" marR="45720" marT="18288" marB="18288" anchor="ctr">
                     <a:lnL w="12700" cap="flat" cmpd="sng" algn="ctr">
                       <a:solidFill>
                         <a:srgbClr val="FFFFFF"/>
@@ -4549,7 +4923,7 @@
                       <a:endParaRPr lang="en-US" sz="1100" dirty="0"/>
                     </a:p>
                   </a:txBody>
-                  <a:tcPr marL="54864" marR="54864" marT="18288" marB="18288" anchor="ctr">
+                  <a:tcPr marL="45720" marR="45720" marT="18288" marB="18288" anchor="ctr">
                     <a:lnL w="12700" cap="flat" cmpd="sng" algn="ctr">
                       <a:solidFill>
                         <a:srgbClr val="FFFFFF"/>
@@ -4610,10 +4984,132 @@
                       <a:endParaRPr lang="en-US" sz="1100" dirty="0"/>
                     </a:p>
                   </a:txBody>
-                  <a:tcPr marL="54864" marR="54864" marT="18288" marB="18288" anchor="ctr">
+                  <a:tcPr marL="45720" marR="45720" marT="18288" marB="18288" anchor="ctr">
                     <a:lnL w="38100" cap="flat" cmpd="sng" algn="ctr">
                       <a:solidFill>
                         <a:srgbClr val="4A5568"/>
+                      </a:solidFill>
+                      <a:prstDash val="solid"/>
+                      <a:round/>
+                      <a:headEnd type="none" w="med" len="med"/>
+                      <a:tailEnd type="none" w="med" len="med"/>
+                    </a:lnL>
+                    <a:lnR w="12700" cap="flat" cmpd="sng" algn="ctr">
+                      <a:solidFill>
+                        <a:srgbClr val="FFFFFF"/>
+                      </a:solidFill>
+                      <a:prstDash val="solid"/>
+                      <a:round/>
+                      <a:headEnd type="none" w="med" len="med"/>
+                      <a:tailEnd type="none" w="med" len="med"/>
+                    </a:lnR>
+                    <a:lnT w="12700" cap="flat" cmpd="sng" algn="ctr">
+                      <a:solidFill>
+                        <a:srgbClr val="FFFFFF"/>
+                      </a:solidFill>
+                      <a:prstDash val="solid"/>
+                      <a:round/>
+                      <a:headEnd type="none" w="med" len="med"/>
+                      <a:tailEnd type="none" w="med" len="med"/>
+                    </a:lnT>
+                    <a:lnB w="12700" cap="flat" cmpd="sng" algn="ctr">
+                      <a:solidFill>
+                        <a:srgbClr val="FFFFFF"/>
+                      </a:solidFill>
+                      <a:prstDash val="solid"/>
+                      <a:round/>
+                      <a:headEnd type="none" w="med" len="med"/>
+                      <a:tailEnd type="none" w="med" len="med"/>
+                    </a:lnB>
+                    <a:solidFill>
+                      <a:srgbClr val="FFFFFF"/>
+                    </a:solidFill>
+                  </a:tcPr>
+                </a:tc>
+                <a:tc>
+                  <a:txBody>
+                    <a:bodyPr/>
+                    <a:lstStyle/>
+                    <a:p>
+                      <a:pPr algn="ctr" indent="0" marL="0">
+                        <a:buNone/>
+                      </a:pPr>
+                      <a:r>
+                        <a:rPr lang="en-US" sz="1100" dirty="0">
+                          <a:solidFill>
+                            <a:srgbClr val="1B2233"/>
+                          </a:solidFill>
+                        </a:rPr>
+                        <a:t>0.78</a:t>
+                      </a:r>
+                      <a:endParaRPr lang="en-US" sz="1100" dirty="0"/>
+                    </a:p>
+                  </a:txBody>
+                  <a:tcPr marL="45720" marR="45720" marT="18288" marB="18288" anchor="ctr">
+                    <a:lnL w="12700" cap="flat" cmpd="sng" algn="ctr">
+                      <a:solidFill>
+                        <a:srgbClr val="FFFFFF"/>
+                      </a:solidFill>
+                      <a:prstDash val="solid"/>
+                      <a:round/>
+                      <a:headEnd type="none" w="med" len="med"/>
+                      <a:tailEnd type="none" w="med" len="med"/>
+                    </a:lnL>
+                    <a:lnR w="12700" cap="flat" cmpd="sng" algn="ctr">
+                      <a:solidFill>
+                        <a:srgbClr val="FFFFFF"/>
+                      </a:solidFill>
+                      <a:prstDash val="solid"/>
+                      <a:round/>
+                      <a:headEnd type="none" w="med" len="med"/>
+                      <a:tailEnd type="none" w="med" len="med"/>
+                    </a:lnR>
+                    <a:lnT w="12700" cap="flat" cmpd="sng" algn="ctr">
+                      <a:solidFill>
+                        <a:srgbClr val="FFFFFF"/>
+                      </a:solidFill>
+                      <a:prstDash val="solid"/>
+                      <a:round/>
+                      <a:headEnd type="none" w="med" len="med"/>
+                      <a:tailEnd type="none" w="med" len="med"/>
+                    </a:lnT>
+                    <a:lnB w="12700" cap="flat" cmpd="sng" algn="ctr">
+                      <a:solidFill>
+                        <a:srgbClr val="FFFFFF"/>
+                      </a:solidFill>
+                      <a:prstDash val="solid"/>
+                      <a:round/>
+                      <a:headEnd type="none" w="med" len="med"/>
+                      <a:tailEnd type="none" w="med" len="med"/>
+                    </a:lnB>
+                    <a:solidFill>
+                      <a:srgbClr val="FFFFFF"/>
+                    </a:solidFill>
+                  </a:tcPr>
+                </a:tc>
+                <a:tc>
+                  <a:txBody>
+                    <a:bodyPr/>
+                    <a:lstStyle/>
+                    <a:p>
+                      <a:pPr algn="ctr" indent="0" marL="0">
+                        <a:buNone/>
+                      </a:pPr>
+                      <a:r>
+                        <a:rPr lang="en-US" sz="1100" dirty="0">
+                          <a:solidFill>
+                            <a:srgbClr val="1B2233"/>
+                          </a:solidFill>
+                        </a:rPr>
+                        <a:t>0.80</a:t>
+                      </a:r>
+                      <a:endParaRPr lang="en-US" sz="1100" dirty="0"/>
+                    </a:p>
+                  </a:txBody>
+                  <a:tcPr marL="45720" marR="45720" marT="18288" marB="18288" anchor="ctr">
+                    <a:lnL w="12700" cap="flat" cmpd="sng" algn="ctr">
+                      <a:solidFill>
+                        <a:srgbClr val="FFFFFF"/>
                       </a:solidFill>
                       <a:prstDash val="solid"/>
                       <a:round/>
@@ -4671,7 +5167,7 @@
                       <a:endParaRPr lang="en-US" sz="1100" dirty="0"/>
                     </a:p>
                   </a:txBody>
-                  <a:tcPr marL="54864" marR="54864" marT="18288" marB="18288" anchor="ctr">
+                  <a:tcPr marL="45720" marR="45720" marT="18288" marB="18288" anchor="ctr">
                     <a:lnL w="12700" cap="flat" cmpd="sng" algn="ctr">
                       <a:solidFill>
                         <a:srgbClr val="FFFFFF"/>
@@ -4714,7 +5210,7 @@
                   </a:tcPr>
                 </a:tc>
               </a:tr>
-              <a:tr h="210312">
+              <a:tr h="219456">
                 <a:tc>
                   <a:txBody>
                     <a:bodyPr/>
@@ -4734,7 +5230,7 @@
                       <a:endParaRPr lang="en-US" sz="1100" dirty="0"/>
                     </a:p>
                   </a:txBody>
-                  <a:tcPr marL="54864" marR="54864" marT="18288" marB="18288" anchor="ctr">
+                  <a:tcPr marL="45720" marR="45720" marT="18288" marB="18288" anchor="ctr">
                     <a:lnL w="12700" cap="flat" cmpd="sng" algn="ctr">
                       <a:solidFill>
                         <a:srgbClr val="FFFFFF"/>
@@ -4795,7 +5291,7 @@
                       <a:endParaRPr lang="en-US" sz="1100" dirty="0"/>
                     </a:p>
                   </a:txBody>
-                  <a:tcPr marL="54864" marR="54864" marT="18288" marB="18288" anchor="ctr">
+                  <a:tcPr marL="45720" marR="45720" marT="18288" marB="18288" anchor="ctr">
                     <a:lnL w="12700" cap="flat" cmpd="sng" algn="ctr">
                       <a:solidFill>
                         <a:srgbClr val="FFFFFF"/>
@@ -4856,7 +5352,7 @@
                       <a:endParaRPr lang="en-US" sz="1100" dirty="0"/>
                     </a:p>
                   </a:txBody>
-                  <a:tcPr marL="54864" marR="54864" marT="18288" marB="18288" anchor="ctr">
+                  <a:tcPr marL="45720" marR="45720" marT="18288" marB="18288" anchor="ctr">
                     <a:lnL w="38100" cap="flat" cmpd="sng" algn="ctr">
                       <a:solidFill>
                         <a:srgbClr val="4A5568"/>
@@ -4917,7 +5413,7 @@
                       <a:endParaRPr lang="en-US" sz="1100" dirty="0"/>
                     </a:p>
                   </a:txBody>
-                  <a:tcPr marL="54864" marR="54864" marT="18288" marB="18288" anchor="ctr">
+                  <a:tcPr marL="45720" marR="45720" marT="18288" marB="18288" anchor="ctr">
                     <a:lnL w="12700" cap="flat" cmpd="sng" algn="ctr">
                       <a:solidFill>
                         <a:srgbClr val="FFFFFF"/>
@@ -4978,7 +5474,7 @@
                       <a:endParaRPr lang="en-US" sz="1100" dirty="0"/>
                     </a:p>
                   </a:txBody>
-                  <a:tcPr marL="54864" marR="54864" marT="18288" marB="18288" anchor="ctr">
+                  <a:tcPr marL="45720" marR="45720" marT="18288" marB="18288" anchor="ctr">
                     <a:lnL w="12700" cap="flat" cmpd="sng" algn="ctr">
                       <a:solidFill>
                         <a:srgbClr val="FFFFFF"/>
@@ -5039,10 +5535,132 @@
                       <a:endParaRPr lang="en-US" sz="1100" dirty="0"/>
                     </a:p>
                   </a:txBody>
-                  <a:tcPr marL="54864" marR="54864" marT="18288" marB="18288" anchor="ctr">
+                  <a:tcPr marL="45720" marR="45720" marT="18288" marB="18288" anchor="ctr">
                     <a:lnL w="38100" cap="flat" cmpd="sng" algn="ctr">
                       <a:solidFill>
                         <a:srgbClr val="4A5568"/>
+                      </a:solidFill>
+                      <a:prstDash val="solid"/>
+                      <a:round/>
+                      <a:headEnd type="none" w="med" len="med"/>
+                      <a:tailEnd type="none" w="med" len="med"/>
+                    </a:lnL>
+                    <a:lnR w="12700" cap="flat" cmpd="sng" algn="ctr">
+                      <a:solidFill>
+                        <a:srgbClr val="FFFFFF"/>
+                      </a:solidFill>
+                      <a:prstDash val="solid"/>
+                      <a:round/>
+                      <a:headEnd type="none" w="med" len="med"/>
+                      <a:tailEnd type="none" w="med" len="med"/>
+                    </a:lnR>
+                    <a:lnT w="12700" cap="flat" cmpd="sng" algn="ctr">
+                      <a:solidFill>
+                        <a:srgbClr val="FFFFFF"/>
+                      </a:solidFill>
+                      <a:prstDash val="solid"/>
+                      <a:round/>
+                      <a:headEnd type="none" w="med" len="med"/>
+                      <a:tailEnd type="none" w="med" len="med"/>
+                    </a:lnT>
+                    <a:lnB w="12700" cap="flat" cmpd="sng" algn="ctr">
+                      <a:solidFill>
+                        <a:srgbClr val="FFFFFF"/>
+                      </a:solidFill>
+                      <a:prstDash val="solid"/>
+                      <a:round/>
+                      <a:headEnd type="none" w="med" len="med"/>
+                      <a:tailEnd type="none" w="med" len="med"/>
+                    </a:lnB>
+                    <a:solidFill>
+                      <a:srgbClr val="EEF2F7"/>
+                    </a:solidFill>
+                  </a:tcPr>
+                </a:tc>
+                <a:tc>
+                  <a:txBody>
+                    <a:bodyPr/>
+                    <a:lstStyle/>
+                    <a:p>
+                      <a:pPr algn="ctr" indent="0" marL="0">
+                        <a:buNone/>
+                      </a:pPr>
+                      <a:r>
+                        <a:rPr lang="en-US" sz="1100" dirty="0">
+                          <a:solidFill>
+                            <a:srgbClr val="1B2233"/>
+                          </a:solidFill>
+                        </a:rPr>
+                        <a:t>9.6 px</a:t>
+                      </a:r>
+                      <a:endParaRPr lang="en-US" sz="1100" dirty="0"/>
+                    </a:p>
+                  </a:txBody>
+                  <a:tcPr marL="45720" marR="45720" marT="18288" marB="18288" anchor="ctr">
+                    <a:lnL w="12700" cap="flat" cmpd="sng" algn="ctr">
+                      <a:solidFill>
+                        <a:srgbClr val="FFFFFF"/>
+                      </a:solidFill>
+                      <a:prstDash val="solid"/>
+                      <a:round/>
+                      <a:headEnd type="none" w="med" len="med"/>
+                      <a:tailEnd type="none" w="med" len="med"/>
+                    </a:lnL>
+                    <a:lnR w="12700" cap="flat" cmpd="sng" algn="ctr">
+                      <a:solidFill>
+                        <a:srgbClr val="FFFFFF"/>
+                      </a:solidFill>
+                      <a:prstDash val="solid"/>
+                      <a:round/>
+                      <a:headEnd type="none" w="med" len="med"/>
+                      <a:tailEnd type="none" w="med" len="med"/>
+                    </a:lnR>
+                    <a:lnT w="12700" cap="flat" cmpd="sng" algn="ctr">
+                      <a:solidFill>
+                        <a:srgbClr val="FFFFFF"/>
+                      </a:solidFill>
+                      <a:prstDash val="solid"/>
+                      <a:round/>
+                      <a:headEnd type="none" w="med" len="med"/>
+                      <a:tailEnd type="none" w="med" len="med"/>
+                    </a:lnT>
+                    <a:lnB w="12700" cap="flat" cmpd="sng" algn="ctr">
+                      <a:solidFill>
+                        <a:srgbClr val="FFFFFF"/>
+                      </a:solidFill>
+                      <a:prstDash val="solid"/>
+                      <a:round/>
+                      <a:headEnd type="none" w="med" len="med"/>
+                      <a:tailEnd type="none" w="med" len="med"/>
+                    </a:lnB>
+                    <a:solidFill>
+                      <a:srgbClr val="EEF2F7"/>
+                    </a:solidFill>
+                  </a:tcPr>
+                </a:tc>
+                <a:tc>
+                  <a:txBody>
+                    <a:bodyPr/>
+                    <a:lstStyle/>
+                    <a:p>
+                      <a:pPr algn="ctr" indent="0" marL="0">
+                        <a:buNone/>
+                      </a:pPr>
+                      <a:r>
+                        <a:rPr lang="en-US" sz="1100" dirty="0">
+                          <a:solidFill>
+                            <a:srgbClr val="1B2233"/>
+                          </a:solidFill>
+                        </a:rPr>
+                        <a:t>8.5 px</a:t>
+                      </a:r>
+                      <a:endParaRPr lang="en-US" sz="1100" dirty="0"/>
+                    </a:p>
+                  </a:txBody>
+                  <a:tcPr marL="45720" marR="45720" marT="18288" marB="18288" anchor="ctr">
+                    <a:lnL w="12700" cap="flat" cmpd="sng" algn="ctr">
+                      <a:solidFill>
+                        <a:srgbClr val="FFFFFF"/>
                       </a:solidFill>
                       <a:prstDash val="solid"/>
                       <a:round/>
@@ -5100,7 +5718,7 @@
                       <a:endParaRPr lang="en-US" sz="1100" dirty="0"/>
                     </a:p>
                   </a:txBody>
-                  <a:tcPr marL="54864" marR="54864" marT="18288" marB="18288" anchor="ctr">
+                  <a:tcPr marL="45720" marR="45720" marT="18288" marB="18288" anchor="ctr">
                     <a:lnL w="12700" cap="flat" cmpd="sng" algn="ctr">
                       <a:solidFill>
                         <a:srgbClr val="FFFFFF"/>
@@ -5143,7 +5761,7 @@
                   </a:tcPr>
                 </a:tc>
               </a:tr>
-              <a:tr h="210312">
+              <a:tr h="219456">
                 <a:tc>
                   <a:txBody>
                     <a:bodyPr/>
@@ -5163,7 +5781,7 @@
                       <a:endParaRPr lang="en-US" sz="1100" dirty="0"/>
                     </a:p>
                   </a:txBody>
-                  <a:tcPr marL="54864" marR="54864" marT="18288" marB="18288" anchor="ctr">
+                  <a:tcPr marL="45720" marR="45720" marT="18288" marB="18288" anchor="ctr">
                     <a:lnL w="12700" cap="flat" cmpd="sng" algn="ctr">
                       <a:solidFill>
                         <a:srgbClr val="FFFFFF"/>
@@ -5224,7 +5842,7 @@
                       <a:endParaRPr lang="en-US" sz="1100" dirty="0"/>
                     </a:p>
                   </a:txBody>
-                  <a:tcPr marL="54864" marR="54864" marT="18288" marB="18288" anchor="ctr">
+                  <a:tcPr marL="45720" marR="45720" marT="18288" marB="18288" anchor="ctr">
                     <a:lnL w="12700" cap="flat" cmpd="sng" algn="ctr">
                       <a:solidFill>
                         <a:srgbClr val="FFFFFF"/>
@@ -5285,7 +5903,7 @@
                       <a:endParaRPr lang="en-US" sz="1100" dirty="0"/>
                     </a:p>
                   </a:txBody>
-                  <a:tcPr marL="54864" marR="54864" marT="18288" marB="18288" anchor="ctr">
+                  <a:tcPr marL="45720" marR="45720" marT="18288" marB="18288" anchor="ctr">
                     <a:lnL w="38100" cap="flat" cmpd="sng" algn="ctr">
                       <a:solidFill>
                         <a:srgbClr val="4A5568"/>
@@ -5346,7 +5964,7 @@
                       <a:endParaRPr lang="en-US" sz="1100" dirty="0"/>
                     </a:p>
                   </a:txBody>
-                  <a:tcPr marL="54864" marR="54864" marT="18288" marB="18288" anchor="ctr">
+                  <a:tcPr marL="45720" marR="45720" marT="18288" marB="18288" anchor="ctr">
                     <a:lnL w="12700" cap="flat" cmpd="sng" algn="ctr">
                       <a:solidFill>
                         <a:srgbClr val="FFFFFF"/>
@@ -5407,7 +6025,7 @@
                       <a:endParaRPr lang="en-US" sz="1100" dirty="0"/>
                     </a:p>
                   </a:txBody>
-                  <a:tcPr marL="54864" marR="54864" marT="18288" marB="18288" anchor="ctr">
+                  <a:tcPr marL="45720" marR="45720" marT="18288" marB="18288" anchor="ctr">
                     <a:lnL w="12700" cap="flat" cmpd="sng" algn="ctr">
                       <a:solidFill>
                         <a:srgbClr val="FFFFFF"/>
@@ -5468,10 +6086,132 @@
                       <a:endParaRPr lang="en-US" sz="1100" dirty="0"/>
                     </a:p>
                   </a:txBody>
-                  <a:tcPr marL="54864" marR="54864" marT="18288" marB="18288" anchor="ctr">
+                  <a:tcPr marL="45720" marR="45720" marT="18288" marB="18288" anchor="ctr">
                     <a:lnL w="38100" cap="flat" cmpd="sng" algn="ctr">
                       <a:solidFill>
                         <a:srgbClr val="4A5568"/>
+                      </a:solidFill>
+                      <a:prstDash val="solid"/>
+                      <a:round/>
+                      <a:headEnd type="none" w="med" len="med"/>
+                      <a:tailEnd type="none" w="med" len="med"/>
+                    </a:lnL>
+                    <a:lnR w="12700" cap="flat" cmpd="sng" algn="ctr">
+                      <a:solidFill>
+                        <a:srgbClr val="FFFFFF"/>
+                      </a:solidFill>
+                      <a:prstDash val="solid"/>
+                      <a:round/>
+                      <a:headEnd type="none" w="med" len="med"/>
+                      <a:tailEnd type="none" w="med" len="med"/>
+                    </a:lnR>
+                    <a:lnT w="12700" cap="flat" cmpd="sng" algn="ctr">
+                      <a:solidFill>
+                        <a:srgbClr val="FFFFFF"/>
+                      </a:solidFill>
+                      <a:prstDash val="solid"/>
+                      <a:round/>
+                      <a:headEnd type="none" w="med" len="med"/>
+                      <a:tailEnd type="none" w="med" len="med"/>
+                    </a:lnT>
+                    <a:lnB w="12700" cap="flat" cmpd="sng" algn="ctr">
+                      <a:solidFill>
+                        <a:srgbClr val="FFFFFF"/>
+                      </a:solidFill>
+                      <a:prstDash val="solid"/>
+                      <a:round/>
+                      <a:headEnd type="none" w="med" len="med"/>
+                      <a:tailEnd type="none" w="med" len="med"/>
+                    </a:lnB>
+                    <a:solidFill>
+                      <a:srgbClr val="FFFFFF"/>
+                    </a:solidFill>
+                  </a:tcPr>
+                </a:tc>
+                <a:tc>
+                  <a:txBody>
+                    <a:bodyPr/>
+                    <a:lstStyle/>
+                    <a:p>
+                      <a:pPr algn="ctr" indent="0" marL="0">
+                        <a:buNone/>
+                      </a:pPr>
+                      <a:r>
+                        <a:rPr lang="en-US" sz="1100" dirty="0">
+                          <a:solidFill>
+                            <a:srgbClr val="1B2233"/>
+                          </a:solidFill>
+                        </a:rPr>
+                        <a:t>37.3 px</a:t>
+                      </a:r>
+                      <a:endParaRPr lang="en-US" sz="1100" dirty="0"/>
+                    </a:p>
+                  </a:txBody>
+                  <a:tcPr marL="45720" marR="45720" marT="18288" marB="18288" anchor="ctr">
+                    <a:lnL w="12700" cap="flat" cmpd="sng" algn="ctr">
+                      <a:solidFill>
+                        <a:srgbClr val="FFFFFF"/>
+                      </a:solidFill>
+                      <a:prstDash val="solid"/>
+                      <a:round/>
+                      <a:headEnd type="none" w="med" len="med"/>
+                      <a:tailEnd type="none" w="med" len="med"/>
+                    </a:lnL>
+                    <a:lnR w="12700" cap="flat" cmpd="sng" algn="ctr">
+                      <a:solidFill>
+                        <a:srgbClr val="FFFFFF"/>
+                      </a:solidFill>
+                      <a:prstDash val="solid"/>
+                      <a:round/>
+                      <a:headEnd type="none" w="med" len="med"/>
+                      <a:tailEnd type="none" w="med" len="med"/>
+                    </a:lnR>
+                    <a:lnT w="12700" cap="flat" cmpd="sng" algn="ctr">
+                      <a:solidFill>
+                        <a:srgbClr val="FFFFFF"/>
+                      </a:solidFill>
+                      <a:prstDash val="solid"/>
+                      <a:round/>
+                      <a:headEnd type="none" w="med" len="med"/>
+                      <a:tailEnd type="none" w="med" len="med"/>
+                    </a:lnT>
+                    <a:lnB w="12700" cap="flat" cmpd="sng" algn="ctr">
+                      <a:solidFill>
+                        <a:srgbClr val="FFFFFF"/>
+                      </a:solidFill>
+                      <a:prstDash val="solid"/>
+                      <a:round/>
+                      <a:headEnd type="none" w="med" len="med"/>
+                      <a:tailEnd type="none" w="med" len="med"/>
+                    </a:lnB>
+                    <a:solidFill>
+                      <a:srgbClr val="FFFFFF"/>
+                    </a:solidFill>
+                  </a:tcPr>
+                </a:tc>
+                <a:tc>
+                  <a:txBody>
+                    <a:bodyPr/>
+                    <a:lstStyle/>
+                    <a:p>
+                      <a:pPr algn="ctr" indent="0" marL="0">
+                        <a:buNone/>
+                      </a:pPr>
+                      <a:r>
+                        <a:rPr lang="en-US" sz="1100" dirty="0">
+                          <a:solidFill>
+                            <a:srgbClr val="1B2233"/>
+                          </a:solidFill>
+                        </a:rPr>
+                        <a:t>38.1 px</a:t>
+                      </a:r>
+                      <a:endParaRPr lang="en-US" sz="1100" dirty="0"/>
+                    </a:p>
+                  </a:txBody>
+                  <a:tcPr marL="45720" marR="45720" marT="18288" marB="18288" anchor="ctr">
+                    <a:lnL w="12700" cap="flat" cmpd="sng" algn="ctr">
+                      <a:solidFill>
+                        <a:srgbClr val="FFFFFF"/>
                       </a:solidFill>
                       <a:prstDash val="solid"/>
                       <a:round/>
@@ -5529,7 +6269,7 @@
                       <a:endParaRPr lang="en-US" sz="1100" dirty="0"/>
                     </a:p>
                   </a:txBody>
-                  <a:tcPr marL="54864" marR="54864" marT="18288" marB="18288" anchor="ctr">
+                  <a:tcPr marL="45720" marR="45720" marT="18288" marB="18288" anchor="ctr">
                     <a:lnL w="12700" cap="flat" cmpd="sng" algn="ctr">
                       <a:solidFill>
                         <a:srgbClr val="FFFFFF"/>
@@ -5572,7 +6312,7 @@
                   </a:tcPr>
                 </a:tc>
               </a:tr>
-              <a:tr h="210312">
+              <a:tr h="219456">
                 <a:tc>
                   <a:txBody>
                     <a:bodyPr/>
@@ -5592,7 +6332,7 @@
                       <a:endParaRPr lang="en-US" sz="1100" dirty="0"/>
                     </a:p>
                   </a:txBody>
-                  <a:tcPr marL="54864" marR="54864" marT="18288" marB="18288" anchor="ctr">
+                  <a:tcPr marL="45720" marR="45720" marT="18288" marB="18288" anchor="ctr">
                     <a:lnL w="12700" cap="flat" cmpd="sng" algn="ctr">
                       <a:solidFill>
                         <a:srgbClr val="FFFFFF"/>
@@ -5653,7 +6393,7 @@
                       <a:endParaRPr lang="en-US" sz="1100" dirty="0"/>
                     </a:p>
                   </a:txBody>
-                  <a:tcPr marL="54864" marR="54864" marT="18288" marB="18288" anchor="ctr">
+                  <a:tcPr marL="45720" marR="45720" marT="18288" marB="18288" anchor="ctr">
                     <a:lnL w="12700" cap="flat" cmpd="sng" algn="ctr">
                       <a:solidFill>
                         <a:srgbClr val="FFFFFF"/>
@@ -5714,7 +6454,7 @@
                       <a:endParaRPr lang="en-US" sz="1100" dirty="0"/>
                     </a:p>
                   </a:txBody>
-                  <a:tcPr marL="54864" marR="54864" marT="18288" marB="18288" anchor="ctr">
+                  <a:tcPr marL="45720" marR="45720" marT="18288" marB="18288" anchor="ctr">
                     <a:lnL w="38100" cap="flat" cmpd="sng" algn="ctr">
                       <a:solidFill>
                         <a:srgbClr val="4A5568"/>
@@ -5775,7 +6515,7 @@
                       <a:endParaRPr lang="en-US" sz="1100" dirty="0"/>
                     </a:p>
                   </a:txBody>
-                  <a:tcPr marL="54864" marR="54864" marT="18288" marB="18288" anchor="ctr">
+                  <a:tcPr marL="45720" marR="45720" marT="18288" marB="18288" anchor="ctr">
                     <a:lnL w="12700" cap="flat" cmpd="sng" algn="ctr">
                       <a:solidFill>
                         <a:srgbClr val="FFFFFF"/>
@@ -5836,7 +6576,7 @@
                       <a:endParaRPr lang="en-US" sz="1100" dirty="0"/>
                     </a:p>
                   </a:txBody>
-                  <a:tcPr marL="54864" marR="54864" marT="18288" marB="18288" anchor="ctr">
+                  <a:tcPr marL="45720" marR="45720" marT="18288" marB="18288" anchor="ctr">
                     <a:lnL w="12700" cap="flat" cmpd="sng" algn="ctr">
                       <a:solidFill>
                         <a:srgbClr val="FFFFFF"/>
@@ -5897,10 +6637,132 @@
                       <a:endParaRPr lang="en-US" sz="1100" dirty="0"/>
                     </a:p>
                   </a:txBody>
-                  <a:tcPr marL="54864" marR="54864" marT="18288" marB="18288" anchor="ctr">
+                  <a:tcPr marL="45720" marR="45720" marT="18288" marB="18288" anchor="ctr">
                     <a:lnL w="38100" cap="flat" cmpd="sng" algn="ctr">
                       <a:solidFill>
                         <a:srgbClr val="4A5568"/>
+                      </a:solidFill>
+                      <a:prstDash val="solid"/>
+                      <a:round/>
+                      <a:headEnd type="none" w="med" len="med"/>
+                      <a:tailEnd type="none" w="med" len="med"/>
+                    </a:lnL>
+                    <a:lnR w="12700" cap="flat" cmpd="sng" algn="ctr">
+                      <a:solidFill>
+                        <a:srgbClr val="FFFFFF"/>
+                      </a:solidFill>
+                      <a:prstDash val="solid"/>
+                      <a:round/>
+                      <a:headEnd type="none" w="med" len="med"/>
+                      <a:tailEnd type="none" w="med" len="med"/>
+                    </a:lnR>
+                    <a:lnT w="12700" cap="flat" cmpd="sng" algn="ctr">
+                      <a:solidFill>
+                        <a:srgbClr val="FFFFFF"/>
+                      </a:solidFill>
+                      <a:prstDash val="solid"/>
+                      <a:round/>
+                      <a:headEnd type="none" w="med" len="med"/>
+                      <a:tailEnd type="none" w="med" len="med"/>
+                    </a:lnT>
+                    <a:lnB w="12700" cap="flat" cmpd="sng" algn="ctr">
+                      <a:solidFill>
+                        <a:srgbClr val="FFFFFF"/>
+                      </a:solidFill>
+                      <a:prstDash val="solid"/>
+                      <a:round/>
+                      <a:headEnd type="none" w="med" len="med"/>
+                      <a:tailEnd type="none" w="med" len="med"/>
+                    </a:lnB>
+                    <a:solidFill>
+                      <a:srgbClr val="EEF2F7"/>
+                    </a:solidFill>
+                  </a:tcPr>
+                </a:tc>
+                <a:tc>
+                  <a:txBody>
+                    <a:bodyPr/>
+                    <a:lstStyle/>
+                    <a:p>
+                      <a:pPr algn="ctr" indent="0" marL="0">
+                        <a:buNone/>
+                      </a:pPr>
+                      <a:r>
+                        <a:rPr lang="en-US" sz="1100" dirty="0">
+                          <a:solidFill>
+                            <a:srgbClr val="1B2233"/>
+                          </a:solidFill>
+                        </a:rPr>
+                        <a:t>77.3 mm</a:t>
+                      </a:r>
+                      <a:endParaRPr lang="en-US" sz="1100" dirty="0"/>
+                    </a:p>
+                  </a:txBody>
+                  <a:tcPr marL="45720" marR="45720" marT="18288" marB="18288" anchor="ctr">
+                    <a:lnL w="12700" cap="flat" cmpd="sng" algn="ctr">
+                      <a:solidFill>
+                        <a:srgbClr val="FFFFFF"/>
+                      </a:solidFill>
+                      <a:prstDash val="solid"/>
+                      <a:round/>
+                      <a:headEnd type="none" w="med" len="med"/>
+                      <a:tailEnd type="none" w="med" len="med"/>
+                    </a:lnL>
+                    <a:lnR w="12700" cap="flat" cmpd="sng" algn="ctr">
+                      <a:solidFill>
+                        <a:srgbClr val="FFFFFF"/>
+                      </a:solidFill>
+                      <a:prstDash val="solid"/>
+                      <a:round/>
+                      <a:headEnd type="none" w="med" len="med"/>
+                      <a:tailEnd type="none" w="med" len="med"/>
+                    </a:lnR>
+                    <a:lnT w="12700" cap="flat" cmpd="sng" algn="ctr">
+                      <a:solidFill>
+                        <a:srgbClr val="FFFFFF"/>
+                      </a:solidFill>
+                      <a:prstDash val="solid"/>
+                      <a:round/>
+                      <a:headEnd type="none" w="med" len="med"/>
+                      <a:tailEnd type="none" w="med" len="med"/>
+                    </a:lnT>
+                    <a:lnB w="12700" cap="flat" cmpd="sng" algn="ctr">
+                      <a:solidFill>
+                        <a:srgbClr val="FFFFFF"/>
+                      </a:solidFill>
+                      <a:prstDash val="solid"/>
+                      <a:round/>
+                      <a:headEnd type="none" w="med" len="med"/>
+                      <a:tailEnd type="none" w="med" len="med"/>
+                    </a:lnB>
+                    <a:solidFill>
+                      <a:srgbClr val="EEF2F7"/>
+                    </a:solidFill>
+                  </a:tcPr>
+                </a:tc>
+                <a:tc>
+                  <a:txBody>
+                    <a:bodyPr/>
+                    <a:lstStyle/>
+                    <a:p>
+                      <a:pPr algn="ctr" indent="0" marL="0">
+                        <a:buNone/>
+                      </a:pPr>
+                      <a:r>
+                        <a:rPr lang="en-US" sz="1100" dirty="0">
+                          <a:solidFill>
+                            <a:srgbClr val="1B2233"/>
+                          </a:solidFill>
+                        </a:rPr>
+                        <a:t>76.8 mm</a:t>
+                      </a:r>
+                      <a:endParaRPr lang="en-US" sz="1100" dirty="0"/>
+                    </a:p>
+                  </a:txBody>
+                  <a:tcPr marL="45720" marR="45720" marT="18288" marB="18288" anchor="ctr">
+                    <a:lnL w="12700" cap="flat" cmpd="sng" algn="ctr">
+                      <a:solidFill>
+                        <a:srgbClr val="FFFFFF"/>
                       </a:solidFill>
                       <a:prstDash val="solid"/>
                       <a:round/>
@@ -5958,7 +6820,7 @@
                       <a:endParaRPr lang="en-US" sz="1100" dirty="0"/>
                     </a:p>
                   </a:txBody>
-                  <a:tcPr marL="54864" marR="54864" marT="18288" marB="18288" anchor="ctr">
+                  <a:tcPr marL="45720" marR="45720" marT="18288" marB="18288" anchor="ctr">
                     <a:lnL w="12700" cap="flat" cmpd="sng" algn="ctr">
                       <a:solidFill>
                         <a:srgbClr val="FFFFFF"/>
@@ -6001,7 +6863,7 @@
                   </a:tcPr>
                 </a:tc>
               </a:tr>
-              <a:tr h="210312">
+              <a:tr h="219456">
                 <a:tc>
                   <a:txBody>
                     <a:bodyPr/>
@@ -6021,7 +6883,7 @@
                       <a:endParaRPr lang="en-US" sz="1100" dirty="0"/>
                     </a:p>
                   </a:txBody>
-                  <a:tcPr marL="54864" marR="54864" marT="18288" marB="18288" anchor="ctr">
+                  <a:tcPr marL="45720" marR="45720" marT="18288" marB="18288" anchor="ctr">
                     <a:lnL w="12700" cap="flat" cmpd="sng" algn="ctr">
                       <a:solidFill>
                         <a:srgbClr val="FFFFFF"/>
@@ -6082,7 +6944,7 @@
                       <a:endParaRPr lang="en-US" sz="1100" dirty="0"/>
                     </a:p>
                   </a:txBody>
-                  <a:tcPr marL="54864" marR="54864" marT="18288" marB="18288" anchor="ctr">
+                  <a:tcPr marL="45720" marR="45720" marT="18288" marB="18288" anchor="ctr">
                     <a:lnL w="12700" cap="flat" cmpd="sng" algn="ctr">
                       <a:solidFill>
                         <a:srgbClr val="FFFFFF"/>
@@ -6143,7 +7005,7 @@
                       <a:endParaRPr lang="en-US" sz="1100" dirty="0"/>
                     </a:p>
                   </a:txBody>
-                  <a:tcPr marL="54864" marR="54864" marT="18288" marB="18288" anchor="ctr">
+                  <a:tcPr marL="45720" marR="45720" marT="18288" marB="18288" anchor="ctr">
                     <a:lnL w="38100" cap="flat" cmpd="sng" algn="ctr">
                       <a:solidFill>
                         <a:srgbClr val="4A5568"/>
@@ -6204,7 +7066,7 @@
                       <a:endParaRPr lang="en-US" sz="1100" dirty="0"/>
                     </a:p>
                   </a:txBody>
-                  <a:tcPr marL="54864" marR="54864" marT="18288" marB="18288" anchor="ctr">
+                  <a:tcPr marL="45720" marR="45720" marT="18288" marB="18288" anchor="ctr">
                     <a:lnL w="12700" cap="flat" cmpd="sng" algn="ctr">
                       <a:solidFill>
                         <a:srgbClr val="FFFFFF"/>
@@ -6265,7 +7127,7 @@
                       <a:endParaRPr lang="en-US" sz="1100" dirty="0"/>
                     </a:p>
                   </a:txBody>
-                  <a:tcPr marL="54864" marR="54864" marT="18288" marB="18288" anchor="ctr">
+                  <a:tcPr marL="45720" marR="45720" marT="18288" marB="18288" anchor="ctr">
                     <a:lnL w="12700" cap="flat" cmpd="sng" algn="ctr">
                       <a:solidFill>
                         <a:srgbClr val="FFFFFF"/>
@@ -6326,10 +7188,132 @@
                       <a:endParaRPr lang="en-US" sz="1100" dirty="0"/>
                     </a:p>
                   </a:txBody>
-                  <a:tcPr marL="54864" marR="54864" marT="18288" marB="18288" anchor="ctr">
+                  <a:tcPr marL="45720" marR="45720" marT="18288" marB="18288" anchor="ctr">
                     <a:lnL w="38100" cap="flat" cmpd="sng" algn="ctr">
                       <a:solidFill>
                         <a:srgbClr val="4A5568"/>
+                      </a:solidFill>
+                      <a:prstDash val="solid"/>
+                      <a:round/>
+                      <a:headEnd type="none" w="med" len="med"/>
+                      <a:tailEnd type="none" w="med" len="med"/>
+                    </a:lnL>
+                    <a:lnR w="12700" cap="flat" cmpd="sng" algn="ctr">
+                      <a:solidFill>
+                        <a:srgbClr val="FFFFFF"/>
+                      </a:solidFill>
+                      <a:prstDash val="solid"/>
+                      <a:round/>
+                      <a:headEnd type="none" w="med" len="med"/>
+                      <a:tailEnd type="none" w="med" len="med"/>
+                    </a:lnR>
+                    <a:lnT w="12700" cap="flat" cmpd="sng" algn="ctr">
+                      <a:solidFill>
+                        <a:srgbClr val="FFFFFF"/>
+                      </a:solidFill>
+                      <a:prstDash val="solid"/>
+                      <a:round/>
+                      <a:headEnd type="none" w="med" len="med"/>
+                      <a:tailEnd type="none" w="med" len="med"/>
+                    </a:lnT>
+                    <a:lnB w="12700" cap="flat" cmpd="sng" algn="ctr">
+                      <a:solidFill>
+                        <a:srgbClr val="FFFFFF"/>
+                      </a:solidFill>
+                      <a:prstDash val="solid"/>
+                      <a:round/>
+                      <a:headEnd type="none" w="med" len="med"/>
+                      <a:tailEnd type="none" w="med" len="med"/>
+                    </a:lnB>
+                    <a:solidFill>
+                      <a:srgbClr val="FFFFFF"/>
+                    </a:solidFill>
+                  </a:tcPr>
+                </a:tc>
+                <a:tc>
+                  <a:txBody>
+                    <a:bodyPr/>
+                    <a:lstStyle/>
+                    <a:p>
+                      <a:pPr algn="ctr" indent="0" marL="0">
+                        <a:buNone/>
+                      </a:pPr>
+                      <a:r>
+                        <a:rPr lang="en-US" sz="1100" dirty="0">
+                          <a:solidFill>
+                            <a:srgbClr val="1B2233"/>
+                          </a:solidFill>
+                        </a:rPr>
+                        <a:t>87.8%</a:t>
+                      </a:r>
+                      <a:endParaRPr lang="en-US" sz="1100" dirty="0"/>
+                    </a:p>
+                  </a:txBody>
+                  <a:tcPr marL="45720" marR="45720" marT="18288" marB="18288" anchor="ctr">
+                    <a:lnL w="12700" cap="flat" cmpd="sng" algn="ctr">
+                      <a:solidFill>
+                        <a:srgbClr val="FFFFFF"/>
+                      </a:solidFill>
+                      <a:prstDash val="solid"/>
+                      <a:round/>
+                      <a:headEnd type="none" w="med" len="med"/>
+                      <a:tailEnd type="none" w="med" len="med"/>
+                    </a:lnL>
+                    <a:lnR w="12700" cap="flat" cmpd="sng" algn="ctr">
+                      <a:solidFill>
+                        <a:srgbClr val="FFFFFF"/>
+                      </a:solidFill>
+                      <a:prstDash val="solid"/>
+                      <a:round/>
+                      <a:headEnd type="none" w="med" len="med"/>
+                      <a:tailEnd type="none" w="med" len="med"/>
+                    </a:lnR>
+                    <a:lnT w="12700" cap="flat" cmpd="sng" algn="ctr">
+                      <a:solidFill>
+                        <a:srgbClr val="FFFFFF"/>
+                      </a:solidFill>
+                      <a:prstDash val="solid"/>
+                      <a:round/>
+                      <a:headEnd type="none" w="med" len="med"/>
+                      <a:tailEnd type="none" w="med" len="med"/>
+                    </a:lnT>
+                    <a:lnB w="12700" cap="flat" cmpd="sng" algn="ctr">
+                      <a:solidFill>
+                        <a:srgbClr val="FFFFFF"/>
+                      </a:solidFill>
+                      <a:prstDash val="solid"/>
+                      <a:round/>
+                      <a:headEnd type="none" w="med" len="med"/>
+                      <a:tailEnd type="none" w="med" len="med"/>
+                    </a:lnB>
+                    <a:solidFill>
+                      <a:srgbClr val="FFFFFF"/>
+                    </a:solidFill>
+                  </a:tcPr>
+                </a:tc>
+                <a:tc>
+                  <a:txBody>
+                    <a:bodyPr/>
+                    <a:lstStyle/>
+                    <a:p>
+                      <a:pPr algn="ctr" indent="0" marL="0">
+                        <a:buNone/>
+                      </a:pPr>
+                      <a:r>
+                        <a:rPr lang="en-US" sz="1100" dirty="0">
+                          <a:solidFill>
+                            <a:srgbClr val="1B2233"/>
+                          </a:solidFill>
+                        </a:rPr>
+                        <a:t>87.8%</a:t>
+                      </a:r>
+                      <a:endParaRPr lang="en-US" sz="1100" dirty="0"/>
+                    </a:p>
+                  </a:txBody>
+                  <a:tcPr marL="45720" marR="45720" marT="18288" marB="18288" anchor="ctr">
+                    <a:lnL w="12700" cap="flat" cmpd="sng" algn="ctr">
+                      <a:solidFill>
+                        <a:srgbClr val="FFFFFF"/>
                       </a:solidFill>
                       <a:prstDash val="solid"/>
                       <a:round/>
@@ -6387,7 +7371,7 @@
                       <a:endParaRPr lang="en-US" sz="1100" dirty="0"/>
                     </a:p>
                   </a:txBody>
-                  <a:tcPr marL="54864" marR="54864" marT="18288" marB="18288" anchor="ctr">
+                  <a:tcPr marL="45720" marR="45720" marT="18288" marB="18288" anchor="ctr">
                     <a:lnL w="12700" cap="flat" cmpd="sng" algn="ctr">
                       <a:solidFill>
                         <a:srgbClr val="FFFFFF"/>
@@ -6442,8 +7426,8 @@
         </p:nvSpPr>
         <p:spPr>
           <a:xfrm>
-            <a:off x="457200" y="3072384"/>
-            <a:ext cx="8229600" cy="347472"/>
+            <a:off x="457200" y="3154680"/>
+            <a:ext cx="8229600" cy="201168"/>
           </a:xfrm>
           <a:prstGeom prst="rect">
             <a:avLst/>
@@ -6464,7 +7448,7 @@
                   <a:schemeClr val="tx2"/>
                 </a:solidFill>
               </a:rPr>
-              <a:t>Fix: targets at the head; ×5 / ×20: depth loss weight. Controls: root targets, depth ×1, same schedule (none at ×5 / ×20). Root error: 3D distance of the predicted to the true root joint (pelvis). Drawn size: predicted / true head-to-pelvis px.</a:t>
+              <a:t>Fix: targets at the head; ×5 / ×20 = depth loss weight. Controls: root targets, depth ×1, same schedule. No control was run at ×5 or ×20.</a:t>
             </a:r>
             <a:endParaRPr lang="en-US" sz="1100" dirty="0"/>
           </a:p>
@@ -6478,8 +7462,8 @@
         </p:nvSpPr>
         <p:spPr>
           <a:xfrm>
-            <a:off x="457200" y="3474720"/>
-            <a:ext cx="8229600" cy="1207008"/>
+            <a:off x="457200" y="3456432"/>
+            <a:ext cx="8229600" cy="1225296"/>
           </a:xfrm>
           <a:prstGeom prst="rect">
             <a:avLst/>
@@ -6493,7 +7477,7 @@
           <a:p>
             <a:pPr marL="177800" indent="-177800">
               <a:spcAft>
-                <a:spcPts val="200"/>
+                <a:spcPts val="300"/>
               </a:spcAft>
               <a:buSzPct val="100000"/>
               <a:buChar char="•"/>
@@ -6504,7 +7488,7 @@
                   <a:schemeClr val="tx1"/>
                 </a:solidFill>
               </a:rPr>
-              <a:t>Works: </a:t>
+              <a:t>Not fixed: </a:t>
             </a:r>
             <a:r>
               <a:rPr lang="en-US" sz="1200" dirty="0">
@@ -6512,14 +7496,14 @@
                   <a:schemeClr val="tx1"/>
                 </a:solidFill>
               </a:rPr>
-              <a:t>head error 7–9 px (controls 58–64); root error 0.53–0.73 m in all five fix runs vs 1.11–1.44 m for the controls.</a:t>
+              <a:t>depth slope 0.30 with the switch alone, 0.38–0.44 with a stronger depth loss; predictions are pulled toward 2.5–2.9 m, cause unknown. With ×5, 10 epochs gave a lower root error than 2 epochs (0.66 → 0.54 m) but no better slope (0.44 → 0.38); with the switch alone neither improved (0.69 → 0.73 m, slope 0.30 → 0.30).</a:t>
             </a:r>
             <a:endParaRPr lang="en-US" sz="1200" dirty="0"/>
           </a:p>
           <a:p>
             <a:pPr marL="177800" indent="-177800">
               <a:spcAft>
-                <a:spcPts val="200"/>
+                <a:spcPts val="300"/>
               </a:spcAft>
               <a:buSzPct val="100000"/>
               <a:buChar char="•"/>
@@ -6530,7 +7514,7 @@
                   <a:schemeClr val="tx1"/>
                 </a:solidFill>
               </a:rPr>
-              <a:t>Not fixed: </a:t>
+              <a:t>Likely cost: </a:t>
             </a:r>
             <a:r>
               <a:rPr lang="en-US" sz="1200" dirty="0">
@@ -6538,33 +7522,7 @@
                   <a:schemeClr val="tx1"/>
                 </a:solidFill>
               </a:rPr>
-              <a:t>slope about 0.4: predictions are pulled toward about 2.5 m, near the estimated training average, while holdout people are nearer (1.9 m). Why near and far are not separated is unknown. Longer training lowers root error (×5: 0.66 → 0.54 m), not the slope (0.44 → 0.38).</a:t>
-            </a:r>
-            <a:endParaRPr lang="en-US" sz="1200" dirty="0"/>
-          </a:p>
-          <a:p>
-            <a:pPr marL="177800" indent="-177800">
-              <a:spcAft>
-                <a:spcPts val="200"/>
-              </a:spcAft>
-              <a:buSzPct val="100000"/>
-              <a:buChar char="•"/>
-            </a:pPr>
-            <a:r>
-              <a:rPr lang="en-US" sz="1200" b="1" dirty="0">
-                <a:solidFill>
-                  <a:schemeClr val="tx1"/>
-                </a:solidFill>
-              </a:rPr>
-              <a:t>Likely cost: </a:t>
-            </a:r>
-            <a:r>
-              <a:rPr lang="en-US" sz="1200" dirty="0">
-                <a:solidFill>
-                  <a:schemeClr val="tx1"/>
-                </a:solidFill>
-              </a:rPr>
-              <a:t>every fix run is worse than its control (PVE +2.6 to +4.9 mm, recall −1.6 to −2.4 points). Each alone is inside pilot noise, but all point the same way.</a:t>
+              <a:t>every fix run is worse than its control: PVE +2.6 to +4.9 mm (inside noise, ~10 mm), recall −1.6 to −2.4 points (about the 2-point noise limit). The five runs share two controls.</a:t>
             </a:r>
             <a:endParaRPr lang="en-US" sz="1200" dirty="0"/>
           </a:p>
@@ -7089,7 +8047,7 @@
                             <a:srgbClr val="1B2233"/>
                           </a:solidFill>
                         </a:rPr>
-                        <a:t>depth slope toward 1, PVE stays near v5 (70.5 mm)</a:t>
+                        <a:t>depth slope toward 1, PVE stays near v5 (70.5 mm)</a:t>
                       </a:r>
                       <a:endParaRPr lang="en-US" sz="1100" dirty="0"/>
                     </a:p>
@@ -7642,7 +8600,7 @@
                             <a:srgbClr val="1B2233"/>
                           </a:solidFill>
                         </a:rPr>
-                        <a:t>11.3° passes, but the controls give 11.7–13.6° (inside the ~3° noise) and the PVE / recall guard fails. Neck bones unchanged (62.5°)</a:t>
+                        <a:t>11.3° passes, but the controls give 11.7–13.6° (inside the ~3° noise). Safety limit (PVE ≤ 71.5 mm, recall ≥ 89.2%) just missed: 71.8 mm, 89.0%. All five control runs miss it too.</a:t>
                       </a:r>
                       <a:endParaRPr lang="en-US" sz="1100" dirty="0"/>
                     </a:p>
@@ -7827,7 +8785,7 @@
                             <a:srgbClr val="1B2233"/>
                           </a:solidFill>
                         </a:rPr>
-                        <a:t>finger error vs rest pose (15.2° in this evaluation)</a:t>
+                        <a:t>finger error vs rest pose (about 15°)</a:t>
                       </a:r>
                       <a:endParaRPr lang="en-US" sz="1100" dirty="0"/>
                     </a:p>
@@ -7948,12 +8906,12 @@
         </p:nvSpPr>
         <p:spPr>
           <a:xfrm>
-            <a:off x="457200" y="3767328"/>
-            <a:ext cx="8229600" cy="896112"/>
+            <a:off x="457200" y="3813048"/>
+            <a:ext cx="8229600" cy="868680"/>
           </a:xfrm>
           <a:prstGeom prst="roundRect">
             <a:avLst>
-              <a:gd name="adj" fmla="val 8163"/>
+              <a:gd name="adj" fmla="val 8421"/>
             </a:avLst>
           </a:prstGeom>
           <a:solidFill>
@@ -7975,8 +8933,8 @@
         </p:nvSpPr>
         <p:spPr>
           <a:xfrm>
-            <a:off x="640080" y="3803904"/>
-            <a:ext cx="7863840" cy="822960"/>
+            <a:off x="640080" y="3840480"/>
+            <a:ext cx="7863840" cy="813816"/>
           </a:xfrm>
           <a:prstGeom prst="rect">
             <a:avLst/>
@@ -8005,7 +8963,7 @@
                   <a:schemeClr val="tx1"/>
                 </a:solidFill>
               </a:rPr>
-              <a:t>No fixed random seed: two identical runs differed by 7.6 mm PVE and 1.9° head error, so one pilot only detects about 10 mm PVE, 3° head error or 2 recall points. Restarting the fine-tune alone costs about 2.4 mm (controls average 72.9 vs 70.5 mm). Root error of the fix runs (0.53–0.73 m vs 1.11–1.44 m for the controls) is far outside this noise. All runs: same holdout and manifest, helper bones masked.</a:t>
+              <a:t>No fixed random seed: two identical runs differed by 7.6 mm PVE and 1.9° head error, so one pilot only detects about 10 mm PVE, 3° head error or 2 recall points. Restarting the fine-tune alone costs about 2.4 mm (controls average 72.9 vs 70.5 mm). Root error has no measured noise floor, but every fix run (0.53–0.73 m) is below every control (1.11–1.44 m). All runs: same holdout and manifest, helper bones masked.</a:t>
             </a:r>
             <a:endParaRPr lang="en-US" sz="1200" dirty="0"/>
           </a:p>
@@ -8161,11 +9119,11 @@
             <a:avLst/>
           </a:prstGeom>
           <a:solidFill>
-            <a:srgbClr val="0E7C86"/>
+            <a:srgbClr val="E8792B"/>
           </a:solidFill>
           <a:ln w="12700">
             <a:solidFill>
-              <a:srgbClr val="0E7C86"/>
+              <a:srgbClr val="E8792B"/>
             </a:solidFill>
             <a:prstDash val="solid"/>
           </a:ln>
@@ -8232,12 +9190,42 @@
               <a:buNone/>
             </a:pPr>
             <a:r>
+              <a:rPr lang="en-US" sz="1200" b="1" dirty="0">
+                <a:solidFill>
+                  <a:srgbClr val="1B2233"/>
+                </a:solidFill>
+              </a:rPr>
+              <a:t>Done: </a:t>
+            </a:r>
+            <a:r>
               <a:rPr lang="en-US" sz="1200" dirty="0">
                 <a:solidFill>
                   <a:schemeClr val="tx2"/>
                 </a:solidFill>
               </a:rPr>
-              <a:t>AnnyOne holdout PVE is 70.5 mm with helper bones masked, as in the demos (V1). The 74.3 mm in the thesis draft is the unmasked evaluation (+3.8 mm paired).</a:t>
+              <a:t>the README gives AnnyOne holdout PVE 70.5 mm, helper bones masked, as in the demos.</a:t>
+            </a:r>
+            <a:endParaRPr lang="en-US" sz="1200" dirty="0"/>
+          </a:p>
+          <a:p>
+            <a:pPr indent="0" marL="0">
+              <a:buNone/>
+            </a:pPr>
+            <a:r>
+              <a:rPr lang="en-US" sz="1200" b="1" dirty="0">
+                <a:solidFill>
+                  <a:srgbClr val="1B2233"/>
+                </a:solidFill>
+              </a:rPr>
+              <a:t>To do: </a:t>
+            </a:r>
+            <a:r>
+              <a:rPr lang="en-US" sz="1200" dirty="0">
+                <a:solidFill>
+                  <a:schemeClr val="tx2"/>
+                </a:solidFill>
+              </a:rPr>
+              <a:t>replace the thesis draft's 74 mm, the unmasked evaluation (+3.8 mm on the same people).</a:t>
             </a:r>
             <a:endParaRPr lang="en-US" sz="1200" dirty="0"/>
           </a:p>
@@ -8356,12 +9344,20 @@
               <a:buNone/>
             </a:pPr>
             <a:r>
+              <a:rPr lang="en-US" sz="1200" b="1" dirty="0">
+                <a:solidFill>
+                  <a:srgbClr val="1B2233"/>
+                </a:solidFill>
+              </a:rPr>
+              <a:t>Done: </a:t>
+            </a:r>
+            <a:r>
               <a:rPr lang="en-US" sz="1200" dirty="0">
                 <a:solidFill>
                   <a:schemeClr val="tx2"/>
                 </a:solidFill>
               </a:rPr>
-              <a:t>All demo scripts zero the fingers and the README says so: finger renders are the rest pose, not predictions.</a:t>
+              <a:t>all demo scripts zero the fingers and the README says so: finger renders are the rest pose, not predictions.</a:t>
             </a:r>
             <a:endParaRPr lang="en-US" sz="1200" dirty="0"/>
           </a:p>
@@ -8480,12 +9476,42 @@
               <a:buNone/>
             </a:pPr>
             <a:r>
+              <a:rPr lang="en-US" sz="1200" b="1" dirty="0">
+                <a:solidFill>
+                  <a:srgbClr val="1B2233"/>
+                </a:solidFill>
+              </a:rPr>
+              <a:t>Done: </a:t>
+            </a:r>
+            <a:r>
               <a:rPr lang="en-US" sz="1200" dirty="0">
                 <a:solidFill>
                   <a:schemeClr val="tx2"/>
                 </a:solidFill>
               </a:rPr>
-              <a:t>Neck, fingers, children: no longer called rig or decoding problems. The README's Known-defects section documents the depth bug. README, findings and handover still carry last week's neck story; I correct them this week.</a:t>
+              <a:t>neck, fingers, children no longer called rig or decoding problems; the README's Known-defects section documents the depth bug.</a:t>
+            </a:r>
+            <a:endParaRPr lang="en-US" sz="1200" dirty="0"/>
+          </a:p>
+          <a:p>
+            <a:pPr indent="0" marL="0">
+              <a:buNone/>
+            </a:pPr>
+            <a:r>
+              <a:rPr lang="en-US" sz="1200" b="1" dirty="0">
+                <a:solidFill>
+                  <a:srgbClr val="1B2233"/>
+                </a:solidFill>
+              </a:rPr>
+              <a:t>To do: </a:t>
+            </a:r>
+            <a:r>
+              <a:rPr lang="en-US" sz="1200" dirty="0">
+                <a:solidFill>
+                  <a:schemeClr val="tx2"/>
+                </a:solidFill>
+              </a:rPr>
+              <a:t>README, findings and handover still carry last week's neck story; I will fix them next week.</a:t>
             </a:r>
             <a:endParaRPr lang="en-US" sz="1200" dirty="0"/>
           </a:p>
@@ -8533,11 +9559,11 @@
             <a:avLst/>
           </a:prstGeom>
           <a:solidFill>
-            <a:srgbClr val="7B8794"/>
+            <a:srgbClr val="3BA55D"/>
           </a:solidFill>
           <a:ln w="12700">
             <a:solidFill>
-              <a:srgbClr val="7B8794"/>
+              <a:srgbClr val="3BA55D"/>
             </a:solidFill>
             <a:prstDash val="solid"/>
           </a:ln>
@@ -8604,12 +9630,20 @@
               <a:buNone/>
             </a:pPr>
             <a:r>
+              <a:rPr lang="en-US" sz="1200" b="1" dirty="0">
+                <a:solidFill>
+                  <a:srgbClr val="1B2233"/>
+                </a:solidFill>
+              </a:rPr>
+              <a:t>Done: </a:t>
+            </a:r>
+            <a:r>
               <a:rPr lang="en-US" sz="1200" dirty="0">
                 <a:solidFill>
                   <a:schemeClr val="tx2"/>
                 </a:solidFill>
               </a:rPr>
-              <a:t>Reorganised, one shared cluster setup, diagnostics and experiments documented so the work can be rerun.</a:t>
+              <a:t>reorganised, one shared cluster setup, diagnostics and experiments documented so the work can be rerun.</a:t>
             </a:r>
             <a:endParaRPr lang="en-US" sz="1200" dirty="0"/>
           </a:p>
@@ -8850,7 +9884,7 @@
                   <a:schemeClr val="tx2"/>
                 </a:solidFill>
               </a:rPr>
-              <a:t>Why stuck at 63° / 90°? Next: error per bone (neck01–03, head, jaw; twist and swing), a neck-skin error, traces of checkpoint 00299 (before masking) and v3 (probably before the boost).</a:t>
+              <a:t>Next: error per bone, split into twist and swing; find when the offset first appeared (earlier checkpoints).</a:t>
             </a:r>
             <a:endParaRPr lang="en-US" sz="1200" dirty="0"/>
           </a:p>
@@ -8947,7 +9981,7 @@
                   <a:schemeClr val="tx1"/>
                 </a:solidFill>
               </a:rPr>
-              <a:t>Depth slope stuck near 0.4</a:t>
+              <a:t>Depth slope stuck at 0.3–0.4</a:t>
             </a:r>
             <a:endParaRPr lang="en-US" sz="1500" dirty="0"/>
           </a:p>
@@ -8983,7 +10017,7 @@
                   <a:schemeClr val="tx2"/>
                 </a:solidFill>
               </a:rPr>
-              <a:t>Why near and far are not separated is unknown. Measure training depths properly (small samples so far: about 2.5–3.2 m) and the fix run's slope on training images (v5: just as low there).</a:t>
+              <a:t>Cause unknown. Next: measure training depths properly, and the fix run's slope on training images.</a:t>
             </a:r>
             <a:endParaRPr lang="en-US" sz="1200" dirty="0"/>
           </a:p>
@@ -9116,7 +10150,7 @@
                   <a:schemeClr val="tx2"/>
                 </a:solidFill>
               </a:rPr>
-              <a:t>Paired PVE on the same people; recall over head-visible people; the fix on 3DPW; root error next to PVE in the thesis. The ×20 10-epoch run: no result yet.</a:t>
+              <a:t>Paired PVE on the same people; recall over people whose head is visible; test the fix on 3DPW. No result yet for the ×20 run at 10 epochs.</a:t>
             </a:r>
             <a:endParaRPr lang="en-US" sz="1200" dirty="0"/>
           </a:p>
@@ -9382,7 +10416,7 @@
                   <a:schemeClr val="tx2"/>
                 </a:solidFill>
               </a:rPr>
-              <a:t>Both models miss them (seen in 4 of 12 rendered images, not yet counted), so the fix did not cause it. Likely a detection problem.</a:t>
+              <a:t>Both models miss them (4 of 12 rendered images), so not caused by the fix. Likely a detection problem; not yet counted.</a:t>
             </a:r>
             <a:endParaRPr lang="en-US" sz="1200" dirty="0"/>
           </a:p>
@@ -9515,7 +10549,7 @@
                   <a:schemeClr val="tx2"/>
                 </a:solidFill>
               </a:rPr>
-              <a:t>One 2-epoch test is not enough. Next: a 10-epoch balanced-sampler run; for fingers, training on larger hand crops. Otherwise both go into the thesis as limitations.</a:t>
+              <a:t>Next: a 10-epoch balanced-sampler run; for fingers, training on larger hand crops. Otherwise: thesis limitations.</a:t>
             </a:r>
             <a:endParaRPr lang="en-US" sz="1200" dirty="0"/>
           </a:p>
@@ -9691,7 +10725,7 @@
                   <a:schemeClr val="bg2"/>
                 </a:solidFill>
               </a:rPr>
-              <a:t>any improvement in neck, fingers or children; good near vs far depth; a fix without cost (likely 3–5 mm PVE and about 2 recall points worse, not yet confirmed).</a:t>
+              <a:t>any improvement in neck, fingers or children; correct depths for both near and far people; a fix without cost (likely 2.6–4.9 mm PVE and 1.6–2.4 recall points worse, not yet confirmed).</a:t>
             </a:r>
             <a:endParaRPr lang="en-US" sz="1700" dirty="0"/>
           </a:p>
@@ -9794,7 +10828,7 @@
                   <a:srgbClr val="EEF2F7"/>
                 </a:solidFill>
               </a:rPr>
-              <a:t>Fine-tune v9 (best on 3DPW) with the fixed targets and depth ×5? Expected from v5: drawn size about 0.84, root error about 0.5 m; likely cost 3–5 mm PVE and 2 recall points. v9 keeps the stuck neck; v10 is the alternative.</a:t>
+              <a:t>Fine-tune v9 (best on 3DPW) with the fixed targets and depth ×5? From v5 (×5, 10 epochs): drawn size 0.84, root error 0.54 m, at +2.6 mm PVE and −1.6 recall points vs its control. v9 keeps the stuck neck; v10 learns the neck but has worse shoulders and arms.</a:t>
             </a:r>
             <a:endParaRPr lang="en-US" sz="1600" dirty="0"/>
           </a:p>
@@ -9959,7 +10993,7 @@
             <a:r>
               <a:rPr lang="en-US" sz="1100" dirty="0">
                 <a:solidFill>
-                  <a:schemeClr val="tx2"/>
+                  <a:schemeClr val="tx1"/>
                 </a:solidFill>
               </a:rPr>
               <a:t>Synthetic holdout image 579860. Predictions use the model's own depth.</a:t>
@@ -10034,7 +11068,7 @@
                   <a:schemeClr val="tx1"/>
                 </a:solidFill>
               </a:rPr>
-              <a:t>Fix + depth loss ×5, 10 epochs: mesh height close to the truth (slightly larger)</a:t>
+              <a:t>Fix + depth ×5, 10 epochs: head level with the truth; mesh cut off at the image edge</a:t>
             </a:r>
             <a:endParaRPr lang="en-US" sz="1100" dirty="0"/>
           </a:p>
@@ -10048,8 +11082,8 @@
         </p:nvSpPr>
         <p:spPr>
           <a:xfrm>
-            <a:off x="640080" y="4218997"/>
-            <a:ext cx="7863840" cy="365760"/>
+            <a:off x="914400" y="4218997"/>
+            <a:ext cx="7315200" cy="365760"/>
           </a:xfrm>
           <a:prstGeom prst="rect">
             <a:avLst/>
@@ -10078,7 +11112,7 @@
                   <a:schemeClr val="tx2"/>
                 </a:solidFill>
               </a:rPr>
-              <a:t>here the fixed mesh is a little larger and wider than the ground truth. The two people in front have no ground-truth mesh either, so they are not counted as misses. Colours follow detection order.</a:t>
+              <a:t>here the fixed mesh is a little larger and wider than the ground truth. The two people in front have no ground-truth mesh, so they are not counted as misses.</a:t>
             </a:r>
             <a:endParaRPr lang="en-US" sz="1100" dirty="0"/>
           </a:p>
@@ -10470,7 +11504,7 @@
                   <a:schemeClr val="tx2"/>
                 </a:solidFill>
               </a:rPr>
-              <a:t>test-time zoom and a new loss weighting did not help.</a:t>
+              <a:t>test-time zoom and a loss rebalance did not help.</a:t>
             </a:r>
             <a:endParaRPr lang="en-US" sz="1300" dirty="0"/>
           </a:p>
@@ -12346,7 +13380,7 @@
       </p:sp>
       <p:sp>
         <p:nvSpPr>
-          <p:cNvPr id="5" name="stat neck bones / head + jaw, rotation vs parent bone: v5, v9, all pilots (±1.5° per person)"/>
+          <p:cNvPr id="5" name="stat neck bones / head + jaw vs parent bone (v5, v9, all pilots); in v5 the same for every person (±1.5°)"/>
           <p:cNvSpPr txBox="1"/>
           <p:nvPr/>
         </p:nvSpPr>
@@ -12382,7 +13416,7 @@
       </p:sp>
       <p:sp>
         <p:nvSpPr>
-          <p:cNvPr id="6" name="label neck bones / head + jaw, rotation vs parent bone: v5, v9, all pilots (±1.5° per person)"/>
+          <p:cNvPr id="6" name="label neck bones / head + jaw vs parent bone (v5, v9, all pilots); in v5 the same for every person (±1.5°)"/>
           <p:cNvSpPr txBox="1"/>
           <p:nvPr/>
         </p:nvSpPr>
@@ -12410,7 +13444,7 @@
                   <a:schemeClr val="tx2"/>
                 </a:solidFill>
               </a:rPr>
-              <a:t>neck bones / head + jaw, rotation vs parent bone: v5, v9, all pilots (±1.5° per person)</a:t>
+              <a:t>neck bones / head + jaw vs parent bone (v5, v9, all pilots); in v5 the same for every person (±1.5°)</a:t>
             </a:r>
             <a:endParaRPr lang="en-US" sz="1300" dirty="0"/>
           </a:p>
@@ -12418,7 +13452,7 @@
       </p:sp>
       <p:sp>
         <p:nvSpPr>
-          <p:cNvPr id="7" name="stat v10, same bones; but holdout PVE 74.1 vs 70.5 mm, shoulders 50°, arms 36°"/>
+          <p:cNvPr id="7" name="stat v10 learns them, but is worse elsewhere (v10 vs v5): PVE 74.1 vs 70.5 mm, shoulders 50° vs 11°"/>
           <p:cNvSpPr txBox="1"/>
           <p:nvPr/>
         </p:nvSpPr>
@@ -12454,7 +13488,7 @@
       </p:sp>
       <p:sp>
         <p:nvSpPr>
-          <p:cNvPr id="8" name="label v10, same bones; but holdout PVE 74.1 vs 70.5 mm, shoulders 50°, arms 36°"/>
+          <p:cNvPr id="8" name="label v10 learns them, but is worse elsewhere (v10 vs v5): PVE 74.1 vs 70.5 mm, shoulders 50° vs 11°"/>
           <p:cNvSpPr txBox="1"/>
           <p:nvPr/>
         </p:nvSpPr>
@@ -12482,7 +13516,7 @@
                   <a:schemeClr val="tx2"/>
                 </a:solidFill>
               </a:rPr>
-              <a:t>v10, same bones; but holdout PVE 74.1 vs 70.5 mm, shoulders 50°, arms 36°</a:t>
+              <a:t>v10 learns them, but is worse elsewhere (v10 vs v5): PVE 74.1 vs 70.5 mm, shoulders 50° vs 11°</a:t>
             </a:r>
             <a:endParaRPr lang="en-US" sz="1300" dirty="0"/>
           </a:p>
@@ -12549,7 +13583,7 @@
                   <a:schemeClr val="tx1"/>
                 </a:solidFill>
               </a:rPr>
-              <a:t>v10 learns these bones with the same loss: </a:t>
+              <a:t>v10 learns these bones with the same loss function: </a:t>
             </a:r>
             <a:r>
               <a:rPr lang="en-US" sz="1200" dirty="0">
@@ -12557,7 +13591,7 @@
                   <a:schemeClr val="tx1"/>
                 </a:solidFill>
               </a:rPr>
-              <a:t>it used the final recipe from the start (masked, no boost, 3DPW); v5 went through a frozen-backbone stage first.</a:t>
+              <a:t>it was trained masked from the start, with no ×4 neck boost and with 3DPW. v5 started from a frozen backbone; masking and the ×4 boost were added later.</a:t>
             </a:r>
             <a:endParaRPr lang="en-US" sz="1200" dirty="0"/>
           </a:p>
@@ -12583,7 +13617,7 @@
                   <a:schemeClr val="tx1"/>
                 </a:solidFill>
               </a:rPr>
-              <a:t>150,000 more steps in v9 changed nothing, nor did a pilot that gave head and neck a third of the rotation loss. Head direction: 12° off on the holdout.</a:t>
+              <a:t>150,000 more steps in v9 changed nothing, nor did a pilot that gave head and neck a third of the rotation loss. Yet the whole head still points only 12° off (holdout).</a:t>
             </a:r>
             <a:endParaRPr lang="en-US" sz="1200" dirty="0"/>
           </a:p>
@@ -12601,7 +13635,7 @@
                   <a:schemeClr val="tx1"/>
                 </a:solidFill>
               </a:rPr>
-              <a:t>Not the depth bug: </a:t>
+              <a:t>Cause unknown. Best guess, not tested: </a:t>
             </a:r>
             <a:r>
               <a:rPr lang="en-US" sz="1200" dirty="0">
@@ -12609,7 +13643,7 @@
                   <a:schemeClr val="tx1"/>
                 </a:solidFill>
               </a:rPr>
-              <a:t>the neck montage and real-photo demos place each body from its detection box (--anchor_to_box 1).</a:t>
+              <a:t>the loss compares rotation matrices number by number and can stick near a 180° flip (one of 3 neck bones flipped: mean near 63°; head or jaw flipped: near 90°).</a:t>
             </a:r>
             <a:endParaRPr lang="en-US" sz="1200" dirty="0"/>
           </a:p>
@@ -12627,7 +13661,7 @@
                   <a:schemeClr val="tx1"/>
                 </a:solidFill>
               </a:rPr>
-              <a:t>Cause unknown. Best guess, not tested: </a:t>
+              <a:t>Not yet shown </a:t>
             </a:r>
             <a:r>
               <a:rPr lang="en-US" sz="1200" dirty="0">
@@ -12635,33 +13669,7 @@
                   <a:schemeClr val="tx1"/>
                 </a:solidFill>
               </a:rPr>
-              <a:t>the loss compares rotation matrices number by number and can stick near a 180° flip (one of 3 neck bones flipped: mean near 63°; head or jaw flipped: near 90°).</a:t>
-            </a:r>
-            <a:endParaRPr lang="en-US" sz="1200" dirty="0"/>
-          </a:p>
-          <a:p>
-            <a:pPr marL="177800" indent="-177800">
-              <a:spcAft>
-                <a:spcPts val="300"/>
-              </a:spcAft>
-              <a:buSzPct val="100000"/>
-              <a:buChar char="•"/>
-            </a:pPr>
-            <a:r>
-              <a:rPr lang="en-US" sz="1200" b="1" dirty="0">
-                <a:solidFill>
-                  <a:schemeClr val="tx1"/>
-                </a:solidFill>
-              </a:rPr>
-              <a:t>Not yet shown </a:t>
-            </a:r>
-            <a:r>
-              <a:rPr lang="en-US" sz="1200" dirty="0">
-                <a:solidFill>
-                  <a:schemeClr val="tx1"/>
-                </a:solidFill>
-              </a:rPr>
-              <a:t>that this offset makes necks look wrong; PVE_hn cannot tell (91% of its vertices are on the head).</a:t>
+              <a:t>that this offset makes necks look wrong. Not the depth bug: the neck montage and the real-photo demos place each body from its detection box.</a:t>
             </a:r>
             <a:endParaRPr lang="en-US" sz="1200" dirty="0"/>
           </a:p>
@@ -12769,7 +13777,7 @@
                   <a:schemeClr val="tx1"/>
                 </a:solidFill>
               </a:rPr>
-              <a:t>Fingers: test-time zoom and a new loss do not help</a:t>
+              <a:t>Fingers: test-time zoom and a loss rebalance do not help</a:t>
             </a:r>
             <a:endParaRPr lang="en-US" sz="2700" dirty="0"/>
           </a:p>
@@ -13588,7 +14596,7 @@
                             <a:srgbClr val="1B2233"/>
                           </a:solidFill>
                         </a:rPr>
-                        <a:t>children's hands</a:t>
+                        <a:t>children's hands, full image</a:t>
                       </a:r>
                       <a:endParaRPr lang="en-US" sz="1200" dirty="0"/>
                     </a:p>
@@ -13820,6 +14828,9 @@
           <a:lstStyle/>
           <a:p>
             <a:pPr indent="0" marL="0">
+              <a:spcAft>
+                <a:spcPts val="600"/>
+              </a:spcAft>
               <a:buNone/>
             </a:pPr>
             <a:r>
@@ -13828,7 +14839,7 @@
                   <a:schemeClr val="tx1"/>
                 </a:solidFill>
               </a:rPr>
-              <a:t>Reading. </a:t>
+              <a:t>What it means: </a:t>
             </a:r>
             <a:r>
               <a:rPr lang="en-US" sz="1200" dirty="0">
@@ -13836,7 +14847,54 @@
                   <a:schemeClr val="tx1"/>
                 </a:solidFill>
               </a:rPr>
-              <a:t>Predicting fingers is worse than not predicting them. Test-time zoom, no retraining: 17.2° vs 17.3°, while body error nearly doubles on these crops. A loss that cut the hands' share of the rotation loss from about 70% (with the ×4 hand boost; 40% without) to 33%: 17.5° vs 17.4° for its control. Not tested: a model trained on larger hands.</a:t>
+              <a:t>predicting fingers is worse than leaving them at rest.</a:t>
+            </a:r>
+            <a:endParaRPr lang="en-US" sz="1200" dirty="0"/>
+          </a:p>
+          <a:p>
+            <a:pPr indent="0" marL="0">
+              <a:spcAft>
+                <a:spcPts val="600"/>
+              </a:spcAft>
+              <a:buNone/>
+            </a:pPr>
+            <a:r>
+              <a:rPr lang="en-US" sz="1200" b="1" dirty="0">
+                <a:solidFill>
+                  <a:schemeClr val="tx1"/>
+                </a:solidFill>
+              </a:rPr>
+              <a:t>Test-time zoom: </a:t>
+            </a:r>
+            <a:r>
+              <a:rPr lang="en-US" sz="1200" dirty="0">
+                <a:solidFill>
+                  <a:schemeClr val="tx1"/>
+                </a:solidFill>
+              </a:rPr>
+              <a:t>17.2° vs 17.3°; body error nearly doubles.</a:t>
+            </a:r>
+            <a:endParaRPr lang="en-US" sz="1200" dirty="0"/>
+          </a:p>
+          <a:p>
+            <a:pPr indent="0" marL="0">
+              <a:buNone/>
+            </a:pPr>
+            <a:r>
+              <a:rPr lang="en-US" sz="1200" b="1" dirty="0">
+                <a:solidFill>
+                  <a:schemeClr val="tx1"/>
+                </a:solidFill>
+              </a:rPr>
+              <a:t>Loss rebalance </a:t>
+            </a:r>
+            <a:r>
+              <a:rPr lang="en-US" sz="1200" dirty="0">
+                <a:solidFill>
+                  <a:schemeClr val="tx1"/>
+                </a:solidFill>
+              </a:rPr>
+              <a:t>(hands 33% of the rotation loss): 17.5° vs 17.4°. It gave fingers less weight; more weight and training on larger hand crops are still untested.</a:t>
             </a:r>
             <a:endParaRPr lang="en-US" sz="1200" dirty="0"/>
           </a:p>
@@ -14096,7 +15154,7 @@
       </p:sp>
       <p:sp>
         <p:nvSpPr>
-          <p:cNvPr id="7" name="stat predicted age of 5 small people in real photos, both arms: adult range"/>
+          <p:cNvPr id="7" name="stat predicted age of 5 small people in real photos (sampler and control runs): same as the holdout adults"/>
           <p:cNvSpPr txBox="1"/>
           <p:nvPr/>
         </p:nvSpPr>
@@ -14132,7 +15190,7 @@
       </p:sp>
       <p:sp>
         <p:nvSpPr>
-          <p:cNvPr id="8" name="label predicted age of 5 small people in real photos, both arms: adult range"/>
+          <p:cNvPr id="8" name="label predicted age of 5 small people in real photos (sampler and control runs): same as the holdout adults"/>
           <p:cNvSpPr txBox="1"/>
           <p:nvPr/>
         </p:nvSpPr>
@@ -14160,7 +15218,7 @@
                   <a:schemeClr val="tx2"/>
                 </a:solidFill>
               </a:rPr>
-              <a:t>predicted age of 5 small people in real photos, both arms: adult range</a:t>
+              <a:t>predicted age of 5 small people in real photos (sampler and control runs): same as the holdout adults</a:t>
             </a:r>
             <a:endParaRPr lang="en-US" sz="1300" dirty="0"/>
           </a:p>
@@ -14313,7 +15371,7 @@
                   <a:schemeClr val="tx1"/>
                 </a:solidFill>
               </a:rPr>
-              <a:t>every synthetic child number is in-sample; the holdout has no children. Years, if Anny's default age scale holds (not yet checked): 0 = 1 y, 0.33 = 11 y, 0.67 = 25 y.</a:t>
+              <a:t>every synthetic child number is in-sample; the holdout has no children. Ages are Anny's 0–1 value (holdout adults: mostly 0.4–0.8). Ages are not converted to years, because Anny's calibration and the labels in our code disagree.</a:t>
             </a:r>
             <a:endParaRPr lang="en-US" sz="1200" dirty="0"/>
           </a:p>
@@ -14877,13 +15935,27 @@
           <a:ln/>
         </p:spPr>
         <p:txBody>
-          <a:bodyPr wrap="square" lIns="0" tIns="0" rIns="0" bIns="0" rtlCol="0" anchor="ctr"/>
+          <a:bodyPr wrap="square" lIns="0" tIns="0" rIns="0" bIns="0" rtlCol="0" anchor="t"/>
           <a:lstStyle/>
           <a:p>
             <a:pPr indent="0" marL="0">
               <a:buNone/>
             </a:pPr>
             <a:r>
+              <a:rPr lang="en-US" sz="1600" b="1" dirty="0">
+                <a:solidFill>
+                  <a:schemeClr val="accent4"/>
+                </a:solidFill>
+              </a:rPr>
+              <a:t>predicted depth =</a:t>
+            </a:r>
+            <a:endParaRPr lang="en-US" sz="1600" dirty="0"/>
+          </a:p>
+          <a:p>
+            <a:pPr indent="0" marL="0">
+              <a:buNone/>
+            </a:pPr>
+            <a:r>
               <a:rPr lang="en-US" sz="2400" b="1" dirty="0">
                 <a:solidFill>
                   <a:schemeClr val="accent4"/>
@@ -14891,7 +15963,7 @@
               </a:rPr>
               <a:t>0.33 × true + 2.36 m</a:t>
             </a:r>
-            <a:endParaRPr lang="en-US" sz="2400" dirty="0"/>
+            <a:endParaRPr lang="en-US" sz="1600" dirty="0"/>
           </a:p>
         </p:txBody>
       </p:sp>
@@ -14973,7 +16045,7 @@
                   <a:schemeClr val="tx1"/>
                 </a:solidFill>
               </a:rPr>
-              <a:t>targets at the head make the bodies much closer to the right size; a same-schedule control does not improve (10 epochs: size 0.59, root error 1.44 m).</a:t>
+              <a:t>with targets at the head, bodies are drawn much closer to the right size; a same-schedule control does not improve (10 epochs: size 0.59, root error 1.44 m).</a:t>
             </a:r>
             <a:endParaRPr lang="en-US" sz="1200" dirty="0"/>
           </a:p>
@@ -15190,7 +16262,7 @@
             <a:r>
               <a:rPr lang="en-US" sz="1100" dirty="0">
                 <a:solidFill>
-                  <a:schemeClr val="tx2"/>
+                  <a:schemeClr val="tx1"/>
                 </a:solidFill>
               </a:rPr>
               <a:t>Synthetic holdout image 579862, model's own depth (no box placement).</a:t>
@@ -15279,8 +16351,8 @@
         </p:nvSpPr>
         <p:spPr>
           <a:xfrm>
-            <a:off x="640080" y="4218997"/>
-            <a:ext cx="7863840" cy="512064"/>
+            <a:off x="914400" y="4218997"/>
+            <a:ext cx="7315200" cy="512064"/>
           </a:xfrm>
           <a:prstGeom prst="rect">
             <a:avLst/>
@@ -15309,7 +16381,7 @@
                   <a:schemeClr val="tx2"/>
                 </a:solidFill>
               </a:rPr>
-              <a:t>near and far people still get similar depths (depth slope 0.38; 1 = perfect, 0 = same depth for everyone), and bodies are still drawn about 16% too small (median). All 12 rendered images show the same change; this one has no missed ground-truth person. Blue mesh: 0.95 of true height. Colours follow detection order.</a:t>
+              <a:t>near and far people still get similar depths (depth slope 0.38; 1 = perfect, 0 = same depth for everyone), and bodies are still drawn about 16% too small (median). All 12 rendered images show the same change; I picked this one because no ground-truth person is missed. After the fix the blue mesh is 0.95 of its true height (before: 0.76).</a:t>
             </a:r>
             <a:endParaRPr lang="en-US" sz="1100" dirty="0"/>
           </a:p>

</xml_diff>

<commit_message>
WIP bone fix: output-level correction for half-turn-flipped bones and exp6 (under review, not for main yet)
Co-Authored-By: Claude Opus 5.5 <noreply@anthropic.com>
Claude-Session: https://claude.ai/code/session_016LhpG4kT7Z7ppxbG4TW5S9
</commit_message>
<xml_diff>
--- a/docs/supervisor_update_2026-10-16.pptx
+++ b/docs/supervisor_update_2026-10-16.pptx
@@ -123,7 +123,7 @@
   <p:extLst>
     <p:ext uri="{521415D9-36F7-43E2-AB2F-B90AF26B5E84}">
       <p14:sectionLst xmlns:p14="http://schemas.microsoft.com/office/powerpoint/2010/main">
-        <p14:section name="Overview" id="{82d9f2dc-1f40-31f4-fe0f-3858cb35e600}">
+        <p14:section name="Overview" id="{bf8bf7df-a7e6-9808-df0f-e3a1d4ef6799}">
           <p14:sldIdLst>
             <p14:sldId id="256"/>
             <p14:sldId id="257"/>
@@ -131,27 +131,27 @@
             <p14:sldId id="259"/>
           </p14:sldIdLst>
         </p14:section>
-        <p14:section name="3DPW labels" id="{92566cdc-5c96-0bf6-fec6-6d97dea00ae5}">
+        <p14:section name="3DPW labels" id="{9c37fc90-15f6-713b-a76e-202b6b4366e1}">
           <p14:sldIdLst>
             <p14:sldId id="260"/>
             <p14:sldId id="261"/>
           </p14:sldIdLst>
         </p14:section>
-        <p14:section name="Findings" id="{f9b14e5b-aeca-5545-f14f-86f56993afb9}">
+        <p14:section name="Findings" id="{cb4013ab-fd32-de11-a9d7-0da37f05f38b}">
           <p14:sldIdLst>
             <p14:sldId id="262"/>
             <p14:sldId id="263"/>
             <p14:sldId id="264"/>
           </p14:sldIdLst>
         </p14:section>
-        <p14:section name="Bug" id="{92b552b3-513d-988a-42e7-8d30c6589a9d}">
+        <p14:section name="Bug" id="{8de466eb-45b4-5317-c665-c8cdc16e0f75}">
           <p14:sldIdLst>
             <p14:sldId id="265"/>
             <p14:sldId id="266"/>
             <p14:sldId id="267"/>
           </p14:sldIdLst>
         </p14:section>
-        <p14:section name="Next" id="{66939039-31d8-1b90-47f2-7dd066311519}">
+        <p14:section name="Next" id="{123c569b-bad0-d1f9-ba91-caa9f6ee7ba1}">
           <p14:sldIdLst>
             <p14:sldId id="268"/>
             <p14:sldId id="269"/>
@@ -159,7 +159,7 @@
             <p14:sldId id="271"/>
           </p14:sldIdLst>
         </p14:section>
-        <p14:section name="Appendix" id="{4616c31b-08d5-5eae-0d63-5b9cba389084}">
+        <p14:section name="Appendix" id="{162fc2a4-22f6-d510-6a47-7638894a04f0}">
           <p14:sldIdLst>
             <p14:sldId id="272"/>
           </p14:sldIdLst>
@@ -568,7 +568,7 @@
           <a:p>
             <a:r>
               <a:rPr lang="en-US" dirty="0"/>
-              <a:t>Since last Friday I measured each stage of the pipeline separately. I will show what is not the cause, how the 3DPW labels are made and two bugs I found in them, what I measured about the neck, the fingers and the children, one depth bug nobody was looking for and its fix, and what is still open. I will say clearly what is measured and what is only a guess.</a:t>
+              <a:t>Since last Friday I measured each stage of the pipeline separately. I will show what is not the cause, how the 3DPW labels are made and two bugs I found in them, what I found in the neck and measured about the fingers and the children, one depth bug nobody was looking for and its fix, and what is still open. I will say clearly what is measured and what is only a guess.</a:t>
             </a:r>
             <a:endParaRPr lang="en-US" dirty="0"/>
           </a:p>
@@ -1096,7 +1096,7 @@
           <a:p>
             <a:r>
               <a:rPr lang="en-US" dirty="0"/>
-              <a:t>Seven things are still open. First, the neck: the error of each neck bone, split into twist and swing, an error on the neck skin only, and traces of checkpoint 299 and of v3, to see when the offset appeared. Second, the depth slope, stuck at 0.3 to 0.4: why near and far are not separated is unknown. The training depths so far come from small samples, batch means of about 2.5 to 3.2 metres, so I will measure them properly, and measure the fix run's slope on training images; for v5 it was just as low there. Third, the cost of the fix: paired PVE on the same people, recall over people whose head is visible, and the root error next to PVE in the thesis. Testing the fix on 3DPW waits for item seven. The twenty-times 10-epoch run has no result yet. Fourth, pilot noise: fix the seed or repeat the key run. Fifth, people very close to the camera: both models miss them in 4 of the 12 rendered images; likely a detection problem, not yet counted. Sixth, children and fingers: one 2-epoch test is not enough to close them. Next is a 10-epoch balanced-sampler run, and for the fingers training on larger hand crops. If those show nothing too, both go into the thesis as limitations. Seventh, the 3DPW labels from slide 6: set men to 0 and women to 1, and pick both people's frames on one shared grid. Both happen inside the fit, so all 87 conversion tasks must be fitted again, not only the 11 missing ones, and into a new folder, because the task script skips every person that already has a file; otherwise old and new fits would mix without a warning. That is an 87-task array job: about 40 GPU hours by the task script's own estimate of 6 seconds per frame, so 5 to 6 hours with 8 GPUs at once; not measured. Then rebuild the labels and run the new check. Only after that should I test the depth fix on 3DPW or fine-tune on it.</a:t>
+              <a:t>Seven things are still open. First, the neck: the per-bone check is done, on slide 7, but nothing is fixed. Next is exp6: turn the flipped bones back with a fixed correction at the network output, tested with no training at all. If the neck skin then gets its thickness back, I will render it to check that the thin neck is what we saw in the overlays. Second, the depth slope, stuck at 0.3 to 0.4: why near and far are not separated is unknown. The training depths so far come from small samples, batch means of about 2.5 to 3.2 metres, so I will measure them properly, and measure the fix run's slope on training images; for v5 it was just as low there. Third, the cost of the fix: paired PVE on the same people, recall over people whose head is visible, and the root error next to PVE in the thesis. Testing the fix on 3DPW waits for item seven. The twenty-times 10-epoch run has no result yet. Fourth, pilot noise: fix the seed or repeat the key run. Fifth, people very close to the camera: both models miss them in 4 of the 12 rendered images; likely a detection problem, not yet counted. Sixth, children and fingers: one 2-epoch test is not enough to close them. Next is a 10-epoch balanced-sampler run, and for the fingers training on larger hand crops. If those show nothing too, both go into the thesis as limitations. Seventh, the 3DPW labels from slide 6: set men to 0 and women to 1, and pick both people's frames on one shared grid. Both happen inside the fit, so all 87 conversion tasks must be fitted again, not only the 11 missing ones, and into a new folder, because the task script skips every person that already has a file; otherwise old and new fits would mix without a warning. That is an 87-task array job: about 40 GPU hours by the task script's own estimate of 6 seconds per frame, so 5 to 6 hours with 8 GPUs at once; not measured. Then rebuild the labels and run the new check. Only after that should I test the depth fix on 3DPW or fine-tune on it.</a:t>
             </a:r>
             <a:endParaRPr lang="en-US" dirty="0"/>
           </a:p>
@@ -1184,7 +1184,7 @@
           <a:p>
             <a:r>
               <a:rPr lang="en-US" dirty="0"/>
-              <a:t>What is measured: the failures are not rig or decoding problems. A training-target bug puts people too far away in v5, v9 and v10; in v5 it is all 222 holdout people. The depth fix draws the bodies much closer to their true size, but near and far are still not separated well, and it likely has a cost: every fix run is worse than its control, by 2.6 to 4.9 millimetres PVE and 1.6 to 2.4 recall points. The PVE gaps are inside pilot noise, the recall drops are at the edge of what one pilot can detect, and the five runs share two controls, but all point the same way. Separately, the 3DPW labels have the two bugs from slide 6: the two-person problem is counted from the label files, the reversed gender is read in the code and seen in v2.1 renders. I do not claim any improvement in the neck, the fingers or the children, and I do not claim an accuracy for the 3DPW labels: nobody has summarised the saved fit error or compared the labels with the SMPL meshes. My question: should I fine-tune v9 with the corrected targets and the depth loss five times stronger, before the thesis numbers are final? That is about one hour of training. From v5 I expect a drawn size of about 0.84 and a root error of about half a metre; on v5 that run cost 2.6 millimetres PVE and 1.6 recall points against its control. Five, not twenty, because the twenty-times 10-epoch run has no result yet. v9 is best on our 3DPW-Anny labels, but those labels have the gender bug and the two-person bug, so that score is not a clean measure. The other option is to fix the labels first: men to 0, one shared frame grid, re-fit all 87 conversion tasks into a new folder, rebuild the labels, then fine-tune. Rebuilding the labels alone is not enough, because the gender and the frame choice are fixed inside the fit; the re-fit is an 87-task array job, about 40 GPU hours by the script's own estimate. I think the 3DPW labels should be re-fitted with the corrected gender before any fine-tune that mixes in 3DPW; otherwise the fine-tune keeps learning the wrong body. A v9 fine-tune keeps the stuck neck; v10 learns the neck but has worse shoulders and arms. Either fine-tune should also mask the 3DPW finger labels, which are set to the rest pose, with mask_3dpw_hands. The ViT-S students use the same training code and are probably affected too; not measured. On the AnnyOne holdout v9 is not the best: 77.0 against 70.5.</a:t>
+              <a:t>What is measured: the failures are not rig or decoding problems. A training-target bug puts people too far away in v5, v9 and v10; in v5 it is all 222 holdout people. The depth fix draws the bodies much closer to their true size, but near and far are still not separated well, and it likely has a cost: every fix run is worse than its control, by 2.6 to 4.9 millimetres PVE and 1.6 to 2.4 recall points. The PVE gaps are inside pilot noise, the recall drops are at the edge of what one pilot can detect, and the five runs share two controls, but all point the same way. Separately, the 3DPW labels have the two bugs from slide 6: the two-person problem is counted from the label files, the reversed gender is read in the code and seen in v2.1 renders. Also measured now: in all eight v5-line checkpoints I traced, neck02 and the head bone sit half a turn off; they cancel, so the head points the right way, but the neck skin is about half as thick. I do not claim a fix for it: a 2-epoch fine-tune did not undo it. Its origin is not known; the singular start value of the rotation output would start a bone turned about its sideways axis, a tilt like the one in v5's left index base, not the twist in neck02 and the head. I do not claim any improvement in the fingers or the children, and I do not claim an accuracy for the 3DPW labels: nobody has summarised the saved fit error or compared the labels with the SMPL meshes. My question: should I fine-tune v9 with the corrected targets and the depth loss five times stronger, before the thesis numbers are final? That is about one hour of training. From v5 I expect a drawn size of about 0.84 and a root error of about half a metre; on v5 that run cost 2.6 millimetres PVE and 1.6 recall points against its control. Five, not twenty, because the twenty-times 10-epoch run has no result yet. v9 is best on our 3DPW-Anny labels, but those labels have the gender bug and the two-person bug, so that score is not a clean measure. The other option is to fix the labels first: men to 0, one shared frame grid, re-fit all 87 conversion tasks into a new folder, rebuild the labels, then fine-tune. Rebuilding the labels alone is not enough, because the gender and the frame choice are fixed inside the fit; the re-fit is an 87-task array job, about 40 GPU hours by the script's own estimate. I think the 3DPW labels should be re-fitted with the corrected gender before any fine-tune that mixes in 3DPW; otherwise the fine-tune keeps learning the wrong body. A v9 fine-tune keeps the neck flip; v10 has no neck flip, but the same kind of flip in the left shoulder and upper arm, which is most of why its shoulders and arms are worse. Either fine-tune should also mask the 3DPW finger labels, which are set to the rest pose, with mask_3dpw_hands. The ViT-S students use the same training code and are probably affected too; not measured. On the AnnyOne holdout v9 is not the best: 77.0 against 70.5.</a:t>
             </a:r>
             <a:endParaRPr lang="en-US" dirty="0"/>
           </a:p>
@@ -1360,7 +1360,7 @@
           <a:p>
             <a:r>
               <a:rPr lang="en-US" dirty="0"/>
-              <a:t>These are the three failures we discussed last time. Until this week they were explained by guesses: a rig problem, too few pixels on the hands, or a shape head that does not learn age. None of these guesses had been tested on its own. That is what I did first. The last line on each card is what this week showed; the details follow. For the neck, I found a fixed rotation error in the v5 models, but I have not yet shown that it causes the look.</a:t>
+              <a:t>These are the three failures we discussed last time. Until this week they were explained by guesses: a rig problem, too few pixels on the hands, or a shape head that does not learn age. None of these guesses had been tested on its own. That is what I did first. The last line on each card is what this week showed; the details follow. For the neck, I found that two bones in the v5 models, neck02 and the head bone, are turned half a turn, and the neck skin comes out about half as thick; I have not yet rendered it to check that this is the look we saw.</a:t>
             </a:r>
             <a:endParaRPr lang="en-US" dirty="0"/>
           </a:p>
@@ -1536,7 +1536,7 @@
           <a:p>
             <a:r>
               <a:rPr lang="en-US" dirty="0"/>
-              <a:t>This slide changes the story. The rig, the decoding and the body model are correct, and gradients reach every bone and every shape output. The one exception: two of the three camera outputs are unused and get no gradient. The overfit test shows the optimiser works for shape and 3D joints: on 40 training images the error falls by 36 percent. It has two warnings. First, even while the images were memorised, the translation loss and the 2D losses went up, from 1.67 to 1.89 and from 58 to 75. The network could not satisfy the position targets and the 2D projection at the same time. That was probably the first sign of the depth bug on slide 10; I have not repeated the overfit test with the fix. Second, the rotation loss barely moved, from 44.6 to 40.8. That is a sum over all 75 bones, so it does not isolate the neck; it may be related to the stuck neck on slide 7, but that is a guess. So the three failures are not rig or decoding problems, which is how the thesis described them until now, but training can still get stuck. One caveat on the ground-truth check: people who fill the frame lose joints at the image border. That is truncation, not a decoding error. This check covered the AnnyOne labels only; the 3DPW labels come on the next two slides.</a:t>
+              <a:t>This slide changes the story. The rig, the decoding and the body model are correct, and gradients reach every bone and every shape output. The one exception: two of the three camera outputs are unused and get no gradient. The overfit test shows the optimiser works for shape and 3D joints: on 40 training images the error falls by 36 percent. It has two warnings. First, even while the images were memorised, the translation loss and the 2D losses went up, from 1.67 to 1.89 and from 58 to 75. The network could not satisfy the position targets and the 2D projection at the same time. That was probably the first sign of the depth bug on slide 10; I have not repeated the overfit test with the fix. Second, the rotation loss barely moved, from 44.6 to 40.8. That is a sum over all 75 bones, so it does not isolate the neck; it may be related to the neck flip on slide 7, but that is a guess. So the three failures are not rig or decoding problems, which is how the thesis described them until now, but training can still get stuck. One caveat on the ground-truth check: people who fill the frame lose joints at the image border. That is truncation, not a decoding error. This check covered the AnnyOne labels only; the 3DPW labels come on the next two slides.</a:t>
             </a:r>
             <a:endParaRPr lang="en-US" dirty="0"/>
           </a:p>
@@ -1800,7 +1800,7 @@
           <a:p>
             <a:r>
               <a:rPr lang="en-US" dirty="0"/>
-              <a:t>The neck length is right, 99 percent of the truth, and with the true shape it is exact. The problem is the rotation of each neck bone relative to its parent. In v5, v9 and all six pilot runs, the three neck bones are on average 63 degrees off, head and jaw 90. In v5 that is the same for every person, within about 1.5 degrees: a fixed offset, not noise. 150 thousand more steps in v9 did not change it, and neither did a pilot that gave head and neck a third of the rotation loss. v10 gets these bones right, 5 and 4 degrees, so the loss can teach the neck, but v10 is worse elsewhere. Its history differs: v10 was trained with the helper bones masked from the start, with no four-times neck boost and with 3DPW. v5 first trained on a frozen backbone with the helper bones unmasked; masking and the neck boost came later. The head points 12 degrees off on the holdout, 8.6 on the held-out test cases and about 20 on the 40 training test cases. I do not know the cause. My guess: the loss compares rotation matrices number by number and can stick near a 180-degree flip; a neck bone and the head flipped about the same axis would cancel, so the head can still point within 12 degrees. I have not shown that this offset makes the necks look wrong; the head-and-neck error PVE_hn cannot tell, because 91 percent of its vertices are on the head. The depth bug cannot cause the neck look in the montage or the photo demos: they place each body from its detection box.</a:t>
+              <a:t>In all eight v5-line checkpoints I traced, two bones are wrong by about half a turn: neck02 by 176 degrees and the head by 178, in every holdout person. The other neck bones and the jaw are fine. It is there from the first training stage, frozen_bb_v2, and nothing later changed it. The two half-turns cancel: the whole head still points the right way, within 12 to 15 degrees, so the head direction and the body PVE never showed it; only the per-bone angles did, last week's 63 and 90 degrees. But the neck skin comes out less than half as thick as the truth. v10 has no neck flip, but the same kind of flip in its left shoulder, its left upper arm and three hand bones, one left and two right. Two epochs with a geodesic loss barely moved it, likely because both bones would have to turn back together. The flip is measured, but I have not yet rendered it to check that it is the look we saw in the overlays. Its origin is not known; the singular start value of the rotation output would start a bone turned about its sideways axis, a tilt like the one in v5's left index base, not the twist in neck02 and the head. Next: a fixed output correction, no training.</a:t>
             </a:r>
             <a:endParaRPr lang="en-US" dirty="0"/>
           </a:p>
@@ -2232,7 +2232,7 @@
         <p:spPr>
           <a:xfrm>
             <a:off x="548640" y="1143000"/>
-            <a:ext cx="8046720" cy="1737360"/>
+            <a:ext cx="8046720" cy="2011680"/>
           </a:xfrm>
           <a:prstGeom prst="rect">
             <a:avLst/>
@@ -2905,7 +2905,21 @@
                   <a:schemeClr val="bg2"/>
                 </a:solidFill>
               </a:rPr>
-              <a:t>Neck, fingers and children: measured, still open.</a:t>
+              <a:t>Neck: two bones turned half a turn, found, not yet fixed.</a:t>
+            </a:r>
+            <a:endParaRPr lang="en-US" sz="1800" dirty="0"/>
+          </a:p>
+          <a:p>
+            <a:pPr algn="l" indent="0" marL="0">
+              <a:buNone/>
+            </a:pPr>
+            <a:r>
+              <a:rPr lang="en-US" sz="1800" dirty="0">
+                <a:solidFill>
+                  <a:schemeClr val="bg2"/>
+                </a:solidFill>
+              </a:rPr>
+              <a:t>Fingers and children: measured, still open.</a:t>
             </a:r>
             <a:endParaRPr lang="en-US" sz="1800" dirty="0"/>
           </a:p>
@@ -11056,7 +11070,7 @@
                   <a:schemeClr val="tx1"/>
                 </a:solidFill>
               </a:rPr>
-              <a:t>Neck offset in the v5 models</a:t>
+              <a:t>Neck: two half-turned bones</a:t>
             </a:r>
             <a:endParaRPr lang="en-US" sz="1500" dirty="0"/>
           </a:p>
@@ -11092,7 +11106,7 @@
                   <a:schemeClr val="tx2"/>
                 </a:solidFill>
               </a:rPr>
-              <a:t>Next: error per bone, split into twist and swing; find when the offset first appeared (earlier checkpoints).</a:t>
+              <a:t>Found (slide 7), not fixed. Next, exp6: a fixed output correction for the flipped bones, no training.</a:t>
             </a:r>
             <a:endParaRPr lang="en-US" sz="1200" dirty="0"/>
           </a:p>
@@ -12015,7 +12029,7 @@
         <p:spPr>
           <a:xfrm>
             <a:off x="548640" y="1143000"/>
-            <a:ext cx="8046720" cy="1737360"/>
+            <a:ext cx="8046720" cy="2011680"/>
           </a:xfrm>
           <a:prstGeom prst="rect">
             <a:avLst/>
@@ -12044,7 +12058,7 @@
                   <a:schemeClr val="bg2"/>
                 </a:solidFill>
               </a:rPr>
-              <a:t>the failures are not rig or decoding problems. A training-target bug puts people too far away in v5, v9 and v10 (v5: all 222 holdout people); the fix draws bodies much closer to their true size. ≥ 48% of two-person 3DPW train images label only one person (counted). </a:t>
+              <a:t>the failures are not rig or decoding problems. A training-target bug puts people too far away in v5, v9 and v10 (v5: all 222 holdout people); the fix draws bodies much closer to their true size. In all 8 v5-line checkpoints traced, neck02 and the head bone sit half a turn off and cancel; the neck skin is half as thick (0.46). ≥ 48% of two-person 3DPW train images label only one person (counted). </a:t>
             </a:r>
             <a:r>
               <a:rPr lang="en-US" sz="1500" b="1" dirty="0">
@@ -12082,7 +12096,7 @@
                   <a:schemeClr val="bg2"/>
                 </a:solidFill>
               </a:rPr>
-              <a:t>any improvement in neck, fingers or children; correct depths for both near and far people; a fix without cost (likely 2.6–4.9 mm PVE and 1.6–2.4 recall points worse, not yet confirmed); any measured accuracy of the 3DPW labels.</a:t>
+              <a:t>a neck fix, or a proven origin of the flip; any improvement in fingers or children; correct depths for both near and far people; a fix without cost (likely 2.6–4.9 mm PVE and 1.6–2.4 recall points worse, not yet confirmed); any measured accuracy of the 3DPW labels.</a:t>
             </a:r>
             <a:endParaRPr lang="en-US" sz="1500" dirty="0"/>
           </a:p>
@@ -12096,8 +12110,8 @@
         </p:nvSpPr>
         <p:spPr>
           <a:xfrm>
-            <a:off x="548640" y="2990088"/>
-            <a:ext cx="8046720" cy="1673352"/>
+            <a:off x="548640" y="3246120"/>
+            <a:ext cx="8046720" cy="1435608"/>
           </a:xfrm>
           <a:prstGeom prst="rect">
             <a:avLst/>
@@ -12121,8 +12135,8 @@
         </p:nvSpPr>
         <p:spPr>
           <a:xfrm>
-            <a:off x="548640" y="2990088"/>
-            <a:ext cx="73152" cy="1673352"/>
+            <a:off x="548640" y="3246120"/>
+            <a:ext cx="73152" cy="1435608"/>
           </a:xfrm>
           <a:prstGeom prst="rect">
             <a:avLst/>
@@ -12146,8 +12160,8 @@
         </p:nvSpPr>
         <p:spPr>
           <a:xfrm>
-            <a:off x="822960" y="3063240"/>
-            <a:ext cx="7635240" cy="1527048"/>
+            <a:off x="822960" y="3291840"/>
+            <a:ext cx="7635240" cy="1344168"/>
           </a:xfrm>
           <a:prstGeom prst="rect">
             <a:avLst/>
@@ -12202,7 +12216,7 @@
                   <a:srgbClr val="EEF2F7"/>
                 </a:solidFill>
               </a:rPr>
-              <a:t>From v5 (×5, 10 epochs): drawn size 0.84, root error 0.54 m, at +2.6 mm PVE and −1.6 recall points vs its control. v9 keeps the stuck neck; v10 learns the neck but has worse shoulders and arms.</a:t>
+              <a:t>From v5 (×5, 10 epochs): drawn size 0.84, root error 0.54 m, at +2.6 mm PVE and −1.6 recall points vs its control. v9 keeps the neck flip; v10 has a similar flip in the left shoulder and upper arm instead.</a:t>
             </a:r>
             <a:endParaRPr lang="en-US" sz="1400" dirty="0"/>
           </a:p>
@@ -12736,7 +12750,7 @@
                   <a:schemeClr val="tx2"/>
                 </a:solidFill>
               </a:rPr>
-              <a:t>the rig is fine. The v5 models are stuck at a fixed neck-bone rotation error. Whether that causes the look is not yet shown.</a:t>
+              <a:t>the rig is fine. In v5, neck02 and the head bone are turned half a turn and the neck skin comes out half as thick. A render check is still to do.</a:t>
             </a:r>
             <a:endParaRPr lang="en-US" sz="1300" dirty="0"/>
           </a:p>
@@ -17172,22 +17186,1718 @@
                   <a:schemeClr val="tx1"/>
                 </a:solidFill>
               </a:rPr>
-              <a:t>Neck: right length, but the v5 models are stuck</a:t>
+              <a:t>Neck: two bones turned half a turn</a:t>
             </a:r>
             <a:endParaRPr lang="en-US" sz="2700" dirty="0"/>
           </a:p>
         </p:txBody>
       </p:sp>
-      <p:sp>
-        <p:nvSpPr>
-          <p:cNvPr id="3" name="stat predicted neck length vs truth (holdout); with the true shape it is exact"/>
+      <p:graphicFrame>
+        <p:nvGraphicFramePr>
+          <p:cNvPr id="8" name="neck table"/>
+          <p:cNvGraphicFramePr>
+            <a:graphicFrameLocks noGrp="1"/>
+          </p:cNvGraphicFramePr>
+          <p:nvPr>
+            <p:extLst>
+              <p:ext uri="{D42A27DB-BD31-4B8C-83A1-F6EECF244321}">
+                <p14:modId xmlns:p14="http://schemas.microsoft.com/office/powerpoint/2010/main" val="1579011935"/>
+              </p:ext>
+            </p:extLst>
+          </p:nvPr>
+        </p:nvGraphicFramePr>
+        <p:xfrm>
+          <a:off x="457200" y="1188720"/>
+          <a:ext cx="4434840" cy="914400"/>
+        </p:xfrm>
+        <a:graphic>
+          <a:graphicData uri="http://schemas.openxmlformats.org/drawingml/2006/table">
+            <a:tbl>
+              <a:tblPr/>
+              <a:tblGrid>
+                <a:gridCol w="1920240"/>
+                <a:gridCol w="1645920"/>
+                <a:gridCol w="868680"/>
+              </a:tblGrid>
+              <a:tr h="246888">
+                <a:tc>
+                  <a:txBody>
+                    <a:bodyPr/>
+                    <a:lstStyle/>
+                    <a:p>
+                      <a:pPr algn="l" indent="0" marL="0">
+                        <a:buNone/>
+                      </a:pPr>
+                      <a:r>
+                        <a:rPr lang="en-US" sz="1100" b="1" dirty="0">
+                          <a:solidFill>
+                            <a:srgbClr val="FFFFFF"/>
+                          </a:solidFill>
+                        </a:rPr>
+                        <a:t>holdout, 100 images</a:t>
+                      </a:r>
+                      <a:endParaRPr lang="en-US" sz="1100" dirty="0"/>
+                    </a:p>
+                  </a:txBody>
+                  <a:tcPr marL="73152" marR="73152" marT="18288" marB="18288" anchor="ctr">
+                    <a:lnL w="12700" cap="flat" cmpd="sng" algn="ctr">
+                      <a:solidFill>
+                        <a:srgbClr val="FFFFFF"/>
+                      </a:solidFill>
+                      <a:prstDash val="solid"/>
+                      <a:round/>
+                      <a:headEnd type="none" w="med" len="med"/>
+                      <a:tailEnd type="none" w="med" len="med"/>
+                    </a:lnL>
+                    <a:lnR w="12700" cap="flat" cmpd="sng" algn="ctr">
+                      <a:solidFill>
+                        <a:srgbClr val="FFFFFF"/>
+                      </a:solidFill>
+                      <a:prstDash val="solid"/>
+                      <a:round/>
+                      <a:headEnd type="none" w="med" len="med"/>
+                      <a:tailEnd type="none" w="med" len="med"/>
+                    </a:lnR>
+                    <a:lnT w="12700" cap="flat" cmpd="sng" algn="ctr">
+                      <a:solidFill>
+                        <a:srgbClr val="FFFFFF"/>
+                      </a:solidFill>
+                      <a:prstDash val="solid"/>
+                      <a:round/>
+                      <a:headEnd type="none" w="med" len="med"/>
+                      <a:tailEnd type="none" w="med" len="med"/>
+                    </a:lnT>
+                    <a:lnB w="12700" cap="flat" cmpd="sng" algn="ctr">
+                      <a:solidFill>
+                        <a:srgbClr val="FFFFFF"/>
+                      </a:solidFill>
+                      <a:prstDash val="solid"/>
+                      <a:round/>
+                      <a:headEnd type="none" w="med" len="med"/>
+                      <a:tailEnd type="none" w="med" len="med"/>
+                    </a:lnB>
+                    <a:solidFill>
+                      <a:srgbClr val="1B2233"/>
+                    </a:solidFill>
+                  </a:tcPr>
+                </a:tc>
+                <a:tc>
+                  <a:txBody>
+                    <a:bodyPr/>
+                    <a:lstStyle/>
+                    <a:p>
+                      <a:pPr algn="ctr" indent="0" marL="0">
+                        <a:buNone/>
+                      </a:pPr>
+                      <a:r>
+                        <a:rPr lang="en-US" sz="1100" b="1" dirty="0">
+                          <a:solidFill>
+                            <a:srgbClr val="FFFFFF"/>
+                          </a:solidFill>
+                        </a:rPr>
+                        <a:t>v5 line, 8 checkpoints</a:t>
+                      </a:r>
+                      <a:endParaRPr lang="en-US" sz="1100" dirty="0"/>
+                    </a:p>
+                  </a:txBody>
+                  <a:tcPr marL="73152" marR="73152" marT="18288" marB="18288" anchor="ctr">
+                    <a:lnL w="12700" cap="flat" cmpd="sng" algn="ctr">
+                      <a:solidFill>
+                        <a:srgbClr val="FFFFFF"/>
+                      </a:solidFill>
+                      <a:prstDash val="solid"/>
+                      <a:round/>
+                      <a:headEnd type="none" w="med" len="med"/>
+                      <a:tailEnd type="none" w="med" len="med"/>
+                    </a:lnL>
+                    <a:lnR w="12700" cap="flat" cmpd="sng" algn="ctr">
+                      <a:solidFill>
+                        <a:srgbClr val="FFFFFF"/>
+                      </a:solidFill>
+                      <a:prstDash val="solid"/>
+                      <a:round/>
+                      <a:headEnd type="none" w="med" len="med"/>
+                      <a:tailEnd type="none" w="med" len="med"/>
+                    </a:lnR>
+                    <a:lnT w="12700" cap="flat" cmpd="sng" algn="ctr">
+                      <a:solidFill>
+                        <a:srgbClr val="FFFFFF"/>
+                      </a:solidFill>
+                      <a:prstDash val="solid"/>
+                      <a:round/>
+                      <a:headEnd type="none" w="med" len="med"/>
+                      <a:tailEnd type="none" w="med" len="med"/>
+                    </a:lnT>
+                    <a:lnB w="12700" cap="flat" cmpd="sng" algn="ctr">
+                      <a:solidFill>
+                        <a:srgbClr val="FFFFFF"/>
+                      </a:solidFill>
+                      <a:prstDash val="solid"/>
+                      <a:round/>
+                      <a:headEnd type="none" w="med" len="med"/>
+                      <a:tailEnd type="none" w="med" len="med"/>
+                    </a:lnB>
+                    <a:solidFill>
+                      <a:srgbClr val="1B2233"/>
+                    </a:solidFill>
+                  </a:tcPr>
+                </a:tc>
+                <a:tc>
+                  <a:txBody>
+                    <a:bodyPr/>
+                    <a:lstStyle/>
+                    <a:p>
+                      <a:pPr algn="ctr" indent="0" marL="0">
+                        <a:buNone/>
+                      </a:pPr>
+                      <a:r>
+                        <a:rPr lang="en-US" sz="1100" b="1" dirty="0">
+                          <a:solidFill>
+                            <a:srgbClr val="FFFFFF"/>
+                          </a:solidFill>
+                        </a:rPr>
+                        <a:t>v10</a:t>
+                      </a:r>
+                      <a:endParaRPr lang="en-US" sz="1100" dirty="0"/>
+                    </a:p>
+                  </a:txBody>
+                  <a:tcPr marL="73152" marR="73152" marT="18288" marB="18288" anchor="ctr">
+                    <a:lnL w="12700" cap="flat" cmpd="sng" algn="ctr">
+                      <a:solidFill>
+                        <a:srgbClr val="FFFFFF"/>
+                      </a:solidFill>
+                      <a:prstDash val="solid"/>
+                      <a:round/>
+                      <a:headEnd type="none" w="med" len="med"/>
+                      <a:tailEnd type="none" w="med" len="med"/>
+                    </a:lnL>
+                    <a:lnR w="12700" cap="flat" cmpd="sng" algn="ctr">
+                      <a:solidFill>
+                        <a:srgbClr val="FFFFFF"/>
+                      </a:solidFill>
+                      <a:prstDash val="solid"/>
+                      <a:round/>
+                      <a:headEnd type="none" w="med" len="med"/>
+                      <a:tailEnd type="none" w="med" len="med"/>
+                    </a:lnR>
+                    <a:lnT w="12700" cap="flat" cmpd="sng" algn="ctr">
+                      <a:solidFill>
+                        <a:srgbClr val="FFFFFF"/>
+                      </a:solidFill>
+                      <a:prstDash val="solid"/>
+                      <a:round/>
+                      <a:headEnd type="none" w="med" len="med"/>
+                      <a:tailEnd type="none" w="med" len="med"/>
+                    </a:lnT>
+                    <a:lnB w="12700" cap="flat" cmpd="sng" algn="ctr">
+                      <a:solidFill>
+                        <a:srgbClr val="FFFFFF"/>
+                      </a:solidFill>
+                      <a:prstDash val="solid"/>
+                      <a:round/>
+                      <a:headEnd type="none" w="med" len="med"/>
+                      <a:tailEnd type="none" w="med" len="med"/>
+                    </a:lnB>
+                    <a:solidFill>
+                      <a:srgbClr val="1B2233"/>
+                    </a:solidFill>
+                  </a:tcPr>
+                </a:tc>
+              </a:tr>
+              <a:tr h="246888">
+                <a:tc>
+                  <a:txBody>
+                    <a:bodyPr/>
+                    <a:lstStyle/>
+                    <a:p>
+                      <a:pPr algn="l" indent="0" marL="0">
+                        <a:buNone/>
+                      </a:pPr>
+                      <a:r>
+                        <a:rPr lang="en-US" sz="1200" b="1" dirty="0">
+                          <a:solidFill>
+                            <a:srgbClr val="1B2233"/>
+                          </a:solidFill>
+                        </a:rPr>
+                        <a:t>neck01</a:t>
+                      </a:r>
+                      <a:endParaRPr lang="en-US" sz="1200" dirty="0"/>
+                    </a:p>
+                  </a:txBody>
+                  <a:tcPr marL="73152" marR="73152" marT="18288" marB="18288" anchor="ctr">
+                    <a:lnL w="12700" cap="flat" cmpd="sng" algn="ctr">
+                      <a:solidFill>
+                        <a:srgbClr val="FFFFFF"/>
+                      </a:solidFill>
+                      <a:prstDash val="solid"/>
+                      <a:round/>
+                      <a:headEnd type="none" w="med" len="med"/>
+                      <a:tailEnd type="none" w="med" len="med"/>
+                    </a:lnL>
+                    <a:lnR w="12700" cap="flat" cmpd="sng" algn="ctr">
+                      <a:solidFill>
+                        <a:srgbClr val="FFFFFF"/>
+                      </a:solidFill>
+                      <a:prstDash val="solid"/>
+                      <a:round/>
+                      <a:headEnd type="none" w="med" len="med"/>
+                      <a:tailEnd type="none" w="med" len="med"/>
+                    </a:lnR>
+                    <a:lnT w="12700" cap="flat" cmpd="sng" algn="ctr">
+                      <a:solidFill>
+                        <a:srgbClr val="FFFFFF"/>
+                      </a:solidFill>
+                      <a:prstDash val="solid"/>
+                      <a:round/>
+                      <a:headEnd type="none" w="med" len="med"/>
+                      <a:tailEnd type="none" w="med" len="med"/>
+                    </a:lnT>
+                    <a:lnB w="12700" cap="flat" cmpd="sng" algn="ctr">
+                      <a:solidFill>
+                        <a:srgbClr val="FFFFFF"/>
+                      </a:solidFill>
+                      <a:prstDash val="solid"/>
+                      <a:round/>
+                      <a:headEnd type="none" w="med" len="med"/>
+                      <a:tailEnd type="none" w="med" len="med"/>
+                    </a:lnB>
+                    <a:solidFill>
+                      <a:srgbClr val="FFFFFF"/>
+                    </a:solidFill>
+                  </a:tcPr>
+                </a:tc>
+                <a:tc>
+                  <a:txBody>
+                    <a:bodyPr/>
+                    <a:lstStyle/>
+                    <a:p>
+                      <a:pPr algn="ctr" indent="0" marL="0">
+                        <a:buNone/>
+                      </a:pPr>
+                      <a:r>
+                        <a:rPr lang="en-US" sz="1200" dirty="0">
+                          <a:solidFill>
+                            <a:srgbClr val="1B2233"/>
+                          </a:solidFill>
+                        </a:rPr>
+                        <a:t>5.3–7.3°</a:t>
+                      </a:r>
+                      <a:endParaRPr lang="en-US" sz="1200" dirty="0"/>
+                    </a:p>
+                  </a:txBody>
+                  <a:tcPr marL="73152" marR="73152" marT="18288" marB="18288" anchor="ctr">
+                    <a:lnL w="12700" cap="flat" cmpd="sng" algn="ctr">
+                      <a:solidFill>
+                        <a:srgbClr val="FFFFFF"/>
+                      </a:solidFill>
+                      <a:prstDash val="solid"/>
+                      <a:round/>
+                      <a:headEnd type="none" w="med" len="med"/>
+                      <a:tailEnd type="none" w="med" len="med"/>
+                    </a:lnL>
+                    <a:lnR w="12700" cap="flat" cmpd="sng" algn="ctr">
+                      <a:solidFill>
+                        <a:srgbClr val="FFFFFF"/>
+                      </a:solidFill>
+                      <a:prstDash val="solid"/>
+                      <a:round/>
+                      <a:headEnd type="none" w="med" len="med"/>
+                      <a:tailEnd type="none" w="med" len="med"/>
+                    </a:lnR>
+                    <a:lnT w="12700" cap="flat" cmpd="sng" algn="ctr">
+                      <a:solidFill>
+                        <a:srgbClr val="FFFFFF"/>
+                      </a:solidFill>
+                      <a:prstDash val="solid"/>
+                      <a:round/>
+                      <a:headEnd type="none" w="med" len="med"/>
+                      <a:tailEnd type="none" w="med" len="med"/>
+                    </a:lnT>
+                    <a:lnB w="12700" cap="flat" cmpd="sng" algn="ctr">
+                      <a:solidFill>
+                        <a:srgbClr val="FFFFFF"/>
+                      </a:solidFill>
+                      <a:prstDash val="solid"/>
+                      <a:round/>
+                      <a:headEnd type="none" w="med" len="med"/>
+                      <a:tailEnd type="none" w="med" len="med"/>
+                    </a:lnB>
+                    <a:solidFill>
+                      <a:srgbClr val="FFFFFF"/>
+                    </a:solidFill>
+                  </a:tcPr>
+                </a:tc>
+                <a:tc>
+                  <a:txBody>
+                    <a:bodyPr/>
+                    <a:lstStyle/>
+                    <a:p>
+                      <a:pPr algn="ctr" indent="0" marL="0">
+                        <a:buNone/>
+                      </a:pPr>
+                      <a:r>
+                        <a:rPr lang="en-US" sz="1200" dirty="0">
+                          <a:solidFill>
+                            <a:srgbClr val="1B2233"/>
+                          </a:solidFill>
+                        </a:rPr>
+                        <a:t>5.6°</a:t>
+                      </a:r>
+                      <a:endParaRPr lang="en-US" sz="1200" dirty="0"/>
+                    </a:p>
+                  </a:txBody>
+                  <a:tcPr marL="73152" marR="73152" marT="18288" marB="18288" anchor="ctr">
+                    <a:lnL w="12700" cap="flat" cmpd="sng" algn="ctr">
+                      <a:solidFill>
+                        <a:srgbClr val="FFFFFF"/>
+                      </a:solidFill>
+                      <a:prstDash val="solid"/>
+                      <a:round/>
+                      <a:headEnd type="none" w="med" len="med"/>
+                      <a:tailEnd type="none" w="med" len="med"/>
+                    </a:lnL>
+                    <a:lnR w="12700" cap="flat" cmpd="sng" algn="ctr">
+                      <a:solidFill>
+                        <a:srgbClr val="FFFFFF"/>
+                      </a:solidFill>
+                      <a:prstDash val="solid"/>
+                      <a:round/>
+                      <a:headEnd type="none" w="med" len="med"/>
+                      <a:tailEnd type="none" w="med" len="med"/>
+                    </a:lnR>
+                    <a:lnT w="12700" cap="flat" cmpd="sng" algn="ctr">
+                      <a:solidFill>
+                        <a:srgbClr val="FFFFFF"/>
+                      </a:solidFill>
+                      <a:prstDash val="solid"/>
+                      <a:round/>
+                      <a:headEnd type="none" w="med" len="med"/>
+                      <a:tailEnd type="none" w="med" len="med"/>
+                    </a:lnT>
+                    <a:lnB w="12700" cap="flat" cmpd="sng" algn="ctr">
+                      <a:solidFill>
+                        <a:srgbClr val="FFFFFF"/>
+                      </a:solidFill>
+                      <a:prstDash val="solid"/>
+                      <a:round/>
+                      <a:headEnd type="none" w="med" len="med"/>
+                      <a:tailEnd type="none" w="med" len="med"/>
+                    </a:lnB>
+                    <a:solidFill>
+                      <a:srgbClr val="FFFFFF"/>
+                    </a:solidFill>
+                  </a:tcPr>
+                </a:tc>
+              </a:tr>
+              <a:tr h="246888">
+                <a:tc>
+                  <a:txBody>
+                    <a:bodyPr/>
+                    <a:lstStyle/>
+                    <a:p>
+                      <a:pPr algn="l" indent="0" marL="0">
+                        <a:buNone/>
+                      </a:pPr>
+                      <a:r>
+                        <a:rPr lang="en-US" sz="1200" b="1" dirty="0">
+                          <a:solidFill>
+                            <a:srgbClr val="1B2233"/>
+                          </a:solidFill>
+                        </a:rPr>
+                        <a:t>neck02</a:t>
+                      </a:r>
+                      <a:endParaRPr lang="en-US" sz="1200" dirty="0"/>
+                    </a:p>
+                  </a:txBody>
+                  <a:tcPr marL="73152" marR="73152" marT="18288" marB="18288" anchor="ctr">
+                    <a:lnL w="12700" cap="flat" cmpd="sng" algn="ctr">
+                      <a:solidFill>
+                        <a:srgbClr val="FFFFFF"/>
+                      </a:solidFill>
+                      <a:prstDash val="solid"/>
+                      <a:round/>
+                      <a:headEnd type="none" w="med" len="med"/>
+                      <a:tailEnd type="none" w="med" len="med"/>
+                    </a:lnL>
+                    <a:lnR w="12700" cap="flat" cmpd="sng" algn="ctr">
+                      <a:solidFill>
+                        <a:srgbClr val="FFFFFF"/>
+                      </a:solidFill>
+                      <a:prstDash val="solid"/>
+                      <a:round/>
+                      <a:headEnd type="none" w="med" len="med"/>
+                      <a:tailEnd type="none" w="med" len="med"/>
+                    </a:lnR>
+                    <a:lnT w="12700" cap="flat" cmpd="sng" algn="ctr">
+                      <a:solidFill>
+                        <a:srgbClr val="FFFFFF"/>
+                      </a:solidFill>
+                      <a:prstDash val="solid"/>
+                      <a:round/>
+                      <a:headEnd type="none" w="med" len="med"/>
+                      <a:tailEnd type="none" w="med" len="med"/>
+                    </a:lnT>
+                    <a:lnB w="12700" cap="flat" cmpd="sng" algn="ctr">
+                      <a:solidFill>
+                        <a:srgbClr val="FFFFFF"/>
+                      </a:solidFill>
+                      <a:prstDash val="solid"/>
+                      <a:round/>
+                      <a:headEnd type="none" w="med" len="med"/>
+                      <a:tailEnd type="none" w="med" len="med"/>
+                    </a:lnB>
+                    <a:solidFill>
+                      <a:srgbClr val="EEF2F7"/>
+                    </a:solidFill>
+                  </a:tcPr>
+                </a:tc>
+                <a:tc>
+                  <a:txBody>
+                    <a:bodyPr/>
+                    <a:lstStyle/>
+                    <a:p>
+                      <a:pPr algn="ctr" indent="0" marL="0">
+                        <a:buNone/>
+                      </a:pPr>
+                      <a:r>
+                        <a:rPr lang="en-US" sz="1200" b="1" dirty="0">
+                          <a:solidFill>
+                            <a:srgbClr val="C0392B"/>
+                          </a:solidFill>
+                        </a:rPr>
+                        <a:t>175.0–176.0°</a:t>
+                      </a:r>
+                      <a:endParaRPr lang="en-US" sz="1200" dirty="0"/>
+                    </a:p>
+                  </a:txBody>
+                  <a:tcPr marL="73152" marR="73152" marT="18288" marB="18288" anchor="ctr">
+                    <a:lnL w="12700" cap="flat" cmpd="sng" algn="ctr">
+                      <a:solidFill>
+                        <a:srgbClr val="FFFFFF"/>
+                      </a:solidFill>
+                      <a:prstDash val="solid"/>
+                      <a:round/>
+                      <a:headEnd type="none" w="med" len="med"/>
+                      <a:tailEnd type="none" w="med" len="med"/>
+                    </a:lnL>
+                    <a:lnR w="12700" cap="flat" cmpd="sng" algn="ctr">
+                      <a:solidFill>
+                        <a:srgbClr val="FFFFFF"/>
+                      </a:solidFill>
+                      <a:prstDash val="solid"/>
+                      <a:round/>
+                      <a:headEnd type="none" w="med" len="med"/>
+                      <a:tailEnd type="none" w="med" len="med"/>
+                    </a:lnR>
+                    <a:lnT w="12700" cap="flat" cmpd="sng" algn="ctr">
+                      <a:solidFill>
+                        <a:srgbClr val="FFFFFF"/>
+                      </a:solidFill>
+                      <a:prstDash val="solid"/>
+                      <a:round/>
+                      <a:headEnd type="none" w="med" len="med"/>
+                      <a:tailEnd type="none" w="med" len="med"/>
+                    </a:lnT>
+                    <a:lnB w="12700" cap="flat" cmpd="sng" algn="ctr">
+                      <a:solidFill>
+                        <a:srgbClr val="FFFFFF"/>
+                      </a:solidFill>
+                      <a:prstDash val="solid"/>
+                      <a:round/>
+                      <a:headEnd type="none" w="med" len="med"/>
+                      <a:tailEnd type="none" w="med" len="med"/>
+                    </a:lnB>
+                    <a:solidFill>
+                      <a:srgbClr val="EEF2F7"/>
+                    </a:solidFill>
+                  </a:tcPr>
+                </a:tc>
+                <a:tc>
+                  <a:txBody>
+                    <a:bodyPr/>
+                    <a:lstStyle/>
+                    <a:p>
+                      <a:pPr algn="ctr" indent="0" marL="0">
+                        <a:buNone/>
+                      </a:pPr>
+                      <a:r>
+                        <a:rPr lang="en-US" sz="1200" dirty="0">
+                          <a:solidFill>
+                            <a:srgbClr val="1B2233"/>
+                          </a:solidFill>
+                        </a:rPr>
+                        <a:t>3.9°</a:t>
+                      </a:r>
+                      <a:endParaRPr lang="en-US" sz="1200" dirty="0"/>
+                    </a:p>
+                  </a:txBody>
+                  <a:tcPr marL="73152" marR="73152" marT="18288" marB="18288" anchor="ctr">
+                    <a:lnL w="12700" cap="flat" cmpd="sng" algn="ctr">
+                      <a:solidFill>
+                        <a:srgbClr val="FFFFFF"/>
+                      </a:solidFill>
+                      <a:prstDash val="solid"/>
+                      <a:round/>
+                      <a:headEnd type="none" w="med" len="med"/>
+                      <a:tailEnd type="none" w="med" len="med"/>
+                    </a:lnL>
+                    <a:lnR w="12700" cap="flat" cmpd="sng" algn="ctr">
+                      <a:solidFill>
+                        <a:srgbClr val="FFFFFF"/>
+                      </a:solidFill>
+                      <a:prstDash val="solid"/>
+                      <a:round/>
+                      <a:headEnd type="none" w="med" len="med"/>
+                      <a:tailEnd type="none" w="med" len="med"/>
+                    </a:lnR>
+                    <a:lnT w="12700" cap="flat" cmpd="sng" algn="ctr">
+                      <a:solidFill>
+                        <a:srgbClr val="FFFFFF"/>
+                      </a:solidFill>
+                      <a:prstDash val="solid"/>
+                      <a:round/>
+                      <a:headEnd type="none" w="med" len="med"/>
+                      <a:tailEnd type="none" w="med" len="med"/>
+                    </a:lnT>
+                    <a:lnB w="12700" cap="flat" cmpd="sng" algn="ctr">
+                      <a:solidFill>
+                        <a:srgbClr val="FFFFFF"/>
+                      </a:solidFill>
+                      <a:prstDash val="solid"/>
+                      <a:round/>
+                      <a:headEnd type="none" w="med" len="med"/>
+                      <a:tailEnd type="none" w="med" len="med"/>
+                    </a:lnB>
+                    <a:solidFill>
+                      <a:srgbClr val="EEF2F7"/>
+                    </a:solidFill>
+                  </a:tcPr>
+                </a:tc>
+              </a:tr>
+              <a:tr h="246888">
+                <a:tc>
+                  <a:txBody>
+                    <a:bodyPr/>
+                    <a:lstStyle/>
+                    <a:p>
+                      <a:pPr algn="l" indent="0" marL="0">
+                        <a:buNone/>
+                      </a:pPr>
+                      <a:r>
+                        <a:rPr lang="en-US" sz="1200" b="1" dirty="0">
+                          <a:solidFill>
+                            <a:srgbClr val="1B2233"/>
+                          </a:solidFill>
+                        </a:rPr>
+                        <a:t>neck03</a:t>
+                      </a:r>
+                      <a:endParaRPr lang="en-US" sz="1200" dirty="0"/>
+                    </a:p>
+                  </a:txBody>
+                  <a:tcPr marL="73152" marR="73152" marT="18288" marB="18288" anchor="ctr">
+                    <a:lnL w="12700" cap="flat" cmpd="sng" algn="ctr">
+                      <a:solidFill>
+                        <a:srgbClr val="FFFFFF"/>
+                      </a:solidFill>
+                      <a:prstDash val="solid"/>
+                      <a:round/>
+                      <a:headEnd type="none" w="med" len="med"/>
+                      <a:tailEnd type="none" w="med" len="med"/>
+                    </a:lnL>
+                    <a:lnR w="12700" cap="flat" cmpd="sng" algn="ctr">
+                      <a:solidFill>
+                        <a:srgbClr val="FFFFFF"/>
+                      </a:solidFill>
+                      <a:prstDash val="solid"/>
+                      <a:round/>
+                      <a:headEnd type="none" w="med" len="med"/>
+                      <a:tailEnd type="none" w="med" len="med"/>
+                    </a:lnR>
+                    <a:lnT w="12700" cap="flat" cmpd="sng" algn="ctr">
+                      <a:solidFill>
+                        <a:srgbClr val="FFFFFF"/>
+                      </a:solidFill>
+                      <a:prstDash val="solid"/>
+                      <a:round/>
+                      <a:headEnd type="none" w="med" len="med"/>
+                      <a:tailEnd type="none" w="med" len="med"/>
+                    </a:lnT>
+                    <a:lnB w="12700" cap="flat" cmpd="sng" algn="ctr">
+                      <a:solidFill>
+                        <a:srgbClr val="FFFFFF"/>
+                      </a:solidFill>
+                      <a:prstDash val="solid"/>
+                      <a:round/>
+                      <a:headEnd type="none" w="med" len="med"/>
+                      <a:tailEnd type="none" w="med" len="med"/>
+                    </a:lnB>
+                    <a:solidFill>
+                      <a:srgbClr val="FFFFFF"/>
+                    </a:solidFill>
+                  </a:tcPr>
+                </a:tc>
+                <a:tc>
+                  <a:txBody>
+                    <a:bodyPr/>
+                    <a:lstStyle/>
+                    <a:p>
+                      <a:pPr algn="ctr" indent="0" marL="0">
+                        <a:buNone/>
+                      </a:pPr>
+                      <a:r>
+                        <a:rPr lang="en-US" sz="1200" dirty="0">
+                          <a:solidFill>
+                            <a:srgbClr val="1B2233"/>
+                          </a:solidFill>
+                        </a:rPr>
+                        <a:t>4.9–8.0°</a:t>
+                      </a:r>
+                      <a:endParaRPr lang="en-US" sz="1200" dirty="0"/>
+                    </a:p>
+                  </a:txBody>
+                  <a:tcPr marL="73152" marR="73152" marT="18288" marB="18288" anchor="ctr">
+                    <a:lnL w="12700" cap="flat" cmpd="sng" algn="ctr">
+                      <a:solidFill>
+                        <a:srgbClr val="FFFFFF"/>
+                      </a:solidFill>
+                      <a:prstDash val="solid"/>
+                      <a:round/>
+                      <a:headEnd type="none" w="med" len="med"/>
+                      <a:tailEnd type="none" w="med" len="med"/>
+                    </a:lnL>
+                    <a:lnR w="12700" cap="flat" cmpd="sng" algn="ctr">
+                      <a:solidFill>
+                        <a:srgbClr val="FFFFFF"/>
+                      </a:solidFill>
+                      <a:prstDash val="solid"/>
+                      <a:round/>
+                      <a:headEnd type="none" w="med" len="med"/>
+                      <a:tailEnd type="none" w="med" len="med"/>
+                    </a:lnR>
+                    <a:lnT w="12700" cap="flat" cmpd="sng" algn="ctr">
+                      <a:solidFill>
+                        <a:srgbClr val="FFFFFF"/>
+                      </a:solidFill>
+                      <a:prstDash val="solid"/>
+                      <a:round/>
+                      <a:headEnd type="none" w="med" len="med"/>
+                      <a:tailEnd type="none" w="med" len="med"/>
+                    </a:lnT>
+                    <a:lnB w="12700" cap="flat" cmpd="sng" algn="ctr">
+                      <a:solidFill>
+                        <a:srgbClr val="FFFFFF"/>
+                      </a:solidFill>
+                      <a:prstDash val="solid"/>
+                      <a:round/>
+                      <a:headEnd type="none" w="med" len="med"/>
+                      <a:tailEnd type="none" w="med" len="med"/>
+                    </a:lnB>
+                    <a:solidFill>
+                      <a:srgbClr val="FFFFFF"/>
+                    </a:solidFill>
+                  </a:tcPr>
+                </a:tc>
+                <a:tc>
+                  <a:txBody>
+                    <a:bodyPr/>
+                    <a:lstStyle/>
+                    <a:p>
+                      <a:pPr algn="ctr" indent="0" marL="0">
+                        <a:buNone/>
+                      </a:pPr>
+                      <a:r>
+                        <a:rPr lang="en-US" sz="1200" dirty="0">
+                          <a:solidFill>
+                            <a:srgbClr val="1B2233"/>
+                          </a:solidFill>
+                        </a:rPr>
+                        <a:t>4.3°</a:t>
+                      </a:r>
+                      <a:endParaRPr lang="en-US" sz="1200" dirty="0"/>
+                    </a:p>
+                  </a:txBody>
+                  <a:tcPr marL="73152" marR="73152" marT="18288" marB="18288" anchor="ctr">
+                    <a:lnL w="12700" cap="flat" cmpd="sng" algn="ctr">
+                      <a:solidFill>
+                        <a:srgbClr val="FFFFFF"/>
+                      </a:solidFill>
+                      <a:prstDash val="solid"/>
+                      <a:round/>
+                      <a:headEnd type="none" w="med" len="med"/>
+                      <a:tailEnd type="none" w="med" len="med"/>
+                    </a:lnL>
+                    <a:lnR w="12700" cap="flat" cmpd="sng" algn="ctr">
+                      <a:solidFill>
+                        <a:srgbClr val="FFFFFF"/>
+                      </a:solidFill>
+                      <a:prstDash val="solid"/>
+                      <a:round/>
+                      <a:headEnd type="none" w="med" len="med"/>
+                      <a:tailEnd type="none" w="med" len="med"/>
+                    </a:lnR>
+                    <a:lnT w="12700" cap="flat" cmpd="sng" algn="ctr">
+                      <a:solidFill>
+                        <a:srgbClr val="FFFFFF"/>
+                      </a:solidFill>
+                      <a:prstDash val="solid"/>
+                      <a:round/>
+                      <a:headEnd type="none" w="med" len="med"/>
+                      <a:tailEnd type="none" w="med" len="med"/>
+                    </a:lnT>
+                    <a:lnB w="12700" cap="flat" cmpd="sng" algn="ctr">
+                      <a:solidFill>
+                        <a:srgbClr val="FFFFFF"/>
+                      </a:solidFill>
+                      <a:prstDash val="solid"/>
+                      <a:round/>
+                      <a:headEnd type="none" w="med" len="med"/>
+                      <a:tailEnd type="none" w="med" len="med"/>
+                    </a:lnB>
+                    <a:solidFill>
+                      <a:srgbClr val="FFFFFF"/>
+                    </a:solidFill>
+                  </a:tcPr>
+                </a:tc>
+              </a:tr>
+              <a:tr h="246888">
+                <a:tc>
+                  <a:txBody>
+                    <a:bodyPr/>
+                    <a:lstStyle/>
+                    <a:p>
+                      <a:pPr algn="l" indent="0" marL="0">
+                        <a:buNone/>
+                      </a:pPr>
+                      <a:r>
+                        <a:rPr lang="en-US" sz="1200" b="1" dirty="0">
+                          <a:solidFill>
+                            <a:srgbClr val="1B2233"/>
+                          </a:solidFill>
+                        </a:rPr>
+                        <a:t>head</a:t>
+                      </a:r>
+                      <a:endParaRPr lang="en-US" sz="1200" dirty="0"/>
+                    </a:p>
+                  </a:txBody>
+                  <a:tcPr marL="73152" marR="73152" marT="18288" marB="18288" anchor="ctr">
+                    <a:lnL w="12700" cap="flat" cmpd="sng" algn="ctr">
+                      <a:solidFill>
+                        <a:srgbClr val="FFFFFF"/>
+                      </a:solidFill>
+                      <a:prstDash val="solid"/>
+                      <a:round/>
+                      <a:headEnd type="none" w="med" len="med"/>
+                      <a:tailEnd type="none" w="med" len="med"/>
+                    </a:lnL>
+                    <a:lnR w="12700" cap="flat" cmpd="sng" algn="ctr">
+                      <a:solidFill>
+                        <a:srgbClr val="FFFFFF"/>
+                      </a:solidFill>
+                      <a:prstDash val="solid"/>
+                      <a:round/>
+                      <a:headEnd type="none" w="med" len="med"/>
+                      <a:tailEnd type="none" w="med" len="med"/>
+                    </a:lnR>
+                    <a:lnT w="12700" cap="flat" cmpd="sng" algn="ctr">
+                      <a:solidFill>
+                        <a:srgbClr val="FFFFFF"/>
+                      </a:solidFill>
+                      <a:prstDash val="solid"/>
+                      <a:round/>
+                      <a:headEnd type="none" w="med" len="med"/>
+                      <a:tailEnd type="none" w="med" len="med"/>
+                    </a:lnT>
+                    <a:lnB w="12700" cap="flat" cmpd="sng" algn="ctr">
+                      <a:solidFill>
+                        <a:srgbClr val="FFFFFF"/>
+                      </a:solidFill>
+                      <a:prstDash val="solid"/>
+                      <a:round/>
+                      <a:headEnd type="none" w="med" len="med"/>
+                      <a:tailEnd type="none" w="med" len="med"/>
+                    </a:lnB>
+                    <a:solidFill>
+                      <a:srgbClr val="EEF2F7"/>
+                    </a:solidFill>
+                  </a:tcPr>
+                </a:tc>
+                <a:tc>
+                  <a:txBody>
+                    <a:bodyPr/>
+                    <a:lstStyle/>
+                    <a:p>
+                      <a:pPr algn="ctr" indent="0" marL="0">
+                        <a:buNone/>
+                      </a:pPr>
+                      <a:r>
+                        <a:rPr lang="en-US" sz="1200" b="1" dirty="0">
+                          <a:solidFill>
+                            <a:srgbClr val="C0392B"/>
+                          </a:solidFill>
+                        </a:rPr>
+                        <a:t>177.1–178.0°</a:t>
+                      </a:r>
+                      <a:endParaRPr lang="en-US" sz="1200" dirty="0"/>
+                    </a:p>
+                  </a:txBody>
+                  <a:tcPr marL="73152" marR="73152" marT="18288" marB="18288" anchor="ctr">
+                    <a:lnL w="12700" cap="flat" cmpd="sng" algn="ctr">
+                      <a:solidFill>
+                        <a:srgbClr val="FFFFFF"/>
+                      </a:solidFill>
+                      <a:prstDash val="solid"/>
+                      <a:round/>
+                      <a:headEnd type="none" w="med" len="med"/>
+                      <a:tailEnd type="none" w="med" len="med"/>
+                    </a:lnL>
+                    <a:lnR w="12700" cap="flat" cmpd="sng" algn="ctr">
+                      <a:solidFill>
+                        <a:srgbClr val="FFFFFF"/>
+                      </a:solidFill>
+                      <a:prstDash val="solid"/>
+                      <a:round/>
+                      <a:headEnd type="none" w="med" len="med"/>
+                      <a:tailEnd type="none" w="med" len="med"/>
+                    </a:lnR>
+                    <a:lnT w="12700" cap="flat" cmpd="sng" algn="ctr">
+                      <a:solidFill>
+                        <a:srgbClr val="FFFFFF"/>
+                      </a:solidFill>
+                      <a:prstDash val="solid"/>
+                      <a:round/>
+                      <a:headEnd type="none" w="med" len="med"/>
+                      <a:tailEnd type="none" w="med" len="med"/>
+                    </a:lnT>
+                    <a:lnB w="12700" cap="flat" cmpd="sng" algn="ctr">
+                      <a:solidFill>
+                        <a:srgbClr val="FFFFFF"/>
+                      </a:solidFill>
+                      <a:prstDash val="solid"/>
+                      <a:round/>
+                      <a:headEnd type="none" w="med" len="med"/>
+                      <a:tailEnd type="none" w="med" len="med"/>
+                    </a:lnB>
+                    <a:solidFill>
+                      <a:srgbClr val="EEF2F7"/>
+                    </a:solidFill>
+                  </a:tcPr>
+                </a:tc>
+                <a:tc>
+                  <a:txBody>
+                    <a:bodyPr/>
+                    <a:lstStyle/>
+                    <a:p>
+                      <a:pPr algn="ctr" indent="0" marL="0">
+                        <a:buNone/>
+                      </a:pPr>
+                      <a:r>
+                        <a:rPr lang="en-US" sz="1200" dirty="0">
+                          <a:solidFill>
+                            <a:srgbClr val="1B2233"/>
+                          </a:solidFill>
+                        </a:rPr>
+                        <a:t>6.8°</a:t>
+                      </a:r>
+                      <a:endParaRPr lang="en-US" sz="1200" dirty="0"/>
+                    </a:p>
+                  </a:txBody>
+                  <a:tcPr marL="73152" marR="73152" marT="18288" marB="18288" anchor="ctr">
+                    <a:lnL w="12700" cap="flat" cmpd="sng" algn="ctr">
+                      <a:solidFill>
+                        <a:srgbClr val="FFFFFF"/>
+                      </a:solidFill>
+                      <a:prstDash val="solid"/>
+                      <a:round/>
+                      <a:headEnd type="none" w="med" len="med"/>
+                      <a:tailEnd type="none" w="med" len="med"/>
+                    </a:lnL>
+                    <a:lnR w="12700" cap="flat" cmpd="sng" algn="ctr">
+                      <a:solidFill>
+                        <a:srgbClr val="FFFFFF"/>
+                      </a:solidFill>
+                      <a:prstDash val="solid"/>
+                      <a:round/>
+                      <a:headEnd type="none" w="med" len="med"/>
+                      <a:tailEnd type="none" w="med" len="med"/>
+                    </a:lnR>
+                    <a:lnT w="12700" cap="flat" cmpd="sng" algn="ctr">
+                      <a:solidFill>
+                        <a:srgbClr val="FFFFFF"/>
+                      </a:solidFill>
+                      <a:prstDash val="solid"/>
+                      <a:round/>
+                      <a:headEnd type="none" w="med" len="med"/>
+                      <a:tailEnd type="none" w="med" len="med"/>
+                    </a:lnT>
+                    <a:lnB w="12700" cap="flat" cmpd="sng" algn="ctr">
+                      <a:solidFill>
+                        <a:srgbClr val="FFFFFF"/>
+                      </a:solidFill>
+                      <a:prstDash val="solid"/>
+                      <a:round/>
+                      <a:headEnd type="none" w="med" len="med"/>
+                      <a:tailEnd type="none" w="med" len="med"/>
+                    </a:lnB>
+                    <a:solidFill>
+                      <a:srgbClr val="EEF2F7"/>
+                    </a:solidFill>
+                  </a:tcPr>
+                </a:tc>
+              </a:tr>
+              <a:tr h="246888">
+                <a:tc>
+                  <a:txBody>
+                    <a:bodyPr/>
+                    <a:lstStyle/>
+                    <a:p>
+                      <a:pPr algn="l" indent="0" marL="0">
+                        <a:buNone/>
+                      </a:pPr>
+                      <a:r>
+                        <a:rPr lang="en-US" sz="1200" b="1" dirty="0">
+                          <a:solidFill>
+                            <a:srgbClr val="1B2233"/>
+                          </a:solidFill>
+                        </a:rPr>
+                        <a:t>jaw</a:t>
+                      </a:r>
+                      <a:endParaRPr lang="en-US" sz="1200" dirty="0"/>
+                    </a:p>
+                  </a:txBody>
+                  <a:tcPr marL="73152" marR="73152" marT="18288" marB="18288" anchor="ctr">
+                    <a:lnL w="12700" cap="flat" cmpd="sng" algn="ctr">
+                      <a:solidFill>
+                        <a:srgbClr val="FFFFFF"/>
+                      </a:solidFill>
+                      <a:prstDash val="solid"/>
+                      <a:round/>
+                      <a:headEnd type="none" w="med" len="med"/>
+                      <a:tailEnd type="none" w="med" len="med"/>
+                    </a:lnL>
+                    <a:lnR w="12700" cap="flat" cmpd="sng" algn="ctr">
+                      <a:solidFill>
+                        <a:srgbClr val="FFFFFF"/>
+                      </a:solidFill>
+                      <a:prstDash val="solid"/>
+                      <a:round/>
+                      <a:headEnd type="none" w="med" len="med"/>
+                      <a:tailEnd type="none" w="med" len="med"/>
+                    </a:lnR>
+                    <a:lnT w="12700" cap="flat" cmpd="sng" algn="ctr">
+                      <a:solidFill>
+                        <a:srgbClr val="FFFFFF"/>
+                      </a:solidFill>
+                      <a:prstDash val="solid"/>
+                      <a:round/>
+                      <a:headEnd type="none" w="med" len="med"/>
+                      <a:tailEnd type="none" w="med" len="med"/>
+                    </a:lnT>
+                    <a:lnB w="12700" cap="flat" cmpd="sng" algn="ctr">
+                      <a:solidFill>
+                        <a:srgbClr val="FFFFFF"/>
+                      </a:solidFill>
+                      <a:prstDash val="solid"/>
+                      <a:round/>
+                      <a:headEnd type="none" w="med" len="med"/>
+                      <a:tailEnd type="none" w="med" len="med"/>
+                    </a:lnB>
+                    <a:solidFill>
+                      <a:srgbClr val="FFFFFF"/>
+                    </a:solidFill>
+                  </a:tcPr>
+                </a:tc>
+                <a:tc>
+                  <a:txBody>
+                    <a:bodyPr/>
+                    <a:lstStyle/>
+                    <a:p>
+                      <a:pPr algn="ctr" indent="0" marL="0">
+                        <a:buNone/>
+                      </a:pPr>
+                      <a:r>
+                        <a:rPr lang="en-US" sz="1200" dirty="0">
+                          <a:solidFill>
+                            <a:srgbClr val="1B2233"/>
+                          </a:solidFill>
+                        </a:rPr>
+                        <a:t>0.2–2.5°</a:t>
+                      </a:r>
+                      <a:endParaRPr lang="en-US" sz="1200" dirty="0"/>
+                    </a:p>
+                  </a:txBody>
+                  <a:tcPr marL="73152" marR="73152" marT="18288" marB="18288" anchor="ctr">
+                    <a:lnL w="12700" cap="flat" cmpd="sng" algn="ctr">
+                      <a:solidFill>
+                        <a:srgbClr val="FFFFFF"/>
+                      </a:solidFill>
+                      <a:prstDash val="solid"/>
+                      <a:round/>
+                      <a:headEnd type="none" w="med" len="med"/>
+                      <a:tailEnd type="none" w="med" len="med"/>
+                    </a:lnL>
+                    <a:lnR w="12700" cap="flat" cmpd="sng" algn="ctr">
+                      <a:solidFill>
+                        <a:srgbClr val="FFFFFF"/>
+                      </a:solidFill>
+                      <a:prstDash val="solid"/>
+                      <a:round/>
+                      <a:headEnd type="none" w="med" len="med"/>
+                      <a:tailEnd type="none" w="med" len="med"/>
+                    </a:lnR>
+                    <a:lnT w="12700" cap="flat" cmpd="sng" algn="ctr">
+                      <a:solidFill>
+                        <a:srgbClr val="FFFFFF"/>
+                      </a:solidFill>
+                      <a:prstDash val="solid"/>
+                      <a:round/>
+                      <a:headEnd type="none" w="med" len="med"/>
+                      <a:tailEnd type="none" w="med" len="med"/>
+                    </a:lnT>
+                    <a:lnB w="12700" cap="flat" cmpd="sng" algn="ctr">
+                      <a:solidFill>
+                        <a:srgbClr val="FFFFFF"/>
+                      </a:solidFill>
+                      <a:prstDash val="solid"/>
+                      <a:round/>
+                      <a:headEnd type="none" w="med" len="med"/>
+                      <a:tailEnd type="none" w="med" len="med"/>
+                    </a:lnB>
+                    <a:solidFill>
+                      <a:srgbClr val="FFFFFF"/>
+                    </a:solidFill>
+                  </a:tcPr>
+                </a:tc>
+                <a:tc>
+                  <a:txBody>
+                    <a:bodyPr/>
+                    <a:lstStyle/>
+                    <a:p>
+                      <a:pPr algn="ctr" indent="0" marL="0">
+                        <a:buNone/>
+                      </a:pPr>
+                      <a:r>
+                        <a:rPr lang="en-US" sz="1200" dirty="0">
+                          <a:solidFill>
+                            <a:srgbClr val="1B2233"/>
+                          </a:solidFill>
+                        </a:rPr>
+                        <a:t>0.2°</a:t>
+                      </a:r>
+                      <a:endParaRPr lang="en-US" sz="1200" dirty="0"/>
+                    </a:p>
+                  </a:txBody>
+                  <a:tcPr marL="73152" marR="73152" marT="18288" marB="18288" anchor="ctr">
+                    <a:lnL w="12700" cap="flat" cmpd="sng" algn="ctr">
+                      <a:solidFill>
+                        <a:srgbClr val="FFFFFF"/>
+                      </a:solidFill>
+                      <a:prstDash val="solid"/>
+                      <a:round/>
+                      <a:headEnd type="none" w="med" len="med"/>
+                      <a:tailEnd type="none" w="med" len="med"/>
+                    </a:lnL>
+                    <a:lnR w="12700" cap="flat" cmpd="sng" algn="ctr">
+                      <a:solidFill>
+                        <a:srgbClr val="FFFFFF"/>
+                      </a:solidFill>
+                      <a:prstDash val="solid"/>
+                      <a:round/>
+                      <a:headEnd type="none" w="med" len="med"/>
+                      <a:tailEnd type="none" w="med" len="med"/>
+                    </a:lnR>
+                    <a:lnT w="12700" cap="flat" cmpd="sng" algn="ctr">
+                      <a:solidFill>
+                        <a:srgbClr val="FFFFFF"/>
+                      </a:solidFill>
+                      <a:prstDash val="solid"/>
+                      <a:round/>
+                      <a:headEnd type="none" w="med" len="med"/>
+                      <a:tailEnd type="none" w="med" len="med"/>
+                    </a:lnT>
+                    <a:lnB w="12700" cap="flat" cmpd="sng" algn="ctr">
+                      <a:solidFill>
+                        <a:srgbClr val="FFFFFF"/>
+                      </a:solidFill>
+                      <a:prstDash val="solid"/>
+                      <a:round/>
+                      <a:headEnd type="none" w="med" len="med"/>
+                      <a:tailEnd type="none" w="med" len="med"/>
+                    </a:lnB>
+                    <a:solidFill>
+                      <a:srgbClr val="FFFFFF"/>
+                    </a:solidFill>
+                  </a:tcPr>
+                </a:tc>
+              </a:tr>
+              <a:tr h="246888">
+                <a:tc>
+                  <a:txBody>
+                    <a:bodyPr/>
+                    <a:lstStyle/>
+                    <a:p>
+                      <a:pPr algn="l" indent="0" marL="0">
+                        <a:buNone/>
+                      </a:pPr>
+                      <a:r>
+                        <a:rPr lang="en-US" sz="1200" b="1" dirty="0">
+                          <a:solidFill>
+                            <a:srgbClr val="1B2233"/>
+                          </a:solidFill>
+                        </a:rPr>
+                        <a:t>whole head direction</a:t>
+                      </a:r>
+                      <a:endParaRPr lang="en-US" sz="1200" dirty="0"/>
+                    </a:p>
+                  </a:txBody>
+                  <a:tcPr marL="73152" marR="73152" marT="18288" marB="18288" anchor="ctr">
+                    <a:lnL w="12700" cap="flat" cmpd="sng" algn="ctr">
+                      <a:solidFill>
+                        <a:srgbClr val="FFFFFF"/>
+                      </a:solidFill>
+                      <a:prstDash val="solid"/>
+                      <a:round/>
+                      <a:headEnd type="none" w="med" len="med"/>
+                      <a:tailEnd type="none" w="med" len="med"/>
+                    </a:lnL>
+                    <a:lnR w="12700" cap="flat" cmpd="sng" algn="ctr">
+                      <a:solidFill>
+                        <a:srgbClr val="FFFFFF"/>
+                      </a:solidFill>
+                      <a:prstDash val="solid"/>
+                      <a:round/>
+                      <a:headEnd type="none" w="med" len="med"/>
+                      <a:tailEnd type="none" w="med" len="med"/>
+                    </a:lnR>
+                    <a:lnT w="12700" cap="flat" cmpd="sng" algn="ctr">
+                      <a:solidFill>
+                        <a:srgbClr val="FFFFFF"/>
+                      </a:solidFill>
+                      <a:prstDash val="solid"/>
+                      <a:round/>
+                      <a:headEnd type="none" w="med" len="med"/>
+                      <a:tailEnd type="none" w="med" len="med"/>
+                    </a:lnT>
+                    <a:lnB w="12700" cap="flat" cmpd="sng" algn="ctr">
+                      <a:solidFill>
+                        <a:srgbClr val="FFFFFF"/>
+                      </a:solidFill>
+                      <a:prstDash val="solid"/>
+                      <a:round/>
+                      <a:headEnd type="none" w="med" len="med"/>
+                      <a:tailEnd type="none" w="med" len="med"/>
+                    </a:lnB>
+                    <a:solidFill>
+                      <a:srgbClr val="EEF2F7"/>
+                    </a:solidFill>
+                  </a:tcPr>
+                </a:tc>
+                <a:tc>
+                  <a:txBody>
+                    <a:bodyPr/>
+                    <a:lstStyle/>
+                    <a:p>
+                      <a:pPr algn="ctr" indent="0" marL="0">
+                        <a:buNone/>
+                      </a:pPr>
+                      <a:r>
+                        <a:rPr lang="en-US" sz="1200" dirty="0">
+                          <a:solidFill>
+                            <a:srgbClr val="1B2233"/>
+                          </a:solidFill>
+                        </a:rPr>
+                        <a:t>12.0–14.9°</a:t>
+                      </a:r>
+                      <a:endParaRPr lang="en-US" sz="1200" dirty="0"/>
+                    </a:p>
+                  </a:txBody>
+                  <a:tcPr marL="73152" marR="73152" marT="18288" marB="18288" anchor="ctr">
+                    <a:lnL w="12700" cap="flat" cmpd="sng" algn="ctr">
+                      <a:solidFill>
+                        <a:srgbClr val="FFFFFF"/>
+                      </a:solidFill>
+                      <a:prstDash val="solid"/>
+                      <a:round/>
+                      <a:headEnd type="none" w="med" len="med"/>
+                      <a:tailEnd type="none" w="med" len="med"/>
+                    </a:lnL>
+                    <a:lnR w="12700" cap="flat" cmpd="sng" algn="ctr">
+                      <a:solidFill>
+                        <a:srgbClr val="FFFFFF"/>
+                      </a:solidFill>
+                      <a:prstDash val="solid"/>
+                      <a:round/>
+                      <a:headEnd type="none" w="med" len="med"/>
+                      <a:tailEnd type="none" w="med" len="med"/>
+                    </a:lnR>
+                    <a:lnT w="12700" cap="flat" cmpd="sng" algn="ctr">
+                      <a:solidFill>
+                        <a:srgbClr val="FFFFFF"/>
+                      </a:solidFill>
+                      <a:prstDash val="solid"/>
+                      <a:round/>
+                      <a:headEnd type="none" w="med" len="med"/>
+                      <a:tailEnd type="none" w="med" len="med"/>
+                    </a:lnT>
+                    <a:lnB w="12700" cap="flat" cmpd="sng" algn="ctr">
+                      <a:solidFill>
+                        <a:srgbClr val="FFFFFF"/>
+                      </a:solidFill>
+                      <a:prstDash val="solid"/>
+                      <a:round/>
+                      <a:headEnd type="none" w="med" len="med"/>
+                      <a:tailEnd type="none" w="med" len="med"/>
+                    </a:lnB>
+                    <a:solidFill>
+                      <a:srgbClr val="EEF2F7"/>
+                    </a:solidFill>
+                  </a:tcPr>
+                </a:tc>
+                <a:tc>
+                  <a:txBody>
+                    <a:bodyPr/>
+                    <a:lstStyle/>
+                    <a:p>
+                      <a:pPr algn="ctr" indent="0" marL="0">
+                        <a:buNone/>
+                      </a:pPr>
+                      <a:r>
+                        <a:rPr lang="en-US" sz="1200" dirty="0">
+                          <a:solidFill>
+                            <a:srgbClr val="1B2233"/>
+                          </a:solidFill>
+                        </a:rPr>
+                        <a:t>12.9°</a:t>
+                      </a:r>
+                      <a:endParaRPr lang="en-US" sz="1200" dirty="0"/>
+                    </a:p>
+                  </a:txBody>
+                  <a:tcPr marL="73152" marR="73152" marT="18288" marB="18288" anchor="ctr">
+                    <a:lnL w="12700" cap="flat" cmpd="sng" algn="ctr">
+                      <a:solidFill>
+                        <a:srgbClr val="FFFFFF"/>
+                      </a:solidFill>
+                      <a:prstDash val="solid"/>
+                      <a:round/>
+                      <a:headEnd type="none" w="med" len="med"/>
+                      <a:tailEnd type="none" w="med" len="med"/>
+                    </a:lnL>
+                    <a:lnR w="12700" cap="flat" cmpd="sng" algn="ctr">
+                      <a:solidFill>
+                        <a:srgbClr val="FFFFFF"/>
+                      </a:solidFill>
+                      <a:prstDash val="solid"/>
+                      <a:round/>
+                      <a:headEnd type="none" w="med" len="med"/>
+                      <a:tailEnd type="none" w="med" len="med"/>
+                    </a:lnR>
+                    <a:lnT w="12700" cap="flat" cmpd="sng" algn="ctr">
+                      <a:solidFill>
+                        <a:srgbClr val="FFFFFF"/>
+                      </a:solidFill>
+                      <a:prstDash val="solid"/>
+                      <a:round/>
+                      <a:headEnd type="none" w="med" len="med"/>
+                      <a:tailEnd type="none" w="med" len="med"/>
+                    </a:lnT>
+                    <a:lnB w="12700" cap="flat" cmpd="sng" algn="ctr">
+                      <a:solidFill>
+                        <a:srgbClr val="FFFFFF"/>
+                      </a:solidFill>
+                      <a:prstDash val="solid"/>
+                      <a:round/>
+                      <a:headEnd type="none" w="med" len="med"/>
+                      <a:tailEnd type="none" w="med" len="med"/>
+                    </a:lnB>
+                    <a:solidFill>
+                      <a:srgbClr val="EEF2F7"/>
+                    </a:solidFill>
+                  </a:tcPr>
+                </a:tc>
+              </a:tr>
+              <a:tr h="246888">
+                <a:tc>
+                  <a:txBody>
+                    <a:bodyPr/>
+                    <a:lstStyle/>
+                    <a:p>
+                      <a:pPr algn="l" indent="0" marL="0">
+                        <a:buNone/>
+                      </a:pPr>
+                      <a:r>
+                        <a:rPr lang="en-US" sz="1200" b="1" dirty="0">
+                          <a:solidFill>
+                            <a:srgbClr val="1B2233"/>
+                          </a:solidFill>
+                        </a:rPr>
+                        <a:t>neck thickness (pred / true)</a:t>
+                      </a:r>
+                      <a:endParaRPr lang="en-US" sz="1200" dirty="0"/>
+                    </a:p>
+                  </a:txBody>
+                  <a:tcPr marL="73152" marR="73152" marT="18288" marB="18288" anchor="ctr">
+                    <a:lnL w="12700" cap="flat" cmpd="sng" algn="ctr">
+                      <a:solidFill>
+                        <a:srgbClr val="FFFFFF"/>
+                      </a:solidFill>
+                      <a:prstDash val="solid"/>
+                      <a:round/>
+                      <a:headEnd type="none" w="med" len="med"/>
+                      <a:tailEnd type="none" w="med" len="med"/>
+                    </a:lnL>
+                    <a:lnR w="12700" cap="flat" cmpd="sng" algn="ctr">
+                      <a:solidFill>
+                        <a:srgbClr val="FFFFFF"/>
+                      </a:solidFill>
+                      <a:prstDash val="solid"/>
+                      <a:round/>
+                      <a:headEnd type="none" w="med" len="med"/>
+                      <a:tailEnd type="none" w="med" len="med"/>
+                    </a:lnR>
+                    <a:lnT w="12700" cap="flat" cmpd="sng" algn="ctr">
+                      <a:solidFill>
+                        <a:srgbClr val="FFFFFF"/>
+                      </a:solidFill>
+                      <a:prstDash val="solid"/>
+                      <a:round/>
+                      <a:headEnd type="none" w="med" len="med"/>
+                      <a:tailEnd type="none" w="med" len="med"/>
+                    </a:lnT>
+                    <a:lnB w="12700" cap="flat" cmpd="sng" algn="ctr">
+                      <a:solidFill>
+                        <a:srgbClr val="FFFFFF"/>
+                      </a:solidFill>
+                      <a:prstDash val="solid"/>
+                      <a:round/>
+                      <a:headEnd type="none" w="med" len="med"/>
+                      <a:tailEnd type="none" w="med" len="med"/>
+                    </a:lnB>
+                    <a:solidFill>
+                      <a:srgbClr val="FFFFFF"/>
+                    </a:solidFill>
+                  </a:tcPr>
+                </a:tc>
+                <a:tc>
+                  <a:txBody>
+                    <a:bodyPr/>
+                    <a:lstStyle/>
+                    <a:p>
+                      <a:pPr algn="ctr" indent="0" marL="0">
+                        <a:buNone/>
+                      </a:pPr>
+                      <a:r>
+                        <a:rPr lang="en-US" sz="1200" b="1" dirty="0">
+                          <a:solidFill>
+                            <a:srgbClr val="C0392B"/>
+                          </a:solidFill>
+                        </a:rPr>
+                        <a:t>0.46–0.47</a:t>
+                      </a:r>
+                      <a:endParaRPr lang="en-US" sz="1200" dirty="0"/>
+                    </a:p>
+                  </a:txBody>
+                  <a:tcPr marL="73152" marR="73152" marT="18288" marB="18288" anchor="ctr">
+                    <a:lnL w="12700" cap="flat" cmpd="sng" algn="ctr">
+                      <a:solidFill>
+                        <a:srgbClr val="FFFFFF"/>
+                      </a:solidFill>
+                      <a:prstDash val="solid"/>
+                      <a:round/>
+                      <a:headEnd type="none" w="med" len="med"/>
+                      <a:tailEnd type="none" w="med" len="med"/>
+                    </a:lnL>
+                    <a:lnR w="12700" cap="flat" cmpd="sng" algn="ctr">
+                      <a:solidFill>
+                        <a:srgbClr val="FFFFFF"/>
+                      </a:solidFill>
+                      <a:prstDash val="solid"/>
+                      <a:round/>
+                      <a:headEnd type="none" w="med" len="med"/>
+                      <a:tailEnd type="none" w="med" len="med"/>
+                    </a:lnR>
+                    <a:lnT w="12700" cap="flat" cmpd="sng" algn="ctr">
+                      <a:solidFill>
+                        <a:srgbClr val="FFFFFF"/>
+                      </a:solidFill>
+                      <a:prstDash val="solid"/>
+                      <a:round/>
+                      <a:headEnd type="none" w="med" len="med"/>
+                      <a:tailEnd type="none" w="med" len="med"/>
+                    </a:lnT>
+                    <a:lnB w="12700" cap="flat" cmpd="sng" algn="ctr">
+                      <a:solidFill>
+                        <a:srgbClr val="FFFFFF"/>
+                      </a:solidFill>
+                      <a:prstDash val="solid"/>
+                      <a:round/>
+                      <a:headEnd type="none" w="med" len="med"/>
+                      <a:tailEnd type="none" w="med" len="med"/>
+                    </a:lnB>
+                    <a:solidFill>
+                      <a:srgbClr val="FFFFFF"/>
+                    </a:solidFill>
+                  </a:tcPr>
+                </a:tc>
+                <a:tc>
+                  <a:txBody>
+                    <a:bodyPr/>
+                    <a:lstStyle/>
+                    <a:p>
+                      <a:pPr algn="ctr" indent="0" marL="0">
+                        <a:buNone/>
+                      </a:pPr>
+                      <a:r>
+                        <a:rPr lang="en-US" sz="1200" dirty="0">
+                          <a:solidFill>
+                            <a:srgbClr val="1B2233"/>
+                          </a:solidFill>
+                        </a:rPr>
+                        <a:t>1.00</a:t>
+                      </a:r>
+                      <a:endParaRPr lang="en-US" sz="1200" dirty="0"/>
+                    </a:p>
+                  </a:txBody>
+                  <a:tcPr marL="73152" marR="73152" marT="18288" marB="18288" anchor="ctr">
+                    <a:lnL w="12700" cap="flat" cmpd="sng" algn="ctr">
+                      <a:solidFill>
+                        <a:srgbClr val="FFFFFF"/>
+                      </a:solidFill>
+                      <a:prstDash val="solid"/>
+                      <a:round/>
+                      <a:headEnd type="none" w="med" len="med"/>
+                      <a:tailEnd type="none" w="med" len="med"/>
+                    </a:lnL>
+                    <a:lnR w="12700" cap="flat" cmpd="sng" algn="ctr">
+                      <a:solidFill>
+                        <a:srgbClr val="FFFFFF"/>
+                      </a:solidFill>
+                      <a:prstDash val="solid"/>
+                      <a:round/>
+                      <a:headEnd type="none" w="med" len="med"/>
+                      <a:tailEnd type="none" w="med" len="med"/>
+                    </a:lnR>
+                    <a:lnT w="12700" cap="flat" cmpd="sng" algn="ctr">
+                      <a:solidFill>
+                        <a:srgbClr val="FFFFFF"/>
+                      </a:solidFill>
+                      <a:prstDash val="solid"/>
+                      <a:round/>
+                      <a:headEnd type="none" w="med" len="med"/>
+                      <a:tailEnd type="none" w="med" len="med"/>
+                    </a:lnT>
+                    <a:lnB w="12700" cap="flat" cmpd="sng" algn="ctr">
+                      <a:solidFill>
+                        <a:srgbClr val="FFFFFF"/>
+                      </a:solidFill>
+                      <a:prstDash val="solid"/>
+                      <a:round/>
+                      <a:headEnd type="none" w="med" len="med"/>
+                      <a:tailEnd type="none" w="med" len="med"/>
+                    </a:lnB>
+                    <a:solidFill>
+                      <a:srgbClr val="FFFFFF"/>
+                    </a:solidFill>
+                  </a:tcPr>
+                </a:tc>
+              </a:tr>
+              <a:tr h="246888">
+                <a:tc>
+                  <a:txBody>
+                    <a:bodyPr/>
+                    <a:lstStyle/>
+                    <a:p>
+                      <a:pPr algn="l" indent="0" marL="0">
+                        <a:buNone/>
+                      </a:pPr>
+                      <a:r>
+                        <a:rPr lang="en-US" sz="1200" b="1" dirty="0">
+                          <a:solidFill>
+                            <a:srgbClr val="1B2233"/>
+                          </a:solidFill>
+                        </a:rPr>
+                        <a:t>neck-skin error</a:t>
+                      </a:r>
+                      <a:endParaRPr lang="en-US" sz="1200" dirty="0"/>
+                    </a:p>
+                  </a:txBody>
+                  <a:tcPr marL="73152" marR="73152" marT="18288" marB="18288" anchor="ctr">
+                    <a:lnL w="12700" cap="flat" cmpd="sng" algn="ctr">
+                      <a:solidFill>
+                        <a:srgbClr val="FFFFFF"/>
+                      </a:solidFill>
+                      <a:prstDash val="solid"/>
+                      <a:round/>
+                      <a:headEnd type="none" w="med" len="med"/>
+                      <a:tailEnd type="none" w="med" len="med"/>
+                    </a:lnL>
+                    <a:lnR w="12700" cap="flat" cmpd="sng" algn="ctr">
+                      <a:solidFill>
+                        <a:srgbClr val="FFFFFF"/>
+                      </a:solidFill>
+                      <a:prstDash val="solid"/>
+                      <a:round/>
+                      <a:headEnd type="none" w="med" len="med"/>
+                      <a:tailEnd type="none" w="med" len="med"/>
+                    </a:lnR>
+                    <a:lnT w="12700" cap="flat" cmpd="sng" algn="ctr">
+                      <a:solidFill>
+                        <a:srgbClr val="FFFFFF"/>
+                      </a:solidFill>
+                      <a:prstDash val="solid"/>
+                      <a:round/>
+                      <a:headEnd type="none" w="med" len="med"/>
+                      <a:tailEnd type="none" w="med" len="med"/>
+                    </a:lnT>
+                    <a:lnB w="12700" cap="flat" cmpd="sng" algn="ctr">
+                      <a:solidFill>
+                        <a:srgbClr val="FFFFFF"/>
+                      </a:solidFill>
+                      <a:prstDash val="solid"/>
+                      <a:round/>
+                      <a:headEnd type="none" w="med" len="med"/>
+                      <a:tailEnd type="none" w="med" len="med"/>
+                    </a:lnB>
+                    <a:solidFill>
+                      <a:srgbClr val="EEF2F7"/>
+                    </a:solidFill>
+                  </a:tcPr>
+                </a:tc>
+                <a:tc>
+                  <a:txBody>
+                    <a:bodyPr/>
+                    <a:lstStyle/>
+                    <a:p>
+                      <a:pPr algn="ctr" indent="0" marL="0">
+                        <a:buNone/>
+                      </a:pPr>
+                      <a:r>
+                        <a:rPr lang="en-US" sz="1200" b="1" dirty="0">
+                          <a:solidFill>
+                            <a:srgbClr val="C0392B"/>
+                          </a:solidFill>
+                        </a:rPr>
+                        <a:t>27.3–28.7 mm</a:t>
+                      </a:r>
+                      <a:endParaRPr lang="en-US" sz="1200" dirty="0"/>
+                    </a:p>
+                  </a:txBody>
+                  <a:tcPr marL="73152" marR="73152" marT="18288" marB="18288" anchor="ctr">
+                    <a:lnL w="12700" cap="flat" cmpd="sng" algn="ctr">
+                      <a:solidFill>
+                        <a:srgbClr val="FFFFFF"/>
+                      </a:solidFill>
+                      <a:prstDash val="solid"/>
+                      <a:round/>
+                      <a:headEnd type="none" w="med" len="med"/>
+                      <a:tailEnd type="none" w="med" len="med"/>
+                    </a:lnL>
+                    <a:lnR w="12700" cap="flat" cmpd="sng" algn="ctr">
+                      <a:solidFill>
+                        <a:srgbClr val="FFFFFF"/>
+                      </a:solidFill>
+                      <a:prstDash val="solid"/>
+                      <a:round/>
+                      <a:headEnd type="none" w="med" len="med"/>
+                      <a:tailEnd type="none" w="med" len="med"/>
+                    </a:lnR>
+                    <a:lnT w="12700" cap="flat" cmpd="sng" algn="ctr">
+                      <a:solidFill>
+                        <a:srgbClr val="FFFFFF"/>
+                      </a:solidFill>
+                      <a:prstDash val="solid"/>
+                      <a:round/>
+                      <a:headEnd type="none" w="med" len="med"/>
+                      <a:tailEnd type="none" w="med" len="med"/>
+                    </a:lnT>
+                    <a:lnB w="12700" cap="flat" cmpd="sng" algn="ctr">
+                      <a:solidFill>
+                        <a:srgbClr val="FFFFFF"/>
+                      </a:solidFill>
+                      <a:prstDash val="solid"/>
+                      <a:round/>
+                      <a:headEnd type="none" w="med" len="med"/>
+                      <a:tailEnd type="none" w="med" len="med"/>
+                    </a:lnB>
+                    <a:solidFill>
+                      <a:srgbClr val="EEF2F7"/>
+                    </a:solidFill>
+                  </a:tcPr>
+                </a:tc>
+                <a:tc>
+                  <a:txBody>
+                    <a:bodyPr/>
+                    <a:lstStyle/>
+                    <a:p>
+                      <a:pPr algn="ctr" indent="0" marL="0">
+                        <a:buNone/>
+                      </a:pPr>
+                      <a:r>
+                        <a:rPr lang="en-US" sz="1200" dirty="0">
+                          <a:solidFill>
+                            <a:srgbClr val="1B2233"/>
+                          </a:solidFill>
+                        </a:rPr>
+                        <a:t>10.3 mm</a:t>
+                      </a:r>
+                      <a:endParaRPr lang="en-US" sz="1200" dirty="0"/>
+                    </a:p>
+                  </a:txBody>
+                  <a:tcPr marL="73152" marR="73152" marT="18288" marB="18288" anchor="ctr">
+                    <a:lnL w="12700" cap="flat" cmpd="sng" algn="ctr">
+                      <a:solidFill>
+                        <a:srgbClr val="FFFFFF"/>
+                      </a:solidFill>
+                      <a:prstDash val="solid"/>
+                      <a:round/>
+                      <a:headEnd type="none" w="med" len="med"/>
+                      <a:tailEnd type="none" w="med" len="med"/>
+                    </a:lnL>
+                    <a:lnR w="12700" cap="flat" cmpd="sng" algn="ctr">
+                      <a:solidFill>
+                        <a:srgbClr val="FFFFFF"/>
+                      </a:solidFill>
+                      <a:prstDash val="solid"/>
+                      <a:round/>
+                      <a:headEnd type="none" w="med" len="med"/>
+                      <a:tailEnd type="none" w="med" len="med"/>
+                    </a:lnR>
+                    <a:lnT w="12700" cap="flat" cmpd="sng" algn="ctr">
+                      <a:solidFill>
+                        <a:srgbClr val="FFFFFF"/>
+                      </a:solidFill>
+                      <a:prstDash val="solid"/>
+                      <a:round/>
+                      <a:headEnd type="none" w="med" len="med"/>
+                      <a:tailEnd type="none" w="med" len="med"/>
+                    </a:lnT>
+                    <a:lnB w="12700" cap="flat" cmpd="sng" algn="ctr">
+                      <a:solidFill>
+                        <a:srgbClr val="FFFFFF"/>
+                      </a:solidFill>
+                      <a:prstDash val="solid"/>
+                      <a:round/>
+                      <a:headEnd type="none" w="med" len="med"/>
+                      <a:tailEnd type="none" w="med" len="med"/>
+                    </a:lnB>
+                    <a:solidFill>
+                      <a:srgbClr val="EEF2F7"/>
+                    </a:solidFill>
+                  </a:tcPr>
+                </a:tc>
+              </a:tr>
+            </a:tbl>
+          </a:graphicData>
+        </a:graphic>
+      </p:graphicFrame>
+      <p:sp>
+        <p:nvSpPr>
+          <p:cNvPr id="4" name="neck table note"/>
           <p:cNvSpPr txBox="1"/>
           <p:nvPr/>
         </p:nvSpPr>
         <p:spPr>
           <a:xfrm>
-            <a:off x="457200" y="1280160"/>
-            <a:ext cx="2560320" cy="822960"/>
+            <a:off x="457200" y="3529584"/>
+            <a:ext cx="4434840" cy="365760"/>
           </a:xfrm>
           <a:prstGeom prst="rect">
             <a:avLst/>
@@ -17196,34 +18906,34 @@
           <a:ln/>
         </p:spPr>
         <p:txBody>
-          <a:bodyPr wrap="square" lIns="0" tIns="0" rIns="0" bIns="0" rtlCol="0" anchor="ctr"/>
+          <a:bodyPr wrap="square" lIns="0" tIns="0" rIns="0" bIns="0" rtlCol="0" anchor="t"/>
           <a:lstStyle/>
           <a:p>
-            <a:pPr algn="l" indent="0" marL="0">
+            <a:pPr indent="0" marL="0">
               <a:buNone/>
             </a:pPr>
             <a:r>
-              <a:rPr lang="en-US" sz="4000" b="1" dirty="0">
-                <a:solidFill>
-                  <a:schemeClr val="accent1"/>
-                </a:solidFill>
-              </a:rPr>
-              <a:t>99%</a:t>
-            </a:r>
-            <a:endParaRPr lang="en-US" sz="4000" dirty="0"/>
-          </a:p>
-        </p:txBody>
-      </p:sp>
-      <p:sp>
-        <p:nvSpPr>
-          <p:cNvPr id="4" name="label predicted neck length vs truth (holdout); with the true shape it is exact"/>
+              <a:rPr lang="en-US" sz="1100" dirty="0">
+                <a:solidFill>
+                  <a:schemeClr val="tx2"/>
+                </a:solidFill>
+              </a:rPr>
+              <a:t>Bone rows: median angle vs parent bone. Head direction: whole head. Thickness: neck-skin radius. Neck-skin error: centred at neck01.</a:t>
+            </a:r>
+            <a:endParaRPr lang="en-US" sz="1100" dirty="0"/>
+          </a:p>
+        </p:txBody>
+      </p:sp>
+      <p:sp>
+        <p:nvSpPr>
+          <p:cNvPr id="5" name="neck text"/>
           <p:cNvSpPr txBox="1"/>
           <p:nvPr/>
         </p:nvSpPr>
         <p:spPr>
           <a:xfrm>
-            <a:off x="457200" y="2103120"/>
-            <a:ext cx="2560320" cy="640080"/>
+            <a:off x="5120640" y="1188720"/>
+            <a:ext cx="3566160" cy="2670048"/>
           </a:xfrm>
           <a:prstGeom prst="rect">
             <a:avLst/>
@@ -17235,179 +18945,125 @@
           <a:bodyPr wrap="square" lIns="0" tIns="0" rIns="0" bIns="0" rtlCol="0" anchor="t"/>
           <a:lstStyle/>
           <a:p>
-            <a:pPr algn="l" indent="0" marL="0">
-              <a:buNone/>
+            <a:pPr marL="177800" indent="-177800">
+              <a:spcAft>
+                <a:spcPts val="600"/>
+              </a:spcAft>
+              <a:buSzPct val="100000"/>
+              <a:buChar char="•"/>
             </a:pPr>
             <a:r>
-              <a:rPr lang="en-US" sz="1300" dirty="0">
-                <a:solidFill>
-                  <a:schemeClr val="tx2"/>
-                </a:solidFill>
-              </a:rPr>
-              <a:t>predicted neck length vs truth (holdout); with the true shape it is exact</a:t>
-            </a:r>
-            <a:endParaRPr lang="en-US" sz="1300" dirty="0"/>
-          </a:p>
-        </p:txBody>
-      </p:sp>
-      <p:sp>
-        <p:nvSpPr>
-          <p:cNvPr id="5" name="stat neck bones / head + jaw vs parent bone (v5, v9, all pilots); in v5 the same for every person (±1.5°)"/>
-          <p:cNvSpPr txBox="1"/>
-          <p:nvPr/>
-        </p:nvSpPr>
-        <p:spPr>
-          <a:xfrm>
-            <a:off x="3200400" y="1280160"/>
-            <a:ext cx="2560320" cy="822960"/>
-          </a:xfrm>
-          <a:prstGeom prst="rect">
-            <a:avLst/>
-          </a:prstGeom>
-          <a:noFill/>
-          <a:ln/>
-        </p:spPr>
-        <p:txBody>
-          <a:bodyPr wrap="square" lIns="0" tIns="0" rIns="0" bIns="0" rtlCol="0" anchor="ctr"/>
-          <a:lstStyle/>
-          <a:p>
-            <a:pPr algn="l" indent="0" marL="0">
-              <a:buNone/>
+              <a:rPr lang="en-US" sz="1200" b="1" dirty="0">
+                <a:solidFill>
+                  <a:schemeClr val="tx1"/>
+                </a:solidFill>
+              </a:rPr>
+              <a:t>Since the first training stage: </a:t>
+            </a:r>
+            <a:r>
+              <a:rPr lang="en-US" sz="1200" dirty="0">
+                <a:solidFill>
+                  <a:schemeClr val="tx1"/>
+                </a:solidFill>
+              </a:rPr>
+              <a:t>already in frozen_bb_v2, unchanged in v3, v4, v5, v9 and every pilot checked.</a:t>
+            </a:r>
+            <a:endParaRPr lang="en-US" sz="1200" dirty="0"/>
+          </a:p>
+          <a:p>
+            <a:pPr marL="177800" indent="-177800">
+              <a:spcAft>
+                <a:spcPts val="600"/>
+              </a:spcAft>
+              <a:buSzPct val="100000"/>
+              <a:buChar char="•"/>
             </a:pPr>
             <a:r>
-              <a:rPr lang="en-US" sz="4000" b="1" dirty="0">
-                <a:solidFill>
-                  <a:schemeClr val="accent4"/>
-                </a:solidFill>
-              </a:rPr>
-              <a:t>63° / 90°</a:t>
-            </a:r>
-            <a:endParaRPr lang="en-US" sz="4000" dirty="0"/>
-          </a:p>
-        </p:txBody>
-      </p:sp>
-      <p:sp>
-        <p:nvSpPr>
-          <p:cNvPr id="6" name="label neck bones / head + jaw vs parent bone (v5, v9, all pilots); in v5 the same for every person (±1.5°)"/>
-          <p:cNvSpPr txBox="1"/>
-          <p:nvPr/>
-        </p:nvSpPr>
-        <p:spPr>
-          <a:xfrm>
-            <a:off x="3200400" y="2103120"/>
-            <a:ext cx="2560320" cy="640080"/>
-          </a:xfrm>
-          <a:prstGeom prst="rect">
-            <a:avLst/>
-          </a:prstGeom>
-          <a:noFill/>
-          <a:ln/>
-        </p:spPr>
-        <p:txBody>
-          <a:bodyPr wrap="square" lIns="0" tIns="0" rIns="0" bIns="0" rtlCol="0" anchor="t"/>
-          <a:lstStyle/>
-          <a:p>
-            <a:pPr algn="l" indent="0" marL="0">
-              <a:buNone/>
+              <a:rPr lang="en-US" sz="1200" b="1" dirty="0">
+                <a:solidFill>
+                  <a:schemeClr val="tx1"/>
+                </a:solidFill>
+              </a:rPr>
+              <a:t>Hidden: </a:t>
+            </a:r>
+            <a:r>
+              <a:rPr lang="en-US" sz="1200" dirty="0">
+                <a:solidFill>
+                  <a:schemeClr val="tx1"/>
+                </a:solidFill>
+              </a:rPr>
+              <a:t>the two half-turns cancel, so the whole head still points the right way (12–15° off); body PVE and head direction missed it, only per-bone angles (last week's 63° / 90°) showed it.</a:t>
+            </a:r>
+            <a:endParaRPr lang="en-US" sz="1200" dirty="0"/>
+          </a:p>
+          <a:p>
+            <a:pPr marL="177800" indent="-177800">
+              <a:spcAft>
+                <a:spcPts val="600"/>
+              </a:spcAft>
+              <a:buSzPct val="100000"/>
+              <a:buChar char="•"/>
             </a:pPr>
             <a:r>
-              <a:rPr lang="en-US" sz="1300" dirty="0">
-                <a:solidFill>
-                  <a:schemeClr val="tx2"/>
-                </a:solidFill>
-              </a:rPr>
-              <a:t>neck bones / head + jaw vs parent bone (v5, v9, all pilots); in v5 the same for every person (±1.5°)</a:t>
-            </a:r>
-            <a:endParaRPr lang="en-US" sz="1300" dirty="0"/>
-          </a:p>
-        </p:txBody>
-      </p:sp>
-      <p:sp>
-        <p:nvSpPr>
-          <p:cNvPr id="7" name="stat v10 learns them, but is worse elsewhere (v10 vs v5): PVE 74.1 vs 70.5 mm, shoulders 50° vs 11°"/>
-          <p:cNvSpPr txBox="1"/>
-          <p:nvPr/>
-        </p:nvSpPr>
-        <p:spPr>
-          <a:xfrm>
-            <a:off x="6035040" y="1280160"/>
-            <a:ext cx="2651760" cy="822960"/>
-          </a:xfrm>
-          <a:prstGeom prst="rect">
-            <a:avLst/>
-          </a:prstGeom>
-          <a:noFill/>
-          <a:ln/>
-        </p:spPr>
-        <p:txBody>
-          <a:bodyPr wrap="square" lIns="0" tIns="0" rIns="0" bIns="0" rtlCol="0" anchor="ctr"/>
-          <a:lstStyle/>
-          <a:p>
-            <a:pPr algn="l" indent="0" marL="0">
-              <a:buNone/>
+              <a:rPr lang="en-US" sz="1200" b="1" dirty="0">
+                <a:solidFill>
+                  <a:schemeClr val="tx1"/>
+                </a:solidFill>
+              </a:rPr>
+              <a:t>Same thing elsewhere: </a:t>
+            </a:r>
+            <a:r>
+              <a:rPr lang="en-US" sz="1200" dirty="0">
+                <a:solidFill>
+                  <a:schemeClr val="tx1"/>
+                </a:solidFill>
+              </a:rPr>
+              <a:t>v5 left index base at 180°; v10: left shoulder, left upper arm and 3 hand bones (1 left, 2 right).</a:t>
+            </a:r>
+            <a:endParaRPr lang="en-US" sz="1200" dirty="0"/>
+          </a:p>
+          <a:p>
+            <a:pPr marL="177800" indent="-177800">
+              <a:spcAft>
+                <a:spcPts val="600"/>
+              </a:spcAft>
+              <a:buSzPct val="100000"/>
+              <a:buChar char="•"/>
             </a:pPr>
             <a:r>
-              <a:rPr lang="en-US" sz="4000" b="1" dirty="0">
-                <a:solidFill>
-                  <a:schemeClr val="accent1"/>
-                </a:solidFill>
-              </a:rPr>
-              <a:t>5° / 4°</a:t>
-            </a:r>
-            <a:endParaRPr lang="en-US" sz="4000" dirty="0"/>
-          </a:p>
-        </p:txBody>
-      </p:sp>
-      <p:sp>
-        <p:nvSpPr>
-          <p:cNvPr id="8" name="label v10 learns them, but is worse elsewhere (v10 vs v5): PVE 74.1 vs 70.5 mm, shoulders 50° vs 11°"/>
-          <p:cNvSpPr txBox="1"/>
-          <p:nvPr/>
-        </p:nvSpPr>
-        <p:spPr>
-          <a:xfrm>
-            <a:off x="6035040" y="2103120"/>
-            <a:ext cx="2651760" cy="640080"/>
-          </a:xfrm>
-          <a:prstGeom prst="rect">
-            <a:avLst/>
-          </a:prstGeom>
-          <a:noFill/>
-          <a:ln/>
-        </p:spPr>
-        <p:txBody>
-          <a:bodyPr wrap="square" lIns="0" tIns="0" rIns="0" bIns="0" rtlCol="0" anchor="t"/>
-          <a:lstStyle/>
-          <a:p>
-            <a:pPr algn="l" indent="0" marL="0">
-              <a:buNone/>
-            </a:pPr>
-            <a:r>
-              <a:rPr lang="en-US" sz="1300" dirty="0">
-                <a:solidFill>
-                  <a:schemeClr val="tx2"/>
-                </a:solidFill>
-              </a:rPr>
-              <a:t>v10 learns them, but is worse elsewhere (v10 vs v5): PVE 74.1 vs 70.5 mm, shoulders 50° vs 11°</a:t>
-            </a:r>
-            <a:endParaRPr lang="en-US" sz="1300" dirty="0"/>
-          </a:p>
-        </p:txBody>
-      </p:sp>
-      <p:sp>
-        <p:nvSpPr>
-          <p:cNvPr id="9" name="neck box"/>
+              <a:rPr lang="en-US" sz="1200" b="1" dirty="0">
+                <a:solidFill>
+                  <a:schemeClr val="tx1"/>
+                </a:solidFill>
+              </a:rPr>
+              <a:t>Fine-tuning does not undo it: </a:t>
+            </a:r>
+            <a:r>
+              <a:rPr lang="en-US" sz="1200" dirty="0">
+                <a:solidFill>
+                  <a:schemeClr val="tx1"/>
+                </a:solidFill>
+              </a:rPr>
+              <a:t>2 epochs with a geodesic loss, 175.6 → 175.0°; likely because both bones must turn back together.</a:t>
+            </a:r>
+            <a:endParaRPr lang="en-US" sz="1200" dirty="0"/>
+          </a:p>
+        </p:txBody>
+      </p:sp>
+      <p:sp>
+        <p:nvSpPr>
+          <p:cNvPr id="6" name="neck cause box"/>
           <p:cNvSpPr/>
           <p:nvPr/>
         </p:nvSpPr>
         <p:spPr>
           <a:xfrm>
-            <a:off x="457200" y="2880360"/>
-            <a:ext cx="8229600" cy="1783080"/>
+            <a:off x="457200" y="3931920"/>
+            <a:ext cx="8229600" cy="749808"/>
           </a:xfrm>
           <a:prstGeom prst="roundRect">
             <a:avLst>
-              <a:gd name="adj" fmla="val 4103"/>
+              <a:gd name="adj" fmla="val 9756"/>
             </a:avLst>
           </a:prstGeom>
           <a:solidFill>
@@ -17423,14 +19079,39 @@
       </p:sp>
       <p:sp>
         <p:nvSpPr>
-          <p:cNvPr id="10" name="neck text"/>
+          <p:cNvPr id="7" name="neck cause dot 0"/>
+          <p:cNvSpPr/>
+          <p:nvPr/>
+        </p:nvSpPr>
+        <p:spPr>
+          <a:xfrm>
+            <a:off x="621792" y="4032504"/>
+            <a:ext cx="118872" cy="118872"/>
+          </a:xfrm>
+          <a:prstGeom prst="ellipse">
+            <a:avLst/>
+          </a:prstGeom>
+          <a:solidFill>
+            <a:schemeClr val="accent3"/>
+          </a:solidFill>
+          <a:ln w="12700">
+            <a:solidFill>
+              <a:schemeClr val="accent3"/>
+            </a:solidFill>
+            <a:prstDash val="solid"/>
+          </a:ln>
+        </p:spPr>
+      </p:sp>
+      <p:sp>
+        <p:nvSpPr>
+          <p:cNvPr id="8" name="neck cause 0"/>
           <p:cNvSpPr txBox="1"/>
           <p:nvPr/>
         </p:nvSpPr>
         <p:spPr>
           <a:xfrm>
-            <a:off x="640080" y="2926080"/>
-            <a:ext cx="7863840" cy="1691640"/>
+            <a:off x="841248" y="3977640"/>
+            <a:ext cx="7726680" cy="228600"/>
           </a:xfrm>
           <a:prstGeom prst="rect">
             <a:avLst/>
@@ -17442,20 +19123,85 @@
           <a:bodyPr wrap="square" lIns="0" tIns="0" rIns="0" bIns="0" rtlCol="0" anchor="ctr"/>
           <a:lstStyle/>
           <a:p>
-            <a:pPr marL="177800" indent="-177800">
-              <a:spcAft>
-                <a:spcPts val="300"/>
-              </a:spcAft>
-              <a:buSzPct val="100000"/>
-              <a:buChar char="•"/>
+            <a:pPr indent="0" marL="0">
+              <a:buNone/>
             </a:pPr>
             <a:r>
               <a:rPr lang="en-US" sz="1200" b="1" dirty="0">
                 <a:solidFill>
+                  <a:srgbClr val="1B2233"/>
+                </a:solidFill>
+              </a:rPr>
+              <a:t>Measured (what): </a:t>
+            </a:r>
+            <a:r>
+              <a:rPr lang="en-US" sz="1200" dirty="0">
+                <a:solidFill>
                   <a:schemeClr val="tx1"/>
                 </a:solidFill>
               </a:rPr>
-              <a:t>v10 learns these bones with the same loss function: </a:t>
+              <a:t>neck02 and head each sit about half a turn off, in 100% of the holdout people; not yet rendered.</a:t>
+            </a:r>
+            <a:endParaRPr lang="en-US" sz="1200" dirty="0"/>
+          </a:p>
+        </p:txBody>
+      </p:sp>
+      <p:sp>
+        <p:nvSpPr>
+          <p:cNvPr id="9" name="neck cause dot 1"/>
+          <p:cNvSpPr/>
+          <p:nvPr/>
+        </p:nvSpPr>
+        <p:spPr>
+          <a:xfrm>
+            <a:off x="621792" y="4261104"/>
+            <a:ext cx="118872" cy="118872"/>
+          </a:xfrm>
+          <a:prstGeom prst="ellipse">
+            <a:avLst/>
+          </a:prstGeom>
+          <a:solidFill>
+            <a:schemeClr val="accent5"/>
+          </a:solidFill>
+          <a:ln w="12700">
+            <a:solidFill>
+              <a:schemeClr val="accent5"/>
+            </a:solidFill>
+            <a:prstDash val="solid"/>
+          </a:ln>
+        </p:spPr>
+      </p:sp>
+      <p:sp>
+        <p:nvSpPr>
+          <p:cNvPr id="10" name="neck cause 1"/>
+          <p:cNvSpPr txBox="1"/>
+          <p:nvPr/>
+        </p:nvSpPr>
+        <p:spPr>
+          <a:xfrm>
+            <a:off x="841248" y="4206240"/>
+            <a:ext cx="7726680" cy="228600"/>
+          </a:xfrm>
+          <a:prstGeom prst="rect">
+            <a:avLst/>
+          </a:prstGeom>
+          <a:noFill/>
+          <a:ln/>
+        </p:spPr>
+        <p:txBody>
+          <a:bodyPr wrap="square" lIns="0" tIns="0" rIns="0" bIns="0" rtlCol="0" anchor="ctr"/>
+          <a:lstStyle/>
+          <a:p>
+            <a:pPr indent="0" marL="0">
+              <a:buNone/>
+            </a:pPr>
+            <a:r>
+              <a:rPr lang="en-US" sz="1200" b="1" dirty="0">
+                <a:solidFill>
+                  <a:srgbClr val="1B2233"/>
+                </a:solidFill>
+              </a:rPr>
+              <a:t>Open (why): </a:t>
             </a:r>
             <a:r>
               <a:rPr lang="en-US" sz="1200" dirty="0">
@@ -17463,85 +19209,76 @@
                   <a:schemeClr val="tx1"/>
                 </a:solidFill>
               </a:rPr>
-              <a:t>it was trained masked from the start, with no ×4 neck boost and with 3DPW. v5 started from a frozen backbone; masking and the ×4 boost were added later.</a:t>
+              <a:t>unknown. The singular start value of the rotation output would give a tilt flip (index base), not this twist.</a:t>
             </a:r>
             <a:endParaRPr lang="en-US" sz="1200" dirty="0"/>
           </a:p>
-          <a:p>
-            <a:pPr marL="177800" indent="-177800">
-              <a:spcAft>
-                <a:spcPts val="300"/>
-              </a:spcAft>
-              <a:buSzPct val="100000"/>
-              <a:buChar char="•"/>
+        </p:txBody>
+      </p:sp>
+      <p:sp>
+        <p:nvSpPr>
+          <p:cNvPr id="11" name="neck cause dot 2"/>
+          <p:cNvSpPr/>
+          <p:nvPr/>
+        </p:nvSpPr>
+        <p:spPr>
+          <a:xfrm>
+            <a:off x="621792" y="4489704"/>
+            <a:ext cx="118872" cy="118872"/>
+          </a:xfrm>
+          <a:prstGeom prst="ellipse">
+            <a:avLst/>
+          </a:prstGeom>
+          <a:solidFill>
+            <a:schemeClr val="accent1"/>
+          </a:solidFill>
+          <a:ln w="12700">
+            <a:solidFill>
+              <a:schemeClr val="accent1"/>
+            </a:solidFill>
+            <a:prstDash val="solid"/>
+          </a:ln>
+        </p:spPr>
+      </p:sp>
+      <p:sp>
+        <p:nvSpPr>
+          <p:cNvPr id="12" name="neck cause 2"/>
+          <p:cNvSpPr txBox="1"/>
+          <p:nvPr/>
+        </p:nvSpPr>
+        <p:spPr>
+          <a:xfrm>
+            <a:off x="841248" y="4434840"/>
+            <a:ext cx="7726680" cy="228600"/>
+          </a:xfrm>
+          <a:prstGeom prst="rect">
+            <a:avLst/>
+          </a:prstGeom>
+          <a:noFill/>
+          <a:ln/>
+        </p:spPr>
+        <p:txBody>
+          <a:bodyPr wrap="square" lIns="0" tIns="0" rIns="0" bIns="0" rtlCol="0" anchor="ctr"/>
+          <a:lstStyle/>
+          <a:p>
+            <a:pPr indent="0" marL="0">
+              <a:buNone/>
             </a:pPr>
             <a:r>
               <a:rPr lang="en-US" sz="1200" b="1" dirty="0">
                 <a:solidFill>
+                  <a:srgbClr val="1B2233"/>
+                </a:solidFill>
+              </a:rPr>
+              <a:t>Next (exp6): </a:t>
+            </a:r>
+            <a:r>
+              <a:rPr lang="en-US" sz="1200" dirty="0">
+                <a:solidFill>
                   <a:schemeClr val="tx1"/>
                 </a:solidFill>
               </a:rPr>
-              <a:t>v5 and its fine-tunes are stuck: </a:t>
-            </a:r>
-            <a:r>
-              <a:rPr lang="en-US" sz="1200" dirty="0">
-                <a:solidFill>
-                  <a:schemeClr val="tx1"/>
-                </a:solidFill>
-              </a:rPr>
-              <a:t>150,000 more steps in v9 changed nothing, nor did a pilot that gave head and neck a third of the rotation loss. Yet the whole head still points only 12° off (holdout).</a:t>
-            </a:r>
-            <a:endParaRPr lang="en-US" sz="1200" dirty="0"/>
-          </a:p>
-          <a:p>
-            <a:pPr marL="177800" indent="-177800">
-              <a:spcAft>
-                <a:spcPts val="300"/>
-              </a:spcAft>
-              <a:buSzPct val="100000"/>
-              <a:buChar char="•"/>
-            </a:pPr>
-            <a:r>
-              <a:rPr lang="en-US" sz="1200" b="1" dirty="0">
-                <a:solidFill>
-                  <a:schemeClr val="tx1"/>
-                </a:solidFill>
-              </a:rPr>
-              <a:t>Cause unknown. Best guess, not tested: </a:t>
-            </a:r>
-            <a:r>
-              <a:rPr lang="en-US" sz="1200" dirty="0">
-                <a:solidFill>
-                  <a:schemeClr val="tx1"/>
-                </a:solidFill>
-              </a:rPr>
-              <a:t>the loss compares rotation matrices number by number and can stick near a 180° flip (one of 3 neck bones flipped: mean near 63°; head or jaw flipped: near 90°).</a:t>
-            </a:r>
-            <a:endParaRPr lang="en-US" sz="1200" dirty="0"/>
-          </a:p>
-          <a:p>
-            <a:pPr marL="177800" indent="-177800">
-              <a:spcAft>
-                <a:spcPts val="300"/>
-              </a:spcAft>
-              <a:buSzPct val="100000"/>
-              <a:buChar char="•"/>
-            </a:pPr>
-            <a:r>
-              <a:rPr lang="en-US" sz="1200" b="1" dirty="0">
-                <a:solidFill>
-                  <a:schemeClr val="tx1"/>
-                </a:solidFill>
-              </a:rPr>
-              <a:t>Not yet shown </a:t>
-            </a:r>
-            <a:r>
-              <a:rPr lang="en-US" sz="1200" dirty="0">
-                <a:solidFill>
-                  <a:schemeClr val="tx1"/>
-                </a:solidFill>
-              </a:rPr>
-              <a:t>that this offset makes necks look wrong. Not the depth bug: the neck montage and the real-photo demos place each body from its detection box.</a:t>
+              <a:t>a fixed output correction for the flipped bones, tested with zero training.</a:t>
             </a:r>
             <a:endParaRPr lang="en-US" sz="1200" dirty="0"/>
           </a:p>

</xml_diff>

<commit_message>
docs: deck slide 6 reports the measured 3DPW->Anny conversion check
Joints, nearest-point surface and 2D pass; three label defects (gender reversed,
missing actor in two-person images, labels not built for 8 sequences); limits by
design. Related claims on slides 1, 5, 14-16 and the notes updated.

Co-Authored-By: Claude Opus 5.5 <noreply@anthropic.com>
Claude-Session: https://claude.ai/code/session_016LhpG4kT7Z7ppxbG4TW5S9
</commit_message>
<xml_diff>
--- a/docs/supervisor_update_2026-10-16.pptx
+++ b/docs/supervisor_update_2026-10-16.pptx
@@ -123,7 +123,7 @@
   <p:extLst>
     <p:ext uri="{521415D9-36F7-43E2-AB2F-B90AF26B5E84}">
       <p14:sectionLst xmlns:p14="http://schemas.microsoft.com/office/powerpoint/2010/main">
-        <p14:section name="Overview" id="{bf8bf7df-a7e6-9808-df0f-e3a1d4ef6799}">
+        <p14:section name="Overview" id="{b53d6943-66d5-d318-d95f-77509c60b5b9}">
           <p14:sldIdLst>
             <p14:sldId id="256"/>
             <p14:sldId id="257"/>
@@ -131,27 +131,27 @@
             <p14:sldId id="259"/>
           </p14:sldIdLst>
         </p14:section>
-        <p14:section name="3DPW labels" id="{9c37fc90-15f6-713b-a76e-202b6b4366e1}">
+        <p14:section name="3DPW labels" id="{78b63fef-ceb4-2d3d-cc51-5f4c9e7ba7ed}">
           <p14:sldIdLst>
             <p14:sldId id="260"/>
             <p14:sldId id="261"/>
           </p14:sldIdLst>
         </p14:section>
-        <p14:section name="Findings" id="{cb4013ab-fd32-de11-a9d7-0da37f05f38b}">
+        <p14:section name="Findings" id="{7f188609-64d0-42d5-3127-295f280f608c}">
           <p14:sldIdLst>
             <p14:sldId id="262"/>
             <p14:sldId id="263"/>
             <p14:sldId id="264"/>
           </p14:sldIdLst>
         </p14:section>
-        <p14:section name="Bug" id="{8de466eb-45b4-5317-c665-c8cdc16e0f75}">
+        <p14:section name="Bug" id="{b0385c4e-7fe0-de58-7bba-2f5d5a3a857c}">
           <p14:sldIdLst>
             <p14:sldId id="265"/>
             <p14:sldId id="266"/>
             <p14:sldId id="267"/>
           </p14:sldIdLst>
         </p14:section>
-        <p14:section name="Next" id="{123c569b-bad0-d1f9-ba91-caa9f6ee7ba1}">
+        <p14:section name="Next" id="{3cc4bffa-2bf0-43dc-fb30-d5cac4cc2767}">
           <p14:sldIdLst>
             <p14:sldId id="268"/>
             <p14:sldId id="269"/>
@@ -159,7 +159,7 @@
             <p14:sldId id="271"/>
           </p14:sldIdLst>
         </p14:section>
-        <p14:section name="Appendix" id="{162fc2a4-22f6-d510-6a47-7638894a04f0}">
+        <p14:section name="Appendix" id="{07ae8734-6332-c847-479b-db5612eece1b}">
           <p14:sldIdLst>
             <p14:sldId id="272"/>
           </p14:sldIdLst>
@@ -568,9 +568,8 @@
           <a:p>
             <a:r>
               <a:rPr lang="en-US" dirty="0"/>
-              <a:t>Since last Friday I measured each stage of the pipeline separately. I will show what is not the cause, how the 3DPW labels are made and two bugs I found in them, what I found in the neck and measured about the fingers and the children, one depth bug nobody was looking for and its fix, and what is still open. I will say clearly what is measured and what is only a guess.</a:t>
-            </a:r>
-            <a:endParaRPr lang="en-US" dirty="0"/>
+              <a:t>Since last Friday I measured each stage of the pipeline separately. I will show what is not the cause, how the 3DPW labels are made, how well they match 3DPW and three defects I found in them, what I found in the neck and measured about the fingers and the children, one depth bug nobody was looking for and its fix, and what is still open. I will say clearly what is measured and what is only a guess.</a:t>
+            </a:r>
           </a:p>
         </p:txBody>
       </p:sp>
@@ -658,7 +657,6 @@
               <a:rPr lang="en-US" dirty="0"/>
               <a:t>This is the main result of the week. The model attaches the mesh to the detected pixel by its head joint and reports the head as its position. The training code built the position, distance, heat-map and offset targets at joint 0, the root joint at the pelvis. Those two can never agree. The cause is confirmed: with targets at the head the bodies are drawn much closer to the right size, and a control run with the same schedule does not improve; after 10 epochs its drawn size is 0.59 and its root error 1.44 metres. The likely mechanism is that the 2D losses solve the conflict by pushing the body farther away, so it is drawn smaller. Measured on the holdout for v5: predicted depth is 0.33 times the true depth plus 2.36 metres, all 222 people too far, and the bodies are drawn at about two thirds of their true size in the image, a size ratio of 0.63. Their 3D height is right, 1.405 against 1.409 metres; they are only placed too far away. Our standard error is pelvis-centred, so it never saw this. That is why the thesis numbers looked normal. The real-photo demos did not show it either, because they place each body from its detection box. The synthetic demo and the trace panels use the model's own depth, and there you can see it, as on the next slide. The bug is in the training code, so v9 and v10 have it too: the same kind of depth fit and size ratio, and v10 is slightly worse.</a:t>
             </a:r>
-            <a:endParaRPr lang="en-US" dirty="0"/>
           </a:p>
         </p:txBody>
       </p:sp>
@@ -746,7 +744,6 @@
               <a:rPr lang="en-US" dirty="0"/>
               <a:t>This is the bug on a synthetic holdout image, using the model's own depth, not the box placement of the real-photo demos. Left is the truth. In the middle, the old model: the bodies are drawn too small, the real man's head sticks out above the mesh, and the mesh floats. On the right, the fix with the depth loss five times stronger, trained for 10 epochs. The blue mesh is now 95 percent of the true height; the woman's mesh is closer to her size but still narrower. I chose this image because no person with a ground-truth mesh is missed, so it is a good case, not a typical one; the arm at the bottom left has no ground-truth mesh, so it is not counted as a miss. On the whole holdout the median drawn size is 84 percent of the truth, so bodies are still about 16 percent too small, and near and far people still get similar depths: in the slope, 1 means perfect and 0 means the same depth for everyone. All 12 holdout images we rendered, in all three prediction settings, show the same change. In 4 of them both models miss people very close to the camera; since both miss them, the fix did not cause it. It is likely a detection problem, but not yet counted. Mesh colours follow detection order.</a:t>
             </a:r>
-            <a:endParaRPr lang="en-US" dirty="0"/>
           </a:p>
         </p:txBody>
       </p:sp>
@@ -832,9 +829,17 @@
           <a:p>
             <a:r>
               <a:rPr lang="en-US" dirty="0"/>
-              <a:t>The fix is one switch, gt_center_joint person_center: build the training targets at the head, the joint the model anchors. Each fix run has a control with the same schedule and the switch off; the stronger-loss runs have no control at the same weight. I report the 3D root error: the distance between the predicted and the true root joint, at the pelvis. Drawn size is the predicted over the true head-to-pelvis distance in pixels. The mean signed depth offset fell from 1.08 to 0.39 metres, but after the fix near people are too far and far people too near, and these cancel in that mean, so it flatters the fix. The head now lands within about 7 to 10 pixels, as expected, because the target moved to the head. With the depth loss five times stronger for 10 epochs, the root error falls from 1.21 to 0.54 metres and bodies are drawn at 84 percent of their true size; twenty times for 2 epochs ties with it, and the controls stay at 1.11 to 1.44. But the slope is 0.30 with the switch alone and 0.38 to 0.44 with the stronger depth loss. Predictions are pulled toward about 2.5 to 2.9 metres, close to the estimated training average; holdout people are nearer, 1.9 metres on average, so this pull becomes a large error here. Why the model cannot separate near from far, I do not know. Longer training is not clearly better: with five times, going from 2 to 10 epochs lowered the root error from 0.66 to 0.54 metres but did not improve the slope; with the switch alone neither improved, the root error went from 0.69 to 0.73 metres, and the control also got worse, from 1.11 to 1.44 metres. Root error has no measured noise floor, so I do not read a trend into this. Every fix run is worse than its control in PVE and recall. The PVE gaps, 2.6 to 4.9 millimetres, are inside pilot noise; the recall drops, 1.6 to 2.4 points, are at the edge of what one pilot can detect; and the five fix runs share only two controls, so they are not five independent tests. I count it as a likely cost. The pelvis 2D error clearly got worse, from about 23 pixels to between 31 and 39 pixels; probably because the body is still drawn too small while the head is now pinned, but I have not checked that. The twenty-times 10-epoch run has no result yet.</a:t>
-            </a:r>
+              <a:t>The fix is one switch: build the training targets at the head, the joint the model anchors. Each fix run has a control with the same schedule and the switch off. The root error is the 3D distance between the predicted and the true root joint, at the pelvis. Drawn size is the predicted head-to-pelvis distance in pixels over the true one; 1 is right. With the depth loss five times stronger for 10 epochs, the root error falls from 1.21 to 0.54 metres, and bodies are drawn at 84 percent of their true size. The controls stay at 1.11 to 1.44 metres. But near and far are still not separated: the slope is 0.30 with the switch alone and 0.38 to 0.44 with the stronger depth loss. Predictions are pulled toward about 2.5 to 2.9 metres, and I do not know why. The fix likely has a cost: every fix run is worse than its control, by 2.6 to 4.9 millimetres PVE and 1.6 to 2.4 recall points. That is inside or at the edge of pilot noise, so I call it a likely cost, not a proven one. The twenty-times 10-epoch run has no result yet.</a:t>
+            </a:r>
+          </a:p>
+          <a:p>
             <a:endParaRPr lang="en-US" dirty="0"/>
+          </a:p>
+          <a:p>
+            <a:r>
+              <a:rPr lang="en-US" dirty="0"/>
+              <a:t>If asked: The switch is gt_center_joint person_center. The stronger-loss runs have no control at the same weight. The mean signed depth offset fell from 1.08 to 0.39 metres, but after the fix near people are too far and far people too near, and these cancel in that mean, so it flatters the fix. The head now lands within about 7 to 10 pixels, as expected, because the target moved to the head. Twenty times for 2 epochs ties with five times for 10 epochs. The pull toward 2.5 to 2.9 metres is close to the estimated training average; holdout people are nearer, 1.9 metres on average, so this pull becomes a large error here. Longer training is not clearly better: with five times, going from 2 to 10 epochs lowered the root error from 0.66 to 0.54 metres but did not improve the slope; with the switch alone neither improved, the root error went from 0.69 to 0.73 metres, and the control also got worse, from 1.11 to 1.44 metres. Root error has no measured noise floor, so I do not read a trend into this. The PVE gaps, 2.6 to 4.9 millimetres, are inside pilot noise; the recall drops, 1.6 to 2.4 points, are at the edge of what one pilot can detect; and the five fix runs share only two controls, so they are not five independent tests. The pelvis 2D error clearly got worse, from about 23 pixels to between 31 and 39 pixels; probably because the body is still drawn too small while the head is now pinned, but I have not checked that.</a:t>
+            </a:r>
           </a:p>
         </p:txBody>
       </p:sp>
@@ -920,9 +925,17 @@
           <a:p>
             <a:r>
               <a:rPr lang="en-US" dirty="0"/>
-              <a:t>All four experiments are done. Each ran next to a control with the main switch off, on the same 100-image holdout and manifest, with helper bones masked. The stronger age loss and the stronger depth loss were not separately controlled: both children arms used the same age and height weights, and the depth runs at five and twenty times have no control at the same weight. Depth: by its own success rule the experiment failed. The slope did not move toward 1: it is 0.30 with the switch alone and 0.38 with the five-times depth loss. PVE is 74.8, against 72.2 for the control and 70.5 for v5. What clearly improved is outside the rule: the root error went from 1.21 to 0.54 metres and the drawn size from 0.63 to 0.84. I say that openly instead of changing the rule afterwards. Children, neck and fingers: no measurable effect. The neck loss gave 11.3 degrees of head error, which passes the rule of below 12, but the two controls gave 11.7 and 13.6, so that is inside the noise. The experiments also have a safety limit: PVE at most 71.5 millimetres and recall at least 89.2 percent. The neck run just missed it, with 71.8 millimetres and 89.0 percent, but all five control runs miss it too, mostly because of the restart cost; its PVE is even 4.5 millimetres better than its own control, which is also inside the noise. Its neck bones stayed at 62.5 degrees. For the fingers, the rest-pose floor is 15.2 degrees in this evaluation and 15.1 on slide 8; the difference is only which people are matched. There is no fixed random seed: two identical runs differed by 7.6 millimetres PVE and 1.9 degrees of head error, so one pilot only detects about 10 millimetres, 3 degrees or 2 recall points. Restarting the fine-tune alone costs about 2.4 millimetres. A 2-epoch pilot trains in about 12 minutes, a 10-epoch run in about one hour. No new architecture, because the diagnostics do not justify one.</a:t>
-            </a:r>
+              <a:t>All four experiments are done. Each ran next to a control with the main switch off, on the same 100-image holdout and manifest, with helper bones masked. Depth: by its own success rule the experiment failed. The slope did not move toward 1: it is 0.30 with the switch alone and 0.38 with the five-times depth loss. PVE is 74.8, against 72.2 for the control and 70.5 for v5. What clearly improved is outside the rule: the root error went from 1.21 to 0.54 metres and the drawn size from 0.63 to 0.84. I say that openly instead of changing the rule afterwards. Children, neck and fingers: no measurable effect. The neck loss gave 11.3 degrees of head error, which passes the rule of below 12, but the two controls gave 11.7 and 13.6, so that is inside the noise. There is no fixed random seed: two identical runs differed by 7.6 millimetres PVE and 1.9 degrees of head error, so one pilot only detects about 10 millimetres, 3 degrees or 2 recall points. No new architecture, because the diagnostics do not justify one.</a:t>
+            </a:r>
+          </a:p>
+          <a:p>
             <a:endParaRPr lang="en-US" dirty="0"/>
+          </a:p>
+          <a:p>
+            <a:r>
+              <a:rPr lang="en-US" dirty="0"/>
+              <a:t>If asked: The stronger age loss and the stronger depth loss were not separately controlled: both children arms used the same age and height weights, and the depth runs at five and twenty times have no control at the same weight. The experiments also have a safety limit: PVE at most 71.5 millimetres and recall at least 89.2 percent. The neck run just missed it, with 71.8 millimetres and 89.0 percent, but all five control runs miss it too, mostly because of the restart cost; its PVE is even 4.5 millimetres better than its own control, which is also inside the noise. Its neck bones stayed at 62.5 degrees. For the fingers, the rest-pose floor is 15.2 degrees in this evaluation and 15.1 on slide 8; the difference is only which people are matched. Restarting the fine-tune alone costs about 2.4 millimetres. A 2-epoch pilot trains in about 12 minutes, a 10-epoch run in about one hour.</a:t>
+            </a:r>
           </a:p>
         </p:txBody>
       </p:sp>
@@ -1010,7 +1023,6 @@
               <a:rPr lang="en-US" dirty="0"/>
               <a:t>Some corrections are already in. The headline AnnyOne number is 70.5 millimetres, measured with the helper bones masked, as in the demos. That is the evaluation setting V1, not the demo's own number: the demo setting gives 68.5 at a lower recall. The 74 millimetres in the thesis draft came from the unmasked evaluation; on the same people that adds 3.8 millimetres. The README already uses 70.5; the thesis draft I still have to change. The demos now say that the fingers are the rest pose. The text no longer blames the rig. The Known-defects section in the README documents the depth bug. But the README, the findings and the handover documents still carry last week's neck story, that the long neck comes from weak supervision and from the depth bug, and some old depth wording, for example that the overlays look wrong and that no improvement is claimed yet. I will correct them next week. The repository is reorganised with everything scripted, so any of these numbers can be produced again.</a:t>
             </a:r>
-            <a:endParaRPr lang="en-US" dirty="0"/>
           </a:p>
         </p:txBody>
       </p:sp>
@@ -1096,9 +1108,17 @@
           <a:p>
             <a:r>
               <a:rPr lang="en-US" dirty="0"/>
-              <a:t>Seven things are still open. First, the neck: the per-bone check is done, on slide 7, but nothing is fixed. Next is exp6: turn the flipped bones back with a fixed correction at the network output, tested with no training at all. If the neck skin then gets its thickness back, I will render it to check that the thin neck is what we saw in the overlays. Second, the depth slope, stuck at 0.3 to 0.4: why near and far are not separated is unknown. The training depths so far come from small samples, batch means of about 2.5 to 3.2 metres, so I will measure them properly, and measure the fix run's slope on training images; for v5 it was just as low there. Third, the cost of the fix: paired PVE on the same people, recall over people whose head is visible, and the root error next to PVE in the thesis. Testing the fix on 3DPW waits for item seven. The twenty-times 10-epoch run has no result yet. Fourth, pilot noise: fix the seed or repeat the key run. Fifth, people very close to the camera: both models miss them in 4 of the 12 rendered images; likely a detection problem, not yet counted. Sixth, children and fingers: one 2-epoch test is not enough to close them. Next is a 10-epoch balanced-sampler run, and for the fingers training on larger hand crops. If those show nothing too, both go into the thesis as limitations. Seventh, the 3DPW labels from slide 6: set men to 0 and women to 1, and pick both people's frames on one shared grid. Both happen inside the fit, so all 87 conversion tasks must be fitted again, not only the 11 missing ones, and into a new folder, because the task script skips every person that already has a file; otherwise old and new fits would mix without a warning. That is an 87-task array job: about 40 GPU hours by the task script's own estimate of 6 seconds per frame, so 5 to 6 hours with 8 GPUs at once; not measured. Then rebuild the labels and run the new check. Only after that should I test the depth fix on 3DPW or fine-tune on it.</a:t>
-            </a:r>
+              <a:t>Seven things are still open. First, the neck: found on slide 7, not fixed. Next is exp6: turn the flipped bones back with a fixed correction at the network output, with no training. Second, the depth slope is stuck at 0.3 to 0.4, and I do not know why. I will measure the training depths properly. Third, the cost of the fix: PVE paired on the same people, and recall for people whose head is visible. Fourth, pilot noise: fix the seed or repeat the key run. Fifth, people very close to the camera: both models miss them; likely detection, not yet counted. Sixth, children and fingers: next is a 10-epoch balanced-sampler run, and larger hand crops for the fingers. If those show nothing, both go into the thesis as limitations. Seventh, the 3DPW labels from slide 6. The rebuild of the missing labels is running now. Then I fix the gender and use one shared frame grid; that needs a new fit of all 87 tasks. I propose to test the depth fix on 3DPW or fine-tune on it only after that; my question on the next slide is about this.</a:t>
+            </a:r>
+          </a:p>
+          <a:p>
             <a:endParaRPr lang="en-US" dirty="0"/>
+          </a:p>
+          <a:p>
+            <a:r>
+              <a:rPr lang="en-US" dirty="0"/>
+              <a:t>If asked: Neck: if the neck skin gets its thickness back with the correction, I will render it to check that the thin neck is what we saw in the overlays. Depth: the training depths so far come from small samples, batch means of about 2.5 to 3.2 metres. I will also measure the fix run's slope on training images; for v5 it was just as low there. Cost: I will report the root error next to PVE in the thesis. Testing the fix on 3DPW waits for item seven. The twenty-times 10-epoch run has no result yet. Close people: both models miss them in 4 of the 12 rendered images. Children and fingers: one 2-epoch test is not enough to close them. 3DPW labels: the missing labels need no new fit: the fits exist, so the label builder is running again now, into a new folder. If the rebuild still gives fewer labels, the 3DPW images for those sequences may be missing on disk; the check did not test that. Gender and the frame grid are different: set men to 0 and, by Anny's convention, women to 1; the refit confirmed it only for men. And pick both people's frames on one shared grid. Both happen inside the fit, so all 87 conversion tasks must be fitted again, into a new folder, because the task script skips every person that already has a file; otherwise old and new fits would mix without a warning. That is an 87-task array job: about 40 GPU hours by the task script's own estimate of 6 seconds per frame, so 5 to 6 hours with 8 GPUs at once; not measured. Then rebuild the labels and run the check again.</a:t>
+            </a:r>
           </a:p>
         </p:txBody>
       </p:sp>
@@ -1184,9 +1204,17 @@
           <a:p>
             <a:r>
               <a:rPr lang="en-US" dirty="0"/>
-              <a:t>What is measured: the failures are not rig or decoding problems. A training-target bug puts people too far away in v5, v9 and v10; in v5 it is all 222 holdout people. The depth fix draws the bodies much closer to their true size, but near and far are still not separated well, and it likely has a cost: every fix run is worse than its control, by 2.6 to 4.9 millimetres PVE and 1.6 to 2.4 recall points. The PVE gaps are inside pilot noise, the recall drops are at the edge of what one pilot can detect, and the five runs share two controls, but all point the same way. Separately, the 3DPW labels have the two bugs from slide 6: the two-person problem is counted from the label files, the reversed gender is read in the code and seen in v2.1 renders. Also measured now: in all eight v5-line checkpoints I traced, neck02 and the head bone sit half a turn off; they cancel, so the head points the right way, but the neck skin is about half as thick. I do not claim a fix for it: a 2-epoch fine-tune did not undo it. Its origin is not known; the singular start value of the rotation output would start a bone turned about its sideways axis, a tilt like the one in v5's left index base, not the twist in neck02 and the head. I do not claim any improvement in the fingers or the children, and I do not claim an accuracy for the 3DPW labels: nobody has summarised the saved fit error or compared the labels with the SMPL meshes. My question: should I fine-tune v9 with the corrected targets and the depth loss five times stronger, before the thesis numbers are final? That is about one hour of training. From v5 I expect a drawn size of about 0.84 and a root error of about half a metre; on v5 that run cost 2.6 millimetres PVE and 1.6 recall points against its control. Five, not twenty, because the twenty-times 10-epoch run has no result yet. v9 is best on our 3DPW-Anny labels, but those labels have the gender bug and the two-person bug, so that score is not a clean measure. The other option is to fix the labels first: men to 0, one shared frame grid, re-fit all 87 conversion tasks into a new folder, rebuild the labels, then fine-tune. Rebuilding the labels alone is not enough, because the gender and the frame choice are fixed inside the fit; the re-fit is an 87-task array job, about 40 GPU hours by the script's own estimate. I think the 3DPW labels should be re-fitted with the corrected gender before any fine-tune that mixes in 3DPW; otherwise the fine-tune keeps learning the wrong body. A v9 fine-tune keeps the neck flip; v10 has no neck flip, but the same kind of flip in the left shoulder and upper arm, which is most of why its shoulders and arms are worse. Either fine-tune should also mask the 3DPW finger labels, which are set to the rest pose, with mask_3dpw_hands. The ViT-S students use the same training code and are probably affected too; not measured. On the AnnyOne holdout v9 is not the best: 77.0 against 70.5.</a:t>
-            </a:r>
+              <a:t>What I claim, measured. First, the failures are not rig or decoding problems. Second, a training-target bug puts people too far away in v5, v9 and v10; the fix draws bodies much closer to their true size. Third, in all eight v5-line checkpoints I traced, neck02 and the head bone sit half a turn off, and the neck skin is about half as thick. Fourth, the 3DPW labels: joints and surface pass the check, but gender is reversed, which a refit confirms for men, one actor is missing in 407 of 960 two-person images, and some labels are missing. What I do not claim: a neck fix, better fingers or children, correct depth for both near and far people, a fix without cost, and head turn, age or limb lengths in the 3DPW labels. My question: should I fine-tune v9 now, with the fixed targets and the depth loss five times stronger? Or first fix the 3DPW labels, re-fit, then fine-tune? I propose the second, as on slide 15, but I want your view.</a:t>
+            </a:r>
+          </a:p>
+          <a:p>
             <a:endParaRPr lang="en-US" dirty="0"/>
+          </a:p>
+          <a:p>
+            <a:r>
+              <a:rPr lang="en-US" dirty="0"/>
+              <a:t>If asked: The depth fix does not separate near and far people well, and it likely has a cost: every fix run is worse than its control, by 2.6 to 4.9 millimetres PVE and 1.6 to 2.4 recall points. The PVE gaps are inside pilot noise, the recall drops are at the edge of what one pilot can detect, and the five runs share two controls, but all point the same way. In v5 the depth bug affects all 222 holdout people. The neck: the two half-turned bones cancel, so the head points the right way. A 2-epoch fine-tune did not undo it. Its origin is not known; the singular start value of the rotation output would start a bone turned about its sideways axis, a tilt like the one in v5's left index base, not the twist in neck02 and the head. The missing 3DPW labels: 6 train sequences, part of a seventh, and one validation sequence; the rebuild is running. For the women, the gender refit is mixed. In the 3DPW labels the head, neck02 and neck03 stay at rest; only neck01 turns. Overall the labels keep about half the head turn, 9.5 against 20 degrees. Train and validation keep most of it; the loss is in the test split, and I do not know why yet. Age is fixed, and the limb-length ratios are not explained yet. The fine-tune is about one hour of training. From v5 I expect a drawn size of about 0.84 and a root error of about half a metre; on v5 that run cost 2.6 millimetres PVE and 1.6 recall points against its control. Five, not twenty, because the twenty-times 10-epoch run has no result yet. v9 is best on our 3DPW-Anny labels, but those labels have the gender and two-person defects, so that score is not a clean measure. The other option: men to 0, women to 1 by Anny's convention, one shared frame grid, re-fit all 87 conversion tasks into a new folder, rebuild the labels, then fine-tune. Rebuilding the labels alone is not enough, because the gender and the frame choice are fixed inside the fit; the re-fit is an 87-task array job, about 40 GPU hours by the script's own estimate. I prefer the re-fit first: 3DPW is 30 percent of each batch, so a fine-tune before it would keep learning the wrong body for the men. A v9 fine-tune keeps the neck flip; v10 has no neck flip, but the same kind of flip in the left shoulder and upper arm, which is most of why its shoulders and arms are worse. Either fine-tune should also mask the 3DPW finger labels, which are set to the rest pose, with mask_3dpw_hands. The ViT-S students use the same training code and are probably affected too; not measured. On the AnnyOne holdout v9 is not the best: 77.0 against 70.5.</a:t>
+            </a:r>
           </a:p>
         </p:txBody>
       </p:sp>
@@ -1274,7 +1302,6 @@
               <a:rPr lang="en-US" dirty="0"/>
               <a:t>A second holdout example, in case there is a question. Before the fix the boy's real head sticks out above a shrunken mesh that floats. After the fix the top of the head is level with the truth; the after mesh is cut off at the bottom of the image, so I cannot measure its full height. Here the fixed mesh is a little larger and wider than the ground truth, so I do not call it an exact fit. The two large people in front have no ground-truth mesh, so they are not counted as misses.</a:t>
             </a:r>
-            <a:endParaRPr lang="en-US" dirty="0"/>
           </a:p>
         </p:txBody>
       </p:sp>
@@ -1362,7 +1389,6 @@
               <a:rPr lang="en-US" dirty="0"/>
               <a:t>These are the three failures we discussed last time. Until this week they were explained by guesses: a rig problem, too few pixels on the hands, or a shape head that does not learn age. None of these guesses had been tested on its own. That is what I did first. The last line on each card is what this week showed; the details follow. For the neck, I found that two bones in the v5 models, neck02 and the head bone, are turned half a turn, and the neck skin comes out about half as thick; I have not yet rendered it to check that this is the look we saw.</a:t>
             </a:r>
-            <a:endParaRPr lang="en-US" dirty="0"/>
           </a:p>
         </p:txBody>
       </p:sp>
@@ -1450,7 +1476,6 @@
               <a:rPr lang="en-US" dirty="0"/>
               <a:t>I built six checks, each testing one stage. I use a fixed holdout of 100 images that were never used in training, and a fixed set of test cases: 40 training images with adults, children, visible hands and hard necks, and 15 held-out images with no children. Most numbers in this talk come from these sets with the same settings.</a:t>
             </a:r>
-            <a:endParaRPr lang="en-US" dirty="0"/>
           </a:p>
         </p:txBody>
       </p:sp>
@@ -1538,7 +1563,6 @@
               <a:rPr lang="en-US" dirty="0"/>
               <a:t>This slide changes the story. The rig, the decoding and the body model are correct, and gradients reach every bone and every shape output. The one exception: two of the three camera outputs are unused and get no gradient. The overfit test shows the optimiser works for shape and 3D joints: on 40 training images the error falls by 36 percent. It has two warnings. First, even while the images were memorised, the translation loss and the 2D losses went up, from 1.67 to 1.89 and from 58 to 75. The network could not satisfy the position targets and the 2D projection at the same time. That was probably the first sign of the depth bug on slide 10; I have not repeated the overfit test with the fix. Second, the rotation loss barely moved, from 44.6 to 40.8. That is a sum over all 75 bones, so it does not isolate the neck; it may be related to the neck flip on slide 7, but that is a guess. So the three failures are not rig or decoding problems, which is how the thesis described them until now, but training can still get stuck. One caveat on the ground-truth check: people who fill the frame lose joints at the image border. That is truncation, not a decoding error. This check covered the AnnyOne labels only; the 3DPW labels come on the next two slides.</a:t>
             </a:r>
-            <a:endParaRPr lang="en-US" dirty="0"/>
           </a:p>
         </p:txBody>
       </p:sp>
@@ -1624,9 +1648,8 @@
           <a:p>
             <a:r>
               <a:rPr lang="en-US" dirty="0"/>
-              <a:t>One more ground-truth check, now for 3DPW. 3DPW gives, per frame, 24 SMPL joint positions, the camera and the gender. I keep the valid frames and take every third one per person. Then Anny is fitted frame by frame with gradient descent, so that its 24 joints land on the SMPL joints. The two skeletons are different, so first each SMPL joint is assigned one Anny bone; the hip and spine choice is checked on the rest pose, and for nine torso joints, where the rigs differ, the fit aims at a fixed offset from the bone, not at the bone itself. Only positions are matched: SMPL rotations, shape values and the surface are not used. Each person then gets one body, the median over the frames, and the pose is fitted again. Moving into the camera changes only the root bone. When the label files are written, fits with more than 80 millimetres joint error, people less than 30 percent visible and boxes under 40 pixels are dropped. Only the root and 18 bones move. The head, finger and toe end bones are mapped, but nothing below them is matched, so they get no signal. Age is fixed at 0.55, and about 144 of the 163 bones stay at rest, including neck02, neck03, the head and the fingers. So in these labels the head never turns relative to the neck.</a:t>
-            </a:r>
-            <a:endParaRPr lang="en-US" dirty="0"/>
+              <a:t>One more ground-truth check, now for 3DPW. 3DPW gives, per frame, 24 SMPL joint positions, the camera and the gender. I keep the valid frames and take every third one per person. Then Anny is fitted frame by frame with gradient descent, so that its 24 joints land on the SMPL joints. The two skeletons are different, so first each SMPL joint is assigned one Anny bone; the hip and spine choice is checked on the rest pose, and for nine torso joints, where the rigs differ, the fit aims at a fixed offset from the bone, not at the bone itself. Only positions are matched: SMPL rotations, shape values and the surface are not used. Each person then gets one body, the median over the frames, and the pose is fitted again. Moving into the camera changes only the root bone. When the label files are written, fits with more than 80 millimetres joint error, people less than 30 percent visible and boxes under 40 pixels are dropped. Only the root and 18 bones move. The head, finger and toe end bones are mapped, but nothing below them is matched, so they get no signal. Age is fixed at 0.55. By the code, 144 of the 163 bones stay at rest, including neck02, neck03, the head and the fingers. The check on the next slide confirms this for every person it sampled. So in these labels the head turns only through neck01.</a:t>
+            </a:r>
           </a:p>
         </p:txBody>
       </p:sp>
@@ -1712,9 +1735,17 @@
           <a:p>
             <a:r>
               <a:rPr lang="en-US" dirty="0"/>
-              <a:t>Short answer: partly. Some parts are measured. On 60 frames of one sequence, raw 3DPW joints land on OpenPose at 8.9 pixels, so the camera formula is right, and the step into the camera is exact. Sides, units and image numbers are right in the code. The fit error is saved for every frame on the cluster and used for the 80 millimetre drop, but nobody has summarised it; the 13 to 20 millimetres in our scripts has no log. An old pilot, not v2.2, matched its own neutral-SMPL target to 13 millimetres on the limbs, but that target was 58 millimetres from the real 3DPW joints, so v2 changed the target; I do not use that number as evidence. A perfect-target test shows why joint error is not enough: joints match to 1.5 millimetres, but a 45-degree head turn is lost. Limb twist is not recovered either. I also found two real bugs. Gender is reversed: men get a female body and women a male one. The code is clear. I also checked Anny directly: at gender 0 the rest body is 1.75 metres tall with 37-centimetre shoulders, at gender 1 it is 1.63 metres with 31 centimetres, so 0 is male. The renders I saw are from v2.1, which uses the same rule, and they show men only. In two-person scenes the frames are picked per person, so at least a third (validation) to a half (train, test) of the images label only one person. Also, 6 train and 2 validation sequences have no labels at all; I do not know why yet. v7 to v10 train on these labels, and our 3DPW scores use them. So our 3DPW scores are measured against these Anny labels on every third frame; they cannot be compared with published 3DPW results, which use the SMPL meshes and all valid frames. I wrote a cluster check that compares the labels with the original SMPL meshes and refits a few people per sequence with the flipped gender; it has not run yet.</a:t>
-            </a:r>
+              <a:t>Until now, the finished labels had not been checked end to end against the original 3DPW data. A cluster check has now done that. Joints, surface and 2D pass the check. Body joints are 18.7 millimetres off at the median. That is below about 26 millimetres, the value the check cites for 3DPW's own joints. The surface is about 19 millimetres off. That is the distance to the nearest point, so the true error can be larger. In 2D the labels are only 1 pixel worse than raw 3DPW. Left and right were correct in every checked person. But the labels have three defects. First, gender is reversed. I refitted 73 male samples with the other gender, and the joint error dropped for 72 of them. For the 31 female samples the result is mixed. Second, in 407 of 960 two-person images one person has no label, because that person was not fitted on that frame. Third, labels are missing for 6 train sequences, part of a seventh, and one validation sequence. The fits exist, so the rebuild is running now. On the right: by design, the head does not turn on its own. The overall FAIL comes only from the limb lengths, and they fail only in the test split; I do not know the cause yet. A few hip outliers give a warning overall, and a FAIL in the train split alone.</a:t>
+            </a:r>
+          </a:p>
+          <a:p>
             <a:endParaRPr lang="en-US" dirty="0"/>
+          </a:p>
+          <a:p>
+            <a:r>
+              <a:rPr lang="en-US" dirty="0"/>
+              <a:t>If asked: The surface test cannot see a wrong gender; that is why there is a separate refit test. In the script's own synthetic test, a label fitted with the wrong gender still stayed at 7 to 10 millimetres from the surface. Anny's male end is 0: at gender 0 the rest body is 1.753 metres tall, at 1 it is 1.632 metres. In the checked images, 1,801 people are labelled male and 734 female; these count people in images, not different persons. All men have the label 1.000, all women 0.000. The refit used 2 people per sequence, 104 samples, so 73 and 31 are samples, not different persons. For the men, the refit with flipped gender lowered the median joint error from 19.2 to 15.3 millimetres, and the surface got closer for 68 of 73. For the women, the flip made the joints worse for most of them, 13.7 to 16.3 millimetres, but the surface closer for 27 of 31. Label images: train 4,451 of 6,437 expected, validation 2,458 of 2,777. If the rebuild still gives fewer labels, the 3DPW images for those sequences may be missing on disk; the check did not test that. All 162 frames of outdoors_crosscountry_00 are dropped by the visibility filter, under 30 percent visible; the fits are fine, and I have not yet checked why the whole sequence counts as not visible. The 18.7 millimetres are measured at the points the fit aims at. The bare bone heads that train.py uses are 32.5 millimetres off, mostly a fixed torso rig gap, not a fit error. The train split alone: body joints 20.2 millimetres, just over the 20 millimetre line, so WARN; and 5.2 percent of people with a joint over 100 millimetres, so FAIL. Limb ratios: forearm 0.879 and thigh 1.119 overall. Train passes, with 0.965 and 1.035; only test fails. All checked test people are men labelled 1, so a link to the gender defect is possible, but not shown. Head turn: train and validation keep most of it, 18.5 against 21.2 degrees and 19.1 against 19.3; the loss is mainly in test, 6.3 against 20.0. The script marks the 26 millimetres for 3DPW as likely, from von Marcard et al., 2018; I have not checked the paper.</a:t>
+            </a:r>
           </a:p>
         </p:txBody>
       </p:sp>
@@ -1802,7 +1833,6 @@
               <a:rPr lang="en-US" dirty="0"/>
               <a:t>In all eight v5-line checkpoints I traced, two bones are wrong by about half a turn: neck02 by 176 degrees and the head by 178, in every holdout person. The other neck bones and the jaw are fine. It is there from the first training stage, frozen_bb_v2, and nothing later changed it. The two half-turns cancel: the whole head still points the right way, within 12 to 15 degrees, so the head direction and the body PVE never showed it; only the per-bone angles did, last week's 63 and 90 degrees. But the neck skin comes out less than half as thick as the truth. v10 has no neck flip, but the same kind of flip in its left shoulder, its left upper arm and three hand bones, one left and two right. Two epochs with a geodesic loss barely moved it, likely because both bones would have to turn back together. The flip is measured, but I have not yet rendered it to check that it is the look we saw in the overlays. Its origin is not known; the singular start value of the rotation output would start a bone turned about its sideways axis, a tilt like the one in v5's left index base, not the twist in neck02 and the head. Next: a fixed output correction, no training.</a:t>
             </a:r>
-            <a:endParaRPr lang="en-US" dirty="0"/>
           </a:p>
         </p:txBody>
       </p:sp>
@@ -1890,7 +1920,6 @@
               <a:rPr lang="en-US" dirty="0"/>
               <a:t>With predicted fingers the error is 17.3 degrees. With the fingers simply left in the rest pose it is 15.1. So the hand prediction is worse than no prediction, which is why the demos zero the fingers and now say so. Hands are small: about two tokens at 672 pixels. I cropped around the person at test time, without retraining. Per person that magnifies the hands by 1.6 times on median, and by 2.5 times or more for a quarter of the people; 26 percent of the people are not magnified at all. The table compares median hand sizes, so it shows a slightly larger factor. The finger error does not change: 17.2 against 17.3, and from 17.7 to 17.5 for the most magnified quarter. The body error nearly doubles on these crops, because the model never saw such a camera in training. So test-time magnification does not help; a model trained on larger hands is not tested. A rebalanced loss also changed nothing: 17.5 against 17.4 for its control. That loss cut the hands' share of the rotation loss from about 70 percent, which includes the four-times hand boost, to 33 percent; without the boost the share would be 40. So it does not test giving the fingers more weight, and the earlier four-times hand boost did not help either. My best guess is supervision or model capacity, but that is not tested.</a:t>
             </a:r>
-            <a:endParaRPr lang="en-US" dirty="0"/>
           </a:p>
         </p:txBody>
       </p:sp>
@@ -1976,9 +2005,17 @@
           <a:p>
             <a:r>
               <a:rPr lang="en-US" dirty="0"/>
-              <a:t>I checked in the code that the shape head is complete: all eleven shape values go into the body model and are trained, with no adult default. The model can make a child: for the youngest training people it predicts age 0.10 for a true 0.015, too old but still clearly a child; the holdout adults lie mostly between 0.4 and 0.8. Anny's own age calibration puts 0.10 at about 2 years and 0.67 at about 16, while the labels in our code assume 0.33 is 11 years and 0.67 is 25; I have not settled which one the dataset follows. The ten children in the training manifest also come out too old, by 0.078 on average. With their true shape, their error falls from 47.8 to 41.6 millimetres, so 6.2 millimetres of it is shape. Only 2 percent of training people are children, so I tried a sampler that shows about 10 percent. In a 2-epoch fine-tune nothing changed, not for the training children and not on real photos: five small people still get the age of the holdout adults, 0.57 to 0.67 in the sampler and the control run. So I compare with the holdout adults rather than give years: 0.57 to 0.67 is about 14 to 16 years on Anny's calibration and 21 to 25 on our code's labels; either way far too old for people 0.6 to 1.1 metres tall. That is a short run on few people, so it shows no effect, not that there can be none. My best guess is a gap between synthetic and real images, plus an old-age bias that shows even on training children; neither is tested. There are no labelled real children, and the 3DPW labels fix age at one value, 0.55, for everyone (slide 5). The next step is a 10-epoch balanced-sampler run; if that also shows nothing, it goes into the thesis as a limitation. The holdout has no children, so every synthetic child number is in-sample.</a:t>
-            </a:r>
+              <a:t>I checked in the code that the shape head is complete: all eleven shape values go into the body model and are trained, with no adult default. The model can make a child: for the youngest training people it predicts age 0.10 for a true 0.015, too old but still clearly a child; the holdout adults lie mostly between 0.4 and 0.8. Only 2 percent of training people are children, so I tried a sampler that shows about 10 percent. In a 2-epoch fine-tune nothing changed, not for the training children and not on real photos: five small people still get the age of the holdout adults, 0.57 to 0.67 in the sampler and the control run. That is a short run on few people, so it shows no effect, not that there can be none. My best guess is a gap between synthetic and real images, plus an old-age bias that shows even on training children; neither is tested. The next step is a 10-epoch balanced-sampler run; if that also shows nothing, it goes into the thesis as a limitation. The holdout has no children, so every synthetic child number is in-sample.</a:t>
+            </a:r>
+          </a:p>
+          <a:p>
             <a:endParaRPr lang="en-US" dirty="0"/>
+          </a:p>
+          <a:p>
+            <a:r>
+              <a:rPr lang="en-US" dirty="0"/>
+              <a:t>If asked: Anny's own age calibration puts 0.10 at about 2 years and 0.67 at about 16, while the labels in our code assume 0.33 is 11 years and 0.67 is 25; I have not settled which one the dataset follows. The ten children in the training manifest also come out too old, by 0.078 on average. With their true shape, their error falls from 47.8 to 41.6 millimetres, so 6.2 millimetres of it is shape. So I compare with the holdout adults rather than give years: 0.57 to 0.67 is about 14 to 16 years on Anny's calibration and 21 to 25 on our code's labels; either way far too old for people 0.6 to 1.1 metres tall. There are no labelled real children, and the 3DPW labels fix age at one value, 0.55, for everyone (slide 5).</a:t>
+            </a:r>
           </a:p>
         </p:txBody>
       </p:sp>
@@ -2122,7 +2159,7 @@
         <p:spPr>
           <a:xfrm>
             <a:off x="548640" y="2834640"/>
-            <a:ext cx="8046720" cy="1463040"/>
+            <a:ext cx="8046720" cy="1645920"/>
           </a:xfrm>
           <a:prstGeom prst="rect">
             <a:avLst/>
@@ -2856,7 +2893,7 @@
         <p:spPr>
           <a:xfrm>
             <a:off x="548640" y="2834640"/>
-            <a:ext cx="8046720" cy="1463040"/>
+            <a:ext cx="8046720" cy="1645920"/>
           </a:xfrm>
           <a:prstGeom prst="rect">
             <a:avLst/>
@@ -2891,7 +2928,7 @@
                   <a:schemeClr val="bg2"/>
                 </a:solidFill>
               </a:rPr>
-              <a:t>Two bugs in the 3DPW labels (gender, two-person frames).</a:t>
+              <a:t>3DPW labels: joints and surface pass, three defects.</a:t>
             </a:r>
             <a:endParaRPr lang="en-US" sz="1800" dirty="0"/>
           </a:p>
@@ -10682,7 +10719,7 @@
         <p:spPr>
           <a:xfrm>
             <a:off x="640080" y="3685032"/>
-            <a:ext cx="3657600" cy="841248"/>
+            <a:ext cx="3657600" cy="914400"/>
           </a:xfrm>
           <a:prstGeom prst="rect">
             <a:avLst/>
@@ -11868,7 +11905,7 @@
                   <a:schemeClr val="tx1"/>
                 </a:solidFill>
               </a:rPr>
-              <a:t>3DPW labels: two bugs and 8 missing sequences (slide 6)</a:t>
+              <a:t>3DPW labels: three defects (slide 6)</a:t>
             </a:r>
             <a:endParaRPr lang="en-US" sz="1500" dirty="0"/>
           </a:p>
@@ -11904,7 +11941,7 @@
                   <a:schemeClr val="tx2"/>
                 </a:solidFill>
               </a:rPr>
-              <a:t>Fix gender (m → 0) and use one shared frame grid; re-fit all 87 tasks into a new folder (the task script skips existing .npz); rebuild the labels; run check_3dpw_conversion.sh. Only then test the depth fix on 3DPW or fine-tune on it.</a:t>
+              <a:t>Running now: rebuild of the missing labels. Then fix gender (m → 0; f → 1 by Anny's convention), use one shared frame grid, re-fit all 87 tasks, rebuild, re-check. Proposed: only then test the depth fix on 3DPW or fine-tune on it.</a:t>
             </a:r>
             <a:endParaRPr lang="en-US" sz="1200" dirty="0"/>
           </a:p>
@@ -12058,23 +12095,7 @@
                   <a:schemeClr val="bg2"/>
                 </a:solidFill>
               </a:rPr>
-              <a:t>the failures are not rig or decoding problems. A training-target bug puts people too far away in v5, v9 and v10 (v5: all 222 holdout people); the fix draws bodies much closer to their true size. In all 8 v5-line checkpoints traced, neck02 and the head bone sit half a turn off and cancel; the neck skin is half as thick (0.46). ≥ 48% of two-person 3DPW train images label only one person (counted). </a:t>
-            </a:r>
-            <a:r>
-              <a:rPr lang="en-US" sz="1500" b="1" dirty="0">
-                <a:solidFill>
-                  <a:srgbClr val="F4C95D"/>
-                </a:solidFill>
-              </a:rPr>
-              <a:t>Found in code: </a:t>
-            </a:r>
-            <a:r>
-              <a:rPr lang="en-US" sz="1500" dirty="0">
-                <a:solidFill>
-                  <a:schemeClr val="bg2"/>
-                </a:solidFill>
-              </a:rPr>
-              <a:t>the 3DPW-Anny labels have reversed gender (seen in v2.1 renders; slide 6).</a:t>
+              <a:t>the failures are not rig or decoding problems. A training-target bug puts people too far away in v5, v9 and v10 (v5: all 222 holdout people); the fix draws bodies closer to their true size. In all 8 v5-line checkpoints traced, neck02 and the head bone sit half a turn off and cancel; the neck skin is half as thick (0.46). 3DPW labels: joints (18.7 mm) and nearest-point surface pass; gender reversed (refit confirms for men), one actor missing in 407 of 960 two-person images (slide 6).</a:t>
             </a:r>
             <a:endParaRPr lang="en-US" sz="1500" dirty="0"/>
           </a:p>
@@ -12096,7 +12117,7 @@
                   <a:schemeClr val="bg2"/>
                 </a:solidFill>
               </a:rPr>
-              <a:t>a neck fix, or a proven origin of the flip; any improvement in fingers or children; correct depths for both near and far people; a fix without cost (likely 2.6–4.9 mm PVE and 1.6–2.4 recall points worse, not yet confirmed); any measured accuracy of the 3DPW labels.</a:t>
+              <a:t>a neck fix, or a proven origin of the flip; any improvement in fingers or children; correct depths for both near and far people; a fix without cost (likely 2.6–4.9 mm PVE and 1.6–2.4 recall points worse, not yet confirmed); head turn, age or limb lengths in the 3DPW labels.</a:t>
             </a:r>
             <a:endParaRPr lang="en-US" sz="1500" dirty="0"/>
           </a:p>
@@ -12202,7 +12223,7 @@
                   <a:srgbClr val="EEF2F7"/>
                 </a:solidFill>
               </a:rPr>
-              <a:t>Fine-tune v9 (best on our 3DPW-Anny labels, which have the gender bug: slide 6) with the fixed targets and depth ×5? Or first fix gender and frame grid, re-fit all 3DPW tasks, then fine-tune?</a:t>
+              <a:t>Fine-tune v9 (best on our 3DPW-Anny labels, which have the gender defect: slide 6) with the fixed targets and depth ×5? Or first fix gender and frame grid, re-fit all 3DPW tasks, then fine-tune?</a:t>
             </a:r>
             <a:endParaRPr lang="en-US" sz="1400" dirty="0"/>
           </a:p>
@@ -16140,7 +16161,7 @@
                   <a:schemeClr val="tx2"/>
                 </a:solidFill>
               </a:rPr>
-              <a:t>Gender from 3DPW (reversed: next slide); age 0.55; the other 7 shape values 0.5. About 144 of 163 bones stay at rest: neck02/03, head, jaw, fingers, twist bones.</a:t>
+              <a:t>Gender from 3DPW (reversed: next slide); age 0.55; the other 7 shape values 0.5. By the code, 144 of 163 bones stay at rest: neck02/03, head, jaw, fingers, twist bones.</a:t>
             </a:r>
             <a:endParaRPr lang="en-US" sz="1100" dirty="0"/>
           </a:p>
@@ -16292,7 +16313,7 @@
                   <a:schemeClr val="tx1"/>
                 </a:solidFill>
               </a:rPr>
-              <a:t>Conversion: camera verified, fit not checked, two bugs</a:t>
+              <a:t>3DPW labels: joints and surface pass, three defects</a:t>
             </a:r>
             <a:endParaRPr lang="en-US" sz="2700" dirty="0"/>
           </a:p>
@@ -16300,18 +16321,18 @@
       </p:sp>
       <p:sp>
         <p:nvSpPr>
-          <p:cNvPr id="3" name="ev Measured"/>
+          <p:cNvPr id="3" name="ev Measured: pass"/>
           <p:cNvSpPr/>
           <p:nvPr/>
         </p:nvSpPr>
         <p:spPr>
           <a:xfrm>
             <a:off x="457200" y="1143000"/>
-            <a:ext cx="2651760" cy="2432304"/>
+            <a:ext cx="2651760" cy="3200400"/>
           </a:xfrm>
           <a:prstGeom prst="roundRect">
             <a:avLst>
-              <a:gd name="adj" fmla="val 3008"/>
+              <a:gd name="adj" fmla="val 2759"/>
             </a:avLst>
           </a:prstGeom>
           <a:solidFill>
@@ -16327,7 +16348,7 @@
       </p:sp>
       <p:sp>
         <p:nvSpPr>
-          <p:cNvPr id="4" name="ev dot Measured"/>
+          <p:cNvPr id="4" name="ev dot Measured: pass"/>
           <p:cNvSpPr/>
           <p:nvPr/>
         </p:nvSpPr>
@@ -16352,7 +16373,7 @@
       </p:sp>
       <p:sp>
         <p:nvSpPr>
-          <p:cNvPr id="5" name="ev head Measured"/>
+          <p:cNvPr id="5" name="ev head Measured: pass"/>
           <p:cNvSpPr txBox="1"/>
           <p:nvPr/>
         </p:nvSpPr>
@@ -16380,7 +16401,7 @@
                   <a:schemeClr val="tx1"/>
                 </a:solidFill>
               </a:rPr>
-              <a:t>Measured</a:t>
+              <a:t>Measured: pass</a:t>
             </a:r>
             <a:endParaRPr lang="en-US" sz="1500" dirty="0"/>
           </a:p>
@@ -16388,14 +16409,14 @@
       </p:sp>
       <p:sp>
         <p:nvSpPr>
-          <p:cNvPr id="6" name="ev body Measured"/>
+          <p:cNvPr id="6" name="ev body Measured: pass"/>
           <p:cNvSpPr txBox="1"/>
           <p:nvPr/>
         </p:nvSpPr>
         <p:spPr>
           <a:xfrm>
             <a:off x="594360" y="1645920"/>
-            <a:ext cx="2377440" cy="1865376"/>
+            <a:ext cx="2377440" cy="2633472"/>
           </a:xfrm>
           <a:prstGeom prst="rect">
             <a:avLst/>
@@ -16409,7 +16430,7 @@
           <a:p>
             <a:pPr marL="177800" indent="-177800">
               <a:spcAft>
-                <a:spcPts val="300"/>
+                <a:spcPts val="400"/>
               </a:spcAft>
               <a:buSzPct val="100000"/>
               <a:buChar char="•"/>
@@ -16420,7 +16441,7 @@
                   <a:schemeClr val="tx1"/>
                 </a:solidFill>
               </a:rPr>
-              <a:t>Camera formula: </a:t>
+              <a:t>Body joints: </a:t>
             </a:r>
             <a:r>
               <a:rPr lang="en-US" sz="1100" dirty="0">
@@ -16428,14 +16449,14 @@
                   <a:schemeClr val="tx1"/>
                 </a:solidFill>
               </a:rPr>
-              <a:t>raw 3DPW joints hit OpenPose 2D at 8.9 px on 60 frames of one sequence (other convention: ~2400 px).</a:t>
+              <a:t>median 18.7 mm (p95 24.5), below the ~26 mm cited for 3DPW's own joints.</a:t>
             </a:r>
             <a:endParaRPr lang="en-US" sz="1100" dirty="0"/>
           </a:p>
           <a:p>
             <a:pPr marL="177800" indent="-177800">
               <a:spcAft>
-                <a:spcPts val="300"/>
+                <a:spcPts val="400"/>
               </a:spcAft>
               <a:buSzPct val="100000"/>
               <a:buChar char="•"/>
@@ -16446,7 +16467,7 @@
                   <a:schemeClr val="tx1"/>
                 </a:solidFill>
               </a:rPr>
-              <a:t>World → camera: </a:t>
+              <a:t>Surface vs SMPL: </a:t>
             </a:r>
             <a:r>
               <a:rPr lang="en-US" sz="1100" dirty="0">
@@ -16454,14 +16475,14 @@
                   <a:schemeClr val="tx1"/>
                 </a:solidFill>
               </a:rPr>
-              <a:t>exact; label mesh = moved fit mesh to 0.002 mm (synthetic test).</a:t>
+              <a:t>median 18.9 / 18.3 mm, nearest point, so a lower bound; worst region torso, 28 mm.</a:t>
             </a:r>
             <a:endParaRPr lang="en-US" sz="1100" dirty="0"/>
           </a:p>
           <a:p>
             <a:pPr marL="177800" indent="-177800">
               <a:spcAft>
-                <a:spcPts val="300"/>
+                <a:spcPts val="400"/>
               </a:spcAft>
               <a:buSzPct val="100000"/>
               <a:buChar char="•"/>
@@ -16472,7 +16493,7 @@
                   <a:schemeClr val="tx1"/>
                 </a:solidFill>
               </a:rPr>
-              <a:t>Perfect targets: </a:t>
+              <a:t>2D vs OpenPose: </a:t>
             </a:r>
             <a:r>
               <a:rPr lang="en-US" sz="1100" dirty="0">
@@ -16480,26 +16501,266 @@
                   <a:schemeClr val="tx1"/>
                 </a:solidFill>
               </a:rPr>
-              <a:t>joints within 1.5 mm, yet a 45° head turn comes back as 0°.</a:t>
+              <a:t>12.4 px median, only +1.1 px over raw 3DPW (11.3 px).</a:t>
             </a:r>
             <a:endParaRPr lang="en-US" sz="1100" dirty="0"/>
           </a:p>
-        </p:txBody>
-      </p:sp>
-      <p:sp>
-        <p:nvSpPr>
-          <p:cNvPr id="7" name="ev Checked in code"/>
+          <a:p>
+            <a:pPr marL="177800" indent="-177800">
+              <a:spcAft>
+                <a:spcPts val="400"/>
+              </a:spcAft>
+              <a:buSzPct val="100000"/>
+              <a:buChar char="•"/>
+            </a:pPr>
+            <a:r>
+              <a:rPr lang="en-US" sz="1100" b="1" dirty="0">
+                <a:solidFill>
+                  <a:schemeClr val="tx1"/>
+                </a:solidFill>
+              </a:rPr>
+              <a:t>Left/right, mirror: </a:t>
+            </a:r>
+            <a:r>
+              <a:rPr lang="en-US" sz="1100" dirty="0">
+                <a:solidFill>
+                  <a:schemeClr val="tx1"/>
+                </a:solidFill>
+              </a:rPr>
+              <a:t>100% pass. The loader passes labels unchanged.</a:t>
+            </a:r>
+            <a:endParaRPr lang="en-US" sz="1100" dirty="0"/>
+          </a:p>
+          <a:p>
+            <a:pPr marL="177800" indent="-177800">
+              <a:spcAft>
+                <a:spcPts val="400"/>
+              </a:spcAft>
+              <a:buSzPct val="100000"/>
+              <a:buChar char="•"/>
+            </a:pPr>
+            <a:r>
+              <a:rPr lang="en-US" sz="1100" b="1" dirty="0">
+                <a:solidFill>
+                  <a:schemeClr val="tx1"/>
+                </a:solidFill>
+              </a:rPr>
+              <a:t>All 87 fits: </a:t>
+            </a:r>
+            <a:r>
+              <a:rPr lang="en-US" sz="1100" dirty="0">
+                <a:solidFill>
+                  <a:schemeClr val="tx1"/>
+                </a:solidFill>
+              </a:rPr>
+              <a:t>22,915 frames; mean joint error per frame: median 18.2 mm, max 70.9 mm.</a:t>
+            </a:r>
+            <a:endParaRPr lang="en-US" sz="1100" dirty="0"/>
+          </a:p>
+        </p:txBody>
+      </p:sp>
+      <p:sp>
+        <p:nvSpPr>
+          <p:cNvPr id="7" name="ev Label defects"/>
           <p:cNvSpPr/>
           <p:nvPr/>
         </p:nvSpPr>
         <p:spPr>
           <a:xfrm>
             <a:off x="3246120" y="1143000"/>
-            <a:ext cx="2651760" cy="2432304"/>
+            <a:ext cx="2651760" cy="3200400"/>
           </a:xfrm>
           <a:prstGeom prst="roundRect">
             <a:avLst>
-              <a:gd name="adj" fmla="val 3008"/>
+              <a:gd name="adj" fmla="val 2759"/>
+            </a:avLst>
+          </a:prstGeom>
+          <a:solidFill>
+            <a:srgbClr val="FBE9E7"/>
+          </a:solidFill>
+          <a:ln w="12700">
+            <a:solidFill>
+              <a:srgbClr val="FBE9E7"/>
+            </a:solidFill>
+            <a:prstDash val="solid"/>
+          </a:ln>
+        </p:spPr>
+      </p:sp>
+      <p:sp>
+        <p:nvSpPr>
+          <p:cNvPr id="8" name="ev dot Label defects"/>
+          <p:cNvSpPr/>
+          <p:nvPr/>
+        </p:nvSpPr>
+        <p:spPr>
+          <a:xfrm>
+            <a:off x="3401568" y="1280160"/>
+            <a:ext cx="274320" cy="274320"/>
+          </a:xfrm>
+          <a:prstGeom prst="ellipse">
+            <a:avLst/>
+          </a:prstGeom>
+          <a:solidFill>
+            <a:schemeClr val="accent4"/>
+          </a:solidFill>
+          <a:ln w="12700">
+            <a:solidFill>
+              <a:schemeClr val="accent4"/>
+            </a:solidFill>
+            <a:prstDash val="solid"/>
+          </a:ln>
+        </p:spPr>
+      </p:sp>
+      <p:sp>
+        <p:nvSpPr>
+          <p:cNvPr id="9" name="ev head Label defects"/>
+          <p:cNvSpPr txBox="1"/>
+          <p:nvPr/>
+        </p:nvSpPr>
+        <p:spPr>
+          <a:xfrm>
+            <a:off x="3794760" y="1234440"/>
+            <a:ext cx="1965960" cy="365760"/>
+          </a:xfrm>
+          <a:prstGeom prst="rect">
+            <a:avLst/>
+          </a:prstGeom>
+          <a:noFill/>
+          <a:ln/>
+        </p:spPr>
+        <p:txBody>
+          <a:bodyPr wrap="square" lIns="0" tIns="0" rIns="0" bIns="0" rtlCol="0" anchor="ctr"/>
+          <a:lstStyle/>
+          <a:p>
+            <a:pPr indent="0" marL="0">
+              <a:buNone/>
+            </a:pPr>
+            <a:r>
+              <a:rPr lang="en-US" sz="1500" b="1" dirty="0">
+                <a:solidFill>
+                  <a:schemeClr val="tx1"/>
+                </a:solidFill>
+              </a:rPr>
+              <a:t>Label defects</a:t>
+            </a:r>
+            <a:endParaRPr lang="en-US" sz="1500" dirty="0"/>
+          </a:p>
+        </p:txBody>
+      </p:sp>
+      <p:sp>
+        <p:nvSpPr>
+          <p:cNvPr id="10" name="ev body Label defects"/>
+          <p:cNvSpPr txBox="1"/>
+          <p:nvPr/>
+        </p:nvSpPr>
+        <p:spPr>
+          <a:xfrm>
+            <a:off x="3383280" y="1645920"/>
+            <a:ext cx="2377440" cy="2633472"/>
+          </a:xfrm>
+          <a:prstGeom prst="rect">
+            <a:avLst/>
+          </a:prstGeom>
+          <a:noFill/>
+          <a:ln/>
+        </p:spPr>
+        <p:txBody>
+          <a:bodyPr wrap="square" lIns="0" tIns="0" rIns="0" bIns="0" rtlCol="0" anchor="t"/>
+          <a:lstStyle/>
+          <a:p>
+            <a:pPr marL="177800" indent="-177800">
+              <a:spcAft>
+                <a:spcPts val="400"/>
+              </a:spcAft>
+              <a:buSzPct val="100000"/>
+              <a:buChar char="•"/>
+            </a:pPr>
+            <a:r>
+              <a:rPr lang="en-US" sz="1100" b="1" dirty="0">
+                <a:solidFill>
+                  <a:schemeClr val="tx1"/>
+                </a:solidFill>
+              </a:rPr>
+              <a:t>Gender reversed: </a:t>
+            </a:r>
+            <a:r>
+              <a:rPr lang="en-US" sz="1100" dirty="0">
+                <a:solidFill>
+                  <a:schemeClr val="tx1"/>
+                </a:solidFill>
+              </a:rPr>
+              <a:t>Anny 0 = male, but 3DPW men get 1, women 0. Refit of 73 male samples, gender flipped: joints better for 72 (19.2 → 15.3 mm), surface for 68. Female (31): mixed, surface better for 27, joints for 8.</a:t>
+            </a:r>
+            <a:endParaRPr lang="en-US" sz="1100" dirty="0"/>
+          </a:p>
+          <a:p>
+            <a:pPr marL="177800" indent="-177800">
+              <a:spcAft>
+                <a:spcPts val="400"/>
+              </a:spcAft>
+              <a:buSzPct val="100000"/>
+              <a:buChar char="•"/>
+            </a:pPr>
+            <a:r>
+              <a:rPr lang="en-US" sz="1100" b="1" dirty="0">
+                <a:solidFill>
+                  <a:schemeClr val="tx1"/>
+                </a:solidFill>
+              </a:rPr>
+              <a:t>Two-person images: </a:t>
+            </a:r>
+            <a:r>
+              <a:rPr lang="en-US" sz="1100" dirty="0">
+                <a:solidFill>
+                  <a:schemeClr val="tx1"/>
+                </a:solidFill>
+              </a:rPr>
+              <a:t>in 407 of 960, one actor (valid in 3DPW) has no label: not fitted on that frame, mostly the per-person frame step (slide 5).</a:t>
+            </a:r>
+            <a:endParaRPr lang="en-US" sz="1100" dirty="0"/>
+          </a:p>
+          <a:p>
+            <a:pPr marL="177800" indent="-177800">
+              <a:spcAft>
+                <a:spcPts val="400"/>
+              </a:spcAft>
+              <a:buSzPct val="100000"/>
+              <a:buChar char="•"/>
+            </a:pPr>
+            <a:r>
+              <a:rPr lang="en-US" sz="1100" b="1" dirty="0">
+                <a:solidFill>
+                  <a:schemeClr val="tx1"/>
+                </a:solidFill>
+              </a:rPr>
+              <a:t>Labels missing: </a:t>
+            </a:r>
+            <a:r>
+              <a:rPr lang="en-US" sz="1100" dirty="0">
+                <a:solidFill>
+                  <a:schemeClr val="tx1"/>
+                </a:solidFill>
+              </a:rPr>
+              <a:t>6 train sequences, part of captureSelfies_00, val basketball_01. The fits exist; rebuild running now.</a:t>
+            </a:r>
+            <a:endParaRPr lang="en-US" sz="1100" dirty="0"/>
+          </a:p>
+        </p:txBody>
+      </p:sp>
+      <p:sp>
+        <p:nvSpPr>
+          <p:cNvPr id="11" name="ev Limits and grades"/>
+          <p:cNvSpPr/>
+          <p:nvPr/>
+        </p:nvSpPr>
+        <p:spPr>
+          <a:xfrm>
+            <a:off x="6035040" y="1143000"/>
+            <a:ext cx="2651760" cy="3200400"/>
+          </a:xfrm>
+          <a:prstGeom prst="roundRect">
+            <a:avLst>
+              <a:gd name="adj" fmla="val 2759"/>
             </a:avLst>
           </a:prstGeom>
           <a:solidFill>
@@ -16515,24 +16776,24 @@
       </p:sp>
       <p:sp>
         <p:nvSpPr>
-          <p:cNvPr id="8" name="ev dot Checked in code"/>
+          <p:cNvPr id="12" name="ev dot Limits and grades"/>
           <p:cNvSpPr/>
           <p:nvPr/>
         </p:nvSpPr>
         <p:spPr>
           <a:xfrm>
-            <a:off x="3401568" y="1280160"/>
+            <a:off x="6190488" y="1280160"/>
             <a:ext cx="274320" cy="274320"/>
           </a:xfrm>
           <a:prstGeom prst="ellipse">
             <a:avLst/>
           </a:prstGeom>
           <a:solidFill>
-            <a:schemeClr val="accent1"/>
+            <a:schemeClr val="accent5"/>
           </a:solidFill>
           <a:ln w="12700">
             <a:solidFill>
-              <a:schemeClr val="accent1"/>
+              <a:schemeClr val="accent5"/>
             </a:solidFill>
             <a:prstDash val="solid"/>
           </a:ln>
@@ -16540,13 +16801,13 @@
       </p:sp>
       <p:sp>
         <p:nvSpPr>
-          <p:cNvPr id="9" name="ev head Checked in code"/>
+          <p:cNvPr id="13" name="ev head Limits and grades"/>
           <p:cNvSpPr txBox="1"/>
           <p:nvPr/>
         </p:nvSpPr>
         <p:spPr>
           <a:xfrm>
-            <a:off x="3794760" y="1234440"/>
+            <a:off x="6583680" y="1234440"/>
             <a:ext cx="1965960" cy="365760"/>
           </a:xfrm>
           <a:prstGeom prst="rect">
@@ -16568,7 +16829,7 @@
                   <a:schemeClr val="tx1"/>
                 </a:solidFill>
               </a:rPr>
-              <a:t>Checked in code</a:t>
+              <a:t>Limits and grades</a:t>
             </a:r>
             <a:endParaRPr lang="en-US" sz="1500" dirty="0"/>
           </a:p>
@@ -16576,14 +16837,14 @@
       </p:sp>
       <p:sp>
         <p:nvSpPr>
-          <p:cNvPr id="10" name="ev body Checked in code"/>
+          <p:cNvPr id="14" name="ev body Limits and grades"/>
           <p:cNvSpPr txBox="1"/>
           <p:nvPr/>
         </p:nvSpPr>
         <p:spPr>
           <a:xfrm>
-            <a:off x="3383280" y="1645920"/>
-            <a:ext cx="2377440" cy="1865376"/>
+            <a:off x="6172200" y="1645920"/>
+            <a:ext cx="2377440" cy="2633472"/>
           </a:xfrm>
           <a:prstGeom prst="rect">
             <a:avLst/>
@@ -16597,7 +16858,7 @@
           <a:p>
             <a:pPr marL="177800" indent="-177800">
               <a:spcAft>
-                <a:spcPts val="300"/>
+                <a:spcPts val="400"/>
               </a:spcAft>
               <a:buSzPct val="100000"/>
               <a:buChar char="•"/>
@@ -16608,7 +16869,7 @@
                   <a:schemeClr val="tx1"/>
                 </a:solidFill>
               </a:rPr>
-              <a:t>Left/right, metres, image numbers </a:t>
+              <a:t>Head at rest: </a:t>
             </a:r>
             <a:r>
               <a:rPr lang="en-US" sz="1100" dirty="0">
@@ -16616,14 +16877,14 @@
                   <a:schemeClr val="tx1"/>
                 </a:solidFill>
               </a:rPr>
-              <a:t>line up; old 60 Hz frame bug fixed.</a:t>
+              <a:t>neck02/03, head, jaw at rest in all 2,535 checked people; only neck01 turns.</a:t>
             </a:r>
             <a:endParaRPr lang="en-US" sz="1100" dirty="0"/>
           </a:p>
           <a:p>
             <a:pPr marL="177800" indent="-177800">
               <a:spcAft>
-                <a:spcPts val="300"/>
+                <a:spcPts val="400"/>
               </a:spcAft>
               <a:buSzPct val="100000"/>
               <a:buChar char="•"/>
@@ -16634,7 +16895,7 @@
                   <a:schemeClr val="tx1"/>
                 </a:solidFill>
               </a:rPr>
-              <a:t>Bones without a target </a:t>
+              <a:t>Head turn vs chest: </a:t>
             </a:r>
             <a:r>
               <a:rPr lang="en-US" sz="1100" dirty="0">
@@ -16642,14 +16903,14 @@
                   <a:schemeClr val="tx1"/>
                 </a:solidFill>
               </a:rPr>
-              <a:t>keep Anny's rest pose; no NaN or broken rotations.</a:t>
+              <a:t>20° in SMPL, 9.5° in the labels (median), lost mainly in test.</a:t>
             </a:r>
             <a:endParaRPr lang="en-US" sz="1100" dirty="0"/>
           </a:p>
           <a:p>
             <a:pPr marL="177800" indent="-177800">
               <a:spcAft>
-                <a:spcPts val="300"/>
+                <a:spcPts val="400"/>
               </a:spcAft>
               <a:buSzPct val="100000"/>
               <a:buChar char="•"/>
@@ -16660,7 +16921,7 @@
                   <a:schemeClr val="tx1"/>
                 </a:solidFill>
               </a:rPr>
-              <a:t>Loader camera: </a:t>
+              <a:t>Overall FAIL: </a:t>
             </a:r>
             <a:r>
               <a:rPr lang="en-US" sz="1100" dirty="0">
@@ -16668,14 +16929,14 @@
                   <a:schemeClr val="tx1"/>
                 </a:solidFill>
               </a:rPr>
-              <a:t>rescaled for the 672 px square (likely right).</a:t>
+              <a:t>limb-length ratios (forearm 0.879, thigh 1.119 Anny/SMPL); FAIL in test only, train PASS; cause unknown. Elbow, wrist 14–18 mm.</a:t>
             </a:r>
             <a:endParaRPr lang="en-US" sz="1100" dirty="0"/>
           </a:p>
           <a:p>
             <a:pPr marL="177800" indent="-177800">
               <a:spcAft>
-                <a:spcPts val="300"/>
+                <a:spcPts val="400"/>
               </a:spcAft>
               <a:buSzPct val="100000"/>
               <a:buChar char="•"/>
@@ -16686,7 +16947,7 @@
                   <a:schemeClr val="tx1"/>
                 </a:solidFill>
               </a:rPr>
-              <a:t>Version: </a:t>
+              <a:t>WARN: </a:t>
             </a:r>
             <a:r>
               <a:rPr lang="en-US" sz="1100" dirty="0">
@@ -16694,7 +16955,7 @@
                   <a:schemeClr val="tx1"/>
                 </a:solidFill>
               </a:rPr>
-              <a:t>the label builder only accepts v2.2 fits.</a:t>
+              <a:t>3.2% of people have a joint &gt; 100 mm (worst: hips). Train alone: 5.2%, FAIL.</a:t>
             </a:r>
             <a:endParaRPr lang="en-US" sz="1100" dirty="0"/>
           </a:p>
@@ -16702,66 +16963,14 @@
       </p:sp>
       <p:sp>
         <p:nvSpPr>
-          <p:cNvPr id="11" name="ev Limits, not yet measured"/>
-          <p:cNvSpPr/>
-          <p:nvPr/>
-        </p:nvSpPr>
-        <p:spPr>
-          <a:xfrm>
-            <a:off x="6035040" y="1143000"/>
-            <a:ext cx="2651760" cy="2432304"/>
-          </a:xfrm>
-          <a:prstGeom prst="roundRect">
-            <a:avLst>
-              <a:gd name="adj" fmla="val 3008"/>
-            </a:avLst>
-          </a:prstGeom>
-          <a:solidFill>
-            <a:schemeClr val="bg2"/>
-          </a:solidFill>
-          <a:ln w="12700">
-            <a:solidFill>
-              <a:schemeClr val="bg2"/>
-            </a:solidFill>
-            <a:prstDash val="solid"/>
-          </a:ln>
-        </p:spPr>
-      </p:sp>
-      <p:sp>
-        <p:nvSpPr>
-          <p:cNvPr id="12" name="ev dot Limits, not yet measured"/>
-          <p:cNvSpPr/>
-          <p:nvPr/>
-        </p:nvSpPr>
-        <p:spPr>
-          <a:xfrm>
-            <a:off x="6190488" y="1280160"/>
-            <a:ext cx="274320" cy="274320"/>
-          </a:xfrm>
-          <a:prstGeom prst="ellipse">
-            <a:avLst/>
-          </a:prstGeom>
-          <a:solidFill>
-            <a:schemeClr val="accent2"/>
-          </a:solidFill>
-          <a:ln w="12700">
-            <a:solidFill>
-              <a:schemeClr val="accent2"/>
-            </a:solidFill>
-            <a:prstDash val="solid"/>
-          </a:ln>
-        </p:spPr>
-      </p:sp>
-      <p:sp>
-        <p:nvSpPr>
-          <p:cNvPr id="13" name="ev head Limits, not yet measured"/>
+          <p:cNvPr id="15" name="check source"/>
           <p:cNvSpPr txBox="1"/>
           <p:nvPr/>
         </p:nvSpPr>
         <p:spPr>
           <a:xfrm>
-            <a:off x="6583680" y="1234440"/>
-            <a:ext cx="1965960" cy="365760"/>
+            <a:off x="457200" y="4443984"/>
+            <a:ext cx="8229600" cy="237744"/>
           </a:xfrm>
           <a:prstGeom prst="rect">
             <a:avLst/>
@@ -16770,315 +16979,27 @@
           <a:ln/>
         </p:spPr>
         <p:txBody>
-          <a:bodyPr wrap="square" lIns="0" tIns="0" rIns="0" bIns="0" rtlCol="0" anchor="ctr"/>
+          <a:bodyPr wrap="square" lIns="0" tIns="0" rIns="0" bIns="0" rtlCol="0" anchor="t"/>
           <a:lstStyle/>
           <a:p>
             <a:pPr indent="0" marL="0">
               <a:buNone/>
             </a:pPr>
             <a:r>
-              <a:rPr lang="en-US" sz="1500" b="1" dirty="0">
-                <a:solidFill>
-                  <a:schemeClr val="tx1"/>
-                </a:solidFill>
-              </a:rPr>
-              <a:t>Limits, not yet measured</a:t>
-            </a:r>
-            <a:endParaRPr lang="en-US" sz="1500" dirty="0"/>
-          </a:p>
-        </p:txBody>
-      </p:sp>
-      <p:sp>
-        <p:nvSpPr>
-          <p:cNvPr id="14" name="ev body Limits, not yet measured"/>
-          <p:cNvSpPr txBox="1"/>
-          <p:nvPr/>
-        </p:nvSpPr>
-        <p:spPr>
-          <a:xfrm>
-            <a:off x="6172200" y="1645920"/>
-            <a:ext cx="2377440" cy="1865376"/>
-          </a:xfrm>
-          <a:prstGeom prst="rect">
-            <a:avLst/>
-          </a:prstGeom>
-          <a:noFill/>
-          <a:ln/>
-        </p:spPr>
-        <p:txBody>
-          <a:bodyPr wrap="square" lIns="0" tIns="0" rIns="0" bIns="0" rtlCol="0" anchor="t"/>
-          <a:lstStyle/>
-          <a:p>
-            <a:pPr marL="177800" indent="-177800">
-              <a:spcAft>
-                <a:spcPts val="300"/>
-              </a:spcAft>
-              <a:buSzPct val="100000"/>
-              <a:buChar char="•"/>
-            </a:pPr>
-            <a:r>
               <a:rPr lang="en-US" sz="1100" b="1" dirty="0">
                 <a:solidFill>
-                  <a:schemeClr val="tx1"/>
-                </a:solidFill>
-              </a:rPr>
-              <a:t>By design: </a:t>
+                  <a:srgbClr val="1B2233"/>
+                </a:solidFill>
+              </a:rPr>
+              <a:t>Source: </a:t>
             </a:r>
             <a:r>
               <a:rPr lang="en-US" sz="1100" dirty="0">
                 <a:solidFill>
-                  <a:schemeClr val="tx1"/>
-                </a:solidFill>
-              </a:rPr>
-              <a:t>head turn and limb twist are not recovered; neck02/03, head and fingers stay at rest; age 0.55.</a:t>
-            </a:r>
-            <a:endParaRPr lang="en-US" sz="1100" dirty="0"/>
-          </a:p>
-          <a:p>
-            <a:pPr marL="177800" indent="-177800">
-              <a:spcAft>
-                <a:spcPts val="300"/>
-              </a:spcAft>
-              <a:buSzPct val="100000"/>
-              <a:buChar char="•"/>
-            </a:pPr>
-            <a:r>
-              <a:rPr lang="en-US" sz="1100" b="1" dirty="0">
-                <a:solidFill>
-                  <a:schemeClr val="tx1"/>
-                </a:solidFill>
-              </a:rPr>
-              <a:t>Never summarised: </a:t>
-            </a:r>
-            <a:r>
-              <a:rPr lang="en-US" sz="1100" dirty="0">
-                <a:solidFill>
-                  <a:schemeClr val="tx1"/>
-                </a:solidFill>
-              </a:rPr>
-              <a:t>v2.2 fit error, saved per frame on the cluster (the ‘13–20 mm’ has no log). Mesh and head error vs SMPL: never measured.</a:t>
-            </a:r>
-            <a:endParaRPr lang="en-US" sz="1100" dirty="0"/>
-          </a:p>
-          <a:p>
-            <a:pPr marL="177800" indent="-177800">
-              <a:spcAft>
-                <a:spcPts val="300"/>
-              </a:spcAft>
-              <a:buSzPct val="100000"/>
-              <a:buChar char="•"/>
-            </a:pPr>
-            <a:r>
-              <a:rPr lang="en-US" sz="1100" b="1" dirty="0">
-                <a:solidFill>
-                  <a:schemeClr val="tx1"/>
-                </a:solidFill>
-              </a:rPr>
-              <a:t>Fresh check, written, not yet run: </a:t>
-            </a:r>
-            <a:r>
-              <a:rPr lang="en-US" sz="1100" dirty="0">
-                <a:solidFill>
-                  <a:schemeClr val="tx1"/>
-                </a:solidFill>
-              </a:rPr>
-              <a:t>slurm/diagnostics/​check_3dpw_conversion.sh</a:t>
-            </a:r>
-            <a:endParaRPr lang="en-US" sz="1100" dirty="0"/>
-          </a:p>
-        </p:txBody>
-      </p:sp>
-      <p:sp>
-        <p:nvSpPr>
-          <p:cNvPr id="15" name="bug band"/>
-          <p:cNvSpPr/>
-          <p:nvPr/>
-        </p:nvSpPr>
-        <p:spPr>
-          <a:xfrm>
-            <a:off x="457200" y="3685032"/>
-            <a:ext cx="8229600" cy="996696"/>
-          </a:xfrm>
-          <a:prstGeom prst="roundRect">
-            <a:avLst>
-              <a:gd name="adj" fmla="val 7339"/>
-            </a:avLst>
-          </a:prstGeom>
-          <a:solidFill>
-            <a:srgbClr val="FBE9E7"/>
-          </a:solidFill>
-          <a:ln w="12700">
-            <a:solidFill>
-              <a:srgbClr val="FBE9E7"/>
-            </a:solidFill>
-            <a:prstDash val="solid"/>
-          </a:ln>
-        </p:spPr>
-      </p:sp>
-      <p:sp>
-        <p:nvSpPr>
-          <p:cNvPr id="16" name="bug dot"/>
-          <p:cNvSpPr/>
-          <p:nvPr/>
-        </p:nvSpPr>
-        <p:spPr>
-          <a:xfrm>
-            <a:off x="612648" y="3758184"/>
-            <a:ext cx="274320" cy="274320"/>
-          </a:xfrm>
-          <a:prstGeom prst="ellipse">
-            <a:avLst/>
-          </a:prstGeom>
-          <a:solidFill>
-            <a:schemeClr val="accent4"/>
-          </a:solidFill>
-          <a:ln w="12700">
-            <a:solidFill>
-              <a:schemeClr val="accent4"/>
-            </a:solidFill>
-            <a:prstDash val="solid"/>
-          </a:ln>
-        </p:spPr>
-      </p:sp>
-      <p:sp>
-        <p:nvSpPr>
-          <p:cNvPr id="17" name="bug head"/>
-          <p:cNvSpPr txBox="1"/>
-          <p:nvPr/>
-        </p:nvSpPr>
-        <p:spPr>
-          <a:xfrm>
-            <a:off x="1005840" y="3712464"/>
-            <a:ext cx="7543800" cy="365760"/>
-          </a:xfrm>
-          <a:prstGeom prst="rect">
-            <a:avLst/>
-          </a:prstGeom>
-          <a:noFill/>
-          <a:ln/>
-        </p:spPr>
-        <p:txBody>
-          <a:bodyPr wrap="square" lIns="0" tIns="0" rIns="0" bIns="0" rtlCol="0" anchor="ctr"/>
-          <a:lstStyle/>
-          <a:p>
-            <a:pPr indent="0" marL="0">
-              <a:buNone/>
-            </a:pPr>
-            <a:r>
-              <a:rPr lang="en-US" sz="1300" b="1" dirty="0">
-                <a:solidFill>
-                  <a:srgbClr val="C0392B"/>
-                </a:solidFill>
-              </a:rPr>
-              <a:t>Two real bugs found </a:t>
-            </a:r>
-            <a:r>
-              <a:rPr lang="en-US" sz="1300" dirty="0">
-                <a:solidFill>
-                  <a:srgbClr val="1B2233"/>
-                </a:solidFill>
-              </a:rPr>
-              <a:t>(read in code, seen in data). v7–v10 train on these labels; all 3DPW scores use them.</a:t>
-            </a:r>
-            <a:endParaRPr lang="en-US" sz="1300" dirty="0"/>
-          </a:p>
-        </p:txBody>
-      </p:sp>
-      <p:sp>
-        <p:nvSpPr>
-          <p:cNvPr id="18" name="bug text"/>
-          <p:cNvSpPr txBox="1"/>
-          <p:nvPr/>
-        </p:nvSpPr>
-        <p:spPr>
-          <a:xfrm>
-            <a:off x="640080" y="4087368"/>
-            <a:ext cx="7909560" cy="566928"/>
-          </a:xfrm>
-          <a:prstGeom prst="rect">
-            <a:avLst/>
-          </a:prstGeom>
-          <a:noFill/>
-          <a:ln/>
-        </p:spPr>
-        <p:txBody>
-          <a:bodyPr wrap="square" lIns="0" tIns="0" rIns="0" bIns="0" rtlCol="0" anchor="t"/>
-          <a:lstStyle/>
-          <a:p>
-            <a:pPr marL="177800" indent="-177800">
-              <a:spcAft>
-                <a:spcPts val="200"/>
-              </a:spcAft>
-              <a:buSzPct val="100000"/>
-              <a:buChar char="•"/>
-            </a:pPr>
-            <a:r>
-              <a:rPr lang="en-US" sz="1100" b="1" dirty="0">
-                <a:solidFill>
-                  <a:schemeClr val="tx1"/>
-                </a:solidFill>
-              </a:rPr>
-              <a:t>Gender reversed: </a:t>
-            </a:r>
-            <a:r>
-              <a:rPr lang="en-US" sz="1100" dirty="0">
-                <a:solidFill>
-                  <a:schemeClr val="tx1"/>
-                </a:solidFill>
-              </a:rPr>
-              <a:t>the code sets man = 1, but in Anny 1 = female: men get a female body (seen in v2.1 renders), women a male one.</a:t>
-            </a:r>
-            <a:endParaRPr lang="en-US" sz="1100" dirty="0"/>
-          </a:p>
-          <a:p>
-            <a:pPr marL="177800" indent="-177800">
-              <a:spcAft>
-                <a:spcPts val="200"/>
-              </a:spcAft>
-              <a:buSzPct val="100000"/>
-              <a:buChar char="•"/>
-            </a:pPr>
-            <a:r>
-              <a:rPr lang="en-US" sz="1100" b="1" dirty="0">
-                <a:solidFill>
-                  <a:schemeClr val="tx1"/>
-                </a:solidFill>
-              </a:rPr>
-              <a:t>Two-person scenes: </a:t>
-            </a:r>
-            <a:r>
-              <a:rPr lang="en-US" sz="1100" dirty="0">
-                <a:solidFill>
-                  <a:schemeClr val="tx1"/>
-                </a:solidFill>
-              </a:rPr>
-              <a:t>frames are picked per person, so ≥ 48% of these train images label only one of the two people.</a:t>
-            </a:r>
-            <a:endParaRPr lang="en-US" sz="1100" dirty="0"/>
-          </a:p>
-          <a:p>
-            <a:pPr marL="177800" indent="-177800">
-              <a:spcAft>
-                <a:spcPts val="200"/>
-              </a:spcAft>
-              <a:buSzPct val="100000"/>
-              <a:buChar char="•"/>
-            </a:pPr>
-            <a:r>
-              <a:rPr lang="en-US" sz="1100" b="1" dirty="0">
-                <a:solidFill>
-                  <a:schemeClr val="tx1"/>
-                </a:solidFill>
-              </a:rPr>
-              <a:t>Also missing: </a:t>
-            </a:r>
-            <a:r>
-              <a:rPr lang="en-US" sz="1100" dirty="0">
-                <a:solidFill>
-                  <a:schemeClr val="tx1"/>
-                </a:solidFill>
-              </a:rPr>
-              <a:t>6 of 24 train and 2 of 12 validation sequences have no labels at all (cause unknown).</a:t>
+                  <a:schemeClr val="tx2"/>
+                </a:solidFill>
+              </a:rPr>
+              <a:t>slurm/diagnostics/check_3dpw_conversion.sh, job 3575369; 2,535 people in 2,080 sampled images (40 per sequence, 52 sequences)</a:t>
             </a:r>
             <a:endParaRPr lang="en-US" sz="1100" dirty="0"/>
           </a:p>

</xml_diff>

<commit_message>
docs: exp6 bone-fix results and the label-rebuild outcome in deck and handover
v5: correction + 2-epoch fine-tune passes (neck02 4.7 deg, girth 1.00, neck skin
10.7 mm, PVE 68.8 vs control 76.9, one run); correction alone fails on head
direction. v10: metacarpal correction passes without training (PVE 74.1 -> 69.9).
Label rebuild gave identical counts: the builder skips frames whose image file is
missing, so the earlier 'built too early' explanation is withdrawn.

Co-Authored-By: Claude Opus 5.5 <noreply@anthropic.com>
Claude-Session: https://claude.ai/code/session_016LhpG4kT7Z7ppxbG4TW5S9
</commit_message>
<xml_diff>
--- a/docs/supervisor_update_2026-10-16.pptx
+++ b/docs/supervisor_update_2026-10-16.pptx
@@ -123,7 +123,7 @@
   <p:extLst>
     <p:ext uri="{521415D9-36F7-43E2-AB2F-B90AF26B5E84}">
       <p14:sectionLst xmlns:p14="http://schemas.microsoft.com/office/powerpoint/2010/main">
-        <p14:section name="Overview" id="{b53d6943-66d5-d318-d95f-77509c60b5b9}">
+        <p14:section name="Overview" id="{143696ff-9e68-629c-c079-03a155879040}">
           <p14:sldIdLst>
             <p14:sldId id="256"/>
             <p14:sldId id="257"/>
@@ -131,27 +131,27 @@
             <p14:sldId id="259"/>
           </p14:sldIdLst>
         </p14:section>
-        <p14:section name="3DPW labels" id="{78b63fef-ceb4-2d3d-cc51-5f4c9e7ba7ed}">
+        <p14:section name="3DPW labels" id="{140fad23-c578-47f0-9e3a-d304fd9a30f9}">
           <p14:sldIdLst>
             <p14:sldId id="260"/>
             <p14:sldId id="261"/>
           </p14:sldIdLst>
         </p14:section>
-        <p14:section name="Findings" id="{7f188609-64d0-42d5-3127-295f280f608c}">
+        <p14:section name="Findings" id="{4ddda28f-6595-fb37-27ef-34ca064d80a1}">
           <p14:sldIdLst>
             <p14:sldId id="262"/>
             <p14:sldId id="263"/>
             <p14:sldId id="264"/>
           </p14:sldIdLst>
         </p14:section>
-        <p14:section name="Bug" id="{b0385c4e-7fe0-de58-7bba-2f5d5a3a857c}">
+        <p14:section name="Bug" id="{010e823a-e03f-3730-8b33-baf08e69e92d}">
           <p14:sldIdLst>
             <p14:sldId id="265"/>
             <p14:sldId id="266"/>
             <p14:sldId id="267"/>
           </p14:sldIdLst>
         </p14:section>
-        <p14:section name="Next" id="{3cc4bffa-2bf0-43dc-fb30-d5cac4cc2767}">
+        <p14:section name="Next" id="{17b11dfb-7fae-669c-4aa7-c115eb2b0c09}">
           <p14:sldIdLst>
             <p14:sldId id="268"/>
             <p14:sldId id="269"/>
@@ -159,7 +159,7 @@
             <p14:sldId id="271"/>
           </p14:sldIdLst>
         </p14:section>
-        <p14:section name="Appendix" id="{07ae8734-6332-c847-479b-db5612eece1b}">
+        <p14:section name="Appendix" id="{60000833-f4f2-6c14-74fa-3fc2d013270f}">
           <p14:sldIdLst>
             <p14:sldId id="272"/>
           </p14:sldIdLst>
@@ -568,7 +568,7 @@
           <a:p>
             <a:r>
               <a:rPr lang="en-US" dirty="0"/>
-              <a:t>Since last Friday I measured each stage of the pipeline separately. I will show what is not the cause, how the 3DPW labels are made, how well they match 3DPW and three defects I found in them, what I found in the neck and measured about the fingers and the children, one depth bug nobody was looking for and its fix, and what is still open. I will say clearly what is measured and what is only a guess.</a:t>
+              <a:t>Since last Friday I measured each stage of the pipeline separately. I will show what is not the cause, how the 3DPW labels are made, how well they match 3DPW and three defects I found in them, what I found in the neck and a first fix for it, what I measured about the fingers and the children, one depth bug nobody was looking for and its fix, and what is still open. I will say clearly what is measured and what is only a guess.</a:t>
             </a:r>
           </a:p>
         </p:txBody>
@@ -925,7 +925,7 @@
           <a:p>
             <a:r>
               <a:rPr lang="en-US" dirty="0"/>
-              <a:t>All four experiments are done. Each ran next to a control with the main switch off, on the same 100-image holdout and manifest, with helper bones masked. Depth: by its own success rule the experiment failed. The slope did not move toward 1: it is 0.30 with the switch alone and 0.38 with the five-times depth loss. PVE is 74.8, against 72.2 for the control and 70.5 for v5. What clearly improved is outside the rule: the root error went from 1.21 to 0.54 metres and the drawn size from 0.63 to 0.84. I say that openly instead of changing the rule afterwards. Children, neck and fingers: no measurable effect. The neck loss gave 11.3 degrees of head error, which passes the rule of below 12, but the two controls gave 11.7 and 13.6, so that is inside the noise. There is no fixed random seed: two identical runs differed by 7.6 millimetres PVE and 1.9 degrees of head error, so one pilot only detects about 10 millimetres, 3 degrees or 2 recall points. No new architecture, because the diagnostics do not justify one.</a:t>
+              <a:t>All four experiments are done, each next to a control with the main switch off. Depth: by its own success rule the experiment failed, because every run, the controls too, misses the limit of 71.5 millimetres PVE and 89.2 percent recall. The 10-epoch run with the stronger loss has 74.8 millimetres and 87.8 percent. The slope is 0.30 with the switch alone and 0.38 to 0.44 with the stronger depth loss, against 0.33 for v5: far from 1. What clearly improved is outside the rule: the root error went from 1.21 to 0.54 metres and the drawn size from 0.63 to 0.84. I say that openly instead of changing the rule afterwards. Children, neck and fingers: no measurable effect. The neck loss gave 11.3 degrees of head error, which passes the rule of below 12, but the two controls gave 11.7 and 13.6, so that is inside the noise. With no fixed seed, one pilot only detects about 10 millimetres PVE, 3 degrees or 2 recall points. No new architecture, because the diagnostics do not justify one.</a:t>
             </a:r>
           </a:p>
           <a:p>
@@ -934,7 +934,7 @@
           <a:p>
             <a:r>
               <a:rPr lang="en-US" dirty="0"/>
-              <a:t>If asked: The stronger age loss and the stronger depth loss were not separately controlled: both children arms used the same age and height weights, and the depth runs at five and twenty times have no control at the same weight. The experiments also have a safety limit: PVE at most 71.5 millimetres and recall at least 89.2 percent. The neck run just missed it, with 71.8 millimetres and 89.0 percent, but all five control runs miss it too, mostly because of the restart cost; its PVE is even 4.5 millimetres better than its own control, which is also inside the noise. Its neck bones stayed at 62.5 degrees. For the fingers, the rest-pose floor is 15.2 degrees in this evaluation and 15.1 on slide 8; the difference is only which people are matched. Restarting the fine-tune alone costs about 2.4 millimetres. A 2-epoch pilot trains in about 12 minutes, a 10-epoch run in about one hour.</a:t>
+              <a:t>If asked: The stronger age loss and the stronger depth loss were not separately controlled: both children arms used the same age and height weights, and the depth runs at five and twenty times have no control at the same weight. Depth PVE: 74.8 for the 10-epoch run with the stronger loss, 72.2 for the 10-epoch control, 70.5 for v5. Two identical runs differed by 7.6 millimetres PVE and 1.9 degrees of head error. The slope part of the depth rule only asks for any move toward 1 with a smaller intercept: it passed for the three stronger-loss runs and even for the 2-epoch control, and failed with the switch alone. All runs used the same 100-image holdout and manifest, with helper bones masked. The neck experiment has the same safety limit, PVE at most 71.5 millimetres and recall at least 89.2 percent. The neck run just missed it, with 71.8 millimetres and 89.0 percent, but all five control runs miss it too, mostly because of the restart cost; its PVE is even 4.5 millimetres better than its own control, which is also inside the noise. Its neck bones stayed at 62.5 degrees. For the fingers, the rest-pose floor is 15.2 degrees in this evaluation and 15.1 on slide 8; the difference is only which people are matched. Restarting the fine-tune alone costs about 2.4 millimetres. A 2-epoch pilot trains in about 12 minutes, a 10-epoch run in about one hour.</a:t>
             </a:r>
           </a:p>
         </p:txBody>
@@ -1108,7 +1108,7 @@
           <a:p>
             <a:r>
               <a:rPr lang="en-US" dirty="0"/>
-              <a:t>Seven things are still open. First, the neck: found on slide 7, not fixed. Next is exp6: turn the flipped bones back with a fixed correction at the network output, with no training. Second, the depth slope is stuck at 0.3 to 0.4, and I do not know why. I will measure the training depths properly. Third, the cost of the fix: PVE paired on the same people, and recall for people whose head is visible. Fourth, pilot noise: fix the seed or repeat the key run. Fifth, people very close to the camera: both models miss them; likely detection, not yet counted. Sixth, children and fingers: next is a 10-epoch balanced-sampler run, and larger hand crops for the fingers. If those show nothing, both go into the thesis as limitations. Seventh, the 3DPW labels from slide 6. The rebuild of the missing labels is running now. Then I fix the gender and use one shared frame grid; that needs a new fit of all 87 tasks. I propose to test the depth fix on 3DPW or fine-tune on it only after that; my question on the next slide is about this.</a:t>
+              <a:t>Seven things are still open. First, the bone flips. The neck fix passes in one run; I still have to check renders, real photos and a longer run. v10's left arm has the same kind of flip, but a bone further down the arm undoes it, so it needs a two-sided correction, not built yet. Second, the depth slope is stuck at 0.3 to 0.4, cause unknown. Third, the cost of the depth fix, paired on the same people. Fourth, pilot noise: fix the seed or repeat key runs. Fifth, people very close to the camera. Sixth, children and fingers: a longer sampler run, and a look at the hands with the bone fix. Seventh, 3DPW: the rebuild gave the same counts, so the images are likely missing; I will check, re-extract and rebuild. Then gender, frame grid and a re-fit of all 87 tasks, before any 3DPW test.</a:t>
             </a:r>
           </a:p>
           <a:p>
@@ -1117,7 +1117,7 @@
           <a:p>
             <a:r>
               <a:rPr lang="en-US" dirty="0"/>
-              <a:t>If asked: Neck: if the neck skin gets its thickness back with the correction, I will render it to check that the thin neck is what we saw in the overlays. Depth: the training depths so far come from small samples, batch means of about 2.5 to 3.2 metres. I will also measure the fix run's slope on training images; for v5 it was just as low there. Cost: I will report the root error next to PVE in the thesis. Testing the fix on 3DPW waits for item seven. The twenty-times 10-epoch run has no result yet. Close people: both models miss them in 4 of the 12 rendered images. Children and fingers: one 2-epoch test is not enough to close them. 3DPW labels: the missing labels need no new fit: the fits exist, so the label builder is running again now, into a new folder. If the rebuild still gives fewer labels, the 3DPW images for those sequences may be missing on disk; the check did not test that. Gender and the frame grid are different: set men to 0 and, by Anny's convention, women to 1; the refit confirmed it only for men. And pick both people's frames on one shared grid. Both happen inside the fit, so all 87 conversion tasks must be fitted again, into a new folder, because the task script skips every person that already has a file; otherwise old and new fits would mix without a warning. That is an 87-task array job: about 40 GPU hours by the task script's own estimate of 6 seconds per frame, so 5 to 6 hours with 8 GPUs at once; not measured. Then rebuild the labels and run the check again.</a:t>
+              <a:t>If asked: Neck: the fine-tuned checkpoint carries the fix in its saved settings, so the demo applies it on load; I copy it next to the other demo models and add it to the demo comparison script. The 12 side-by-side panels on the holdout are written; I have not looked at them. v10: correcting three of its flipped hand bones passed without training; two more finger bones, seen on training images, are not corrected yet; shoulder01.L at 166 degrees and upperarm02.L at 180 stay flipped, because one constant per bone would break the chain that compensates them. Depth: the training depths so far come from small samples, batch means of about 2.5 to 3.2 metres. I will also measure the fix run's slope on training images; for v5 it was just as low there. Cost: I will report the root error next to PVE in the thesis. Testing the depth fix on 3DPW waits for item seven. The twenty-times 10-epoch run has no result yet. Close people: both models miss them in 4 of the 12 rendered images. Children and fingers: one 2-epoch test is not enough to close them. 3DPW labels: the rebuild, into a new folder, gave the same counts, so my old guess that the builder ran before the fits finished is wrong. The builder skips every frame without an image file. The check is one file count per image folder of the eight affected sequences; if they are empty or short, I unzip the 3DPW images again and rebuild. Gender and the frame grid are different: set men to 0 and, by Anny's convention, women to 1; the refit confirmed it only for men. And pick both people's frames on one shared grid. Both happen inside the fit, so all 87 conversion tasks must be fitted again, into a new folder, because the task script skips every person that already has a file; otherwise old and new fits would mix without a warning. That is an 87-task array job: about 40 GPU hours by the task script's own estimate of 6 seconds per frame, so 5 to 6 hours with 8 GPUs at once; not measured. Then rebuild the labels and run the check again.</a:t>
             </a:r>
           </a:p>
         </p:txBody>
@@ -1204,7 +1204,7 @@
           <a:p>
             <a:r>
               <a:rPr lang="en-US" dirty="0"/>
-              <a:t>What I claim, measured. First, the failures are not rig or decoding problems. Second, a training-target bug puts people too far away in v5, v9 and v10; the fix draws bodies much closer to their true size. Third, in all eight v5-line checkpoints I traced, neck02 and the head bone sit half a turn off, and the neck skin is about half as thick. Fourth, the 3DPW labels: joints and surface pass the check, but gender is reversed, which a refit confirms for men, one actor is missing in 407 of 960 two-person images, and some labels are missing. What I do not claim: a neck fix, better fingers or children, correct depth for both near and far people, a fix without cost, and head turn, age or limb lengths in the 3DPW labels. My question: should I fine-tune v9 now, with the fixed targets and the depth loss five times stronger? Or first fix the 3DPW labels, re-fit, then fine-tune? I propose the second, as on slide 15, but I want your view.</a:t>
+              <a:t>What I claim, measured. The failures are not rig or decoding problems. A training-target bug puts people too far away in v5, v9 and v10; the fix draws bodies much closer to their true size. In the v5 line, neck02 and the head bone sit half a turn off. One pilot run with a fixed correction and a short fine-tune restores the neck thickness and passes the fine-tune checks. Two flipped hand bones were about half the finger error. The 3DPW labels pass on joints and surface, but have three defects. What I do not claim: that the neck fix is proven, since it is one run without a fixed seed; better children; correct depth for near and far people; a depth fix without cost. My question: fine-tune v9 now, or first fix the 3DPW labels and re-fit? I propose the second, as on slide 15, but want your view.</a:t>
             </a:r>
           </a:p>
           <a:p>
@@ -1213,7 +1213,55 @@
           <a:p>
             <a:r>
               <a:rPr lang="en-US" dirty="0"/>
-              <a:t>If asked: The depth fix does not separate near and far people well, and it likely has a cost: every fix run is worse than its control, by 2.6 to 4.9 millimetres PVE and 1.6 to 2.4 recall points. The PVE gaps are inside pilot noise, the recall drops are at the edge of what one pilot can detect, and the five runs share two controls, but all point the same way. In v5 the depth bug affects all 222 holdout people. The neck: the two half-turned bones cancel, so the head points the right way. A 2-epoch fine-tune did not undo it. Its origin is not known; the singular start value of the rotation output would start a bone turned about its sideways axis, a tilt like the one in v5's left index base, not the twist in neck02 and the head. The missing 3DPW labels: 6 train sequences, part of a seventh, and one validation sequence; the rebuild is running. For the women, the gender refit is mixed. In the 3DPW labels the head, neck02 and neck03 stay at rest; only neck01 turns. Overall the labels keep about half the head turn, 9.5 against 20 degrees. Train and validation keep most of it; the loss is in the test split, and I do not know why yet. Age is fixed, and the limb-length ratios are not explained yet. The fine-tune is about one hour of training. From v5 I expect a drawn size of about 0.84 and a root error of about half a metre; on v5 that run cost 2.6 millimetres PVE and 1.6 recall points against its control. Five, not twenty, because the twenty-times 10-epoch run has no result yet. v9 is best on our 3DPW-Anny labels, but those labels have the gender and two-person defects, so that score is not a clean measure. The other option: men to 0, women to 1 by Anny's convention, one shared frame grid, re-fit all 87 conversion tasks into a new folder, rebuild the labels, then fine-tune. Rebuilding the labels alone is not enough, because the gender and the frame choice are fixed inside the fit; the re-fit is an 87-task array job, about 40 GPU hours by the script's own estimate. I prefer the re-fit first: 3DPW is 30 percent of each batch, so a fine-tune before it would keep learning the wrong body for the men. A v9 fine-tune keeps the neck flip; v10 has no neck flip, but the same kind of flip in the left shoulder and upper arm, which is most of why its shoulders and arms are worse. Either fine-tune should also mask the 3DPW finger labels, which are set to the rest pose, with mask_3dpw_hands. The ViT-S students use the same training code and are probably affected too; not measured. On the AnnyOne holdout v9 is not the best: 77.0 against 70.5.</a:t>
+              <a:t>If asked:</a:t>
+            </a:r>
+          </a:p>
+          <a:p>
+            <a:r>
+              <a:rPr lang="en-US" dirty="0"/>
+              <a:t>- Depth fix: it does not separate near and far people well, and it likely has a cost: every fix run is worse than its control, by 2.6 to 4.9 millimetres PVE and 1.6 to 2.4 recall points. The PVE gaps are inside pilot noise, the recall drops are at the edge of what one pilot can detect, and the five runs share two controls, but all point the same way. In v5 the depth bug affects all 222 holdout people. The ViT-S students use the same training code and are probably affected too; not measured.</a:t>
+            </a:r>
+          </a:p>
+          <a:p>
+            <a:r>
+              <a:rPr lang="en-US" dirty="0"/>
+              <a:t>- Neck: the two half-turned bones cancel, so the head points the right way. A 2-epoch geodesic loss did not undo it. The fixed correction with a 2-epoch fine-tune did, in one run: neck02 4.7 degrees, thickness 1.00, head direction 14.4 against 13.8 for its control and 12.0 before. One run without a seed is not proof, and I have not looked at the renders or real photos yet. The origin of the flip is not known; the singular start value of the rotation output would start a bone turned about its sideways axis, a tilt like the one in v5's left index base, not the twist in neck02 and the head.</a:t>
+            </a:r>
+          </a:p>
+          <a:p>
+            <a:r>
+              <a:rPr lang="en-US" dirty="0"/>
+              <a:t>- Fingers: two flipped hand bones were about half the finger number, 17.3 to 8.3 degrees; I have not looked at the hands, so I do not claim better-looking fingers.</a:t>
+            </a:r>
+          </a:p>
+          <a:p>
+            <a:r>
+              <a:rPr lang="en-US" dirty="0"/>
+              <a:t>- 3DPW labels: 6 train sequences, part of a seventh, and one validation sequence have no labels; a rebuild gave the same counts, so their image files are likely missing on the cluster; the check is still to do. For the women, the gender refit is mixed. In the 3DPW labels the head, neck02 and neck03 stay at rest; only neck01 turns. Overall the labels keep about half the head turn, 9.5 against 20 degrees. Train and validation keep most of it; the loss is in the test split, and I do not know why yet. Age is fixed, and the limb-length ratios are not explained yet.</a:t>
+            </a:r>
+          </a:p>
+          <a:p>
+            <a:r>
+              <a:rPr lang="en-US" dirty="0"/>
+              <a:t>- Option 1, v9 now: the fine-tune is about 1 to 2 hours of training; that is not measured with 3DPW batches, and the v9 script expects 8 to 10 minutes per epoch. From v5 I expect a drawn size of about 0.84 and a root error of about half a metre; on v5 that run cost 2.6 millimetres PVE and 1.6 recall points against its control. Five, not twenty, because the twenty-times 10-epoch run has no result yet. v9 is best on our 3DPW-Anny labels, but those labels have the gender and two-person defects, so that score is not a clean measure. On the AnnyOne holdout v9 is not the best: 75.0 at epoch 62, the planned start, and 77.0 at epoch 149, against 70.5.</a:t>
+            </a:r>
+          </a:p>
+          <a:p>
+            <a:r>
+              <a:rPr lang="en-US" dirty="0"/>
+              <a:t>- Option 2, labels first: men to 0, women to 1 by Anny's convention, one shared frame grid, re-fit all 87 conversion tasks into a new folder, rebuild the labels, then fine-tune. Rebuilding the labels alone is not enough, because the gender and the frame choice are fixed inside the fit; the re-fit is an 87-task array job, about 40 GPU hours by the script's own estimate. I prefer the re-fit first: 3DPW is 30 percent of each batch, so a fine-tune before it would keep learning the wrong body for the men.</a:t>
+            </a:r>
+          </a:p>
+          <a:p>
+            <a:r>
+              <a:rPr lang="en-US" dirty="0"/>
+              <a:t>- Bone flips in v9 and v10: a v9 fine-tune keeps the neck flip unless it carries the bone fix, estimated on v9 first; the v5 constants belong to v5. The flip was measured on v9 epoch 149; epoch 62, the planned start, was never measured per bone, so there it is likely, not shown. v10 has no neck flip, but the same kind of flip in the left shoulder and upper arm, which is likely most of why its shoulders and arms are worse; not shown.</a:t>
+            </a:r>
+          </a:p>
+          <a:p>
+            <a:r>
+              <a:rPr lang="en-US" dirty="0"/>
+              <a:t>- Both options: either fine-tune should also mask the 3DPW finger labels, which are set to the rest pose, with mask_3dpw_hands.</a:t>
             </a:r>
           </a:p>
         </p:txBody>
@@ -1387,7 +1435,7 @@
           <a:p>
             <a:r>
               <a:rPr lang="en-US" dirty="0"/>
-              <a:t>These are the three failures we discussed last time. Until this week they were explained by guesses: a rig problem, too few pixels on the hands, or a shape head that does not learn age. None of these guesses had been tested on its own. That is what I did first. The last line on each card is what this week showed; the details follow. For the neck, I found that two bones in the v5 models, neck02 and the head bone, are turned half a turn, and the neck skin comes out about half as thick; I have not yet rendered it to check that this is the look we saw.</a:t>
+              <a:t>These are the three failures we discussed last time. Until this week they were explained by guesses: a rig problem, too few pixels on the hands, or a shape head that does not learn age. None of these guesses had been tested on its own. That is what I did first. The last line on each card is what this week showed; the details follow. For the neck, two bones in the v5 models, neck02 and the head bone, are turned half a turn, and the neck skin comes out about half as thick. A first fix, in one run, restores it; I have not yet looked at the renders. For the fingers, about half of the error came from two flipped hand bones.</a:t>
             </a:r>
           </a:p>
         </p:txBody>
@@ -1735,7 +1783,7 @@
           <a:p>
             <a:r>
               <a:rPr lang="en-US" dirty="0"/>
-              <a:t>Until now, the finished labels had not been checked end to end against the original 3DPW data. A cluster check has now done that. Joints, surface and 2D pass the check. Body joints are 18.7 millimetres off at the median. That is below about 26 millimetres, the value the check cites for 3DPW's own joints. The surface is about 19 millimetres off. That is the distance to the nearest point, so the true error can be larger. In 2D the labels are only 1 pixel worse than raw 3DPW. Left and right were correct in every checked person. But the labels have three defects. First, gender is reversed. I refitted 73 male samples with the other gender, and the joint error dropped for 72 of them. For the 31 female samples the result is mixed. Second, in 407 of 960 two-person images one person has no label, because that person was not fitted on that frame. Third, labels are missing for 6 train sequences, part of a seventh, and one validation sequence. The fits exist, so the rebuild is running now. On the right: by design, the head does not turn on its own. The overall FAIL comes only from the limb lengths, and they fail only in the test split; I do not know the cause yet. A few hip outliers give a warning overall, and a FAIL in the train split alone.</a:t>
+              <a:t>The finished labels had never been checked end to end against 3DPW. A cluster check has now done that. Joints, surface and 2D pass. Body joints are 18.7 millimetres off at the median, below the about 26 millimetres cited for 3DPW's own joints. The surface is about 19 millimetres off; that is a nearest-point distance, so a lower bound. But the labels have three defects. First, gender is reversed: with the other gender, the joint error dropped for 72 of 73 male samples. Second, in 407 of 960 two-person images one person has no label, because that person was not fitted on that frame. Third, labels are missing for 6 train sequences, part of a seventh, and one validation sequence. The fits exist, but a rebuild gave the same counts. So the image files of those sequences are likely missing on the cluster; I have not checked that yet.</a:t>
             </a:r>
           </a:p>
           <a:p>
@@ -1744,7 +1792,49 @@
           <a:p>
             <a:r>
               <a:rPr lang="en-US" dirty="0"/>
-              <a:t>If asked: The surface test cannot see a wrong gender; that is why there is a separate refit test. In the script's own synthetic test, a label fitted with the wrong gender still stayed at 7 to 10 millimetres from the surface. Anny's male end is 0: at gender 0 the rest body is 1.753 metres tall, at 1 it is 1.632 metres. In the checked images, 1,801 people are labelled male and 734 female; these count people in images, not different persons. All men have the label 1.000, all women 0.000. The refit used 2 people per sequence, 104 samples, so 73 and 31 are samples, not different persons. For the men, the refit with flipped gender lowered the median joint error from 19.2 to 15.3 millimetres, and the surface got closer for 68 of 73. For the women, the flip made the joints worse for most of them, 13.7 to 16.3 millimetres, but the surface closer for 27 of 31. Label images: train 4,451 of 6,437 expected, validation 2,458 of 2,777. If the rebuild still gives fewer labels, the 3DPW images for those sequences may be missing on disk; the check did not test that. All 162 frames of outdoors_crosscountry_00 are dropped by the visibility filter, under 30 percent visible; the fits are fine, and I have not yet checked why the whole sequence counts as not visible. The 18.7 millimetres are measured at the points the fit aims at. The bare bone heads that train.py uses are 32.5 millimetres off, mostly a fixed torso rig gap, not a fit error. The train split alone: body joints 20.2 millimetres, just over the 20 millimetre line, so WARN; and 5.2 percent of people with a joint over 100 millimetres, so FAIL. Limb ratios: forearm 0.879 and thigh 1.119 overall. Train passes, with 0.965 and 1.035; only test fails. All checked test people are men labelled 1, so a link to the gender defect is possible, but not shown. Head turn: train and validation keep most of it, 18.5 against 21.2 degrees and 19.1 against 19.3; the loss is mainly in test, 6.3 against 20.0. The script marks the 26 millimetres for 3DPW as likely, from von Marcard et al., 2018; I have not checked the paper.</a:t>
+              <a:t>If asked:</a:t>
+            </a:r>
+          </a:p>
+          <a:p>
+            <a:r>
+              <a:rPr lang="en-US" dirty="0"/>
+              <a:t>- Right column: by design, the head does not turn on its own. The overall FAIL comes only from the limb lengths, and they fail only in the test split; I do not know the cause yet. A few hip outliers give a warning overall, and a FAIL in the train split alone.</a:t>
+            </a:r>
+          </a:p>
+          <a:p>
+            <a:r>
+              <a:rPr lang="en-US" dirty="0"/>
+              <a:t>- Gender: for the 31 female samples the gender result is mixed. The surface test cannot see a wrong gender; that is why there is a separate refit test. In the script's own synthetic test, a label fitted with the wrong gender still stayed at 7 to 10 millimetres from the surface. Anny's male end is 0: at gender 0 the rest body is 1.753 metres tall, at 1 it is 1.632 metres. In the checked images, 1,801 people are labelled male and 734 female; these count people in images, not different persons. All men have the label 1.000, all women 0.000. The refit used 2 people per sequence, 104 samples, so 73 and 31 are samples, not different persons. For the men, the refit with flipped gender lowered the median joint error from 19.2 to 15.3 millimetres, and the surface got closer for 68 of 73. For the women, the flip made the joints worse for most of them, 13.7 to 16.3 millimetres, but the surface closer for 27 of 31.</a:t>
+            </a:r>
+          </a:p>
+          <a:p>
+            <a:r>
+              <a:rPr lang="en-US" dirty="0"/>
+              <a:t>- Missing labels: train has 4,451 of 6,437 expected label images, validation 2,458 of 2,777. The rebuild, job 3579266, gave the same image counts: train 4,451 (5,183 people), validation 2,458, test 9,722, 16,631 label files in total; the same six train sequences and basketball_01 at zero, captureSelfies_00 at 319. The label builder skips every frame whose image file is missing, without a warning. So the likely cause is an incomplete unzip of the 3DPW images on the cluster; counting the files in each of those image folders will show it. My earlier guess, that the builder ran before the fits finished, was wrong. All 162 frames of outdoors_crosscountry_00 are dropped by the visibility filter, under 30 percent visible; the fits are fine, and I have not yet checked why the whole sequence counts as not visible.</a:t>
+            </a:r>
+          </a:p>
+          <a:p>
+            <a:r>
+              <a:rPr lang="en-US" dirty="0"/>
+              <a:t>- Joints: the 18.7 millimetres are measured at the points the fit aims at. The bare bone heads that train.py uses are 32.5 millimetres off, mostly a fixed torso rig gap, not a fit error. The train split alone: body joints 20.2 millimetres, just over the 20 millimetre line, so WARN; and 5.2 percent of people with a joint over 100 millimetres, so FAIL. The script marks the 26 millimetres for 3DPW as likely, from von Marcard et al., 2018; I have not checked the paper.</a:t>
+            </a:r>
+          </a:p>
+          <a:p>
+            <a:r>
+              <a:rPr lang="en-US" dirty="0"/>
+              <a:t>- 2D and left/right: in 2D the labels are only 1 pixel worse than raw 3DPW, and left and right were correct in every checked person.</a:t>
+            </a:r>
+          </a:p>
+          <a:p>
+            <a:r>
+              <a:rPr lang="en-US" dirty="0"/>
+              <a:t>- Limb lengths: the ratios are forearm 0.879 and thigh 1.119 overall. Train passes, with 0.965 and 1.035; only test fails. All checked test people are men labelled 1, so a link to the gender defect is possible, but not shown.</a:t>
+            </a:r>
+          </a:p>
+          <a:p>
+            <a:r>
+              <a:rPr lang="en-US" dirty="0"/>
+              <a:t>- Head turn: train and validation keep most of it, 18.5 against 21.2 degrees and 19.1 against 19.3; the loss is mainly in test, 6.3 against 20.0.</a:t>
             </a:r>
           </a:p>
         </p:txBody>
@@ -1831,7 +1921,16 @@
           <a:p>
             <a:r>
               <a:rPr lang="en-US" dirty="0"/>
-              <a:t>In all eight v5-line checkpoints I traced, two bones are wrong by about half a turn: neck02 by 176 degrees and the head by 178, in every holdout person. The other neck bones and the jaw are fine. It is there from the first training stage, frozen_bb_v2, and nothing later changed it. The two half-turns cancel: the whole head still points the right way, within 12 to 15 degrees, so the head direction and the body PVE never showed it; only the per-bone angles did, last week's 63 and 90 degrees. But the neck skin comes out less than half as thick as the truth. v10 has no neck flip, but the same kind of flip in its left shoulder, its left upper arm and three hand bones, one left and two right. Two epochs with a geodesic loss barely moved it, likely because both bones would have to turn back together. The flip is measured, but I have not yet rendered it to check that it is the look we saw in the overlays. Its origin is not known; the singular start value of the rotation output would start a bone turned about its sideways axis, a tilt like the one in v5's left index base, not the twist in neck02 and the head. Next: a fixed output correction, no training.</a:t>
+              <a:t>In all eight v5-line checkpoints, neck02 and the head bone are about half a turn off. The two half-turns cancel, so the head still points the right way and PVE never showed it, but the neck skin comes out half as thick. I tested a fix: one constant turn per flipped bone at the network output, estimated on 200 training images. On the holdout, the fix alone turns both bones back; neck thickness goes from 0.46 to 1.00. But head direction gets worse, 19.1 degrees, likely because the head's offset differs per person. After a two-epoch fine-tune, it passes the fine-tune checks, each within a tolerance of its control; head direction is 14.4, still worse than 12.0 before. One run, no fixed seed: I claim no PVE gain, only no sign of a PVE cost, 68.8 against 76.9 for the control. I have not yet looked at the renders.</a:t>
+            </a:r>
+          </a:p>
+          <a:p>
+            <a:endParaRPr lang="en-US" dirty="0"/>
+          </a:p>
+          <a:p>
+            <a:r>
+              <a:rPr lang="en-US" dirty="0"/>
+              <a:t>If asked: After the fine-tune, neck02 is 4.7 degrees and the thickness 1.00. The flip is there from the first training stage, frozen_bb_v2, and in v3, v4, v5, v9 and every pilot checked. A two-epoch geodesic loss barely moved it, 175.6 to 175.0 degrees. Its origin is not known: the singular start value of the rotation output would start a bone with a tilt, like v5's left index base, not this twist. v10 has no neck flip. The constants are 178.8 degrees for neck02 and 179.2 for the head. Before the test, the script's guard predicted the head-direction rise, 8.4 to 17.9 degrees on the training sample: a compensated chain, since the head's offset differs per person and one constant cannot undo it. Without training, the head-and-neck surface error also rose, 52.3 to 63.1 millimetres; after the fine-tune it is 51.8. The fine-tune checks, against the control: corrected bones under 15 degrees, thickness at least 0.9, PVE at most 8 millimetres higher, recall at most 2 points lower, head direction at most 3 degrees worse. Recall passed by only 0.3 points, 89.4 against a limit of 89.1. Against the control: PVE 68.8 against 76.9, PA-PVE 50.9 against 55.2, recall 89.4 against 91.1, head direction 14.4 against 13.8. Against v5 before: PVE 68.8 against 70.5, PA-PVE 50.9 against 53.3, recall 89.4 against 90.2. Identical configs differ by up to 7.6 millimetres PVE, so none of these PVE differences is certain. Last week's group errors, 63 degrees for the neck and 90 for the head, are now 5.9 and 6.7. The script wrote 12 side-by-side panels, without and with the correction alone; I have not looked at them yet. Next: a real-photo demo with the fine-tuned checkpoint, which carries the fix, and a longer fine-tune with the fix.</a:t>
             </a:r>
           </a:p>
         </p:txBody>
@@ -1918,7 +2017,16 @@
           <a:p>
             <a:r>
               <a:rPr lang="en-US" dirty="0"/>
-              <a:t>With predicted fingers the error is 17.3 degrees. With the fingers simply left in the rest pose it is 15.1. So the hand prediction is worse than no prediction, which is why the demos zero the fingers and now say so. Hands are small: about two tokens at 672 pixels. I cropped around the person at test time, without retraining. Per person that magnifies the hands by 1.6 times on median, and by 2.5 times or more for a quarter of the people; 26 percent of the people are not magnified at all. The table compares median hand sizes, so it shows a slightly larger factor. The finger error does not change: 17.2 against 17.3, and from 17.7 to 17.5 for the most magnified quarter. The body error nearly doubles on these crops, because the model never saw such a camera in training. So test-time magnification does not help; a model trained on larger hands is not tested. A rebalanced loss also changed nothing: 17.5 against 17.4 for its control. That loss cut the hands' share of the rotation loss from about 70 percent, which includes the four-times hand boost, to 33 percent; without the boost the share would be 40. So it does not test giving the fingers more weight, and the earlier four-times hand boost did not help either. My best guess is supervision or model capacity, but that is not tested.</a:t>
+              <a:t>With predicted fingers the finger error is 17.3 degrees; with the fingers left at rest it is 15.1. The new result: about half of the 17.3 came from two hand bones turned half a turn, the left index base and one right finger bone. The same correction as for the neck turns them back: the error falls to 8.2 degrees with no training and 8.3 after the fine-tune. I have not yet looked at the hands in the renders. The rest-pose number still contains the index-base flip, because rest pose does not reset that bone, and I have not measured it with the fix. What I tested before did not help: magnifying the person at test time gave 17.2 against 17.3, and a rebalanced loss gave 17.5 against 17.4 for its control.</a:t>
+            </a:r>
+          </a:p>
+          <a:p>
+            <a:endParaRPr lang="en-US" dirty="0"/>
+          </a:p>
+          <a:p>
+            <a:r>
+              <a:rPr lang="en-US" dirty="0"/>
+              <a:t>If asked: The finger error is a mean over the hand bones of each person, so two bones at half a turn raise it a lot. The left index base is 180 degrees off on the holdout. The other bone, finger4-1.R, at 178.8 degrees, was seen only on the 200 training images, because the earlier holdout dump did not cover finger bones; with the fix it is 10.2 degrees on the holdout. Hands are small: about two tokens at 672 pixels. Cropping around the person at test time, without retraining, magnifies the hands by 1.6 times on median per person, and by 2.5 times or more for a quarter; 26 percent are not magnified. The table compares median hand sizes, so it shows a slightly larger factor. For the most magnified quarter the finger error went from 17.7 to 17.5. The body error nearly doubles on these crops, because the model never saw such a camera in training. The rebalanced loss cut the hands' share of the rotation loss from about 70 percent, which includes the four-times hand boost, to 33 percent; without the boost it would be 40. So it does not test giving the fingers more weight; more weight and training on larger hand crops are untested. v10 has at least five flipped hand bones. Correcting three of them, with no training, took its finger error from 32.0 to 17.8 degrees and PVE from 74.1 to 69.9 millimetres; PA-PVE went from 55.6 to 51.1, while head direction and recall did not change. Two more, finger2-1.L and finger5-2.L, seen on training images, are not corrected yet; they may be part of why v10's fingers are still at 17.8, but that is a guess. The demos zero the fingers, but rest pose does not reset the hand bases, so the bent index base is likely visible there.</a:t>
             </a:r>
           </a:p>
         </p:txBody>
@@ -2269,7 +2377,7 @@
         <p:spPr>
           <a:xfrm>
             <a:off x="548640" y="1143000"/>
-            <a:ext cx="8046720" cy="2011680"/>
+            <a:ext cx="8046720" cy="2148840"/>
           </a:xfrm>
           <a:prstGeom prst="rect">
             <a:avLst/>
@@ -2876,7 +2984,21 @@
                   <a:schemeClr val="bg1"/>
                 </a:solidFill>
               </a:rPr>
-              <a:t>Multi-HMR with Anny: what this week found</a:t>
+              <a:t>Multi-HMR with Anny:</a:t>
+            </a:r>
+            <a:endParaRPr lang="en-US" sz="4000" dirty="0"/>
+          </a:p>
+          <a:p>
+            <a:pPr algn="l" indent="0" marL="0">
+              <a:buNone/>
+            </a:pPr>
+            <a:r>
+              <a:rPr lang="en-US" sz="4000" b="1" dirty="0">
+                <a:solidFill>
+                  <a:schemeClr val="bg1"/>
+                </a:solidFill>
+              </a:rPr>
+              <a:t>what this week found</a:t>
             </a:r>
             <a:endParaRPr lang="en-US" sz="4000" dirty="0"/>
           </a:p>
@@ -2942,7 +3064,7 @@
                   <a:schemeClr val="bg2"/>
                 </a:solidFill>
               </a:rPr>
-              <a:t>Neck: two bones turned half a turn, found, not yet fixed.</a:t>
+              <a:t>Neck: two bones turned half a turn; a pilot fix passes (one run).</a:t>
             </a:r>
             <a:endParaRPr lang="en-US" sz="1800" dirty="0"/>
           </a:p>
@@ -2956,18 +3078,21 @@
                   <a:schemeClr val="bg2"/>
                 </a:solidFill>
               </a:rPr>
-              <a:t>Fingers and children: measured, still open.</a:t>
+              <a:t>Fingers: half the error was two flipped bones. Children: open.</a:t>
             </a:r>
             <a:endParaRPr lang="en-US" sz="1800" dirty="0"/>
           </a:p>
           <a:p>
             <a:pPr algn="l" indent="0" marL="0">
+              <a:spcBef>
+                <a:spcPts val="1400"/>
+              </a:spcBef>
               <a:buNone/>
             </a:pPr>
             <a:r>
-              <a:rPr lang="en-US" sz="1800" dirty="0">
-                <a:solidFill>
-                  <a:schemeClr val="bg2"/>
+              <a:rPr lang="en-US" sz="1400" dirty="0">
+                <a:solidFill>
+                  <a:srgbClr val="9AA5B4"/>
                 </a:solidFill>
               </a:rPr>
               <a:t>Saad Najib, supervisor update, 16 October 2026</a:t>
@@ -9306,7 +9431,7 @@
                             <a:srgbClr val="1B2233"/>
                           </a:solidFill>
                         </a:rPr>
-                        <a:t>depth slope toward 1, PVE stays near v5 (70.5 mm)</a:t>
+                        <a:t>depth slope toward 1; PVE ≤ 71.5 mm, recall ≥ 89.2%</a:t>
                       </a:r>
                       <a:endParaRPr lang="en-US" sz="1100" dirty="0"/>
                     </a:p>
@@ -9367,7 +9492,7 @@
                             <a:srgbClr val="1B2233"/>
                           </a:solidFill>
                         </a:rPr>
-                        <a:t>Rule not met: slope 0.30 (switch alone) / 0.38 (×5), not near 1; PVE 74.8 mm (control 72.2, v5 70.5). Outside the rule, clearly better: root error 1.21 → 0.54 m, drawn size 0.63 → 0.84</a:t>
+                        <a:t>Rule not met: PVE and recall miss in every run, controls too (×5, 10 epochs: 74.8 mm, 87.8%); slope 0.30–0.44, far from 1. Outside the rule, clearly better: root error 1.21 → 0.54 m, size 0.63 → 0.84</a:t>
                       </a:r>
                       <a:endParaRPr lang="en-US" sz="1100" dirty="0"/>
                     </a:p>
@@ -11107,7 +11232,7 @@
                   <a:schemeClr val="tx1"/>
                 </a:solidFill>
               </a:rPr>
-              <a:t>Neck: two half-turned bones</a:t>
+              <a:t>Bone flips: confirm the pilot fix</a:t>
             </a:r>
             <a:endParaRPr lang="en-US" sz="1500" dirty="0"/>
           </a:p>
@@ -11143,7 +11268,7 @@
                   <a:schemeClr val="tx2"/>
                 </a:solidFill>
               </a:rPr>
-              <a:t>Found (slide 7), not fixed. Next, exp6: a fixed output correction for the flipped bones, no training.</a:t>
+              <a:t>Neck (slide 7): renders, real photos, a longer run. v10's left arm: two-sided fix, not built yet.</a:t>
             </a:r>
             <a:endParaRPr lang="en-US" sz="1200" dirty="0"/>
           </a:p>
@@ -11808,7 +11933,7 @@
                   <a:schemeClr val="tx2"/>
                 </a:solidFill>
               </a:rPr>
-              <a:t>Next: 10-epoch balanced-sampler run; larger hand crops for fingers. If no effect: thesis limitations.</a:t>
+              <a:t>10-epoch sampler run; check the hands with the bone fix, then larger hand crops. Else: limitations.</a:t>
             </a:r>
             <a:endParaRPr lang="en-US" sz="1200" dirty="0"/>
           </a:p>
@@ -11920,7 +12045,7 @@
         <p:spPr>
           <a:xfrm>
             <a:off x="1097280" y="4215384"/>
-            <a:ext cx="7589520" cy="548640"/>
+            <a:ext cx="7589520" cy="502920"/>
           </a:xfrm>
           <a:prstGeom prst="rect">
             <a:avLst/>
@@ -11941,7 +12066,7 @@
                   <a:schemeClr val="tx2"/>
                 </a:solidFill>
               </a:rPr>
-              <a:t>Running now: rebuild of the missing labels. Then fix gender (m → 0; f → 1 by Anny's convention), use one shared frame grid, re-fit all 87 tasks, rebuild, re-check. Proposed: only then test the depth fix on 3DPW or fine-tune on it.</a:t>
+              <a:t>Rebuild gave the same counts; the image files are likely missing (check pending): re-extract, rebuild. Then gender (m → 0, f → 1), one shared frame grid, re-fit all 87 tasks, rebuild, re-check. Proposed: only then use 3DPW.</a:t>
             </a:r>
             <a:endParaRPr lang="en-US" sz="1200" dirty="0"/>
           </a:p>
@@ -12066,7 +12191,7 @@
         <p:spPr>
           <a:xfrm>
             <a:off x="548640" y="1143000"/>
-            <a:ext cx="8046720" cy="2011680"/>
+            <a:ext cx="8046720" cy="2148840"/>
           </a:xfrm>
           <a:prstGeom prst="rect">
             <a:avLst/>
@@ -12095,7 +12220,7 @@
                   <a:schemeClr val="bg2"/>
                 </a:solidFill>
               </a:rPr>
-              <a:t>the failures are not rig or decoding problems. A training-target bug puts people too far away in v5, v9 and v10 (v5: all 222 holdout people); the fix draws bodies closer to their true size. In all 8 v5-line checkpoints traced, neck02 and the head bone sit half a turn off and cancel; the neck skin is half as thick (0.46). 3DPW labels: joints (18.7 mm) and nearest-point surface pass; gender reversed (refit confirms for men), one actor missing in 407 of 960 two-person images (slide 6).</a:t>
+              <a:t>the failures are not rig or decoding problems. A training-target bug puts people too far away in v5, v9 and v10; the fix draws bodies closer to their true size. In all 8 v5-line checkpoints, neck02 and the head bone sit half a turn off; in one pilot run, a fixed correction plus a 2-epoch fine-tune restores the neck and passes the fine-tune checks. Two flipped hand bones were half the finger error. 3DPW labels: joints and surface pass; three defects (slide 6).</a:t>
             </a:r>
             <a:endParaRPr lang="en-US" sz="1500" dirty="0"/>
           </a:p>
@@ -12117,7 +12242,7 @@
                   <a:schemeClr val="bg2"/>
                 </a:solidFill>
               </a:rPr>
-              <a:t>a neck fix, or a proven origin of the flip; any improvement in fingers or children; correct depths for both near and far people; a fix without cost (likely 2.6–4.9 mm PVE and 1.6–2.4 recall points worse, not yet confirmed); head turn, age or limb lengths in the 3DPW labels.</a:t>
+              <a:t>a proven neck fix (one run, no seed; head direction 14.4° vs 12.0°) or why the bones flipped; better children; correct depths for near and far people; a depth fix without cost (likely 2.6 to 4.9 mm PVE, 1.6 to 2.4 recall points); head turn, age or limb lengths in the 3DPW labels.</a:t>
             </a:r>
             <a:endParaRPr lang="en-US" sz="1500" dirty="0"/>
           </a:p>
@@ -12131,8 +12256,8 @@
         </p:nvSpPr>
         <p:spPr>
           <a:xfrm>
-            <a:off x="548640" y="3246120"/>
-            <a:ext cx="8046720" cy="1435608"/>
+            <a:off x="548640" y="3310128"/>
+            <a:ext cx="8046720" cy="1371600"/>
           </a:xfrm>
           <a:prstGeom prst="rect">
             <a:avLst/>
@@ -12156,8 +12281,8 @@
         </p:nvSpPr>
         <p:spPr>
           <a:xfrm>
-            <a:off x="548640" y="3246120"/>
-            <a:ext cx="73152" cy="1435608"/>
+            <a:off x="548640" y="3310128"/>
+            <a:ext cx="73152" cy="1371600"/>
           </a:xfrm>
           <a:prstGeom prst="rect">
             <a:avLst/>
@@ -12181,8 +12306,8 @@
         </p:nvSpPr>
         <p:spPr>
           <a:xfrm>
-            <a:off x="822960" y="3291840"/>
-            <a:ext cx="7635240" cy="1344168"/>
+            <a:off x="822960" y="3355848"/>
+            <a:ext cx="7635240" cy="1280160"/>
           </a:xfrm>
           <a:prstGeom prst="rect">
             <a:avLst/>
@@ -12201,14 +12326,14 @@
               <a:buNone/>
             </a:pPr>
             <a:r>
-              <a:rPr lang="en-US" sz="1400" b="1" dirty="0">
+              <a:rPr lang="en-US" sz="1300" b="1" dirty="0">
                 <a:solidFill>
                   <a:srgbClr val="F4C95D"/>
                 </a:solidFill>
               </a:rPr>
               <a:t>Question for you</a:t>
             </a:r>
-            <a:endParaRPr lang="en-US" sz="1400" dirty="0"/>
+            <a:endParaRPr lang="en-US" sz="1300" dirty="0"/>
           </a:p>
           <a:p>
             <a:pPr indent="0" marL="0">
@@ -12218,28 +12343,28 @@
               <a:buNone/>
             </a:pPr>
             <a:r>
-              <a:rPr lang="en-US" sz="1400" b="1" dirty="0">
+              <a:rPr lang="en-US" sz="1300" b="1" dirty="0">
                 <a:solidFill>
                   <a:srgbClr val="EEF2F7"/>
                 </a:solidFill>
               </a:rPr>
               <a:t>Fine-tune v9 (best on our 3DPW-Anny labels, which have the gender defect: slide 6) with the fixed targets and depth ×5? Or first fix gender and frame grid, re-fit all 3DPW tasks, then fine-tune?</a:t>
             </a:r>
-            <a:endParaRPr lang="en-US" sz="1400" dirty="0"/>
+            <a:endParaRPr lang="en-US" sz="1300" dirty="0"/>
           </a:p>
           <a:p>
             <a:pPr indent="0" marL="0">
               <a:buNone/>
             </a:pPr>
             <a:r>
-              <a:rPr lang="en-US" sz="1400" dirty="0">
+              <a:rPr lang="en-US" sz="1300" dirty="0">
                 <a:solidFill>
                   <a:srgbClr val="EEF2F7"/>
                 </a:solidFill>
               </a:rPr>
-              <a:t>From v5 (×5, 10 epochs): drawn size 0.84, root error 0.54 m, at +2.6 mm PVE and −1.6 recall points vs its control. v9 keeps the neck flip; v10 has a similar flip in the left shoulder and upper arm instead.</a:t>
-            </a:r>
-            <a:endParaRPr lang="en-US" sz="1400" dirty="0"/>
+              <a:t>v9 also has the neck flip (measured at epoch 149) and needs its own bone fix; v10 has a similar left-arm flip.</a:t>
+            </a:r>
+            <a:endParaRPr lang="en-US" sz="1300" dirty="0"/>
           </a:p>
         </p:txBody>
       </p:sp>
@@ -12771,7 +12896,7 @@
                   <a:schemeClr val="tx2"/>
                 </a:solidFill>
               </a:rPr>
-              <a:t>the rig is fine. In v5, neck02 and the head bone are turned half a turn and the neck skin comes out half as thick. A render check is still to do.</a:t>
+              <a:t>the rig is fine. v5's neck02 and head bone are half a turn off; neck skin half as thick. A pilot fix restores it (one run).</a:t>
             </a:r>
             <a:endParaRPr lang="en-US" sz="1300" dirty="0"/>
           </a:p>
@@ -12913,7 +13038,7 @@
                   <a:schemeClr val="tx2"/>
                 </a:solidFill>
               </a:rPr>
-              <a:t>test-time zoom and a loss rebalance did not help.</a:t>
+              <a:t>test-time zoom and a loss rebalance did not help; half the error was two flipped bones.</a:t>
             </a:r>
             <a:endParaRPr lang="en-US" sz="1300" dirty="0"/>
           </a:p>
@@ -16741,7 +16866,7 @@
                   <a:schemeClr val="tx1"/>
                 </a:solidFill>
               </a:rPr>
-              <a:t>6 train sequences, part of captureSelfies_00, val basketball_01. The fits exist; rebuild running now.</a:t>
+              <a:t>6 train sequences, part of captureSelfies_00, val basketball_01. Rebuild: same counts; likely missing image files.</a:t>
             </a:r>
             <a:endParaRPr lang="en-US" sz="1100" dirty="0"/>
           </a:p>
@@ -17107,7 +17232,7 @@
                   <a:schemeClr val="tx1"/>
                 </a:solidFill>
               </a:rPr>
-              <a:t>Neck: two bones turned half a turn</a:t>
+              <a:t>Neck: two half-turned bones, and a pilot fix</a:t>
             </a:r>
             <a:endParaRPr lang="en-US" sz="2700" dirty="0"/>
           </a:p>
@@ -17129,18 +17254,20 @@
         </p:nvGraphicFramePr>
         <p:xfrm>
           <a:off x="457200" y="1188720"/>
-          <a:ext cx="4434840" cy="914400"/>
+          <a:ext cx="4846320" cy="914400"/>
         </p:xfrm>
         <a:graphic>
           <a:graphicData uri="http://schemas.openxmlformats.org/drawingml/2006/table">
             <a:tbl>
               <a:tblPr/>
               <a:tblGrid>
-                <a:gridCol w="1920240"/>
-                <a:gridCol w="1645920"/>
+                <a:gridCol w="1325880"/>
+                <a:gridCol w="822960"/>
+                <a:gridCol w="868680"/>
+                <a:gridCol w="960120"/>
                 <a:gridCol w="868680"/>
               </a:tblGrid>
-              <a:tr h="246888">
+              <a:tr h="384048">
                 <a:tc>
                   <a:txBody>
                     <a:bodyPr/>
@@ -17160,7 +17287,7 @@
                       <a:endParaRPr lang="en-US" sz="1100" dirty="0"/>
                     </a:p>
                   </a:txBody>
-                  <a:tcPr marL="73152" marR="73152" marT="18288" marB="18288" anchor="ctr">
+                  <a:tcPr marL="54864" marR="54864" marT="18288" marB="18288" anchor="ctr">
                     <a:lnL w="12700" cap="flat" cmpd="sng" algn="ctr">
                       <a:solidFill>
                         <a:srgbClr val="FFFFFF"/>
@@ -17216,12 +17343,12 @@
                             <a:srgbClr val="FFFFFF"/>
                           </a:solidFill>
                         </a:rPr>
-                        <a:t>v5 line, 8 checkpoints</a:t>
+                        <a:t>v5 before</a:t>
                       </a:r>
                       <a:endParaRPr lang="en-US" sz="1100" dirty="0"/>
                     </a:p>
                   </a:txBody>
-                  <a:tcPr marL="73152" marR="73152" marT="18288" marB="18288" anchor="ctr">
+                  <a:tcPr marL="54864" marR="54864" marT="18288" marB="18288" anchor="ctr">
                     <a:lnL w="12700" cap="flat" cmpd="sng" algn="ctr">
                       <a:solidFill>
                         <a:srgbClr val="FFFFFF"/>
@@ -17277,12 +17404,12 @@
                             <a:srgbClr val="FFFFFF"/>
                           </a:solidFill>
                         </a:rPr>
-                        <a:t>v10</a:t>
+                        <a:t>fix, no training</a:t>
                       </a:r>
                       <a:endParaRPr lang="en-US" sz="1100" dirty="0"/>
                     </a:p>
                   </a:txBody>
-                  <a:tcPr marL="73152" marR="73152" marT="18288" marB="18288" anchor="ctr">
+                  <a:tcPr marL="54864" marR="54864" marT="18288" marB="18288" anchor="ctr">
                     <a:lnL w="12700" cap="flat" cmpd="sng" algn="ctr">
                       <a:solidFill>
                         <a:srgbClr val="FFFFFF"/>
@@ -17321,69 +17448,6 @@
                     </a:lnB>
                     <a:solidFill>
                       <a:srgbClr val="1B2233"/>
-                    </a:solidFill>
-                  </a:tcPr>
-                </a:tc>
-              </a:tr>
-              <a:tr h="246888">
-                <a:tc>
-                  <a:txBody>
-                    <a:bodyPr/>
-                    <a:lstStyle/>
-                    <a:p>
-                      <a:pPr algn="l" indent="0" marL="0">
-                        <a:buNone/>
-                      </a:pPr>
-                      <a:r>
-                        <a:rPr lang="en-US" sz="1200" b="1" dirty="0">
-                          <a:solidFill>
-                            <a:srgbClr val="1B2233"/>
-                          </a:solidFill>
-                        </a:rPr>
-                        <a:t>neck01</a:t>
-                      </a:r>
-                      <a:endParaRPr lang="en-US" sz="1200" dirty="0"/>
-                    </a:p>
-                  </a:txBody>
-                  <a:tcPr marL="73152" marR="73152" marT="18288" marB="18288" anchor="ctr">
-                    <a:lnL w="12700" cap="flat" cmpd="sng" algn="ctr">
-                      <a:solidFill>
-                        <a:srgbClr val="FFFFFF"/>
-                      </a:solidFill>
-                      <a:prstDash val="solid"/>
-                      <a:round/>
-                      <a:headEnd type="none" w="med" len="med"/>
-                      <a:tailEnd type="none" w="med" len="med"/>
-                    </a:lnL>
-                    <a:lnR w="12700" cap="flat" cmpd="sng" algn="ctr">
-                      <a:solidFill>
-                        <a:srgbClr val="FFFFFF"/>
-                      </a:solidFill>
-                      <a:prstDash val="solid"/>
-                      <a:round/>
-                      <a:headEnd type="none" w="med" len="med"/>
-                      <a:tailEnd type="none" w="med" len="med"/>
-                    </a:lnR>
-                    <a:lnT w="12700" cap="flat" cmpd="sng" algn="ctr">
-                      <a:solidFill>
-                        <a:srgbClr val="FFFFFF"/>
-                      </a:solidFill>
-                      <a:prstDash val="solid"/>
-                      <a:round/>
-                      <a:headEnd type="none" w="med" len="med"/>
-                      <a:tailEnd type="none" w="med" len="med"/>
-                    </a:lnT>
-                    <a:lnB w="12700" cap="flat" cmpd="sng" algn="ctr">
-                      <a:solidFill>
-                        <a:srgbClr val="FFFFFF"/>
-                      </a:solidFill>
-                      <a:prstDash val="solid"/>
-                      <a:round/>
-                      <a:headEnd type="none" w="med" len="med"/>
-                      <a:tailEnd type="none" w="med" len="med"/>
-                    </a:lnB>
-                    <a:solidFill>
-                      <a:srgbClr val="FFFFFF"/>
                     </a:solidFill>
                   </a:tcPr>
                 </a:tc>
@@ -17396,17 +17460,17 @@
                         <a:buNone/>
                       </a:pPr>
                       <a:r>
-                        <a:rPr lang="en-US" sz="1200" dirty="0">
+                        <a:rPr lang="en-US" sz="1100" b="1" dirty="0">
                           <a:solidFill>
-                            <a:srgbClr val="1B2233"/>
+                            <a:srgbClr val="FFFFFF"/>
                           </a:solidFill>
                         </a:rPr>
-                        <a:t>5.3–7.3°</a:t>
+                        <a:t>fix + 2-epoch fine-tune</a:t>
                       </a:r>
-                      <a:endParaRPr lang="en-US" sz="1200" dirty="0"/>
+                      <a:endParaRPr lang="en-US" sz="1100" dirty="0"/>
                     </a:p>
                   </a:txBody>
-                  <a:tcPr marL="73152" marR="73152" marT="18288" marB="18288" anchor="ctr">
+                  <a:tcPr marL="54864" marR="54864" marT="18288" marB="18288" anchor="ctr">
                     <a:lnL w="12700" cap="flat" cmpd="sng" algn="ctr">
                       <a:solidFill>
                         <a:srgbClr val="FFFFFF"/>
@@ -17444,7 +17508,7 @@
                       <a:tailEnd type="none" w="med" len="med"/>
                     </a:lnB>
                     <a:solidFill>
-                      <a:srgbClr val="FFFFFF"/>
+                      <a:srgbClr val="0E7C86"/>
                     </a:solidFill>
                   </a:tcPr>
                 </a:tc>
@@ -17457,17 +17521,17 @@
                         <a:buNone/>
                       </a:pPr>
                       <a:r>
-                        <a:rPr lang="en-US" sz="1200" dirty="0">
+                        <a:rPr lang="en-US" sz="1100" b="1" dirty="0">
                           <a:solidFill>
-                            <a:srgbClr val="1B2233"/>
+                            <a:srgbClr val="FFFFFF"/>
                           </a:solidFill>
                         </a:rPr>
-                        <a:t>5.6°</a:t>
+                        <a:t>control (no fix)</a:t>
                       </a:r>
-                      <a:endParaRPr lang="en-US" sz="1200" dirty="0"/>
+                      <a:endParaRPr lang="en-US" sz="1100" dirty="0"/>
                     </a:p>
                   </a:txBody>
-                  <a:tcPr marL="73152" marR="73152" marT="18288" marB="18288" anchor="ctr">
+                  <a:tcPr marL="54864" marR="54864" marT="18288" marB="18288" anchor="ctr">
                     <a:lnL w="12700" cap="flat" cmpd="sng" algn="ctr">
                       <a:solidFill>
                         <a:srgbClr val="FFFFFF"/>
@@ -17505,7 +17569,7 @@
                       <a:tailEnd type="none" w="med" len="med"/>
                     </a:lnB>
                     <a:solidFill>
-                      <a:srgbClr val="FFFFFF"/>
+                      <a:srgbClr val="1B2233"/>
                     </a:solidFill>
                   </a:tcPr>
                 </a:tc>
@@ -17530,7 +17594,7 @@
                       <a:endParaRPr lang="en-US" sz="1200" dirty="0"/>
                     </a:p>
                   </a:txBody>
-                  <a:tcPr marL="73152" marR="73152" marT="18288" marB="18288" anchor="ctr">
+                  <a:tcPr marL="54864" marR="54864" marT="18288" marB="18288" anchor="ctr">
                     <a:lnL w="12700" cap="flat" cmpd="sng" algn="ctr">
                       <a:solidFill>
                         <a:srgbClr val="FFFFFF"/>
@@ -17568,7 +17632,7 @@
                       <a:tailEnd type="none" w="med" len="med"/>
                     </a:lnB>
                     <a:solidFill>
-                      <a:srgbClr val="EEF2F7"/>
+                      <a:srgbClr val="FFFFFF"/>
                     </a:solidFill>
                   </a:tcPr>
                 </a:tc>
@@ -17586,136 +17650,12 @@
                             <a:srgbClr val="C0392B"/>
                           </a:solidFill>
                         </a:rPr>
-                        <a:t>175.0–176.0°</a:t>
+                        <a:t>175.6°</a:t>
                       </a:r>
                       <a:endParaRPr lang="en-US" sz="1200" dirty="0"/>
                     </a:p>
                   </a:txBody>
-                  <a:tcPr marL="73152" marR="73152" marT="18288" marB="18288" anchor="ctr">
-                    <a:lnL w="12700" cap="flat" cmpd="sng" algn="ctr">
-                      <a:solidFill>
-                        <a:srgbClr val="FFFFFF"/>
-                      </a:solidFill>
-                      <a:prstDash val="solid"/>
-                      <a:round/>
-                      <a:headEnd type="none" w="med" len="med"/>
-                      <a:tailEnd type="none" w="med" len="med"/>
-                    </a:lnL>
-                    <a:lnR w="12700" cap="flat" cmpd="sng" algn="ctr">
-                      <a:solidFill>
-                        <a:srgbClr val="FFFFFF"/>
-                      </a:solidFill>
-                      <a:prstDash val="solid"/>
-                      <a:round/>
-                      <a:headEnd type="none" w="med" len="med"/>
-                      <a:tailEnd type="none" w="med" len="med"/>
-                    </a:lnR>
-                    <a:lnT w="12700" cap="flat" cmpd="sng" algn="ctr">
-                      <a:solidFill>
-                        <a:srgbClr val="FFFFFF"/>
-                      </a:solidFill>
-                      <a:prstDash val="solid"/>
-                      <a:round/>
-                      <a:headEnd type="none" w="med" len="med"/>
-                      <a:tailEnd type="none" w="med" len="med"/>
-                    </a:lnT>
-                    <a:lnB w="12700" cap="flat" cmpd="sng" algn="ctr">
-                      <a:solidFill>
-                        <a:srgbClr val="FFFFFF"/>
-                      </a:solidFill>
-                      <a:prstDash val="solid"/>
-                      <a:round/>
-                      <a:headEnd type="none" w="med" len="med"/>
-                      <a:tailEnd type="none" w="med" len="med"/>
-                    </a:lnB>
-                    <a:solidFill>
-                      <a:srgbClr val="EEF2F7"/>
-                    </a:solidFill>
-                  </a:tcPr>
-                </a:tc>
-                <a:tc>
-                  <a:txBody>
-                    <a:bodyPr/>
-                    <a:lstStyle/>
-                    <a:p>
-                      <a:pPr algn="ctr" indent="0" marL="0">
-                        <a:buNone/>
-                      </a:pPr>
-                      <a:r>
-                        <a:rPr lang="en-US" sz="1200" dirty="0">
-                          <a:solidFill>
-                            <a:srgbClr val="1B2233"/>
-                          </a:solidFill>
-                        </a:rPr>
-                        <a:t>3.9°</a:t>
-                      </a:r>
-                      <a:endParaRPr lang="en-US" sz="1200" dirty="0"/>
-                    </a:p>
-                  </a:txBody>
-                  <a:tcPr marL="73152" marR="73152" marT="18288" marB="18288" anchor="ctr">
-                    <a:lnL w="12700" cap="flat" cmpd="sng" algn="ctr">
-                      <a:solidFill>
-                        <a:srgbClr val="FFFFFF"/>
-                      </a:solidFill>
-                      <a:prstDash val="solid"/>
-                      <a:round/>
-                      <a:headEnd type="none" w="med" len="med"/>
-                      <a:tailEnd type="none" w="med" len="med"/>
-                    </a:lnL>
-                    <a:lnR w="12700" cap="flat" cmpd="sng" algn="ctr">
-                      <a:solidFill>
-                        <a:srgbClr val="FFFFFF"/>
-                      </a:solidFill>
-                      <a:prstDash val="solid"/>
-                      <a:round/>
-                      <a:headEnd type="none" w="med" len="med"/>
-                      <a:tailEnd type="none" w="med" len="med"/>
-                    </a:lnR>
-                    <a:lnT w="12700" cap="flat" cmpd="sng" algn="ctr">
-                      <a:solidFill>
-                        <a:srgbClr val="FFFFFF"/>
-                      </a:solidFill>
-                      <a:prstDash val="solid"/>
-                      <a:round/>
-                      <a:headEnd type="none" w="med" len="med"/>
-                      <a:tailEnd type="none" w="med" len="med"/>
-                    </a:lnT>
-                    <a:lnB w="12700" cap="flat" cmpd="sng" algn="ctr">
-                      <a:solidFill>
-                        <a:srgbClr val="FFFFFF"/>
-                      </a:solidFill>
-                      <a:prstDash val="solid"/>
-                      <a:round/>
-                      <a:headEnd type="none" w="med" len="med"/>
-                      <a:tailEnd type="none" w="med" len="med"/>
-                    </a:lnB>
-                    <a:solidFill>
-                      <a:srgbClr val="EEF2F7"/>
-                    </a:solidFill>
-                  </a:tcPr>
-                </a:tc>
-              </a:tr>
-              <a:tr h="246888">
-                <a:tc>
-                  <a:txBody>
-                    <a:bodyPr/>
-                    <a:lstStyle/>
-                    <a:p>
-                      <a:pPr algn="l" indent="0" marL="0">
-                        <a:buNone/>
-                      </a:pPr>
-                      <a:r>
-                        <a:rPr lang="en-US" sz="1200" b="1" dirty="0">
-                          <a:solidFill>
-                            <a:srgbClr val="1B2233"/>
-                          </a:solidFill>
-                        </a:rPr>
-                        <a:t>neck03</a:t>
-                      </a:r>
-                      <a:endParaRPr lang="en-US" sz="1200" dirty="0"/>
-                    </a:p>
-                  </a:txBody>
-                  <a:tcPr marL="73152" marR="73152" marT="18288" marB="18288" anchor="ctr">
+                  <a:tcPr marL="54864" marR="54864" marT="18288" marB="18288" anchor="ctr">
                     <a:lnL w="12700" cap="flat" cmpd="sng" algn="ctr">
                       <a:solidFill>
                         <a:srgbClr val="FFFFFF"/>
@@ -17771,12 +17711,12 @@
                             <a:srgbClr val="1B2233"/>
                           </a:solidFill>
                         </a:rPr>
-                        <a:t>4.9–8.0°</a:t>
+                        <a:t>4.5°</a:t>
                       </a:r>
                       <a:endParaRPr lang="en-US" sz="1200" dirty="0"/>
                     </a:p>
                   </a:txBody>
-                  <a:tcPr marL="73152" marR="73152" marT="18288" marB="18288" anchor="ctr">
+                  <a:tcPr marL="54864" marR="54864" marT="18288" marB="18288" anchor="ctr">
                     <a:lnL w="12700" cap="flat" cmpd="sng" algn="ctr">
                       <a:solidFill>
                         <a:srgbClr val="FFFFFF"/>
@@ -17832,12 +17772,73 @@
                             <a:srgbClr val="1B2233"/>
                           </a:solidFill>
                         </a:rPr>
-                        <a:t>4.3°</a:t>
+                        <a:t>4.7°</a:t>
                       </a:r>
                       <a:endParaRPr lang="en-US" sz="1200" dirty="0"/>
                     </a:p>
                   </a:txBody>
-                  <a:tcPr marL="73152" marR="73152" marT="18288" marB="18288" anchor="ctr">
+                  <a:tcPr marL="54864" marR="54864" marT="18288" marB="18288" anchor="ctr">
+                    <a:lnL w="12700" cap="flat" cmpd="sng" algn="ctr">
+                      <a:solidFill>
+                        <a:srgbClr val="FFFFFF"/>
+                      </a:solidFill>
+                      <a:prstDash val="solid"/>
+                      <a:round/>
+                      <a:headEnd type="none" w="med" len="med"/>
+                      <a:tailEnd type="none" w="med" len="med"/>
+                    </a:lnL>
+                    <a:lnR w="12700" cap="flat" cmpd="sng" algn="ctr">
+                      <a:solidFill>
+                        <a:srgbClr val="FFFFFF"/>
+                      </a:solidFill>
+                      <a:prstDash val="solid"/>
+                      <a:round/>
+                      <a:headEnd type="none" w="med" len="med"/>
+                      <a:tailEnd type="none" w="med" len="med"/>
+                    </a:lnR>
+                    <a:lnT w="12700" cap="flat" cmpd="sng" algn="ctr">
+                      <a:solidFill>
+                        <a:srgbClr val="FFFFFF"/>
+                      </a:solidFill>
+                      <a:prstDash val="solid"/>
+                      <a:round/>
+                      <a:headEnd type="none" w="med" len="med"/>
+                      <a:tailEnd type="none" w="med" len="med"/>
+                    </a:lnT>
+                    <a:lnB w="12700" cap="flat" cmpd="sng" algn="ctr">
+                      <a:solidFill>
+                        <a:srgbClr val="FFFFFF"/>
+                      </a:solidFill>
+                      <a:prstDash val="solid"/>
+                      <a:round/>
+                      <a:headEnd type="none" w="med" len="med"/>
+                      <a:tailEnd type="none" w="med" len="med"/>
+                    </a:lnB>
+                    <a:solidFill>
+                      <a:srgbClr val="D3ECEE"/>
+                    </a:solidFill>
+                  </a:tcPr>
+                </a:tc>
+                <a:tc>
+                  <a:txBody>
+                    <a:bodyPr/>
+                    <a:lstStyle/>
+                    <a:p>
+                      <a:pPr algn="ctr" indent="0" marL="0">
+                        <a:buNone/>
+                      </a:pPr>
+                      <a:r>
+                        <a:rPr lang="en-US" sz="1200" b="1" dirty="0">
+                          <a:solidFill>
+                            <a:srgbClr val="C0392B"/>
+                          </a:solidFill>
+                        </a:rPr>
+                        <a:t>175.7°</a:t>
+                      </a:r>
+                      <a:endParaRPr lang="en-US" sz="1200" dirty="0"/>
+                    </a:p>
+                  </a:txBody>
+                  <a:tcPr marL="54864" marR="54864" marT="18288" marB="18288" anchor="ctr">
                     <a:lnL w="12700" cap="flat" cmpd="sng" algn="ctr">
                       <a:solidFill>
                         <a:srgbClr val="FFFFFF"/>
@@ -17900,7 +17901,7 @@
                       <a:endParaRPr lang="en-US" sz="1200" dirty="0"/>
                     </a:p>
                   </a:txBody>
-                  <a:tcPr marL="73152" marR="73152" marT="18288" marB="18288" anchor="ctr">
+                  <a:tcPr marL="54864" marR="54864" marT="18288" marB="18288" anchor="ctr">
                     <a:lnL w="12700" cap="flat" cmpd="sng" algn="ctr">
                       <a:solidFill>
                         <a:srgbClr val="FFFFFF"/>
@@ -17956,12 +17957,12 @@
                             <a:srgbClr val="C0392B"/>
                           </a:solidFill>
                         </a:rPr>
-                        <a:t>177.1–178.0°</a:t>
+                        <a:t>177.9°</a:t>
                       </a:r>
                       <a:endParaRPr lang="en-US" sz="1200" dirty="0"/>
                     </a:p>
                   </a:txBody>
-                  <a:tcPr marL="73152" marR="73152" marT="18288" marB="18288" anchor="ctr">
+                  <a:tcPr marL="54864" marR="54864" marT="18288" marB="18288" anchor="ctr">
                     <a:lnL w="12700" cap="flat" cmpd="sng" algn="ctr">
                       <a:solidFill>
                         <a:srgbClr val="FFFFFF"/>
@@ -18017,12 +18018,134 @@
                             <a:srgbClr val="1B2233"/>
                           </a:solidFill>
                         </a:rPr>
-                        <a:t>6.8°</a:t>
+                        <a:t>12.4°</a:t>
                       </a:r>
                       <a:endParaRPr lang="en-US" sz="1200" dirty="0"/>
                     </a:p>
                   </a:txBody>
-                  <a:tcPr marL="73152" marR="73152" marT="18288" marB="18288" anchor="ctr">
+                  <a:tcPr marL="54864" marR="54864" marT="18288" marB="18288" anchor="ctr">
+                    <a:lnL w="12700" cap="flat" cmpd="sng" algn="ctr">
+                      <a:solidFill>
+                        <a:srgbClr val="FFFFFF"/>
+                      </a:solidFill>
+                      <a:prstDash val="solid"/>
+                      <a:round/>
+                      <a:headEnd type="none" w="med" len="med"/>
+                      <a:tailEnd type="none" w="med" len="med"/>
+                    </a:lnL>
+                    <a:lnR w="12700" cap="flat" cmpd="sng" algn="ctr">
+                      <a:solidFill>
+                        <a:srgbClr val="FFFFFF"/>
+                      </a:solidFill>
+                      <a:prstDash val="solid"/>
+                      <a:round/>
+                      <a:headEnd type="none" w="med" len="med"/>
+                      <a:tailEnd type="none" w="med" len="med"/>
+                    </a:lnR>
+                    <a:lnT w="12700" cap="flat" cmpd="sng" algn="ctr">
+                      <a:solidFill>
+                        <a:srgbClr val="FFFFFF"/>
+                      </a:solidFill>
+                      <a:prstDash val="solid"/>
+                      <a:round/>
+                      <a:headEnd type="none" w="med" len="med"/>
+                      <a:tailEnd type="none" w="med" len="med"/>
+                    </a:lnT>
+                    <a:lnB w="12700" cap="flat" cmpd="sng" algn="ctr">
+                      <a:solidFill>
+                        <a:srgbClr val="FFFFFF"/>
+                      </a:solidFill>
+                      <a:prstDash val="solid"/>
+                      <a:round/>
+                      <a:headEnd type="none" w="med" len="med"/>
+                      <a:tailEnd type="none" w="med" len="med"/>
+                    </a:lnB>
+                    <a:solidFill>
+                      <a:srgbClr val="EEF2F7"/>
+                    </a:solidFill>
+                  </a:tcPr>
+                </a:tc>
+                <a:tc>
+                  <a:txBody>
+                    <a:bodyPr/>
+                    <a:lstStyle/>
+                    <a:p>
+                      <a:pPr algn="ctr" indent="0" marL="0">
+                        <a:buNone/>
+                      </a:pPr>
+                      <a:r>
+                        <a:rPr lang="en-US" sz="1200" dirty="0">
+                          <a:solidFill>
+                            <a:srgbClr val="1B2233"/>
+                          </a:solidFill>
+                        </a:rPr>
+                        <a:t>11.2°</a:t>
+                      </a:r>
+                      <a:endParaRPr lang="en-US" sz="1200" dirty="0"/>
+                    </a:p>
+                  </a:txBody>
+                  <a:tcPr marL="54864" marR="54864" marT="18288" marB="18288" anchor="ctr">
+                    <a:lnL w="12700" cap="flat" cmpd="sng" algn="ctr">
+                      <a:solidFill>
+                        <a:srgbClr val="FFFFFF"/>
+                      </a:solidFill>
+                      <a:prstDash val="solid"/>
+                      <a:round/>
+                      <a:headEnd type="none" w="med" len="med"/>
+                      <a:tailEnd type="none" w="med" len="med"/>
+                    </a:lnL>
+                    <a:lnR w="12700" cap="flat" cmpd="sng" algn="ctr">
+                      <a:solidFill>
+                        <a:srgbClr val="FFFFFF"/>
+                      </a:solidFill>
+                      <a:prstDash val="solid"/>
+                      <a:round/>
+                      <a:headEnd type="none" w="med" len="med"/>
+                      <a:tailEnd type="none" w="med" len="med"/>
+                    </a:lnR>
+                    <a:lnT w="12700" cap="flat" cmpd="sng" algn="ctr">
+                      <a:solidFill>
+                        <a:srgbClr val="FFFFFF"/>
+                      </a:solidFill>
+                      <a:prstDash val="solid"/>
+                      <a:round/>
+                      <a:headEnd type="none" w="med" len="med"/>
+                      <a:tailEnd type="none" w="med" len="med"/>
+                    </a:lnT>
+                    <a:lnB w="12700" cap="flat" cmpd="sng" algn="ctr">
+                      <a:solidFill>
+                        <a:srgbClr val="FFFFFF"/>
+                      </a:solidFill>
+                      <a:prstDash val="solid"/>
+                      <a:round/>
+                      <a:headEnd type="none" w="med" len="med"/>
+                      <a:tailEnd type="none" w="med" len="med"/>
+                    </a:lnB>
+                    <a:solidFill>
+                      <a:srgbClr val="D3ECEE"/>
+                    </a:solidFill>
+                  </a:tcPr>
+                </a:tc>
+                <a:tc>
+                  <a:txBody>
+                    <a:bodyPr/>
+                    <a:lstStyle/>
+                    <a:p>
+                      <a:pPr algn="ctr" indent="0" marL="0">
+                        <a:buNone/>
+                      </a:pPr>
+                      <a:r>
+                        <a:rPr lang="en-US" sz="1200" b="1" dirty="0">
+                          <a:solidFill>
+                            <a:srgbClr val="C0392B"/>
+                          </a:solidFill>
+                        </a:rPr>
+                        <a:t>177.9°</a:t>
+                      </a:r>
+                      <a:endParaRPr lang="en-US" sz="1200" dirty="0"/>
+                    </a:p>
+                  </a:txBody>
+                  <a:tcPr marL="54864" marR="54864" marT="18288" marB="18288" anchor="ctr">
                     <a:lnL w="12700" cap="flat" cmpd="sng" algn="ctr">
                       <a:solidFill>
                         <a:srgbClr val="FFFFFF"/>
@@ -18080,382 +18203,12 @@
                             <a:srgbClr val="1B2233"/>
                           </a:solidFill>
                         </a:rPr>
-                        <a:t>jaw</a:t>
+                        <a:t>neck thickness</a:t>
                       </a:r>
                       <a:endParaRPr lang="en-US" sz="1200" dirty="0"/>
                     </a:p>
                   </a:txBody>
-                  <a:tcPr marL="73152" marR="73152" marT="18288" marB="18288" anchor="ctr">
-                    <a:lnL w="12700" cap="flat" cmpd="sng" algn="ctr">
-                      <a:solidFill>
-                        <a:srgbClr val="FFFFFF"/>
-                      </a:solidFill>
-                      <a:prstDash val="solid"/>
-                      <a:round/>
-                      <a:headEnd type="none" w="med" len="med"/>
-                      <a:tailEnd type="none" w="med" len="med"/>
-                    </a:lnL>
-                    <a:lnR w="12700" cap="flat" cmpd="sng" algn="ctr">
-                      <a:solidFill>
-                        <a:srgbClr val="FFFFFF"/>
-                      </a:solidFill>
-                      <a:prstDash val="solid"/>
-                      <a:round/>
-                      <a:headEnd type="none" w="med" len="med"/>
-                      <a:tailEnd type="none" w="med" len="med"/>
-                    </a:lnR>
-                    <a:lnT w="12700" cap="flat" cmpd="sng" algn="ctr">
-                      <a:solidFill>
-                        <a:srgbClr val="FFFFFF"/>
-                      </a:solidFill>
-                      <a:prstDash val="solid"/>
-                      <a:round/>
-                      <a:headEnd type="none" w="med" len="med"/>
-                      <a:tailEnd type="none" w="med" len="med"/>
-                    </a:lnT>
-                    <a:lnB w="12700" cap="flat" cmpd="sng" algn="ctr">
-                      <a:solidFill>
-                        <a:srgbClr val="FFFFFF"/>
-                      </a:solidFill>
-                      <a:prstDash val="solid"/>
-                      <a:round/>
-                      <a:headEnd type="none" w="med" len="med"/>
-                      <a:tailEnd type="none" w="med" len="med"/>
-                    </a:lnB>
-                    <a:solidFill>
-                      <a:srgbClr val="FFFFFF"/>
-                    </a:solidFill>
-                  </a:tcPr>
-                </a:tc>
-                <a:tc>
-                  <a:txBody>
-                    <a:bodyPr/>
-                    <a:lstStyle/>
-                    <a:p>
-                      <a:pPr algn="ctr" indent="0" marL="0">
-                        <a:buNone/>
-                      </a:pPr>
-                      <a:r>
-                        <a:rPr lang="en-US" sz="1200" dirty="0">
-                          <a:solidFill>
-                            <a:srgbClr val="1B2233"/>
-                          </a:solidFill>
-                        </a:rPr>
-                        <a:t>0.2–2.5°</a:t>
-                      </a:r>
-                      <a:endParaRPr lang="en-US" sz="1200" dirty="0"/>
-                    </a:p>
-                  </a:txBody>
-                  <a:tcPr marL="73152" marR="73152" marT="18288" marB="18288" anchor="ctr">
-                    <a:lnL w="12700" cap="flat" cmpd="sng" algn="ctr">
-                      <a:solidFill>
-                        <a:srgbClr val="FFFFFF"/>
-                      </a:solidFill>
-                      <a:prstDash val="solid"/>
-                      <a:round/>
-                      <a:headEnd type="none" w="med" len="med"/>
-                      <a:tailEnd type="none" w="med" len="med"/>
-                    </a:lnL>
-                    <a:lnR w="12700" cap="flat" cmpd="sng" algn="ctr">
-                      <a:solidFill>
-                        <a:srgbClr val="FFFFFF"/>
-                      </a:solidFill>
-                      <a:prstDash val="solid"/>
-                      <a:round/>
-                      <a:headEnd type="none" w="med" len="med"/>
-                      <a:tailEnd type="none" w="med" len="med"/>
-                    </a:lnR>
-                    <a:lnT w="12700" cap="flat" cmpd="sng" algn="ctr">
-                      <a:solidFill>
-                        <a:srgbClr val="FFFFFF"/>
-                      </a:solidFill>
-                      <a:prstDash val="solid"/>
-                      <a:round/>
-                      <a:headEnd type="none" w="med" len="med"/>
-                      <a:tailEnd type="none" w="med" len="med"/>
-                    </a:lnT>
-                    <a:lnB w="12700" cap="flat" cmpd="sng" algn="ctr">
-                      <a:solidFill>
-                        <a:srgbClr val="FFFFFF"/>
-                      </a:solidFill>
-                      <a:prstDash val="solid"/>
-                      <a:round/>
-                      <a:headEnd type="none" w="med" len="med"/>
-                      <a:tailEnd type="none" w="med" len="med"/>
-                    </a:lnB>
-                    <a:solidFill>
-                      <a:srgbClr val="FFFFFF"/>
-                    </a:solidFill>
-                  </a:tcPr>
-                </a:tc>
-                <a:tc>
-                  <a:txBody>
-                    <a:bodyPr/>
-                    <a:lstStyle/>
-                    <a:p>
-                      <a:pPr algn="ctr" indent="0" marL="0">
-                        <a:buNone/>
-                      </a:pPr>
-                      <a:r>
-                        <a:rPr lang="en-US" sz="1200" dirty="0">
-                          <a:solidFill>
-                            <a:srgbClr val="1B2233"/>
-                          </a:solidFill>
-                        </a:rPr>
-                        <a:t>0.2°</a:t>
-                      </a:r>
-                      <a:endParaRPr lang="en-US" sz="1200" dirty="0"/>
-                    </a:p>
-                  </a:txBody>
-                  <a:tcPr marL="73152" marR="73152" marT="18288" marB="18288" anchor="ctr">
-                    <a:lnL w="12700" cap="flat" cmpd="sng" algn="ctr">
-                      <a:solidFill>
-                        <a:srgbClr val="FFFFFF"/>
-                      </a:solidFill>
-                      <a:prstDash val="solid"/>
-                      <a:round/>
-                      <a:headEnd type="none" w="med" len="med"/>
-                      <a:tailEnd type="none" w="med" len="med"/>
-                    </a:lnL>
-                    <a:lnR w="12700" cap="flat" cmpd="sng" algn="ctr">
-                      <a:solidFill>
-                        <a:srgbClr val="FFFFFF"/>
-                      </a:solidFill>
-                      <a:prstDash val="solid"/>
-                      <a:round/>
-                      <a:headEnd type="none" w="med" len="med"/>
-                      <a:tailEnd type="none" w="med" len="med"/>
-                    </a:lnR>
-                    <a:lnT w="12700" cap="flat" cmpd="sng" algn="ctr">
-                      <a:solidFill>
-                        <a:srgbClr val="FFFFFF"/>
-                      </a:solidFill>
-                      <a:prstDash val="solid"/>
-                      <a:round/>
-                      <a:headEnd type="none" w="med" len="med"/>
-                      <a:tailEnd type="none" w="med" len="med"/>
-                    </a:lnT>
-                    <a:lnB w="12700" cap="flat" cmpd="sng" algn="ctr">
-                      <a:solidFill>
-                        <a:srgbClr val="FFFFFF"/>
-                      </a:solidFill>
-                      <a:prstDash val="solid"/>
-                      <a:round/>
-                      <a:headEnd type="none" w="med" len="med"/>
-                      <a:tailEnd type="none" w="med" len="med"/>
-                    </a:lnB>
-                    <a:solidFill>
-                      <a:srgbClr val="FFFFFF"/>
-                    </a:solidFill>
-                  </a:tcPr>
-                </a:tc>
-              </a:tr>
-              <a:tr h="246888">
-                <a:tc>
-                  <a:txBody>
-                    <a:bodyPr/>
-                    <a:lstStyle/>
-                    <a:p>
-                      <a:pPr algn="l" indent="0" marL="0">
-                        <a:buNone/>
-                      </a:pPr>
-                      <a:r>
-                        <a:rPr lang="en-US" sz="1200" b="1" dirty="0">
-                          <a:solidFill>
-                            <a:srgbClr val="1B2233"/>
-                          </a:solidFill>
-                        </a:rPr>
-                        <a:t>whole head direction</a:t>
-                      </a:r>
-                      <a:endParaRPr lang="en-US" sz="1200" dirty="0"/>
-                    </a:p>
-                  </a:txBody>
-                  <a:tcPr marL="73152" marR="73152" marT="18288" marB="18288" anchor="ctr">
-                    <a:lnL w="12700" cap="flat" cmpd="sng" algn="ctr">
-                      <a:solidFill>
-                        <a:srgbClr val="FFFFFF"/>
-                      </a:solidFill>
-                      <a:prstDash val="solid"/>
-                      <a:round/>
-                      <a:headEnd type="none" w="med" len="med"/>
-                      <a:tailEnd type="none" w="med" len="med"/>
-                    </a:lnL>
-                    <a:lnR w="12700" cap="flat" cmpd="sng" algn="ctr">
-                      <a:solidFill>
-                        <a:srgbClr val="FFFFFF"/>
-                      </a:solidFill>
-                      <a:prstDash val="solid"/>
-                      <a:round/>
-                      <a:headEnd type="none" w="med" len="med"/>
-                      <a:tailEnd type="none" w="med" len="med"/>
-                    </a:lnR>
-                    <a:lnT w="12700" cap="flat" cmpd="sng" algn="ctr">
-                      <a:solidFill>
-                        <a:srgbClr val="FFFFFF"/>
-                      </a:solidFill>
-                      <a:prstDash val="solid"/>
-                      <a:round/>
-                      <a:headEnd type="none" w="med" len="med"/>
-                      <a:tailEnd type="none" w="med" len="med"/>
-                    </a:lnT>
-                    <a:lnB w="12700" cap="flat" cmpd="sng" algn="ctr">
-                      <a:solidFill>
-                        <a:srgbClr val="FFFFFF"/>
-                      </a:solidFill>
-                      <a:prstDash val="solid"/>
-                      <a:round/>
-                      <a:headEnd type="none" w="med" len="med"/>
-                      <a:tailEnd type="none" w="med" len="med"/>
-                    </a:lnB>
-                    <a:solidFill>
-                      <a:srgbClr val="EEF2F7"/>
-                    </a:solidFill>
-                  </a:tcPr>
-                </a:tc>
-                <a:tc>
-                  <a:txBody>
-                    <a:bodyPr/>
-                    <a:lstStyle/>
-                    <a:p>
-                      <a:pPr algn="ctr" indent="0" marL="0">
-                        <a:buNone/>
-                      </a:pPr>
-                      <a:r>
-                        <a:rPr lang="en-US" sz="1200" dirty="0">
-                          <a:solidFill>
-                            <a:srgbClr val="1B2233"/>
-                          </a:solidFill>
-                        </a:rPr>
-                        <a:t>12.0–14.9°</a:t>
-                      </a:r>
-                      <a:endParaRPr lang="en-US" sz="1200" dirty="0"/>
-                    </a:p>
-                  </a:txBody>
-                  <a:tcPr marL="73152" marR="73152" marT="18288" marB="18288" anchor="ctr">
-                    <a:lnL w="12700" cap="flat" cmpd="sng" algn="ctr">
-                      <a:solidFill>
-                        <a:srgbClr val="FFFFFF"/>
-                      </a:solidFill>
-                      <a:prstDash val="solid"/>
-                      <a:round/>
-                      <a:headEnd type="none" w="med" len="med"/>
-                      <a:tailEnd type="none" w="med" len="med"/>
-                    </a:lnL>
-                    <a:lnR w="12700" cap="flat" cmpd="sng" algn="ctr">
-                      <a:solidFill>
-                        <a:srgbClr val="FFFFFF"/>
-                      </a:solidFill>
-                      <a:prstDash val="solid"/>
-                      <a:round/>
-                      <a:headEnd type="none" w="med" len="med"/>
-                      <a:tailEnd type="none" w="med" len="med"/>
-                    </a:lnR>
-                    <a:lnT w="12700" cap="flat" cmpd="sng" algn="ctr">
-                      <a:solidFill>
-                        <a:srgbClr val="FFFFFF"/>
-                      </a:solidFill>
-                      <a:prstDash val="solid"/>
-                      <a:round/>
-                      <a:headEnd type="none" w="med" len="med"/>
-                      <a:tailEnd type="none" w="med" len="med"/>
-                    </a:lnT>
-                    <a:lnB w="12700" cap="flat" cmpd="sng" algn="ctr">
-                      <a:solidFill>
-                        <a:srgbClr val="FFFFFF"/>
-                      </a:solidFill>
-                      <a:prstDash val="solid"/>
-                      <a:round/>
-                      <a:headEnd type="none" w="med" len="med"/>
-                      <a:tailEnd type="none" w="med" len="med"/>
-                    </a:lnB>
-                    <a:solidFill>
-                      <a:srgbClr val="EEF2F7"/>
-                    </a:solidFill>
-                  </a:tcPr>
-                </a:tc>
-                <a:tc>
-                  <a:txBody>
-                    <a:bodyPr/>
-                    <a:lstStyle/>
-                    <a:p>
-                      <a:pPr algn="ctr" indent="0" marL="0">
-                        <a:buNone/>
-                      </a:pPr>
-                      <a:r>
-                        <a:rPr lang="en-US" sz="1200" dirty="0">
-                          <a:solidFill>
-                            <a:srgbClr val="1B2233"/>
-                          </a:solidFill>
-                        </a:rPr>
-                        <a:t>12.9°</a:t>
-                      </a:r>
-                      <a:endParaRPr lang="en-US" sz="1200" dirty="0"/>
-                    </a:p>
-                  </a:txBody>
-                  <a:tcPr marL="73152" marR="73152" marT="18288" marB="18288" anchor="ctr">
-                    <a:lnL w="12700" cap="flat" cmpd="sng" algn="ctr">
-                      <a:solidFill>
-                        <a:srgbClr val="FFFFFF"/>
-                      </a:solidFill>
-                      <a:prstDash val="solid"/>
-                      <a:round/>
-                      <a:headEnd type="none" w="med" len="med"/>
-                      <a:tailEnd type="none" w="med" len="med"/>
-                    </a:lnL>
-                    <a:lnR w="12700" cap="flat" cmpd="sng" algn="ctr">
-                      <a:solidFill>
-                        <a:srgbClr val="FFFFFF"/>
-                      </a:solidFill>
-                      <a:prstDash val="solid"/>
-                      <a:round/>
-                      <a:headEnd type="none" w="med" len="med"/>
-                      <a:tailEnd type="none" w="med" len="med"/>
-                    </a:lnR>
-                    <a:lnT w="12700" cap="flat" cmpd="sng" algn="ctr">
-                      <a:solidFill>
-                        <a:srgbClr val="FFFFFF"/>
-                      </a:solidFill>
-                      <a:prstDash val="solid"/>
-                      <a:round/>
-                      <a:headEnd type="none" w="med" len="med"/>
-                      <a:tailEnd type="none" w="med" len="med"/>
-                    </a:lnT>
-                    <a:lnB w="12700" cap="flat" cmpd="sng" algn="ctr">
-                      <a:solidFill>
-                        <a:srgbClr val="FFFFFF"/>
-                      </a:solidFill>
-                      <a:prstDash val="solid"/>
-                      <a:round/>
-                      <a:headEnd type="none" w="med" len="med"/>
-                      <a:tailEnd type="none" w="med" len="med"/>
-                    </a:lnB>
-                    <a:solidFill>
-                      <a:srgbClr val="EEF2F7"/>
-                    </a:solidFill>
-                  </a:tcPr>
-                </a:tc>
-              </a:tr>
-              <a:tr h="246888">
-                <a:tc>
-                  <a:txBody>
-                    <a:bodyPr/>
-                    <a:lstStyle/>
-                    <a:p>
-                      <a:pPr algn="l" indent="0" marL="0">
-                        <a:buNone/>
-                      </a:pPr>
-                      <a:r>
-                        <a:rPr lang="en-US" sz="1200" b="1" dirty="0">
-                          <a:solidFill>
-                            <a:srgbClr val="1B2233"/>
-                          </a:solidFill>
-                        </a:rPr>
-                        <a:t>neck thickness (pred / true)</a:t>
-                      </a:r>
-                      <a:endParaRPr lang="en-US" sz="1200" dirty="0"/>
-                    </a:p>
-                  </a:txBody>
-                  <a:tcPr marL="73152" marR="73152" marT="18288" marB="18288" anchor="ctr">
+                  <a:tcPr marL="54864" marR="54864" marT="18288" marB="18288" anchor="ctr">
                     <a:lnL w="12700" cap="flat" cmpd="sng" algn="ctr">
                       <a:solidFill>
                         <a:srgbClr val="FFFFFF"/>
@@ -18511,12 +18264,12 @@
                             <a:srgbClr val="C0392B"/>
                           </a:solidFill>
                         </a:rPr>
-                        <a:t>0.46–0.47</a:t>
+                        <a:t>0.46</a:t>
                       </a:r>
                       <a:endParaRPr lang="en-US" sz="1200" dirty="0"/>
                     </a:p>
                   </a:txBody>
-                  <a:tcPr marL="73152" marR="73152" marT="18288" marB="18288" anchor="ctr">
+                  <a:tcPr marL="54864" marR="54864" marT="18288" marB="18288" anchor="ctr">
                     <a:lnL w="12700" cap="flat" cmpd="sng" algn="ctr">
                       <a:solidFill>
                         <a:srgbClr val="FFFFFF"/>
@@ -18577,7 +18330,129 @@
                       <a:endParaRPr lang="en-US" sz="1200" dirty="0"/>
                     </a:p>
                   </a:txBody>
-                  <a:tcPr marL="73152" marR="73152" marT="18288" marB="18288" anchor="ctr">
+                  <a:tcPr marL="54864" marR="54864" marT="18288" marB="18288" anchor="ctr">
+                    <a:lnL w="12700" cap="flat" cmpd="sng" algn="ctr">
+                      <a:solidFill>
+                        <a:srgbClr val="FFFFFF"/>
+                      </a:solidFill>
+                      <a:prstDash val="solid"/>
+                      <a:round/>
+                      <a:headEnd type="none" w="med" len="med"/>
+                      <a:tailEnd type="none" w="med" len="med"/>
+                    </a:lnL>
+                    <a:lnR w="12700" cap="flat" cmpd="sng" algn="ctr">
+                      <a:solidFill>
+                        <a:srgbClr val="FFFFFF"/>
+                      </a:solidFill>
+                      <a:prstDash val="solid"/>
+                      <a:round/>
+                      <a:headEnd type="none" w="med" len="med"/>
+                      <a:tailEnd type="none" w="med" len="med"/>
+                    </a:lnR>
+                    <a:lnT w="12700" cap="flat" cmpd="sng" algn="ctr">
+                      <a:solidFill>
+                        <a:srgbClr val="FFFFFF"/>
+                      </a:solidFill>
+                      <a:prstDash val="solid"/>
+                      <a:round/>
+                      <a:headEnd type="none" w="med" len="med"/>
+                      <a:tailEnd type="none" w="med" len="med"/>
+                    </a:lnT>
+                    <a:lnB w="12700" cap="flat" cmpd="sng" algn="ctr">
+                      <a:solidFill>
+                        <a:srgbClr val="FFFFFF"/>
+                      </a:solidFill>
+                      <a:prstDash val="solid"/>
+                      <a:round/>
+                      <a:headEnd type="none" w="med" len="med"/>
+                      <a:tailEnd type="none" w="med" len="med"/>
+                    </a:lnB>
+                    <a:solidFill>
+                      <a:srgbClr val="FFFFFF"/>
+                    </a:solidFill>
+                  </a:tcPr>
+                </a:tc>
+                <a:tc>
+                  <a:txBody>
+                    <a:bodyPr/>
+                    <a:lstStyle/>
+                    <a:p>
+                      <a:pPr algn="ctr" indent="0" marL="0">
+                        <a:buNone/>
+                      </a:pPr>
+                      <a:r>
+                        <a:rPr lang="en-US" sz="1200" dirty="0">
+                          <a:solidFill>
+                            <a:srgbClr val="1B2233"/>
+                          </a:solidFill>
+                        </a:rPr>
+                        <a:t>1.00</a:t>
+                      </a:r>
+                      <a:endParaRPr lang="en-US" sz="1200" dirty="0"/>
+                    </a:p>
+                  </a:txBody>
+                  <a:tcPr marL="54864" marR="54864" marT="18288" marB="18288" anchor="ctr">
+                    <a:lnL w="12700" cap="flat" cmpd="sng" algn="ctr">
+                      <a:solidFill>
+                        <a:srgbClr val="FFFFFF"/>
+                      </a:solidFill>
+                      <a:prstDash val="solid"/>
+                      <a:round/>
+                      <a:headEnd type="none" w="med" len="med"/>
+                      <a:tailEnd type="none" w="med" len="med"/>
+                    </a:lnL>
+                    <a:lnR w="12700" cap="flat" cmpd="sng" algn="ctr">
+                      <a:solidFill>
+                        <a:srgbClr val="FFFFFF"/>
+                      </a:solidFill>
+                      <a:prstDash val="solid"/>
+                      <a:round/>
+                      <a:headEnd type="none" w="med" len="med"/>
+                      <a:tailEnd type="none" w="med" len="med"/>
+                    </a:lnR>
+                    <a:lnT w="12700" cap="flat" cmpd="sng" algn="ctr">
+                      <a:solidFill>
+                        <a:srgbClr val="FFFFFF"/>
+                      </a:solidFill>
+                      <a:prstDash val="solid"/>
+                      <a:round/>
+                      <a:headEnd type="none" w="med" len="med"/>
+                      <a:tailEnd type="none" w="med" len="med"/>
+                    </a:lnT>
+                    <a:lnB w="12700" cap="flat" cmpd="sng" algn="ctr">
+                      <a:solidFill>
+                        <a:srgbClr val="FFFFFF"/>
+                      </a:solidFill>
+                      <a:prstDash val="solid"/>
+                      <a:round/>
+                      <a:headEnd type="none" w="med" len="med"/>
+                      <a:tailEnd type="none" w="med" len="med"/>
+                    </a:lnB>
+                    <a:solidFill>
+                      <a:srgbClr val="D3ECEE"/>
+                    </a:solidFill>
+                  </a:tcPr>
+                </a:tc>
+                <a:tc>
+                  <a:txBody>
+                    <a:bodyPr/>
+                    <a:lstStyle/>
+                    <a:p>
+                      <a:pPr algn="ctr" indent="0" marL="0">
+                        <a:buNone/>
+                      </a:pPr>
+                      <a:r>
+                        <a:rPr lang="en-US" sz="1200" b="1" dirty="0">
+                          <a:solidFill>
+                            <a:srgbClr val="C0392B"/>
+                          </a:solidFill>
+                        </a:rPr>
+                        <a:t>0.46</a:t>
+                      </a:r>
+                      <a:endParaRPr lang="en-US" sz="1200" dirty="0"/>
+                    </a:p>
+                  </a:txBody>
+                  <a:tcPr marL="54864" marR="54864" marT="18288" marB="18288" anchor="ctr">
                     <a:lnL w="12700" cap="flat" cmpd="sng" algn="ctr">
                       <a:solidFill>
                         <a:srgbClr val="FFFFFF"/>
@@ -18640,7 +18515,7 @@
                       <a:endParaRPr lang="en-US" sz="1200" dirty="0"/>
                     </a:p>
                   </a:txBody>
-                  <a:tcPr marL="73152" marR="73152" marT="18288" marB="18288" anchor="ctr">
+                  <a:tcPr marL="54864" marR="54864" marT="18288" marB="18288" anchor="ctr">
                     <a:lnL w="12700" cap="flat" cmpd="sng" algn="ctr">
                       <a:solidFill>
                         <a:srgbClr val="FFFFFF"/>
@@ -18696,12 +18571,12 @@
                             <a:srgbClr val="C0392B"/>
                           </a:solidFill>
                         </a:rPr>
-                        <a:t>27.3–28.7 mm</a:t>
+                        <a:t>27.3 mm</a:t>
                       </a:r>
                       <a:endParaRPr lang="en-US" sz="1200" dirty="0"/>
                     </a:p>
                   </a:txBody>
-                  <a:tcPr marL="73152" marR="73152" marT="18288" marB="18288" anchor="ctr">
+                  <a:tcPr marL="54864" marR="54864" marT="18288" marB="18288" anchor="ctr">
                     <a:lnL w="12700" cap="flat" cmpd="sng" algn="ctr">
                       <a:solidFill>
                         <a:srgbClr val="FFFFFF"/>
@@ -18757,12 +18632,748 @@
                             <a:srgbClr val="1B2233"/>
                           </a:solidFill>
                         </a:rPr>
-                        <a:t>10.3 mm</a:t>
+                        <a:t>10.8 mm</a:t>
                       </a:r>
                       <a:endParaRPr lang="en-US" sz="1200" dirty="0"/>
                     </a:p>
                   </a:txBody>
-                  <a:tcPr marL="73152" marR="73152" marT="18288" marB="18288" anchor="ctr">
+                  <a:tcPr marL="54864" marR="54864" marT="18288" marB="18288" anchor="ctr">
+                    <a:lnL w="12700" cap="flat" cmpd="sng" algn="ctr">
+                      <a:solidFill>
+                        <a:srgbClr val="FFFFFF"/>
+                      </a:solidFill>
+                      <a:prstDash val="solid"/>
+                      <a:round/>
+                      <a:headEnd type="none" w="med" len="med"/>
+                      <a:tailEnd type="none" w="med" len="med"/>
+                    </a:lnL>
+                    <a:lnR w="12700" cap="flat" cmpd="sng" algn="ctr">
+                      <a:solidFill>
+                        <a:srgbClr val="FFFFFF"/>
+                      </a:solidFill>
+                      <a:prstDash val="solid"/>
+                      <a:round/>
+                      <a:headEnd type="none" w="med" len="med"/>
+                      <a:tailEnd type="none" w="med" len="med"/>
+                    </a:lnR>
+                    <a:lnT w="12700" cap="flat" cmpd="sng" algn="ctr">
+                      <a:solidFill>
+                        <a:srgbClr val="FFFFFF"/>
+                      </a:solidFill>
+                      <a:prstDash val="solid"/>
+                      <a:round/>
+                      <a:headEnd type="none" w="med" len="med"/>
+                      <a:tailEnd type="none" w="med" len="med"/>
+                    </a:lnT>
+                    <a:lnB w="12700" cap="flat" cmpd="sng" algn="ctr">
+                      <a:solidFill>
+                        <a:srgbClr val="FFFFFF"/>
+                      </a:solidFill>
+                      <a:prstDash val="solid"/>
+                      <a:round/>
+                      <a:headEnd type="none" w="med" len="med"/>
+                      <a:tailEnd type="none" w="med" len="med"/>
+                    </a:lnB>
+                    <a:solidFill>
+                      <a:srgbClr val="EEF2F7"/>
+                    </a:solidFill>
+                  </a:tcPr>
+                </a:tc>
+                <a:tc>
+                  <a:txBody>
+                    <a:bodyPr/>
+                    <a:lstStyle/>
+                    <a:p>
+                      <a:pPr algn="ctr" indent="0" marL="0">
+                        <a:buNone/>
+                      </a:pPr>
+                      <a:r>
+                        <a:rPr lang="en-US" sz="1200" dirty="0">
+                          <a:solidFill>
+                            <a:srgbClr val="1B2233"/>
+                          </a:solidFill>
+                        </a:rPr>
+                        <a:t>10.7 mm</a:t>
+                      </a:r>
+                      <a:endParaRPr lang="en-US" sz="1200" dirty="0"/>
+                    </a:p>
+                  </a:txBody>
+                  <a:tcPr marL="54864" marR="54864" marT="18288" marB="18288" anchor="ctr">
+                    <a:lnL w="12700" cap="flat" cmpd="sng" algn="ctr">
+                      <a:solidFill>
+                        <a:srgbClr val="FFFFFF"/>
+                      </a:solidFill>
+                      <a:prstDash val="solid"/>
+                      <a:round/>
+                      <a:headEnd type="none" w="med" len="med"/>
+                      <a:tailEnd type="none" w="med" len="med"/>
+                    </a:lnL>
+                    <a:lnR w="12700" cap="flat" cmpd="sng" algn="ctr">
+                      <a:solidFill>
+                        <a:srgbClr val="FFFFFF"/>
+                      </a:solidFill>
+                      <a:prstDash val="solid"/>
+                      <a:round/>
+                      <a:headEnd type="none" w="med" len="med"/>
+                      <a:tailEnd type="none" w="med" len="med"/>
+                    </a:lnR>
+                    <a:lnT w="12700" cap="flat" cmpd="sng" algn="ctr">
+                      <a:solidFill>
+                        <a:srgbClr val="FFFFFF"/>
+                      </a:solidFill>
+                      <a:prstDash val="solid"/>
+                      <a:round/>
+                      <a:headEnd type="none" w="med" len="med"/>
+                      <a:tailEnd type="none" w="med" len="med"/>
+                    </a:lnT>
+                    <a:lnB w="12700" cap="flat" cmpd="sng" algn="ctr">
+                      <a:solidFill>
+                        <a:srgbClr val="FFFFFF"/>
+                      </a:solidFill>
+                      <a:prstDash val="solid"/>
+                      <a:round/>
+                      <a:headEnd type="none" w="med" len="med"/>
+                      <a:tailEnd type="none" w="med" len="med"/>
+                    </a:lnB>
+                    <a:solidFill>
+                      <a:srgbClr val="D3ECEE"/>
+                    </a:solidFill>
+                  </a:tcPr>
+                </a:tc>
+                <a:tc>
+                  <a:txBody>
+                    <a:bodyPr/>
+                    <a:lstStyle/>
+                    <a:p>
+                      <a:pPr algn="ctr" indent="0" marL="0">
+                        <a:buNone/>
+                      </a:pPr>
+                      <a:r>
+                        <a:rPr lang="en-US" sz="1200" b="1" dirty="0">
+                          <a:solidFill>
+                            <a:srgbClr val="C0392B"/>
+                          </a:solidFill>
+                        </a:rPr>
+                        <a:t>27.9 mm</a:t>
+                      </a:r>
+                      <a:endParaRPr lang="en-US" sz="1200" dirty="0"/>
+                    </a:p>
+                  </a:txBody>
+                  <a:tcPr marL="54864" marR="54864" marT="18288" marB="18288" anchor="ctr">
+                    <a:lnL w="12700" cap="flat" cmpd="sng" algn="ctr">
+                      <a:solidFill>
+                        <a:srgbClr val="FFFFFF"/>
+                      </a:solidFill>
+                      <a:prstDash val="solid"/>
+                      <a:round/>
+                      <a:headEnd type="none" w="med" len="med"/>
+                      <a:tailEnd type="none" w="med" len="med"/>
+                    </a:lnL>
+                    <a:lnR w="12700" cap="flat" cmpd="sng" algn="ctr">
+                      <a:solidFill>
+                        <a:srgbClr val="FFFFFF"/>
+                      </a:solidFill>
+                      <a:prstDash val="solid"/>
+                      <a:round/>
+                      <a:headEnd type="none" w="med" len="med"/>
+                      <a:tailEnd type="none" w="med" len="med"/>
+                    </a:lnR>
+                    <a:lnT w="12700" cap="flat" cmpd="sng" algn="ctr">
+                      <a:solidFill>
+                        <a:srgbClr val="FFFFFF"/>
+                      </a:solidFill>
+                      <a:prstDash val="solid"/>
+                      <a:round/>
+                      <a:headEnd type="none" w="med" len="med"/>
+                      <a:tailEnd type="none" w="med" len="med"/>
+                    </a:lnT>
+                    <a:lnB w="12700" cap="flat" cmpd="sng" algn="ctr">
+                      <a:solidFill>
+                        <a:srgbClr val="FFFFFF"/>
+                      </a:solidFill>
+                      <a:prstDash val="solid"/>
+                      <a:round/>
+                      <a:headEnd type="none" w="med" len="med"/>
+                      <a:tailEnd type="none" w="med" len="med"/>
+                    </a:lnB>
+                    <a:solidFill>
+                      <a:srgbClr val="EEF2F7"/>
+                    </a:solidFill>
+                  </a:tcPr>
+                </a:tc>
+              </a:tr>
+              <a:tr h="246888">
+                <a:tc>
+                  <a:txBody>
+                    <a:bodyPr/>
+                    <a:lstStyle/>
+                    <a:p>
+                      <a:pPr algn="l" indent="0" marL="0">
+                        <a:buNone/>
+                      </a:pPr>
+                      <a:r>
+                        <a:rPr lang="en-US" sz="1200" b="1" dirty="0">
+                          <a:solidFill>
+                            <a:srgbClr val="1B2233"/>
+                          </a:solidFill>
+                        </a:rPr>
+                        <a:t>body PVE</a:t>
+                      </a:r>
+                      <a:endParaRPr lang="en-US" sz="1200" dirty="0"/>
+                    </a:p>
+                  </a:txBody>
+                  <a:tcPr marL="54864" marR="54864" marT="18288" marB="18288" anchor="ctr">
+                    <a:lnL w="12700" cap="flat" cmpd="sng" algn="ctr">
+                      <a:solidFill>
+                        <a:srgbClr val="FFFFFF"/>
+                      </a:solidFill>
+                      <a:prstDash val="solid"/>
+                      <a:round/>
+                      <a:headEnd type="none" w="med" len="med"/>
+                      <a:tailEnd type="none" w="med" len="med"/>
+                    </a:lnL>
+                    <a:lnR w="12700" cap="flat" cmpd="sng" algn="ctr">
+                      <a:solidFill>
+                        <a:srgbClr val="FFFFFF"/>
+                      </a:solidFill>
+                      <a:prstDash val="solid"/>
+                      <a:round/>
+                      <a:headEnd type="none" w="med" len="med"/>
+                      <a:tailEnd type="none" w="med" len="med"/>
+                    </a:lnR>
+                    <a:lnT w="12700" cap="flat" cmpd="sng" algn="ctr">
+                      <a:solidFill>
+                        <a:srgbClr val="FFFFFF"/>
+                      </a:solidFill>
+                      <a:prstDash val="solid"/>
+                      <a:round/>
+                      <a:headEnd type="none" w="med" len="med"/>
+                      <a:tailEnd type="none" w="med" len="med"/>
+                    </a:lnT>
+                    <a:lnB w="12700" cap="flat" cmpd="sng" algn="ctr">
+                      <a:solidFill>
+                        <a:srgbClr val="FFFFFF"/>
+                      </a:solidFill>
+                      <a:prstDash val="solid"/>
+                      <a:round/>
+                      <a:headEnd type="none" w="med" len="med"/>
+                      <a:tailEnd type="none" w="med" len="med"/>
+                    </a:lnB>
+                    <a:solidFill>
+                      <a:srgbClr val="FFFFFF"/>
+                    </a:solidFill>
+                  </a:tcPr>
+                </a:tc>
+                <a:tc>
+                  <a:txBody>
+                    <a:bodyPr/>
+                    <a:lstStyle/>
+                    <a:p>
+                      <a:pPr algn="ctr" indent="0" marL="0">
+                        <a:buNone/>
+                      </a:pPr>
+                      <a:r>
+                        <a:rPr lang="en-US" sz="1200" dirty="0">
+                          <a:solidFill>
+                            <a:srgbClr val="1B2233"/>
+                          </a:solidFill>
+                        </a:rPr>
+                        <a:t>70.5 mm</a:t>
+                      </a:r>
+                      <a:endParaRPr lang="en-US" sz="1200" dirty="0"/>
+                    </a:p>
+                  </a:txBody>
+                  <a:tcPr marL="54864" marR="54864" marT="18288" marB="18288" anchor="ctr">
+                    <a:lnL w="12700" cap="flat" cmpd="sng" algn="ctr">
+                      <a:solidFill>
+                        <a:srgbClr val="FFFFFF"/>
+                      </a:solidFill>
+                      <a:prstDash val="solid"/>
+                      <a:round/>
+                      <a:headEnd type="none" w="med" len="med"/>
+                      <a:tailEnd type="none" w="med" len="med"/>
+                    </a:lnL>
+                    <a:lnR w="12700" cap="flat" cmpd="sng" algn="ctr">
+                      <a:solidFill>
+                        <a:srgbClr val="FFFFFF"/>
+                      </a:solidFill>
+                      <a:prstDash val="solid"/>
+                      <a:round/>
+                      <a:headEnd type="none" w="med" len="med"/>
+                      <a:tailEnd type="none" w="med" len="med"/>
+                    </a:lnR>
+                    <a:lnT w="12700" cap="flat" cmpd="sng" algn="ctr">
+                      <a:solidFill>
+                        <a:srgbClr val="FFFFFF"/>
+                      </a:solidFill>
+                      <a:prstDash val="solid"/>
+                      <a:round/>
+                      <a:headEnd type="none" w="med" len="med"/>
+                      <a:tailEnd type="none" w="med" len="med"/>
+                    </a:lnT>
+                    <a:lnB w="12700" cap="flat" cmpd="sng" algn="ctr">
+                      <a:solidFill>
+                        <a:srgbClr val="FFFFFF"/>
+                      </a:solidFill>
+                      <a:prstDash val="solid"/>
+                      <a:round/>
+                      <a:headEnd type="none" w="med" len="med"/>
+                      <a:tailEnd type="none" w="med" len="med"/>
+                    </a:lnB>
+                    <a:solidFill>
+                      <a:srgbClr val="FFFFFF"/>
+                    </a:solidFill>
+                  </a:tcPr>
+                </a:tc>
+                <a:tc>
+                  <a:txBody>
+                    <a:bodyPr/>
+                    <a:lstStyle/>
+                    <a:p>
+                      <a:pPr algn="ctr" indent="0" marL="0">
+                        <a:buNone/>
+                      </a:pPr>
+                      <a:r>
+                        <a:rPr lang="en-US" sz="1200" dirty="0">
+                          <a:solidFill>
+                            <a:srgbClr val="1B2233"/>
+                          </a:solidFill>
+                        </a:rPr>
+                        <a:t>71.3 mm</a:t>
+                      </a:r>
+                      <a:endParaRPr lang="en-US" sz="1200" dirty="0"/>
+                    </a:p>
+                  </a:txBody>
+                  <a:tcPr marL="54864" marR="54864" marT="18288" marB="18288" anchor="ctr">
+                    <a:lnL w="12700" cap="flat" cmpd="sng" algn="ctr">
+                      <a:solidFill>
+                        <a:srgbClr val="FFFFFF"/>
+                      </a:solidFill>
+                      <a:prstDash val="solid"/>
+                      <a:round/>
+                      <a:headEnd type="none" w="med" len="med"/>
+                      <a:tailEnd type="none" w="med" len="med"/>
+                    </a:lnL>
+                    <a:lnR w="12700" cap="flat" cmpd="sng" algn="ctr">
+                      <a:solidFill>
+                        <a:srgbClr val="FFFFFF"/>
+                      </a:solidFill>
+                      <a:prstDash val="solid"/>
+                      <a:round/>
+                      <a:headEnd type="none" w="med" len="med"/>
+                      <a:tailEnd type="none" w="med" len="med"/>
+                    </a:lnR>
+                    <a:lnT w="12700" cap="flat" cmpd="sng" algn="ctr">
+                      <a:solidFill>
+                        <a:srgbClr val="FFFFFF"/>
+                      </a:solidFill>
+                      <a:prstDash val="solid"/>
+                      <a:round/>
+                      <a:headEnd type="none" w="med" len="med"/>
+                      <a:tailEnd type="none" w="med" len="med"/>
+                    </a:lnT>
+                    <a:lnB w="12700" cap="flat" cmpd="sng" algn="ctr">
+                      <a:solidFill>
+                        <a:srgbClr val="FFFFFF"/>
+                      </a:solidFill>
+                      <a:prstDash val="solid"/>
+                      <a:round/>
+                      <a:headEnd type="none" w="med" len="med"/>
+                      <a:tailEnd type="none" w="med" len="med"/>
+                    </a:lnB>
+                    <a:solidFill>
+                      <a:srgbClr val="FFFFFF"/>
+                    </a:solidFill>
+                  </a:tcPr>
+                </a:tc>
+                <a:tc>
+                  <a:txBody>
+                    <a:bodyPr/>
+                    <a:lstStyle/>
+                    <a:p>
+                      <a:pPr algn="ctr" indent="0" marL="0">
+                        <a:buNone/>
+                      </a:pPr>
+                      <a:r>
+                        <a:rPr lang="en-US" sz="1200" dirty="0">
+                          <a:solidFill>
+                            <a:srgbClr val="1B2233"/>
+                          </a:solidFill>
+                        </a:rPr>
+                        <a:t>68.8 mm</a:t>
+                      </a:r>
+                      <a:endParaRPr lang="en-US" sz="1200" dirty="0"/>
+                    </a:p>
+                  </a:txBody>
+                  <a:tcPr marL="54864" marR="54864" marT="18288" marB="18288" anchor="ctr">
+                    <a:lnL w="12700" cap="flat" cmpd="sng" algn="ctr">
+                      <a:solidFill>
+                        <a:srgbClr val="FFFFFF"/>
+                      </a:solidFill>
+                      <a:prstDash val="solid"/>
+                      <a:round/>
+                      <a:headEnd type="none" w="med" len="med"/>
+                      <a:tailEnd type="none" w="med" len="med"/>
+                    </a:lnL>
+                    <a:lnR w="12700" cap="flat" cmpd="sng" algn="ctr">
+                      <a:solidFill>
+                        <a:srgbClr val="FFFFFF"/>
+                      </a:solidFill>
+                      <a:prstDash val="solid"/>
+                      <a:round/>
+                      <a:headEnd type="none" w="med" len="med"/>
+                      <a:tailEnd type="none" w="med" len="med"/>
+                    </a:lnR>
+                    <a:lnT w="12700" cap="flat" cmpd="sng" algn="ctr">
+                      <a:solidFill>
+                        <a:srgbClr val="FFFFFF"/>
+                      </a:solidFill>
+                      <a:prstDash val="solid"/>
+                      <a:round/>
+                      <a:headEnd type="none" w="med" len="med"/>
+                      <a:tailEnd type="none" w="med" len="med"/>
+                    </a:lnT>
+                    <a:lnB w="12700" cap="flat" cmpd="sng" algn="ctr">
+                      <a:solidFill>
+                        <a:srgbClr val="FFFFFF"/>
+                      </a:solidFill>
+                      <a:prstDash val="solid"/>
+                      <a:round/>
+                      <a:headEnd type="none" w="med" len="med"/>
+                      <a:tailEnd type="none" w="med" len="med"/>
+                    </a:lnB>
+                    <a:solidFill>
+                      <a:srgbClr val="D3ECEE"/>
+                    </a:solidFill>
+                  </a:tcPr>
+                </a:tc>
+                <a:tc>
+                  <a:txBody>
+                    <a:bodyPr/>
+                    <a:lstStyle/>
+                    <a:p>
+                      <a:pPr algn="ctr" indent="0" marL="0">
+                        <a:buNone/>
+                      </a:pPr>
+                      <a:r>
+                        <a:rPr lang="en-US" sz="1200" dirty="0">
+                          <a:solidFill>
+                            <a:srgbClr val="1B2233"/>
+                          </a:solidFill>
+                        </a:rPr>
+                        <a:t>76.9 mm</a:t>
+                      </a:r>
+                      <a:endParaRPr lang="en-US" sz="1200" dirty="0"/>
+                    </a:p>
+                  </a:txBody>
+                  <a:tcPr marL="54864" marR="54864" marT="18288" marB="18288" anchor="ctr">
+                    <a:lnL w="12700" cap="flat" cmpd="sng" algn="ctr">
+                      <a:solidFill>
+                        <a:srgbClr val="FFFFFF"/>
+                      </a:solidFill>
+                      <a:prstDash val="solid"/>
+                      <a:round/>
+                      <a:headEnd type="none" w="med" len="med"/>
+                      <a:tailEnd type="none" w="med" len="med"/>
+                    </a:lnL>
+                    <a:lnR w="12700" cap="flat" cmpd="sng" algn="ctr">
+                      <a:solidFill>
+                        <a:srgbClr val="FFFFFF"/>
+                      </a:solidFill>
+                      <a:prstDash val="solid"/>
+                      <a:round/>
+                      <a:headEnd type="none" w="med" len="med"/>
+                      <a:tailEnd type="none" w="med" len="med"/>
+                    </a:lnR>
+                    <a:lnT w="12700" cap="flat" cmpd="sng" algn="ctr">
+                      <a:solidFill>
+                        <a:srgbClr val="FFFFFF"/>
+                      </a:solidFill>
+                      <a:prstDash val="solid"/>
+                      <a:round/>
+                      <a:headEnd type="none" w="med" len="med"/>
+                      <a:tailEnd type="none" w="med" len="med"/>
+                    </a:lnT>
+                    <a:lnB w="12700" cap="flat" cmpd="sng" algn="ctr">
+                      <a:solidFill>
+                        <a:srgbClr val="FFFFFF"/>
+                      </a:solidFill>
+                      <a:prstDash val="solid"/>
+                      <a:round/>
+                      <a:headEnd type="none" w="med" len="med"/>
+                      <a:tailEnd type="none" w="med" len="med"/>
+                    </a:lnB>
+                    <a:solidFill>
+                      <a:srgbClr val="FFFFFF"/>
+                    </a:solidFill>
+                  </a:tcPr>
+                </a:tc>
+              </a:tr>
+              <a:tr h="246888">
+                <a:tc>
+                  <a:txBody>
+                    <a:bodyPr/>
+                    <a:lstStyle/>
+                    <a:p>
+                      <a:pPr algn="l" indent="0" marL="0">
+                        <a:buNone/>
+                      </a:pPr>
+                      <a:r>
+                        <a:rPr lang="en-US" sz="1200" b="1" dirty="0">
+                          <a:solidFill>
+                            <a:srgbClr val="1B2233"/>
+                          </a:solidFill>
+                        </a:rPr>
+                        <a:t>head direction</a:t>
+                      </a:r>
+                      <a:endParaRPr lang="en-US" sz="1200" dirty="0"/>
+                    </a:p>
+                  </a:txBody>
+                  <a:tcPr marL="54864" marR="54864" marT="18288" marB="18288" anchor="ctr">
+                    <a:lnL w="12700" cap="flat" cmpd="sng" algn="ctr">
+                      <a:solidFill>
+                        <a:srgbClr val="FFFFFF"/>
+                      </a:solidFill>
+                      <a:prstDash val="solid"/>
+                      <a:round/>
+                      <a:headEnd type="none" w="med" len="med"/>
+                      <a:tailEnd type="none" w="med" len="med"/>
+                    </a:lnL>
+                    <a:lnR w="12700" cap="flat" cmpd="sng" algn="ctr">
+                      <a:solidFill>
+                        <a:srgbClr val="FFFFFF"/>
+                      </a:solidFill>
+                      <a:prstDash val="solid"/>
+                      <a:round/>
+                      <a:headEnd type="none" w="med" len="med"/>
+                      <a:tailEnd type="none" w="med" len="med"/>
+                    </a:lnR>
+                    <a:lnT w="12700" cap="flat" cmpd="sng" algn="ctr">
+                      <a:solidFill>
+                        <a:srgbClr val="FFFFFF"/>
+                      </a:solidFill>
+                      <a:prstDash val="solid"/>
+                      <a:round/>
+                      <a:headEnd type="none" w="med" len="med"/>
+                      <a:tailEnd type="none" w="med" len="med"/>
+                    </a:lnT>
+                    <a:lnB w="12700" cap="flat" cmpd="sng" algn="ctr">
+                      <a:solidFill>
+                        <a:srgbClr val="FFFFFF"/>
+                      </a:solidFill>
+                      <a:prstDash val="solid"/>
+                      <a:round/>
+                      <a:headEnd type="none" w="med" len="med"/>
+                      <a:tailEnd type="none" w="med" len="med"/>
+                    </a:lnB>
+                    <a:solidFill>
+                      <a:srgbClr val="EEF2F7"/>
+                    </a:solidFill>
+                  </a:tcPr>
+                </a:tc>
+                <a:tc>
+                  <a:txBody>
+                    <a:bodyPr/>
+                    <a:lstStyle/>
+                    <a:p>
+                      <a:pPr algn="ctr" indent="0" marL="0">
+                        <a:buNone/>
+                      </a:pPr>
+                      <a:r>
+                        <a:rPr lang="en-US" sz="1200" dirty="0">
+                          <a:solidFill>
+                            <a:srgbClr val="1B2233"/>
+                          </a:solidFill>
+                        </a:rPr>
+                        <a:t>12.0°</a:t>
+                      </a:r>
+                      <a:endParaRPr lang="en-US" sz="1200" dirty="0"/>
+                    </a:p>
+                  </a:txBody>
+                  <a:tcPr marL="54864" marR="54864" marT="18288" marB="18288" anchor="ctr">
+                    <a:lnL w="12700" cap="flat" cmpd="sng" algn="ctr">
+                      <a:solidFill>
+                        <a:srgbClr val="FFFFFF"/>
+                      </a:solidFill>
+                      <a:prstDash val="solid"/>
+                      <a:round/>
+                      <a:headEnd type="none" w="med" len="med"/>
+                      <a:tailEnd type="none" w="med" len="med"/>
+                    </a:lnL>
+                    <a:lnR w="12700" cap="flat" cmpd="sng" algn="ctr">
+                      <a:solidFill>
+                        <a:srgbClr val="FFFFFF"/>
+                      </a:solidFill>
+                      <a:prstDash val="solid"/>
+                      <a:round/>
+                      <a:headEnd type="none" w="med" len="med"/>
+                      <a:tailEnd type="none" w="med" len="med"/>
+                    </a:lnR>
+                    <a:lnT w="12700" cap="flat" cmpd="sng" algn="ctr">
+                      <a:solidFill>
+                        <a:srgbClr val="FFFFFF"/>
+                      </a:solidFill>
+                      <a:prstDash val="solid"/>
+                      <a:round/>
+                      <a:headEnd type="none" w="med" len="med"/>
+                      <a:tailEnd type="none" w="med" len="med"/>
+                    </a:lnT>
+                    <a:lnB w="12700" cap="flat" cmpd="sng" algn="ctr">
+                      <a:solidFill>
+                        <a:srgbClr val="FFFFFF"/>
+                      </a:solidFill>
+                      <a:prstDash val="solid"/>
+                      <a:round/>
+                      <a:headEnd type="none" w="med" len="med"/>
+                      <a:tailEnd type="none" w="med" len="med"/>
+                    </a:lnB>
+                    <a:solidFill>
+                      <a:srgbClr val="EEF2F7"/>
+                    </a:solidFill>
+                  </a:tcPr>
+                </a:tc>
+                <a:tc>
+                  <a:txBody>
+                    <a:bodyPr/>
+                    <a:lstStyle/>
+                    <a:p>
+                      <a:pPr algn="ctr" indent="0" marL="0">
+                        <a:buNone/>
+                      </a:pPr>
+                      <a:r>
+                        <a:rPr lang="en-US" sz="1200" b="1" dirty="0">
+                          <a:solidFill>
+                            <a:srgbClr val="C0392B"/>
+                          </a:solidFill>
+                        </a:rPr>
+                        <a:t>19.1°</a:t>
+                      </a:r>
+                      <a:endParaRPr lang="en-US" sz="1200" dirty="0"/>
+                    </a:p>
+                  </a:txBody>
+                  <a:tcPr marL="54864" marR="54864" marT="18288" marB="18288" anchor="ctr">
+                    <a:lnL w="12700" cap="flat" cmpd="sng" algn="ctr">
+                      <a:solidFill>
+                        <a:srgbClr val="FFFFFF"/>
+                      </a:solidFill>
+                      <a:prstDash val="solid"/>
+                      <a:round/>
+                      <a:headEnd type="none" w="med" len="med"/>
+                      <a:tailEnd type="none" w="med" len="med"/>
+                    </a:lnL>
+                    <a:lnR w="12700" cap="flat" cmpd="sng" algn="ctr">
+                      <a:solidFill>
+                        <a:srgbClr val="FFFFFF"/>
+                      </a:solidFill>
+                      <a:prstDash val="solid"/>
+                      <a:round/>
+                      <a:headEnd type="none" w="med" len="med"/>
+                      <a:tailEnd type="none" w="med" len="med"/>
+                    </a:lnR>
+                    <a:lnT w="12700" cap="flat" cmpd="sng" algn="ctr">
+                      <a:solidFill>
+                        <a:srgbClr val="FFFFFF"/>
+                      </a:solidFill>
+                      <a:prstDash val="solid"/>
+                      <a:round/>
+                      <a:headEnd type="none" w="med" len="med"/>
+                      <a:tailEnd type="none" w="med" len="med"/>
+                    </a:lnT>
+                    <a:lnB w="12700" cap="flat" cmpd="sng" algn="ctr">
+                      <a:solidFill>
+                        <a:srgbClr val="FFFFFF"/>
+                      </a:solidFill>
+                      <a:prstDash val="solid"/>
+                      <a:round/>
+                      <a:headEnd type="none" w="med" len="med"/>
+                      <a:tailEnd type="none" w="med" len="med"/>
+                    </a:lnB>
+                    <a:solidFill>
+                      <a:srgbClr val="EEF2F7"/>
+                    </a:solidFill>
+                  </a:tcPr>
+                </a:tc>
+                <a:tc>
+                  <a:txBody>
+                    <a:bodyPr/>
+                    <a:lstStyle/>
+                    <a:p>
+                      <a:pPr algn="ctr" indent="0" marL="0">
+                        <a:buNone/>
+                      </a:pPr>
+                      <a:r>
+                        <a:rPr lang="en-US" sz="1200" dirty="0">
+                          <a:solidFill>
+                            <a:srgbClr val="1B2233"/>
+                          </a:solidFill>
+                        </a:rPr>
+                        <a:t>14.4°</a:t>
+                      </a:r>
+                      <a:endParaRPr lang="en-US" sz="1200" dirty="0"/>
+                    </a:p>
+                  </a:txBody>
+                  <a:tcPr marL="54864" marR="54864" marT="18288" marB="18288" anchor="ctr">
+                    <a:lnL w="12700" cap="flat" cmpd="sng" algn="ctr">
+                      <a:solidFill>
+                        <a:srgbClr val="FFFFFF"/>
+                      </a:solidFill>
+                      <a:prstDash val="solid"/>
+                      <a:round/>
+                      <a:headEnd type="none" w="med" len="med"/>
+                      <a:tailEnd type="none" w="med" len="med"/>
+                    </a:lnL>
+                    <a:lnR w="12700" cap="flat" cmpd="sng" algn="ctr">
+                      <a:solidFill>
+                        <a:srgbClr val="FFFFFF"/>
+                      </a:solidFill>
+                      <a:prstDash val="solid"/>
+                      <a:round/>
+                      <a:headEnd type="none" w="med" len="med"/>
+                      <a:tailEnd type="none" w="med" len="med"/>
+                    </a:lnR>
+                    <a:lnT w="12700" cap="flat" cmpd="sng" algn="ctr">
+                      <a:solidFill>
+                        <a:srgbClr val="FFFFFF"/>
+                      </a:solidFill>
+                      <a:prstDash val="solid"/>
+                      <a:round/>
+                      <a:headEnd type="none" w="med" len="med"/>
+                      <a:tailEnd type="none" w="med" len="med"/>
+                    </a:lnT>
+                    <a:lnB w="12700" cap="flat" cmpd="sng" algn="ctr">
+                      <a:solidFill>
+                        <a:srgbClr val="FFFFFF"/>
+                      </a:solidFill>
+                      <a:prstDash val="solid"/>
+                      <a:round/>
+                      <a:headEnd type="none" w="med" len="med"/>
+                      <a:tailEnd type="none" w="med" len="med"/>
+                    </a:lnB>
+                    <a:solidFill>
+                      <a:srgbClr val="D3ECEE"/>
+                    </a:solidFill>
+                  </a:tcPr>
+                </a:tc>
+                <a:tc>
+                  <a:txBody>
+                    <a:bodyPr/>
+                    <a:lstStyle/>
+                    <a:p>
+                      <a:pPr algn="ctr" indent="0" marL="0">
+                        <a:buNone/>
+                      </a:pPr>
+                      <a:r>
+                        <a:rPr lang="en-US" sz="1200" dirty="0">
+                          <a:solidFill>
+                            <a:srgbClr val="1B2233"/>
+                          </a:solidFill>
+                        </a:rPr>
+                        <a:t>13.8°</a:t>
+                      </a:r>
+                      <a:endParaRPr lang="en-US" sz="1200" dirty="0"/>
+                    </a:p>
+                  </a:txBody>
+                  <a:tcPr marL="54864" marR="54864" marT="18288" marB="18288" anchor="ctr">
                     <a:lnL w="12700" cap="flat" cmpd="sng" algn="ctr">
                       <a:solidFill>
                         <a:srgbClr val="FFFFFF"/>
@@ -18817,8 +19428,8 @@
         </p:nvSpPr>
         <p:spPr>
           <a:xfrm>
-            <a:off x="457200" y="3529584"/>
-            <a:ext cx="4434840" cy="365760"/>
+            <a:off x="457200" y="3127248"/>
+            <a:ext cx="4846320" cy="548640"/>
           </a:xfrm>
           <a:prstGeom prst="rect">
             <a:avLst/>
@@ -18839,7 +19450,7 @@
                   <a:schemeClr val="tx2"/>
                 </a:solidFill>
               </a:rPr>
-              <a:t>Bone rows: median angle vs parent bone. Head direction: whole head. Thickness: neck-skin radius. Neck-skin error: centred at neck01.</a:t>
+              <a:t>Bones: median error vs truth, relative to the parent bone. Thickness: neck-skin radius, predicted / true. Neck-skin error: centred at neck01. Head direction: error of the whole head's direction.</a:t>
             </a:r>
             <a:endParaRPr lang="en-US" sz="1100" dirty="0"/>
           </a:p>
@@ -18853,8 +19464,8 @@
         </p:nvSpPr>
         <p:spPr>
           <a:xfrm>
-            <a:off x="5120640" y="1188720"/>
-            <a:ext cx="3566160" cy="2670048"/>
+            <a:off x="5532120" y="1188720"/>
+            <a:ext cx="3154680" cy="2670048"/>
           </a:xfrm>
           <a:prstGeom prst="rect">
             <a:avLst/>
@@ -18868,7 +19479,7 @@
           <a:p>
             <a:pPr marL="177800" indent="-177800">
               <a:spcAft>
-                <a:spcPts val="600"/>
+                <a:spcPts val="500"/>
               </a:spcAft>
               <a:buSzPct val="100000"/>
               <a:buChar char="•"/>
@@ -18879,7 +19490,7 @@
                   <a:schemeClr val="tx1"/>
                 </a:solidFill>
               </a:rPr>
-              <a:t>Since the first training stage: </a:t>
+              <a:t>Cause, measured: </a:t>
             </a:r>
             <a:r>
               <a:rPr lang="en-US" sz="1200" dirty="0">
@@ -18887,14 +19498,14 @@
                   <a:schemeClr val="tx1"/>
                 </a:solidFill>
               </a:rPr>
-              <a:t>already in frozen_bb_v2, unchanged in v3, v4, v5, v9 and every pilot checked.</a:t>
+              <a:t>in all 8 v5-line checkpoints, neck02 and head sit half a turn off. They cancel, so PVE hid it, but the neck skin is half as thick.</a:t>
             </a:r>
             <a:endParaRPr lang="en-US" sz="1200" dirty="0"/>
           </a:p>
           <a:p>
             <a:pPr marL="177800" indent="-177800">
               <a:spcAft>
-                <a:spcPts val="600"/>
+                <a:spcPts val="500"/>
               </a:spcAft>
               <a:buSzPct val="100000"/>
               <a:buChar char="•"/>
@@ -18905,7 +19516,7 @@
                   <a:schemeClr val="tx1"/>
                 </a:solidFill>
               </a:rPr>
-              <a:t>Hidden: </a:t>
+              <a:t>Fix (exp6): </a:t>
             </a:r>
             <a:r>
               <a:rPr lang="en-US" sz="1200" dirty="0">
@@ -18913,14 +19524,14 @@
                   <a:schemeClr val="tx1"/>
                 </a:solidFill>
               </a:rPr>
-              <a:t>the two half-turns cancel, so the whole head still points the right way (12–15° off); body PVE and head direction missed it, only per-bone angles (last week's 63° / 90°) showed it.</a:t>
+              <a:t>one constant turn of about 179° per flipped bone at the network output, estimated on 200 training images. It also turns back two hand bones (slide 8).</a:t>
             </a:r>
             <a:endParaRPr lang="en-US" sz="1200" dirty="0"/>
           </a:p>
           <a:p>
             <a:pPr marL="177800" indent="-177800">
               <a:spcAft>
-                <a:spcPts val="600"/>
+                <a:spcPts val="500"/>
               </a:spcAft>
               <a:buSzPct val="100000"/>
               <a:buChar char="•"/>
@@ -18931,7 +19542,7 @@
                   <a:schemeClr val="tx1"/>
                 </a:solidFill>
               </a:rPr>
-              <a:t>Same thing elsewhere: </a:t>
+              <a:t>Fix, no training: </a:t>
             </a:r>
             <a:r>
               <a:rPr lang="en-US" sz="1200" dirty="0">
@@ -18939,14 +19550,14 @@
                   <a:schemeClr val="tx1"/>
                 </a:solidFill>
               </a:rPr>
-              <a:t>v5 left index base at 180°; v10: left shoulder, left upper arm and 3 hand bones (1 left, 2 right).</a:t>
+              <a:t>head direction fails its 15° limit; likely a per-person head offset.</a:t>
             </a:r>
             <a:endParaRPr lang="en-US" sz="1200" dirty="0"/>
           </a:p>
           <a:p>
             <a:pPr marL="177800" indent="-177800">
               <a:spcAft>
-                <a:spcPts val="600"/>
+                <a:spcPts val="500"/>
               </a:spcAft>
               <a:buSzPct val="100000"/>
               <a:buChar char="•"/>
@@ -18957,7 +19568,7 @@
                   <a:schemeClr val="tx1"/>
                 </a:solidFill>
               </a:rPr>
-              <a:t>Fine-tuning does not undo it: </a:t>
+              <a:t>Fix + 2-epoch fine-tune: </a:t>
             </a:r>
             <a:r>
               <a:rPr lang="en-US" sz="1200" dirty="0">
@@ -18965,7 +19576,7 @@
                   <a:schemeClr val="tx1"/>
                 </a:solidFill>
               </a:rPr>
-              <a:t>2 epochs with a geodesic loss, 175.6 → 175.0°; likely because both bones must turn back together.</a:t>
+              <a:t>passes the fine-tune checks, each within a tolerance of its control.</a:t>
             </a:r>
             <a:endParaRPr lang="en-US" sz="1200" dirty="0"/>
           </a:p>
@@ -19013,11 +19624,11 @@
             <a:avLst/>
           </a:prstGeom>
           <a:solidFill>
-            <a:schemeClr val="accent3"/>
+            <a:schemeClr val="accent2"/>
           </a:solidFill>
           <a:ln w="12700">
             <a:solidFill>
-              <a:schemeClr val="accent3"/>
+              <a:schemeClr val="accent2"/>
             </a:solidFill>
             <a:prstDash val="solid"/>
           </a:ln>
@@ -19053,7 +19664,7 @@
                   <a:srgbClr val="1B2233"/>
                 </a:solidFill>
               </a:rPr>
-              <a:t>Measured (what): </a:t>
+              <a:t>Caveat: </a:t>
             </a:r>
             <a:r>
               <a:rPr lang="en-US" sz="1200" dirty="0">
@@ -19061,7 +19672,7 @@
                   <a:schemeClr val="tx1"/>
                 </a:solidFill>
               </a:rPr>
-              <a:t>neck02 and head each sit about half a turn off, in 100% of the holdout people; not yet rendered.</a:t>
+              <a:t>one run, no fixed seed (identical runs differ by up to 7.6 mm PVE), so no PVE gain is claimed.</a:t>
             </a:r>
             <a:endParaRPr lang="en-US" sz="1200" dirty="0"/>
           </a:p>
@@ -19122,7 +19733,7 @@
                   <a:srgbClr val="1B2233"/>
                 </a:solidFill>
               </a:rPr>
-              <a:t>Open (why): </a:t>
+              <a:t>Open: </a:t>
             </a:r>
             <a:r>
               <a:rPr lang="en-US" sz="1200" dirty="0">
@@ -19130,7 +19741,7 @@
                   <a:schemeClr val="tx1"/>
                 </a:solidFill>
               </a:rPr>
-              <a:t>unknown. The singular start value of the rotation output would give a tilt flip (index base), not this twist.</a:t>
+              <a:t>why the bones flipped; whether the fix looks right (renders not yet viewed, no real photos yet).</a:t>
             </a:r>
             <a:endParaRPr lang="en-US" sz="1200" dirty="0"/>
           </a:p>
@@ -19191,7 +19802,7 @@
                   <a:srgbClr val="1B2233"/>
                 </a:solidFill>
               </a:rPr>
-              <a:t>Next (exp6): </a:t>
+              <a:t>Next: </a:t>
             </a:r>
             <a:r>
               <a:rPr lang="en-US" sz="1200" dirty="0">
@@ -19199,7 +19810,7 @@
                   <a:schemeClr val="tx1"/>
                 </a:solidFill>
               </a:rPr>
-              <a:t>a fixed output correction for the flipped bones, tested with zero training.</a:t>
+              <a:t>real-photo demo of the fine-tuned fixed checkpoint; a longer fine-tune with the fix.</a:t>
             </a:r>
             <a:endParaRPr lang="en-US" sz="1200" dirty="0"/>
           </a:p>
@@ -19307,7 +19918,7 @@
                   <a:schemeClr val="tx1"/>
                 </a:solidFill>
               </a:rPr>
-              <a:t>Fingers: test-time zoom and a loss rebalance do not help</a:t>
+              <a:t>Fingers: about half the error was two flipped bones</a:t>
             </a:r>
             <a:endParaRPr lang="en-US" sz="2700" dirty="0"/>
           </a:p>
@@ -19315,7 +19926,7 @@
       </p:sp>
       <p:sp>
         <p:nvSpPr>
-          <p:cNvPr id="3" name="stat finger error with predicted fingers"/>
+          <p:cNvPr id="3" name="stat finger error, v5 with predicted fingers"/>
           <p:cNvSpPr txBox="1"/>
           <p:nvPr/>
         </p:nvSpPr>
@@ -19351,7 +19962,7 @@
       </p:sp>
       <p:sp>
         <p:nvSpPr>
-          <p:cNvPr id="4" name="label finger error with predicted fingers"/>
+          <p:cNvPr id="4" name="label finger error, v5 with predicted fingers"/>
           <p:cNvSpPr txBox="1"/>
           <p:nvPr/>
         </p:nvSpPr>
@@ -19379,7 +19990,7 @@
                   <a:schemeClr val="tx2"/>
                 </a:solidFill>
               </a:rPr>
-              <a:t>finger error with predicted fingers</a:t>
+              <a:t>finger error, v5 with predicted fingers</a:t>
             </a:r>
             <a:endParaRPr lang="en-US" sz="1300" dirty="0"/>
           </a:p>
@@ -19387,7 +19998,7 @@
       </p:sp>
       <p:sp>
         <p:nvSpPr>
-          <p:cNvPr id="5" name="stat finger error with fingers set to rest pose"/>
+          <p:cNvPr id="5" name="stat with the bone fix, fine-tuned 2 epochs (8.2° with no training)"/>
           <p:cNvSpPr txBox="1"/>
           <p:nvPr/>
         </p:nvSpPr>
@@ -19415,7 +20026,7 @@
                   <a:schemeClr val="accent3"/>
                 </a:solidFill>
               </a:rPr>
-              <a:t>15.1°</a:t>
+              <a:t>8.3°</a:t>
             </a:r>
             <a:endParaRPr lang="en-US" sz="4000" dirty="0"/>
           </a:p>
@@ -19423,7 +20034,7 @@
       </p:sp>
       <p:sp>
         <p:nvSpPr>
-          <p:cNvPr id="6" name="label finger error with fingers set to rest pose"/>
+          <p:cNvPr id="6" name="label with the bone fix, fine-tuned 2 epochs (8.2° with no training)"/>
           <p:cNvSpPr txBox="1"/>
           <p:nvPr/>
         </p:nvSpPr>
@@ -19451,7 +20062,7 @@
                   <a:schemeClr val="tx2"/>
                 </a:solidFill>
               </a:rPr>
-              <a:t>finger error with fingers set to rest pose</a:t>
+              <a:t>with the bone fix, fine-tuned 2 epochs (8.2° with no training)</a:t>
             </a:r>
             <a:endParaRPr lang="en-US" sz="1300" dirty="0"/>
           </a:p>
@@ -19459,7 +20070,7 @@
       </p:sp>
       <p:sp>
         <p:nvSpPr>
-          <p:cNvPr id="7" name="stat change when the person is magnified at test time (no retraining)"/>
+          <p:cNvPr id="7" name="stat fingers set to rest pose, before the fix (the index-base flip stays)"/>
           <p:cNvSpPr txBox="1"/>
           <p:nvPr/>
         </p:nvSpPr>
@@ -19487,7 +20098,7 @@
                   <a:schemeClr val="accent5"/>
                 </a:solidFill>
               </a:rPr>
-              <a:t>0.1°</a:t>
+              <a:t>15.1°</a:t>
             </a:r>
             <a:endParaRPr lang="en-US" sz="4000" dirty="0"/>
           </a:p>
@@ -19495,7 +20106,7 @@
       </p:sp>
       <p:sp>
         <p:nvSpPr>
-          <p:cNvPr id="8" name="label change when the person is magnified at test time (no retraining)"/>
+          <p:cNvPr id="8" name="label fingers set to rest pose, before the fix (the index-base flip stays)"/>
           <p:cNvSpPr txBox="1"/>
           <p:nvPr/>
         </p:nvSpPr>
@@ -19523,7 +20134,7 @@
                   <a:schemeClr val="tx2"/>
                 </a:solidFill>
               </a:rPr>
-              <a:t>change when the person is magnified at test time (no retraining)</a:t>
+              <a:t>fingers set to rest pose, before the fix (the index-base flip stays)</a:t>
             </a:r>
             <a:endParaRPr lang="en-US" sz="1300" dirty="0"/>
           </a:p>
@@ -20369,7 +20980,7 @@
                   <a:schemeClr val="tx1"/>
                 </a:solidFill>
               </a:rPr>
-              <a:t>What it means: </a:t>
+              <a:t>Two flipped bones: </a:t>
             </a:r>
             <a:r>
               <a:rPr lang="en-US" sz="1200" dirty="0">
@@ -20377,7 +20988,7 @@
                   <a:schemeClr val="tx1"/>
                 </a:solidFill>
               </a:rPr>
-              <a:t>predicting fingers is worse than leaving them at rest.</a:t>
+              <a:t>left index base and finger4-1.R, each about half a turn off. Turning them back halves the error; not yet checked by eye.</a:t>
             </a:r>
             <a:endParaRPr lang="en-US" sz="1200" dirty="0"/>
           </a:p>
@@ -20424,7 +21035,7 @@
                   <a:schemeClr val="tx1"/>
                 </a:solidFill>
               </a:rPr>
-              <a:t>(hands 33% of the rotation loss): 17.5° vs 17.4°. It gave fingers less weight; more weight and training on larger hand crops are still untested.</a:t>
+              <a:t>(hands 33% of the rotation loss): 17.5° vs 17.4°.</a:t>
             </a:r>
             <a:endParaRPr lang="en-US" sz="1200" dirty="0"/>
           </a:p>
@@ -20875,7 +21486,7 @@
                   <a:schemeClr val="tx1"/>
                 </a:solidFill>
               </a:rPr>
-              <a:t>a synthetic-to-real gap, plus an old-age bias even on training children. One 2-epoch test is not enough to call it a limitation.</a:t>
+              <a:t>a synthetic-to-real gap, plus an old-age bias even on training children. One 2-epoch test cannot settle it.</a:t>
             </a:r>
             <a:endParaRPr lang="en-US" sz="1200" dirty="0"/>
           </a:p>

</xml_diff>

<commit_message>
WIP: converter fix flags, neck before/after slide, handover (verification in progress, not for main yet)
Co-Authored-By: Claude Opus 5.5 <noreply@anthropic.com>
Claude-Session: https://claude.ai/code/session_016LhpG4kT7Z7ppxbG4TW5S9
</commit_message>
<xml_diff>
--- a/docs/supervisor_update_2026-10-16.pptx
+++ b/docs/supervisor_update_2026-10-16.pptx
@@ -124,7 +124,7 @@
   <p:extLst>
     <p:ext uri="{521415D9-36F7-43E2-AB2F-B90AF26B5E84}">
       <p14:sectionLst xmlns:p14="http://schemas.microsoft.com/office/powerpoint/2010/main">
-        <p14:section name="Overview" id="{6ade6bb9-5581-af90-1f67-c5f888fa88c3}">
+        <p14:section name="Overview" id="{b9ca40a5-9096-e7e1-ce92-268dec35fb71}">
           <p14:sldIdLst>
             <p14:sldId id="256"/>
             <p14:sldId id="257"/>
@@ -132,13 +132,13 @@
             <p14:sldId id="259"/>
           </p14:sldIdLst>
         </p14:section>
-        <p14:section name="3DPW labels" id="{0b53982a-e35c-4883-a861-479acf281736}">
+        <p14:section name="3DPW labels" id="{a89b1ef6-396b-ad3d-fd3f-f28f4a254c6c}">
           <p14:sldIdLst>
             <p14:sldId id="260"/>
             <p14:sldId id="261"/>
           </p14:sldIdLst>
         </p14:section>
-        <p14:section name="Findings" id="{bf21a552-33ee-8fb8-63a3-288fe5817619}">
+        <p14:section name="Findings" id="{5a94d1db-aa60-94f9-ccab-5234ba84cfe4}">
           <p14:sldIdLst>
             <p14:sldId id="262"/>
             <p14:sldId id="263"/>
@@ -146,14 +146,14 @@
             <p14:sldId id="265"/>
           </p14:sldIdLst>
         </p14:section>
-        <p14:section name="Bug" id="{74a88fb8-04e6-6ec7-79b8-fa40febb9d78}">
+        <p14:section name="Bug" id="{ef95e2d9-a7e6-3df6-fe9b-1f088e12768a}">
           <p14:sldIdLst>
             <p14:sldId id="266"/>
             <p14:sldId id="267"/>
             <p14:sldId id="268"/>
           </p14:sldIdLst>
         </p14:section>
-        <p14:section name="Next" id="{746dc5f2-5356-d070-c606-0d5d7f83659e}">
+        <p14:section name="Next" id="{7a7a1ecd-255f-eb88-a9f2-deffc38a9aa2}">
           <p14:sldIdLst>
             <p14:sldId id="269"/>
             <p14:sldId id="270"/>
@@ -161,7 +161,7 @@
             <p14:sldId id="272"/>
           </p14:sldIdLst>
         </p14:section>
-        <p14:section name="Appendix" id="{8d4f756f-2afd-c968-e815-9a8dae7f009d}">
+        <p14:section name="Appendix" id="{5f27f25d-278c-0bab-dce9-2427167e8c86}">
           <p14:sldIdLst>
             <p14:sldId id="273"/>
           </p14:sldIdLst>
@@ -1119,7 +1119,7 @@
           <a:p>
             <a:r>
               <a:rPr lang="en-US" dirty="0"/>
-              <a:t>Some corrections are already in. The headline AnnyOne number is 70.5 millimetres, measured with the helper bones masked, as in the demos. That is the evaluation setting V1, not the demo's own number: the demo setting gives 68.5 at a lower recall. The 74 millimetres in the thesis draft came from the unmasked evaluation; on the same people that adds 3.8 millimetres. The README already uses 70.5; the thesis draft I still have to change. The demos now say that the fingers are the rest pose. The text no longer blames the rig. The Known-defects section in the README documents the depth bug. But the README, the findings and the handover documents still carry last week's neck story, that the long neck comes from weak supervision and from the depth bug, and some old depth wording, for example that the overlays look wrong and that no improvement is claimed yet. I will correct them next week. The repository is reorganised with everything scripted, so any of these numbers can be produced again.</a:t>
+              <a:t>Some corrections are already in. The headline AnnyOne number is 70.5 millimetres, measured with the helper bones masked, as in the demos. That is the evaluation setting V1, not the demo's own number: the demo setting gives 68.5 at a lower recall. The 74 millimetres in the thesis draft came from the unmasked evaluation; on the same people that adds 3.8 millimetres. The README already uses 70.5; the thesis draft I still have to change. The demos now say that the fingers are the rest pose. The text no longer blames the rig. The Known-defects section in the README documents the depth bug. But the README and the findings document still carry last week's neck story, that the long neck comes from weak supervision and from the depth bug, and some old depth wording, for example that the overlays look wrong and that no improvement is claimed yet. I will correct them next week. The repository is reorganised with everything scripted, so any of these numbers can be produced again.</a:t>
             </a:r>
           </a:p>
         </p:txBody>
@@ -1215,7 +1215,7 @@
           <a:p>
             <a:r>
               <a:rPr lang="en-US" dirty="0"/>
-              <a:t>If asked: Neck: the fine-tuned checkpoint carries the fix in its saved settings, so the demo applies it on load; I copy it next to the other demo models and add it to the demo comparison script. In the 12 side-by-side holdout panels the corrected necks have normal width wherever a neck is visible (slide 8). v10: correcting three of its flipped hand bones passed without training; two more finger bones, seen on training images, are not corrected yet; shoulder01.L at 166 degrees and upperarm02.L at 180 stay flipped, because one constant per bone would break the chain that compensates them. Depth: the training depths so far come from small samples, batch means of about 2.5 to 3.2 metres. I will also measure the fix run's slope on training images; for v5 it was just as low there. Cost: I will report the root error next to PVE in the thesis. Testing the depth fix on 3DPW waits for item seven. The twenty-times 10-epoch run has no result yet. Close people: both models miss them in 4 of the 12 rendered images. Children and fingers: one 2-epoch test is not enough to close them. 3DPW labels: the rebuild, into a new folder, gave the same counts, so my old guess that the builder ran before the fits finished is wrong. The builder skips every frame without an image file. The check is one file count per image folder of the eight affected sequences; if they are empty or short, I unzip the 3DPW images again and rebuild. Gender and the frame grid are different: set men to 0 and, by Anny's convention, women to 1; the refit confirmed it only for men. And pick both people's frames on one shared grid. Both happen inside the fit, so all 87 conversion tasks must be fitted again, into a new folder, because the task script skips every person that already has a file; otherwise old and new fits would mix without a warning. That is an 87-task array job: about 40 GPU hours by the task script's own estimate of 6 seconds per frame, so 5 to 6 hours with 8 GPUs at once; not measured. Then rebuild the labels and run the check again.</a:t>
+              <a:t>If asked: Neck: the fine-tuned checkpoint carries the fix in its saved settings, so the demo applies it on load; I copy it next to the other demo models and add it to the demo comparison script. In the 12 side-by-side holdout panels, with the correction alone and no training, the necks have normal width wherever a neck is visible (slide 8). v10: correcting three of its flipped hand bones passed without training; two more finger bones, seen on training images, are not corrected yet; shoulder01.L at 166 degrees and upperarm02.L at 180 stay flipped, because one constant per bone would break the chain that compensates them. Depth: the training depths so far come from small samples, batch means of about 2.5 to 3.2 metres. I will also measure the fix run's slope on training images; for v5 it was just as low there. Cost: I will report the root error next to PVE in the thesis. Testing the depth fix on 3DPW waits for item seven. The twenty-times 10-epoch run has no result yet. Close people: both models miss them in 4 of the 12 rendered images. Children and fingers: one 2-epoch test is not enough to close them. 3DPW labels: the rebuild, into a new folder, gave the same counts, so my old guess that the builder ran before the fits finished is wrong. The builder skips every frame without an image file. The check is one file count per image folder of the eight affected sequences; if they are empty or short, I unzip the 3DPW images again and rebuild. Gender and the frame grid are different: set men to 0 and, by Anny's convention, women to 1; the refit confirmed it only for men. And pick both people's frames on one shared grid. Both happen inside the fit, so all 87 conversion tasks must be fitted again, into a new folder, because the task script skips every person that already has a file; otherwise old and new fits would mix without a warning. That is an 87-task array job: about 40 GPU hours by the task script's own estimate of 6 seconds per frame, so 5 to 6 hours with 8 GPUs at once; not measured. Then rebuild the labels and run the check again.</a:t>
             </a:r>
           </a:p>
         </p:txBody>
@@ -1533,7 +1533,7 @@
           <a:p>
             <a:r>
               <a:rPr lang="en-US" dirty="0"/>
-              <a:t>These are the three failures we discussed last time. Until this week they were explained by guesses: a rig problem, too few pixels on the hands, or a shape head that does not learn age. None of these guesses had been tested on its own. That is what I did first. The last line on each card is what this week showed; the details follow. For the neck, two bones in the v5 models, neck02 and the head bone, are turned half a turn, and the neck skin comes out about half as thick. A first fix, in one run, restores it; the holdout renders confirm it, real photos are still to check. For the fingers, about half of the error came from two flipped hand bones.</a:t>
+              <a:t>These are the three failures we discussed last time. Until this week they were explained by guesses: a rig problem, too few pixels on the hands, or a shape head that does not learn age. None of these guesses had been tested on its own. That is what I did first. The last line on each card is what this week showed; the details follow. For the neck, two bones in the v5 models, neck02 and the head bone, are turned half a turn, and the neck skin comes out about half as thick. A first fix, in one run, restores it; holdout renders of the correction alone, before the fine-tune, show normal necks; real photos are still to check. For the fingers, about half of the error came from two flipped hand bones.</a:t>
             </a:r>
           </a:p>
         </p:txBody>
@@ -2019,7 +2019,7 @@
           <a:p>
             <a:r>
               <a:rPr lang="en-US" dirty="0"/>
-              <a:t>In all eight v5-line checkpoints, neck02 and the head bone are about half a turn off. The two half-turns cancel, so the head still points the right way and PVE never showed it, but the neck skin comes out half as thick. I tested a fix: one constant turn per flipped bone at the network output, estimated on 200 training images. On the holdout, the fix alone turns both bones back; neck thickness goes from 0.46 to 1.00. But head direction gets worse, 19.1 degrees, likely because the head's offset differs per person. After a two-epoch fine-tune, it passes the fine-tune checks, each within a tolerance of its control; head direction is 14.4, still worse than 12.0 before. One run, no fixed seed: I claim no PVE gain, only no sign of a PVE cost, 68.8 against 76.9 for the control. The next slide shows what it looks like; real photos are not checked yet.</a:t>
+              <a:t>In all eight v5-line checkpoints, neck02 and the head bone are about half a turn off. The two half-turns cancel, so the head still points the right way and PVE never showed it, but the neck skin comes out half as thick. I tested a fix: one constant turn per flipped bone at the network output, estimated on 200 training images. On the holdout, the fix alone turns both bones back; neck thickness goes from 0.46 to 1.00. But head direction gets worse, 19.1 degrees, likely because the head's offset differs per person. After a two-epoch fine-tune, it passes the fine-tune checks, each within a tolerance of its control; head direction is 14.4, still worse than 12.0 before. One run, no fixed seed: I claim no PVE gain, only no sign of a PVE cost, 68.8 against 76.9 for the control. The next slide shows the correction alone, before the fine-tune; real photos are not checked yet.</a:t>
             </a:r>
           </a:p>
           <a:p>
@@ -2115,7 +2115,7 @@
           <a:p>
             <a:r>
               <a:rPr lang="en-US" dirty="0"/>
-              <a:t>These are two of the twelve holdout images. Left is v5 as trained. Right is the same model with the correction, no training; on the neck, only neck02 and the head are turned back. Look at the necks: on the left they are thin stalks, on the right they have normal width. That is the thickness 0.46 to 1.00 from the last slide. All twelve images show this wherever a neck is visible. Three limits. Without fine-tuning the head points 19 degrees off, against 12 before; the fine-tune brings it to 14. The bodies are still too small; that is the depth bug. Real photos are not checked yet.</a:t>
+              <a:t>These are two of the twelve holdout images. For each image, the left panel is v5 as trained and the right panel is the same model with the correction, no training; on the neck, only neck02 and the head are turned back. Look at the necks: on the left they are thin stalks, on the right they have normal width. That is the thickness 0.46 to 1.00 on slide 7, measured over all 100 holdout images. All twelve images show this wherever a neck is visible. Three limits. Without fine-tuning the head points 19 degrees off, against 12 before; the fine-tune brings it to 14. The bodies are still too small; that is the depth bug. Real photos are not checked yet.</a:t>
             </a:r>
           </a:p>
         </p:txBody>
@@ -2519,7 +2519,7 @@
           </a:extLst>
         </p:spPr>
         <p:txBody>
-          <a:bodyPr/>
+          <a:bodyPr lIns="91440" tIns="0" rIns="0" bIns="0" anchor="ctr"/>
           <a:lstStyle>
             <a:lvl1pPr>
               <a:defRPr sz="1000">
@@ -2671,7 +2671,7 @@
           </a:extLst>
         </p:spPr>
         <p:txBody>
-          <a:bodyPr/>
+          <a:bodyPr lIns="91440" tIns="0" rIns="0" bIns="0" anchor="ctr"/>
           <a:lstStyle>
             <a:lvl1pPr>
               <a:defRPr sz="1000">
@@ -2741,7 +2741,7 @@
           </a:extLst>
         </p:spPr>
         <p:txBody>
-          <a:bodyPr/>
+          <a:bodyPr lIns="91440" tIns="0" rIns="0" bIns="0" anchor="ctr"/>
           <a:lstStyle>
             <a:lvl1pPr>
               <a:defRPr sz="1000">
@@ -3647,7 +3647,7 @@
           </a:extLst>
         </p:spPr>
         <p:txBody>
-          <a:bodyPr/>
+          <a:bodyPr lIns="91440" tIns="0" rIns="0" bIns="0" anchor="ctr"/>
           <a:lstStyle>
             <a:lvl1pPr>
               <a:defRPr sz="1000">
@@ -4373,7 +4373,7 @@
           </a:extLst>
         </p:spPr>
         <p:txBody>
-          <a:bodyPr/>
+          <a:bodyPr lIns="91440" tIns="0" rIns="0" bIns="0" anchor="ctr"/>
           <a:lstStyle>
             <a:lvl1pPr>
               <a:defRPr sz="1000">
@@ -4657,7 +4657,7 @@
           </a:extLst>
         </p:spPr>
         <p:txBody>
-          <a:bodyPr/>
+          <a:bodyPr lIns="91440" tIns="0" rIns="0" bIns="0" anchor="ctr"/>
           <a:lstStyle>
             <a:lvl1pPr>
               <a:defRPr sz="1000">
@@ -9503,7 +9503,7 @@
           </a:extLst>
         </p:spPr>
         <p:txBody>
-          <a:bodyPr/>
+          <a:bodyPr lIns="91440" tIns="0" rIns="0" bIns="0" anchor="ctr"/>
           <a:lstStyle>
             <a:lvl1pPr>
               <a:defRPr sz="1000">
@@ -10944,7 +10944,7 @@
           </a:extLst>
         </p:spPr>
         <p:txBody>
-          <a:bodyPr/>
+          <a:bodyPr lIns="91440" tIns="0" rIns="0" bIns="0" anchor="ctr"/>
           <a:lstStyle>
             <a:lvl1pPr>
               <a:defRPr sz="1000">
@@ -11461,7 +11461,7 @@
                   <a:schemeClr val="tx2"/>
                 </a:solidFill>
               </a:rPr>
-              <a:t>README, findings and handover still carry last week's neck story; I will fix them next week.</a:t>
+              <a:t>README and findings still carry last week's neck story; I will fix them next week.</a:t>
             </a:r>
             <a:endParaRPr lang="en-US" sz="1200" dirty="0"/>
           </a:p>
@@ -11624,7 +11624,7 @@
           </a:extLst>
         </p:spPr>
         <p:txBody>
-          <a:bodyPr/>
+          <a:bodyPr lIns="91440" tIns="0" rIns="0" bIns="0" anchor="ctr"/>
           <a:lstStyle>
             <a:lvl1pPr>
               <a:defRPr sz="1000">
@@ -11834,7 +11834,7 @@
                   <a:schemeClr val="tx2"/>
                 </a:solidFill>
               </a:rPr>
-              <a:t>Neck: real photos, a longer run (renders confirm it: slide 8). v10's left arm: two-sided fix, not built yet.</a:t>
+              <a:t>Neck: real photos, a longer run (slide 8: no training). v10's left arm: two-sided fix, not built yet.</a:t>
             </a:r>
             <a:endParaRPr lang="en-US" sz="1200" dirty="0"/>
           </a:p>
@@ -12663,7 +12663,7 @@
           </a:extLst>
         </p:spPr>
         <p:txBody>
-          <a:bodyPr/>
+          <a:bodyPr lIns="91440" tIns="0" rIns="0" bIns="0" anchor="ctr"/>
           <a:lstStyle>
             <a:lvl1pPr>
               <a:defRPr sz="1000">
@@ -12959,7 +12959,7 @@
           </a:extLst>
         </p:spPr>
         <p:txBody>
-          <a:bodyPr/>
+          <a:bodyPr lIns="91440" tIns="0" rIns="0" bIns="0" anchor="ctr"/>
           <a:lstStyle>
             <a:lvl1pPr>
               <a:defRPr sz="1000">
@@ -13243,7 +13243,7 @@
           </a:extLst>
         </p:spPr>
         <p:txBody>
-          <a:bodyPr/>
+          <a:bodyPr lIns="91440" tIns="0" rIns="0" bIns="0" anchor="ctr"/>
           <a:lstStyle>
             <a:lvl1pPr>
               <a:defRPr sz="1000">
@@ -13777,7 +13777,7 @@
           </a:extLst>
         </p:spPr>
         <p:txBody>
-          <a:bodyPr/>
+          <a:bodyPr lIns="91440" tIns="0" rIns="0" bIns="0" anchor="ctr"/>
           <a:lstStyle>
             <a:lvl1pPr>
               <a:defRPr sz="1000">
@@ -14683,7 +14683,7 @@
           </a:extLst>
         </p:spPr>
         <p:txBody>
-          <a:bodyPr/>
+          <a:bodyPr lIns="91440" tIns="0" rIns="0" bIns="0" anchor="ctr"/>
           <a:lstStyle>
             <a:lvl1pPr>
               <a:defRPr sz="1000">
@@ -15323,7 +15323,7 @@
           </a:extLst>
         </p:spPr>
         <p:txBody>
-          <a:bodyPr/>
+          <a:bodyPr lIns="91440" tIns="0" rIns="0" bIns="0" anchor="ctr"/>
           <a:lstStyle>
             <a:lvl1pPr>
               <a:defRPr sz="1000">
@@ -16927,7 +16927,7 @@
           </a:extLst>
         </p:spPr>
         <p:txBody>
-          <a:bodyPr/>
+          <a:bodyPr lIns="91440" tIns="0" rIns="0" bIns="0" anchor="ctr"/>
           <a:lstStyle>
             <a:lvl1pPr>
               <a:defRPr sz="1000">
@@ -17721,7 +17721,7 @@
           </a:extLst>
         </p:spPr>
         <p:txBody>
-          <a:bodyPr/>
+          <a:bodyPr lIns="91440" tIns="0" rIns="0" bIns="0" anchor="ctr"/>
           <a:lstStyle>
             <a:lvl1pPr>
               <a:defRPr sz="1000">
@@ -20307,7 +20307,7 @@
                   <a:schemeClr val="tx1"/>
                 </a:solidFill>
               </a:rPr>
-              <a:t>why the bones flipped; real photos (the holdout renders confirm the neck: next slide).</a:t>
+              <a:t>why the bones flipped; real photos. Holdout renders of the fix with no training: next slide.</a:t>
             </a:r>
             <a:endParaRPr lang="en-US" sz="1200" dirty="0"/>
           </a:p>
@@ -20407,7 +20407,7 @@
           </a:extLst>
         </p:spPr>
         <p:txBody>
-          <a:bodyPr/>
+          <a:bodyPr lIns="91440" tIns="0" rIns="0" bIns="0" anchor="ctr"/>
           <a:lstStyle>
             <a:lvl1pPr>
               <a:defRPr sz="1000">
@@ -20490,9 +20490,47 @@
           </a:p>
         </p:txBody>
       </p:sp>
+      <p:sp>
+        <p:nvSpPr>
+          <p:cNvPr id="3" name="neck header 0"/>
+          <p:cNvSpPr txBox="1"/>
+          <p:nvPr/>
+        </p:nvSpPr>
+        <p:spPr>
+          <a:xfrm>
+            <a:off x="457200" y="1097280"/>
+            <a:ext cx="2189951" cy="310896"/>
+          </a:xfrm>
+          <a:prstGeom prst="rect">
+            <a:avLst/>
+          </a:prstGeom>
+          <a:solidFill>
+            <a:srgbClr val="C0392B"/>
+          </a:solidFill>
+          <a:ln/>
+        </p:spPr>
+        <p:txBody>
+          <a:bodyPr wrap="square" lIns="0" tIns="0" rIns="0" bIns="0" rtlCol="0" anchor="ctr"/>
+          <a:lstStyle/>
+          <a:p>
+            <a:pPr algn="ctr" indent="0" marL="0">
+              <a:buNone/>
+            </a:pPr>
+            <a:r>
+              <a:rPr lang="en-US" sz="1600" b="1" dirty="0">
+                <a:solidFill>
+                  <a:srgbClr val="FFFFFF"/>
+                </a:solidFill>
+              </a:rPr>
+              <a:t>Before (v5)</a:t>
+            </a:r>
+            <a:endParaRPr lang="en-US" sz="1600" dirty="0"/>
+          </a:p>
+        </p:txBody>
+      </p:sp>
       <p:pic>
         <p:nvPicPr>
-          <p:cNvPr id="3" name="figure neck_before_after_v5.jpg" descr="Holdout images 579862 and 579863: v5 as trained (left, thin necks) and with the correction on neck02 and the head (right, normal neck width)">    </p:cNvPr>
+          <p:cNvPr id="4" name="figure neck_before_after_v5.jpg 579862 before" descr="Holdout image 579862, v5 as trained: thin neck">    </p:cNvPr>
           <p:cNvPicPr>
             <a:picLocks noChangeAspect="1"/>
           </p:cNvPicPr>
@@ -20500,14 +20538,13 @@
         </p:nvPicPr>
         <p:blipFill>
           <a:blip r:embed="rId1"/>
-          <a:stretch>
-            <a:fillRect/>
-          </a:stretch>
+          <a:srcRect l="80" r="50638" t="4562" b="49106"/>
+          <a:stretch/>
         </p:blipFill>
         <p:spPr>
           <a:xfrm>
-            <a:off x="2941244" y="1024128"/>
-            <a:ext cx="3261513" cy="2907792"/>
+            <a:off x="457200" y="1408176"/>
+            <a:ext cx="2189951" cy="1835590"/>
           </a:xfrm>
           <a:prstGeom prst="rect">
             <a:avLst/>
@@ -20516,90 +20553,353 @@
       </p:pic>
       <p:sp>
         <p:nvSpPr>
-          <p:cNvPr id="4" name="neck figure caption"/>
+          <p:cNvPr id="5" name="neck header 1"/>
           <p:cNvSpPr txBox="1"/>
           <p:nvPr/>
         </p:nvSpPr>
         <p:spPr>
           <a:xfrm>
-            <a:off x="457200" y="3977640"/>
-            <a:ext cx="8229600" cy="347472"/>
+            <a:off x="2702015" y="1097280"/>
+            <a:ext cx="2189951" cy="310896"/>
           </a:xfrm>
           <a:prstGeom prst="rect">
             <a:avLst/>
           </a:prstGeom>
-          <a:noFill/>
+          <a:solidFill>
+            <a:srgbClr val="0E7C86"/>
+          </a:solidFill>
           <a:ln/>
         </p:spPr>
         <p:txBody>
-          <a:bodyPr wrap="square" lIns="0" tIns="0" rIns="0" bIns="0" rtlCol="0" anchor="t"/>
+          <a:bodyPr wrap="square" lIns="0" tIns="0" rIns="0" bIns="0" rtlCol="0" anchor="ctr"/>
           <a:lstStyle/>
           <a:p>
             <a:pPr algn="ctr" indent="0" marL="0">
               <a:buNone/>
             </a:pPr>
             <a:r>
-              <a:rPr lang="en-US" sz="1100" dirty="0">
-                <a:solidFill>
-                  <a:schemeClr val="tx1"/>
-                </a:solidFill>
-              </a:rPr>
-              <a:t>Synthetic holdout images 579862 (top) and 579863 (bottom). Same model, no training.</a:t>
-            </a:r>
-            <a:endParaRPr lang="en-US" sz="1100" dirty="0"/>
-          </a:p>
+              <a:rPr lang="en-US" sz="1600" b="1" dirty="0">
+                <a:solidFill>
+                  <a:srgbClr val="FFFFFF"/>
+                </a:solidFill>
+              </a:rPr>
+              <a:t>After (correction)</a:t>
+            </a:r>
+            <a:endParaRPr lang="en-US" sz="1600" dirty="0"/>
+          </a:p>
+        </p:txBody>
+      </p:sp>
+      <p:pic>
+        <p:nvPicPr>
+          <p:cNvPr id="6" name="figure neck_before_after_v5.jpg 579862 after" descr="Holdout image 579862, with the correction on neck02 and the head, no training: normal neck width">    </p:cNvPr>
+          <p:cNvPicPr>
+            <a:picLocks noChangeAspect="1"/>
+          </p:cNvPicPr>
+          <p:nvPr/>
+        </p:nvPicPr>
+        <p:blipFill>
+          <a:blip r:embed="rId2"/>
+          <a:srcRect l="50638" r="80" t="4562" b="49106"/>
+          <a:stretch/>
+        </p:blipFill>
+        <p:spPr>
+          <a:xfrm>
+            <a:off x="2702015" y="1408176"/>
+            <a:ext cx="2189951" cy="1835590"/>
+          </a:xfrm>
+          <a:prstGeom prst="rect">
+            <a:avLst/>
+          </a:prstGeom>
+        </p:spPr>
+      </p:pic>
+      <p:sp>
+        <p:nvSpPr>
+          <p:cNvPr id="7" name="neck header 2"/>
+          <p:cNvSpPr txBox="1"/>
+          <p:nvPr/>
+        </p:nvSpPr>
+        <p:spPr>
+          <a:xfrm>
+            <a:off x="5166286" y="1097280"/>
+            <a:ext cx="1732825" cy="310896"/>
+          </a:xfrm>
+          <a:prstGeom prst="rect">
+            <a:avLst/>
+          </a:prstGeom>
+          <a:solidFill>
+            <a:srgbClr val="C0392B"/>
+          </a:solidFill>
+          <a:ln/>
+        </p:spPr>
+        <p:txBody>
+          <a:bodyPr wrap="square" lIns="0" tIns="0" rIns="0" bIns="0" rtlCol="0" anchor="ctr"/>
+          <a:lstStyle/>
           <a:p>
             <a:pPr algn="ctr" indent="0" marL="0">
               <a:buNone/>
             </a:pPr>
             <a:r>
-              <a:rPr lang="en-US" sz="1100" dirty="0">
-                <a:solidFill>
-                  <a:schemeClr val="tx1"/>
-                </a:solidFill>
-              </a:rPr>
-              <a:t>On the neck, only the output of neck02 and the head is corrected. Neck skin thickness 0.46 → 1.00 of the true value (job 3579014).</a:t>
-            </a:r>
-            <a:endParaRPr lang="en-US" sz="1100" dirty="0"/>
-          </a:p>
-        </p:txBody>
-      </p:sp>
-      <p:sp>
-        <p:nvSpPr>
-          <p:cNvPr id="5" name="neck figure footnote"/>
+              <a:rPr lang="en-US" sz="1600" b="1" dirty="0">
+                <a:solidFill>
+                  <a:srgbClr val="FFFFFF"/>
+                </a:solidFill>
+              </a:rPr>
+              <a:t>Before (v5)</a:t>
+            </a:r>
+            <a:endParaRPr lang="en-US" sz="1600" dirty="0"/>
+          </a:p>
+        </p:txBody>
+      </p:sp>
+      <p:pic>
+        <p:nvPicPr>
+          <p:cNvPr id="8" name="figure neck_before_after_v5.jpg 579863 before" descr="Holdout image 579863, v5 as trained: thin neck">    </p:cNvPr>
+          <p:cNvPicPr>
+            <a:picLocks noChangeAspect="1"/>
+          </p:cNvPicPr>
+          <p:nvPr/>
+        </p:nvPicPr>
+        <p:blipFill>
+          <a:blip r:embed="rId3"/>
+          <a:srcRect l="5183" r="55821" t="52326" b="1342"/>
+          <a:stretch/>
+        </p:blipFill>
+        <p:spPr>
+          <a:xfrm>
+            <a:off x="5166286" y="1408176"/>
+            <a:ext cx="1732825" cy="1835590"/>
+          </a:xfrm>
+          <a:prstGeom prst="rect">
+            <a:avLst/>
+          </a:prstGeom>
+        </p:spPr>
+      </p:pic>
+      <p:sp>
+        <p:nvSpPr>
+          <p:cNvPr id="9" name="neck header 3"/>
           <p:cNvSpPr txBox="1"/>
           <p:nvPr/>
         </p:nvSpPr>
         <p:spPr>
           <a:xfrm>
-            <a:off x="457200" y="4352544"/>
-            <a:ext cx="8229600" cy="347472"/>
+            <a:off x="6953975" y="1097280"/>
+            <a:ext cx="1732825" cy="310896"/>
           </a:xfrm>
           <a:prstGeom prst="rect">
             <a:avLst/>
           </a:prstGeom>
-          <a:noFill/>
+          <a:solidFill>
+            <a:srgbClr val="0E7C86"/>
+          </a:solidFill>
           <a:ln/>
         </p:spPr>
         <p:txBody>
-          <a:bodyPr wrap="square" lIns="0" tIns="0" rIns="0" bIns="0" rtlCol="0" anchor="t"/>
+          <a:bodyPr wrap="square" lIns="0" tIns="0" rIns="0" bIns="0" rtlCol="0" anchor="ctr"/>
           <a:lstStyle/>
           <a:p>
             <a:pPr algn="ctr" indent="0" marL="0">
               <a:buNone/>
             </a:pPr>
             <a:r>
+              <a:rPr lang="en-US" sz="1600" b="1" dirty="0">
+                <a:solidFill>
+                  <a:srgbClr val="FFFFFF"/>
+                </a:solidFill>
+              </a:rPr>
+              <a:t>After (correction)</a:t>
+            </a:r>
+            <a:endParaRPr lang="en-US" sz="1600" dirty="0"/>
+          </a:p>
+        </p:txBody>
+      </p:sp>
+      <p:pic>
+        <p:nvPicPr>
+          <p:cNvPr id="10" name="figure neck_before_after_v5.jpg 579863 after" descr="Holdout image 579863, with the correction on neck02 and the head, no training: normal neck width">    </p:cNvPr>
+          <p:cNvPicPr>
+            <a:picLocks noChangeAspect="1"/>
+          </p:cNvPicPr>
+          <p:nvPr/>
+        </p:nvPicPr>
+        <p:blipFill>
+          <a:blip r:embed="rId4"/>
+          <a:srcRect l="55742" r="5263" t="52326" b="1342"/>
+          <a:stretch/>
+        </p:blipFill>
+        <p:spPr>
+          <a:xfrm>
+            <a:off x="6953975" y="1408176"/>
+            <a:ext cx="1732825" cy="1835590"/>
+          </a:xfrm>
+          <a:prstGeom prst="rect">
+            <a:avLst/>
+          </a:prstGeom>
+        </p:spPr>
+      </p:pic>
+      <p:sp>
+        <p:nvSpPr>
+          <p:cNvPr id="11" name="neck caption 579862"/>
+          <p:cNvSpPr txBox="1"/>
+          <p:nvPr/>
+        </p:nvSpPr>
+        <p:spPr>
+          <a:xfrm>
+            <a:off x="457200" y="3298630"/>
+            <a:ext cx="4434766" cy="201168"/>
+          </a:xfrm>
+          <a:prstGeom prst="rect">
+            <a:avLst/>
+          </a:prstGeom>
+          <a:noFill/>
+          <a:ln/>
+        </p:spPr>
+        <p:txBody>
+          <a:bodyPr wrap="square" lIns="0" tIns="0" rIns="0" bIns="0" rtlCol="0" anchor="t"/>
+          <a:lstStyle/>
+          <a:p>
+            <a:pPr indent="0" marL="0">
+              <a:buNone/>
+            </a:pPr>
+            <a:r>
               <a:rPr lang="en-US" sz="1100" dirty="0">
                 <a:solidFill>
+                  <a:schemeClr val="tx1"/>
+                </a:solidFill>
+              </a:rPr>
+              <a:t>Synthetic holdout image 579862</a:t>
+            </a:r>
+            <a:endParaRPr lang="en-US" sz="1100" dirty="0"/>
+          </a:p>
+        </p:txBody>
+      </p:sp>
+      <p:sp>
+        <p:nvSpPr>
+          <p:cNvPr id="12" name="neck caption 579863"/>
+          <p:cNvSpPr txBox="1"/>
+          <p:nvPr/>
+        </p:nvSpPr>
+        <p:spPr>
+          <a:xfrm>
+            <a:off x="5166286" y="3298630"/>
+            <a:ext cx="3520514" cy="201168"/>
+          </a:xfrm>
+          <a:prstGeom prst="rect">
+            <a:avLst/>
+          </a:prstGeom>
+          <a:noFill/>
+          <a:ln/>
+        </p:spPr>
+        <p:txBody>
+          <a:bodyPr wrap="square" lIns="0" tIns="0" rIns="0" bIns="0" rtlCol="0" anchor="t"/>
+          <a:lstStyle/>
+          <a:p>
+            <a:pPr indent="0" marL="0">
+              <a:buNone/>
+            </a:pPr>
+            <a:r>
+              <a:rPr lang="en-US" sz="1100" dirty="0">
+                <a:solidFill>
+                  <a:schemeClr val="tx1"/>
+                </a:solidFill>
+              </a:rPr>
+              <a:t>Synthetic holdout image 579863</a:t>
+            </a:r>
+            <a:endParaRPr lang="en-US" sz="1100" dirty="0"/>
+          </a:p>
+        </p:txBody>
+      </p:sp>
+      <p:sp>
+        <p:nvSpPr>
+          <p:cNvPr id="13" name="neck figure caption"/>
+          <p:cNvSpPr txBox="1"/>
+          <p:nvPr/>
+        </p:nvSpPr>
+        <p:spPr>
+          <a:xfrm>
+            <a:off x="457200" y="3572950"/>
+            <a:ext cx="8229600" cy="365760"/>
+          </a:xfrm>
+          <a:prstGeom prst="rect">
+            <a:avLst/>
+          </a:prstGeom>
+          <a:noFill/>
+          <a:ln/>
+        </p:spPr>
+        <p:txBody>
+          <a:bodyPr wrap="square" lIns="0" tIns="0" rIns="0" bIns="0" rtlCol="0" anchor="t"/>
+          <a:lstStyle/>
+          <a:p>
+            <a:pPr indent="0" marL="0">
+              <a:buNone/>
+            </a:pPr>
+            <a:r>
+              <a:rPr lang="en-US" sz="1100" dirty="0">
+                <a:solidFill>
+                  <a:schemeClr val="tx1"/>
+                </a:solidFill>
+              </a:rPr>
+              <a:t>Same model, no training. On the neck, only the output of neck02 and the head is corrected.</a:t>
+            </a:r>
+            <a:endParaRPr lang="en-US" sz="1100" dirty="0"/>
+          </a:p>
+          <a:p>
+            <a:pPr indent="0" marL="0">
+              <a:buNone/>
+            </a:pPr>
+            <a:r>
+              <a:rPr lang="en-US" sz="1100" dirty="0">
+                <a:solidFill>
+                  <a:schemeClr val="tx1"/>
+                </a:solidFill>
+              </a:rPr>
+              <a:t>Neck skin thickness on the 100-image holdout: 0.46 → 1.00 of the true value (job 3579014).</a:t>
+            </a:r>
+            <a:endParaRPr lang="en-US" sz="1100" dirty="0"/>
+          </a:p>
+        </p:txBody>
+      </p:sp>
+      <p:sp>
+        <p:nvSpPr>
+          <p:cNvPr id="14" name="neck figure footnote"/>
+          <p:cNvSpPr txBox="1"/>
+          <p:nvPr/>
+        </p:nvSpPr>
+        <p:spPr>
+          <a:xfrm>
+            <a:off x="457200" y="4011862"/>
+            <a:ext cx="8229600" cy="365760"/>
+          </a:xfrm>
+          <a:prstGeom prst="rect">
+            <a:avLst/>
+          </a:prstGeom>
+          <a:noFill/>
+          <a:ln/>
+        </p:spPr>
+        <p:txBody>
+          <a:bodyPr wrap="square" lIns="0" tIns="0" rIns="0" bIns="0" rtlCol="0" anchor="t"/>
+          <a:lstStyle/>
+          <a:p>
+            <a:pPr indent="0" marL="0">
+              <a:buNone/>
+            </a:pPr>
+            <a:r>
+              <a:rPr lang="en-US" sz="1100" b="1" dirty="0">
+                <a:solidFill>
+                  <a:srgbClr val="1B2233"/>
+                </a:solidFill>
+              </a:rPr>
+              <a:t>Limits: </a:t>
+            </a:r>
+            <a:r>
+              <a:rPr lang="en-US" sz="1100" dirty="0">
+                <a:solidFill>
                   <a:schemeClr val="tx2"/>
                 </a:solidFill>
               </a:rPr>
-              <a:t>Without fine-tuning the head points 19° off (12° before); the 2-epoch fine-tune brings it to 14°.</a:t>
+              <a:t>without fine-tuning the head points 19° off (12° before); the 2-epoch fine-tune brings it to 14°.</a:t>
             </a:r>
             <a:endParaRPr lang="en-US" sz="1100" dirty="0"/>
           </a:p>
           <a:p>
-            <a:pPr algn="ctr" indent="0" marL="0">
+            <a:pPr indent="0" marL="0">
               <a:buNone/>
             </a:pPr>
             <a:r>
@@ -20639,7 +20939,7 @@
           </a:extLst>
         </p:spPr>
         <p:txBody>
-          <a:bodyPr/>
+          <a:bodyPr lIns="91440" tIns="0" rIns="0" bIns="0" anchor="ctr"/>
           <a:lstStyle>
             <a:lvl1pPr>
               <a:defRPr sz="1000">
@@ -21864,7 +22164,7 @@
           </a:extLst>
         </p:spPr>
         <p:txBody>
-          <a:bodyPr/>
+          <a:bodyPr lIns="91440" tIns="0" rIns="0" bIns="0" anchor="ctr"/>
           <a:lstStyle>
             <a:lvl1pPr>
               <a:defRPr sz="1000">

</xml_diff>

<commit_message>
WIP: converter fix and deck/handover edits in progress (not for main yet)
Co-Authored-By: Claude Opus 5.5 <noreply@anthropic.com>
Claude-Session: https://claude.ai/code/session_016LhpG4kT7Z7ppxbG4TW5S9
</commit_message>
<xml_diff>
--- a/docs/supervisor_update_2026-10-16.pptx
+++ b/docs/supervisor_update_2026-10-16.pptx
@@ -124,7 +124,7 @@
   <p:extLst>
     <p:ext uri="{521415D9-36F7-43E2-AB2F-B90AF26B5E84}">
       <p14:sectionLst xmlns:p14="http://schemas.microsoft.com/office/powerpoint/2010/main">
-        <p14:section name="Overview" id="{b9ca40a5-9096-e7e1-ce92-268dec35fb71}">
+        <p14:section name="Overview" id="{1172506b-0cca-c7d9-3e6c-b0bef2618da0}">
           <p14:sldIdLst>
             <p14:sldId id="256"/>
             <p14:sldId id="257"/>
@@ -132,13 +132,13 @@
             <p14:sldId id="259"/>
           </p14:sldIdLst>
         </p14:section>
-        <p14:section name="3DPW labels" id="{a89b1ef6-396b-ad3d-fd3f-f28f4a254c6c}">
+        <p14:section name="3DPW labels" id="{ad0c0608-500d-1fe1-2f9c-352cbf9057d9}">
           <p14:sldIdLst>
             <p14:sldId id="260"/>
             <p14:sldId id="261"/>
           </p14:sldIdLst>
         </p14:section>
-        <p14:section name="Findings" id="{5a94d1db-aa60-94f9-ccab-5234ba84cfe4}">
+        <p14:section name="Findings" id="{ea43f461-02c1-76d1-6125-40ff2fd666c5}">
           <p14:sldIdLst>
             <p14:sldId id="262"/>
             <p14:sldId id="263"/>
@@ -146,14 +146,14 @@
             <p14:sldId id="265"/>
           </p14:sldIdLst>
         </p14:section>
-        <p14:section name="Bug" id="{ef95e2d9-a7e6-3df6-fe9b-1f088e12768a}">
+        <p14:section name="Bug" id="{fc60ff21-5fa8-f92d-aa53-2f3c06cb206d}">
           <p14:sldIdLst>
             <p14:sldId id="266"/>
             <p14:sldId id="267"/>
             <p14:sldId id="268"/>
           </p14:sldIdLst>
         </p14:section>
-        <p14:section name="Next" id="{7a7a1ecd-255f-eb88-a9f2-deffc38a9aa2}">
+        <p14:section name="Next" id="{e1e01bfa-b10f-a381-b468-2268d16ec325}">
           <p14:sldIdLst>
             <p14:sldId id="269"/>
             <p14:sldId id="270"/>
@@ -161,7 +161,7 @@
             <p14:sldId id="272"/>
           </p14:sldIdLst>
         </p14:section>
-        <p14:section name="Appendix" id="{5f27f25d-278c-0bab-dce9-2427167e8c86}">
+        <p14:section name="Appendix" id="{426b0dc6-0675-049a-f360-1bb1d21544d2}">
           <p14:sldIdLst>
             <p14:sldId id="273"/>
           </p14:sldIdLst>
@@ -2115,7 +2115,16 @@
           <a:p>
             <a:r>
               <a:rPr lang="en-US" dirty="0"/>
-              <a:t>These are two of the twelve holdout images. For each image, the left panel is v5 as trained and the right panel is the same model with the correction, no training; on the neck, only neck02 and the head are turned back. Look at the necks: on the left they are thin stalks, on the right they have normal width. That is the thickness 0.46 to 1.00 on slide 7, measured over all 100 holdout images. All twelve images show this wherever a neck is visible. Three limits. Without fine-tuning the head points 19 degrees off, against 12 before; the fine-tune brings it to 14. The bodies are still too small; that is the depth bug. Real photos are not checked yet.</a:t>
+              <a:t>These are two of the twelve holdout images. For each image, the left panel is v5 as trained and the right panel is the same model with the correction, no training; on the neck, only neck02 and the head are turned back. Look at the necks, ringed in yellow: on the left they are thin stalks, on the right they have normal width. This matches the thickness 0.46 to 1.00 on slide 7, measured over all 100 holdout images. All twelve images show this wherever a neck is visible. Three limits. Without fine-tuning the head points 19 degrees off, against 12 before; the fine-tune brings it to 14. The bodies are still too small; that is the depth bug. Real photos are not checked yet.</a:t>
+            </a:r>
+          </a:p>
+          <a:p>
+            <a:endParaRPr lang="en-US" dirty="0"/>
+          </a:p>
+          <a:p>
+            <a:r>
+              <a:rPr lang="en-US" dirty="0"/>
+              <a:t>If asked: the same correction also turns back two hand bones, so the hands differ too; I have not judged them (slide 9).</a:t>
             </a:r>
           </a:p>
         </p:txBody>
@@ -20499,7 +20508,7 @@
         <p:spPr>
           <a:xfrm>
             <a:off x="457200" y="1097280"/>
-            <a:ext cx="2189951" cy="310896"/>
+            <a:ext cx="2189951" cy="457200"/>
           </a:xfrm>
           <a:prstGeom prst="rect">
             <a:avLst/>
@@ -20523,6 +20532,20 @@
                 </a:solidFill>
               </a:rPr>
               <a:t>Before (v5)</a:t>
+            </a:r>
+            <a:endParaRPr lang="en-US" sz="1600" dirty="0"/>
+          </a:p>
+          <a:p>
+            <a:pPr algn="ctr" indent="0" marL="0">
+              <a:buNone/>
+            </a:pPr>
+            <a:r>
+              <a:rPr lang="en-US" sz="1200" dirty="0">
+                <a:solidFill>
+                  <a:srgbClr val="FFFFFF"/>
+                </a:solidFill>
+              </a:rPr>
+              <a:t>as trained</a:t>
             </a:r>
             <a:endParaRPr lang="en-US" sz="1600" dirty="0"/>
           </a:p>
@@ -20543,7 +20566,7 @@
         </p:blipFill>
         <p:spPr>
           <a:xfrm>
-            <a:off x="457200" y="1408176"/>
+            <a:off x="457200" y="1554480"/>
             <a:ext cx="2189951" cy="1835590"/>
           </a:xfrm>
           <a:prstGeom prst="rect">
@@ -20553,14 +20576,60 @@
       </p:pic>
       <p:sp>
         <p:nvSpPr>
-          <p:cNvPr id="5" name="neck header 1"/>
+          <p:cNvPr id="5" name="neck ring 579862 before 0"/>
+          <p:cNvSpPr/>
+          <p:nvPr/>
+        </p:nvSpPr>
+        <p:spPr>
+          <a:xfrm>
+            <a:off x="884044" y="2077001"/>
+            <a:ext cx="237744" cy="237744"/>
+          </a:xfrm>
+          <a:prstGeom prst="ellipse">
+            <a:avLst/>
+          </a:prstGeom>
+          <a:noFill/>
+          <a:ln w="25400">
+            <a:solidFill>
+              <a:srgbClr val="F4C95D"/>
+            </a:solidFill>
+            <a:prstDash val="solid"/>
+          </a:ln>
+        </p:spPr>
+      </p:sp>
+      <p:sp>
+        <p:nvSpPr>
+          <p:cNvPr id="6" name="neck ring 579862 before 1"/>
+          <p:cNvSpPr/>
+          <p:nvPr/>
+        </p:nvSpPr>
+        <p:spPr>
+          <a:xfrm>
+            <a:off x="2035717" y="2441993"/>
+            <a:ext cx="237744" cy="237744"/>
+          </a:xfrm>
+          <a:prstGeom prst="ellipse">
+            <a:avLst/>
+          </a:prstGeom>
+          <a:noFill/>
+          <a:ln w="25400">
+            <a:solidFill>
+              <a:srgbClr val="F4C95D"/>
+            </a:solidFill>
+            <a:prstDash val="solid"/>
+          </a:ln>
+        </p:spPr>
+      </p:sp>
+      <p:sp>
+        <p:nvSpPr>
+          <p:cNvPr id="7" name="neck header 1"/>
           <p:cNvSpPr txBox="1"/>
           <p:nvPr/>
         </p:nvSpPr>
         <p:spPr>
           <a:xfrm>
             <a:off x="2702015" y="1097280"/>
-            <a:ext cx="2189951" cy="310896"/>
+            <a:ext cx="2189951" cy="457200"/>
           </a:xfrm>
           <a:prstGeom prst="rect">
             <a:avLst/>
@@ -20587,11 +20656,25 @@
             </a:r>
             <a:endParaRPr lang="en-US" sz="1600" dirty="0"/>
           </a:p>
+          <a:p>
+            <a:pPr algn="ctr" indent="0" marL="0">
+              <a:buNone/>
+            </a:pPr>
+            <a:r>
+              <a:rPr lang="en-US" sz="1200" dirty="0">
+                <a:solidFill>
+                  <a:srgbClr val="FFFFFF"/>
+                </a:solidFill>
+              </a:rPr>
+              <a:t>no training</a:t>
+            </a:r>
+            <a:endParaRPr lang="en-US" sz="1600" dirty="0"/>
+          </a:p>
         </p:txBody>
       </p:sp>
       <p:pic>
         <p:nvPicPr>
-          <p:cNvPr id="6" name="figure neck_before_after_v5.jpg 579862 after" descr="Holdout image 579862, with the correction on neck02 and the head, no training: normal neck width">    </p:cNvPr>
+          <p:cNvPr id="8" name="figure neck_before_after_v5.jpg 579862 after" descr="Holdout image 579862, with the correction on neck02 and the head, no training: normal neck width">    </p:cNvPr>
           <p:cNvPicPr>
             <a:picLocks noChangeAspect="1"/>
           </p:cNvPicPr>
@@ -20604,7 +20687,7 @@
         </p:blipFill>
         <p:spPr>
           <a:xfrm>
-            <a:off x="2702015" y="1408176"/>
+            <a:off x="2702015" y="1554480"/>
             <a:ext cx="2189951" cy="1835590"/>
           </a:xfrm>
           <a:prstGeom prst="rect">
@@ -20614,14 +20697,60 @@
       </p:pic>
       <p:sp>
         <p:nvSpPr>
-          <p:cNvPr id="7" name="neck header 2"/>
+          <p:cNvPr id="9" name="neck ring 579862 after 0"/>
+          <p:cNvSpPr/>
+          <p:nvPr/>
+        </p:nvSpPr>
+        <p:spPr>
+          <a:xfrm>
+            <a:off x="3128859" y="2077001"/>
+            <a:ext cx="237744" cy="237744"/>
+          </a:xfrm>
+          <a:prstGeom prst="ellipse">
+            <a:avLst/>
+          </a:prstGeom>
+          <a:noFill/>
+          <a:ln w="25400">
+            <a:solidFill>
+              <a:srgbClr val="F4C95D"/>
+            </a:solidFill>
+            <a:prstDash val="solid"/>
+          </a:ln>
+        </p:spPr>
+      </p:sp>
+      <p:sp>
+        <p:nvSpPr>
+          <p:cNvPr id="10" name="neck ring 579862 after 1"/>
+          <p:cNvSpPr/>
+          <p:nvPr/>
+        </p:nvSpPr>
+        <p:spPr>
+          <a:xfrm>
+            <a:off x="4280532" y="2441993"/>
+            <a:ext cx="237744" cy="237744"/>
+          </a:xfrm>
+          <a:prstGeom prst="ellipse">
+            <a:avLst/>
+          </a:prstGeom>
+          <a:noFill/>
+          <a:ln w="25400">
+            <a:solidFill>
+              <a:srgbClr val="F4C95D"/>
+            </a:solidFill>
+            <a:prstDash val="solid"/>
+          </a:ln>
+        </p:spPr>
+      </p:sp>
+      <p:sp>
+        <p:nvSpPr>
+          <p:cNvPr id="11" name="neck header 2"/>
           <p:cNvSpPr txBox="1"/>
           <p:nvPr/>
         </p:nvSpPr>
         <p:spPr>
           <a:xfrm>
             <a:off x="5166286" y="1097280"/>
-            <a:ext cx="1732825" cy="310896"/>
+            <a:ext cx="1732825" cy="457200"/>
           </a:xfrm>
           <a:prstGeom prst="rect">
             <a:avLst/>
@@ -20648,11 +20777,25 @@
             </a:r>
             <a:endParaRPr lang="en-US" sz="1600" dirty="0"/>
           </a:p>
+          <a:p>
+            <a:pPr algn="ctr" indent="0" marL="0">
+              <a:buNone/>
+            </a:pPr>
+            <a:r>
+              <a:rPr lang="en-US" sz="1200" dirty="0">
+                <a:solidFill>
+                  <a:srgbClr val="FFFFFF"/>
+                </a:solidFill>
+              </a:rPr>
+              <a:t>as trained</a:t>
+            </a:r>
+            <a:endParaRPr lang="en-US" sz="1600" dirty="0"/>
+          </a:p>
         </p:txBody>
       </p:sp>
       <p:pic>
         <p:nvPicPr>
-          <p:cNvPr id="8" name="figure neck_before_after_v5.jpg 579863 before" descr="Holdout image 579863, v5 as trained: thin neck">    </p:cNvPr>
+          <p:cNvPr id="12" name="figure neck_before_after_v5.jpg 579863 before" descr="Holdout image 579863, v5 as trained: thin neck">    </p:cNvPr>
           <p:cNvPicPr>
             <a:picLocks noChangeAspect="1"/>
           </p:cNvPicPr>
@@ -20665,7 +20808,7 @@
         </p:blipFill>
         <p:spPr>
           <a:xfrm>
-            <a:off x="5166286" y="1408176"/>
+            <a:off x="5166286" y="1554480"/>
             <a:ext cx="1732825" cy="1835590"/>
           </a:xfrm>
           <a:prstGeom prst="rect">
@@ -20675,14 +20818,37 @@
       </p:pic>
       <p:sp>
         <p:nvSpPr>
-          <p:cNvPr id="9" name="neck header 3"/>
+          <p:cNvPr id="13" name="neck ring 579863 before 0"/>
+          <p:cNvSpPr/>
+          <p:nvPr/>
+        </p:nvSpPr>
+        <p:spPr>
+          <a:xfrm>
+            <a:off x="6032537" y="1892734"/>
+            <a:ext cx="237744" cy="237744"/>
+          </a:xfrm>
+          <a:prstGeom prst="ellipse">
+            <a:avLst/>
+          </a:prstGeom>
+          <a:noFill/>
+          <a:ln w="25400">
+            <a:solidFill>
+              <a:srgbClr val="F4C95D"/>
+            </a:solidFill>
+            <a:prstDash val="solid"/>
+          </a:ln>
+        </p:spPr>
+      </p:sp>
+      <p:sp>
+        <p:nvSpPr>
+          <p:cNvPr id="14" name="neck header 3"/>
           <p:cNvSpPr txBox="1"/>
           <p:nvPr/>
         </p:nvSpPr>
         <p:spPr>
           <a:xfrm>
             <a:off x="6953975" y="1097280"/>
-            <a:ext cx="1732825" cy="310896"/>
+            <a:ext cx="1732825" cy="457200"/>
           </a:xfrm>
           <a:prstGeom prst="rect">
             <a:avLst/>
@@ -20709,11 +20875,25 @@
             </a:r>
             <a:endParaRPr lang="en-US" sz="1600" dirty="0"/>
           </a:p>
+          <a:p>
+            <a:pPr algn="ctr" indent="0" marL="0">
+              <a:buNone/>
+            </a:pPr>
+            <a:r>
+              <a:rPr lang="en-US" sz="1200" dirty="0">
+                <a:solidFill>
+                  <a:srgbClr val="FFFFFF"/>
+                </a:solidFill>
+              </a:rPr>
+              <a:t>no training</a:t>
+            </a:r>
+            <a:endParaRPr lang="en-US" sz="1600" dirty="0"/>
+          </a:p>
         </p:txBody>
       </p:sp>
       <p:pic>
         <p:nvPicPr>
-          <p:cNvPr id="10" name="figure neck_before_after_v5.jpg 579863 after" descr="Holdout image 579863, with the correction on neck02 and the head, no training: normal neck width">    </p:cNvPr>
+          <p:cNvPr id="15" name="figure neck_before_after_v5.jpg 579863 after" descr="Holdout image 579863, with the correction on neck02 and the head, no training: normal neck width">    </p:cNvPr>
           <p:cNvPicPr>
             <a:picLocks noChangeAspect="1"/>
           </p:cNvPicPr>
@@ -20726,7 +20906,7 @@
         </p:blipFill>
         <p:spPr>
           <a:xfrm>
-            <a:off x="6953975" y="1408176"/>
+            <a:off x="6953975" y="1554480"/>
             <a:ext cx="1732825" cy="1835590"/>
           </a:xfrm>
           <a:prstGeom prst="rect">
@@ -20736,13 +20916,36 @@
       </p:pic>
       <p:sp>
         <p:nvSpPr>
-          <p:cNvPr id="11" name="neck caption 579862"/>
+          <p:cNvPr id="16" name="neck ring 579863 after 0"/>
+          <p:cNvSpPr/>
+          <p:nvPr/>
+        </p:nvSpPr>
+        <p:spPr>
+          <a:xfrm>
+            <a:off x="7820226" y="1892734"/>
+            <a:ext cx="237744" cy="237744"/>
+          </a:xfrm>
+          <a:prstGeom prst="ellipse">
+            <a:avLst/>
+          </a:prstGeom>
+          <a:noFill/>
+          <a:ln w="25400">
+            <a:solidFill>
+              <a:srgbClr val="F4C95D"/>
+            </a:solidFill>
+            <a:prstDash val="solid"/>
+          </a:ln>
+        </p:spPr>
+      </p:sp>
+      <p:sp>
+        <p:nvSpPr>
+          <p:cNvPr id="17" name="neck caption 579862"/>
           <p:cNvSpPr txBox="1"/>
           <p:nvPr/>
         </p:nvSpPr>
         <p:spPr>
           <a:xfrm>
-            <a:off x="457200" y="3298630"/>
+            <a:off x="457200" y="3444934"/>
             <a:ext cx="4434766" cy="201168"/>
           </a:xfrm>
           <a:prstGeom prst="rect">
@@ -20772,13 +20975,13 @@
       </p:sp>
       <p:sp>
         <p:nvSpPr>
-          <p:cNvPr id="12" name="neck caption 579863"/>
+          <p:cNvPr id="18" name="neck caption 579863"/>
           <p:cNvSpPr txBox="1"/>
           <p:nvPr/>
         </p:nvSpPr>
         <p:spPr>
           <a:xfrm>
-            <a:off x="5166286" y="3298630"/>
+            <a:off x="5166286" y="3444934"/>
             <a:ext cx="3520514" cy="201168"/>
           </a:xfrm>
           <a:prstGeom prst="rect">
@@ -20808,13 +21011,13 @@
       </p:sp>
       <p:sp>
         <p:nvSpPr>
-          <p:cNvPr id="13" name="neck figure caption"/>
+          <p:cNvPr id="19" name="neck figure caption"/>
           <p:cNvSpPr txBox="1"/>
           <p:nvPr/>
         </p:nvSpPr>
         <p:spPr>
           <a:xfrm>
-            <a:off x="457200" y="3572950"/>
+            <a:off x="457200" y="3719254"/>
             <a:ext cx="8229600" cy="365760"/>
           </a:xfrm>
           <a:prstGeom prst="rect">
@@ -20858,13 +21061,13 @@
       </p:sp>
       <p:sp>
         <p:nvSpPr>
-          <p:cNvPr id="14" name="neck figure footnote"/>
+          <p:cNvPr id="20" name="neck figure footnote"/>
           <p:cNvSpPr txBox="1"/>
           <p:nvPr/>
         </p:nvSpPr>
         <p:spPr>
           <a:xfrm>
-            <a:off x="457200" y="4011862"/>
+            <a:off x="457200" y="4158166"/>
             <a:ext cx="8229600" cy="365760"/>
           </a:xfrm>
           <a:prstGeom prst="rect">

</xml_diff>

<commit_message>
WIP: slide 8 real pair, handover and converter doc edits in progress (not for main yet)
Co-Authored-By: Claude Opus 5.5 <noreply@anthropic.com>
Claude-Session: https://claude.ai/code/session_016LhpG4kT7Z7ppxbG4TW5S9
</commit_message>
<xml_diff>
--- a/docs/supervisor_update_2026-10-16.pptx
+++ b/docs/supervisor_update_2026-10-16.pptx
@@ -124,7 +124,7 @@
   <p:extLst>
     <p:ext uri="{521415D9-36F7-43E2-AB2F-B90AF26B5E84}">
       <p14:sectionLst xmlns:p14="http://schemas.microsoft.com/office/powerpoint/2010/main">
-        <p14:section name="Overview" id="{1172506b-0cca-c7d9-3e6c-b0bef2618da0}">
+        <p14:section name="Overview" id="{ef82fb89-331b-4e6f-5621-3d2f26bb6458}">
           <p14:sldIdLst>
             <p14:sldId id="256"/>
             <p14:sldId id="257"/>
@@ -132,13 +132,13 @@
             <p14:sldId id="259"/>
           </p14:sldIdLst>
         </p14:section>
-        <p14:section name="3DPW labels" id="{ad0c0608-500d-1fe1-2f9c-352cbf9057d9}">
+        <p14:section name="3DPW labels" id="{fb228ada-20b5-cb5f-0baa-0bf568c2738f}">
           <p14:sldIdLst>
             <p14:sldId id="260"/>
             <p14:sldId id="261"/>
           </p14:sldIdLst>
         </p14:section>
-        <p14:section name="Findings" id="{ea43f461-02c1-76d1-6125-40ff2fd666c5}">
+        <p14:section name="Findings" id="{3c048e27-696e-f31f-9919-5da3aa2c010f}">
           <p14:sldIdLst>
             <p14:sldId id="262"/>
             <p14:sldId id="263"/>
@@ -146,14 +146,14 @@
             <p14:sldId id="265"/>
           </p14:sldIdLst>
         </p14:section>
-        <p14:section name="Bug" id="{fc60ff21-5fa8-f92d-aa53-2f3c06cb206d}">
+        <p14:section name="Bug" id="{e144d7df-82a2-f5ac-5ec4-37598ebb6543}">
           <p14:sldIdLst>
             <p14:sldId id="266"/>
             <p14:sldId id="267"/>
             <p14:sldId id="268"/>
           </p14:sldIdLst>
         </p14:section>
-        <p14:section name="Next" id="{e1e01bfa-b10f-a381-b468-2268d16ec325}">
+        <p14:section name="Next" id="{8f65a859-78f3-d3cf-65c6-3a807fa4c422}">
           <p14:sldIdLst>
             <p14:sldId id="269"/>
             <p14:sldId id="270"/>
@@ -161,7 +161,7 @@
             <p14:sldId id="272"/>
           </p14:sldIdLst>
         </p14:section>
-        <p14:section name="Appendix" id="{426b0dc6-0675-049a-f360-1bb1d21544d2}">
+        <p14:section name="Appendix" id="{70d06c7f-3bd3-d055-432c-d478faddc087}">
           <p14:sldIdLst>
             <p14:sldId id="273"/>
           </p14:sldIdLst>
@@ -1206,7 +1206,7 @@
           <a:p>
             <a:r>
               <a:rPr lang="en-US" dirty="0"/>
-              <a:t>Seven things are still open. First, the bone flips. The neck fix passes in one run, and the holdout renders of the correction alone show normal necks; I still have to check real photos and a longer run. v10's left arm has the same kind of flip, but a bone further down the arm undoes it, so it needs a two-sided correction, not built yet. Second, the depth slope is stuck at 0.3 to 0.4, cause unknown. Third, the cost of the depth fix, paired on the same people. Fourth, pilot noise: fix the seed or repeat key runs. Fifth, people very close to the camera. Sixth, children and fingers: a longer sampler run, and a look at the hands with the bone fix. Seventh, 3DPW: the rebuild gave the same counts, so the images are likely missing; I will check, re-extract and rebuild. Then gender, frame grid and a re-fit of all 87 tasks, before any 3DPW test.</a:t>
+              <a:t>Seven things are still open. First, the bone flips. The neck fix passes in one run; the holdout renders of the correction alone show normal necks, and so, by eye, does a first real-image demo of the fine-tuned model. I still need a longer run, and real images have no neck metric. v10's left arm has the same kind of flip, but a bone further down the arm undoes it, so it needs a two-sided correction, not built yet. Second, the depth slope is stuck at 0.3 to 0.4, cause unknown. Third, the cost of the depth fix, paired on the same people. Fourth, pilot noise: fix the seed or repeat key runs. Fifth, people very close to the camera. Sixth, children and fingers: a longer sampler run, and a look at the hands with the bone fix. Seventh, 3DPW: the rebuild gave the same counts, so the images are likely missing; I will check, re-extract and rebuild. Then gender, frame grid and a re-fit of all 87 tasks, before any 3DPW test.</a:t>
             </a:r>
           </a:p>
           <a:p>
@@ -1215,7 +1215,7 @@
           <a:p>
             <a:r>
               <a:rPr lang="en-US" dirty="0"/>
-              <a:t>If asked: Neck: the fine-tuned checkpoint carries the fix in its saved settings, so the demo applies it on load; I copy it next to the other demo models and add it to the demo comparison script. In the 12 side-by-side holdout panels, with the correction alone and no training, the necks have normal width wherever a neck is visible (slide 8). v10: correcting three of its flipped hand bones passed without training; two more finger bones, seen on training images, are not corrected yet; shoulder01.L at 166 degrees and upperarm02.L at 180 stay flipped, because one constant per bone would break the chain that compensates them. Depth: the training depths so far come from small samples, batch means of about 2.5 to 3.2 metres. I will also measure the fix run's slope on training images; for v5 it was just as low there. Cost: I will report the root error next to PVE in the thesis. Testing the depth fix on 3DPW waits for item seven. The twenty-times 10-epoch run has no result yet. Close people: both models miss them in 4 of the 12 rendered images. Children and fingers: one 2-epoch test is not enough to close them. 3DPW labels: the rebuild, into a new folder, gave the same counts, so my old guess that the builder ran before the fits finished is wrong. The builder skips every frame without an image file. The check is one file count per image folder of the eight affected sequences; if they are empty or short, I unzip the 3DPW images again and rebuild. Gender and the frame grid are different: set men to 0 and, by Anny's convention, women to 1; the refit confirmed it only for men. And pick both people's frames on one shared grid. Both happen inside the fit, so all 87 conversion tasks must be fitted again, into a new folder, because the task script skips every person that already has a file; otherwise old and new fits would mix without a warning. That is an 87-task array job: about 40 GPU hours by the task script's own estimate of 6 seconds per frame, so 5 to 6 hours with 8 GPUs at once; not measured. Then rebuild the labels and run the check again.</a:t>
+              <a:t>If asked: Neck: the fine-tuned checkpoint carries the fix in its saved settings, so the demo applies it on load; the demo comparison, job 3581312, ran it next to v5 on 4 example photos and 8 3DPW test frames (slide 8). In the 12 side-by-side holdout panels, with the correction alone and no training, the necks have normal width wherever a neck is visible (slide 8). v10: correcting three of its flipped hand bones passed without training; two more finger bones, seen on training images, are not corrected yet; shoulder01.L at 166 degrees and upperarm02.L at 180 stay flipped, because one constant per bone would break the chain that compensates them. Depth: the training depths so far come from small samples, batch means of about 2.5 to 3.2 metres. I will also measure the fix run's slope on training images; for v5 it was just as low there. Cost: I will report the root error next to PVE in the thesis. Testing the depth fix on 3DPW waits for item seven. The twenty-times 10-epoch run has no result yet. Close people: both models miss them in 4 of the 12 rendered images. Children and fingers: one 2-epoch test is not enough to close them. 3DPW labels: the rebuild, into a new folder, gave the same counts, so my old guess that the builder ran before the fits finished is wrong. The builder skips every frame without an image file. The check is one file count per image folder of the eight affected sequences; if they are empty or short, I unzip the 3DPW images again and rebuild. Gender and the frame grid are different: set men to 0 and, by Anny's convention, women to 1; the refit confirmed it only for men. And pick both people's frames on one shared grid. Both happen inside the fit, so all 87 conversion tasks must be fitted again, into a new folder, because the task script skips every person that already has a file; otherwise old and new fits would mix without a warning. That is an 87-task array job: about 40 GPU hours by the task script's own estimate of 6 seconds per frame, so 5 to 6 hours with 8 GPUs at once; not measured. Then rebuild the labels and run the check again.</a:t>
             </a:r>
           </a:p>
         </p:txBody>
@@ -1323,7 +1323,7 @@
           <a:p>
             <a:r>
               <a:rPr lang="en-US" dirty="0"/>
-              <a:t>- Neck: the two half-turned bones cancel, so the head points the right way. A 2-epoch geodesic loss did not undo it. The fixed correction with a 2-epoch fine-tune did, in one run: neck02 4.7 degrees, thickness 1.00, head direction 14.4 against 13.8 for its control and 12.0 before. One run without a seed is not proof; the holdout renders of the correction without training show normal neck width, but I have not looked at the fine-tuned model's renders or at real photos yet. The origin of the flip is not known; the singular start value of the rotation output would start a bone turned about its sideways axis, a tilt like the one in v5's left index base, not the twist in neck02 and the head.</a:t>
+              <a:t>- Neck: the two half-turned bones cancel, so the head points the right way. A 2-epoch geodesic loss did not undo it. The fixed correction with a 2-epoch fine-tune did, in one run: neck02 4.7 degrees, thickness 1.00, head direction 14.4 against 13.8 for its control and 12.0 before. One run without a seed is not proof; the holdout renders of the correction without training show normal neck width, and in a first real-image demo the fine-tuned model's necks look normal, judged by eye only; there is no neck metric on real images. The origin of the flip is not known; the singular start value of the rotation output would start a bone turned about its sideways axis, a tilt like the one in v5's left index base, not the twist in neck02 and the head.</a:t>
             </a:r>
           </a:p>
           <a:p>
@@ -1533,7 +1533,7 @@
           <a:p>
             <a:r>
               <a:rPr lang="en-US" dirty="0"/>
-              <a:t>These are the three failures we discussed last time. Until this week they were explained by guesses: a rig problem, too few pixels on the hands, or a shape head that does not learn age. None of these guesses had been tested on its own. That is what I did first. The last line on each card is what this week showed; the details follow. For the neck, two bones in the v5 models, neck02 and the head bone, are turned half a turn, and the neck skin comes out about half as thick. A first fix, in one run, restores it; holdout renders of the correction alone, before the fine-tune, show normal necks; real photos are still to check. For the fingers, about half of the error came from two flipped hand bones.</a:t>
+              <a:t>These are the three failures we discussed last time. Until this week they were explained by guesses: a rig problem, too few pixels on the hands, or a shape head that does not learn age. None of these guesses had been tested on its own. That is what I did first. The last line on each card is what this week showed; the details follow. For the neck, two bones in the v5 models, neck02 and the head bone, are turned half a turn, and the neck skin comes out about half as thick. A first fix, in one run, restores it; holdout renders of the correction alone show normal necks, and on real images the fine-tuned fixed model's necks look normal, judged by eye only; there is no neck metric for real images. For the fingers, about half of the error came from two flipped hand bones.</a:t>
             </a:r>
           </a:p>
         </p:txBody>
@@ -2019,7 +2019,7 @@
           <a:p>
             <a:r>
               <a:rPr lang="en-US" dirty="0"/>
-              <a:t>In all eight v5-line checkpoints, neck02 and the head bone are about half a turn off. The two half-turns cancel, so the head still points the right way and PVE never showed it, but the neck skin comes out half as thick. I tested a fix: one constant turn per flipped bone at the network output, estimated on 200 training images. On the holdout, the fix alone turns both bones back; neck thickness goes from 0.46 to 1.00. But head direction gets worse, 19.1 degrees, likely because the head's offset differs per person. After a two-epoch fine-tune, it passes the fine-tune checks, each within a tolerance of its control; head direction is 14.4, still worse than 12.0 before. One run, no fixed seed: I claim no PVE gain, only no sign of a PVE cost, 68.8 against 76.9 for the control. The next slide shows the correction alone, before the fine-tune; real photos are not checked yet.</a:t>
+              <a:t>In all eight v5-line checkpoints, neck02 and the head bone are about half a turn off. The two half-turns cancel, so the head still points the right way and PVE never showed it, but the neck skin comes out half as thick. I tested a fix: one constant turn per flipped bone at the network output, estimated on 200 training images. On the holdout, the fix alone turns both bones back; neck thickness goes from 0.46 to 1.00. But head direction gets worse, 19.1 degrees, likely because the head's offset differs per person. After a two-epoch fine-tune, it passes the fine-tune checks, each within a tolerance of its control; head direction is 14.4, still worse than 12.0 before. One run, no fixed seed: I claim no PVE gain, only no sign of a PVE cost, 68.8 against 76.9 for the control. The next slide shows the correction alone on a holdout image, and the fine-tuned model on a real 3DPW test frame.</a:t>
             </a:r>
           </a:p>
           <a:p>
@@ -2028,7 +2028,7 @@
           <a:p>
             <a:r>
               <a:rPr lang="en-US" dirty="0"/>
-              <a:t>If asked: After the fine-tune, neck02 is 4.7 degrees and the thickness 1.00. The flip is there from the first training stage, frozen_bb_v2, and in v3, v4, v5, v9 and every pilot checked. A two-epoch geodesic loss barely moved it, 175.6 to 175.0 degrees. Its origin is not known: the singular start value of the rotation output would start a bone with a tilt, like v5's left index base, not this twist. v10 has no neck flip. The constants are 178.8 degrees for neck02 and 179.2 for the head. Before the test, the script's guard predicted the head-direction rise, 8.4 to 17.9 degrees on the training sample: a compensated chain, since the head's offset differs per person and one constant cannot undo it. Without training, the head-and-neck surface error also rose, 52.3 to 63.1 millimetres; after the fine-tune it is 51.8. The fine-tune checks, against the control: corrected bones under 15 degrees, thickness at least 0.9, PVE at most 8 millimetres higher, recall at most 2 points lower, head direction at most 3 degrees worse. Recall passed by only 0.3 points, 89.4 against a limit of 89.1. Against the control: PVE 68.8 against 76.9, PA-PVE 50.9 against 55.2, recall 89.4 against 91.1, head direction 14.4 against 13.8. Against v5 before: PVE 68.8 against 70.5, PA-PVE 50.9 against 53.3, recall 89.4 against 90.2. Identical configs differ by up to 7.6 millimetres PVE, so none of these PVE differences is certain. Last week's group errors, 63 degrees for the neck and 90 for the head, are now 5.9 and 6.7. The script wrote 12 side-by-side panels, without and with the correction alone; the next slide shows two of them. Next: a real-photo demo with the fine-tuned checkpoint, which carries the fix, and a longer fine-tune with the fix.</a:t>
+              <a:t>If asked: After the fine-tune, neck02 is 4.7 degrees and the thickness 1.00. The flip is there from the first training stage, frozen_bb_v2, and in v3, v4, v5, v9 and every pilot checked. A two-epoch geodesic loss barely moved it, 175.6 to 175.0 degrees. Its origin is not known: the singular start value of the rotation output would start a bone with a tilt, like v5's left index base, not this twist. v10 has no neck flip. The constants are 178.8 degrees for neck02 and 179.2 for the head. Before the test, the script's guard predicted the head-direction rise, 8.4 to 17.9 degrees on the training sample: a compensated chain, since the head's offset differs per person and one constant cannot undo it. Without training, the head-and-neck surface error also rose, 52.3 to 63.1 millimetres; after the fine-tune it is 51.8. The fine-tune checks, against the control: corrected bones under 15 degrees, thickness at least 0.9, PVE at most 8 millimetres higher, recall at most 2 points lower, head direction at most 3 degrees worse. Recall passed by only 0.3 points, 89.4 against a limit of 89.1. Against the control: PVE 68.8 against 76.9, PA-PVE 50.9 against 55.2, recall 89.4 against 91.1, head direction 14.4 against 13.8. Against v5 before: PVE 68.8 against 70.5, PA-PVE 50.9 against 53.3, recall 89.4 against 90.2. Identical configs differ by up to 7.6 millimetres PVE, so none of these PVE differences is certain. Last week's group errors, 63 degrees for the neck and 90 for the head, are now 5.9 and 6.7. The script wrote 12 side-by-side panels, without and with the correction alone; the next slide shows one of them, next to a real-image demo of the fine-tuned checkpoint, which carries the fix. Next: a longer fine-tune with the fix.</a:t>
             </a:r>
           </a:p>
         </p:txBody>
@@ -2115,7 +2115,7 @@
           <a:p>
             <a:r>
               <a:rPr lang="en-US" dirty="0"/>
-              <a:t>These are two of the twelve holdout images. For each image, the left panel is v5 as trained and the right panel is the same model with the correction, no training; on the neck, only neck02 and the head are turned back. Look at the necks, ringed in yellow: on the left they are thin stalks, on the right they have normal width. This matches the thickness 0.46 to 1.00 on slide 7, measured over all 100 holdout images. All twelve images show this wherever a neck is visible. Three limits. Without fine-tuning the head points 19 degrees off, against 12 before; the fine-tune brings it to 14. The bodies are still too small; that is the depth bug. Real photos are not checked yet.</a:t>
+              <a:t>Two pairs. On the left, a synthetic holdout image: v5 as trained, then the same model with the correction alone, no training. On the right, a real 3DPW test frame, never trained on: v5, then the fine-tuned fixed model. Look at the necks, ringed in yellow. With v5 they are thin stalks, pinched under the head; with the fix they have normal width. On the holdout this is measured: thickness 0.46 to 1.00 over 100 images. On real images I can only judge by eye. The change is clearest here and on an office frame, and also visible on two more 3DPW sequences and three photos. Head direction stays a limit: 14 degrees after the fine-tune, against 12.</a:t>
             </a:r>
           </a:p>
           <a:p>
@@ -2124,7 +2124,37 @@
           <a:p>
             <a:r>
               <a:rPr lang="en-US" dirty="0"/>
-              <a:t>If asked: the same correction also turns back two hand bones, so the hands differ too; I have not judged them (slide 9).</a:t>
+              <a:t>If asked:</a:t>
+            </a:r>
+          </a:p>
+          <a:p>
+            <a:r>
+              <a:rPr lang="en-US" dirty="0"/>
+              <a:t>- The right column is the fine-tuned checkpoint, so it differs from v5 by the correction and by two epochs of training; this pair cannot separate the two. The demo log shows the fix on for four bones. Demo: job 3581312, person detector, each body placed from its detection box, 4 example photos and 8 3DPW test frames.</a:t>
+            </a:r>
+          </a:p>
+          <a:p>
+            <a:r>
+              <a:rPr lang="en-US" dirty="0"/>
+              <a:t>- Men: in both models, adult men on real photos get female-looking bodies, with breasts and narrow shoulders, for example the male tennis players. v5 never saw 3DPW, so this is not the gender defect in our 3DPW labels; the cause is unknown. My guess is the gender or shape prediction on real images, a synthetic-to-real gap like the age problem; not tested.</a:t>
+            </a:r>
+          </a:p>
+          <a:p>
+            <a:r>
+              <a:rPr lang="en-US" dirty="0"/>
+              <a:t>- Also in both models: some bodies are still small or misplaced in depth, although the demo places them from the detection box, and a figure in a painting is detected as a person.</a:t>
+            </a:r>
+          </a:p>
+          <a:p>
+            <a:r>
+              <a:rPr lang="en-US" dirty="0"/>
+              <a:t>- The correction also turns back two hand bones, so the hands differ too; I have not judged them (slide 9).</a:t>
+            </a:r>
+          </a:p>
+          <a:p>
+            <a:r>
+              <a:rPr lang="en-US" dirty="0"/>
+              <a:t>- All twelve holdout panels show the thin neck and its fix wherever a neck is visible.</a:t>
             </a:r>
           </a:p>
         </p:txBody>
@@ -11843,7 +11873,7 @@
                   <a:schemeClr val="tx2"/>
                 </a:solidFill>
               </a:rPr>
-              <a:t>Neck: real photos, a longer run (slide 8: no training). v10's left arm: two-sided fix, not built yet.</a:t>
+              <a:t>Neck: a longer run; real images by eye only (slide 8). v10's left arm: two-sided fix, not built yet.</a:t>
             </a:r>
             <a:endParaRPr lang="en-US" sz="1200" dirty="0"/>
           </a:p>
@@ -13471,7 +13501,7 @@
                   <a:schemeClr val="tx2"/>
                 </a:solidFill>
               </a:rPr>
-              <a:t>the rig is fine. v5's neck02 and head bone are half a turn off; neck skin half as thick. A pilot fix restores it (one run).</a:t>
+              <a:t>the rig is fine. v5's neck02 and head bone are half a turn off; neck skin half as thick. A pilot fix restores it (one run; on real images by eye only).</a:t>
             </a:r>
             <a:endParaRPr lang="en-US" sz="1300" dirty="0"/>
           </a:p>
@@ -20316,7 +20346,7 @@
                   <a:schemeClr val="tx1"/>
                 </a:solidFill>
               </a:rPr>
-              <a:t>why the bones flipped; real photos. Holdout renders of the fix with no training: next slide.</a:t>
+              <a:t>why the bones flipped. Next slide: the fix on a holdout image and on a real 3DPW test frame (by eye).</a:t>
             </a:r>
             <a:endParaRPr lang="en-US" sz="1200" dirty="0"/>
           </a:p>
@@ -20385,7 +20415,7 @@
                   <a:schemeClr val="tx1"/>
                 </a:solidFill>
               </a:rPr>
-              <a:t>real-photo demo of the fine-tuned fixed checkpoint; a longer fine-tune with the fix.</a:t>
+              <a:t>a longer fine-tune with the fix (slide 16).</a:t>
             </a:r>
             <a:endParaRPr lang="en-US" sz="1200" dirty="0"/>
           </a:p>
@@ -20508,7 +20538,7 @@
         <p:spPr>
           <a:xfrm>
             <a:off x="457200" y="1097280"/>
-            <a:ext cx="2189951" cy="457200"/>
+            <a:ext cx="2061459" cy="457200"/>
           </a:xfrm>
           <a:prstGeom prst="rect">
             <a:avLst/>
@@ -20540,7 +20570,7 @@
               <a:buNone/>
             </a:pPr>
             <a:r>
-              <a:rPr lang="en-US" sz="1200" dirty="0">
+              <a:rPr lang="en-US" sz="1100" dirty="0">
                 <a:solidFill>
                   <a:srgbClr val="FFFFFF"/>
                 </a:solidFill>
@@ -20553,7 +20583,7 @@
       </p:sp>
       <p:pic>
         <p:nvPicPr>
-          <p:cNvPr id="4" name="figure neck_before_after_v5.jpg 579862 before" descr="Holdout image 579862, v5 as trained: thin neck">    </p:cNvPr>
+          <p:cNvPr id="4" name="figure neck_before_after_v5.jpg before" descr="Synthetic holdout image 579862, v5 as trained: thin necks">    </p:cNvPr>
           <p:cNvPicPr>
             <a:picLocks noChangeAspect="1"/>
           </p:cNvPicPr>
@@ -20567,7 +20597,7 @@
         <p:spPr>
           <a:xfrm>
             <a:off x="457200" y="1554480"/>
-            <a:ext cx="2189951" cy="1835590"/>
+            <a:ext cx="2061459" cy="1727889"/>
           </a:xfrm>
           <a:prstGeom prst="rect">
             <a:avLst/>
@@ -20576,13 +20606,13 @@
       </p:pic>
       <p:sp>
         <p:nvSpPr>
-          <p:cNvPr id="5" name="neck ring 579862 before 0"/>
+          <p:cNvPr id="5" name="neck ring holdout before 0"/>
           <p:cNvSpPr/>
           <p:nvPr/>
         </p:nvSpPr>
         <p:spPr>
           <a:xfrm>
-            <a:off x="884044" y="2077001"/>
+            <a:off x="852025" y="2039369"/>
             <a:ext cx="237744" cy="237744"/>
           </a:xfrm>
           <a:prstGeom prst="ellipse">
@@ -20599,13 +20629,13 @@
       </p:sp>
       <p:sp>
         <p:nvSpPr>
-          <p:cNvPr id="6" name="neck ring 579862 before 1"/>
+          <p:cNvPr id="6" name="neck ring holdout before 1"/>
           <p:cNvSpPr/>
           <p:nvPr/>
         </p:nvSpPr>
         <p:spPr>
           <a:xfrm>
-            <a:off x="2035717" y="2441993"/>
+            <a:off x="1936125" y="2382945"/>
             <a:ext cx="237744" cy="237744"/>
           </a:xfrm>
           <a:prstGeom prst="ellipse">
@@ -20628,8 +20658,8 @@
         </p:nvSpPr>
         <p:spPr>
           <a:xfrm>
-            <a:off x="2702015" y="1097280"/>
-            <a:ext cx="2189951" cy="457200"/>
+            <a:off x="2573523" y="1097280"/>
+            <a:ext cx="2061459" cy="457200"/>
           </a:xfrm>
           <a:prstGeom prst="rect">
             <a:avLst/>
@@ -20661,7 +20691,7 @@
               <a:buNone/>
             </a:pPr>
             <a:r>
-              <a:rPr lang="en-US" sz="1200" dirty="0">
+              <a:rPr lang="en-US" sz="1100" dirty="0">
                 <a:solidFill>
                   <a:srgbClr val="FFFFFF"/>
                 </a:solidFill>
@@ -20674,7 +20704,7 @@
       </p:sp>
       <p:pic>
         <p:nvPicPr>
-          <p:cNvPr id="8" name="figure neck_before_after_v5.jpg 579862 after" descr="Holdout image 579862, with the correction on neck02 and the head, no training: normal neck width">    </p:cNvPr>
+          <p:cNvPr id="8" name="figure neck_before_after_v5.jpg after" descr="Synthetic holdout image 579862, v5 with the correction on neck02 and the head, no training: normal neck width">    </p:cNvPr>
           <p:cNvPicPr>
             <a:picLocks noChangeAspect="1"/>
           </p:cNvPicPr>
@@ -20687,8 +20717,8 @@
         </p:blipFill>
         <p:spPr>
           <a:xfrm>
-            <a:off x="2702015" y="1554480"/>
-            <a:ext cx="2189951" cy="1835590"/>
+            <a:off x="2573523" y="1554480"/>
+            <a:ext cx="2061459" cy="1727889"/>
           </a:xfrm>
           <a:prstGeom prst="rect">
             <a:avLst/>
@@ -20697,13 +20727,13 @@
       </p:pic>
       <p:sp>
         <p:nvSpPr>
-          <p:cNvPr id="9" name="neck ring 579862 after 0"/>
+          <p:cNvPr id="9" name="neck ring holdout after 0"/>
           <p:cNvSpPr/>
           <p:nvPr/>
         </p:nvSpPr>
         <p:spPr>
           <a:xfrm>
-            <a:off x="3128859" y="2077001"/>
+            <a:off x="2968348" y="2039369"/>
             <a:ext cx="237744" cy="237744"/>
           </a:xfrm>
           <a:prstGeom prst="ellipse">
@@ -20720,13 +20750,13 @@
       </p:sp>
       <p:sp>
         <p:nvSpPr>
-          <p:cNvPr id="10" name="neck ring 579862 after 1"/>
+          <p:cNvPr id="10" name="neck ring holdout after 1"/>
           <p:cNvSpPr/>
           <p:nvPr/>
         </p:nvSpPr>
         <p:spPr>
           <a:xfrm>
-            <a:off x="4280532" y="2441993"/>
+            <a:off x="4052448" y="2382945"/>
             <a:ext cx="237744" cy="237744"/>
           </a:xfrm>
           <a:prstGeom prst="ellipse">
@@ -20749,8 +20779,8 @@
         </p:nvSpPr>
         <p:spPr>
           <a:xfrm>
-            <a:off x="5166286" y="1097280"/>
-            <a:ext cx="1732825" cy="457200"/>
+            <a:off x="4909302" y="1097280"/>
+            <a:ext cx="1861317" cy="457200"/>
           </a:xfrm>
           <a:prstGeom prst="rect">
             <a:avLst/>
@@ -20782,12 +20812,12 @@
               <a:buNone/>
             </a:pPr>
             <a:r>
-              <a:rPr lang="en-US" sz="1200" dirty="0">
+              <a:rPr lang="en-US" sz="1100" dirty="0">
                 <a:solidFill>
                   <a:srgbClr val="FFFFFF"/>
                 </a:solidFill>
               </a:rPr>
-              <a:t>as trained</a:t>
+              <a:t>real image</a:t>
             </a:r>
             <a:endParaRPr lang="en-US" sz="1600" dirty="0"/>
           </a:p>
@@ -20795,7 +20825,7 @@
       </p:sp>
       <p:pic>
         <p:nvPicPr>
-          <p:cNvPr id="12" name="figure neck_before_after_v5.jpg 579863 before" descr="Holdout image 579863, v5 as trained: thin neck">    </p:cNvPr>
+          <p:cNvPr id="12" name="figure neck_before_after_3dpw_bar.jpg before" descr="3DPW test image downtown_bar_00 frame 701, v5: thin necks">    </p:cNvPr>
           <p:cNvPicPr>
             <a:picLocks noChangeAspect="1"/>
           </p:cNvPicPr>
@@ -20803,13 +20833,13 @@
         </p:nvPicPr>
         <p:blipFill>
           <a:blip r:embed="rId3"/>
-          <a:srcRect l="5183" r="55821" t="52326" b="1342"/>
+          <a:srcRect l="88" r="50705" t="8947" b="176"/>
           <a:stretch/>
         </p:blipFill>
         <p:spPr>
           <a:xfrm>
-            <a:off x="5166286" y="1554480"/>
-            <a:ext cx="1732825" cy="1835590"/>
+            <a:off x="4909302" y="1554480"/>
+            <a:ext cx="1861317" cy="1727889"/>
           </a:xfrm>
           <a:prstGeom prst="rect">
             <a:avLst/>
@@ -20818,13 +20848,13 @@
       </p:pic>
       <p:sp>
         <p:nvSpPr>
-          <p:cNvPr id="13" name="neck ring 579863 before 0"/>
+          <p:cNvPr id="13" name="neck ring bar before 0"/>
           <p:cNvSpPr/>
           <p:nvPr/>
         </p:nvSpPr>
         <p:spPr>
           <a:xfrm>
-            <a:off x="6032537" y="1892734"/>
+            <a:off x="5264098" y="1839227"/>
             <a:ext cx="237744" cy="237744"/>
           </a:xfrm>
           <a:prstGeom prst="ellipse">
@@ -20841,88 +20871,13 @@
       </p:sp>
       <p:sp>
         <p:nvSpPr>
-          <p:cNvPr id="14" name="neck header 3"/>
-          <p:cNvSpPr txBox="1"/>
-          <p:nvPr/>
-        </p:nvSpPr>
-        <p:spPr>
-          <a:xfrm>
-            <a:off x="6953975" y="1097280"/>
-            <a:ext cx="1732825" cy="457200"/>
-          </a:xfrm>
-          <a:prstGeom prst="rect">
-            <a:avLst/>
-          </a:prstGeom>
-          <a:solidFill>
-            <a:srgbClr val="0E7C86"/>
-          </a:solidFill>
-          <a:ln/>
-        </p:spPr>
-        <p:txBody>
-          <a:bodyPr wrap="square" lIns="0" tIns="0" rIns="0" bIns="0" rtlCol="0" anchor="ctr"/>
-          <a:lstStyle/>
-          <a:p>
-            <a:pPr algn="ctr" indent="0" marL="0">
-              <a:buNone/>
-            </a:pPr>
-            <a:r>
-              <a:rPr lang="en-US" sz="1600" b="1" dirty="0">
-                <a:solidFill>
-                  <a:srgbClr val="FFFFFF"/>
-                </a:solidFill>
-              </a:rPr>
-              <a:t>After (correction)</a:t>
-            </a:r>
-            <a:endParaRPr lang="en-US" sz="1600" dirty="0"/>
-          </a:p>
-          <a:p>
-            <a:pPr algn="ctr" indent="0" marL="0">
-              <a:buNone/>
-            </a:pPr>
-            <a:r>
-              <a:rPr lang="en-US" sz="1200" dirty="0">
-                <a:solidFill>
-                  <a:srgbClr val="FFFFFF"/>
-                </a:solidFill>
-              </a:rPr>
-              <a:t>no training</a:t>
-            </a:r>
-            <a:endParaRPr lang="en-US" sz="1600" dirty="0"/>
-          </a:p>
-        </p:txBody>
-      </p:sp>
-      <p:pic>
-        <p:nvPicPr>
-          <p:cNvPr id="15" name="figure neck_before_after_v5.jpg 579863 after" descr="Holdout image 579863, with the correction on neck02 and the head, no training: normal neck width">    </p:cNvPr>
-          <p:cNvPicPr>
-            <a:picLocks noChangeAspect="1"/>
-          </p:cNvPicPr>
-          <p:nvPr/>
-        </p:nvPicPr>
-        <p:blipFill>
-          <a:blip r:embed="rId4"/>
-          <a:srcRect l="55742" r="5263" t="52326" b="1342"/>
-          <a:stretch/>
-        </p:blipFill>
-        <p:spPr>
-          <a:xfrm>
-            <a:off x="6953975" y="1554480"/>
-            <a:ext cx="1732825" cy="1835590"/>
-          </a:xfrm>
-          <a:prstGeom prst="rect">
-            <a:avLst/>
-          </a:prstGeom>
-        </p:spPr>
-      </p:pic>
-      <p:sp>
-        <p:nvSpPr>
-          <p:cNvPr id="16" name="neck ring 579863 after 0"/>
+          <p:cNvPr id="14" name="neck ring bar before 1"/>
           <p:cNvSpPr/>
           <p:nvPr/>
         </p:nvSpPr>
         <p:spPr>
           <a:xfrm>
-            <a:off x="7820226" y="1892734"/>
+            <a:off x="5901216" y="1839227"/>
             <a:ext cx="237744" cy="237744"/>
           </a:xfrm>
           <a:prstGeom prst="ellipse">
@@ -20939,14 +20894,135 @@
       </p:sp>
       <p:sp>
         <p:nvSpPr>
-          <p:cNvPr id="17" name="neck caption 579862"/>
+          <p:cNvPr id="15" name="neck header 3"/>
           <p:cNvSpPr txBox="1"/>
           <p:nvPr/>
         </p:nvSpPr>
         <p:spPr>
           <a:xfrm>
-            <a:off x="457200" y="3444934"/>
-            <a:ext cx="4434766" cy="201168"/>
+            <a:off x="6825483" y="1097280"/>
+            <a:ext cx="1861317" cy="457200"/>
+          </a:xfrm>
+          <a:prstGeom prst="rect">
+            <a:avLst/>
+          </a:prstGeom>
+          <a:solidFill>
+            <a:srgbClr val="0E7C86"/>
+          </a:solidFill>
+          <a:ln/>
+        </p:spPr>
+        <p:txBody>
+          <a:bodyPr wrap="square" lIns="0" tIns="0" rIns="0" bIns="0" rtlCol="0" anchor="ctr"/>
+          <a:lstStyle/>
+          <a:p>
+            <a:pPr algn="ctr" indent="0" marL="0">
+              <a:buNone/>
+            </a:pPr>
+            <a:r>
+              <a:rPr lang="en-US" sz="1600" b="1" dirty="0">
+                <a:solidFill>
+                  <a:srgbClr val="FFFFFF"/>
+                </a:solidFill>
+              </a:rPr>
+              <a:t>After (fixed model)</a:t>
+            </a:r>
+            <a:endParaRPr lang="en-US" sz="1600" dirty="0"/>
+          </a:p>
+          <a:p>
+            <a:pPr algn="ctr" indent="0" marL="0">
+              <a:buNone/>
+            </a:pPr>
+            <a:r>
+              <a:rPr lang="en-US" sz="1100" dirty="0">
+                <a:solidFill>
+                  <a:srgbClr val="FFFFFF"/>
+                </a:solidFill>
+              </a:rPr>
+              <a:t>correction + 2-epoch fine-tune</a:t>
+            </a:r>
+            <a:endParaRPr lang="en-US" sz="1600" dirty="0"/>
+          </a:p>
+        </p:txBody>
+      </p:sp>
+      <p:pic>
+        <p:nvPicPr>
+          <p:cNvPr id="16" name="figure neck_before_after_3dpw_bar.jpg after" descr="3DPW test image downtown_bar_00 frame 701, fixed model after the 2-epoch fine-tune: normal neck width">    </p:cNvPr>
+          <p:cNvPicPr>
+            <a:picLocks noChangeAspect="1"/>
+          </p:cNvPicPr>
+          <p:nvPr/>
+        </p:nvPicPr>
+        <p:blipFill>
+          <a:blip r:embed="rId4"/>
+          <a:srcRect l="50705" r="88" t="8947" b="176"/>
+          <a:stretch/>
+        </p:blipFill>
+        <p:spPr>
+          <a:xfrm>
+            <a:off x="6825483" y="1554480"/>
+            <a:ext cx="1861317" cy="1727889"/>
+          </a:xfrm>
+          <a:prstGeom prst="rect">
+            <a:avLst/>
+          </a:prstGeom>
+        </p:spPr>
+      </p:pic>
+      <p:sp>
+        <p:nvSpPr>
+          <p:cNvPr id="17" name="neck ring bar after 0"/>
+          <p:cNvSpPr/>
+          <p:nvPr/>
+        </p:nvSpPr>
+        <p:spPr>
+          <a:xfrm>
+            <a:off x="7180279" y="1839227"/>
+            <a:ext cx="237744" cy="237744"/>
+          </a:xfrm>
+          <a:prstGeom prst="ellipse">
+            <a:avLst/>
+          </a:prstGeom>
+          <a:noFill/>
+          <a:ln w="25400">
+            <a:solidFill>
+              <a:srgbClr val="F4C95D"/>
+            </a:solidFill>
+            <a:prstDash val="solid"/>
+          </a:ln>
+        </p:spPr>
+      </p:sp>
+      <p:sp>
+        <p:nvSpPr>
+          <p:cNvPr id="18" name="neck ring bar after 1"/>
+          <p:cNvSpPr/>
+          <p:nvPr/>
+        </p:nvSpPr>
+        <p:spPr>
+          <a:xfrm>
+            <a:off x="7817397" y="1839227"/>
+            <a:ext cx="237744" cy="237744"/>
+          </a:xfrm>
+          <a:prstGeom prst="ellipse">
+            <a:avLst/>
+          </a:prstGeom>
+          <a:noFill/>
+          <a:ln w="25400">
+            <a:solidFill>
+              <a:srgbClr val="F4C95D"/>
+            </a:solidFill>
+            <a:prstDash val="solid"/>
+          </a:ln>
+        </p:spPr>
+      </p:sp>
+      <p:sp>
+        <p:nvSpPr>
+          <p:cNvPr id="19" name="neck caption holdout"/>
+          <p:cNvSpPr txBox="1"/>
+          <p:nvPr/>
+        </p:nvSpPr>
+        <p:spPr>
+          <a:xfrm>
+            <a:off x="457200" y="3337233"/>
+            <a:ext cx="4177782" cy="201168"/>
           </a:xfrm>
           <a:prstGeom prst="rect">
             <a:avLst/>
@@ -20967,7 +21043,7 @@
                   <a:schemeClr val="tx1"/>
                 </a:solidFill>
               </a:rPr>
-              <a:t>Synthetic holdout image 579862</a:t>
+              <a:t>Synthetic holdout 579862 (correction only, no training)</a:t>
             </a:r>
             <a:endParaRPr lang="en-US" sz="1100" dirty="0"/>
           </a:p>
@@ -20975,14 +21051,14 @@
       </p:sp>
       <p:sp>
         <p:nvSpPr>
-          <p:cNvPr id="18" name="neck caption 579863"/>
+          <p:cNvPr id="20" name="neck caption bar"/>
           <p:cNvSpPr txBox="1"/>
           <p:nvPr/>
         </p:nvSpPr>
         <p:spPr>
           <a:xfrm>
-            <a:off x="5166286" y="3444934"/>
-            <a:ext cx="3520514" cy="201168"/>
+            <a:off x="4909302" y="3337233"/>
+            <a:ext cx="3777498" cy="201168"/>
           </a:xfrm>
           <a:prstGeom prst="rect">
             <a:avLst/>
@@ -21003,7 +21079,7 @@
                   <a:schemeClr val="tx1"/>
                 </a:solidFill>
               </a:rPr>
-              <a:t>Synthetic holdout image 579863</a:t>
+              <a:t>3DPW test frame (real, never trained on), downtown_bar_00</a:t>
             </a:r>
             <a:endParaRPr lang="en-US" sz="1100" dirty="0"/>
           </a:p>
@@ -21011,13 +21087,13 @@
       </p:sp>
       <p:sp>
         <p:nvSpPr>
-          <p:cNvPr id="19" name="neck figure caption"/>
+          <p:cNvPr id="21" name="neck figure caption"/>
           <p:cNvSpPr txBox="1"/>
           <p:nvPr/>
         </p:nvSpPr>
         <p:spPr>
           <a:xfrm>
-            <a:off x="457200" y="3719254"/>
+            <a:off x="457200" y="3611553"/>
             <a:ext cx="8229600" cy="365760"/>
           </a:xfrm>
           <a:prstGeom prst="rect">
@@ -21039,7 +21115,7 @@
                   <a:schemeClr val="tx1"/>
                 </a:solidFill>
               </a:rPr>
-              <a:t>Same model, no training. On the neck, only the output of neck02 and the head is corrected.</a:t>
+              <a:t>Left: same model, no training; on the neck, only neck02 and the head are corrected. Right: fixed model, fine-tuned 2 epochs.</a:t>
             </a:r>
             <a:endParaRPr lang="en-US" sz="1100" dirty="0"/>
           </a:p>
@@ -21053,7 +21129,7 @@
                   <a:schemeClr val="tx1"/>
                 </a:solidFill>
               </a:rPr>
-              <a:t>Neck skin thickness on the 100-image holdout: 0.46 → 1.00 of the true value (job 3579014).</a:t>
+              <a:t>Neck skin thickness on the 100-image holdout: 0.46 → 1.00 of the true value (job 3579014). Real-image demo: job 3581312.</a:t>
             </a:r>
             <a:endParaRPr lang="en-US" sz="1100" dirty="0"/>
           </a:p>
@@ -21061,13 +21137,13 @@
       </p:sp>
       <p:sp>
         <p:nvSpPr>
-          <p:cNvPr id="20" name="neck figure footnote"/>
+          <p:cNvPr id="22" name="neck figure footnote"/>
           <p:cNvSpPr txBox="1"/>
           <p:nvPr/>
         </p:nvSpPr>
         <p:spPr>
           <a:xfrm>
-            <a:off x="457200" y="4158166"/>
+            <a:off x="457200" y="4050465"/>
             <a:ext cx="8229600" cy="365760"/>
           </a:xfrm>
           <a:prstGeom prst="rect">
@@ -21111,7 +21187,7 @@
                   <a:schemeClr val="tx2"/>
                 </a:solidFill>
               </a:rPr>
-              <a:t>Bodies are still too small here (separate depth bug). Real photos not checked yet.</a:t>
+              <a:t>Holdout bodies are still too small (separate depth bug). Real images judged by eye only: no neck ground truth, no metric.</a:t>
             </a:r>
             <a:endParaRPr lang="en-US" sz="1100" dirty="0"/>
           </a:p>

</xml_diff>

<commit_message>
WIP docs: slide 8 with the real 3DPW neck pair; notes (merge with the final handover)
Co-Authored-By: Claude Opus 5.5 <noreply@anthropic.com>
Claude-Session: https://claude.ai/code/session_016LhpG4kT7Z7ppxbG4TW5S9
</commit_message>
<xml_diff>
--- a/docs/supervisor_update_2026-10-16.pptx
+++ b/docs/supervisor_update_2026-10-16.pptx
@@ -124,7 +124,7 @@
   <p:extLst>
     <p:ext uri="{521415D9-36F7-43E2-AB2F-B90AF26B5E84}">
       <p14:sectionLst xmlns:p14="http://schemas.microsoft.com/office/powerpoint/2010/main">
-        <p14:section name="Overview" id="{ef82fb89-331b-4e6f-5621-3d2f26bb6458}">
+        <p14:section name="Overview" id="{57a97123-4671-0c9b-340c-d8e7c54545af}">
           <p14:sldIdLst>
             <p14:sldId id="256"/>
             <p14:sldId id="257"/>
@@ -132,13 +132,13 @@
             <p14:sldId id="259"/>
           </p14:sldIdLst>
         </p14:section>
-        <p14:section name="3DPW labels" id="{fb228ada-20b5-cb5f-0baa-0bf568c2738f}">
+        <p14:section name="3DPW labels" id="{03f6424f-a281-ca5e-f4ac-dc28ae9382d1}">
           <p14:sldIdLst>
             <p14:sldId id="260"/>
             <p14:sldId id="261"/>
           </p14:sldIdLst>
         </p14:section>
-        <p14:section name="Findings" id="{3c048e27-696e-f31f-9919-5da3aa2c010f}">
+        <p14:section name="Findings" id="{6875509e-20a7-f259-119e-a16f91e3857d}">
           <p14:sldIdLst>
             <p14:sldId id="262"/>
             <p14:sldId id="263"/>
@@ -146,14 +146,14 @@
             <p14:sldId id="265"/>
           </p14:sldIdLst>
         </p14:section>
-        <p14:section name="Bug" id="{e144d7df-82a2-f5ac-5ec4-37598ebb6543}">
+        <p14:section name="Bug" id="{6bf0cd1f-0ba8-1ca0-3397-10095ead2f69}">
           <p14:sldIdLst>
             <p14:sldId id="266"/>
             <p14:sldId id="267"/>
             <p14:sldId id="268"/>
           </p14:sldIdLst>
         </p14:section>
-        <p14:section name="Next" id="{8f65a859-78f3-d3cf-65c6-3a807fa4c422}">
+        <p14:section name="Next" id="{a8f9d1e1-8ad5-7fbc-d63e-2a63bb2ce066}">
           <p14:sldIdLst>
             <p14:sldId id="269"/>
             <p14:sldId id="270"/>
@@ -161,7 +161,7 @@
             <p14:sldId id="272"/>
           </p14:sldIdLst>
         </p14:section>
-        <p14:section name="Appendix" id="{70d06c7f-3bd3-d055-432c-d478faddc087}">
+        <p14:section name="Appendix" id="{fbee3a26-379d-96ca-ac4d-5e8b070e0538}">
           <p14:sldIdLst>
             <p14:sldId id="273"/>
           </p14:sldIdLst>
@@ -1206,7 +1206,7 @@
           <a:p>
             <a:r>
               <a:rPr lang="en-US" dirty="0"/>
-              <a:t>Seven things are still open. First, the bone flips. The neck fix passes in one run; the holdout renders of the correction alone show normal necks, and so, by eye, does a first real-image demo of the fine-tuned model. I still need a longer run, and real images have no neck metric. v10's left arm has the same kind of flip, but a bone further down the arm undoes it, so it needs a two-sided correction, not built yet. Second, the depth slope is stuck at 0.3 to 0.4, cause unknown. Third, the cost of the depth fix, paired on the same people. Fourth, pilot noise: fix the seed or repeat key runs. Fifth, people very close to the camera. Sixth, children and fingers: a longer sampler run, and a look at the hands with the bone fix. Seventh, 3DPW: the rebuild gave the same counts, so the images are likely missing; I will check, re-extract and rebuild. Then gender, frame grid and a re-fit of all 87 tasks, before any 3DPW test.</a:t>
+              <a:t>Seven things are still open. First, the bone flips. The neck fix passes in one run; the holdout renders of the correction alone show normal necks, and so, by eye, do the 8 real images I have seen so far from a first demo of the fine-tuned model. I still need a longer run, and real images have no neck metric. v10's left arm has the same kind of flip, but a bone further down the arm undoes it, so it needs a two-sided correction, not built yet. Second, the depth slope is stuck at 0.3 to 0.4, cause unknown. Third, the cost of the depth fix, paired on the same people. Fourth, pilot noise: fix the seed or repeat key runs. Fifth, people very close to the camera. Sixth, children and fingers: a longer sampler run, and a look at the hands with the bone fix. Seventh, 3DPW: the rebuild gave the same counts, so I re-extracted the images of the eight sequences on 16 October; captureSelfies_00 went from 480 to 750 files. A second rebuild, job 3581320, is pending. Then gender, frame grid and a re-fit of all 87 tasks, before any 3DPW test.</a:t>
             </a:r>
           </a:p>
           <a:p>
@@ -1215,7 +1215,7 @@
           <a:p>
             <a:r>
               <a:rPr lang="en-US" dirty="0"/>
-              <a:t>If asked: Neck: the fine-tuned checkpoint carries the fix in its saved settings, so the demo applies it on load; the demo comparison, job 3581312, ran it next to v5 on 4 example photos and 8 3DPW test frames (slide 8). In the 12 side-by-side holdout panels, with the correction alone and no training, the necks have normal width wherever a neck is visible (slide 8). v10: correcting three of its flipped hand bones passed without training; two more finger bones, seen on training images, are not corrected yet; shoulder01.L at 166 degrees and upperarm02.L at 180 stay flipped, because one constant per bone would break the chain that compensates them. Depth: the training depths so far come from small samples, batch means of about 2.5 to 3.2 metres. I will also measure the fix run's slope on training images; for v5 it was just as low there. Cost: I will report the root error next to PVE in the thesis. Testing the depth fix on 3DPW waits for item seven. The twenty-times 10-epoch run has no result yet. Close people: both models miss them in 4 of the 12 rendered images. Children and fingers: one 2-epoch test is not enough to close them. 3DPW labels: the rebuild, into a new folder, gave the same counts, so my old guess that the builder ran before the fits finished is wrong. The builder skips every frame without an image file. The check is one file count per image folder of the eight affected sequences; if they are empty or short, I unzip the 3DPW images again and rebuild. Gender and the frame grid are different: set men to 0 and, by Anny's convention, women to 1; the refit confirmed it only for men. And pick both people's frames on one shared grid. Both happen inside the fit, so all 87 conversion tasks must be fitted again, into a new folder, because the task script skips every person that already has a file; otherwise old and new fits would mix without a warning. That is an 87-task array job: about 40 GPU hours by the task script's own estimate of 6 seconds per frame, so 5 to 6 hours with 8 GPUs at once; not measured. Then rebuild the labels and run the check again.</a:t>
+              <a:t>If asked: Neck: the fine-tuned checkpoint carries the fix in its saved settings, so the demo applies it on load; the demo comparison, job 3581312, ran it next to v5 on 4 example photos and 8 3DPW test frames (slide 8); I have looked at 8 of these 12 images so far. In the 12 side-by-side holdout panels, with the correction alone and no training, the necks have normal width wherever a neck is visible (slide 8). v10: correcting three of its flipped hand bones passed without training; two more finger bones, seen on training images, are not corrected yet; shoulder01.L at 166 degrees and upperarm02.L at 180 stay flipped, because one constant per bone would break the chain that compensates them. Depth: the training depths so far come from small samples, batch means of about 2.5 to 3.2 metres. I will also measure the fix run's slope on training images; for v5 it was just as low there. Cost: I will report the root error next to PVE in the thesis. Testing the depth fix on 3DPW waits for item seven. The twenty-times 10-epoch run has no result yet. Close people: v5 and the depth-fix model both miss them in 4 of the 12 rendered holdout images (slide 12). Children and fingers: one 2-epoch test is not enough to close them. 3DPW labels: the rebuild, into a new folder, gave the same counts, so my old guess that the builder ran before the fits finished is wrong. The builder skips every frame without an image file. So I re-extracted the image folders of the eight affected sequences on 16 October: captureSelfies_00 had 480 of 750 files; for the other seven the counts before were not recorded. The second rebuild, job 3581320, is pending: if the images were the cause, train rises from 4,451 to about 6,437 label images and validation from 2,458 to about 2,777. Gender and the frame grid are different: set men to 0 and, by Anny's convention, women to 1; the refit confirmed it only for men. And pick both people's frames on one shared grid. Both happen inside the fit, so all 87 conversion tasks must be fitted again, into a new folder, because the task script skips every person that already has a file; otherwise old and new fits would mix without a warning. That is an 87-task array job: about 40 GPU hours by the task script's own estimate of 6 seconds per frame, so 5 to 6 hours with 8 GPUs at once; not measured. Then rebuild the labels and run the check again.</a:t>
             </a:r>
           </a:p>
         </p:txBody>
@@ -1323,7 +1323,7 @@
           <a:p>
             <a:r>
               <a:rPr lang="en-US" dirty="0"/>
-              <a:t>- Neck: the two half-turned bones cancel, so the head points the right way. A 2-epoch geodesic loss did not undo it. The fixed correction with a 2-epoch fine-tune did, in one run: neck02 4.7 degrees, thickness 1.00, head direction 14.4 against 13.8 for its control and 12.0 before. One run without a seed is not proof; the holdout renders of the correction without training show normal neck width, and in a first real-image demo the fine-tuned model's necks look normal, judged by eye only; there is no neck metric on real images. The origin of the flip is not known; the singular start value of the rotation output would start a bone turned about its sideways axis, a tilt like the one in v5's left index base, not the twist in neck02 and the head.</a:t>
+              <a:t>- Neck: the two half-turned bones cancel, so the head points the right way. A 2-epoch geodesic loss did not undo it. The fixed correction with a 2-epoch fine-tune did, in one run: neck02 4.7 degrees, thickness 1.00, head direction 14.4 against 13.8 for its control and 12.0 before. One run without a seed is not proof; the holdout renders of the correction without training show normal neck width, and in a first real-image demo the fine-tuned model's necks look normal in the 8 of its 12 images I have seen, judged by eye only; there is no neck metric on real images. The origin of the flip is not known; the singular start value of the rotation output would start a bone turned about its sideways axis, a tilt like the one in v5's left index base, not the twist in neck02 and the head.</a:t>
             </a:r>
           </a:p>
           <a:p>
@@ -1335,7 +1335,7 @@
           <a:p>
             <a:r>
               <a:rPr lang="en-US" dirty="0"/>
-              <a:t>- 3DPW labels: 6 train sequences, part of a seventh, and one validation sequence have no labels; a rebuild gave the same counts, so their image files are likely missing on the cluster; the check is still to do. For the women, the gender refit is mixed. In the 3DPW labels the head, neck02 and neck03 stay at rest; only neck01 turns. Overall the labels keep about half the head turn, 9.5 against 20 degrees. Train and validation keep most of it; the loss is in the test split, and I do not know why yet. Age is fixed, and the limb-length ratios are not explained yet.</a:t>
+              <a:t>- 3DPW labels: 6 train sequences, part of a seventh, and one validation sequence have no labels; a rebuild gave the same counts, so their image files were likely missing on the cluster. On 16 October I re-extracted them, captureSelfies_00 went from 480 to 750 files, and a second rebuild, job 3581320, is pending. For the women, the gender refit is mixed. In the 3DPW labels the head, neck02 and neck03 stay at rest; only neck01 turns. Overall the labels keep about half the head turn, 9.5 against 20 degrees. Train and validation keep most of it; the loss is in the test split, and I do not know why yet. Age is fixed, and the limb-length ratios are not explained yet.</a:t>
             </a:r>
           </a:p>
           <a:p>
@@ -1881,7 +1881,7 @@
           <a:p>
             <a:r>
               <a:rPr lang="en-US" dirty="0"/>
-              <a:t>The finished labels had never been checked end to end against 3DPW. A cluster check has now done that. Joints, surface and 2D pass. Body joints are 18.7 millimetres off at the median, below the about 26 millimetres cited for 3DPW's own joints. The surface is about 19 millimetres off; that is a nearest-point distance, so a lower bound. But the labels have three defects. First, gender is reversed: with the other gender, the joint error dropped for 72 of 73 male samples. Second, in 407 of 960 two-person images one person has no label, because that person was not fitted on that frame. Third, labels are missing for 6 train sequences, part of a seventh, and one validation sequence. The fits exist, but a rebuild gave the same counts. So the image files of those sequences are likely missing on the cluster; I have not checked that yet.</a:t>
+              <a:t>The finished labels had never been checked end to end against 3DPW. A cluster check has now done that. Joints, surface and 2D pass. Body joints are 18.7 millimetres off at the median, below the about 26 millimetres cited for 3DPW's own joints. The surface is about 19 millimetres off; that is a nearest-point distance, so a lower bound. But the labels have three defects. First, gender is reversed: with the other gender, the joint error dropped for 72 of 73 male samples. Second, in 407 of 960 two-person images one person has no label, because that person was not fitted on that frame. Third, labels are missing for 6 train sequences, part of a seventh, and one validation sequence. The fits exist, but a rebuild gave the same counts, so the image files of those sequences were likely missing on the cluster. On 16 October I re-extracted the images of the eight sequences; captureSelfies_00 went from 480 to 750 files. A second rebuild, job 3581320, is pending.</a:t>
             </a:r>
           </a:p>
           <a:p>
@@ -1908,7 +1908,7 @@
           <a:p>
             <a:r>
               <a:rPr lang="en-US" dirty="0"/>
-              <a:t>- Missing labels: train has 4,451 of 6,437 expected label images, validation 2,458 of 2,777. The rebuild, job 3579266, gave the same image counts: train 4,451 (5,183 people), validation 2,458, test 9,722, 16,631 label files in total; the same six train sequences and basketball_01 at zero, captureSelfies_00 at 319. The label builder skips every frame whose image file is missing, without a warning. So the likely cause is an incomplete unzip of the 3DPW images on the cluster; counting the files in each of those image folders will show it. My earlier guess, that the builder ran before the fits finished, was wrong. All 162 frames of outdoors_crosscountry_00 are dropped by the visibility filter, under 30 percent visible; the fits are fine, and I have not yet checked why the whole sequence counts as not visible.</a:t>
+              <a:t>- Missing labels: train has 4,451 of 6,437 expected label images, validation 2,458 of 2,777. The rebuild, job 3579266, gave the same image counts: train 4,451 (5,183 people), validation 2,458, test 9,722, 16,631 label files in total; the same six train sequences and basketball_01 at zero, captureSelfies_00 at 319. The label builder skips every frame whose image file is missing, without a warning. So the likely cause is an incomplete unzip of the 3DPW images on the cluster. On 16 October I re-extracted the image folders of the eight sequences: captureSelfies_00 had 480 of 750 files; for the other seven the counts before were not recorded. The second rebuild, job 3581320, is pending; if the images were the cause, train rises to about 6,437 label images and validation to about 2,777. My earlier guess, that the builder ran before the fits finished, was wrong. All 162 frames of outdoors_crosscountry_00 are dropped by the visibility filter, under 30 percent visible; the fits are fine, and I have not yet checked why the whole sequence counts as not visible.</a:t>
             </a:r>
           </a:p>
           <a:p>
@@ -2130,7 +2130,7 @@
           <a:p>
             <a:r>
               <a:rPr lang="en-US" dirty="0"/>
-              <a:t>- The right column is the fine-tuned checkpoint, so it differs from v5 by the correction and by two epochs of training; this pair cannot separate the two. The demo log shows the fix on for four bones. Demo: job 3581312, person detector, each body placed from its detection box, 4 example photos and 8 3DPW test frames.</a:t>
+              <a:t>- The right column is the fine-tuned checkpoint, so it differs from v5 by the correction and by two epochs of training; this pair cannot separate the two. On the holdout, the same 2-epoch fine-tune without the fix keeps thickness 0.46, so the correction is the likely cause; not tested on real images. The demo log shows the fix on for four bones. Demo: job 3581312, person detector, each body placed from its detection box, 4 example photos and 8 3DPW test frames. I have looked at 8 of these 12 images so far; the other four, the runForBus, sitOnStairs and fencing frames and one photo, not yet.</a:t>
             </a:r>
           </a:p>
           <a:p>
@@ -12405,7 +12405,7 @@
                   <a:schemeClr val="tx2"/>
                 </a:solidFill>
               </a:rPr>
-              <a:t>Both models miss them (4 of 12 rendered images), so not the fix. Likely detection; not yet counted.</a:t>
+              <a:t>Both v5 and the depth fix miss them (4 of 12 holdout renders): not the fix. Likely detection; not counted.</a:t>
             </a:r>
             <a:endParaRPr lang="en-US" sz="1200" dirty="0"/>
           </a:p>
@@ -12671,7 +12671,7 @@
                   <a:schemeClr val="tx2"/>
                 </a:solidFill>
               </a:rPr>
-              <a:t>Rebuild gave the same counts; the image files are likely missing (check pending): re-extract, rebuild. Then gender (m → 0, f → 1), one shared frame grid, re-fit all 87 tasks, rebuild, re-check. Proposed: only then use 3DPW.</a:t>
+              <a:t>Images of the missing sequences re-extracted 16 Oct; second rebuild job 3581320 pending. Then gender (m → 0, f → 1), one shared frame grid, re-fit all 87 tasks, rebuild, re-check. Proposed: only then use 3DPW.</a:t>
             </a:r>
             <a:endParaRPr lang="en-US" sz="1200" dirty="0"/>
           </a:p>
@@ -17471,7 +17471,7 @@
                   <a:schemeClr val="tx1"/>
                 </a:solidFill>
               </a:rPr>
-              <a:t>6 train sequences, part of captureSelfies_00, val basketball_01. Rebuild: same counts; likely missing image files.</a:t>
+              <a:t>6 train sequences, part of captureSelfies_00, val basketball_01. Images re-extracted; second rebuild job 3581320 pending.</a:t>
             </a:r>
             <a:endParaRPr lang="en-US" sz="1100" dirty="0"/>
           </a:p>
@@ -20346,7 +20346,7 @@
                   <a:schemeClr val="tx1"/>
                 </a:solidFill>
               </a:rPr>
-              <a:t>why the bones flipped. Next slide: the fix on a holdout image and on a real 3DPW test frame (by eye).</a:t>
+              <a:t>why the bones flipped. Next slide: the fix alone on a holdout image; fix + fine-tune on a real 3DPW frame.</a:t>
             </a:r>
             <a:endParaRPr lang="en-US" sz="1200" dirty="0"/>
           </a:p>
@@ -20523,7 +20523,7 @@
                   <a:schemeClr val="tx1"/>
                 </a:solidFill>
               </a:rPr>
-              <a:t>Neck: before and after the correction</a:t>
+              <a:t>Neck: before and after the fix</a:t>
             </a:r>
             <a:endParaRPr lang="en-US" sz="2700" dirty="0"/>
           </a:p>
@@ -20938,7 +20938,7 @@
                   <a:srgbClr val="FFFFFF"/>
                 </a:solidFill>
               </a:rPr>
-              <a:t>correction + 2-epoch fine-tune</a:t>
+              <a:t>fix + 2-epoch fine-tune</a:t>
             </a:r>
             <a:endParaRPr lang="en-US" sz="1600" dirty="0"/>
           </a:p>

</xml_diff>

<commit_message>
docs: label rebuild 3581320 done (train 6,437, val 2,777 images) in handover and deck
The re-extracted images fix the missing-labels defect; gender and two-person
defects remain until the v2.3 refit, so labels_rebuilt is not for training.

Co-Authored-By: Claude Opus 5.5 <noreply@anthropic.com>
Claude-Session: https://claude.ai/code/session_016LhpG4kT7Z7ppxbG4TW5S9
</commit_message>
<xml_diff>
--- a/docs/supervisor_update_2026-10-16.pptx
+++ b/docs/supervisor_update_2026-10-16.pptx
@@ -124,7 +124,7 @@
   <p:extLst>
     <p:ext uri="{521415D9-36F7-43E2-AB2F-B90AF26B5E84}">
       <p14:sectionLst xmlns:p14="http://schemas.microsoft.com/office/powerpoint/2010/main">
-        <p14:section name="Overview" id="{57a97123-4671-0c9b-340c-d8e7c54545af}">
+        <p14:section name="Overview" id="{0ef16ca8-16ca-afbb-50d7-0f91f805e331}">
           <p14:sldIdLst>
             <p14:sldId id="256"/>
             <p14:sldId id="257"/>
@@ -132,13 +132,13 @@
             <p14:sldId id="259"/>
           </p14:sldIdLst>
         </p14:section>
-        <p14:section name="3DPW labels" id="{03f6424f-a281-ca5e-f4ac-dc28ae9382d1}">
+        <p14:section name="3DPW labels" id="{d1f7bbda-37fc-f8ce-cc91-2dec125c61d6}">
           <p14:sldIdLst>
             <p14:sldId id="260"/>
             <p14:sldId id="261"/>
           </p14:sldIdLst>
         </p14:section>
-        <p14:section name="Findings" id="{6875509e-20a7-f259-119e-a16f91e3857d}">
+        <p14:section name="Findings" id="{c444980a-b04a-4a44-c320-c76cd50a248d}">
           <p14:sldIdLst>
             <p14:sldId id="262"/>
             <p14:sldId id="263"/>
@@ -146,14 +146,14 @@
             <p14:sldId id="265"/>
           </p14:sldIdLst>
         </p14:section>
-        <p14:section name="Bug" id="{6bf0cd1f-0ba8-1ca0-3397-10095ead2f69}">
+        <p14:section name="Bug" id="{126f1db0-e9e2-e170-478f-c2ed8fe5af99}">
           <p14:sldIdLst>
             <p14:sldId id="266"/>
             <p14:sldId id="267"/>
             <p14:sldId id="268"/>
           </p14:sldIdLst>
         </p14:section>
-        <p14:section name="Next" id="{a8f9d1e1-8ad5-7fbc-d63e-2a63bb2ce066}">
+        <p14:section name="Next" id="{160f6312-a0c3-0698-5fe6-2ca20a2e9188}">
           <p14:sldIdLst>
             <p14:sldId id="269"/>
             <p14:sldId id="270"/>
@@ -161,7 +161,7 @@
             <p14:sldId id="272"/>
           </p14:sldIdLst>
         </p14:section>
-        <p14:section name="Appendix" id="{fbee3a26-379d-96ca-ac4d-5e8b070e0538}">
+        <p14:section name="Appendix" id="{7771e3ca-d719-1464-6e77-536e1aef1ad4}">
           <p14:sldIdLst>
             <p14:sldId id="273"/>
           </p14:sldIdLst>
@@ -1206,7 +1206,7 @@
           <a:p>
             <a:r>
               <a:rPr lang="en-US" dirty="0"/>
-              <a:t>Seven things are still open. First, the bone flips. The neck fix passes in one run; the holdout renders of the correction alone show normal necks, and so, by eye, do the 8 real images I have seen so far from a first demo of the fine-tuned model. I still need a longer run, and real images have no neck metric. v10's left arm has the same kind of flip, but a bone further down the arm undoes it, so it needs a two-sided correction, not built yet. Second, the depth slope is stuck at 0.3 to 0.4, cause unknown. Third, the cost of the depth fix, paired on the same people. Fourth, pilot noise: fix the seed or repeat key runs. Fifth, people very close to the camera. Sixth, children and fingers: a longer sampler run, and a look at the hands with the bone fix. Seventh, 3DPW: the rebuild gave the same counts, so I re-extracted the images of the eight sequences on 16 October; captureSelfies_00 went from 480 to 750 files. A second rebuild, job 3581320, is pending. Then gender, frame grid and a re-fit of all 87 tasks, before any 3DPW test.</a:t>
+              <a:t>Seven things are still open. First, the bone flips. The neck fix passes in one run; the holdout renders of the correction alone show normal necks, and so, by eye, do the 8 real images I have seen so far from a first demo of the fine-tuned model. I still need a longer run, and real images have no neck metric. v10's left arm has the same kind of flip, but a bone further down the arm undoes it, so it needs a two-sided correction, not built yet. Second, the depth slope is stuck at 0.3 to 0.4, cause unknown. Third, the cost of the depth fix, paired on the same people. Fourth, pilot noise: fix the seed or repeat key runs. Fifth, people very close to the camera. Sixth, children and fingers: a longer sampler run, and a look at the hands with the bone fix. Seventh, 3DPW: the first rebuild gave the same counts, so I re-extracted the images of the eight sequences on 16 October; captureSelfies_00 went from 480 to 750 files. The second rebuild, job 3581320, brought the missing labels back: train 6,437 label images instead of 4,451, validation 2,777 instead of 2,458. Then gender, frame grid and a re-fit of all 87 tasks, before any 3DPW test.</a:t>
             </a:r>
           </a:p>
           <a:p>
@@ -1215,7 +1215,7 @@
           <a:p>
             <a:r>
               <a:rPr lang="en-US" dirty="0"/>
-              <a:t>If asked: Neck: the fine-tuned checkpoint carries the fix in its saved settings, so the demo applies it on load; the demo comparison, job 3581312, ran it next to v5 on 4 example photos and 8 3DPW test frames (slide 8); I have looked at 8 of these 12 images so far. In the 12 side-by-side holdout panels, with the correction alone and no training, the necks have normal width wherever a neck is visible (slide 8). v10: correcting three of its flipped hand bones passed without training; two more finger bones, seen on training images, are not corrected yet; shoulder01.L at 166 degrees and upperarm02.L at 180 stay flipped, because one constant per bone would break the chain that compensates them. Depth: the training depths so far come from small samples, batch means of about 2.5 to 3.2 metres. I will also measure the fix run's slope on training images; for v5 it was just as low there. Cost: I will report the root error next to PVE in the thesis. Testing the depth fix on 3DPW waits for item seven. The twenty-times 10-epoch run has no result yet. Close people: v5 and the depth-fix model both miss them in 4 of the 12 rendered holdout images (slide 12). Children and fingers: one 2-epoch test is not enough to close them. 3DPW labels: the rebuild, into a new folder, gave the same counts, so my old guess that the builder ran before the fits finished is wrong. The builder skips every frame without an image file. So I re-extracted the image folders of the eight affected sequences on 16 October: captureSelfies_00 had 480 of 750 files; for the other seven the counts before were not recorded. The second rebuild, job 3581320, is pending: if the images were the cause, train rises from 4,451 to about 6,437 label images and validation from 2,458 to about 2,777. Gender and the frame grid are different: set men to 0 and, by Anny's convention, women to 1; the refit confirmed it only for men. And pick both people's frames on one shared grid. Both happen inside the fit, so all 87 conversion tasks must be fitted again, into a new folder, because the task script skips every person that already has a file; otherwise old and new fits would mix without a warning. That is an 87-task array job: about 40 GPU hours by the task script's own estimate of 6 seconds per frame, so 5 to 6 hours with 8 GPUs at once; not measured. Then rebuild the labels and run the check again.</a:t>
+              <a:t>If asked: Neck: the fine-tuned checkpoint carries the fix in its saved settings, so the demo applies it on load; the demo comparison, job 3581312, ran it next to v5 on 4 example photos and 8 3DPW test frames (slide 8); I have looked at 8 of these 12 images so far. In the 12 side-by-side holdout panels, with the correction alone and no training, the necks have normal width wherever a neck is visible (slide 8). v10: correcting three of its flipped hand bones passed without training; two more finger bones, seen on training images, are not corrected yet; shoulder01.L at 166 degrees and upperarm02.L at 180 stay flipped, because one constant per bone would break the chain that compensates them. Depth: the training depths so far come from small samples, batch means of about 2.5 to 3.2 metres. I will also measure the fix run's slope on training images; for v5 it was just as low there. Cost: I will report the root error next to PVE in the thesis. Testing the depth fix on 3DPW waits for item seven. The twenty-times 10-epoch run has no result yet. Close people: v5 and the depth-fix model both miss them in 4 of the 12 rendered holdout images (slide 12). Children and fingers: one 2-epoch test is not enough to close them. 3DPW labels: the rebuild, into a new folder, gave the same counts, so my old guess that the builder ran before the fits finished is wrong. The builder skips every frame without an image file. So I re-extracted the image folders of the eight affected sequences on 16 October: captureSelfies_00 had 480 of 750 files; for the other seven the counts before were not recorded. The second rebuild, job 3581320, confirmed it: train rose from 4,451 to 6,437 label images and validation from 2,458 to 2,777, exactly what the fits imply; test stayed at 9,722. Those labels still have the reversed gender and the missing second person. Gender and the frame grid are different: set men to 0 and, by Anny's convention, women to 1; the refit confirmed it only for men. And pick both people's frames on one shared grid. Both happen inside the fit, so all 87 conversion tasks must be fitted again, into a new folder, because the task script skips every person that already has a file; otherwise old and new fits would mix without a warning. That is an 87-task array job: about 40 GPU hours by the task script's own estimate of 6 seconds per frame, so 5 to 6 hours with 8 GPUs at once; not measured. Then rebuild the labels and run the check again.</a:t>
             </a:r>
           </a:p>
         </p:txBody>
@@ -1335,7 +1335,7 @@
           <a:p>
             <a:r>
               <a:rPr lang="en-US" dirty="0"/>
-              <a:t>- 3DPW labels: 6 train sequences, part of a seventh, and one validation sequence have no labels; a rebuild gave the same counts, so their image files were likely missing on the cluster. On 16 October I re-extracted them, captureSelfies_00 went from 480 to 750 files, and a second rebuild, job 3581320, is pending. For the women, the gender refit is mixed. In the 3DPW labels the head, neck02 and neck03 stay at rest; only neck01 turns. Overall the labels keep about half the head turn, 9.5 against 20 degrees. Train and validation keep most of it; the loss is in the test split, and I do not know why yet. Age is fixed, and the limb-length ratios are not explained yet.</a:t>
+              <a:t>- 3DPW labels: 6 train sequences, part of a seventh, and one validation sequence had no labels, because their image files were missing on the cluster. On 16 October I re-extracted them, captureSelfies_00 went from 480 to 750 files, and a second rebuild, job 3581320, brought the labels back: train 6,437 label images instead of 4,451, validation 2,777 instead of 2,458. Gender and the missing second person still need the re-fit. For the women, the gender refit is mixed. In the 3DPW labels the head, neck02 and neck03 stay at rest; only neck01 turns. Overall the labels keep about half the head turn, 9.5 against 20 degrees. Train and validation keep most of it; the loss is in the test split, and I do not know why yet. Age is fixed, and the limb-length ratios are not explained yet.</a:t>
             </a:r>
           </a:p>
           <a:p>
@@ -1881,7 +1881,7 @@
           <a:p>
             <a:r>
               <a:rPr lang="en-US" dirty="0"/>
-              <a:t>The finished labels had never been checked end to end against 3DPW. A cluster check has now done that. Joints, surface and 2D pass. Body joints are 18.7 millimetres off at the median, below the about 26 millimetres cited for 3DPW's own joints. The surface is about 19 millimetres off; that is a nearest-point distance, so a lower bound. But the labels have three defects. First, gender is reversed: with the other gender, the joint error dropped for 72 of 73 male samples. Second, in 407 of 960 two-person images one person has no label, because that person was not fitted on that frame. Third, labels are missing for 6 train sequences, part of a seventh, and one validation sequence. The fits exist, but a rebuild gave the same counts, so the image files of those sequences were likely missing on the cluster. On 16 October I re-extracted the images of the eight sequences; captureSelfies_00 went from 480 to 750 files. A second rebuild, job 3581320, is pending.</a:t>
+              <a:t>The finished labels had never been checked end to end against 3DPW. A cluster check has now done that. Joints, surface and 2D pass. Body joints are 18.7 millimetres off at the median, below the about 26 millimetres cited for 3DPW's own joints. The surface is about 19 millimetres off; that is a nearest-point distance, so a lower bound. But the labels have three defects. First, gender is reversed: with the other gender, the joint error dropped for 72 of 73 male samples. Second, in 407 of 960 two-person images one person has no label, because that person was not fitted on that frame. Third, labels were missing for 6 train sequences, part of a seventh, and one validation sequence. The fits existed, but a first rebuild gave the same counts: the image files of those sequences were missing on the cluster. On 16 October I re-extracted the images of the eight sequences; captureSelfies_00 went from 480 to 750 files. The second rebuild, job 3581320, brought the labels back: train now has 6,437 label images instead of 4,451, validation 2,777 instead of 2,458, exactly what the fits imply. This third defect is fixed; the first two need the re-fit.</a:t>
             </a:r>
           </a:p>
           <a:p>
@@ -1908,7 +1908,7 @@
           <a:p>
             <a:r>
               <a:rPr lang="en-US" dirty="0"/>
-              <a:t>- Missing labels: train has 4,451 of 6,437 expected label images, validation 2,458 of 2,777. The rebuild, job 3579266, gave the same image counts: train 4,451 (5,183 people), validation 2,458, test 9,722, 16,631 label files in total; the same six train sequences and basketball_01 at zero, captureSelfies_00 at 319. The label builder skips every frame whose image file is missing, without a warning. So the likely cause is an incomplete unzip of the 3DPW images on the cluster. On 16 October I re-extracted the image folders of the eight sequences: captureSelfies_00 had 480 of 750 files; for the other seven the counts before were not recorded. The second rebuild, job 3581320, is pending; if the images were the cause, train rises to about 6,437 label images and validation to about 2,777. My earlier guess, that the builder ran before the fits finished, was wrong. All 162 frames of outdoors_crosscountry_00 are dropped by the visibility filter, under 30 percent visible; the fits are fine, and I have not yet checked why the whole sequence counts as not visible.</a:t>
+              <a:t>- Missing labels: train had 4,451 of 6,437 expected label images, validation 2,458 of 2,777. The first rebuild, job 3579266, gave the same image counts: train 4,451 (5,183 people), validation 2,458, test 9,722, 16,631 label files in total; the same six train sequences and basketball_01 at zero, captureSelfies_00 at 319. The label builder skips every frame whose image file is missing, without a warning. So the likely cause was an incomplete unzip of the 3DPW images on the cluster. On 16 October I re-extracted the image folders of the eight sequences: captureSelfies_00 had 480 of 750 files; for the other seven the counts before were not recorded. The second rebuild, job 3581320, gave train 6,437 label images with 7,589 people, validation 2,777, test 9,722 unchanged: 18,936 label files, exactly what the fits imply. All six train sequences and basketball_01 now have labels, and captureSelfies_00 has 401. These rebuilt labels still come from the old fits, so gender is still reversed; I will not train on them before the re-fit. My earlier guess, that the builder ran before the fits finished, was wrong. All 162 frames of outdoors_crosscountry_00 are dropped by the visibility filter, under 30 percent visible; the fits are fine, and I have not yet checked why the whole sequence counts as not visible.</a:t>
             </a:r>
           </a:p>
           <a:p>
@@ -12671,7 +12671,7 @@
                   <a:schemeClr val="tx2"/>
                 </a:solidFill>
               </a:rPr>
-              <a:t>Images of the missing sequences re-extracted 16 Oct; second rebuild job 3581320 pending. Then gender (m → 0, f → 1), one shared frame grid, re-fit all 87 tasks, rebuild, re-check. Proposed: only then use 3DPW.</a:t>
+              <a:t>Missing labels fixed 16 Oct (images re-extracted; train 4,451 → 6,437 images). Then gender (m → 0, f → 1), one shared frame grid, re-fit all 87 tasks, rebuild, re-check. Proposed: only then use 3DPW.</a:t>
             </a:r>
             <a:endParaRPr lang="en-US" sz="1200" dirty="0"/>
           </a:p>
@@ -17471,7 +17471,7 @@
                   <a:schemeClr val="tx1"/>
                 </a:solidFill>
               </a:rPr>
-              <a:t>6 train sequences, part of captureSelfies_00, val basketball_01. Images re-extracted; second rebuild job 3581320 pending.</a:t>
+              <a:t>6 train sequences, part of captureSelfies_00, val basketball_01 (image files missing). Fixed 16 Oct: train 4,451 → 6,437, val 2,458 → 2,777.</a:t>
             </a:r>
             <a:endParaRPr lang="en-US" sz="1100" dirty="0"/>
           </a:p>

</xml_diff>

<commit_message>
Handover and deck notes: refit test 3589270, venv route, queue lessons, next steps
Co-Authored-By: Claude Opus 5.5 <noreply@anthropic.com>
Claude-Session: https://claude.ai/code/session_016LhpG4kT7Z7ppxbG4TW5S9
</commit_message>
<xml_diff>
--- a/docs/supervisor_update_2026-10-16.pptx
+++ b/docs/supervisor_update_2026-10-16.pptx
@@ -124,7 +124,7 @@
   <p:extLst>
     <p:ext uri="{521415D9-36F7-43E2-AB2F-B90AF26B5E84}">
       <p14:sectionLst xmlns:p14="http://schemas.microsoft.com/office/powerpoint/2010/main">
-        <p14:section name="Overview" id="{0ef16ca8-16ca-afbb-50d7-0f91f805e331}">
+        <p14:section name="Overview" id="{a3f549c6-928f-8fed-980a-7936e1d82ad5}">
           <p14:sldIdLst>
             <p14:sldId id="256"/>
             <p14:sldId id="257"/>
@@ -132,13 +132,13 @@
             <p14:sldId id="259"/>
           </p14:sldIdLst>
         </p14:section>
-        <p14:section name="3DPW labels" id="{d1f7bbda-37fc-f8ce-cc91-2dec125c61d6}">
+        <p14:section name="3DPW labels" id="{2b62828c-cb16-65dd-8f24-15f8120f0c5e}">
           <p14:sldIdLst>
             <p14:sldId id="260"/>
             <p14:sldId id="261"/>
           </p14:sldIdLst>
         </p14:section>
-        <p14:section name="Findings" id="{c444980a-b04a-4a44-c320-c76cd50a248d}">
+        <p14:section name="Findings" id="{57511f15-a8ea-5439-d464-4c4bded6ead5}">
           <p14:sldIdLst>
             <p14:sldId id="262"/>
             <p14:sldId id="263"/>
@@ -146,14 +146,14 @@
             <p14:sldId id="265"/>
           </p14:sldIdLst>
         </p14:section>
-        <p14:section name="Bug" id="{126f1db0-e9e2-e170-478f-c2ed8fe5af99}">
+        <p14:section name="Bug" id="{f0678ead-e463-2402-23d9-3be0857e0249}">
           <p14:sldIdLst>
             <p14:sldId id="266"/>
             <p14:sldId id="267"/>
             <p14:sldId id="268"/>
           </p14:sldIdLst>
         </p14:section>
-        <p14:section name="Next" id="{160f6312-a0c3-0698-5fe6-2ca20a2e9188}">
+        <p14:section name="Next" id="{6155cb80-aeea-04a6-02be-6be0f6cb7bf5}">
           <p14:sldIdLst>
             <p14:sldId id="269"/>
             <p14:sldId id="270"/>
@@ -161,7 +161,7 @@
             <p14:sldId id="272"/>
           </p14:sldIdLst>
         </p14:section>
-        <p14:section name="Appendix" id="{7771e3ca-d719-1464-6e77-536e1aef1ad4}">
+        <p14:section name="Appendix" id="{b3fa66c5-dc75-784e-741f-14c76b2142f4}">
           <p14:sldIdLst>
             <p14:sldId id="273"/>
           </p14:sldIdLst>
@@ -1206,7 +1206,7 @@
           <a:p>
             <a:r>
               <a:rPr lang="en-US" dirty="0"/>
-              <a:t>Seven things are still open. First, the bone flips. The neck fix passes in one run; the holdout renders of the correction alone show normal necks, and so, by eye, do the 8 real images I have seen so far from a first demo of the fine-tuned model. I still need a longer run, and real images have no neck metric. v10's left arm has the same kind of flip, but a bone further down the arm undoes it, so it needs a two-sided correction, not built yet. Second, the depth slope is stuck at 0.3 to 0.4, cause unknown. Third, the cost of the depth fix, paired on the same people. Fourth, pilot noise: fix the seed or repeat key runs. Fifth, people very close to the camera. Sixth, children and fingers: a longer sampler run, and a look at the hands with the bone fix. Seventh, 3DPW: the first rebuild gave the same counts, so I re-extracted the images of the eight sequences on 16 October; captureSelfies_00 went from 480 to 750 files. The second rebuild, job 3581320, brought the missing labels back: train 6,437 label images instead of 4,451, validation 2,777 instead of 2,458. Then gender, frame grid and a re-fit of all 87 tasks, before any 3DPW test.</a:t>
+              <a:t>Seven things are still open. First, the bone flips. The neck fix passes in one run; the holdout renders of the correction alone show normal necks, and so, by eye, do the 8 real images I have seen so far from a first demo of the fine-tuned model. I still need a longer run, and real images have no neck metric. v10's left arm has the same kind of flip, but a bone further down the arm undoes it, so it needs a two-sided correction, not built yet. Second, the depth slope is stuck at 0.3 to 0.4, cause unknown. Third, the cost of the depth fix, paired on the same people. Fourth, pilot noise: fix the seed or repeat key runs. Fifth, people very close to the camera. Sixth, children and fingers: a longer sampler run, and a look at the hands with the bone fix. Seventh, 3DPW: the first rebuild gave the same counts, so I re-extracted the images of the eight sequences on 16 October; captureSelfies_00 went from 480 to 750 files. The second rebuild, job 3581320, brought the missing labels back: train 6,437 label images instead of 4,451, validation 2,777 instead of 2,458. Then gender, frame grid and a re-fit of all 87 tasks, before any 3DPW test. A first test on one two-person sequence ran on 17 October: the man, now with the correct gender, fits at 14.3 millimetres, the woman at 15.5, and both people are fitted on one shared frame grid; the full re-fit has not run yet.</a:t>
             </a:r>
           </a:p>
           <a:p>
@@ -1215,7 +1215,7 @@
           <a:p>
             <a:r>
               <a:rPr lang="en-US" dirty="0"/>
-              <a:t>If asked: Neck: the fine-tuned checkpoint carries the fix in its saved settings, so the demo applies it on load; the demo comparison, job 3581312, ran it next to v5 on 4 example photos and 8 3DPW test frames (slide 8); I have looked at 8 of these 12 images so far. In the 12 side-by-side holdout panels, with the correction alone and no training, the necks have normal width wherever a neck is visible (slide 8). v10: correcting three of its flipped hand bones passed without training; two more finger bones, seen on training images, are not corrected yet; shoulder01.L at 166 degrees and upperarm02.L at 180 stay flipped, because one constant per bone would break the chain that compensates them. Depth: the training depths so far come from small samples, batch means of about 2.5 to 3.2 metres. I will also measure the fix run's slope on training images; for v5 it was just as low there. Cost: I will report the root error next to PVE in the thesis. Testing the depth fix on 3DPW waits for item seven. The twenty-times 10-epoch run has no result yet. Close people: v5 and the depth-fix model both miss them in 4 of the 12 rendered holdout images (slide 12). Children and fingers: one 2-epoch test is not enough to close them. 3DPW labels: the rebuild, into a new folder, gave the same counts, so my old guess that the builder ran before the fits finished is wrong. The builder skips every frame without an image file. So I re-extracted the image folders of the eight affected sequences on 16 October: captureSelfies_00 had 480 of 750 files; for the other seven the counts before were not recorded. The second rebuild, job 3581320, confirmed it: train rose from 4,451 to 6,437 label images and validation from 2,458 to 2,777, exactly what the fits imply; test stayed at 9,722. Those labels still have the reversed gender and the missing second person. Gender and the frame grid are different: set men to 0 and, by Anny's convention, women to 1; the refit confirmed it only for men. And pick both people's frames on one shared grid. Both happen inside the fit, so all 87 conversion tasks must be fitted again, into a new folder, because the task script skips every person that already has a file; otherwise old and new fits would mix without a warning. That is an 87-task array job: about 40 GPU hours by the task script's own estimate of 6 seconds per frame, so 5 to 6 hours with 8 GPUs at once; not measured. Then rebuild the labels and run the check again.</a:t>
+              <a:t>If asked: Neck: the fine-tuned checkpoint carries the fix in its saved settings, so the demo applies it on load; the demo comparison, job 3581312, ran it next to v5 on 4 example photos and 8 3DPW test frames (slide 8); I have looked at 8 of these 12 images so far. In the 12 side-by-side holdout panels, with the correction alone and no training, the necks have normal width wherever a neck is visible (slide 8). v10: correcting three of its flipped hand bones passed without training; two more finger bones, seen on training images, are not corrected yet; shoulder01.L at 166 degrees and upperarm02.L at 180 stay flipped, because one constant per bone would break the chain that compensates them. Depth: the training depths so far come from small samples, batch means of about 2.5 to 3.2 metres. I will also measure the fix run's slope on training images; for v5 it was just as low there. Cost: I will report the root error next to PVE in the thesis. Testing the depth fix on 3DPW waits for item seven. The twenty-times 10-epoch run has no result yet. Close people: v5 and the depth-fix model both miss them in 4 of the 12 rendered holdout images (slide 12). Children and fingers: one 2-epoch test is not enough to close them. 3DPW labels: the rebuild, into a new folder, gave the same counts, so my old guess that the builder ran before the fits finished is wrong. The builder skips every frame without an image file. So I re-extracted the image folders of the eight affected sequences on 16 October: captureSelfies_00 had 480 of 750 files; for the other seven the counts before were not recorded. The second rebuild, job 3581320, confirmed it: train rose from 4,451 to 6,437 label images and validation from 2,458 to 2,777, exactly what the fits imply; test stayed at 9,722. Those labels still have the reversed gender and the missing second person. Gender and the frame grid are different: set men to 0 and, by Anny's convention, women to 1; the gender refit in the 15-October check confirmed it only for men. And pick both people's frames on one shared grid. Both happen inside the fit, so all 87 conversion tasks must be fitted again, into a new folder, because the task script skips every person that already has a file; the task script now refuses to mix old and new fits. That is an 87-task array job: about 28 GPU hours at the measured 4.4 seconds per frame (the 17 October test, on an H100), so about 3.5 to 4 hours with 8 free H100s. Then rebuild the labels and run the check again.</a:t>
             </a:r>
           </a:p>
         </p:txBody>
@@ -1347,7 +1347,7 @@
           <a:p>
             <a:r>
               <a:rPr lang="en-US" dirty="0"/>
-              <a:t>- Option 2, labels first: men to 0, women to 1 by Anny's convention, one shared frame grid, re-fit all 87 conversion tasks into a new folder, rebuild the labels, then fine-tune. Rebuilding the labels alone is not enough, because the gender and the frame choice are fixed inside the fit; the re-fit is an 87-task array job, about 40 GPU hours by the script's own estimate. I prefer the re-fit first: 3DPW is 30 percent of each batch, so a fine-tune before it would keep learning the wrong body for the men.</a:t>
+              <a:t>- Option 2, labels first: men to 0, women to 1 by Anny's convention, one shared frame grid, re-fit all 87 conversion tasks into a new folder, rebuild the labels, then fine-tune. Rebuilding the labels alone is not enough, because the gender and the frame choice are fixed inside the fit; the re-fit is an 87-task array job, about 28 GPU hours at the measured 4.4 seconds per frame, so about 3.5 to 4 hours with 8 free H100s. A first test on one two-person sequence, on 17 October, gave the man the correct gender and 14.3 millimetres, with both people on one shared frame grid; the full re-fit has not run yet. The fine-tune after it would start from v5 with v5's own bone fix and the depth fix, run 10 epochs, and have a control run without the two fixes; it has not run yet. I prefer the re-fit first: 3DPW is 30 percent of each batch, so a fine-tune before it would keep learning the wrong body for the men.</a:t>
             </a:r>
           </a:p>
           <a:p>
@@ -1881,7 +1881,7 @@
           <a:p>
             <a:r>
               <a:rPr lang="en-US" dirty="0"/>
-              <a:t>The finished labels had never been checked end to end against 3DPW. A cluster check has now done that. Joints, surface and 2D pass. Body joints are 18.7 millimetres off at the median, below the about 26 millimetres cited for 3DPW's own joints. The surface is about 19 millimetres off; that is a nearest-point distance, so a lower bound. But the labels have three defects. First, gender is reversed: with the other gender, the joint error dropped for 72 of 73 male samples. Second, in 407 of 960 two-person images one person has no label, because that person was not fitted on that frame. Third, labels were missing for 6 train sequences, part of a seventh, and one validation sequence. The fits existed, but a first rebuild gave the same counts: the image files of those sequences were missing on the cluster. On 16 October I re-extracted the images of the eight sequences; captureSelfies_00 went from 480 to 750 files. The second rebuild, job 3581320, brought the labels back: train now has 6,437 label images instead of 4,451, validation 2,777 instead of 2,458, exactly what the fits imply. This third defect is fixed; the first two need the re-fit.</a:t>
+              <a:t>The finished labels had never been checked end to end against 3DPW. A cluster check has now done that. Joints, surface and 2D pass. Body joints are 18.7 millimetres off at the median, below the about 26 millimetres cited for 3DPW's own joints. The surface is about 19 millimetres off; that is a nearest-point distance, so a lower bound. But the labels have three defects. First, gender is reversed: with the other gender, the joint error dropped for 72 of 73 male samples. Second, in 407 of 960 two-person images one person has no label, because that person was not fitted on that frame. Third, labels were missing for 6 train sequences, part of a seventh, and one validation sequence. The fits existed, but a first rebuild gave the same counts: the image files of those sequences were missing on the cluster. On 16 October I re-extracted the images of the eight sequences; captureSelfies_00 went from 480 to 750 files. The second rebuild, job 3581320, brought the labels back: train now has 6,437 label images instead of 4,451, validation 2,777 instead of 2,458, exactly what the fits imply. This third defect is fixed; the first two need the re-fit. A first test of the re-fit ran on 17 October on one two-person sequence, captureSelfies_00: the man now gets the correct gender and fits at 14.3 millimetres mean joint error, the woman at 15.5, and both people are fitted on one shared frame grid; the full re-fit of all 87 tasks has not run yet.</a:t>
             </a:r>
           </a:p>
           <a:p>

</xml_diff>

<commit_message>
WIP docs: children diagnosis correction (handover 3.4, slide 10, notes) - in progress, not for main yet
Co-Authored-By: Claude Fable 5.1 <noreply@anthropic.com>
Claude-Session: https://claude.ai/code/session_016LhpG4kT7Z7ppxbG4TW5S9
</commit_message>
<xml_diff>
--- a/docs/supervisor_update_2026-10-16.pptx
+++ b/docs/supervisor_update_2026-10-16.pptx
@@ -124,7 +124,7 @@
   <p:extLst>
     <p:ext uri="{521415D9-36F7-43E2-AB2F-B90AF26B5E84}">
       <p14:sectionLst xmlns:p14="http://schemas.microsoft.com/office/powerpoint/2010/main">
-        <p14:section name="Overview" id="{a3f549c6-928f-8fed-980a-7936e1d82ad5}">
+        <p14:section name="Overview" id="{45d927bb-f159-5a59-289a-2ae483f54be9}">
           <p14:sldIdLst>
             <p14:sldId id="256"/>
             <p14:sldId id="257"/>
@@ -132,13 +132,13 @@
             <p14:sldId id="259"/>
           </p14:sldIdLst>
         </p14:section>
-        <p14:section name="3DPW labels" id="{2b62828c-cb16-65dd-8f24-15f8120f0c5e}">
+        <p14:section name="3DPW labels" id="{033f3e53-eef0-5923-c870-d27a1b20b60d}">
           <p14:sldIdLst>
             <p14:sldId id="260"/>
             <p14:sldId id="261"/>
           </p14:sldIdLst>
         </p14:section>
-        <p14:section name="Findings" id="{57511f15-a8ea-5439-d464-4c4bded6ead5}">
+        <p14:section name="Findings" id="{4a986576-35be-9509-a1e7-05e50fb6192a}">
           <p14:sldIdLst>
             <p14:sldId id="262"/>
             <p14:sldId id="263"/>
@@ -146,14 +146,14 @@
             <p14:sldId id="265"/>
           </p14:sldIdLst>
         </p14:section>
-        <p14:section name="Bug" id="{f0678ead-e463-2402-23d9-3be0857e0249}">
+        <p14:section name="Bug" id="{2fb0e6d0-eaf0-fe3c-94a2-d9fefc7c0526}">
           <p14:sldIdLst>
             <p14:sldId id="266"/>
             <p14:sldId id="267"/>
             <p14:sldId id="268"/>
           </p14:sldIdLst>
         </p14:section>
-        <p14:section name="Next" id="{6155cb80-aeea-04a6-02be-6be0f6cb7bf5}">
+        <p14:section name="Next" id="{3567360f-539f-c86d-c0d9-b44fdf71f3a5}">
           <p14:sldIdLst>
             <p14:sldId id="269"/>
             <p14:sldId id="270"/>
@@ -161,7 +161,7 @@
             <p14:sldId id="272"/>
           </p14:sldIdLst>
         </p14:section>
-        <p14:section name="Appendix" id="{b3fa66c5-dc75-784e-741f-14c76b2142f4}">
+        <p14:section name="Appendix" id="{66db5ebb-3a2b-c0b3-06f8-924b0ea45906}">
           <p14:sldIdLst>
             <p14:sldId id="273"/>
           </p14:sldIdLst>
@@ -657,7 +657,7 @@
           <a:p>
             <a:r>
               <a:rPr lang="en-US" dirty="0"/>
-              <a:t>I checked in the code that the shape head is complete: all eleven shape values go into the body model and are trained, with no adult default. The model can make a child: for the youngest training people it predicts age 0.10 for a true 0.015, too old but still clearly a child; the holdout adults lie mostly between 0.4 and 0.8. Only 2 percent of training people are children, so I tried a sampler that shows about 10 percent. In a 2-epoch fine-tune nothing changed, not for the training children and not on real photos: five small people still get the age of the holdout adults, 0.57 to 0.67 in the sampler and the control run. That is a short run on few people, so it shows no effect, not that there can be none. My best guess is a gap between synthetic and real images, plus an old-age bias that shows even on training children; neither is tested. The next step is a 10-epoch balanced-sampler run; if that also shows nothing, it goes into the thesis as a limitation. The holdout has no children, so every synthetic child number is in-sample.</a:t>
+              <a:t>On training images the model can make child-like bodies, but its shape output falls back to the middle of the training data: the youngest and the older synthetic people are pulled toward it, and on real photos the predicted age, gender and height sit almost exactly at the training medians. I first read five small people in our photos as children with adult ages; checking the photos again, most of them are adults crouching or sitting, so that reading said nothing about children. Our photos hold one real child, a standing boy, and the model gives him age 0.60, the training median, which is an adult body. Showing about five times more synthetic children for two epochs was inconclusive, and it has no mechanism to fix real photos, so it is now low priority. My proposal is to first measure children properly on Relative Human, a public set of real photos with age-group labels, and then decide: write it up as a limitation, or add weak age labels from real photos as the BEV paper did, which is one to two weeks of code after the final model. Separately, a new flag can stop the 3DPW labels from training every real person toward one fixed average body; it is off by default, and whether the final model uses it is a decision for today.</a:t>
             </a:r>
           </a:p>
           <a:p>
@@ -666,7 +666,7 @@
           <a:p>
             <a:r>
               <a:rPr lang="en-US" dirty="0"/>
-              <a:t>If asked: Anny's own age calibration puts 0.10 at about 2 years and 0.67 at about 16, while the labels in our code assume 0.33 is 11 years and 0.67 is 25; I have not settled which one the dataset follows. The ten children in the training manifest also come out too old, by 0.078 on average. With their true shape, their error falls from 47.8 to 41.6 millimetres, so 6.2 millimetres of it is shape. So I compare with the holdout adults rather than give years: 0.57 to 0.67 is about 14 to 16 years on Anny's calibration and 21 to 25 on our code's labels; either way far too old for people 0.6 to 1.1 metres tall. There are no labelled real children, and the 3DPW labels fix age at one value, 0.55, for everyone (slide 5).</a:t>
+              <a:t>If asked: Why the five were mostly adults: the skeletal height I quoted is measured on the posed body, so crouching or sitting makes it short, and their height values, 0.47 to 0.56, are adult rest bodies; the boy gets height 0.48. On the real photos, across the demo's 299 shape lines, the median gender is 0.59, age 0.61 and height 0.50, against training medians of 0.59, 0.60 and 0.50; proportions and weight sit at fixed offsets instead. Those lines cover about 30 people, nearly all adults and each counted several times, so I do not read their spread; only gender says something there: men dominate the frames, yet only 14 percent of the lines are below 0.5. On synthetic data the same pull shows at both ends: holdout people with a true age of 0.6 to 0.8 come out at 0.57, and the youngest training people at 0.10 instead of 0.015. So I cannot yet say whether the cause is the gap between synthetic and real images, or the loss, an L1 through a sigmoid on rare values. In Anny a child is mainly narrow shoulders relative to the head, and only a low age gives that; a low height at age 0.6 gives a short, broad-shouldered adult, at least 1.22 metres tall. I do not convert ages to years: our code uses three different scales, and the dataset most likely does not follow Anny's own calibration. Relative Human has about 24,800 people with age-group labels, among them 2,720 children and 1,534 babies, plus gender; I would report the mean predicted age per group, how well age separates children from adults, gender accuracy, and how many of each group are detected at all. The 3DPW labels fix age at 0.55 and seven more shape values at 0.5 for everyone; only height and proportions are fitted, and gender comes from 3DPW. With the flag on, the final model's 3DPW error can change for a reason unrelated to the depth and bone fixes, because the 3DPW ground-truth meshes keep that average body. Anny-Fit, from the group that made Anny, refits bodies at test time from a vision-language model's age and gender; it could give better figures, but it is not our model.</a:t>
             </a:r>
           </a:p>
         </p:txBody>
@@ -1023,7 +1023,7 @@
           <a:p>
             <a:r>
               <a:rPr lang="en-US" dirty="0"/>
-              <a:t>All four experiments are done, each next to a control with the main switch off. Depth: by its own success rule the experiment failed, because every run, the controls too, misses the limit of 71.5 millimetres PVE and 89.2 percent recall. The 10-epoch run with the stronger loss has 74.8 millimetres and 87.8 percent. The slope is 0.30 with the switch alone and 0.38 to 0.44 with the stronger depth loss, against 0.33 for v5: far from 1. What clearly improved is outside the rule: the root error went from 1.21 to 0.54 metres and the drawn size from 0.63 to 0.84. I say that openly instead of changing the rule afterwards. Children, neck and fingers: no measurable effect. The neck loss gave 11.3 degrees of head error, which passes the rule of below 12, but the two controls gave 11.7 and 13.6, so that is inside the noise. With no fixed seed, one pilot only detects about 10 millimetres PVE, 3 degrees or 2 recall points. No new architecture, because the diagnostics do not justify one.</a:t>
+              <a:t>All four experiments are done, each next to a control with the main switch off. Depth: by its own success rule the experiment failed, because every run, the controls too, misses the limit of 71.5 millimetres PVE and 89.2 percent recall. The 10-epoch run with the stronger loss has 74.8 millimetres and 87.8 percent. The slope is 0.30 with the switch alone and 0.38 to 0.44 with the stronger depth loss, against 0.33 for v5: far from 1. What clearly improved is outside the rule: the root error went from 1.21 to 0.54 metres and the drawn size from 0.63 to 0.84. I say that openly instead of changing the rule afterwards. Neck and fingers: no measurable effect. Children: inconclusive after two epochs, 48.5 against 53.1 millimetres on ten training children. The neck loss gave 11.3 degrees of head error, which passes the rule of below 12, but the two controls gave 11.7 and 13.6, so that is inside the noise. With no fixed seed, one pilot only detects about 10 millimetres PVE, 3 degrees or 2 recall points. No new architecture, because the diagnostics do not justify one.</a:t>
             </a:r>
           </a:p>
           <a:p>
@@ -1206,7 +1206,7 @@
           <a:p>
             <a:r>
               <a:rPr lang="en-US" dirty="0"/>
-              <a:t>Seven things are still open. First, the bone flips. The neck fix passes in one run; the holdout renders of the correction alone show normal necks, and so, by eye, do the 8 real images I have seen so far from a first demo of the fine-tuned model. I still need a longer run, and real images have no neck metric. v10's left arm has the same kind of flip, but a bone further down the arm undoes it, so it needs a two-sided correction, not built yet. Second, the depth slope is stuck at 0.3 to 0.4, cause unknown. Third, the cost of the depth fix, paired on the same people. Fourth, pilot noise: fix the seed or repeat key runs. Fifth, people very close to the camera. Sixth, children and fingers: a longer sampler run, and a look at the hands with the bone fix. Seventh, 3DPW: the first rebuild gave the same counts, so I re-extracted the images of the eight sequences on 16 October; captureSelfies_00 went from 480 to 750 files. The second rebuild, job 3581320, brought the missing labels back: train 6,437 label images instead of 4,451, validation 2,777 instead of 2,458. Then gender, frame grid and a re-fit of all 87 tasks, before any 3DPW test. A first test on one two-person sequence ran on 17 October: the man, now with the correct gender, fits at 14.3 millimetres, the woman at 15.5, and both people are fitted on one shared frame grid; the full re-fit has not run yet.</a:t>
+              <a:t>Seven things are still open. First, the bone flips. The neck fix passes in one run; the holdout renders of the correction alone show normal necks, and so, by eye, do the 8 real images I have seen so far from a first demo of the fine-tuned model. I still need a longer run, and real images have no neck metric. v10's left arm has the same kind of flip, but a bone further down the arm undoes it, so it needs a two-sided correction, not built yet. Second, the depth slope is stuck at 0.3 to 0.4, cause unknown. Third, the cost of the depth fix, paired on the same people. Fourth, pilot noise: fix the seed or repeat key runs. Fifth, people very close to the camera. Sixth, children and fingers: for children, a measurement on real photos with age labels, the Relative Human dataset, before any more training (slide 10); for fingers, a look at the hands with the bone fix. Seventh, 3DPW: the first rebuild gave the same counts, so I re-extracted the images of the eight sequences on 16 October; captureSelfies_00 went from 480 to 750 files. The second rebuild, job 3581320, brought the missing labels back: train 6,437 label images instead of 4,451, validation 2,777 instead of 2,458. Then gender, frame grid and a re-fit of all 87 tasks, before any 3DPW test. A first test on one two-person sequence ran on 17 October: the man, now with the correct gender, fits at 14.3 millimetres, the woman at 15.5, and both people are fitted on one shared frame grid; the full re-fit has not run yet.</a:t>
             </a:r>
           </a:p>
           <a:p>
@@ -1215,7 +1215,7 @@
           <a:p>
             <a:r>
               <a:rPr lang="en-US" dirty="0"/>
-              <a:t>If asked: Neck: the fine-tuned checkpoint carries the fix in its saved settings, so the demo applies it on load; the demo comparison, job 3581312, ran it next to v5 on 4 example photos and 8 3DPW test frames (slide 8); I have looked at 8 of these 12 images so far. In the 12 side-by-side holdout panels, with the correction alone and no training, the necks have normal width wherever a neck is visible (slide 8). v10: correcting three of its flipped hand bones passed without training; two more finger bones, seen on training images, are not corrected yet; shoulder01.L at 166 degrees and upperarm02.L at 180 stay flipped, because one constant per bone would break the chain that compensates them. Depth: the training depths so far come from small samples, batch means of about 2.5 to 3.2 metres. I will also measure the fix run's slope on training images; for v5 it was just as low there. Cost: I will report the root error next to PVE in the thesis. Testing the depth fix on 3DPW waits for item seven. The twenty-times 10-epoch run has no result yet. Close people: v5 and the depth-fix model both miss them in 4 of the 12 rendered holdout images (slide 12). Children and fingers: one 2-epoch test is not enough to close them. 3DPW labels: the rebuild, into a new folder, gave the same counts, so my old guess that the builder ran before the fits finished is wrong. The builder skips every frame without an image file. So I re-extracted the image folders of the eight affected sequences on 16 October: captureSelfies_00 had 480 of 750 files; for the other seven the counts before were not recorded. The second rebuild, job 3581320, confirmed it: train rose from 4,451 to 6,437 label images and validation from 2,458 to 2,777, exactly what the fits imply; test stayed at 9,722. Those labels still have the reversed gender and the missing second person. Gender and the frame grid are different: set men to 0 and, by Anny's convention, women to 1; the gender refit in the 15-October check confirmed it only for men. And pick both people's frames on one shared grid. Both happen inside the fit, so all 87 conversion tasks must be fitted again, into a new folder, because the task script skips every person that already has a file; the task script now refuses to mix old and new fits. That is an 87-task array job: about 28 GPU hours at the measured 4.4 seconds per frame (the 17 October test, on an H100), so about 3.5 to 4 hours with 8 free H100s. Then rebuild the labels and run the check again.</a:t>
+              <a:t>If asked: Neck: the fine-tuned checkpoint carries the fix in its saved settings, so the demo applies it on load; the demo comparison, job 3581312, ran it next to v5 on 4 example photos and 8 3DPW test frames (slide 8); I have looked at 8 of these 12 images so far. In the 12 side-by-side holdout panels, with the correction alone and no training, the necks have normal width wherever a neck is visible (slide 8). v10: correcting three of its flipped hand bones passed without training; two more finger bones, seen on training images, are not corrected yet; shoulder01.L at 166 degrees and upperarm02.L at 180 stay flipped, because one constant per bone would break the chain that compensates them. Depth: the training depths so far come from small samples, batch means of about 2.5 to 3.2 metres. I will also measure the fix run's slope on training images; for v5 it was just as low there. Cost: I will report the root error next to PVE in the thesis. Testing the depth fix on 3DPW waits for item seven. The twenty-times 10-epoch run has no result yet. Close people: v5 and the depth-fix model both miss them in 4 of the 12 rendered holdout images (slide 12). Children and fingers: one 2-epoch test is not enough to close them; for children it is inconclusive, not a proof that more synthetic children cannot help, and a 10-epoch sampler run stays a low-priority option. 3DPW labels: the rebuild, into a new folder, gave the same counts, so my old guess that the builder ran before the fits finished is wrong. The builder skips every frame without an image file. So I re-extracted the image folders of the eight affected sequences on 16 October: captureSelfies_00 had 480 of 750 files; for the other seven the counts before were not recorded. The second rebuild, job 3581320, confirmed it: train rose from 4,451 to 6,437 label images and validation from 2,458 to 2,777, exactly what the fits imply; test stayed at 9,722. Those labels still have the reversed gender and the missing second person. Gender and the frame grid are different: set men to 0 and, by Anny's convention, women to 1; the gender refit in the 15-October check confirmed it only for men. And pick both people's frames on one shared grid. Both happen inside the fit, so all 87 conversion tasks must be fitted again, into a new folder, because the task script skips every person that already has a file; the task script now refuses to mix old and new fits. That is an 87-task array job: about 28 GPU hours at the measured 4.4 seconds per frame (the 17 October test, on an H100), so about 3.5 to 4 hours with 8 free H100s. Then rebuild the labels and run the check again.</a:t>
             </a:r>
           </a:p>
         </p:txBody>
@@ -1359,7 +1359,7 @@
           <a:p>
             <a:r>
               <a:rPr lang="en-US" dirty="0"/>
-              <a:t>- Both options: either fine-tune should also mask the 3DPW finger labels, which are set to the rest pose, with mask_3dpw_hands.</a:t>
+              <a:t>- Both options: either fine-tune should also mask the 3DPW finger labels, which are set to the rest pose, with mask_3dpw_hands. A new flag can also leave out the eight 3DPW shape values that are constants, age 0.55 and seven at 0.5; it is off by default, and on or off is a decision for today (slide 10). With it on, the 3DPW error can change for a reason unrelated to the two fixes.</a:t>
             </a:r>
           </a:p>
         </p:txBody>
@@ -2136,7 +2136,7 @@
           <a:p>
             <a:r>
               <a:rPr lang="en-US" dirty="0"/>
-              <a:t>- Men: in both models, adult men on real photos get female-looking bodies, with breasts and narrow shoulders, for example the male tennis players. v5 never saw 3DPW, so this is not the gender defect in our 3DPW labels; the cause is unknown. My guess is the gender or shape prediction on real images, a synthetic-to-real gap like the age problem; not tested.</a:t>
+              <a:t>- Men: in both models, adult men on real photos get female-looking bodies, with breasts and narrow shoulders, for example the male tennis players. v5 never saw 3DPW, so this is not the gender defect in our 3DPW labels. The demo log shows predicted gender near the training median, about 0.6, while Anny's male end is 0: the same pull to the median as for age (slide 10). Whether the gap between synthetic and real images or the loss causes it is not settled.</a:t>
             </a:r>
           </a:p>
           <a:p>
@@ -3294,7 +3294,7 @@
       </p:sp>
       <p:sp>
         <p:nvSpPr>
-          <p:cNvPr id="3" name="stat children in supervised training with the balanced sampler: no effect"/>
+          <p:cNvPr id="3" name="stat children in supervised training with the balanced sampler: unproven after 2 epochs"/>
           <p:cNvSpPr txBox="1"/>
           <p:nvPr/>
         </p:nvSpPr>
@@ -3330,7 +3330,7 @@
       </p:sp>
       <p:sp>
         <p:nvSpPr>
-          <p:cNvPr id="4" name="label children in supervised training with the balanced sampler: no effect"/>
+          <p:cNvPr id="4" name="label children in supervised training with the balanced sampler: unproven after 2 epochs"/>
           <p:cNvSpPr txBox="1"/>
           <p:nvPr/>
         </p:nvSpPr>
@@ -3358,7 +3358,7 @@
                   <a:schemeClr val="tx2"/>
                 </a:solidFill>
               </a:rPr>
-              <a:t>children in supervised training with the balanced sampler: no effect</a:t>
+              <a:t>children in supervised training with the balanced sampler: unproven after 2 epochs</a:t>
             </a:r>
             <a:endParaRPr lang="en-US" sz="1300" dirty="0"/>
           </a:p>
@@ -3438,7 +3438,7 @@
       </p:sp>
       <p:sp>
         <p:nvSpPr>
-          <p:cNvPr id="7" name="stat predicted age of 5 small people in real photos (sampler and control runs): same as the holdout adults"/>
+          <p:cNvPr id="7" name="stat predicted age of the one real child in our photos: the training median, an adult body"/>
           <p:cNvSpPr txBox="1"/>
           <p:nvPr/>
         </p:nvSpPr>
@@ -3466,7 +3466,7 @@
                   <a:schemeClr val="accent4"/>
                 </a:solidFill>
               </a:rPr>
-              <a:t>0.57–0.67</a:t>
+              <a:t>0.60</a:t>
             </a:r>
             <a:endParaRPr lang="en-US" sz="4000" dirty="0"/>
           </a:p>
@@ -3474,7 +3474,7 @@
       </p:sp>
       <p:sp>
         <p:nvSpPr>
-          <p:cNvPr id="8" name="label predicted age of 5 small people in real photos (sampler and control runs): same as the holdout adults"/>
+          <p:cNvPr id="8" name="label predicted age of the one real child in our photos: the training median, an adult body"/>
           <p:cNvSpPr txBox="1"/>
           <p:nvPr/>
         </p:nvSpPr>
@@ -3502,7 +3502,7 @@
                   <a:schemeClr val="tx2"/>
                 </a:solidFill>
               </a:rPr>
-              <a:t>predicted age of 5 small people in real photos (sampler and control runs): same as the holdout adults</a:t>
+              <a:t>predicted age of the one real child in our photos: the training median, an adult body</a:t>
             </a:r>
             <a:endParaRPr lang="en-US" sz="1300" dirty="0"/>
           </a:p>
@@ -3595,7 +3595,7 @@
                   <a:schemeClr val="tx1"/>
                 </a:solidFill>
               </a:rPr>
-              <a:t>More children did not help in a 2-epoch fine-tune: </a:t>
+              <a:t>More children, 2-epoch fine-tune: </a:t>
             </a:r>
             <a:r>
               <a:rPr lang="en-US" sz="1200" dirty="0">
@@ -3603,7 +3603,7 @@
                   <a:schemeClr val="tx1"/>
                 </a:solidFill>
               </a:rPr>
-              <a:t>about 5 times more in training; no change on the 10 training children or on the real photos (no age labels).</a:t>
+              <a:t>about 5 times more in training; inconclusive on the 10 training children (48.5 vs 53.1 mm); the baby age floor stayed at 0.10.</a:t>
             </a:r>
             <a:endParaRPr lang="en-US" sz="1200" dirty="0"/>
           </a:p>
@@ -3621,7 +3621,7 @@
                   <a:schemeClr val="tx1"/>
                 </a:solidFill>
               </a:rPr>
-              <a:t>Best guess: </a:t>
+              <a:t>Diagnosis: </a:t>
             </a:r>
             <a:r>
               <a:rPr lang="en-US" sz="1200" dirty="0">
@@ -3629,7 +3629,7 @@
                   <a:schemeClr val="tx1"/>
                 </a:solidFill>
               </a:rPr>
-              <a:t>a synthetic-to-real gap, plus an old-age bias even on training children. One 2-epoch test cannot settle it.</a:t>
+              <a:t>the shape head falls back to the training median, in both synthetic tails and on real photos (age, gender, height). Domain gap or loss: not yet separable.</a:t>
             </a:r>
             <a:endParaRPr lang="en-US" sz="1200" dirty="0"/>
           </a:p>
@@ -3655,7 +3655,7 @@
                   <a:schemeClr val="tx1"/>
                 </a:solidFill>
               </a:rPr>
-              <a:t>every synthetic child number is in-sample; the holdout has no children. Ages are Anny's 0–1 value (holdout adults: mostly 0.4–0.8). Ages are not converted to years, because Anny's calibration and the labels in our code disagree.</a:t>
+              <a:t>every synthetic child number is in-sample; the holdout has no children. Ages are Anny's 0–1 value (holdout adults: mostly 0.4–0.8), not years: our code uses three different scales.</a:t>
             </a:r>
             <a:endParaRPr lang="en-US" sz="1200" dirty="0"/>
           </a:p>
@@ -10343,7 +10343,7 @@
                             <a:srgbClr val="1B2233"/>
                           </a:solidFill>
                         </a:rPr>
-                        <a:t>No effect in a 2-epoch fine-tune: training children and real photos unchanged. Pilot and control both use age loss ×3, height ×2</a:t>
+                        <a:t>Inconclusive after 2 epochs: 10 training children 48.5 vs 53.1 mm. Pilot and control both use age loss ×3, height ×2</a:t>
                       </a:r>
                       <a:endParaRPr lang="en-US" sz="1100" dirty="0"/>
                     </a:p>
@@ -12538,7 +12538,7 @@
                   <a:schemeClr val="tx2"/>
                 </a:solidFill>
               </a:rPr>
-              <a:t>10-epoch sampler run; check the hands with the bone fix, then larger hand crops. Else: limitations.</a:t>
+              <a:t>Children: measure on Relative Human first. Fingers: check the bone-fix hands, then larger crops.</a:t>
             </a:r>
             <a:endParaRPr lang="en-US" sz="1200" dirty="0"/>
           </a:p>

</xml_diff>

<commit_message>
WIP docs: deck/handover update in progress (Relative Human, v23 check) - not for main yet
Co-Authored-By: Claude Fable 5.1 <noreply@anthropic.com>
Claude-Session: https://claude.ai/code/session_016LhpG4kT7Z7ppxbG4TW5S9
</commit_message>
<xml_diff>
--- a/docs/supervisor_update_2026-10-16.pptx
+++ b/docs/supervisor_update_2026-10-16.pptx
@@ -124,7 +124,7 @@
   <p:extLst>
     <p:ext uri="{521415D9-36F7-43E2-AB2F-B90AF26B5E84}">
       <p14:sectionLst xmlns:p14="http://schemas.microsoft.com/office/powerpoint/2010/main">
-        <p14:section name="Overview" id="{45d927bb-f159-5a59-289a-2ae483f54be9}">
+        <p14:section name="Overview" id="{480f32ca-5e82-d50f-3476-6077eb44aa42}">
           <p14:sldIdLst>
             <p14:sldId id="256"/>
             <p14:sldId id="257"/>
@@ -132,13 +132,13 @@
             <p14:sldId id="259"/>
           </p14:sldIdLst>
         </p14:section>
-        <p14:section name="3DPW labels" id="{033f3e53-eef0-5923-c870-d27a1b20b60d}">
+        <p14:section name="3DPW labels" id="{16e27fbb-b679-5934-8a69-464407c49795}">
           <p14:sldIdLst>
             <p14:sldId id="260"/>
             <p14:sldId id="261"/>
           </p14:sldIdLst>
         </p14:section>
-        <p14:section name="Findings" id="{4a986576-35be-9509-a1e7-05e50fb6192a}">
+        <p14:section name="Findings" id="{a0026603-5dca-cef9-a609-20ff0fd05b7a}">
           <p14:sldIdLst>
             <p14:sldId id="262"/>
             <p14:sldId id="263"/>
@@ -146,14 +146,14 @@
             <p14:sldId id="265"/>
           </p14:sldIdLst>
         </p14:section>
-        <p14:section name="Bug" id="{2fb0e6d0-eaf0-fe3c-94a2-d9fefc7c0526}">
+        <p14:section name="Bug" id="{f4bf4c1c-cc75-1281-4ba3-85a04aba7a09}">
           <p14:sldIdLst>
             <p14:sldId id="266"/>
             <p14:sldId id="267"/>
             <p14:sldId id="268"/>
           </p14:sldIdLst>
         </p14:section>
-        <p14:section name="Next" id="{3567360f-539f-c86d-c0d9-b44fdf71f3a5}">
+        <p14:section name="Next" id="{e9a23628-a2fb-8c12-98a6-f4870ac2bdd1}">
           <p14:sldIdLst>
             <p14:sldId id="269"/>
             <p14:sldId id="270"/>
@@ -161,7 +161,7 @@
             <p14:sldId id="272"/>
           </p14:sldIdLst>
         </p14:section>
-        <p14:section name="Appendix" id="{66db5ebb-3a2b-c0b3-06f8-924b0ea45906}">
+        <p14:section name="Appendix" id="{423479b1-2ce8-ac0b-97e1-1f3b29768165}">
           <p14:sldIdLst>
             <p14:sldId id="273"/>
           </p14:sldIdLst>
@@ -570,7 +570,7 @@
           <a:p>
             <a:r>
               <a:rPr lang="en-US" dirty="0"/>
-              <a:t>Since last Friday I measured each stage of the pipeline separately. I will show what is not the cause, how the 3DPW labels are made, how well they match 3DPW and three defects I found in them, what I found in the neck and a first fix for it, what I measured about the fingers and the children, one depth bug nobody was looking for and its fix, and what is still open. I will say clearly what is measured and what is only a guess.</a:t>
+              <a:t>Since last Friday I measured each stage of the pipeline separately. I will show what is not the cause, how the 3DPW labels are made, how well they match 3DPW, three defects I found in them and their fix, what I found in the neck and a first fix for it, what I measured about the fingers and the children, one depth bug nobody was looking for and its fix, and what is still open. I will say clearly what is measured and what is only a guess.</a:t>
             </a:r>
           </a:p>
         </p:txBody>
@@ -657,7 +657,7 @@
           <a:p>
             <a:r>
               <a:rPr lang="en-US" dirty="0"/>
-              <a:t>On training images the model can make child-like bodies, but its shape output falls back to the middle of the training data: the youngest and the older synthetic people are pulled toward it, and on real photos the predicted age, gender and height sit almost exactly at the training medians. I first read five small people in our photos as children with adult ages; checking the photos again, most of them are adults crouching or sitting, so that reading said nothing about children. Our photos hold one real child, a standing boy, and the model gives him age 0.60, the training median, which is an adult body. Showing about five times more synthetic children for two epochs was inconclusive, and it has no mechanism to fix real photos, so it is now low priority. My proposal is to first measure children properly on Relative Human, a public set of real photos with age-group labels, and then decide: write it up as a limitation, or add weak age labels from real photos as the BEV paper did, which is one to two weeks of code after the final model. Separately, a new flag can stop the 3DPW labels from training every real person toward one fixed average body; it is off by default, and whether the final model uses it is a decision for today.</a:t>
+              <a:t>On training images the model can make child-like bodies, but on real photos it does not. I measured this on Relative Human, a public set of real photos with age-group labels: 635 validation images with 2,130 labelled people. The detected kids get a predicted age of 0.61 and the babies 0.62, against 0.63 for adults, so age barely separates them: the AUC is 0.61, where 0.5 is chance, and none of the 89 detected kids and only one of the 38 babies falls below our child threshold of 0.45. The model does see that they are small, but it puts that into height, not age: height goes from 0.51 for adults to 0.45 for kids and 0.39 for babies. So it reads children as short adults; in Anny, a low height at an adult age is a short, broad-shouldered adult. Gender carries no signal either: men get 0.535 on average and women 0.551, while Anny's male end is 0. This is the same pull to the training median we see on synthetic data, and it replaces my earlier by-eye reading of a few people in our own photos. The decision for today: write it up as a limitation, or add weak age labels from the Relative Human training set, as the BEV paper did, which is one to two weeks of code after the final model. Separately, a flag can stop the 3DPW labels from training every real person toward one fixed average body; it is off by default, and whether the final model uses it is also a decision for today.</a:t>
             </a:r>
           </a:p>
           <a:p>
@@ -666,7 +666,7 @@
           <a:p>
             <a:r>
               <a:rPr lang="en-US" dirty="0"/>
-              <a:t>If asked: Why the five were mostly adults: the skeletal height I quoted is measured on the posed body, so crouching or sitting makes it short, and their height values, 0.47 to 0.56, are adult rest bodies; the boy gets height 0.48. On the real photos, across the demo's 299 shape lines, the median gender is 0.59, age 0.61 and height 0.50, against training medians of 0.59, 0.60 and 0.50; proportions and weight sit at fixed offsets instead. Those lines cover about 30 people, nearly all adults and each counted several times, so I do not read their spread; only gender says something there: men dominate the frames, yet only 14 percent of the lines are below 0.5. On synthetic data the same pull shows at both ends: holdout people with a true age of 0.6 to 0.8 come out at 0.57, and the youngest training people at 0.10 instead of 0.015. So I cannot yet say whether the cause is the gap between synthetic and real images, or the loss, an L1 through a sigmoid on rare values. In Anny a child is mainly narrow shoulders relative to the head, and only a low age gives that; a low height at age 0.6 gives a short, broad-shouldered adult, at least 1.22 metres tall. I do not convert ages to years: our code uses three different scales, and the dataset most likely does not follow Anny's own calibration. Relative Human has about 24,800 people with age-group labels, among them 2,720 children and 1,534 babies, plus gender; I would report the mean predicted age per group, how well age separates children from adults, gender accuracy, and how many of each group are detected at all. The 3DPW labels fix age at 0.55 and seven more shape values at 0.5 for everyone; only height and proportions are fitted, and gender comes from 3DPW. With the flag on, the final model's 3DPW error can change for a reason unrelated to the depth and bone fixes, because the 3DPW ground-truth meshes keep that average body. Anny-Fit, from the group that made Anny, refits bodies at test time from a vision-language model's age and gender; it could give better figures, but it is not our model.</a:t>
+              <a:t>If asked: Recall: the model detects only 47 percent of the labelled people, 33 percent of the babies and 43 percent of the kids; the photos are crowded and the model runs at 672 pixels. So every number covers detected people only. Matching: each detection is paired with a labelled box by overlap, IoU at least 0.3. In crowded scenes a few child labels may get an adult detection; that would blur the height drop and any age gap, but it cannot create the height drop, and the clear height drop says most matches are real children. The fine-tuned model with the neck and finger fix gives the same numbers within noise: AUC 0.613, kids 0.62, adults 0.64, gender 0.533 for men and 0.562 for women. That is expected: the fix turns bones, not the shape output. Teens sit in between, age 0.60 and height 0.49. Our own photos agree: the one real child, a standing boy, gets age 0.60 and height 0.48; the five small people I quoted before were mostly crouching or seated adults, because the skeletal height I used is measured on the posed body. On synthetic data the same pull shows at both ends: holdout people with a true age of 0.6 to 0.8 come out at 0.57, and the youngest training people at 0.10 instead of 0.015. Showing about five times more synthetic children for two epochs was inconclusive, 48.5 against 53.1 millimetres on ten training children, and it has no mechanism for real photos. So I cannot yet say whether the cause is the gap between synthetic and real images, or the loss, an L1 through a sigmoid on rare values. In Anny a child is mainly narrow shoulders relative to the head, and only a low age gives that; a low height at age 0.6 gives a short, broad-shouldered adult, at least 1.22 metres tall. I do not convert ages to years: our code uses three different scales, and the dataset most likely does not follow Anny's own calibration. Relative Human has about 24,800 people with age-group labels, among them 2,720 children and 1,534 babies, plus gender; its training split is where weak labels would come from. The 3DPW labels fix age at 0.55 and seven more shape values at 0.5 for everyone; only height and proportions are fitted, and gender comes from 3DPW. With the flag on, the final model's 3DPW error can change for a reason unrelated to the depth and bone fixes, because the 3DPW ground-truth meshes keep that average body. Anny-Fit, from the group that made Anny, refits bodies at test time from a vision-language model's age and gender; it could give better figures, but it is not our model.</a:t>
             </a:r>
           </a:p>
         </p:txBody>
@@ -1023,7 +1023,7 @@
           <a:p>
             <a:r>
               <a:rPr lang="en-US" dirty="0"/>
-              <a:t>All four experiments are done, each next to a control with the main switch off. Depth: by its own success rule the experiment failed, because every run, the controls too, misses the limit of 71.5 millimetres PVE and 89.2 percent recall. The 10-epoch run with the stronger loss has 74.8 millimetres and 87.8 percent. The slope is 0.30 with the switch alone and 0.38 to 0.44 with the stronger depth loss, against 0.33 for v5: far from 1. What clearly improved is outside the rule: the root error went from 1.21 to 0.54 metres and the drawn size from 0.63 to 0.84. I say that openly instead of changing the rule afterwards. Neck and fingers: no measurable effect. Children: inconclusive after two epochs, 48.5 against 53.1 millimetres on ten training children. The neck loss gave 11.3 degrees of head error, which passes the rule of below 12, but the two controls gave 11.7 and 13.6, so that is inside the noise. With no fixed seed, one pilot only detects about 10 millimetres PVE, 3 degrees or 2 recall points. No new architecture, because the diagnostics do not justify one.</a:t>
+              <a:t>All four experiments are done, each next to a control with the main switch off. Depth: by its own success rule the experiment failed, because every run, the controls too, misses the limit of 71.5 millimetres PVE and 89.2 percent recall. The 10-epoch run with the stronger loss has 74.8 millimetres and 87.8 percent. The slope is 0.30 with the switch alone and 0.38 to 0.44 with the stronger depth loss, against 0.33 for v5: far from 1. What clearly improved is outside the rule: the root error went from 1.21 to 0.54 metres and the drawn size from 0.63 to 0.84. I say that openly instead of changing the rule afterwards. Neck and fingers: no measurable effect. Children: inconclusive after two epochs, 48.5 against 53.1 millimetres on ten training children; on real photos, v5 still gives children an adult age (slide 10). The neck loss gave 11.3 degrees of head error, which passes the rule of below 12, but the two controls gave 11.7 and 13.6, so that is inside the noise. With no fixed seed, one pilot only detects about 10 millimetres PVE, 3 degrees or 2 recall points. No new architecture, because the diagnostics do not justify one.</a:t>
             </a:r>
           </a:p>
           <a:p>
@@ -1206,7 +1206,7 @@
           <a:p>
             <a:r>
               <a:rPr lang="en-US" dirty="0"/>
-              <a:t>Seven things are still open. First, the bone flips. The neck fix passes in one run; the holdout renders of the correction alone show normal necks, and so, by eye, do the 8 real images I have seen so far from a first demo of the fine-tuned model. I still need a longer run, and real images have no neck metric. v10's left arm has the same kind of flip, but a bone further down the arm undoes it, so it needs a two-sided correction, not built yet. Second, the depth slope is stuck at 0.3 to 0.4, cause unknown. Third, the cost of the depth fix, paired on the same people. Fourth, pilot noise: fix the seed or repeat key runs. Fifth, people very close to the camera. Sixth, children and fingers: for children, a measurement on real photos with age labels, the Relative Human dataset, before any more training (slide 10); for fingers, a look at the hands with the bone fix. Seventh, 3DPW: the first rebuild gave the same counts, so I re-extracted the images of the eight sequences on 16 October; captureSelfies_00 went from 480 to 750 files. The second rebuild, job 3581320, brought the missing labels back: train 6,437 label images instead of 4,451, validation 2,777 instead of 2,458. Then gender, frame grid and a re-fit of all 87 tasks, before any 3DPW test. A first test on one two-person sequence ran on 17 October: the man, now with the correct gender, fits at 14.3 millimetres, the woman at 15.5, and both people are fitted on one shared frame grid; the full re-fit has not run yet.</a:t>
+              <a:t>Seven things are still open. First, the bone flips. The neck fix passes in one run; the holdout renders of the correction alone show normal necks, and so, by eye, do the 8 real images I have seen so far from a first demo of the fine-tuned model. I still need a longer run, and real images have no neck metric. v10's left arm has the same kind of flip, but a bone further down the arm undoes it, so it needs a two-sided correction, not built yet. Second, the depth slope is stuck at 0.3 to 0.4, cause unknown. Third, the cost of the depth fix, paired on the same people. Fourth, pilot noise: fix the seed or repeat key runs. Fifth, people very close to the camera. Sixth, children and fingers: children are now measured on real photos with age labels, the Relative Human dataset: the model reads them as short adults, and age separates them from adults with an AUC of only 0.61 (slide 10); the decision is a limitation or weak age labels. For fingers, a look at the hands with the bone fix. Seventh, 3DPW: the labels had three defects. The missing labels came back on 16 October, when I re-extracted the images of eight sequences; train went from 4,451 to 6,437 label images. The re-fit with the gender and frame-grid fixes finished on 18 October, and the check on the new labels passes with a warning, with no defect left (slide 6). What stays open is to use them: the final model would be the first run on these labels.</a:t>
             </a:r>
           </a:p>
           <a:p>
@@ -1215,7 +1215,7 @@
           <a:p>
             <a:r>
               <a:rPr lang="en-US" dirty="0"/>
-              <a:t>If asked: Neck: the fine-tuned checkpoint carries the fix in its saved settings, so the demo applies it on load; the demo comparison, job 3581312, ran it next to v5 on 4 example photos and 8 3DPW test frames (slide 8); I have looked at 8 of these 12 images so far. In the 12 side-by-side holdout panels, with the correction alone and no training, the necks have normal width wherever a neck is visible (slide 8). v10: correcting three of its flipped hand bones passed without training; two more finger bones, seen on training images, are not corrected yet; shoulder01.L at 166 degrees and upperarm02.L at 180 stay flipped, because one constant per bone would break the chain that compensates them. Depth: the training depths so far come from small samples, batch means of about 2.5 to 3.2 metres. I will also measure the fix run's slope on training images; for v5 it was just as low there. Cost: I will report the root error next to PVE in the thesis. Testing the depth fix on 3DPW waits for item seven. The twenty-times 10-epoch run has no result yet. Close people: v5 and the depth-fix model both miss them in 4 of the 12 rendered holdout images (slide 12). Children and fingers: one 2-epoch test is not enough to close them; for children it is inconclusive, not a proof that more synthetic children cannot help, and a 10-epoch sampler run stays a low-priority option. 3DPW labels: the rebuild, into a new folder, gave the same counts, so my old guess that the builder ran before the fits finished is wrong. The builder skips every frame without an image file. So I re-extracted the image folders of the eight affected sequences on 16 October: captureSelfies_00 had 480 of 750 files; for the other seven the counts before were not recorded. The second rebuild, job 3581320, confirmed it: train rose from 4,451 to 6,437 label images and validation from 2,458 to 2,777, exactly what the fits imply; test stayed at 9,722. Those labels still have the reversed gender and the missing second person. Gender and the frame grid are different: set men to 0 and, by Anny's convention, women to 1; the gender refit in the 15-October check confirmed it only for men. And pick both people's frames on one shared grid. Both happen inside the fit, so all 87 conversion tasks must be fitted again, into a new folder, because the task script skips every person that already has a file; the task script now refuses to mix old and new fits. That is an 87-task array job: about 28 GPU hours at the measured 4.4 seconds per frame (the 17 October test, on an H100), so about 3.5 to 4 hours with 8 free H100s. Then rebuild the labels and run the check again.</a:t>
+              <a:t>If asked: Neck: the fine-tuned checkpoint carries the fix in its saved settings, so the demo applies it on load; the demo comparison, job 3581312, ran it next to v5 on 4 example photos and 8 3DPW test frames (slide 8); I have looked at 8 of these 12 images so far. In the 12 side-by-side holdout panels, with the correction alone and no training, the necks have normal width wherever a neck is visible (slide 8). v10: correcting three of its flipped hand bones passed without training; two more finger bones, seen on training images, are not corrected yet; shoulder01.L at 166 degrees and upperarm02.L at 180 stay flipped, because one constant per bone would break the chain that compensates them. Depth: the training depths so far come from small samples, batch means of about 2.5 to 3.2 metres. I will also measure the fix run's slope on training images; for v5 it was just as low there. Cost: I will report the root error next to PVE in the thesis. Testing the depth fix on 3DPW comes with the final model, on the new labels. The twenty-times 10-epoch run has no result yet. Close people: v5 and the depth-fix model both miss them in 4 of the 12 rendered holdout images (slide 12). Children and fingers: one 2-epoch test is not enough to close them; for children it is inconclusive, not a proof that more synthetic children cannot help, and a 10-epoch sampler run stays a low-priority option. 3DPW labels: the rebuild, into a new folder, gave the same counts, so my old guess that the builder ran before the fits finished is wrong. The builder skips every frame without an image file. So I re-extracted the image folders of the eight affected sequences on 16 October: captureSelfies_00 had 480 of 750 files; for the other seven the counts before were not recorded. The second rebuild, job 3581320, confirmed it: train rose from 4,451 to 6,437 label images and validation from 2,458 to 2,777, exactly what the fits imply; test stayed at 9,722. Those labels still had the reversed gender and the missing second person. Gender and the frame grid are different: men to 0 and, by Anny's convention, women to 1, and both people's frames on one shared grid. Both happen inside the fit, so all 87 conversion tasks were fitted again, into a new folder, because the task script skips every person that already has a file; the task script now refuses to mix old and new fits. That was an 87-task array job: about 28 GPU hours at the measured 4.4 seconds per frame (the 17 October test, on an H100), done on 18 October. The rebuilt labels have 16,694 images with 22,749 people, and the check on them confirms both fixes: flipping the gender now makes the fit worse, and no two-person image misses a person.</a:t>
             </a:r>
           </a:p>
         </p:txBody>
@@ -1302,7 +1302,7 @@
           <a:p>
             <a:r>
               <a:rPr lang="en-US" dirty="0"/>
-              <a:t>What I claim, measured. The failures are not rig or decoding problems. A training-target bug puts people too far away in v5, v9 and v10; the fix draws bodies much closer to their true size. In the v5 line, neck02 and the head bone sit half a turn off. One pilot run with a fixed correction and a short fine-tune restores the neck thickness and passes the fine-tune checks. Two flipped hand bones were about half the finger error. The 3DPW labels pass on joints and surface, but have three defects. What I do not claim: that the neck fix is proven, since it is one run without a fixed seed; better children; correct depth for near and far people; a depth fix without cost. My question: fine-tune v9 now, or first fix the 3DPW labels and re-fit? I propose the second, as on slide 16, but want your view.</a:t>
+              <a:t>What I claim, measured. The failures are not rig or decoding problems. A training-target bug puts people too far away in v5, v9 and v10; the fix draws bodies much closer to their true size. In the v5 line, neck02 and the head bone sit half a turn off. One pilot run with a fixed correction and a short fine-tune restores the neck thickness and passes the fine-tune checks. Two flipped hand bones were about half the finger error. The 3DPW labels had three defects; a re-fit fixed them, and the new labels pass the check with a warning (slide 6). What I do not claim: that the neck fix is proven, since it is one run without a fixed seed; better children; correct depth for near and far people; a depth fix without cost. My question: fine-tune v9 now, or first fix the 3DPW labels and re-fit? The re-fit is now done, so the second waits only for the training queue. I propose the second, as on slide 16, but want your view.</a:t>
             </a:r>
           </a:p>
           <a:p>
@@ -1335,19 +1335,19 @@
           <a:p>
             <a:r>
               <a:rPr lang="en-US" dirty="0"/>
-              <a:t>- 3DPW labels: 6 train sequences, part of a seventh, and one validation sequence had no labels, because their image files were missing on the cluster. On 16 October I re-extracted them, captureSelfies_00 went from 480 to 750 files, and a second rebuild, job 3581320, brought the labels back: train 6,437 label images instead of 4,451, validation 2,777 instead of 2,458. Gender and the missing second person still need the re-fit. For the women, the gender refit is mixed. In the 3DPW labels the head, neck02 and neck03 stay at rest; only neck01 turns. Overall the labels keep about half the head turn, 9.5 against 20 degrees. Train and validation keep most of it; the loss is in the test split, and I do not know why yet. Age is fixed, and the limb-length ratios are not explained yet.</a:t>
+              <a:t>- 3DPW labels: 6 train sequences, part of a seventh, and one validation sequence had no labels, because their image files were missing on the cluster. On 16 October I re-extracted them, and a second rebuild, job 3581320, brought the labels back. The re-fit fixed gender and the missing second person on 18 October; the check on the new labels confirms both: flipping the gender now makes the fit worse, and no two-person image misses a person. In the 3DPW labels the head, neck02 and neck03 stay at rest; only neck01 turns. Age is fixed at 0.55. The remaining warnings are the limb proportions and the hip joint, where Anny and SMPL differ.</a:t>
             </a:r>
           </a:p>
           <a:p>
             <a:r>
               <a:rPr lang="en-US" dirty="0"/>
-              <a:t>- Option 1, v9 now: the fine-tune is about 1 to 2 hours of training; that is not measured with 3DPW batches, and the v9 script expects 8 to 10 minutes per epoch. From v5 I expect a drawn size of about 0.84 and a root error of about half a metre; on v5 that run cost 2.6 millimetres PVE and 1.6 recall points against its control. Five, not twenty, because the twenty-times 10-epoch run has no result yet. v9 is best on our 3DPW-Anny labels, but those labels have the gender and two-person defects, so that score is not a clean measure. On the AnnyOne holdout v9 is not the best: 75.0 at epoch 62, the planned start, and 77.0 at epoch 149, against 70.5.</a:t>
+              <a:t>- Option 1, v9 now: the fine-tune is about 1 to 2 hours of training; that is not measured with 3DPW batches, and the v9 script expects 8 to 10 minutes per epoch. From v5 I expect a drawn size of about 0.84 and a root error of about half a metre; on v5 that run cost 2.6 millimetres PVE and 1.6 recall points against its control. Five, not twenty, because the twenty-times 10-epoch run has no result yet. v9 is best on our old 3DPW-Anny labels, but those labels had the gender and two-person defects, so that score is not a clean measure. On the AnnyOne holdout v9 is not the best: 75.0 at epoch 62, the planned start, and 77.0 at epoch 149, against 70.5.</a:t>
             </a:r>
           </a:p>
           <a:p>
             <a:r>
               <a:rPr lang="en-US" dirty="0"/>
-              <a:t>- Option 2, labels first: men to 0, women to 1 by Anny's convention, one shared frame grid, re-fit all 87 conversion tasks into a new folder, rebuild the labels, then fine-tune. Rebuilding the labels alone is not enough, because the gender and the frame choice are fixed inside the fit; the re-fit is an 87-task array job, about 28 GPU hours at the measured 4.4 seconds per frame, so about 3.5 to 4 hours with 8 free H100s. A first test on one two-person sequence, on 17 October, gave the man the correct gender and 14.3 millimetres, with both people on one shared frame grid; the full re-fit has not run yet. The fine-tune after it would start from v5 with v5's own bone fix and the depth fix, run 10 epochs, and have a control run without the two fixes; it has not run yet. I prefer the re-fit first: 3DPW is 30 percent of each batch, so a fine-tune before it would keep learning the wrong body for the men.</a:t>
+              <a:t>- Option 2, labels first: the re-fit is done. Men to 0, women to 1 by Anny's convention, one shared frame grid, all 87 conversion tasks fitted again into a new folder, about 28 GPU hours at the measured 4.4 seconds per frame, finished on 18 October; the labels are rebuilt, 16,694 images, and the check on them passes with a warning (slide 6). Rebuilding the labels alone would not have been enough, because the gender and the frame choice are fixed inside the fit. The fine-tune after it would start from v5 with v5's own bone fix and the depth fix, run 10 epochs, and have a control run without the two fixes; it has not run yet. I prefer this option: 3DPW is 30 percent of each batch, so a fine-tune on the old labels would keep learning the wrong body for the men.</a:t>
             </a:r>
           </a:p>
           <a:p>
@@ -1881,7 +1881,7 @@
           <a:p>
             <a:r>
               <a:rPr lang="en-US" dirty="0"/>
-              <a:t>The finished labels had never been checked end to end against 3DPW. A cluster check has now done that. Joints, surface and 2D pass. Body joints are 18.7 millimetres off at the median, below the about 26 millimetres cited for 3DPW's own joints. The surface is about 19 millimetres off; that is a nearest-point distance, so a lower bound. But the labels have three defects. First, gender is reversed: with the other gender, the joint error dropped for 72 of 73 male samples. Second, in 407 of 960 two-person images one person has no label, because that person was not fitted on that frame. Third, labels were missing for 6 train sequences, part of a seventh, and one validation sequence. The fits existed, but a first rebuild gave the same counts: the image files of those sequences were missing on the cluster. On 16 October I re-extracted the images of the eight sequences; captureSelfies_00 went from 480 to 750 files. The second rebuild, job 3581320, brought the labels back: train now has 6,437 label images instead of 4,451, validation 2,777 instead of 2,458, exactly what the fits imply. This third defect is fixed; the first two need the re-fit. A first test of the re-fit ran on 17 October on one two-person sequence, captureSelfies_00: the man now gets the correct gender and fits at 14.3 millimetres mean joint error, the woman at 15.5, and both people are fitted on one shared frame grid; the full re-fit of all 87 tasks has not run yet.</a:t>
+              <a:t>The finished labels had never been checked end to end against 3DPW. A first cluster check, on 15 October, found that joints, surface and 2D pass, but also three defects: gender was reversed, in 407 of 960 two-person images one person had no label, and eight sequences had no labels or too few. The missing labels came from missing image files; I re-extracted them on 16 October, and a second rebuild brought them back. Gender and the missing person are decided inside the fit, so I re-fitted all 87 people with two fixes: gender by Anny's convention, men 0 and women 1, and one shared frame grid for both people. That finished on 18 October, and the fit's own check passed on all 60 sequences: the men's mean joint error went from 19.0 to 14.7 millimetres, the women stayed at about 15, and the frames where one of two people was missing went from 54 percent to zero. The new labels have 16,694 images with 22,749 people: fewer images than the 18,936 before, with the same people, because both people now share each frame. Then I ran the same conversion check on the new labels, and this slide shows it. Body joints are 14.1 millimetres off at the median, was 18.7, below the about 26 millimetres cited for 3DPW's own joints. The surface is 18.9 and 16.1 millimetres off, was 18.9 and 18.3; that is a nearest-point distance, so a lower bound. In 2D the labels are only 0.4 pixels worse than raw 3DPW, was 1.1. Gender is now right: flipping it makes the fit worse, for the men 13.9 against 20.0 millimetres, where on 15 October the flip was better for 72 of 73. No two-person image misses a person now, 0 of 1,080. The overall grade went from FAIL to WARN. What is left are known differences between the Anny and SMPL bodies, the limb proportions and the hip joint, not label bugs. So the final model can train on these labels.</a:t>
             </a:r>
           </a:p>
           <a:p>
@@ -1896,43 +1896,55 @@
           <a:p>
             <a:r>
               <a:rPr lang="en-US" dirty="0"/>
-              <a:t>- Right column: by design, the head does not turn on its own. The overall FAIL comes only from the limb lengths, and they fail only in the test split; I do not know the cause yet. A few hip outliers give a warning overall, and a FAIL in the train split alone.</a:t>
+              <a:t>- Right column: by design, the head does not turn on its own: neck02, neck03, head and jaw stay at rest in every label, and only neck01 turns. The head turn against the chest is now 19.6 degrees in the labels against 19.3 in SMPL, at the median. In the old labels it was 9.5 against 20, lost mainly in the test split. I have not checked why it came back; my guess is the gender fix, because every test person is a man and was fitted with the female body before.</a:t>
             </a:r>
           </a:p>
           <a:p>
             <a:r>
               <a:rPr lang="en-US" dirty="0"/>
-              <a:t>- Gender: for the 31 female samples the gender result is mixed. The surface test cannot see a wrong gender; that is why there is a separate refit test. In the script's own synthetic test, a label fitted with the wrong gender still stayed at 7 to 10 millimetres from the surface. Anny's male end is 0: at gender 0 the rest body is 1.753 metres tall, at 1 it is 1.632 metres. In the checked images, 1,801 people are labelled male and 734 female; these count people in images, not different persons. All men have the label 1.000, all women 0.000. The refit used 2 people per sequence, 104 samples, so 73 and 31 are samples, not different persons. For the men, the refit with flipped gender lowered the median joint error from 19.2 to 15.3 millimetres, and the surface got closer for 68 of 73. For the women, the flip made the joints worse for most of them, 13.7 to 16.3 millimetres, but the surface closer for 27 of 31.</a:t>
+              <a:t>- Grades: the WARN comes from two checks. Limb-length ratios: forearm 0.948 and thigh 1.064, Anny over SMPL; in the validation split alone the forearm is 0.877, so FAIL there. And 3.2 percent of people have a joint more than 100 millimetres off, mostly the left hip in outdoors_climbing_02, plus a few capoeira, freestyle and dancing frames; that is 5.5 percent in the train split, so FAIL there. Before the re-fit the limb ratios failed in test only, forearm 0.879 and thigh 1.119; the gender fix most likely removed that, but I have not shown it.</a:t>
             </a:r>
           </a:p>
           <a:p>
             <a:r>
               <a:rPr lang="en-US" dirty="0"/>
-              <a:t>- Missing labels: train had 4,451 of 6,437 expected label images, validation 2,458 of 2,777. The first rebuild, job 3579266, gave the same image counts: train 4,451 (5,183 people), validation 2,458, test 9,722, 16,631 label files in total; the same six train sequences and basketball_01 at zero, captureSelfies_00 at 319. The label builder skips every frame whose image file is missing, without a warning. So the likely cause was an incomplete unzip of the 3DPW images on the cluster. On 16 October I re-extracted the image folders of the eight sequences: captureSelfies_00 had 480 of 750 files; for the other seven the counts before were not recorded. The second rebuild, job 3581320, gave train 6,437 label images with 7,589 people, validation 2,777, test 9,722 unchanged: 18,936 label files, exactly what the fits imply. All six train sequences and basketball_01 now have labels, and captureSelfies_00 has 401. These rebuilt labels still come from the old fits, so gender is still reversed; I will not train on them before the re-fit. My earlier guess, that the builder ran before the fits finished, was wrong. All 162 frames of outdoors_crosscountry_00 are dropped by the visibility filter, under 30 percent visible; the fits are fine, and I have not yet checked why the whole sequence counts as not visible.</a:t>
+              <a:t>- Gender: Anny's male end is 0: at gender 0 the rest body is 1.753 metres tall, at 1 it is 1.632 metres. In the new check every man is labelled 0.000 and every woman 1.000, 2,386 and 928 people in the checked images; these count people in images, not different persons. The refit test used 118 people, 2 per sequence: men 13.9 millimetres with their label and 20.0 with the gender flipped, the flip better for 1 percent of them; women 14.8 against 15.6, the flip better for 38 percent on the joints but only 9 percent on the surface. On 15 October the flip lowered the men's median joint error from 19.2 to 15.3 millimetres, better for 72 of 73. The surface test alone cannot see a wrong gender; that is why there is a separate refit test.</a:t>
             </a:r>
           </a:p>
           <a:p>
             <a:r>
               <a:rPr lang="en-US" dirty="0"/>
-              <a:t>- Joints: the 18.7 millimetres are measured at the points the fit aims at. The bare bone heads that train.py uses are 32.5 millimetres off, mostly a fixed torso rig gap, not a fit error. The train split alone: body joints 20.2 millimetres, just over the 20 millimetre line, so WARN; and 5.2 percent of people with a joint over 100 millimetres, so FAIL. The script marks the 26 millimetres for 3DPW as likely, from von Marcard et al., 2018; I have not checked the paper.</a:t>
+              <a:t>- Missing labels: train had 4,451 of 6,437 expected label images, validation 2,458 of 2,777. The first rebuild, job 3579266, gave the same counts. The label builder skips every frame whose image file is missing, without a warning, so the likely cause was an incomplete unzip of the 3DPW images on the cluster. On 16 October I re-extracted the image folders of the eight sequences; captureSelfies_00 had 480 of 750 files. The second rebuild, job 3581320, gave 18,936 label images, exactly what the old fits imply. My earlier guess, that the builder ran before the fits finished, was wrong.</a:t>
             </a:r>
           </a:p>
           <a:p>
             <a:r>
               <a:rPr lang="en-US" dirty="0"/>
-              <a:t>- 2D and left/right: in 2D the labels are only 1 pixel worse than raw 3DPW, and left and right were correct in every checked person.</a:t>
+              <a:t>- Re-fit: all 87 fits ran on free GPU nodes through a small environment with a newer PyTorch, so they did not wait in the queue; 36 tasks first failed on two V100 nodes and were rerun elsewhere. New label counts: train 5,882 images, validation 2,622, test 8,190.</a:t>
             </a:r>
           </a:p>
           <a:p>
             <a:r>
               <a:rPr lang="en-US" dirty="0"/>
-              <a:t>- Limb lengths: the ratios are forearm 0.879 and thigh 1.119 overall. Train passes, with 0.965 and 1.035; only test fails. All checked test people are men labelled 1, so a link to the gender defect is possible, but not shown.</a:t>
+              <a:t>- outdoors_crosscountry_00 has no labels, now or before: with 3DPW's own camera its people sit behind the camera, so nothing projects into the image. The fit itself is fine, 17.8 millimetres. So 3DPW validation has 11 usable sequences.</a:t>
             </a:r>
           </a:p>
           <a:p>
             <a:r>
               <a:rPr lang="en-US" dirty="0"/>
-              <a:t>- Head turn: train and validation keep most of it, 18.5 against 21.2 degrees and 19.1 against 19.3; the loss is mainly in test, 6.3 against 20.0.</a:t>
+              <a:t>- Joints: the 14.1 millimetres are measured at the points the fit aims at. The bare bone heads that train.py uses are 30.0 millimetres off, was 32.5, mostly a fixed torso rig gap, not a fit error. The script marks the 26 millimetres for 3DPW as likely, from von Marcard et al., 2018; I have not checked the paper.</a:t>
+            </a:r>
+          </a:p>
+          <a:p>
+            <a:r>
+              <a:rPr lang="en-US" dirty="0"/>
+              <a:t>- Still fixed by design: age 0.55 for everyone and seven more shape values at 0.5; only height and proportions are fitted, and gender comes from 3DPW.</a:t>
+            </a:r>
+          </a:p>
+          <a:p>
+            <a:r>
+              <a:rPr lang="en-US" dirty="0"/>
+              <a:t>- 2D and left/right: left and right were correct in every checked person, and the mirror test passes.</a:t>
             </a:r>
           </a:p>
         </p:txBody>
@@ -2136,7 +2148,7 @@
           <a:p>
             <a:r>
               <a:rPr lang="en-US" dirty="0"/>
-              <a:t>- Men: in both models, adult men on real photos get female-looking bodies, with breasts and narrow shoulders, for example the male tennis players. v5 never saw 3DPW, so this is not the gender defect in our 3DPW labels. The demo log shows predicted gender near the training median, about 0.6, while Anny's male end is 0: the same pull to the median as for age (slide 10). Whether the gap between synthetic and real images or the loss causes it is not settled.</a:t>
+              <a:t>- Men: in both models, adult men on real photos get female-looking bodies, with breasts and narrow shoulders, for example the male tennis players. v5 never saw 3DPW, so this is not the gender defect in our 3DPW labels. The demo log shows predicted gender near the training median, about 0.6, while Anny's male end is 0: the same pull to the median as for age (slide 10). On Relative Human, measured on 932 real people, men get 0.535 on average and women 0.551: no gender signal. Whether the gap between synthetic and real images or the loss causes it is not settled.</a:t>
             </a:r>
           </a:p>
           <a:p>
@@ -3178,7 +3190,7 @@
                   <a:schemeClr val="bg2"/>
                 </a:solidFill>
               </a:rPr>
-              <a:t>3DPW labels: joints and surface pass, three defects.</a:t>
+              <a:t>3DPW labels: three defects found and fixed.</a:t>
             </a:r>
             <a:endParaRPr lang="en-US" sz="1800" dirty="0"/>
           </a:p>
@@ -3438,7 +3450,7 @@
       </p:sp>
       <p:sp>
         <p:nvSpPr>
-          <p:cNvPr id="7" name="stat predicted age of the one real child in our photos: the training median, an adult body"/>
+          <p:cNvPr id="7" name="stat predicted age of 127 real children vs 821 adults (Relative Human val); separation AUC 0.61"/>
           <p:cNvSpPr txBox="1"/>
           <p:nvPr/>
         </p:nvSpPr>
@@ -3466,7 +3478,7 @@
                   <a:schemeClr val="accent4"/>
                 </a:solidFill>
               </a:rPr>
-              <a:t>0.60</a:t>
+              <a:t>0.61 vs 0.63</a:t>
             </a:r>
             <a:endParaRPr lang="en-US" sz="4000" dirty="0"/>
           </a:p>
@@ -3474,7 +3486,7 @@
       </p:sp>
       <p:sp>
         <p:nvSpPr>
-          <p:cNvPr id="8" name="label predicted age of the one real child in our photos: the training median, an adult body"/>
+          <p:cNvPr id="8" name="label predicted age of 127 real children vs 821 adults (Relative Human val); separation AUC 0.61"/>
           <p:cNvSpPr txBox="1"/>
           <p:nvPr/>
         </p:nvSpPr>
@@ -3502,7 +3514,7 @@
                   <a:schemeClr val="tx2"/>
                 </a:solidFill>
               </a:rPr>
-              <a:t>predicted age of the one real child in our photos: the training median, an adult body</a:t>
+              <a:t>predicted age of 127 real children vs 821 adults (Relative Human val); separation AUC 0.61</a:t>
             </a:r>
             <a:endParaRPr lang="en-US" sz="1300" dirty="0"/>
           </a:p>
@@ -3577,7 +3589,7 @@
                   <a:schemeClr val="tx1"/>
                 </a:solidFill>
               </a:rPr>
-              <a:t>all eleven shape outputs are trained, none is clamped to an adult; training babies come out child-like, but too old. With the true shape, the 10 training children's error falls 47.8 → 41.6 mm.</a:t>
+              <a:t>no shape output is clamped; training babies come out child-like, but too old. True shape: 10 training children 47.8 → 41.6 mm.</a:t>
             </a:r>
             <a:endParaRPr lang="en-US" sz="1200" dirty="0"/>
           </a:p>
@@ -3595,7 +3607,7 @@
                   <a:schemeClr val="tx1"/>
                 </a:solidFill>
               </a:rPr>
-              <a:t>More children, 2-epoch fine-tune: </a:t>
+              <a:t>Children are read as short adults: </a:t>
             </a:r>
             <a:r>
               <a:rPr lang="en-US" sz="1200" dirty="0">
@@ -3603,7 +3615,7 @@
                   <a:schemeClr val="tx1"/>
                 </a:solidFill>
               </a:rPr>
-              <a:t>about 5 times more in training; inconclusive on the 10 training children (48.5 vs 53.1 mm); the baby age floor stayed at 0.10.</a:t>
+              <a:t>height 0.45 kid / 0.39 baby vs 0.51 adult; age unchanged (Relative Human val).</a:t>
             </a:r>
             <a:endParaRPr lang="en-US" sz="1200" dirty="0"/>
           </a:p>
@@ -3621,7 +3633,7 @@
                   <a:schemeClr val="tx1"/>
                 </a:solidFill>
               </a:rPr>
-              <a:t>Diagnosis: </a:t>
+              <a:t>Gender: </a:t>
             </a:r>
             <a:r>
               <a:rPr lang="en-US" sz="1200" dirty="0">
@@ -3629,7 +3641,7 @@
                   <a:schemeClr val="tx1"/>
                 </a:solidFill>
               </a:rPr>
-              <a:t>the shape head falls back to the training median, in both synthetic tails and on real photos (age, gender, height). Domain gap or loss: not yet separable.</a:t>
+              <a:t>men 0.535, women 0.551: no gender signal on real photos.</a:t>
             </a:r>
             <a:endParaRPr lang="en-US" sz="1200" dirty="0"/>
           </a:p>
@@ -3647,6 +3659,32 @@
                   <a:schemeClr val="tx1"/>
                 </a:solidFill>
               </a:rPr>
+              <a:t>Diagnosis: </a:t>
+            </a:r>
+            <a:r>
+              <a:rPr lang="en-US" sz="1200" dirty="0">
+                <a:solidFill>
+                  <a:schemeClr val="tx1"/>
+                </a:solidFill>
+              </a:rPr>
+              <a:t>the shape head falls back to the training median, in both synthetic tails and on real photos. 2-epoch sampler pilot: inconclusive. Domain gap or loss: not yet separable.</a:t>
+            </a:r>
+            <a:endParaRPr lang="en-US" sz="1200" dirty="0"/>
+          </a:p>
+          <a:p>
+            <a:pPr marL="177800" indent="-177800">
+              <a:spcAft>
+                <a:spcPts val="300"/>
+              </a:spcAft>
+              <a:buSzPct val="100000"/>
+              <a:buChar char="•"/>
+            </a:pPr>
+            <a:r>
+              <a:rPr lang="en-US" sz="1200" b="1" dirty="0">
+                <a:solidFill>
+                  <a:schemeClr val="tx1"/>
+                </a:solidFill>
+              </a:rPr>
               <a:t>Caveat: </a:t>
             </a:r>
             <a:r>
@@ -3655,7 +3693,7 @@
                   <a:schemeClr val="tx1"/>
                 </a:solidFill>
               </a:rPr>
-              <a:t>every synthetic child number is in-sample; the holdout has no children. Ages are Anny's 0–1 value (holdout adults: mostly 0.4–0.8), not years: our code uses three different scales.</a:t>
+              <a:t>synthetic child numbers are in-sample (no children in the holdout); real-photo numbers cover detected people only (47%). Ages are Anny's 0–1 value, not years.</a:t>
             </a:r>
             <a:endParaRPr lang="en-US" sz="1200" dirty="0"/>
           </a:p>
@@ -10343,7 +10381,7 @@
                             <a:srgbClr val="1B2233"/>
                           </a:solidFill>
                         </a:rPr>
-                        <a:t>Inconclusive after 2 epochs: 10 training children 48.5 vs 53.1 mm. Pilot and control both use age loss ×3, height ×2</a:t>
+                        <a:t>Inconclusive after 2 epochs: 10 training children 48.5 vs 53.1 mm (both arms: age loss ×3, height ×2). v5 on 127 real children (Relative Human): adult age, AUC 0.61 (slide 10)</a:t>
                       </a:r>
                       <a:endParaRPr lang="en-US" sz="1100" dirty="0"/>
                     </a:p>
@@ -12538,7 +12576,7 @@
                   <a:schemeClr val="tx2"/>
                 </a:solidFill>
               </a:rPr>
-              <a:t>Children: measure on Relative Human first. Fingers: check the bone-fix hands, then larger crops.</a:t>
+              <a:t>Children: measured on Relative Human (AUC 0.61, read as short adults); decision: limitation or weak labels. Fingers: bone-fix hands, then larger crops.</a:t>
             </a:r>
             <a:endParaRPr lang="en-US" sz="1200" dirty="0"/>
           </a:p>
@@ -12559,11 +12597,11 @@
             <a:avLst/>
           </a:prstGeom>
           <a:solidFill>
-            <a:schemeClr val="accent4"/>
+            <a:schemeClr val="accent3"/>
           </a:solidFill>
           <a:ln w="12700">
             <a:solidFill>
-              <a:schemeClr val="accent4"/>
+              <a:schemeClr val="accent3"/>
             </a:solidFill>
             <a:prstDash val="solid"/>
           </a:ln>
@@ -12635,7 +12673,7 @@
                   <a:schemeClr val="tx1"/>
                 </a:solidFill>
               </a:rPr>
-              <a:t>3DPW labels: three defects (slide 6)</a:t>
+              <a:t>3DPW labels: three defects fixed (slide 6)</a:t>
             </a:r>
             <a:endParaRPr lang="en-US" sz="1500" dirty="0"/>
           </a:p>
@@ -12671,7 +12709,7 @@
                   <a:schemeClr val="tx2"/>
                 </a:solidFill>
               </a:rPr>
-              <a:t>Missing labels fixed 16 Oct (images re-extracted; train 4,451 → 6,437 images). Then gender (m → 0, f → 1), one shared frame grid, re-fit all 87 tasks, rebuild, re-check. Proposed: only then use 3DPW.</a:t>
+              <a:t>Missing labels fixed 16 Oct (images re-extracted). Re-fit of all 87 tasks (gender m → 0, f → 1; one shared frame grid) and re-check done 18 Oct: WARN (was FAIL), no actor missing. Proposed: use these labels in the final model.</a:t>
             </a:r>
             <a:endParaRPr lang="en-US" sz="1200" dirty="0"/>
           </a:p>
@@ -12825,7 +12863,7 @@
                   <a:schemeClr val="bg2"/>
                 </a:solidFill>
               </a:rPr>
-              <a:t>the failures are not rig or decoding problems. A training-target bug puts people too far away in v5, v9 and v10; the fix draws bodies closer to their true size. In all 8 v5-line checkpoints, neck02 and the head bone sit half a turn off; in one pilot run, a fixed correction plus a 2-epoch fine-tune restores the neck and passes the fine-tune checks. Two flipped hand bones were half the finger error. 3DPW labels: joints and surface pass; three defects (slide 6).</a:t>
+              <a:t>the failures are not rig or decoding problems. A training-target bug puts people too far away in v5, v9 and v10; the fix draws bodies closer to their true size. In all 8 v5-line checkpoints, neck02 and the head bone sit half a turn off; in one pilot run, a fixed correction plus a 2-epoch fine-tune restores the neck and passes the fine-tune checks. Two flipped hand bones were half the finger error. 3DPW labels: three defects found and fixed by a re-fit (slide 6).</a:t>
             </a:r>
             <a:endParaRPr lang="en-US" sz="1500" dirty="0"/>
           </a:p>
@@ -12953,7 +12991,7 @@
                   <a:srgbClr val="EEF2F7"/>
                 </a:solidFill>
               </a:rPr>
-              <a:t>Fine-tune v9 (best on our 3DPW-Anny labels, which have the gender defect: slide 6) with the fixed targets and depth ×5? Or first fix gender and frame grid, re-fit all 3DPW tasks, then fine-tune?</a:t>
+              <a:t>Fine-tune v9 (best on our old 3DPW-Anny labels, which had the gender defect: slide 6) with the fixed targets and depth ×5? Or first fix gender and frame grid, re-fit all 3DPW tasks (done 18 Oct), then fine-tune?</a:t>
             </a:r>
             <a:endParaRPr lang="en-US" sz="1300" dirty="0"/>
           </a:p>
@@ -17043,7 +17081,7 @@
                   <a:schemeClr val="tx1"/>
                 </a:solidFill>
               </a:rPr>
-              <a:t>3DPW labels: joints and surface pass, three defects</a:t>
+              <a:t>3DPW labels: three defects found and fixed</a:t>
             </a:r>
             <a:endParaRPr lang="en-US" sz="2700" dirty="0"/>
           </a:p>
@@ -17179,7 +17217,7 @@
                   <a:schemeClr val="tx1"/>
                 </a:solidFill>
               </a:rPr>
-              <a:t>median 18.7 mm (p95 24.5), below the ~26 mm cited for 3DPW's own joints.</a:t>
+              <a:t>median 14.1 mm (p95 21.1; was 18.7), below the ~26 mm cited for 3DPW's own joints.</a:t>
             </a:r>
             <a:endParaRPr lang="en-US" sz="1100" dirty="0"/>
           </a:p>
@@ -17205,7 +17243,7 @@
                   <a:schemeClr val="tx1"/>
                 </a:solidFill>
               </a:rPr>
-              <a:t>median 18.9 / 18.3 mm, nearest point, so a lower bound; worst region torso, 28 mm.</a:t>
+              <a:t>median 18.9 / 16.1 mm (was 18.9 / 18.3), nearest point, so a lower bound.</a:t>
             </a:r>
             <a:endParaRPr lang="en-US" sz="1100" dirty="0"/>
           </a:p>
@@ -17231,7 +17269,7 @@
                   <a:schemeClr val="tx1"/>
                 </a:solidFill>
               </a:rPr>
-              <a:t>12.4 px median, only +1.1 px over raw 3DPW (11.3 px).</a:t>
+              <a:t>11.5 px median, only +0.4 px over raw 3DPW (11.1 px); was +1.1.</a:t>
             </a:r>
             <a:endParaRPr lang="en-US" sz="1100" dirty="0"/>
           </a:p>
@@ -17283,7 +17321,7 @@
                   <a:schemeClr val="tx1"/>
                 </a:solidFill>
               </a:rPr>
-              <a:t>22,915 frames; mean joint error per frame: median 18.2 mm, max 70.9 mm.</a:t>
+              <a:t>22,912 frames; mean joint error per frame: median 14.0 mm, max 79.8 mm.</a:t>
             </a:r>
             <a:endParaRPr lang="en-US" sz="1100" dirty="0"/>
           </a:p>
@@ -17291,7 +17329,7 @@
       </p:sp>
       <p:sp>
         <p:nvSpPr>
-          <p:cNvPr id="7" name="ev Label defects"/>
+          <p:cNvPr id="7" name="ev Defects: fixed"/>
           <p:cNvSpPr/>
           <p:nvPr/>
         </p:nvSpPr>
@@ -17306,11 +17344,11 @@
             </a:avLst>
           </a:prstGeom>
           <a:solidFill>
-            <a:srgbClr val="FBE9E7"/>
+            <a:srgbClr val="E6F4EA"/>
           </a:solidFill>
           <a:ln w="12700">
             <a:solidFill>
-              <a:srgbClr val="FBE9E7"/>
+              <a:srgbClr val="E6F4EA"/>
             </a:solidFill>
             <a:prstDash val="solid"/>
           </a:ln>
@@ -17318,7 +17356,7 @@
       </p:sp>
       <p:sp>
         <p:nvSpPr>
-          <p:cNvPr id="8" name="ev dot Label defects"/>
+          <p:cNvPr id="8" name="ev dot Defects: fixed"/>
           <p:cNvSpPr/>
           <p:nvPr/>
         </p:nvSpPr>
@@ -17331,11 +17369,11 @@
             <a:avLst/>
           </a:prstGeom>
           <a:solidFill>
-            <a:schemeClr val="accent4"/>
+            <a:schemeClr val="accent3"/>
           </a:solidFill>
           <a:ln w="12700">
             <a:solidFill>
-              <a:schemeClr val="accent4"/>
+              <a:schemeClr val="accent3"/>
             </a:solidFill>
             <a:prstDash val="solid"/>
           </a:ln>
@@ -17343,7 +17381,7 @@
       </p:sp>
       <p:sp>
         <p:nvSpPr>
-          <p:cNvPr id="9" name="ev head Label defects"/>
+          <p:cNvPr id="9" name="ev head Defects: fixed"/>
           <p:cNvSpPr txBox="1"/>
           <p:nvPr/>
         </p:nvSpPr>
@@ -17371,7 +17409,7 @@
                   <a:schemeClr val="tx1"/>
                 </a:solidFill>
               </a:rPr>
-              <a:t>Label defects</a:t>
+              <a:t>Defects: fixed</a:t>
             </a:r>
             <a:endParaRPr lang="en-US" sz="1500" dirty="0"/>
           </a:p>
@@ -17379,7 +17417,7 @@
       </p:sp>
       <p:sp>
         <p:nvSpPr>
-          <p:cNvPr id="10" name="ev body Label defects"/>
+          <p:cNvPr id="10" name="ev body Defects: fixed"/>
           <p:cNvSpPr txBox="1"/>
           <p:nvPr/>
         </p:nvSpPr>
@@ -17411,7 +17449,7 @@
                   <a:schemeClr val="tx1"/>
                 </a:solidFill>
               </a:rPr>
-              <a:t>Gender reversed: </a:t>
+              <a:t>Gender: </a:t>
             </a:r>
             <a:r>
               <a:rPr lang="en-US" sz="1100" dirty="0">
@@ -17419,7 +17457,7 @@
                   <a:schemeClr val="tx1"/>
                 </a:solidFill>
               </a:rPr>
-              <a:t>Anny 0 = male, but 3DPW men get 1, women 0. Refit of 73 male samples, gender flipped: joints better for 72 (19.2 → 15.3 mm), surface for 68. Female (31): mixed, surface better for 27, joints for 8.</a:t>
+              <a:t>was reversed (men 1, women 0); now men 0, women 1, Anny's convention. Flipping it now makes the fit worse: men 13.9 → 20.0 mm (was better for 72 of 73).</a:t>
             </a:r>
             <a:endParaRPr lang="en-US" sz="1100" dirty="0"/>
           </a:p>
@@ -17445,7 +17483,7 @@
                   <a:schemeClr val="tx1"/>
                 </a:solidFill>
               </a:rPr>
-              <a:t>in 407 of 960, one actor (valid in 3DPW) has no label: not fitted on that frame, mostly the per-person frame step (slide 5).</a:t>
+              <a:t>one actor unlabelled in 407 of 960 → 0 of 1,080: both people now share one frame grid.</a:t>
             </a:r>
             <a:endParaRPr lang="en-US" sz="1100" dirty="0"/>
           </a:p>
@@ -17471,7 +17509,7 @@
                   <a:schemeClr val="tx1"/>
                 </a:solidFill>
               </a:rPr>
-              <a:t>6 train sequences, part of captureSelfies_00, val basketball_01 (image files missing). Fixed 16 Oct: train 4,451 → 6,437, val 2,458 → 2,777.</a:t>
+              <a:t>image files missing; re-extracted 16 Oct. New labels: 16,694 images, 22,749 people (fewer images, same people).</a:t>
             </a:r>
             <a:endParaRPr lang="en-US" sz="1100" dirty="0"/>
           </a:p>
@@ -17607,7 +17645,7 @@
                   <a:schemeClr val="tx1"/>
                 </a:solidFill>
               </a:rPr>
-              <a:t>neck02/03, head, jaw at rest in all 2,535 checked people; only neck01 turns.</a:t>
+              <a:t>neck02/03, head, jaw at rest in every label; only neck01 turns.</a:t>
             </a:r>
             <a:endParaRPr lang="en-US" sz="1100" dirty="0"/>
           </a:p>
@@ -17633,7 +17671,7 @@
                   <a:schemeClr val="tx1"/>
                 </a:solidFill>
               </a:rPr>
-              <a:t>20° in SMPL, 9.5° in the labels (median), lost mainly in test.</a:t>
+              <a:t>19.3° in SMPL, 19.6° in the labels (median); was 9.5°.</a:t>
             </a:r>
             <a:endParaRPr lang="en-US" sz="1100" dirty="0"/>
           </a:p>
@@ -17651,7 +17689,7 @@
                   <a:schemeClr val="tx1"/>
                 </a:solidFill>
               </a:rPr>
-              <a:t>Overall FAIL: </a:t>
+              <a:t>Overall WARN (was FAIL): </a:t>
             </a:r>
             <a:r>
               <a:rPr lang="en-US" sz="1100" dirty="0">
@@ -17659,7 +17697,7 @@
                   <a:schemeClr val="tx1"/>
                 </a:solidFill>
               </a:rPr>
-              <a:t>limb-length ratios (forearm 0.879, thigh 1.119 Anny/SMPL); FAIL in test only, train PASS; cause unknown. Elbow, wrist 14–18 mm.</a:t>
+              <a:t>limb-length ratios, forearm 0.948, thigh 1.064 Anny/SMPL; FAIL in validation only (forearm 0.877).</a:t>
             </a:r>
             <a:endParaRPr lang="en-US" sz="1100" dirty="0"/>
           </a:p>
@@ -17685,7 +17723,7 @@
                   <a:schemeClr val="tx1"/>
                 </a:solidFill>
               </a:rPr>
-              <a:t>3.2% of people have a joint &gt; 100 mm (worst: hips). Train alone: 5.2%, FAIL.</a:t>
+              <a:t>3.2% of people have a joint &gt; 100 mm (worst: left hip, climbing_02). Train alone: 5.5%, FAIL.</a:t>
             </a:r>
             <a:endParaRPr lang="en-US" sz="1100" dirty="0"/>
           </a:p>
@@ -17729,7 +17767,7 @@
                   <a:schemeClr val="tx2"/>
                 </a:solidFill>
               </a:rPr>
-              <a:t>slurm/diagnostics/check_3dpw_conversion.sh, job 3575369; 2,535 people in 2,080 sampled images (40 per sequence, 52 sequences)</a:t>
+              <a:t>check_3dpw_conversion.sh, job 3611284 on the re-fit labels (old labels: 3575369); 3,314 people, 2,360 images, 59 sequences</a:t>
             </a:r>
             <a:endParaRPr lang="en-US" sz="1100" dirty="0"/>
           </a:p>

</xml_diff>

<commit_message>
WIP docs: handover/deck update still in progress - not for main yet
Co-Authored-By: Claude Fable 5.1 <noreply@anthropic.com>
Claude-Session: https://claude.ai/code/session_016LhpG4kT7Z7ppxbG4TW5S9
</commit_message>
<xml_diff>
--- a/docs/supervisor_update_2026-10-16.pptx
+++ b/docs/supervisor_update_2026-10-16.pptx
@@ -124,7 +124,7 @@
   <p:extLst>
     <p:ext uri="{521415D9-36F7-43E2-AB2F-B90AF26B5E84}">
       <p14:sectionLst xmlns:p14="http://schemas.microsoft.com/office/powerpoint/2010/main">
-        <p14:section name="Overview" id="{480f32ca-5e82-d50f-3476-6077eb44aa42}">
+        <p14:section name="Overview" id="{c4d3c183-8fcb-ea29-b9c3-b7a1163f06b9}">
           <p14:sldIdLst>
             <p14:sldId id="256"/>
             <p14:sldId id="257"/>
@@ -132,13 +132,13 @@
             <p14:sldId id="259"/>
           </p14:sldIdLst>
         </p14:section>
-        <p14:section name="3DPW labels" id="{16e27fbb-b679-5934-8a69-464407c49795}">
+        <p14:section name="3DPW labels" id="{ed74554a-6a09-1b84-3fab-1ddc5391090b}">
           <p14:sldIdLst>
             <p14:sldId id="260"/>
             <p14:sldId id="261"/>
           </p14:sldIdLst>
         </p14:section>
-        <p14:section name="Findings" id="{a0026603-5dca-cef9-a609-20ff0fd05b7a}">
+        <p14:section name="Findings" id="{46dc4d55-5a2c-bdad-cd2c-43282fb57536}">
           <p14:sldIdLst>
             <p14:sldId id="262"/>
             <p14:sldId id="263"/>
@@ -146,14 +146,14 @@
             <p14:sldId id="265"/>
           </p14:sldIdLst>
         </p14:section>
-        <p14:section name="Bug" id="{f4bf4c1c-cc75-1281-4ba3-85a04aba7a09}">
+        <p14:section name="Bug" id="{8de0477c-d3fe-b629-f3ba-a28acf771616}">
           <p14:sldIdLst>
             <p14:sldId id="266"/>
             <p14:sldId id="267"/>
             <p14:sldId id="268"/>
           </p14:sldIdLst>
         </p14:section>
-        <p14:section name="Next" id="{e9a23628-a2fb-8c12-98a6-f4870ac2bdd1}">
+        <p14:section name="Next" id="{f71b6dc8-b739-90b3-7323-71036e95ebff}">
           <p14:sldIdLst>
             <p14:sldId id="269"/>
             <p14:sldId id="270"/>
@@ -161,7 +161,7 @@
             <p14:sldId id="272"/>
           </p14:sldIdLst>
         </p14:section>
-        <p14:section name="Appendix" id="{423479b1-2ce8-ac0b-97e1-1f3b29768165}">
+        <p14:section name="Appendix" id="{1d4d6046-6a20-fbf1-47d5-cb2a9811a4eb}">
           <p14:sldIdLst>
             <p14:sldId id="273"/>
           </p14:sldIdLst>
@@ -666,7 +666,7 @@
           <a:p>
             <a:r>
               <a:rPr lang="en-US" dirty="0"/>
-              <a:t>If asked: Recall: the model detects only 47 percent of the labelled people, 33 percent of the babies and 43 percent of the kids; the photos are crowded and the model runs at 672 pixels. So every number covers detected people only. Matching: each detection is paired with a labelled box by overlap, IoU at least 0.3. In crowded scenes a few child labels may get an adult detection; that would blur the height drop and any age gap, but it cannot create the height drop, and the clear height drop says most matches are real children. The fine-tuned model with the neck and finger fix gives the same numbers within noise: AUC 0.613, kids 0.62, adults 0.64, gender 0.533 for men and 0.562 for women. That is expected: the fix turns bones, not the shape output. Teens sit in between, age 0.60 and height 0.49. Our own photos agree: the one real child, a standing boy, gets age 0.60 and height 0.48; the five small people I quoted before were mostly crouching or seated adults, because the skeletal height I used is measured on the posed body. On synthetic data the same pull shows at both ends: holdout people with a true age of 0.6 to 0.8 come out at 0.57, and the youngest training people at 0.10 instead of 0.015. Showing about five times more synthetic children for two epochs was inconclusive, 48.5 against 53.1 millimetres on ten training children, and it has no mechanism for real photos. So I cannot yet say whether the cause is the gap between synthetic and real images, or the loss, an L1 through a sigmoid on rare values. In Anny a child is mainly narrow shoulders relative to the head, and only a low age gives that; a low height at age 0.6 gives a short, broad-shouldered adult, at least 1.22 metres tall. I do not convert ages to years: our code uses three different scales, and the dataset most likely does not follow Anny's own calibration. Relative Human has about 24,800 people with age-group labels, among them 2,720 children and 1,534 babies, plus gender; its training split is where weak labels would come from. The 3DPW labels fix age at 0.55 and seven more shape values at 0.5 for everyone; only height and proportions are fitted, and gender comes from 3DPW. With the flag on, the final model's 3DPW error can change for a reason unrelated to the depth and bone fixes, because the 3DPW ground-truth meshes keep that average body. Anny-Fit, from the group that made Anny, refits bodies at test time from a vision-language model's age and gender; it could give better figures, but it is not our model.</a:t>
+              <a:t>If asked: Recall: the model detects only 47 percent of the labelled people, 33 percent of the babies and 43 percent of the kids; the photos are crowded and the model runs at 672 pixels. So every number covers detected people only. Matching: each detection is paired with a labelled box by overlap, IoU at least 0.3. In crowded scenes a few child labels may get an adult detection; that would blur the height drop and any age gap, but it cannot create the height drop, and the clear height drop says most matches are real children. The fine-tuned model with the neck and finger fix gives the same numbers within noise: AUC 0.613, kids 0.62, adults 0.64, gender 0.533 for men and 0.562 for women. That is expected: the fix turns bones, not the shape output. Teens get age 0.60 and height 0.49, between adults and kids in height. Our own photos agree: the one real child, a standing boy, gets age 0.60 and height 0.48; the five small people I quoted before were mostly crouching or seated adults, because the skeletal height I used is measured on the posed body. On synthetic data the same pull shows at both ends: holdout people with a true age of 0.6 to 0.8 come out at 0.57, and the youngest training people at 0.10 instead of 0.015. Showing about five times more synthetic children for two epochs was inconclusive, 48.5 against 53.1 millimetres on ten training children, and it has no mechanism for real photos. So I cannot yet say whether the cause is the gap between synthetic and real images, or the loss, an L1 through a sigmoid on rare values. In Anny a child is mainly narrow shoulders relative to the head, and only a low age gives that; a low height at age 0.6 gives a short, broad-shouldered adult, at least 1.22 metres tall. I do not convert ages to years: our code uses three different scales, and the dataset most likely does not follow Anny's own calibration. Relative Human has about 24,800 people with age-group labels, among them 2,720 children and 1,534 babies, plus gender; its training split is where weak labels would come from. The 3DPW labels fix age at 0.55 and seven more shape values at 0.5 for everyone; only height and proportions are fitted, and gender comes from 3DPW. With the flag on, the final model's 3DPW error can change for a reason unrelated to the depth and bone fixes, because the 3DPW ground-truth meshes keep that average body. Anny-Fit, from the group that made Anny, refits bodies at test time from a vision-language model's age and gender; it could give better figures, but it is not our model.</a:t>
             </a:r>
           </a:p>
         </p:txBody>

</xml_diff>

<commit_message>
Deck: final model now training (slides 16, 17 and notes 10, 16, 17); handover check line
Co-Authored-By: Claude Opus 5.5 <noreply@anthropic.com>
Claude-Session: https://claude.ai/code/session_016LhpG4kT7Z7ppxbG4TW5S9
</commit_message>
<xml_diff>
--- a/docs/supervisor_update_2026-10-16.pptx
+++ b/docs/supervisor_update_2026-10-16.pptx
@@ -124,7 +124,7 @@
   <p:extLst>
     <p:ext uri="{521415D9-36F7-43E2-AB2F-B90AF26B5E84}">
       <p14:sectionLst xmlns:p14="http://schemas.microsoft.com/office/powerpoint/2010/main">
-        <p14:section name="Overview" id="{c4d3c183-8fcb-ea29-b9c3-b7a1163f06b9}">
+        <p14:section name="Overview" id="{4f714fe2-108b-882f-8c0f-6b56b949ed76}">
           <p14:sldIdLst>
             <p14:sldId id="256"/>
             <p14:sldId id="257"/>
@@ -132,13 +132,13 @@
             <p14:sldId id="259"/>
           </p14:sldIdLst>
         </p14:section>
-        <p14:section name="3DPW labels" id="{ed74554a-6a09-1b84-3fab-1ddc5391090b}">
+        <p14:section name="3DPW labels" id="{7ede61d7-e3d9-20ba-01bf-cab12b5cabea}">
           <p14:sldIdLst>
             <p14:sldId id="260"/>
             <p14:sldId id="261"/>
           </p14:sldIdLst>
         </p14:section>
-        <p14:section name="Findings" id="{46dc4d55-5a2c-bdad-cd2c-43282fb57536}">
+        <p14:section name="Findings" id="{8f010fcd-5259-cd36-f45a-9f1713e2ab3e}">
           <p14:sldIdLst>
             <p14:sldId id="262"/>
             <p14:sldId id="263"/>
@@ -146,14 +146,14 @@
             <p14:sldId id="265"/>
           </p14:sldIdLst>
         </p14:section>
-        <p14:section name="Bug" id="{8de0477c-d3fe-b629-f3ba-a28acf771616}">
+        <p14:section name="Bug" id="{c1102b0f-ca97-044b-b743-b0b9b53a950f}">
           <p14:sldIdLst>
             <p14:sldId id="266"/>
             <p14:sldId id="267"/>
             <p14:sldId id="268"/>
           </p14:sldIdLst>
         </p14:section>
-        <p14:section name="Next" id="{f71b6dc8-b739-90b3-7323-71036e95ebff}">
+        <p14:section name="Next" id="{ee7b92de-e5d5-7ef8-2f7b-99111b4924ab}">
           <p14:sldIdLst>
             <p14:sldId id="269"/>
             <p14:sldId id="270"/>
@@ -161,7 +161,7 @@
             <p14:sldId id="272"/>
           </p14:sldIdLst>
         </p14:section>
-        <p14:section name="Appendix" id="{1d4d6046-6a20-fbf1-47d5-cb2a9811a4eb}">
+        <p14:section name="Appendix" id="{a8842475-ea0e-8213-b3c4-486fc362b04e}">
           <p14:sldIdLst>
             <p14:sldId id="273"/>
           </p14:sldIdLst>
@@ -657,7 +657,7 @@
           <a:p>
             <a:r>
               <a:rPr lang="en-US" dirty="0"/>
-              <a:t>On training images the model can make child-like bodies, but on real photos it does not. I measured this on Relative Human, a public set of real photos with age-group labels: 635 validation images with 2,130 labelled people. The detected kids get a predicted age of 0.61 and the babies 0.62, against 0.63 for adults, so age barely separates them: the AUC is 0.61, where 0.5 is chance, and none of the 89 detected kids and only one of the 38 babies falls below our child threshold of 0.45. The model does see that they are small, but it puts that into height, not age: height goes from 0.51 for adults to 0.45 for kids and 0.39 for babies. So it reads children as short adults; in Anny, a low height at an adult age is a short, broad-shouldered adult. Gender carries no signal either: men get 0.535 on average and women 0.551, while Anny's male end is 0. This is the same pull to the training median we see on synthetic data, and it replaces my earlier by-eye reading of a few people in our own photos. The decision for today: write it up as a limitation, or add weak age labels from the Relative Human training set, as the BEV paper did, which is one to two weeks of code after the final model. Separately, a flag can stop the 3DPW labels from training every real person toward one fixed average body; it is off by default, and whether the final model uses it is also a decision for today.</a:t>
+              <a:t>On training images the model can make child-like bodies, but on real photos it does not. I measured this on Relative Human, a public set of real photos with age-group labels: 635 validation images with 2,130 labelled people. The detected kids get a predicted age of 0.61 and the babies 0.62, against 0.63 for adults, so age barely separates them: the AUC is 0.61, where 0.5 is chance, and none of the 89 detected kids and only one of the 38 babies falls below our child threshold of 0.45. The model does see that they are small, but it puts that into height, not age: height goes from 0.51 for adults to 0.45 for kids and 0.39 for babies. So it reads children as short adults; in Anny, a low height at an adult age is a short, broad-shouldered adult. Gender carries no signal either: men get 0.535 on average and women 0.551, while Anny's male end is 0. This is the same pull to the training median we see on synthetic data, and it replaces my earlier by-eye reading of a few people in our own photos. The decision for today: write it up as a limitation, or add weak age labels from the Relative Human training set, as the BEV paper did, which is one to two weeks of code after the final model. Separately, a flag can stop the 3DPW labels from training every real person toward one fixed average body; it is off by default, and the final model that started training on 18 October has it off; a run with it on can follow.</a:t>
             </a:r>
           </a:p>
           <a:p>
@@ -1206,7 +1206,7 @@
           <a:p>
             <a:r>
               <a:rPr lang="en-US" dirty="0"/>
-              <a:t>Seven things are still open. First, the bone flips. The neck fix passes in one run; the holdout renders of the correction alone show normal necks, and so, by eye, do the 8 real images I have seen so far from a first demo of the fine-tuned model. I still need a longer run, and real images have no neck metric. v10's left arm has the same kind of flip, but a bone further down the arm undoes it, so it needs a two-sided correction, not built yet. Second, the depth slope is stuck at 0.3 to 0.4, cause unknown. Third, the cost of the depth fix, paired on the same people. Fourth, pilot noise: fix the seed or repeat key runs. Fifth, people very close to the camera. Sixth, children and fingers: children are now measured on real photos with age labels, the Relative Human dataset: the model reads them as short adults, and age separates them from adults with an AUC of only 0.61 (slide 10); the decision is a limitation or weak age labels. For fingers, a look at the hands with the bone fix. Seventh, 3DPW: the labels had three defects. The missing labels came back on 16 October, when I re-extracted the images of eight sequences; train went from 4,451 to 6,437 label images. The re-fit with the gender and frame-grid fixes finished on 18 October, and the check on the new labels passes with a warning, with no defect left (slide 6). What stays open is to use them: the final model would be the first run on these labels.</a:t>
+              <a:t>Seven things are still open. First, the bone flips. The neck fix passes in one run; the holdout renders of the correction alone show normal necks, and so, by eye, do the 8 real images I have seen so far from a first demo of the fine-tuned model. I still need a longer run, and real images have no neck metric. v10's left arm has the same kind of flip, but a bone further down the arm undoes it, so it needs a two-sided correction, not built yet. Second, the depth slope is stuck at 0.3 to 0.4, cause unknown. Third, the cost of the depth fix, paired on the same people. Fourth, pilot noise: fix the seed or repeat key runs. Fifth, people very close to the camera. Sixth, children and fingers: children are now measured on real photos with age labels, the Relative Human dataset: the model reads them as short adults, and age separates them from adults with an AUC of only 0.61 (slide 10); the decision is a limitation or weak age labels. For fingers, a look at the hands with the bone fix. Seventh, 3DPW: the labels had three defects. The missing labels came back on 16 October, when I re-extracted the images of eight sequences; train went from 4,451 to 6,437 label images. The re-fit with the gender and frame-grid fixes finished on 18 October, and the check on the new labels passes with a warning, with no defect left (slide 6). They are in use: the final model and its control started training on them on 18 October, and a short smoke test of the whole recipe passed.</a:t>
             </a:r>
           </a:p>
           <a:p>
@@ -1347,7 +1347,7 @@
           <a:p>
             <a:r>
               <a:rPr lang="en-US" dirty="0"/>
-              <a:t>- Option 2, labels first: the re-fit is done. Men to 0, women to 1 by Anny's convention, one shared frame grid, all 87 conversion tasks fitted again into a new folder, about 28 GPU hours at the measured 4.4 seconds per frame, finished on 18 October; the labels are rebuilt, 16,694 images, and the check on them passes with a warning (slide 6). Rebuilding the labels alone would not have been enough, because the gender and the frame choice are fixed inside the fit. The fine-tune after it would start from v5 with v5's own bone fix and the depth fix, run 10 epochs, and have a control run without the two fixes; it has not run yet. I prefer this option: 3DPW is 30 percent of each batch, so a fine-tune on the old labels would keep learning the wrong body for the men.</a:t>
+              <a:t>- Option 2, labels first: the re-fit is done. Men to 0, women to 1 by Anny's convention, one shared frame grid, all 87 conversion tasks fitted again into a new folder, about 28 GPU hours at the measured 4.4 seconds per frame, finished on 18 October; the labels are rebuilt, 16,694 images, and the check on them passes with a warning (slide 6). Rebuilding the labels alone would not have been enough, because the gender and the frame choice are fixed inside the fit. The fine-tune after it would start from v5 with v5's own bone fix and the depth fix, run 10 epochs, and have a control run without the two fixes; both started training on 18 October, after a short smoke test of the whole recipe passed. I prefer this option: 3DPW is 30 percent of each batch, so a fine-tune on the old labels would keep learning the wrong body for the men.</a:t>
             </a:r>
           </a:p>
           <a:p>
@@ -1359,7 +1359,7 @@
           <a:p>
             <a:r>
               <a:rPr lang="en-US" dirty="0"/>
-              <a:t>- Both options: either fine-tune should also mask the 3DPW finger labels, which are set to the rest pose, with mask_3dpw_hands. A new flag can also leave out the eight 3DPW shape values that are constants, age 0.55 and seven at 0.5; it is off by default, and on or off is a decision for today (slide 10). With it on, the 3DPW error can change for a reason unrelated to the two fixes.</a:t>
+              <a:t>- Both options: either fine-tune should also mask the 3DPW finger labels, which are set to the rest pose, with mask_3dpw_hands. A new flag can also leave out the eight 3DPW shape values that are constants, age 0.55 and seven at 0.5; it is off by default, and the first final-model run has it off (slide 10). With it on, the 3DPW error can change for a reason unrelated to the two fixes.</a:t>
             </a:r>
           </a:p>
         </p:txBody>
@@ -12709,7 +12709,7 @@
                   <a:schemeClr val="tx2"/>
                 </a:solidFill>
               </a:rPr>
-              <a:t>Missing labels fixed 16 Oct (images re-extracted). Re-fit of all 87 tasks (gender m → 0, f → 1; one shared frame grid) and re-check done 18 Oct: WARN (was FAIL), no actor missing. Proposed: use these labels in the final model.</a:t>
+              <a:t>Missing labels fixed 16 Oct (images re-extracted). Re-fit of all 87 tasks (gender m → 0, f → 1; one shared frame grid) and re-check done 18 Oct: WARN (was FAIL), no actor missing. In use: the final model started training on them 18 Oct.</a:t>
             </a:r>
             <a:endParaRPr lang="en-US" sz="1200" dirty="0"/>
           </a:p>
@@ -12991,7 +12991,7 @@
                   <a:srgbClr val="EEF2F7"/>
                 </a:solidFill>
               </a:rPr>
-              <a:t>Fine-tune v9 (best on our old 3DPW-Anny labels, which had the gender defect: slide 6) with the fixed targets and depth ×5? Or first fix gender and frame grid, re-fit all 3DPW tasks (done 18 Oct), then fine-tune?</a:t>
+              <a:t>Chosen: fix gender and frame grid, re-fit all 3DPW tasks, then fine-tune v5 (re-fit done; fine-tune and control training since 18 Oct). Next: write up, or also add weak age labels for children (1–2 weeks)?</a:t>
             </a:r>
             <a:endParaRPr lang="en-US" sz="1300" dirty="0"/>
           </a:p>

</xml_diff>

<commit_message>
WIP docs: final-model slide (verification in progress) + real-photo figure - not for main yet
Co-Authored-By: Claude Fable 5.1 <noreply@anthropic.com>
Claude-Session: https://claude.ai/code/session_016LhpG4kT7Z7ppxbG4TW5S9
</commit_message>
<xml_diff>
--- a/docs/supervisor_update_2026-10-16.pptx
+++ b/docs/supervisor_update_2026-10-16.pptx
@@ -125,7 +125,7 @@
   <p:extLst>
     <p:ext uri="{521415D9-36F7-43E2-AB2F-B90AF26B5E84}">
       <p14:sectionLst xmlns:p14="http://schemas.microsoft.com/office/powerpoint/2010/main">
-        <p14:section name="Overview" id="{e01ea985-1071-e2b8-1fdf-a4f6380745d2}">
+        <p14:section name="Overview" id="{3eb7fa51-31d1-5a7d-c6f6-9b6c8a82c955}">
           <p14:sldIdLst>
             <p14:sldId id="256"/>
             <p14:sldId id="257"/>
@@ -133,13 +133,13 @@
             <p14:sldId id="259"/>
           </p14:sldIdLst>
         </p14:section>
-        <p14:section name="3DPW labels" id="{0d9854fb-fb38-968c-8f83-45501d754c1a}">
+        <p14:section name="3DPW labels" id="{1c862f68-4b85-2c20-1f2d-08a20775f0e2}">
           <p14:sldIdLst>
             <p14:sldId id="260"/>
             <p14:sldId id="261"/>
           </p14:sldIdLst>
         </p14:section>
-        <p14:section name="Findings" id="{7fafdf10-7e9b-7ce0-8551-4703560017c0}">
+        <p14:section name="Findings" id="{3aa04325-3df7-5f8f-4a75-bb7ea97d054e}">
           <p14:sldIdLst>
             <p14:sldId id="262"/>
             <p14:sldId id="263"/>
@@ -147,14 +147,14 @@
             <p14:sldId id="265"/>
           </p14:sldIdLst>
         </p14:section>
-        <p14:section name="Bug" id="{db84a4d9-e48e-4177-5127-64ddeb01df21}">
+        <p14:section name="Bug" id="{3ac16dd5-6330-0a17-9ceb-c92eac6c9aa7}">
           <p14:sldIdLst>
             <p14:sldId id="266"/>
             <p14:sldId id="267"/>
             <p14:sldId id="268"/>
           </p14:sldIdLst>
         </p14:section>
-        <p14:section name="Next" id="{8c0c7be1-203c-47e5-4e80-efea5c39aab4}">
+        <p14:section name="Next" id="{4f7e3e65-b3c0-050e-17fc-99d6dd2b0564}">
           <p14:sldIdLst>
             <p14:sldId id="269"/>
             <p14:sldId id="270"/>
@@ -163,7 +163,7 @@
             <p14:sldId id="273"/>
           </p14:sldIdLst>
         </p14:section>
-        <p14:section name="Appendix" id="{f99d6df1-7146-e96d-629c-324209651f1a}">
+        <p14:section name="Appendix" id="{b4f38c31-588c-79b0-65b5-e7791c40e1d1}">
           <p14:sldIdLst>
             <p14:sldId id="274"/>
           </p14:sldIdLst>
@@ -929,7 +929,7 @@
           <a:p>
             <a:r>
               <a:rPr lang="en-US" dirty="0"/>
-              <a:t>The fix is one switch: build the training targets at the head, the joint the model anchors. Each fix run has a control with the same schedule and the switch off. The root error is the 3D distance between the predicted and the true root joint, at the pelvis. Drawn size is the predicted head-to-pelvis distance in pixels over the true one; 1 is right. With the depth loss five times stronger for 10 epochs, the root error falls from 1.21 to 0.54 metres, and bodies are drawn at 84 percent of their true size. The controls stay at 1.11 to 1.44 metres. But near and far are still not separated: the slope is 0.30 with the switch alone and 0.38 to 0.44 with the stronger depth loss. Predictions are pulled toward about 2.5 to 2.9 metres, and I do not know why. The fix likely has a cost: every fix run is worse than its control, by 2.6 to 4.9 millimetres PVE and 1.6 to 2.4 recall points. That is inside or at the edge of pilot noise, so I call it a likely cost, not a proven one. The twenty-times 10-epoch run has no result yet. The final model on slide 16 uses the five-times fix together with the bone fix and real photos: root error 0.73 metres against 1.40 for its own control and 1.21 for v5, size 0.78 against 0.59, slope 0.42 against 0.28. So its slope is the best so far, but still far from 1, and its measured cost is 2 recall points, with PVE inside the noise.</a:t>
+              <a:t>The fix is one switch: build the training targets at the head, the joint the model anchors. Each fix run has a control with the same schedule and the switch off. The root error is the 3D distance between the predicted and the true root joint, at the pelvis. Drawn size is the predicted head-to-pelvis distance in pixels over the true one; 1 is right. With the depth loss five times stronger for 10 epochs, the root error falls from 1.21 to 0.54 metres, and bodies are drawn at 84 percent of their true size. The controls stay at 1.11 to 1.44 metres. But near and far are still not separated: the slope is 0.30 with the switch alone and 0.38 to 0.44 with the stronger depth loss. Predictions are pulled toward about 2.5 to 2.9 metres, and I do not know why. The fix likely has a cost: every fix run is worse than its control, by 2.6 to 4.9 millimetres PVE and 1.6 to 2.4 recall points. That is inside or at the edge of pilot noise, so I call it a likely cost, not a proven one. The twenty-times 10-epoch run has no result yet. The final model on slide 16 uses the five-times fix together with the bone fix and real photos: root error 0.73 metres against 1.40 for its own control and 1.21 for v5, size 0.78 against 0.59, slope 0.42 against 0.28. So its slope is about as good as the best pilots, but still far from 1, and its measured cost is 2 recall points, with PVE inside the noise.</a:t>
             </a:r>
           </a:p>
           <a:p>
@@ -1208,7 +1208,7 @@
           <a:p>
             <a:r>
               <a:rPr lang="en-US" dirty="0"/>
-              <a:t>This is the final model: v5 fine-tuned for 10 epochs with all fixes at once, the depth fix, the bone fix and the corrected 3DPW labels, next to a control with the same recipe but without the depth and bone fixes. All three fixes hold together after 10 epochs with real photos in the mix: the neck bone goes from 176 to 5 degrees and the neck thickness from 0.46 to 1.00, the finger error halves from 17.4 to 8.3 degrees, and the root error drops by 48 percent, from 1.40 to 0.73 metres. PA-PVE is 50.3 millimetres, 6.1 better than the control and the best of every model so far; that gap is beyond the pilot noise. PVE is 3.7 millimetres better than the control, which is inside the noise. Recall is 2 points lower than the control and 3.2 lower than v5; that is a real cost, and I state it. On the 3DPW test split with the corrected labels, the final model also beats its control: PVE 89.0 against 91.5, PA-PVE 57.6 against 59.7. Both arms sit above v5's 70.5 on the holdout, the restart cost we saw in every fine-tune; the final model recovers more of it than the control. What stays open: the depth slope is 0.42, the best so far but far from 1, so predicted depth is still compressed; the fix moved the offset and the body size, not the slope.</a:t>
+              <a:t>This is the final model: v5 fine-tuned for 10 epochs with all fixes at once, the depth fix, the bone fix and the corrected 3DPW labels, next to a control with the same recipe but without the depth and bone fixes. All three fixes hold together after 10 epochs with real photos in the mix: the neck bone goes from 176 to 5 degrees and the neck thickness from 0.46 to 1.00, the finger error halves from 17.4 to 8.3 degrees, and the root error drops by 48 percent, from 1.40 to 0.73 metres. PA-PVE is 50.3 millimetres, 6.1 better than the control and the best of every model so far; that gap is beyond the pilot noise. PVE is 3.7 millimetres better than the control, which is inside the noise. Recall is 2 points lower than the control and 3.2 lower than v5; that is a real cost, and I state it. On the 3DPW test split with the corrected labels, the final model also beats its control: PVE 89.0 against 91.5, PA-PVE 57.6 against 59.7. Both arms sit above v5's 70.5 on the holdout, the restart cost we saw in every fine-tune; the final model recovers more of it than the control. What stays open: the depth slope is 0.42, as good as the best pilots, 0.43 to 0.44, but far from 1, so predicted depth is still compressed; the fix moved the offset and the body size, not the slope.</a:t>
             </a:r>
           </a:p>
           <a:p>
@@ -1346,7 +1346,7 @@
           <a:p>
             <a:r>
               <a:rPr lang="en-US" dirty="0"/>
-              <a:t>Seven things are still open. First, the bone flips. The fix now holds in the 10-epoch final model, with real photos in training: neck02 4.8 degrees and fingers 8.3 (slide 16). The holdout renders of the correction alone show normal necks, and so, by eye, do the 8 real images I have seen so far from a first demo of the 2-epoch model; real images have no neck metric. v10's left arm has the same kind of flip, but a bone further down the arm undoes it, so it needs a two-sided correction, not built yet. Second, the depth slope: 0.42 in the final model, the best so far but far from 1; cause unknown. Third, the cost of the depth fix: now measured in the final model against its control, PVE within the noise and recall 2 points lower; a comparison paired on the same people is still to do. Fourth, pilot noise: fix the seed or repeat key runs. Fifth, people very close to the camera. Sixth, children and fingers: children are now measured on real photos with age labels, the Relative Human dataset: the model reads them as short adults, and age separates them from adults with an AUC of only 0.61 (slide 10); the decision is a limitation or weak age labels. For fingers, a look at the hands with the bone fix. Seventh, 3DPW: the labels had three defects. The missing labels came back on 16 October, when I re-extracted the images of eight sequences; train went from 4,451 to 6,437 label images. The re-fit with the gender and frame-grid fixes finished on 18 October, and the check on the new labels passes with a warning, with no defect left (slide 6). They are in use: the final model and its control trained on them on 18 October, after a short smoke test of the whole recipe passed (slide 16).</a:t>
+              <a:t>Seven things are still open. First, the bone flips. The fix now holds in the 10-epoch final model, with real photos in training: neck02 4.8 degrees and fingers 8.3 (slide 16). The holdout renders of the correction alone show normal necks, and so, by eye, do the 8 real images I have seen so far from a first demo of the 2-epoch model; real images have no neck metric. v10's left arm has the same kind of flip, but a bone further down the arm undoes it, so it needs a two-sided correction, not built yet. Second, the depth slope: 0.42 in the final model, about as good as the best pilots but far from 1; cause unknown. Third, the cost of the depth fix: now measured in the final model against its control, PVE within the noise and recall 2 points lower; a comparison paired on the same people is still to do. Fourth, pilot noise: fix the seed or repeat key runs. Fifth, people very close to the camera. Sixth, children and fingers: children are now measured on real photos with age labels, the Relative Human dataset: the model reads them as short adults, and age separates them from adults with an AUC of only 0.61 (slide 10); the decision is a limitation or weak age labels. For fingers, a look at the hands with the bone fix. Seventh, 3DPW: the labels had three defects. The missing labels came back on 16 October, when I re-extracted the images of eight sequences; train went from 4,451 to 6,437 label images. The re-fit with the gender and frame-grid fixes finished on 18 October, and the check on the new labels passes with a warning, with no defect left (slide 6). They are in use: the final model and its control trained on them on 18 October, after a short smoke test of the whole recipe passed (slide 16).</a:t>
             </a:r>
           </a:p>
           <a:p>

</xml_diff>

<commit_message>
WIP docs: v23 comparison + real-photo slide + requirements plan in progress - not for main yet
Co-Authored-By: Claude Fable 5.1 <noreply@anthropic.com>
Claude-Session: https://claude.ai/code/session_016LhpG4kT7Z7ppxbG4TW5S9
</commit_message>
<xml_diff>
--- a/docs/supervisor_update_2026-10-16.pptx
+++ b/docs/supervisor_update_2026-10-16.pptx
@@ -24,9 +24,10 @@
     <p:sldId id="272" r:id="rId18"/>
     <p:sldId id="273" r:id="rId19"/>
     <p:sldId id="274" r:id="rId20"/>
+    <p:sldId id="275" r:id="rId21"/>
   </p:sldIdLst>
   <p:notesMasterIdLst>
-    <p:notesMasterId r:id="rId21"/>
+    <p:notesMasterId r:id="rId22"/>
   </p:notesMasterIdLst>
   <p:sldSz cx="9144000" cy="5143500"/>
   <p:notesSz cx="5143500" cy="9144000"/>
@@ -125,7 +126,7 @@
   <p:extLst>
     <p:ext uri="{521415D9-36F7-43E2-AB2F-B90AF26B5E84}">
       <p14:sectionLst xmlns:p14="http://schemas.microsoft.com/office/powerpoint/2010/main">
-        <p14:section name="Overview" id="{3eb7fa51-31d1-5a7d-c6f6-9b6c8a82c955}">
+        <p14:section name="Overview" id="{da8d3304-9dd2-dc43-1253-d26814150d00}">
           <p14:sldIdLst>
             <p14:sldId id="256"/>
             <p14:sldId id="257"/>
@@ -133,13 +134,13 @@
             <p14:sldId id="259"/>
           </p14:sldIdLst>
         </p14:section>
-        <p14:section name="3DPW labels" id="{1c862f68-4b85-2c20-1f2d-08a20775f0e2}">
+        <p14:section name="3DPW labels" id="{7fa300ec-dded-754f-25b0-6b3dcc05fe7e}">
           <p14:sldIdLst>
             <p14:sldId id="260"/>
             <p14:sldId id="261"/>
           </p14:sldIdLst>
         </p14:section>
-        <p14:section name="Findings" id="{3aa04325-3df7-5f8f-4a75-bb7ea97d054e}">
+        <p14:section name="Findings" id="{fb307fe4-d1f1-ab85-96f1-23d3c0b01362}">
           <p14:sldIdLst>
             <p14:sldId id="262"/>
             <p14:sldId id="263"/>
@@ -147,25 +148,26 @@
             <p14:sldId id="265"/>
           </p14:sldIdLst>
         </p14:section>
-        <p14:section name="Bug" id="{3ac16dd5-6330-0a17-9ceb-c92eac6c9aa7}">
+        <p14:section name="Bug" id="{8f29ea54-c4c1-bdcc-5681-2eb39299d43d}">
           <p14:sldIdLst>
             <p14:sldId id="266"/>
             <p14:sldId id="267"/>
             <p14:sldId id="268"/>
           </p14:sldIdLst>
         </p14:section>
-        <p14:section name="Next" id="{4f7e3e65-b3c0-050e-17fc-99d6dd2b0564}">
+        <p14:section name="Next" id="{0bd2bdb5-7dcb-a7b0-d0af-d6c7869db96a}">
           <p14:sldIdLst>
             <p14:sldId id="269"/>
             <p14:sldId id="270"/>
             <p14:sldId id="271"/>
             <p14:sldId id="272"/>
             <p14:sldId id="273"/>
+            <p14:sldId id="274"/>
           </p14:sldIdLst>
         </p14:section>
-        <p14:section name="Appendix" id="{b4f38c31-588c-79b0-65b5-e7791c40e1d1}">
+        <p14:section name="Appendix" id="{e5cd6953-a2e6-30c2-5ac0-318d62f98b00}">
           <p14:sldIdLst>
-            <p14:sldId id="274"/>
+            <p14:sldId id="275"/>
           </p14:sldIdLst>
         </p14:section>
       </p14:sectionLst>
@@ -572,7 +574,7 @@
           <a:p>
             <a:r>
               <a:rPr lang="en-US" dirty="0"/>
-              <a:t>Since last Friday I measured each stage of the pipeline separately. I will show what is not the cause, how the 3DPW labels are made, how well they match 3DPW, three defects I found in them and their fix, what I found in the neck and a first fix for it, what I measured about the fingers and the children, one depth bug nobody was looking for and its fix, the final model with all fixes together next to a control, and what is still open. I will say clearly what is measured and what is only a guess.</a:t>
+              <a:t>Since last Friday I measured each stage of the pipeline separately. I will show what is not the cause, how the 3DPW labels are made, how well they match 3DPW, three defects I found in them and their fix, what I found in the neck and a first fix for it, what I measured about the fingers and the children, one depth bug nobody was looking for and its fix, the final model with all fixes together next to a control, how it looks on real photos, and what is still open. I will say clearly what is measured and what is only a guess.</a:t>
             </a:r>
           </a:p>
         </p:txBody>
@@ -1208,7 +1210,7 @@
           <a:p>
             <a:r>
               <a:rPr lang="en-US" dirty="0"/>
-              <a:t>This is the final model: v5 fine-tuned for 10 epochs with all fixes at once, the depth fix, the bone fix and the corrected 3DPW labels, next to a control with the same recipe but without the depth and bone fixes. All three fixes hold together after 10 epochs with real photos in the mix: the neck bone goes from 176 to 5 degrees and the neck thickness from 0.46 to 1.00, the finger error halves from 17.4 to 8.3 degrees, and the root error drops by 48 percent, from 1.40 to 0.73 metres. PA-PVE is 50.3 millimetres, 6.1 better than the control and the best of every model so far; that gap is beyond the pilot noise. PVE is 3.7 millimetres better than the control, which is inside the noise. Recall is 2 points lower than the control and 3.2 lower than v5; that is a real cost, and I state it. On the 3DPW test split with the corrected labels, the final model also beats its control: PVE 89.0 against 91.5, PA-PVE 57.6 against 59.7. Both arms sit above v5's 70.5 on the holdout, the restart cost we saw in every fine-tune; the final model recovers more of it than the control. What stays open: the depth slope is 0.42, as good as the best pilots, 0.43 to 0.44, but far from 1, so predicted depth is still compressed; the fix moved the offset and the body size, not the slope.</a:t>
+              <a:t>This is the final model: v5 fine-tuned for 10 epochs with all fixes at once, the depth fix, the bone fix and the corrected 3DPW labels, next to a control with the same recipe but without the depth and bone fixes. All three fixes hold together after 10 epochs with real photos in the mix: the neck bone goes from 176 to 5 degrees and the neck thickness from 0.46 to 1.00, the finger error halves from 17.4 to 8.3 degrees, and the root error drops by 48 percent, from 1.40 to 0.73 metres. PA-PVE is 50.3 millimetres, 6.1 better than the control and the best of every model so far; that gap is beyond the pilot noise. PVE is 3.7 millimetres better than the control, which is inside the noise. Recall is 2 points lower than the control and 3.2 lower than v5; that is a real cost, and I state it. On the 3DPW test split with the corrected labels, the final model also beats its control: PVE 89.0 against 91.5, PA-PVE 57.6 against 59.7. And it is now the best of our models on real photos: on the same labels v9, the previous best, gets 95.5 and v5 121.8, so the final model is 6.5 millimetres better than v9, and it finds more of the 3DPW people, 99 percent against 94. Most of the gain over v5 comes from training on 3DPW at all: the control, without the two fixes, already gets 91.5. The fixes add 2.5 millimetres PVE and 2.1 PA-PVE on top, plus the neck, the fingers and the depth, which a pelvis-aligned PVE barely sees. Both arms sit above v5's 70.5 on the holdout, the restart cost we saw in every fine-tune; the final model recovers more of it than the control. What stays open: the depth slope is 0.42, as good as the best pilots, 0.43 to 0.44, but far from 1, so predicted depth is still compressed; the fix moved the offset and the body size, not the slope.</a:t>
             </a:r>
           </a:p>
           <a:p>
@@ -1223,7 +1225,13 @@
           <a:p>
             <a:r>
               <a:rPr lang="en-US" dirty="0"/>
-              <a:t>- 3DPW test against v5 and v9: not yet on the same labels. The old numbers, v9 102.5 and v5 119.1, were measured against the old labels, so they cannot be put next to these. The re-evaluations of v5, v9 epoch 62 and the 2-epoch neck model on the new labels are submitted. MPJPE on the 3DPW test: 88.3 against 90.9 for the control.</a:t>
+              <a:t>- 3DPW test, all five models on the corrected labels with the same script and the same 8,190 images (jobs 3612073 to 3612075 and the two exp7 jobs): PVE v5 121.8, v9 epoch 62 95.5, the 2-epoch neck pilot 120.2, control 91.5, final model 89.0; PA-PVE 72.0, 62.9, 68.7, 59.7, 57.6; MPJPE 126.9, 94.8, 124.8, 90.9, 88.3. v9 trained on the old labels with the reversed gender; like every model it is tested on the corrected ones. The old numbers, v9 102.5 and v5 119.1, are retired: only numbers on the corrected labels are compared now.</a:t>
+            </a:r>
+          </a:p>
+          <a:p>
+            <a:r>
+              <a:rPr lang="en-US" dirty="0"/>
+              <a:t>- Detection on 3DPW: the final model finds 99 percent of the labelled people, v9 94, v5 and the neck pilot 100. Precision is 64 percent for the final model, 73 for v9 and 54 for v5; 3DPW labels only the one or two actors, not the people walking past, so a low precision partly counts real bystanders, and I do not read much into it.</a:t>
             </a:r>
           </a:p>
           <a:p>
@@ -1253,7 +1261,7 @@
           <a:p>
             <a:r>
               <a:rPr lang="en-US" dirty="0"/>
-              <a:t>- Children and gender: unchanged by design. The shape mask was off and training has no child signal, so the Relative Human result on slide 10 stands.</a:t>
+              <a:t>- Children: unchanged; training has no child signal, so the Relative Human result on slide 10 stands. Gender is different: the shape mask was off, so the corrected 3DPW gender labels train the shape head, and on real photos most men now look male, judged by eye (next slide). The Relative Human number for the final model is not run yet.</a:t>
             </a:r>
           </a:p>
           <a:p>
@@ -1346,7 +1354,7 @@
           <a:p>
             <a:r>
               <a:rPr lang="en-US" dirty="0"/>
-              <a:t>Seven things are still open. First, the bone flips. The fix now holds in the 10-epoch final model, with real photos in training: neck02 4.8 degrees and fingers 8.3 (slide 16). The holdout renders of the correction alone show normal necks, and so, by eye, do the 8 real images I have seen so far from a first demo of the 2-epoch model; real images have no neck metric. v10's left arm has the same kind of flip, but a bone further down the arm undoes it, so it needs a two-sided correction, not built yet. Second, the depth slope: 0.42 in the final model, about as good as the best pilots but far from 1; cause unknown. Third, the cost of the depth fix: now measured in the final model against its control, PVE within the noise and recall 2 points lower; a comparison paired on the same people is still to do. Fourth, pilot noise: fix the seed or repeat key runs. Fifth, people very close to the camera. Sixth, children and fingers: children are now measured on real photos with age labels, the Relative Human dataset: the model reads them as short adults, and age separates them from adults with an AUC of only 0.61 (slide 10); the decision is a limitation or weak age labels. For fingers, a look at the hands with the bone fix. Seventh, 3DPW: the labels had three defects. The missing labels came back on 16 October, when I re-extracted the images of eight sequences; train went from 4,451 to 6,437 label images. The re-fit with the gender and frame-grid fixes finished on 18 October, and the check on the new labels passes with a warning, with no defect left (slide 6). They are in use: the final model and its control trained on them on 18 October, after a short smoke test of the whole recipe passed (slide 16).</a:t>
+              <a:t>This is the final model on real photos, next to v5, judged by eye. These are three of the twelve demo images: a photo from our example set and two 3DPW test frames that no model trained on; v5 on the left, the final model on the right. The clearest change is the body shape of the men. v5 gave them breasts and wide hips; the final model gives most of them a flat chest and broader shoulders: three of the four men on the tennis photo, both men in the walking frame, the man on the phone, the guitar player and the seated man in the WhatsApp photo. Women stay female, and the bodies look a little larger, which fits the size ratio going from 0.63 to 0.78 on the synthetic holdout. What did not change: the boy in the garden photo still gets an adult body, some bodies still sit off their person, half-visible people still get ghost bodies, and hard poses like the guitar player or the seated man are poor in both models. All of this is by eye: the gender number on Relative Human for the final model is not run yet; for v5 it was 46.5 percent, which is chance.</a:t>
             </a:r>
           </a:p>
           <a:p>
@@ -1355,7 +1363,37 @@
           <a:p>
             <a:r>
               <a:rPr lang="en-US" dirty="0"/>
-              <a:t>If asked: Neck: the fine-tuned checkpoint carries the fix in its saved settings, so the demo applies it on load; the demo comparison, job 3581312, ran it next to v5 on 4 example photos and 8 3DPW test frames (slide 8); I have looked at 8 of these 12 images so far. In the 12 side-by-side holdout panels, with the correction alone and no training, the necks have normal width wherever a neck is visible (slide 8). v10: correcting three of its flipped hand bones passed without training; two more finger bones, seen on training images, are not corrected yet; shoulder01.L at 166 degrees and upperarm02.L at 180 stay flipped, because one constant per bone would break the chain that compensates them. Depth: the training depths so far come from small samples, batch means of about 2.5 to 3.2 metres. I will also measure the fix run's slope on training images; for v5 it was just as low there. Cost: I will report the root error next to PVE in the thesis. On the 3DPW test split, with the new labels, the final model beats its control, 89.0 against 91.5 millimetres PVE; v5 and v9 on the same labels are still pending. The twenty-times 10-epoch run has no result yet. Close people: v5 and the depth-fix model both miss them in 4 of the 12 rendered holdout images (slide 12). Children and fingers: one 2-epoch test is not enough to close them; for children it is inconclusive, not a proof that more synthetic children cannot help, and a 10-epoch sampler run stays a low-priority option. 3DPW labels: the rebuild, into a new folder, gave the same counts, so my old guess that the builder ran before the fits finished is wrong. The builder skips every frame without an image file. So I re-extracted the image folders of the eight affected sequences on 16 October: captureSelfies_00 had 480 of 750 files; for the other seven the counts before were not recorded. The second rebuild, job 3581320, confirmed it: train rose from 4,451 to 6,437 label images and validation from 2,458 to 2,777, exactly what the fits imply; test stayed at 9,722. Those labels still had the reversed gender and the missing second person. Gender and the frame grid are different: men to 0 and, by Anny's convention, women to 1, and both people's frames on one shared grid. Both happen inside the fit, so all 87 conversion tasks were fitted again, into a new folder, because the task script skips every person that already has a file; the task script now refuses to mix old and new fits. That was an 87-task array job: about 28 GPU hours at the measured 4.4 seconds per frame (the 17 October test, on an H100), done on 18 October. The rebuilt labels have 16,694 images with 22,749 people, and the check on them confirms both fixes: flipping the gender now makes the fit worse, and no two-person image misses a person.</a:t>
+              <a:t>If asked:</a:t>
+            </a:r>
+          </a:p>
+          <a:p>
+            <a:r>
+              <a:rPr lang="en-US" dirty="0"/>
+              <a:t>- Source: demo job 3612078, the same demo script as slide 8, v5 epoch 99 next to the final model, on 4 example photos and 8 3DPW test frames, 12 images in all. The final model carries the bone fix in its saved settings, and the log shows it applied on load.</a:t>
+            </a:r>
+          </a:p>
+          <a:p>
+            <a:r>
+              <a:rPr lang="en-US" dirty="0"/>
+              <a:t>- Why gender changed: the shape mask was off, so the corrected 3DPW gender labels train the shape head; v5 never saw 3DPW. That is my reading; I have not tested it.</a:t>
+            </a:r>
+          </a:p>
+          <a:p>
+            <a:r>
+              <a:rPr lang="en-US" dirty="0"/>
+              <a:t>- The log's predicted gender, over all 12 images: v5 0.32 to 0.76, median 0.59, close to the training median; the final model 0.05 to 0.99, median 0.90. So the shape head now gives clear values instead of the middle. The log does not settle the direction: zero is male in Anny, the man on the phone gets 0.05 to 0.16, but on the tennis photo, where the men look male, most values are above 0.7, and the log does not say which value belongs to which body. Other shape values moved too and likely add to the male look: muscle, median 0.28 to 0.48, and proportions, 0.81 to 0.57. Age: v5 0.50 to 0.77, the final model 0.42 to 0.65.</a:t>
+            </a:r>
+          </a:p>
+          <a:p>
+            <a:r>
+              <a:rPr lang="en-US" dirty="0"/>
+              <a:t>- The Relative Human run is one job with the final model's checkpoint, the same evaluation as slide 10; it gives gender accuracy, the children's age and recall. Until it has run, gender is by eye only.</a:t>
+            </a:r>
+          </a:p>
+          <a:p>
+            <a:r>
+              <a:rPr lang="en-US" dirty="0"/>
+              <a:t>- Ghost bodies: in the walking frame the final model draws a green body on a person cut off at the image edge; in the stage photo both models draw a yellow one. Placement offsets: the bar and fencing frames, in both models.</a:t>
             </a:r>
           </a:p>
         </p:txBody>
@@ -1442,7 +1480,7 @@
           <a:p>
             <a:r>
               <a:rPr lang="en-US" dirty="0"/>
-              <a:t>What I claim, measured. The failures are not rig or decoding problems. A training-target bug puts people too far away in v5, v9 and v10; the fix draws bodies much closer to their true size. In the v5 line, neck02 and the head bone sit half a turn off, and two flipped hand bones were about half the finger error; a fixed correction turns them back. The 3DPW labels had three defects; a re-fit fixed them, and the new labels pass the check with a warning (slide 6). And the final model, with all fixes together, keeps every fix against its own control: the root error is 48 percent lower, neck02 is 4.8 degrees, the fingers 8.3, PA-PVE 50.3 against 56.4 millimetres, and on the 3DPW test the PVE is 89.0 against 91.5 (slide 16). What I do not claim: results proven over several seeds, since each arm ran once; why the bones flipped; better children; correct depth for near and far people, since the slope is still 0.42; fixes without a cost, since recall is 2 points below the control and 3 below v5; and a 3DPW gain over v5 or v9, because those are not yet evaluated on the new labels. On last week's question, v9 now or the labels first: I went ahead with the labels first, then fine-tuned v5; that is the final model. My question now: do I write up, or also add weak age labels for children, which is one to two weeks of work?</a:t>
+              <a:t>Seven things are still open. First, the bone flips. The fix now holds in the 10-epoch final model, with real photos in training: neck02 4.8 degrees and fingers 8.3 (slide 16). The holdout renders of the correction alone show normal necks, and so, by eye, do the 8 real images I have seen so far from a first demo of the 2-epoch model; real images have no neck metric. v10's left arm has the same kind of flip, but a bone further down the arm undoes it, so it needs a two-sided correction, not built yet. Second, the depth slope: 0.42 in the final model, about as good as the best pilots but far from 1; cause unknown. Third, the cost of the depth fix: now measured in the final model against its control, PVE within the noise and recall 2 points lower; a comparison paired on the same people is still to do. Fourth, pilot noise: fix the seed or repeat key runs. Fifth, people very close to the camera. Sixth, children and fingers: children are now measured on real photos with age labels, the Relative Human dataset: the model reads them as short adults, and age separates them from adults with an AUC of only 0.61 (slide 10); the decision is a limitation or weak age labels. For fingers, a look at the hands with the bone fix. Seventh, 3DPW: the labels had three defects. The missing labels came back on 16 October, when I re-extracted the images of eight sequences; train went from 4,451 to 6,437 label images. The re-fit with the gender and frame-grid fixes finished on 18 October, and the check on the new labels passes with a warning, with no defect left (slide 6). They are in use: the final model and its control trained on them on 18 October, after a short smoke test of the whole recipe passed (slide 16).</a:t>
             </a:r>
           </a:p>
           <a:p>
@@ -1451,61 +1489,7 @@
           <a:p>
             <a:r>
               <a:rPr lang="en-US" dirty="0"/>
-              <a:t>If asked:</a:t>
-            </a:r>
-          </a:p>
-          <a:p>
-            <a:r>
-              <a:rPr lang="en-US" dirty="0"/>
-              <a:t>- Depth fix: it does not separate near and far people well; the slope is 0.42 in the final model, against 0.28 for its control and 0.33 for v5. Its cost is now measured in the final model against its control: PVE 3.7 millimetres better, inside the noise, and recall 2 points lower, at the noise limit; against v5, recall is 3.2 points lower, and I state that as a real cost. In the pilots, every fix run was worse than its control, by 2.6 to 4.9 millimetres PVE and 1.6 to 2.4 recall points. In v5 the depth bug affects all 222 holdout people. The ViT-S students use the same training code and are probably affected too; not measured.</a:t>
-            </a:r>
-          </a:p>
-          <a:p>
-            <a:r>
-              <a:rPr lang="en-US" dirty="0"/>
-              <a:t>- Neck: the two half-turned bones cancel, so the head points the right way. A 2-epoch geodesic loss did not undo it. The fixed correction with a 2-epoch fine-tune did, in one run: neck02 4.7 degrees, thickness 1.00, head direction 14.4 against 13.8 for its control and 12.0 before. In the 10-epoch final model it holds: neck02 4.8 degrees, thickness 1.00, head direction 13.1 against 13.0 for its control, so the 14.4 did not repeat. One run per arm without a seed is not proof; the holdout renders of the correction without training show normal neck width, and in a first real-image demo the 2-epoch model's necks look normal in the 8 of its 12 images I have seen, judged by eye only; there is no neck metric on real images. The origin of the flip is not known; the singular start value of the rotation output would start a bone turned about its sideways axis, a tilt like the one in v5's left index base, not the twist in neck02 and the head.</a:t>
-            </a:r>
-          </a:p>
-          <a:p>
-            <a:r>
-              <a:rPr lang="en-US" dirty="0"/>
-              <a:t>- Fingers: two flipped hand bones were about half the finger number, 17.3 to 8.3 degrees, and the final model keeps 8.3 against 17.4 for its control; I have not looked at the hands, so I do not claim better-looking fingers.</a:t>
-            </a:r>
-          </a:p>
-          <a:p>
-            <a:r>
-              <a:rPr lang="en-US" dirty="0"/>
-              <a:t>- 3DPW labels: 6 train sequences, part of a seventh, and one validation sequence had no labels, because their image files were missing on the cluster. On 16 October I re-extracted them, and a second rebuild, job 3581320, brought the labels back. The re-fit fixed gender and the missing second person on 18 October; the check on the new labels confirms both: flipping the gender now makes the fit worse, and no two-person image misses a person. In the 3DPW labels the head, neck02 and neck03 stay at rest; only neck01 turns. Age is fixed at 0.55. The remaining warnings are the limb proportions and the hip joint, where Anny and SMPL differ.</a:t>
-            </a:r>
-          </a:p>
-          <a:p>
-            <a:r>
-              <a:rPr lang="en-US" dirty="0"/>
-              <a:t>- 3DPW test: the old numbers, v9 102.5 and v5 119.1, are against the old labels and cannot be put next to the final model's 89.0. The re-evaluations of v5, v9 epoch 62 and the 2-epoch neck model on the new labels are submitted.</a:t>
-            </a:r>
-          </a:p>
-          <a:p>
-            <a:r>
-              <a:rPr lang="en-US" dirty="0"/>
-              <a:t>- Option 1, v9 now, which I did not choose: the fine-tune is about 1 to 2 hours of training; that is not measured with 3DPW batches, and the v9 script expects 8 to 10 minutes per epoch. From the v5 pilot I expected a drawn size of about 0.84 and a root error of about half a metre; the v5 final model reached 0.78 and 0.73 metres, at a cost of 2 recall points against its control. Five, not twenty, because the twenty-times 10-epoch run has no result yet. v9 is best on our old 3DPW-Anny labels, but those labels had the gender and two-person defects, so that score is not a clean measure. On the AnnyOne holdout v9 is not the best: 75.0 at epoch 62, the planned start, and 77.0 at epoch 149, against 70.5.</a:t>
-            </a:r>
-          </a:p>
-          <a:p>
-            <a:r>
-              <a:rPr lang="en-US" dirty="0"/>
-              <a:t>- Option 2, labels first, which I chose and did: the re-fit is done. Men to 0, women to 1 by Anny's convention, one shared frame grid, all 87 conversion tasks fitted again into a new folder, about 28 GPU hours at the measured 4.4 seconds per frame, finished on 18 October; the labels are rebuilt, 16,694 images, and the check on them passes with a warning (slide 6). Rebuilding the labels alone would not have been enough, because the gender and the frame choice are fixed inside the fit. The fine-tune after it started from v5 with v5's own bone fix and the depth fix, ran 10 epochs, and had a control run without the two fixes; both trained on 18 October, after a short smoke test of the whole recipe passed; the result is on slide 16. I chose this option because 3DPW is 30 percent of each batch, so a fine-tune on the old labels would keep learning the wrong body for the men.</a:t>
-            </a:r>
-          </a:p>
-          <a:p>
-            <a:r>
-              <a:rPr lang="en-US" dirty="0"/>
-              <a:t>- Bone flips in v9 and v10: a v9 fine-tune keeps the neck flip unless it carries the bone fix, estimated on v9 first; the v5 constants belong to v5. The flip was measured on v9 epoch 149; epoch 62, the planned start, was never measured per bone, so there it is likely, not shown. v10 has no neck flip, but the same kind of flip in the left shoulder and upper arm, which is likely most of why its shoulders and arms are worse; not shown.</a:t>
-            </a:r>
-          </a:p>
-          <a:p>
-            <a:r>
-              <a:rPr lang="en-US" dirty="0"/>
-              <a:t>- Both options: either fine-tune should also mask the 3DPW finger labels, which are set to the rest pose, with mask_3dpw_hands; the final model does. A new flag can also leave out the eight 3DPW shape values that are constants, age 0.55 and seven at 0.5; it is off by default, and the final model has it off (slide 10). With it on, the 3DPW error can change for a reason unrelated to the two fixes.</a:t>
+              <a:t>If asked: Neck: the fine-tuned checkpoint carries the fix in its saved settings, so the demo applies it on load; the demo comparison, job 3581312, ran it next to v5 on 4 example photos and 8 3DPW test frames (slide 8); I have looked at 8 of these 12 images so far. In the 12 side-by-side holdout panels, with the correction alone and no training, the necks have normal width wherever a neck is visible (slide 8). v10: correcting three of its flipped hand bones passed without training; two more finger bones, seen on training images, are not corrected yet; shoulder01.L at 166 degrees and upperarm02.L at 180 stay flipped, because one constant per bone would break the chain that compensates them. Depth: the training depths so far come from small samples, batch means of about 2.5 to 3.2 metres. I will also measure the fix run's slope on training images; for v5 it was just as low there. Cost: I will report the root error next to PVE in the thesis. On the 3DPW test split, with the new labels, the final model beats its control, 89.0 against 91.5 millimetres PVE, and also v9, 95.5, and v5, 121.8, on the same labels; most of that gain comes from the 3DPW training itself (slide 16). The twenty-times 10-epoch run has no result yet. Close people: v5 and the depth-fix model both miss them in 4 of the 12 rendered holdout images (slide 12). Children and fingers: one 2-epoch test is not enough to close them; for children it is inconclusive, not a proof that more synthetic children cannot help, and a 10-epoch sampler run stays a low-priority option. 3DPW labels: the rebuild, into a new folder, gave the same counts, so my old guess that the builder ran before the fits finished is wrong. The builder skips every frame without an image file. So I re-extracted the image folders of the eight affected sequences on 16 October: captureSelfies_00 had 480 of 750 files; for the other seven the counts before were not recorded. The second rebuild, job 3581320, confirmed it: train rose from 4,451 to 6,437 label images and validation from 2,458 to 2,777, exactly what the fits imply; test stayed at 9,722. Those labels still had the reversed gender and the missing second person. Gender and the frame grid are different: men to 0 and, by Anny's convention, women to 1, and both people's frames on one shared grid. Both happen inside the fit, so all 87 conversion tasks were fitted again, into a new folder, because the task script skips every person that already has a file; the task script now refuses to mix old and new fits. That was an 87-task array job: about 28 GPU hours at the measured 4.4 seconds per frame (the 17 October test, on an H100), done on 18 October. The rebuilt labels have 16,694 images with 22,749 people, and the check on them confirms both fixes: flipping the gender now makes the fit worse, and no two-person image misses a person.</a:t>
             </a:r>
           </a:p>
         </p:txBody>
@@ -1592,7 +1576,70 @@
           <a:p>
             <a:r>
               <a:rPr lang="en-US" dirty="0"/>
-              <a:t>A second holdout example, in case there is a question. Before the fix the boy's real head sticks out above a shrunken mesh that floats. After the fix the top of the head is level with the truth; the after mesh is cut off at the bottom of the image, so I cannot measure its full height. Here the fixed mesh is a little larger and wider than the ground truth, so I do not call it an exact fit. The two large people in front have no ground-truth mesh, so they are not counted as misses.</a:t>
+              <a:t>What I claim, measured. The failures are not rig or decoding problems. A training-target bug puts people too far away in v5, v9 and v10; the fix draws bodies much closer to their true size. In the v5 line, neck02 and the head bone sit half a turn off, and two flipped hand bones were about half the finger error; a fixed correction turns them back. The 3DPW labels had three defects; a re-fit fixed them, and the new labels pass the check with a warning (slide 6). And the final model, with all fixes together, keeps every fix against its own control: the root error is 48 percent lower, neck02 is 4.8 degrees, the fingers 8.3, PA-PVE 50.3 against 56.4 millimetres, and on the 3DPW test the PVE is 89.0 against 91.5, against 95.5 for v9, the previous best, and 121.8 for v5 (slide 16). What I do not claim: results proven over several seeds, since each arm ran once; why the bones flipped; better children; correct depth for near and far people, since the slope is still 0.42; fixes without a cost, since recall is 2 points below the control and 3 below v5; that the fixes made most of the 3DPW gain, because training on 3DPW at all did most of it and the fixes add 2.5 millimetres; and a gender number for the final model: on real photos men now look male, but only by eye (slide 17). On last week's question, v9 now or the labels first: I went ahead with the labels first, then fine-tuned v5; that is the final model. My question now: do I write up, or also add weak age labels for children, which is one to two weeks of work?</a:t>
+            </a:r>
+          </a:p>
+          <a:p>
+            <a:endParaRPr lang="en-US" dirty="0"/>
+          </a:p>
+          <a:p>
+            <a:r>
+              <a:rPr lang="en-US" dirty="0"/>
+              <a:t>If asked:</a:t>
+            </a:r>
+          </a:p>
+          <a:p>
+            <a:r>
+              <a:rPr lang="en-US" dirty="0"/>
+              <a:t>- Depth fix: it does not separate near and far people well; the slope is 0.42 in the final model, against 0.28 for its control and 0.33 for v5. Its cost is now measured in the final model against its control: PVE 3.7 millimetres better, inside the noise, and recall 2 points lower, at the noise limit; against v5, recall is 3.2 points lower, and I state that as a real cost. In the pilots, every fix run was worse than its control, by 2.6 to 4.9 millimetres PVE and 1.6 to 2.4 recall points. In v5 the depth bug affects all 222 holdout people. The ViT-S students use the same training code and are probably affected too; not measured.</a:t>
+            </a:r>
+          </a:p>
+          <a:p>
+            <a:r>
+              <a:rPr lang="en-US" dirty="0"/>
+              <a:t>- Neck: the two half-turned bones cancel, so the head points the right way. A 2-epoch geodesic loss did not undo it. The fixed correction with a 2-epoch fine-tune did, in one run: neck02 4.7 degrees, thickness 1.00, head direction 14.4 against 13.8 for its control and 12.0 before. In the 10-epoch final model it holds: neck02 4.8 degrees, thickness 1.00, head direction 13.1 against 13.0 for its control, so the 14.4 did not repeat. One run per arm without a seed is not proof; the holdout renders of the correction without training show normal neck width, and in a first real-image demo the 2-epoch model's necks look normal in the 8 of its 12 images I have seen, judged by eye only; there is no neck metric on real images. The origin of the flip is not known; the singular start value of the rotation output would start a bone turned about its sideways axis, a tilt like the one in v5's left index base, not the twist in neck02 and the head.</a:t>
+            </a:r>
+          </a:p>
+          <a:p>
+            <a:r>
+              <a:rPr lang="en-US" dirty="0"/>
+              <a:t>- Fingers: two flipped hand bones were about half the finger number, 17.3 to 8.3 degrees, and the final model keeps 8.3 against 17.4 for its control; I have not looked at the hands, so I do not claim better-looking fingers.</a:t>
+            </a:r>
+          </a:p>
+          <a:p>
+            <a:r>
+              <a:rPr lang="en-US" dirty="0"/>
+              <a:t>- 3DPW labels: 6 train sequences, part of a seventh, and one validation sequence had no labels, because their image files were missing on the cluster. On 16 October I re-extracted them, and a second rebuild, job 3581320, brought the labels back. The re-fit fixed gender and the missing second person on 18 October; the check on the new labels confirms both: flipping the gender now makes the fit worse, and no two-person image misses a person. In the 3DPW labels the head, neck02 and neck03 stay at rest; only neck01 turns. Age is fixed at 0.55. The remaining warnings are the limb proportions and the hip joint, where Anny and SMPL differ.</a:t>
+            </a:r>
+          </a:p>
+          <a:p>
+            <a:r>
+              <a:rPr lang="en-US" dirty="0"/>
+              <a:t>- 3DPW test, all on the corrected labels: PVE v5 121.8, the 2-epoch neck model 120.2, v9 epoch 62 95.5, control 91.5, final model 89.0; the final model also finds more 3DPW people than v9, 99 percent against 94. The old numbers, v9 102.5 and v5 119.1, measured on the old labels, are retired.</a:t>
+            </a:r>
+          </a:p>
+          <a:p>
+            <a:r>
+              <a:rPr lang="en-US" dirty="0"/>
+              <a:t>- Option 1, v9 now, which I did not choose: the fine-tune is about 1 to 2 hours of training; that is not measured with 3DPW batches, and the v9 script expects 8 to 10 minutes per epoch. From the v5 pilot I expected a drawn size of about 0.84 and a root error of about half a metre; the v5 final model reached 0.78 and 0.73 metres, at a cost of 2 recall points against its control. Five, not twenty, because the twenty-times 10-epoch run has no result yet. v9 is best on our old 3DPW-Anny labels, but those labels had the gender and two-person defects, so that score is not a clean measure; on the corrected labels v9 gets 95.5, behind the final model's 89.0. On the AnnyOne holdout v9 is not the best: 75.0 at epoch 62, the planned start, and 77.0 at epoch 149, against 70.5.</a:t>
+            </a:r>
+          </a:p>
+          <a:p>
+            <a:r>
+              <a:rPr lang="en-US" dirty="0"/>
+              <a:t>- Option 2, labels first, which I chose and did: the re-fit is done. Men to 0, women to 1 by Anny's convention, one shared frame grid, all 87 conversion tasks fitted again into a new folder, about 28 GPU hours at the measured 4.4 seconds per frame, finished on 18 October; the labels are rebuilt, 16,694 images, and the check on them passes with a warning (slide 6). Rebuilding the labels alone would not have been enough, because the gender and the frame choice are fixed inside the fit. The fine-tune after it started from v5 with v5's own bone fix and the depth fix, ran 10 epochs, and had a control run without the two fixes; both trained on 18 October, after a short smoke test of the whole recipe passed; the result is on slide 16. I chose this option because 3DPW is 30 percent of each batch, so a fine-tune on the old labels would keep learning the wrong body for the men.</a:t>
+            </a:r>
+          </a:p>
+          <a:p>
+            <a:r>
+              <a:rPr lang="en-US" dirty="0"/>
+              <a:t>- Bone flips in v9 and v10: a v9 fine-tune keeps the neck flip unless it carries the bone fix, estimated on v9 first; the v5 constants belong to v5. The flip was measured on v9 epoch 149; epoch 62, the planned start, was never measured per bone, so there it is likely, not shown. v10 has no neck flip, but the same kind of flip in the left shoulder and upper arm, which is likely most of why its shoulders and arms are worse; not shown.</a:t>
+            </a:r>
+          </a:p>
+          <a:p>
+            <a:r>
+              <a:rPr lang="en-US" dirty="0"/>
+              <a:t>- Both options: either fine-tune should also mask the 3DPW finger labels, which are set to the rest pose, with mask_3dpw_hands; the final model does. A new flag can also leave out the eight 3DPW shape values that are constants, age 0.55 and seven at 0.5; it is off by default, and the final model has it off (slide 10). With it on, the 3DPW error can change for a reason unrelated to the two fixes.</a:t>
             </a:r>
           </a:p>
         </p:txBody>
@@ -1720,6 +1767,93 @@
 </p:notes>
 </file>
 
+<file path=ppt/notesSlides/notesSlide20.xml><?xml version="1.0" encoding="utf-8"?>
+<p:notes xmlns:a="http://schemas.openxmlformats.org/drawingml/2006/main" xmlns:r="http://schemas.openxmlformats.org/officeDocument/2006/relationships" xmlns:p="http://schemas.openxmlformats.org/presentationml/2006/main">
+  <p:cSld>
+    <p:spTree>
+      <p:nvGrpSpPr>
+        <p:cNvPr id="1" name=""/>
+        <p:cNvGrpSpPr/>
+        <p:nvPr/>
+      </p:nvGrpSpPr>
+      <p:grpSpPr>
+        <a:xfrm>
+          <a:off x="0" y="0"/>
+          <a:ext cx="0" cy="0"/>
+          <a:chOff x="0" y="0"/>
+          <a:chExt cx="0" cy="0"/>
+        </a:xfrm>
+      </p:grpSpPr>
+      <p:sp>
+        <p:nvSpPr>
+          <p:cNvPr id="2" name="Slide Image Placeholder 1"/>
+          <p:cNvSpPr>
+            <a:spLocks noGrp="1" noRot="1" noChangeAspect="1"/>
+          </p:cNvSpPr>
+          <p:nvPr>
+            <p:ph type="sldImg"/>
+          </p:nvPr>
+        </p:nvSpPr>
+        <p:spPr/>
+      </p:sp>
+      <p:sp>
+        <p:nvSpPr>
+          <p:cNvPr id="3" name="Notes Placeholder 2"/>
+          <p:cNvSpPr>
+            <a:spLocks noGrp="1"/>
+          </p:cNvSpPr>
+          <p:nvPr>
+            <p:ph type="body" idx="1"/>
+          </p:nvPr>
+        </p:nvSpPr>
+        <p:spPr/>
+        <p:txBody>
+          <a:bodyPr/>
+          <a:lstStyle/>
+          <a:p>
+            <a:r>
+              <a:rPr lang="en-US" dirty="0"/>
+              <a:t>A second holdout example, in case there is a question. Before the fix the boy's real head sticks out above a shrunken mesh that floats. After the fix the top of the head is level with the truth; the after mesh is cut off at the bottom of the image, so I cannot measure its full height. Here the fixed mesh is a little larger and wider than the ground truth, so I do not call it an exact fit. The two large people in front have no ground-truth mesh, so they are not counted as misses.</a:t>
+            </a:r>
+          </a:p>
+        </p:txBody>
+      </p:sp>
+      <p:sp>
+        <p:nvSpPr>
+          <p:cNvPr id="4" name="Slide Number Placeholder 3"/>
+          <p:cNvSpPr>
+            <a:spLocks noGrp="1"/>
+          </p:cNvSpPr>
+          <p:nvPr>
+            <p:ph type="sldNum" sz="quarter" idx="10"/>
+          </p:nvPr>
+        </p:nvSpPr>
+        <p:spPr/>
+        <p:txBody>
+          <a:bodyPr/>
+          <a:lstStyle/>
+          <a:p>
+            <a:fld id="{F7021451-1387-4CA6-816F-3879F97B5CBC}" type="slidenum">
+              <a:rPr lang="en-US"/>
+              <a:t>20</a:t>
+            </a:fld>
+            <a:endParaRPr lang="en-US"/>
+          </a:p>
+        </p:txBody>
+      </p:sp>
+    </p:spTree>
+    <p:extLst>
+      <p:ext uri="{BB962C8B-B14F-4D97-AF65-F5344CB8AC3E}">
+        <p14:creationId xmlns:p14="http://schemas.microsoft.com/office/powerpoint/2010/main" val="1024086991"/>
+      </p:ext>
+    </p:extLst>
+  </p:cSld>
+  <p:clrMapOvr>
+    <a:masterClrMapping/>
+  </p:clrMapOvr>
+</p:notes>
+</file>
+
 <file path=ppt/notesSlides/notesSlide3.xml><?xml version="1.0" encoding="utf-8"?>
 <p:notes xmlns:a="http://schemas.openxmlformats.org/drawingml/2006/main" xmlns:r="http://schemas.openxmlformats.org/officeDocument/2006/relationships" xmlns:p="http://schemas.openxmlformats.org/presentationml/2006/main">
   <p:cSld>
@@ -2294,7 +2428,7 @@
           <a:p>
             <a:r>
               <a:rPr lang="en-US" dirty="0"/>
-              <a:t>- Men: in both models, adult men on real photos get female-looking bodies, with breasts and narrow shoulders, for example the male tennis players. v5 never saw 3DPW, so this is not the gender defect in our 3DPW labels. The demo log shows predicted gender near the training median, about 0.6, while Anny's male end is 0: the same pull to the median as for age (slide 10). On Relative Human, measured on 932 real people, men get 0.535 on average and women 0.551: no gender signal. Whether the gap between synthetic and real images or the loss causes it is not settled.</a:t>
+              <a:t>- Men: in both models, adult men on real photos get female-looking bodies, with breasts and narrow shoulders, for example the male tennis players. v5 never saw 3DPW, so this is not the gender defect in our 3DPW labels. The demo log shows predicted gender near the training median, about 0.6, while Anny's male end is 0: the same pull to the median as for age (slide 10). On Relative Human, measured on 932 real people, men get 0.535 on average and women 0.551: no gender signal. Whether the gap between synthetic and real images or the loss causes it is not settled. The final model, trained with the corrected 3DPW gender labels, gives most men male bodies, judged by eye (slide 17).</a:t>
             </a:r>
           </a:p>
           <a:p>
@@ -12244,7 +12378,7 @@
                   </a:tcPr>
                 </a:tc>
               </a:tr>
-              <a:tr h="265176">
+              <a:tr h="237744">
                 <a:tc>
                   <a:txBody>
                     <a:bodyPr/>
@@ -12490,7 +12624,7 @@
                   </a:tcPr>
                 </a:tc>
               </a:tr>
-              <a:tr h="265176">
+              <a:tr h="237744">
                 <a:tc>
                   <a:txBody>
                     <a:bodyPr/>
@@ -12736,7 +12870,7 @@
                   </a:tcPr>
                 </a:tc>
               </a:tr>
-              <a:tr h="265176">
+              <a:tr h="237744">
                 <a:tc>
                   <a:txBody>
                     <a:bodyPr/>
@@ -12982,7 +13116,7 @@
                   </a:tcPr>
                 </a:tc>
               </a:tr>
-              <a:tr h="265176">
+              <a:tr h="237744">
                 <a:tc>
                   <a:txBody>
                     <a:bodyPr/>
@@ -13228,7 +13362,7 @@
                   </a:tcPr>
                 </a:tc>
               </a:tr>
-              <a:tr h="265176">
+              <a:tr h="237744">
                 <a:tc>
                   <a:txBody>
                     <a:bodyPr/>
@@ -13474,7 +13608,7 @@
                   </a:tcPr>
                 </a:tc>
               </a:tr>
-              <a:tr h="265176">
+              <a:tr h="237744">
                 <a:tc>
                   <a:txBody>
                     <a:bodyPr/>
@@ -13720,7 +13854,7 @@
                   </a:tcPr>
                 </a:tc>
               </a:tr>
-              <a:tr h="265176">
+              <a:tr h="237744">
                 <a:tc>
                   <a:txBody>
                     <a:bodyPr/>
@@ -13966,7 +14100,7 @@
                   </a:tcPr>
                 </a:tc>
               </a:tr>
-              <a:tr h="265176">
+              <a:tr h="237744">
                 <a:tc>
                   <a:txBody>
                     <a:bodyPr/>
@@ -14212,7 +14346,7 @@
                   </a:tcPr>
                 </a:tc>
               </a:tr>
-              <a:tr h="265176">
+              <a:tr h="237744">
                 <a:tc>
                   <a:txBody>
                     <a:bodyPr/>
@@ -14283,12 +14417,12 @@
                         <a:buNone/>
                       </a:pPr>
                       <a:r>
-                        <a:rPr lang="en-US" sz="1200" i="1" dirty="0">
+                        <a:rPr lang="en-US" sz="1200" dirty="0">
                           <a:solidFill>
-                            <a:srgbClr val="7B8794"/>
+                            <a:srgbClr val="1B2233"/>
                           </a:solidFill>
                         </a:rPr>
-                        <a:t>pending</a:t>
+                        <a:t>121.8</a:t>
                       </a:r>
                       <a:endParaRPr lang="en-US" sz="1200" dirty="0"/>
                     </a:p>
@@ -14538,14 +14672,14 @@
       </p:sp>
       <p:sp>
         <p:nvSpPr>
-          <p:cNvPr id="5" name="final recipe"/>
+          <p:cNvPr id="5" name="final 3dpw line"/>
           <p:cNvSpPr txBox="1"/>
           <p:nvPr/>
         </p:nvSpPr>
         <p:spPr>
           <a:xfrm>
-            <a:off x="457200" y="3950208"/>
-            <a:ext cx="8229600" cy="384048"/>
+            <a:off x="457200" y="3685032"/>
+            <a:ext cx="8229600" cy="365760"/>
           </a:xfrm>
           <a:prstGeom prst="rect">
             <a:avLst/>
@@ -14561,12 +14695,20 @@
               <a:buNone/>
             </a:pPr>
             <a:r>
+              <a:rPr lang="en-US" sz="1100" b="1" dirty="0">
+                <a:solidFill>
+                  <a:srgbClr val="1B2233"/>
+                </a:solidFill>
+              </a:rPr>
+              <a:t>3DPW test, corrected labels, 8,190 images: </a:t>
+            </a:r>
+            <a:r>
               <a:rPr lang="en-US" sz="1100" dirty="0">
                 <a:solidFill>
                   <a:schemeClr val="tx1"/>
                 </a:solidFill>
               </a:rPr>
-              <a:t>10 epochs, 40,000 images, 70% AnnyOne + 30% 3DPW-train (corrected labels); same recipe for both arms; one run each, no seed (noise ~7.6 mm PVE, ~2 recall points).</a:t>
+              <a:t>v5 121.8 · v9 (old best) 95.5 · neck pilot 120.2 · control 91.5 · final 89.0 mm; final model finds 99% of people, v9 94%.</a:t>
             </a:r>
             <a:endParaRPr lang="en-US" sz="1100" dirty="0"/>
           </a:p>
@@ -14574,14 +14716,14 @@
       </p:sp>
       <p:sp>
         <p:nvSpPr>
-          <p:cNvPr id="6" name="final source"/>
+          <p:cNvPr id="6" name="final recipe"/>
           <p:cNvSpPr txBox="1"/>
           <p:nvPr/>
         </p:nvSpPr>
         <p:spPr>
           <a:xfrm>
-            <a:off x="457200" y="4443984"/>
-            <a:ext cx="8229600" cy="237744"/>
+            <a:off x="457200" y="4078224"/>
+            <a:ext cx="8229600" cy="365760"/>
           </a:xfrm>
           <a:prstGeom prst="rect">
             <a:avLst/>
@@ -14597,6 +14739,42 @@
               <a:buNone/>
             </a:pPr>
             <a:r>
+              <a:rPr lang="en-US" sz="1100" dirty="0">
+                <a:solidFill>
+                  <a:schemeClr val="tx1"/>
+                </a:solidFill>
+              </a:rPr>
+              <a:t>10 epochs, 40,000 images, 70% AnnyOne + 30% 3DPW-train (corrected labels); same recipe for both arms; one run each, no seed (noise ~7.6 mm PVE, ~2 recall points).</a:t>
+            </a:r>
+            <a:endParaRPr lang="en-US" sz="1100" dirty="0"/>
+          </a:p>
+        </p:txBody>
+      </p:sp>
+      <p:sp>
+        <p:nvSpPr>
+          <p:cNvPr id="7" name="final source"/>
+          <p:cNvSpPr txBox="1"/>
+          <p:nvPr/>
+        </p:nvSpPr>
+        <p:spPr>
+          <a:xfrm>
+            <a:off x="457200" y="4462272"/>
+            <a:ext cx="8229600" cy="219456"/>
+          </a:xfrm>
+          <a:prstGeom prst="rect">
+            <a:avLst/>
+          </a:prstGeom>
+          <a:noFill/>
+          <a:ln/>
+        </p:spPr>
+        <p:txBody>
+          <a:bodyPr wrap="square" lIns="0" tIns="0" rIns="0" bIns="0" rtlCol="0" anchor="t"/>
+          <a:lstStyle/>
+          <a:p>
+            <a:pPr indent="0" marL="0">
+              <a:buNone/>
+            </a:pPr>
+            <a:r>
               <a:rPr lang="en-US" sz="1100" b="1" dirty="0">
                 <a:solidFill>
                   <a:srgbClr val="1B2233"/>
@@ -14610,7 +14788,7 @@
                   <a:schemeClr val="tx2"/>
                 </a:solidFill>
               </a:rPr>
-              <a:t>exp7, jobs 3611336 (final model) and 3611339 (control). Holdout: helper bones masked. 3DPW test: 8,190 images.</a:t>
+              <a:t>exp7, jobs 3611336 (final model) and 3611339 (control); v5, v9, neck pilot: jobs 3612073–75. Holdout: helper bones masked.</a:t>
             </a:r>
             <a:endParaRPr lang="en-US" sz="1100" dirty="0"/>
           </a:p>
@@ -14718,47 +14896,46 @@
                   <a:schemeClr val="tx1"/>
                 </a:solidFill>
               </a:rPr>
-              <a:t>Still open, and what I test next</a:t>
+              <a:t>Final model on real photos: v5 vs final (by eye)</a:t>
             </a:r>
             <a:endParaRPr lang="en-US" sz="2700" dirty="0"/>
           </a:p>
         </p:txBody>
       </p:sp>
-      <p:sp>
-        <p:nvSpPr>
-          <p:cNvPr id="3" name="open 1"/>
-          <p:cNvSpPr/>
+      <p:pic>
+        <p:nvPicPr>
+          <p:cNvPr id="3" name="figure final_model_real_photos.jpg" descr="Real photos, v5 (left) and the final model (right): a tennis photo and two 3DPW test frames; men get male bodies in the final model">    </p:cNvPr>
+          <p:cNvPicPr>
+            <a:picLocks noChangeAspect="1"/>
+          </p:cNvPicPr>
           <p:nvPr/>
-        </p:nvSpPr>
-        <p:spPr>
-          <a:xfrm>
-            <a:off x="457200" y="1188720"/>
-            <a:ext cx="457200" cy="457200"/>
-          </a:xfrm>
-          <a:prstGeom prst="ellipse">
-            <a:avLst/>
-          </a:prstGeom>
-          <a:solidFill>
-            <a:schemeClr val="accent1"/>
-          </a:solidFill>
-          <a:ln w="12700">
-            <a:solidFill>
-              <a:schemeClr val="accent1"/>
-            </a:solidFill>
-            <a:prstDash val="solid"/>
-          </a:ln>
-        </p:spPr>
-      </p:sp>
-      <p:sp>
-        <p:nvSpPr>
-          <p:cNvPr id="4" name="open num 1"/>
+        </p:nvPicPr>
+        <p:blipFill>
+          <a:blip r:embed="rId1"/>
+          <a:stretch>
+            <a:fillRect/>
+          </a:stretch>
+        </p:blipFill>
+        <p:spPr>
+          <a:xfrm>
+            <a:off x="457200" y="1097280"/>
+            <a:ext cx="3594689" cy="3566160"/>
+          </a:xfrm>
+          <a:prstGeom prst="rect">
+            <a:avLst/>
+          </a:prstGeom>
+        </p:spPr>
+      </p:pic>
+      <p:sp>
+        <p:nvSpPr>
+          <p:cNvPr id="4" name="real photos text"/>
           <p:cNvSpPr txBox="1"/>
           <p:nvPr/>
         </p:nvSpPr>
         <p:spPr>
           <a:xfrm>
-            <a:off x="457200" y="1188720"/>
-            <a:ext cx="457200" cy="457200"/>
+            <a:off x="4344497" y="1143000"/>
+            <a:ext cx="4342303" cy="2697480"/>
           </a:xfrm>
           <a:prstGeom prst="rect">
             <a:avLst/>
@@ -14767,34 +14944,150 @@
           <a:ln/>
         </p:spPr>
         <p:txBody>
-          <a:bodyPr wrap="square" lIns="0" tIns="0" rIns="0" bIns="0" rtlCol="0" anchor="ctr"/>
+          <a:bodyPr wrap="square" lIns="0" tIns="0" rIns="0" bIns="0" rtlCol="0" anchor="t"/>
           <a:lstStyle/>
           <a:p>
-            <a:pPr algn="ctr" indent="0" marL="0">
-              <a:buNone/>
+            <a:pPr marL="177800" indent="-177800">
+              <a:spcAft>
+                <a:spcPts val="800"/>
+              </a:spcAft>
+              <a:buSzPct val="100000"/>
+              <a:buChar char="•"/>
             </a:pPr>
             <a:r>
-              <a:rPr lang="en-US" sz="1600" b="1" dirty="0">
-                <a:solidFill>
-                  <a:schemeClr val="bg1"/>
-                </a:solidFill>
-              </a:rPr>
-              <a:t>1</a:t>
-            </a:r>
-            <a:endParaRPr lang="en-US" sz="1600" dirty="0"/>
+              <a:rPr lang="en-US" sz="1400" b="1" dirty="0">
+                <a:solidFill>
+                  <a:schemeClr val="tx1"/>
+                </a:solidFill>
+              </a:rPr>
+              <a:t>Men look male: </a:t>
+            </a:r>
+            <a:r>
+              <a:rPr lang="en-US" sz="1400" dirty="0">
+                <a:solidFill>
+                  <a:schemeClr val="tx1"/>
+                </a:solidFill>
+              </a:rPr>
+              <a:t>tennis (3 of 4 men), walking, office, guitar: flat chest, broader shoulders. v5 gave them breasts.</a:t>
+            </a:r>
+            <a:endParaRPr lang="en-US" sz="1400" dirty="0"/>
+          </a:p>
+          <a:p>
+            <a:pPr marL="177800" indent="-177800">
+              <a:spcAft>
+                <a:spcPts val="800"/>
+              </a:spcAft>
+              <a:buSzPct val="100000"/>
+              <a:buChar char="•"/>
+            </a:pPr>
+            <a:r>
+              <a:rPr lang="en-US" sz="1400" b="1" dirty="0">
+                <a:solidFill>
+                  <a:schemeClr val="tx1"/>
+                </a:solidFill>
+              </a:rPr>
+              <a:t>Women stay female: </a:t>
+            </a:r>
+            <a:r>
+              <a:rPr lang="en-US" sz="1400" dirty="0">
+                <a:solidFill>
+                  <a:schemeClr val="tx1"/>
+                </a:solidFill>
+              </a:rPr>
+              <a:t>stage photo, weekly market.</a:t>
+            </a:r>
+            <a:endParaRPr lang="en-US" sz="1400" dirty="0"/>
+          </a:p>
+          <a:p>
+            <a:pPr marL="177800" indent="-177800">
+              <a:spcAft>
+                <a:spcPts val="800"/>
+              </a:spcAft>
+              <a:buSzPct val="100000"/>
+              <a:buChar char="•"/>
+            </a:pPr>
+            <a:r>
+              <a:rPr lang="en-US" sz="1400" b="1" dirty="0">
+                <a:solidFill>
+                  <a:schemeClr val="tx1"/>
+                </a:solidFill>
+              </a:rPr>
+              <a:t>Bodies a little larger: </a:t>
+            </a:r>
+            <a:r>
+              <a:rPr lang="en-US" sz="1400" dirty="0">
+                <a:solidFill>
+                  <a:schemeClr val="tx1"/>
+                </a:solidFill>
+              </a:rPr>
+              <a:t>size ratio 0.63 → 0.78 on the synthetic holdout (slide 16).</a:t>
+            </a:r>
+            <a:endParaRPr lang="en-US" sz="1400" dirty="0"/>
+          </a:p>
+          <a:p>
+            <a:pPr marL="177800" indent="-177800">
+              <a:spcAft>
+                <a:spcPts val="800"/>
+              </a:spcAft>
+              <a:buSzPct val="100000"/>
+              <a:buChar char="•"/>
+            </a:pPr>
+            <a:r>
+              <a:rPr lang="en-US" sz="1400" b="1" dirty="0">
+                <a:solidFill>
+                  <a:schemeClr val="tx1"/>
+                </a:solidFill>
+              </a:rPr>
+              <a:t>Unchanged: </a:t>
+            </a:r>
+            <a:r>
+              <a:rPr lang="en-US" sz="1400" dirty="0">
+                <a:solidFill>
+                  <a:schemeClr val="tx1"/>
+                </a:solidFill>
+              </a:rPr>
+              <a:t>the boy is still an adult body; placement offsets; ghost bodies on half-visible people; hard poses.</a:t>
+            </a:r>
+            <a:endParaRPr lang="en-US" sz="1400" dirty="0"/>
+          </a:p>
+          <a:p>
+            <a:pPr marL="177800" indent="-177800">
+              <a:spcAft>
+                <a:spcPts val="800"/>
+              </a:spcAft>
+              <a:buSzPct val="100000"/>
+              <a:buChar char="•"/>
+            </a:pPr>
+            <a:r>
+              <a:rPr lang="en-US" sz="1400" b="1" dirty="0">
+                <a:solidFill>
+                  <a:schemeClr val="tx1"/>
+                </a:solidFill>
+              </a:rPr>
+              <a:t>Gender on Relative Human: </a:t>
+            </a:r>
+            <a:r>
+              <a:rPr lang="en-US" sz="1400" dirty="0">
+                <a:solidFill>
+                  <a:schemeClr val="tx1"/>
+                </a:solidFill>
+              </a:rPr>
+              <a:t>pending (v5: 46.5%, chance).</a:t>
+            </a:r>
+            <a:endParaRPr lang="en-US" sz="1400" dirty="0"/>
           </a:p>
         </p:txBody>
       </p:sp>
       <p:sp>
         <p:nvSpPr>
-          <p:cNvPr id="5" name="open head 1"/>
+          <p:cNvPr id="5" name="real photos source"/>
           <p:cNvSpPr txBox="1"/>
           <p:nvPr/>
         </p:nvSpPr>
         <p:spPr>
           <a:xfrm>
-            <a:off x="1097280" y="1143000"/>
-            <a:ext cx="3337560" cy="301752"/>
+            <a:off x="4344497" y="3977640"/>
+            <a:ext cx="4342303" cy="685800"/>
           </a:xfrm>
           <a:prstGeom prst="rect">
             <a:avLst/>
@@ -14803,855 +15096,29 @@
           <a:ln/>
         </p:spPr>
         <p:txBody>
-          <a:bodyPr wrap="square" lIns="0" tIns="0" rIns="0" bIns="0" rtlCol="0" anchor="ctr"/>
+          <a:bodyPr wrap="square" lIns="0" tIns="0" rIns="0" bIns="0" rtlCol="0" anchor="b"/>
           <a:lstStyle/>
           <a:p>
             <a:pPr indent="0" marL="0">
               <a:buNone/>
             </a:pPr>
             <a:r>
-              <a:rPr lang="en-US" sz="1500" b="1" dirty="0">
-                <a:solidFill>
-                  <a:schemeClr val="tx1"/>
-                </a:solidFill>
-              </a:rPr>
-              <a:t>Bone flips: fix confirmed at 10 epochs</a:t>
-            </a:r>
-            <a:endParaRPr lang="en-US" sz="1500" dirty="0"/>
-          </a:p>
-        </p:txBody>
-      </p:sp>
-      <p:sp>
-        <p:nvSpPr>
-          <p:cNvPr id="6" name="open body 1"/>
-          <p:cNvSpPr txBox="1"/>
-          <p:nvPr/>
-        </p:nvSpPr>
-        <p:spPr>
-          <a:xfrm>
-            <a:off x="1097280" y="1472184"/>
-            <a:ext cx="3337560" cy="548640"/>
-          </a:xfrm>
-          <a:prstGeom prst="rect">
-            <a:avLst/>
-          </a:prstGeom>
-          <a:noFill/>
-          <a:ln/>
-        </p:spPr>
-        <p:txBody>
-          <a:bodyPr wrap="square" lIns="0" tIns="0" rIns="0" bIns="0" rtlCol="0" anchor="t"/>
-          <a:lstStyle/>
-          <a:p>
-            <a:pPr indent="0" marL="0">
-              <a:buNone/>
-            </a:pPr>
-            <a:r>
-              <a:rPr lang="en-US" sz="1200" dirty="0">
+              <a:rPr lang="en-US" sz="1100" b="1" dirty="0">
+                <a:solidFill>
+                  <a:srgbClr val="1B2233"/>
+                </a:solidFill>
+              </a:rPr>
+              <a:t>Source: </a:t>
+            </a:r>
+            <a:r>
+              <a:rPr lang="en-US" sz="1100" dirty="0">
                 <a:solidFill>
                   <a:schemeClr val="tx2"/>
                 </a:solidFill>
               </a:rPr>
-              <a:t>Final model, real photos in training: neck02 4.8° (slide 16). Real images by eye only (slide 8). v10's left arm: two-sided fix, not built yet.</a:t>
-            </a:r>
-            <a:endParaRPr lang="en-US" sz="1200" dirty="0"/>
-          </a:p>
-        </p:txBody>
-      </p:sp>
-      <p:sp>
-        <p:nvSpPr>
-          <p:cNvPr id="7" name="open 2"/>
-          <p:cNvSpPr/>
-          <p:nvPr/>
-        </p:nvSpPr>
-        <p:spPr>
-          <a:xfrm>
-            <a:off x="4709160" y="1188720"/>
-            <a:ext cx="457200" cy="457200"/>
-          </a:xfrm>
-          <a:prstGeom prst="ellipse">
-            <a:avLst/>
-          </a:prstGeom>
-          <a:solidFill>
-            <a:schemeClr val="accent1"/>
-          </a:solidFill>
-          <a:ln w="12700">
-            <a:solidFill>
-              <a:schemeClr val="accent1"/>
-            </a:solidFill>
-            <a:prstDash val="solid"/>
-          </a:ln>
-        </p:spPr>
-      </p:sp>
-      <p:sp>
-        <p:nvSpPr>
-          <p:cNvPr id="8" name="open num 2"/>
-          <p:cNvSpPr txBox="1"/>
-          <p:nvPr/>
-        </p:nvSpPr>
-        <p:spPr>
-          <a:xfrm>
-            <a:off x="4709160" y="1188720"/>
-            <a:ext cx="457200" cy="457200"/>
-          </a:xfrm>
-          <a:prstGeom prst="rect">
-            <a:avLst/>
-          </a:prstGeom>
-          <a:noFill/>
-          <a:ln/>
-        </p:spPr>
-        <p:txBody>
-          <a:bodyPr wrap="square" lIns="0" tIns="0" rIns="0" bIns="0" rtlCol="0" anchor="ctr"/>
-          <a:lstStyle/>
-          <a:p>
-            <a:pPr algn="ctr" indent="0" marL="0">
-              <a:buNone/>
-            </a:pPr>
-            <a:r>
-              <a:rPr lang="en-US" sz="1600" b="1" dirty="0">
-                <a:solidFill>
-                  <a:schemeClr val="bg1"/>
-                </a:solidFill>
-              </a:rPr>
-              <a:t>2</a:t>
-            </a:r>
-            <a:endParaRPr lang="en-US" sz="1600" dirty="0"/>
-          </a:p>
-        </p:txBody>
-      </p:sp>
-      <p:sp>
-        <p:nvSpPr>
-          <p:cNvPr id="9" name="open head 2"/>
-          <p:cNvSpPr txBox="1"/>
-          <p:nvPr/>
-        </p:nvSpPr>
-        <p:spPr>
-          <a:xfrm>
-            <a:off x="5349240" y="1143000"/>
-            <a:ext cx="3337560" cy="301752"/>
-          </a:xfrm>
-          <a:prstGeom prst="rect">
-            <a:avLst/>
-          </a:prstGeom>
-          <a:noFill/>
-          <a:ln/>
-        </p:spPr>
-        <p:txBody>
-          <a:bodyPr wrap="square" lIns="0" tIns="0" rIns="0" bIns="0" rtlCol="0" anchor="ctr"/>
-          <a:lstStyle/>
-          <a:p>
-            <a:pPr indent="0" marL="0">
-              <a:buNone/>
-            </a:pPr>
-            <a:r>
-              <a:rPr lang="en-US" sz="1500" b="1" dirty="0">
-                <a:solidFill>
-                  <a:schemeClr val="tx1"/>
-                </a:solidFill>
-              </a:rPr>
-              <a:t>Depth slope: 0.42 in the final model</a:t>
-            </a:r>
-            <a:endParaRPr lang="en-US" sz="1500" dirty="0"/>
-          </a:p>
-        </p:txBody>
-      </p:sp>
-      <p:sp>
-        <p:nvSpPr>
-          <p:cNvPr id="10" name="open body 2"/>
-          <p:cNvSpPr txBox="1"/>
-          <p:nvPr/>
-        </p:nvSpPr>
-        <p:spPr>
-          <a:xfrm>
-            <a:off x="5349240" y="1472184"/>
-            <a:ext cx="3337560" cy="548640"/>
-          </a:xfrm>
-          <a:prstGeom prst="rect">
-            <a:avLst/>
-          </a:prstGeom>
-          <a:noFill/>
-          <a:ln/>
-        </p:spPr>
-        <p:txBody>
-          <a:bodyPr wrap="square" lIns="0" tIns="0" rIns="0" bIns="0" rtlCol="0" anchor="t"/>
-          <a:lstStyle/>
-          <a:p>
-            <a:pPr indent="0" marL="0">
-              <a:buNone/>
-            </a:pPr>
-            <a:r>
-              <a:rPr lang="en-US" sz="1200" dirty="0">
-                <a:solidFill>
-                  <a:schemeClr val="tx2"/>
-                </a:solidFill>
-              </a:rPr>
-              <a:t>Still far from 1; cause unknown. Next: measure training depths properly, and the slope on training images.</a:t>
-            </a:r>
-            <a:endParaRPr lang="en-US" sz="1200" dirty="0"/>
-          </a:p>
-        </p:txBody>
-      </p:sp>
-      <p:sp>
-        <p:nvSpPr>
-          <p:cNvPr id="11" name="open 3"/>
-          <p:cNvSpPr/>
-          <p:nvPr/>
-        </p:nvSpPr>
-        <p:spPr>
-          <a:xfrm>
-            <a:off x="457200" y="2103120"/>
-            <a:ext cx="457200" cy="457200"/>
-          </a:xfrm>
-          <a:prstGeom prst="ellipse">
-            <a:avLst/>
-          </a:prstGeom>
-          <a:solidFill>
-            <a:schemeClr val="accent1"/>
-          </a:solidFill>
-          <a:ln w="12700">
-            <a:solidFill>
-              <a:schemeClr val="accent1"/>
-            </a:solidFill>
-            <a:prstDash val="solid"/>
-          </a:ln>
-        </p:spPr>
-      </p:sp>
-      <p:sp>
-        <p:nvSpPr>
-          <p:cNvPr id="12" name="open num 3"/>
-          <p:cNvSpPr txBox="1"/>
-          <p:nvPr/>
-        </p:nvSpPr>
-        <p:spPr>
-          <a:xfrm>
-            <a:off x="457200" y="2103120"/>
-            <a:ext cx="457200" cy="457200"/>
-          </a:xfrm>
-          <a:prstGeom prst="rect">
-            <a:avLst/>
-          </a:prstGeom>
-          <a:noFill/>
-          <a:ln/>
-        </p:spPr>
-        <p:txBody>
-          <a:bodyPr wrap="square" lIns="0" tIns="0" rIns="0" bIns="0" rtlCol="0" anchor="ctr"/>
-          <a:lstStyle/>
-          <a:p>
-            <a:pPr algn="ctr" indent="0" marL="0">
-              <a:buNone/>
-            </a:pPr>
-            <a:r>
-              <a:rPr lang="en-US" sz="1600" b="1" dirty="0">
-                <a:solidFill>
-                  <a:schemeClr val="bg1"/>
-                </a:solidFill>
-              </a:rPr>
-              <a:t>3</a:t>
-            </a:r>
-            <a:endParaRPr lang="en-US" sz="1600" dirty="0"/>
-          </a:p>
-        </p:txBody>
-      </p:sp>
-      <p:sp>
-        <p:nvSpPr>
-          <p:cNvPr id="13" name="open head 3"/>
-          <p:cNvSpPr txBox="1"/>
-          <p:nvPr/>
-        </p:nvSpPr>
-        <p:spPr>
-          <a:xfrm>
-            <a:off x="1097280" y="2057400"/>
-            <a:ext cx="3337560" cy="301752"/>
-          </a:xfrm>
-          <a:prstGeom prst="rect">
-            <a:avLst/>
-          </a:prstGeom>
-          <a:noFill/>
-          <a:ln/>
-        </p:spPr>
-        <p:txBody>
-          <a:bodyPr wrap="square" lIns="0" tIns="0" rIns="0" bIns="0" rtlCol="0" anchor="ctr"/>
-          <a:lstStyle/>
-          <a:p>
-            <a:pPr indent="0" marL="0">
-              <a:buNone/>
-            </a:pPr>
-            <a:r>
-              <a:rPr lang="en-US" sz="1500" b="1" dirty="0">
-                <a:solidFill>
-                  <a:schemeClr val="tx1"/>
-                </a:solidFill>
-              </a:rPr>
-              <a:t>Depth fix cost: now measured</a:t>
-            </a:r>
-            <a:endParaRPr lang="en-US" sz="1500" dirty="0"/>
-          </a:p>
-        </p:txBody>
-      </p:sp>
-      <p:sp>
-        <p:nvSpPr>
-          <p:cNvPr id="14" name="open body 3"/>
-          <p:cNvSpPr txBox="1"/>
-          <p:nvPr/>
-        </p:nvSpPr>
-        <p:spPr>
-          <a:xfrm>
-            <a:off x="1097280" y="2386584"/>
-            <a:ext cx="3337560" cy="548640"/>
-          </a:xfrm>
-          <a:prstGeom prst="rect">
-            <a:avLst/>
-          </a:prstGeom>
-          <a:noFill/>
-          <a:ln/>
-        </p:spPr>
-        <p:txBody>
-          <a:bodyPr wrap="square" lIns="0" tIns="0" rIns="0" bIns="0" rtlCol="0" anchor="t"/>
-          <a:lstStyle/>
-          <a:p>
-            <a:pPr indent="0" marL="0">
-              <a:buNone/>
-            </a:pPr>
-            <a:r>
-              <a:rPr lang="en-US" sz="1200" dirty="0">
-                <a:solidFill>
-                  <a:schemeClr val="tx2"/>
-                </a:solidFill>
-              </a:rPr>
-              <a:t>Final model vs its control: PVE within noise, recall −2 points (−3 vs v5). Paired PVE not done; no ×20 result at 10 epochs.</a:t>
-            </a:r>
-            <a:endParaRPr lang="en-US" sz="1200" dirty="0"/>
-          </a:p>
-        </p:txBody>
-      </p:sp>
-      <p:sp>
-        <p:nvSpPr>
-          <p:cNvPr id="15" name="open 4"/>
-          <p:cNvSpPr/>
-          <p:nvPr/>
-        </p:nvSpPr>
-        <p:spPr>
-          <a:xfrm>
-            <a:off x="4709160" y="2103120"/>
-            <a:ext cx="457200" cy="457200"/>
-          </a:xfrm>
-          <a:prstGeom prst="ellipse">
-            <a:avLst/>
-          </a:prstGeom>
-          <a:solidFill>
-            <a:schemeClr val="accent1"/>
-          </a:solidFill>
-          <a:ln w="12700">
-            <a:solidFill>
-              <a:schemeClr val="accent1"/>
-            </a:solidFill>
-            <a:prstDash val="solid"/>
-          </a:ln>
-        </p:spPr>
-      </p:sp>
-      <p:sp>
-        <p:nvSpPr>
-          <p:cNvPr id="16" name="open num 4"/>
-          <p:cNvSpPr txBox="1"/>
-          <p:nvPr/>
-        </p:nvSpPr>
-        <p:spPr>
-          <a:xfrm>
-            <a:off x="4709160" y="2103120"/>
-            <a:ext cx="457200" cy="457200"/>
-          </a:xfrm>
-          <a:prstGeom prst="rect">
-            <a:avLst/>
-          </a:prstGeom>
-          <a:noFill/>
-          <a:ln/>
-        </p:spPr>
-        <p:txBody>
-          <a:bodyPr wrap="square" lIns="0" tIns="0" rIns="0" bIns="0" rtlCol="0" anchor="ctr"/>
-          <a:lstStyle/>
-          <a:p>
-            <a:pPr algn="ctr" indent="0" marL="0">
-              <a:buNone/>
-            </a:pPr>
-            <a:r>
-              <a:rPr lang="en-US" sz="1600" b="1" dirty="0">
-                <a:solidFill>
-                  <a:schemeClr val="bg1"/>
-                </a:solidFill>
-              </a:rPr>
-              <a:t>4</a:t>
-            </a:r>
-            <a:endParaRPr lang="en-US" sz="1600" dirty="0"/>
-          </a:p>
-        </p:txBody>
-      </p:sp>
-      <p:sp>
-        <p:nvSpPr>
-          <p:cNvPr id="17" name="open head 4"/>
-          <p:cNvSpPr txBox="1"/>
-          <p:nvPr/>
-        </p:nvSpPr>
-        <p:spPr>
-          <a:xfrm>
-            <a:off x="5349240" y="2057400"/>
-            <a:ext cx="3337560" cy="301752"/>
-          </a:xfrm>
-          <a:prstGeom prst="rect">
-            <a:avLst/>
-          </a:prstGeom>
-          <a:noFill/>
-          <a:ln/>
-        </p:spPr>
-        <p:txBody>
-          <a:bodyPr wrap="square" lIns="0" tIns="0" rIns="0" bIns="0" rtlCol="0" anchor="ctr"/>
-          <a:lstStyle/>
-          <a:p>
-            <a:pPr indent="0" marL="0">
-              <a:buNone/>
-            </a:pPr>
-            <a:r>
-              <a:rPr lang="en-US" sz="1500" b="1" dirty="0">
-                <a:solidFill>
-                  <a:schemeClr val="tx1"/>
-                </a:solidFill>
-              </a:rPr>
-              <a:t>Pilot noise</a:t>
-            </a:r>
-            <a:endParaRPr lang="en-US" sz="1500" dirty="0"/>
-          </a:p>
-        </p:txBody>
-      </p:sp>
-      <p:sp>
-        <p:nvSpPr>
-          <p:cNvPr id="18" name="open body 4"/>
-          <p:cNvSpPr txBox="1"/>
-          <p:nvPr/>
-        </p:nvSpPr>
-        <p:spPr>
-          <a:xfrm>
-            <a:off x="5349240" y="2386584"/>
-            <a:ext cx="3337560" cy="548640"/>
-          </a:xfrm>
-          <a:prstGeom prst="rect">
-            <a:avLst/>
-          </a:prstGeom>
-          <a:noFill/>
-          <a:ln/>
-        </p:spPr>
-        <p:txBody>
-          <a:bodyPr wrap="square" lIns="0" tIns="0" rIns="0" bIns="0" rtlCol="0" anchor="t"/>
-          <a:lstStyle/>
-          <a:p>
-            <a:pPr indent="0" marL="0">
-              <a:buNone/>
-            </a:pPr>
-            <a:r>
-              <a:rPr lang="en-US" sz="1200" dirty="0">
-                <a:solidFill>
-                  <a:schemeClr val="tx2"/>
-                </a:solidFill>
-              </a:rPr>
-              <a:t>No fixed seed. Fix it, or repeat the key run, before trusting differences under about 10 mm.</a:t>
-            </a:r>
-            <a:endParaRPr lang="en-US" sz="1200" dirty="0"/>
-          </a:p>
-        </p:txBody>
-      </p:sp>
-      <p:sp>
-        <p:nvSpPr>
-          <p:cNvPr id="19" name="open 5"/>
-          <p:cNvSpPr/>
-          <p:nvPr/>
-        </p:nvSpPr>
-        <p:spPr>
-          <a:xfrm>
-            <a:off x="457200" y="3017520"/>
-            <a:ext cx="457200" cy="457200"/>
-          </a:xfrm>
-          <a:prstGeom prst="ellipse">
-            <a:avLst/>
-          </a:prstGeom>
-          <a:solidFill>
-            <a:schemeClr val="accent1"/>
-          </a:solidFill>
-          <a:ln w="12700">
-            <a:solidFill>
-              <a:schemeClr val="accent1"/>
-            </a:solidFill>
-            <a:prstDash val="solid"/>
-          </a:ln>
-        </p:spPr>
-      </p:sp>
-      <p:sp>
-        <p:nvSpPr>
-          <p:cNvPr id="20" name="open num 5"/>
-          <p:cNvSpPr txBox="1"/>
-          <p:nvPr/>
-        </p:nvSpPr>
-        <p:spPr>
-          <a:xfrm>
-            <a:off x="457200" y="3017520"/>
-            <a:ext cx="457200" cy="457200"/>
-          </a:xfrm>
-          <a:prstGeom prst="rect">
-            <a:avLst/>
-          </a:prstGeom>
-          <a:noFill/>
-          <a:ln/>
-        </p:spPr>
-        <p:txBody>
-          <a:bodyPr wrap="square" lIns="0" tIns="0" rIns="0" bIns="0" rtlCol="0" anchor="ctr"/>
-          <a:lstStyle/>
-          <a:p>
-            <a:pPr algn="ctr" indent="0" marL="0">
-              <a:buNone/>
-            </a:pPr>
-            <a:r>
-              <a:rPr lang="en-US" sz="1600" b="1" dirty="0">
-                <a:solidFill>
-                  <a:schemeClr val="bg1"/>
-                </a:solidFill>
-              </a:rPr>
-              <a:t>5</a:t>
-            </a:r>
-            <a:endParaRPr lang="en-US" sz="1600" dirty="0"/>
-          </a:p>
-        </p:txBody>
-      </p:sp>
-      <p:sp>
-        <p:nvSpPr>
-          <p:cNvPr id="21" name="open head 5"/>
-          <p:cNvSpPr txBox="1"/>
-          <p:nvPr/>
-        </p:nvSpPr>
-        <p:spPr>
-          <a:xfrm>
-            <a:off x="1097280" y="2971800"/>
-            <a:ext cx="3337560" cy="301752"/>
-          </a:xfrm>
-          <a:prstGeom prst="rect">
-            <a:avLst/>
-          </a:prstGeom>
-          <a:noFill/>
-          <a:ln/>
-        </p:spPr>
-        <p:txBody>
-          <a:bodyPr wrap="square" lIns="0" tIns="0" rIns="0" bIns="0" rtlCol="0" anchor="ctr"/>
-          <a:lstStyle/>
-          <a:p>
-            <a:pPr indent="0" marL="0">
-              <a:buNone/>
-            </a:pPr>
-            <a:r>
-              <a:rPr lang="en-US" sz="1500" b="1" dirty="0">
-                <a:solidFill>
-                  <a:schemeClr val="tx1"/>
-                </a:solidFill>
-              </a:rPr>
-              <a:t>People very close to the camera</a:t>
-            </a:r>
-            <a:endParaRPr lang="en-US" sz="1500" dirty="0"/>
-          </a:p>
-        </p:txBody>
-      </p:sp>
-      <p:sp>
-        <p:nvSpPr>
-          <p:cNvPr id="22" name="open body 5"/>
-          <p:cNvSpPr txBox="1"/>
-          <p:nvPr/>
-        </p:nvSpPr>
-        <p:spPr>
-          <a:xfrm>
-            <a:off x="1097280" y="3300984"/>
-            <a:ext cx="3337560" cy="548640"/>
-          </a:xfrm>
-          <a:prstGeom prst="rect">
-            <a:avLst/>
-          </a:prstGeom>
-          <a:noFill/>
-          <a:ln/>
-        </p:spPr>
-        <p:txBody>
-          <a:bodyPr wrap="square" lIns="0" tIns="0" rIns="0" bIns="0" rtlCol="0" anchor="t"/>
-          <a:lstStyle/>
-          <a:p>
-            <a:pPr indent="0" marL="0">
-              <a:buNone/>
-            </a:pPr>
-            <a:r>
-              <a:rPr lang="en-US" sz="1200" dirty="0">
-                <a:solidFill>
-                  <a:schemeClr val="tx2"/>
-                </a:solidFill>
-              </a:rPr>
-              <a:t>Both v5 and the depth fix miss them (4 of 12 holdout renders): not the fix. Likely detection; not counted.</a:t>
-            </a:r>
-            <a:endParaRPr lang="en-US" sz="1200" dirty="0"/>
-          </a:p>
-        </p:txBody>
-      </p:sp>
-      <p:sp>
-        <p:nvSpPr>
-          <p:cNvPr id="23" name="open 6"/>
-          <p:cNvSpPr/>
-          <p:nvPr/>
-        </p:nvSpPr>
-        <p:spPr>
-          <a:xfrm>
-            <a:off x="4709160" y="3017520"/>
-            <a:ext cx="457200" cy="457200"/>
-          </a:xfrm>
-          <a:prstGeom prst="ellipse">
-            <a:avLst/>
-          </a:prstGeom>
-          <a:solidFill>
-            <a:schemeClr val="accent1"/>
-          </a:solidFill>
-          <a:ln w="12700">
-            <a:solidFill>
-              <a:schemeClr val="accent1"/>
-            </a:solidFill>
-            <a:prstDash val="solid"/>
-          </a:ln>
-        </p:spPr>
-      </p:sp>
-      <p:sp>
-        <p:nvSpPr>
-          <p:cNvPr id="24" name="open num 6"/>
-          <p:cNvSpPr txBox="1"/>
-          <p:nvPr/>
-        </p:nvSpPr>
-        <p:spPr>
-          <a:xfrm>
-            <a:off x="4709160" y="3017520"/>
-            <a:ext cx="457200" cy="457200"/>
-          </a:xfrm>
-          <a:prstGeom prst="rect">
-            <a:avLst/>
-          </a:prstGeom>
-          <a:noFill/>
-          <a:ln/>
-        </p:spPr>
-        <p:txBody>
-          <a:bodyPr wrap="square" lIns="0" tIns="0" rIns="0" bIns="0" rtlCol="0" anchor="ctr"/>
-          <a:lstStyle/>
-          <a:p>
-            <a:pPr algn="ctr" indent="0" marL="0">
-              <a:buNone/>
-            </a:pPr>
-            <a:r>
-              <a:rPr lang="en-US" sz="1600" b="1" dirty="0">
-                <a:solidFill>
-                  <a:schemeClr val="bg1"/>
-                </a:solidFill>
-              </a:rPr>
-              <a:t>6</a:t>
-            </a:r>
-            <a:endParaRPr lang="en-US" sz="1600" dirty="0"/>
-          </a:p>
-        </p:txBody>
-      </p:sp>
-      <p:sp>
-        <p:nvSpPr>
-          <p:cNvPr id="25" name="open head 6"/>
-          <p:cNvSpPr txBox="1"/>
-          <p:nvPr/>
-        </p:nvSpPr>
-        <p:spPr>
-          <a:xfrm>
-            <a:off x="5349240" y="2971800"/>
-            <a:ext cx="3337560" cy="301752"/>
-          </a:xfrm>
-          <a:prstGeom prst="rect">
-            <a:avLst/>
-          </a:prstGeom>
-          <a:noFill/>
-          <a:ln/>
-        </p:spPr>
-        <p:txBody>
-          <a:bodyPr wrap="square" lIns="0" tIns="0" rIns="0" bIns="0" rtlCol="0" anchor="ctr"/>
-          <a:lstStyle/>
-          <a:p>
-            <a:pPr indent="0" marL="0">
-              <a:buNone/>
-            </a:pPr>
-            <a:r>
-              <a:rPr lang="en-US" sz="1500" b="1" dirty="0">
-                <a:solidFill>
-                  <a:schemeClr val="tx1"/>
-                </a:solidFill>
-              </a:rPr>
-              <a:t>Children and fingers</a:t>
-            </a:r>
-            <a:endParaRPr lang="en-US" sz="1500" dirty="0"/>
-          </a:p>
-        </p:txBody>
-      </p:sp>
-      <p:sp>
-        <p:nvSpPr>
-          <p:cNvPr id="26" name="open body 6"/>
-          <p:cNvSpPr txBox="1"/>
-          <p:nvPr/>
-        </p:nvSpPr>
-        <p:spPr>
-          <a:xfrm>
-            <a:off x="5349240" y="3300984"/>
-            <a:ext cx="3337560" cy="548640"/>
-          </a:xfrm>
-          <a:prstGeom prst="rect">
-            <a:avLst/>
-          </a:prstGeom>
-          <a:noFill/>
-          <a:ln/>
-        </p:spPr>
-        <p:txBody>
-          <a:bodyPr wrap="square" lIns="0" tIns="0" rIns="0" bIns="0" rtlCol="0" anchor="t"/>
-          <a:lstStyle/>
-          <a:p>
-            <a:pPr indent="0" marL="0">
-              <a:buNone/>
-            </a:pPr>
-            <a:r>
-              <a:rPr lang="en-US" sz="1200" dirty="0">
-                <a:solidFill>
-                  <a:schemeClr val="tx2"/>
-                </a:solidFill>
-              </a:rPr>
-              <a:t>Children: measured on Relative Human (AUC 0.61, read as short adults); decision: limitation or weak labels. Fingers: bone-fix hands, then larger crops.</a:t>
-            </a:r>
-            <a:endParaRPr lang="en-US" sz="1200" dirty="0"/>
-          </a:p>
-        </p:txBody>
-      </p:sp>
-      <p:sp>
-        <p:nvSpPr>
-          <p:cNvPr id="27" name="open 7"/>
-          <p:cNvSpPr/>
-          <p:nvPr/>
-        </p:nvSpPr>
-        <p:spPr>
-          <a:xfrm>
-            <a:off x="457200" y="3931920"/>
-            <a:ext cx="457200" cy="457200"/>
-          </a:xfrm>
-          <a:prstGeom prst="ellipse">
-            <a:avLst/>
-          </a:prstGeom>
-          <a:solidFill>
-            <a:schemeClr val="accent3"/>
-          </a:solidFill>
-          <a:ln w="12700">
-            <a:solidFill>
-              <a:schemeClr val="accent3"/>
-            </a:solidFill>
-            <a:prstDash val="solid"/>
-          </a:ln>
-        </p:spPr>
-      </p:sp>
-      <p:sp>
-        <p:nvSpPr>
-          <p:cNvPr id="28" name="open num 7"/>
-          <p:cNvSpPr txBox="1"/>
-          <p:nvPr/>
-        </p:nvSpPr>
-        <p:spPr>
-          <a:xfrm>
-            <a:off x="457200" y="3931920"/>
-            <a:ext cx="457200" cy="457200"/>
-          </a:xfrm>
-          <a:prstGeom prst="rect">
-            <a:avLst/>
-          </a:prstGeom>
-          <a:noFill/>
-          <a:ln/>
-        </p:spPr>
-        <p:txBody>
-          <a:bodyPr wrap="square" lIns="0" tIns="0" rIns="0" bIns="0" rtlCol="0" anchor="ctr"/>
-          <a:lstStyle/>
-          <a:p>
-            <a:pPr algn="ctr" indent="0" marL="0">
-              <a:buNone/>
-            </a:pPr>
-            <a:r>
-              <a:rPr lang="en-US" sz="1600" b="1" dirty="0">
-                <a:solidFill>
-                  <a:schemeClr val="bg1"/>
-                </a:solidFill>
-              </a:rPr>
-              <a:t>7</a:t>
-            </a:r>
-            <a:endParaRPr lang="en-US" sz="1600" dirty="0"/>
-          </a:p>
-        </p:txBody>
-      </p:sp>
-      <p:sp>
-        <p:nvSpPr>
-          <p:cNvPr id="29" name="open head 7"/>
-          <p:cNvSpPr txBox="1"/>
-          <p:nvPr/>
-        </p:nvSpPr>
-        <p:spPr>
-          <a:xfrm>
-            <a:off x="1097280" y="3886200"/>
-            <a:ext cx="7589520" cy="301752"/>
-          </a:xfrm>
-          <a:prstGeom prst="rect">
-            <a:avLst/>
-          </a:prstGeom>
-          <a:noFill/>
-          <a:ln/>
-        </p:spPr>
-        <p:txBody>
-          <a:bodyPr wrap="square" lIns="0" tIns="0" rIns="0" bIns="0" rtlCol="0" anchor="ctr"/>
-          <a:lstStyle/>
-          <a:p>
-            <a:pPr indent="0" marL="0">
-              <a:buNone/>
-            </a:pPr>
-            <a:r>
-              <a:rPr lang="en-US" sz="1500" b="1" dirty="0">
-                <a:solidFill>
-                  <a:schemeClr val="tx1"/>
-                </a:solidFill>
-              </a:rPr>
-              <a:t>3DPW labels: three defects fixed (slide 6)</a:t>
-            </a:r>
-            <a:endParaRPr lang="en-US" sz="1500" dirty="0"/>
-          </a:p>
-        </p:txBody>
-      </p:sp>
-      <p:sp>
-        <p:nvSpPr>
-          <p:cNvPr id="30" name="open body 7"/>
-          <p:cNvSpPr txBox="1"/>
-          <p:nvPr/>
-        </p:nvSpPr>
-        <p:spPr>
-          <a:xfrm>
-            <a:off x="1097280" y="4215384"/>
-            <a:ext cx="7589520" cy="502920"/>
-          </a:xfrm>
-          <a:prstGeom prst="rect">
-            <a:avLst/>
-          </a:prstGeom>
-          <a:noFill/>
-          <a:ln/>
-        </p:spPr>
-        <p:txBody>
-          <a:bodyPr wrap="square" lIns="0" tIns="0" rIns="0" bIns="0" rtlCol="0" anchor="t"/>
-          <a:lstStyle/>
-          <a:p>
-            <a:pPr indent="0" marL="0">
-              <a:buNone/>
-            </a:pPr>
-            <a:r>
-              <a:rPr lang="en-US" sz="1200" dirty="0">
-                <a:solidFill>
-                  <a:schemeClr val="tx2"/>
-                </a:solidFill>
-              </a:rPr>
-              <a:t>Missing labels fixed 16 Oct (images re-extracted). Re-fit of all 87 tasks (gender m → 0, f → 1; one shared frame grid) and re-check done 18 Oct: WARN (was FAIL), no actor missing. In use: the final model trained on them (slide 16).</a:t>
-            </a:r>
-            <a:endParaRPr lang="en-US" sz="1200" dirty="0"/>
+              <a:t>demo job 3612078, 4 photos + 8 3DPW-test frames, never trained on. Shown: the tennis photo, downtown_walking_00, downtown_runForBus_00. Judged by eye; no metric.</a:t>
+            </a:r>
+            <a:endParaRPr lang="en-US" sz="1100" dirty="0"/>
           </a:p>
         </p:txBody>
       </p:sp>
@@ -15735,8 +15202,8 @@
         </p:nvSpPr>
         <p:spPr>
           <a:xfrm>
-            <a:off x="548640" y="320040"/>
-            <a:ext cx="8046720" cy="731520"/>
+            <a:off x="457200" y="320040"/>
+            <a:ext cx="8229600" cy="731520"/>
           </a:xfrm>
           <a:prstGeom prst="rect">
             <a:avLst/>
@@ -15745,36 +15212,131 @@
           <a:ln/>
         </p:spPr>
         <p:txBody>
-          <a:bodyPr wrap="square" lIns="0" tIns="0" rIns="0" bIns="0" rtlCol="0"/>
+          <a:bodyPr wrap="square" lIns="0" tIns="0" rIns="0" bIns="0" rtlCol="0" anchor="ctr"/>
           <a:lstStyle/>
           <a:p>
             <a:pPr algn="l" indent="0" marL="0">
               <a:buNone/>
             </a:pPr>
             <a:r>
-              <a:rPr lang="en-US" sz="3600" b="1" dirty="0">
+              <a:rPr lang="en-US" sz="2700" b="1" dirty="0">
+                <a:solidFill>
+                  <a:schemeClr val="tx1"/>
+                </a:solidFill>
+              </a:rPr>
+              <a:t>Still open, and what I test next</a:t>
+            </a:r>
+            <a:endParaRPr lang="en-US" sz="2700" dirty="0"/>
+          </a:p>
+        </p:txBody>
+      </p:sp>
+      <p:sp>
+        <p:nvSpPr>
+          <p:cNvPr id="3" name="open 1"/>
+          <p:cNvSpPr/>
+          <p:nvPr/>
+        </p:nvSpPr>
+        <p:spPr>
+          <a:xfrm>
+            <a:off x="457200" y="1188720"/>
+            <a:ext cx="457200" cy="457200"/>
+          </a:xfrm>
+          <a:prstGeom prst="ellipse">
+            <a:avLst/>
+          </a:prstGeom>
+          <a:solidFill>
+            <a:schemeClr val="accent1"/>
+          </a:solidFill>
+          <a:ln w="12700">
+            <a:solidFill>
+              <a:schemeClr val="accent1"/>
+            </a:solidFill>
+            <a:prstDash val="solid"/>
+          </a:ln>
+        </p:spPr>
+      </p:sp>
+      <p:sp>
+        <p:nvSpPr>
+          <p:cNvPr id="4" name="open num 1"/>
+          <p:cNvSpPr txBox="1"/>
+          <p:nvPr/>
+        </p:nvSpPr>
+        <p:spPr>
+          <a:xfrm>
+            <a:off x="457200" y="1188720"/>
+            <a:ext cx="457200" cy="457200"/>
+          </a:xfrm>
+          <a:prstGeom prst="rect">
+            <a:avLst/>
+          </a:prstGeom>
+          <a:noFill/>
+          <a:ln/>
+        </p:spPr>
+        <p:txBody>
+          <a:bodyPr wrap="square" lIns="0" tIns="0" rIns="0" bIns="0" rtlCol="0" anchor="ctr"/>
+          <a:lstStyle/>
+          <a:p>
+            <a:pPr algn="ctr" indent="0" marL="0">
+              <a:buNone/>
+            </a:pPr>
+            <a:r>
+              <a:rPr lang="en-US" sz="1600" b="1" dirty="0">
                 <a:solidFill>
                   <a:schemeClr val="bg1"/>
                 </a:solidFill>
               </a:rPr>
-              <a:t>What I claim today, and what I do not</a:t>
-            </a:r>
-            <a:endParaRPr lang="en-US" sz="3600" dirty="0"/>
+              <a:t>1</a:t>
+            </a:r>
+            <a:endParaRPr lang="en-US" sz="1600" dirty="0"/>
           </a:p>
         </p:txBody>
       </p:sp>
       <p:sp>
         <p:nvSpPr>
-          <p:cNvPr id="3" name="Text 0"/>
-          <p:cNvSpPr/>
-          <p:nvPr>
-            <p:ph idx="101" type="body" hasCustomPrompt="1"/>
-          </p:nvPr>
-        </p:nvSpPr>
-        <p:spPr>
-          <a:xfrm>
-            <a:off x="548640" y="1143000"/>
-            <a:ext cx="8046720" cy="2148840"/>
+          <p:cNvPr id="5" name="open head 1"/>
+          <p:cNvSpPr txBox="1"/>
+          <p:nvPr/>
+        </p:nvSpPr>
+        <p:spPr>
+          <a:xfrm>
+            <a:off x="1097280" y="1143000"/>
+            <a:ext cx="3337560" cy="301752"/>
+          </a:xfrm>
+          <a:prstGeom prst="rect">
+            <a:avLst/>
+          </a:prstGeom>
+          <a:noFill/>
+          <a:ln/>
+        </p:spPr>
+        <p:txBody>
+          <a:bodyPr wrap="square" lIns="0" tIns="0" rIns="0" bIns="0" rtlCol="0" anchor="ctr"/>
+          <a:lstStyle/>
+          <a:p>
+            <a:pPr indent="0" marL="0">
+              <a:buNone/>
+            </a:pPr>
+            <a:r>
+              <a:rPr lang="en-US" sz="1500" b="1" dirty="0">
+                <a:solidFill>
+                  <a:schemeClr val="tx1"/>
+                </a:solidFill>
+              </a:rPr>
+              <a:t>Bone flips: fix confirmed at 10 epochs</a:t>
+            </a:r>
+            <a:endParaRPr lang="en-US" sz="1500" dirty="0"/>
+          </a:p>
+        </p:txBody>
+      </p:sp>
+      <p:sp>
+        <p:nvSpPr>
+          <p:cNvPr id="6" name="open body 1"/>
+          <p:cNvSpPr txBox="1"/>
+          <p:nvPr/>
+        </p:nvSpPr>
+        <p:spPr>
+          <a:xfrm>
+            <a:off x="1097280" y="1472184"/>
+            <a:ext cx="3337560" cy="548640"/>
           </a:xfrm>
           <a:prstGeom prst="rect">
             <a:avLst/>
@@ -15786,71 +15348,41 @@
           <a:bodyPr wrap="square" lIns="0" tIns="0" rIns="0" bIns="0" rtlCol="0" anchor="t"/>
           <a:lstStyle/>
           <a:p>
-            <a:pPr algn="l" indent="0" marL="0">
+            <a:pPr indent="0" marL="0">
               <a:buNone/>
             </a:pPr>
             <a:r>
-              <a:rPr lang="en-US" sz="1500" b="1" dirty="0">
-                <a:solidFill>
-                  <a:srgbClr val="F4C95D"/>
-                </a:solidFill>
-              </a:rPr>
-              <a:t>Claimed, measured: </a:t>
-            </a:r>
-            <a:r>
-              <a:rPr lang="en-US" sz="1500" dirty="0">
-                <a:solidFill>
-                  <a:schemeClr val="bg2"/>
-                </a:solidFill>
-              </a:rPr>
-              <a:t>the failures are not rig or decoding problems. A training-target bug puts people too far away in v5, v9 and v10. In all 8 v5-line checkpoints, neck02 and the head bone sit half a turn off; two flipped hand bones were half the finger error. 3DPW labels: three defects fixed by a re-fit (slide 6). The final model keeps every fix against its own control: root error −48%, neck02 4.8°, fingers 8.3°, PA-PVE 50.3 vs 56.4 mm, 3DPW test PVE 89.0 vs 91.5 mm (slide 16).</a:t>
-            </a:r>
-            <a:endParaRPr lang="en-US" sz="1500" dirty="0"/>
-          </a:p>
-          <a:p>
-            <a:pPr algn="l" indent="0" marL="0">
-              <a:buNone/>
-            </a:pPr>
-            <a:r>
-              <a:rPr lang="en-US" sz="1500" b="1" dirty="0">
-                <a:solidFill>
-                  <a:srgbClr val="F4C95D"/>
-                </a:solidFill>
-              </a:rPr>
-              <a:t>Not claimed: </a:t>
-            </a:r>
-            <a:r>
-              <a:rPr lang="en-US" sz="1500" dirty="0">
-                <a:solidFill>
-                  <a:schemeClr val="bg2"/>
-                </a:solidFill>
-              </a:rPr>
-              <a:t>results proven over seeds (one run each) or why the bones flipped; better children; correct near/far depths (slope 0.42); fixes without cost (recall −2 points vs the control, −3 vs v5); a 3DPW gain over v5 or v9 (not yet on the new labels); head turn, age or limb lengths in the 3DPW labels.</a:t>
-            </a:r>
-            <a:endParaRPr lang="en-US" sz="1500" dirty="0"/>
+              <a:rPr lang="en-US" sz="1200" dirty="0">
+                <a:solidFill>
+                  <a:schemeClr val="tx2"/>
+                </a:solidFill>
+              </a:rPr>
+              <a:t>Final model, real photos in training: neck02 4.8° (slide 16). Real images by eye only (slide 8). v10's left arm: two-sided fix, not built yet.</a:t>
+            </a:r>
+            <a:endParaRPr lang="en-US" sz="1200" dirty="0"/>
           </a:p>
         </p:txBody>
       </p:sp>
       <p:sp>
         <p:nvSpPr>
-          <p:cNvPr id="4" name="question box"/>
+          <p:cNvPr id="7" name="open 2"/>
           <p:cNvSpPr/>
           <p:nvPr/>
         </p:nvSpPr>
         <p:spPr>
           <a:xfrm>
-            <a:off x="548640" y="3310128"/>
-            <a:ext cx="8046720" cy="1371600"/>
-          </a:xfrm>
-          <a:prstGeom prst="rect">
+            <a:off x="4709160" y="1188720"/>
+            <a:ext cx="457200" cy="457200"/>
+          </a:xfrm>
+          <a:prstGeom prst="ellipse">
             <a:avLst/>
           </a:prstGeom>
           <a:solidFill>
-            <a:srgbClr val="2B3550"/>
+            <a:schemeClr val="accent1"/>
           </a:solidFill>
           <a:ln w="12700">
             <a:solidFill>
-              <a:srgbClr val="2B3550"/>
+              <a:schemeClr val="accent1"/>
             </a:solidFill>
             <a:prstDash val="solid"/>
           </a:ln>
@@ -15858,24 +15390,132 @@
       </p:sp>
       <p:sp>
         <p:nvSpPr>
-          <p:cNvPr id="5" name="question bar"/>
+          <p:cNvPr id="8" name="open num 2"/>
+          <p:cNvSpPr txBox="1"/>
+          <p:nvPr/>
+        </p:nvSpPr>
+        <p:spPr>
+          <a:xfrm>
+            <a:off x="4709160" y="1188720"/>
+            <a:ext cx="457200" cy="457200"/>
+          </a:xfrm>
+          <a:prstGeom prst="rect">
+            <a:avLst/>
+          </a:prstGeom>
+          <a:noFill/>
+          <a:ln/>
+        </p:spPr>
+        <p:txBody>
+          <a:bodyPr wrap="square" lIns="0" tIns="0" rIns="0" bIns="0" rtlCol="0" anchor="ctr"/>
+          <a:lstStyle/>
+          <a:p>
+            <a:pPr algn="ctr" indent="0" marL="0">
+              <a:buNone/>
+            </a:pPr>
+            <a:r>
+              <a:rPr lang="en-US" sz="1600" b="1" dirty="0">
+                <a:solidFill>
+                  <a:schemeClr val="bg1"/>
+                </a:solidFill>
+              </a:rPr>
+              <a:t>2</a:t>
+            </a:r>
+            <a:endParaRPr lang="en-US" sz="1600" dirty="0"/>
+          </a:p>
+        </p:txBody>
+      </p:sp>
+      <p:sp>
+        <p:nvSpPr>
+          <p:cNvPr id="9" name="open head 2"/>
+          <p:cNvSpPr txBox="1"/>
+          <p:nvPr/>
+        </p:nvSpPr>
+        <p:spPr>
+          <a:xfrm>
+            <a:off x="5349240" y="1143000"/>
+            <a:ext cx="3337560" cy="301752"/>
+          </a:xfrm>
+          <a:prstGeom prst="rect">
+            <a:avLst/>
+          </a:prstGeom>
+          <a:noFill/>
+          <a:ln/>
+        </p:spPr>
+        <p:txBody>
+          <a:bodyPr wrap="square" lIns="0" tIns="0" rIns="0" bIns="0" rtlCol="0" anchor="ctr"/>
+          <a:lstStyle/>
+          <a:p>
+            <a:pPr indent="0" marL="0">
+              <a:buNone/>
+            </a:pPr>
+            <a:r>
+              <a:rPr lang="en-US" sz="1500" b="1" dirty="0">
+                <a:solidFill>
+                  <a:schemeClr val="tx1"/>
+                </a:solidFill>
+              </a:rPr>
+              <a:t>Depth slope: 0.42 in the final model</a:t>
+            </a:r>
+            <a:endParaRPr lang="en-US" sz="1500" dirty="0"/>
+          </a:p>
+        </p:txBody>
+      </p:sp>
+      <p:sp>
+        <p:nvSpPr>
+          <p:cNvPr id="10" name="open body 2"/>
+          <p:cNvSpPr txBox="1"/>
+          <p:nvPr/>
+        </p:nvSpPr>
+        <p:spPr>
+          <a:xfrm>
+            <a:off x="5349240" y="1472184"/>
+            <a:ext cx="3337560" cy="548640"/>
+          </a:xfrm>
+          <a:prstGeom prst="rect">
+            <a:avLst/>
+          </a:prstGeom>
+          <a:noFill/>
+          <a:ln/>
+        </p:spPr>
+        <p:txBody>
+          <a:bodyPr wrap="square" lIns="0" tIns="0" rIns="0" bIns="0" rtlCol="0" anchor="t"/>
+          <a:lstStyle/>
+          <a:p>
+            <a:pPr indent="0" marL="0">
+              <a:buNone/>
+            </a:pPr>
+            <a:r>
+              <a:rPr lang="en-US" sz="1200" dirty="0">
+                <a:solidFill>
+                  <a:schemeClr val="tx2"/>
+                </a:solidFill>
+              </a:rPr>
+              <a:t>Still far from 1; cause unknown. Next: measure training depths properly, and the slope on training images.</a:t>
+            </a:r>
+            <a:endParaRPr lang="en-US" sz="1200" dirty="0"/>
+          </a:p>
+        </p:txBody>
+      </p:sp>
+      <p:sp>
+        <p:nvSpPr>
+          <p:cNvPr id="11" name="open 3"/>
           <p:cNvSpPr/>
           <p:nvPr/>
         </p:nvSpPr>
         <p:spPr>
           <a:xfrm>
-            <a:off x="548640" y="3310128"/>
-            <a:ext cx="73152" cy="1371600"/>
-          </a:xfrm>
-          <a:prstGeom prst="rect">
+            <a:off x="457200" y="2103120"/>
+            <a:ext cx="457200" cy="457200"/>
+          </a:xfrm>
+          <a:prstGeom prst="ellipse">
             <a:avLst/>
           </a:prstGeom>
           <a:solidFill>
-            <a:srgbClr val="F4C95D"/>
+            <a:schemeClr val="accent1"/>
           </a:solidFill>
           <a:ln w="12700">
             <a:solidFill>
-              <a:srgbClr val="F4C95D"/>
+              <a:schemeClr val="accent1"/>
             </a:solidFill>
             <a:prstDash val="solid"/>
           </a:ln>
@@ -15883,14 +15523,14 @@
       </p:sp>
       <p:sp>
         <p:nvSpPr>
-          <p:cNvPr id="6" name="question text"/>
+          <p:cNvPr id="12" name="open num 3"/>
           <p:cNvSpPr txBox="1"/>
           <p:nvPr/>
         </p:nvSpPr>
         <p:spPr>
           <a:xfrm>
-            <a:off x="822960" y="3355848"/>
-            <a:ext cx="7635240" cy="1280160"/>
+            <a:off x="457200" y="2103120"/>
+            <a:ext cx="457200" cy="457200"/>
           </a:xfrm>
           <a:prstGeom prst="rect">
             <a:avLst/>
@@ -15902,52 +15542,622 @@
           <a:bodyPr wrap="square" lIns="0" tIns="0" rIns="0" bIns="0" rtlCol="0" anchor="ctr"/>
           <a:lstStyle/>
           <a:p>
-            <a:pPr indent="0" marL="0">
-              <a:spcAft>
-                <a:spcPts val="400"/>
-              </a:spcAft>
+            <a:pPr algn="ctr" indent="0" marL="0">
               <a:buNone/>
             </a:pPr>
             <a:r>
-              <a:rPr lang="en-US" sz="1300" b="1" dirty="0">
-                <a:solidFill>
-                  <a:srgbClr val="F4C95D"/>
-                </a:solidFill>
-              </a:rPr>
-              <a:t>Question for you</a:t>
-            </a:r>
-            <a:endParaRPr lang="en-US" sz="1300" dirty="0"/>
-          </a:p>
-          <a:p>
-            <a:pPr indent="0" marL="0">
-              <a:spcAft>
-                <a:spcPts val="400"/>
-              </a:spcAft>
-              <a:buNone/>
-            </a:pPr>
-            <a:r>
-              <a:rPr lang="en-US" sz="1300" b="1" dirty="0">
-                <a:solidFill>
-                  <a:srgbClr val="EEF2F7"/>
-                </a:solidFill>
-              </a:rPr>
-              <a:t>Chosen: fix gender and frame grid, re-fit all 3DPW tasks, then fine-tune v5 (done 18 Oct: slide 16). Next: write up, or also add weak age labels for children (1–2 weeks)?</a:t>
-            </a:r>
-            <a:endParaRPr lang="en-US" sz="1300" dirty="0"/>
-          </a:p>
+              <a:rPr lang="en-US" sz="1600" b="1" dirty="0">
+                <a:solidFill>
+                  <a:schemeClr val="bg1"/>
+                </a:solidFill>
+              </a:rPr>
+              <a:t>3</a:t>
+            </a:r>
+            <a:endParaRPr lang="en-US" sz="1600" dirty="0"/>
+          </a:p>
+        </p:txBody>
+      </p:sp>
+      <p:sp>
+        <p:nvSpPr>
+          <p:cNvPr id="13" name="open head 3"/>
+          <p:cNvSpPr txBox="1"/>
+          <p:nvPr/>
+        </p:nvSpPr>
+        <p:spPr>
+          <a:xfrm>
+            <a:off x="1097280" y="2057400"/>
+            <a:ext cx="3337560" cy="301752"/>
+          </a:xfrm>
+          <a:prstGeom prst="rect">
+            <a:avLst/>
+          </a:prstGeom>
+          <a:noFill/>
+          <a:ln/>
+        </p:spPr>
+        <p:txBody>
+          <a:bodyPr wrap="square" lIns="0" tIns="0" rIns="0" bIns="0" rtlCol="0" anchor="ctr"/>
+          <a:lstStyle/>
           <a:p>
             <a:pPr indent="0" marL="0">
               <a:buNone/>
             </a:pPr>
             <a:r>
-              <a:rPr lang="en-US" sz="1300" dirty="0">
-                <a:solidFill>
-                  <a:srgbClr val="EEF2F7"/>
-                </a:solidFill>
-              </a:rPr>
-              <a:t>v9 also has the neck flip (measured at epoch 149) and needs its own bone fix; v10 has a similar left-arm flip.</a:t>
-            </a:r>
-            <a:endParaRPr lang="en-US" sz="1300" dirty="0"/>
+              <a:rPr lang="en-US" sz="1500" b="1" dirty="0">
+                <a:solidFill>
+                  <a:schemeClr val="tx1"/>
+                </a:solidFill>
+              </a:rPr>
+              <a:t>Depth fix cost: now measured</a:t>
+            </a:r>
+            <a:endParaRPr lang="en-US" sz="1500" dirty="0"/>
+          </a:p>
+        </p:txBody>
+      </p:sp>
+      <p:sp>
+        <p:nvSpPr>
+          <p:cNvPr id="14" name="open body 3"/>
+          <p:cNvSpPr txBox="1"/>
+          <p:nvPr/>
+        </p:nvSpPr>
+        <p:spPr>
+          <a:xfrm>
+            <a:off x="1097280" y="2386584"/>
+            <a:ext cx="3337560" cy="548640"/>
+          </a:xfrm>
+          <a:prstGeom prst="rect">
+            <a:avLst/>
+          </a:prstGeom>
+          <a:noFill/>
+          <a:ln/>
+        </p:spPr>
+        <p:txBody>
+          <a:bodyPr wrap="square" lIns="0" tIns="0" rIns="0" bIns="0" rtlCol="0" anchor="t"/>
+          <a:lstStyle/>
+          <a:p>
+            <a:pPr indent="0" marL="0">
+              <a:buNone/>
+            </a:pPr>
+            <a:r>
+              <a:rPr lang="en-US" sz="1200" dirty="0">
+                <a:solidFill>
+                  <a:schemeClr val="tx2"/>
+                </a:solidFill>
+              </a:rPr>
+              <a:t>Final model vs its control: PVE within noise, recall −2 points (−3 vs v5). Paired PVE not done; no ×20 result at 10 epochs.</a:t>
+            </a:r>
+            <a:endParaRPr lang="en-US" sz="1200" dirty="0"/>
+          </a:p>
+        </p:txBody>
+      </p:sp>
+      <p:sp>
+        <p:nvSpPr>
+          <p:cNvPr id="15" name="open 4"/>
+          <p:cNvSpPr/>
+          <p:nvPr/>
+        </p:nvSpPr>
+        <p:spPr>
+          <a:xfrm>
+            <a:off x="4709160" y="2103120"/>
+            <a:ext cx="457200" cy="457200"/>
+          </a:xfrm>
+          <a:prstGeom prst="ellipse">
+            <a:avLst/>
+          </a:prstGeom>
+          <a:solidFill>
+            <a:schemeClr val="accent1"/>
+          </a:solidFill>
+          <a:ln w="12700">
+            <a:solidFill>
+              <a:schemeClr val="accent1"/>
+            </a:solidFill>
+            <a:prstDash val="solid"/>
+          </a:ln>
+        </p:spPr>
+      </p:sp>
+      <p:sp>
+        <p:nvSpPr>
+          <p:cNvPr id="16" name="open num 4"/>
+          <p:cNvSpPr txBox="1"/>
+          <p:nvPr/>
+        </p:nvSpPr>
+        <p:spPr>
+          <a:xfrm>
+            <a:off x="4709160" y="2103120"/>
+            <a:ext cx="457200" cy="457200"/>
+          </a:xfrm>
+          <a:prstGeom prst="rect">
+            <a:avLst/>
+          </a:prstGeom>
+          <a:noFill/>
+          <a:ln/>
+        </p:spPr>
+        <p:txBody>
+          <a:bodyPr wrap="square" lIns="0" tIns="0" rIns="0" bIns="0" rtlCol="0" anchor="ctr"/>
+          <a:lstStyle/>
+          <a:p>
+            <a:pPr algn="ctr" indent="0" marL="0">
+              <a:buNone/>
+            </a:pPr>
+            <a:r>
+              <a:rPr lang="en-US" sz="1600" b="1" dirty="0">
+                <a:solidFill>
+                  <a:schemeClr val="bg1"/>
+                </a:solidFill>
+              </a:rPr>
+              <a:t>4</a:t>
+            </a:r>
+            <a:endParaRPr lang="en-US" sz="1600" dirty="0"/>
+          </a:p>
+        </p:txBody>
+      </p:sp>
+      <p:sp>
+        <p:nvSpPr>
+          <p:cNvPr id="17" name="open head 4"/>
+          <p:cNvSpPr txBox="1"/>
+          <p:nvPr/>
+        </p:nvSpPr>
+        <p:spPr>
+          <a:xfrm>
+            <a:off x="5349240" y="2057400"/>
+            <a:ext cx="3337560" cy="301752"/>
+          </a:xfrm>
+          <a:prstGeom prst="rect">
+            <a:avLst/>
+          </a:prstGeom>
+          <a:noFill/>
+          <a:ln/>
+        </p:spPr>
+        <p:txBody>
+          <a:bodyPr wrap="square" lIns="0" tIns="0" rIns="0" bIns="0" rtlCol="0" anchor="ctr"/>
+          <a:lstStyle/>
+          <a:p>
+            <a:pPr indent="0" marL="0">
+              <a:buNone/>
+            </a:pPr>
+            <a:r>
+              <a:rPr lang="en-US" sz="1500" b="1" dirty="0">
+                <a:solidFill>
+                  <a:schemeClr val="tx1"/>
+                </a:solidFill>
+              </a:rPr>
+              <a:t>Pilot noise</a:t>
+            </a:r>
+            <a:endParaRPr lang="en-US" sz="1500" dirty="0"/>
+          </a:p>
+        </p:txBody>
+      </p:sp>
+      <p:sp>
+        <p:nvSpPr>
+          <p:cNvPr id="18" name="open body 4"/>
+          <p:cNvSpPr txBox="1"/>
+          <p:nvPr/>
+        </p:nvSpPr>
+        <p:spPr>
+          <a:xfrm>
+            <a:off x="5349240" y="2386584"/>
+            <a:ext cx="3337560" cy="548640"/>
+          </a:xfrm>
+          <a:prstGeom prst="rect">
+            <a:avLst/>
+          </a:prstGeom>
+          <a:noFill/>
+          <a:ln/>
+        </p:spPr>
+        <p:txBody>
+          <a:bodyPr wrap="square" lIns="0" tIns="0" rIns="0" bIns="0" rtlCol="0" anchor="t"/>
+          <a:lstStyle/>
+          <a:p>
+            <a:pPr indent="0" marL="0">
+              <a:buNone/>
+            </a:pPr>
+            <a:r>
+              <a:rPr lang="en-US" sz="1200" dirty="0">
+                <a:solidFill>
+                  <a:schemeClr val="tx2"/>
+                </a:solidFill>
+              </a:rPr>
+              <a:t>No fixed seed. Fix it, or repeat the key run, before trusting differences under about 10 mm.</a:t>
+            </a:r>
+            <a:endParaRPr lang="en-US" sz="1200" dirty="0"/>
+          </a:p>
+        </p:txBody>
+      </p:sp>
+      <p:sp>
+        <p:nvSpPr>
+          <p:cNvPr id="19" name="open 5"/>
+          <p:cNvSpPr/>
+          <p:nvPr/>
+        </p:nvSpPr>
+        <p:spPr>
+          <a:xfrm>
+            <a:off x="457200" y="3017520"/>
+            <a:ext cx="457200" cy="457200"/>
+          </a:xfrm>
+          <a:prstGeom prst="ellipse">
+            <a:avLst/>
+          </a:prstGeom>
+          <a:solidFill>
+            <a:schemeClr val="accent1"/>
+          </a:solidFill>
+          <a:ln w="12700">
+            <a:solidFill>
+              <a:schemeClr val="accent1"/>
+            </a:solidFill>
+            <a:prstDash val="solid"/>
+          </a:ln>
+        </p:spPr>
+      </p:sp>
+      <p:sp>
+        <p:nvSpPr>
+          <p:cNvPr id="20" name="open num 5"/>
+          <p:cNvSpPr txBox="1"/>
+          <p:nvPr/>
+        </p:nvSpPr>
+        <p:spPr>
+          <a:xfrm>
+            <a:off x="457200" y="3017520"/>
+            <a:ext cx="457200" cy="457200"/>
+          </a:xfrm>
+          <a:prstGeom prst="rect">
+            <a:avLst/>
+          </a:prstGeom>
+          <a:noFill/>
+          <a:ln/>
+        </p:spPr>
+        <p:txBody>
+          <a:bodyPr wrap="square" lIns="0" tIns="0" rIns="0" bIns="0" rtlCol="0" anchor="ctr"/>
+          <a:lstStyle/>
+          <a:p>
+            <a:pPr algn="ctr" indent="0" marL="0">
+              <a:buNone/>
+            </a:pPr>
+            <a:r>
+              <a:rPr lang="en-US" sz="1600" b="1" dirty="0">
+                <a:solidFill>
+                  <a:schemeClr val="bg1"/>
+                </a:solidFill>
+              </a:rPr>
+              <a:t>5</a:t>
+            </a:r>
+            <a:endParaRPr lang="en-US" sz="1600" dirty="0"/>
+          </a:p>
+        </p:txBody>
+      </p:sp>
+      <p:sp>
+        <p:nvSpPr>
+          <p:cNvPr id="21" name="open head 5"/>
+          <p:cNvSpPr txBox="1"/>
+          <p:nvPr/>
+        </p:nvSpPr>
+        <p:spPr>
+          <a:xfrm>
+            <a:off x="1097280" y="2971800"/>
+            <a:ext cx="3337560" cy="301752"/>
+          </a:xfrm>
+          <a:prstGeom prst="rect">
+            <a:avLst/>
+          </a:prstGeom>
+          <a:noFill/>
+          <a:ln/>
+        </p:spPr>
+        <p:txBody>
+          <a:bodyPr wrap="square" lIns="0" tIns="0" rIns="0" bIns="0" rtlCol="0" anchor="ctr"/>
+          <a:lstStyle/>
+          <a:p>
+            <a:pPr indent="0" marL="0">
+              <a:buNone/>
+            </a:pPr>
+            <a:r>
+              <a:rPr lang="en-US" sz="1500" b="1" dirty="0">
+                <a:solidFill>
+                  <a:schemeClr val="tx1"/>
+                </a:solidFill>
+              </a:rPr>
+              <a:t>People very close to the camera</a:t>
+            </a:r>
+            <a:endParaRPr lang="en-US" sz="1500" dirty="0"/>
+          </a:p>
+        </p:txBody>
+      </p:sp>
+      <p:sp>
+        <p:nvSpPr>
+          <p:cNvPr id="22" name="open body 5"/>
+          <p:cNvSpPr txBox="1"/>
+          <p:nvPr/>
+        </p:nvSpPr>
+        <p:spPr>
+          <a:xfrm>
+            <a:off x="1097280" y="3300984"/>
+            <a:ext cx="3337560" cy="548640"/>
+          </a:xfrm>
+          <a:prstGeom prst="rect">
+            <a:avLst/>
+          </a:prstGeom>
+          <a:noFill/>
+          <a:ln/>
+        </p:spPr>
+        <p:txBody>
+          <a:bodyPr wrap="square" lIns="0" tIns="0" rIns="0" bIns="0" rtlCol="0" anchor="t"/>
+          <a:lstStyle/>
+          <a:p>
+            <a:pPr indent="0" marL="0">
+              <a:buNone/>
+            </a:pPr>
+            <a:r>
+              <a:rPr lang="en-US" sz="1200" dirty="0">
+                <a:solidFill>
+                  <a:schemeClr val="tx2"/>
+                </a:solidFill>
+              </a:rPr>
+              <a:t>Both v5 and the depth fix miss them (4 of 12 holdout renders): not the fix. Likely detection; not counted.</a:t>
+            </a:r>
+            <a:endParaRPr lang="en-US" sz="1200" dirty="0"/>
+          </a:p>
+        </p:txBody>
+      </p:sp>
+      <p:sp>
+        <p:nvSpPr>
+          <p:cNvPr id="23" name="open 6"/>
+          <p:cNvSpPr/>
+          <p:nvPr/>
+        </p:nvSpPr>
+        <p:spPr>
+          <a:xfrm>
+            <a:off x="4709160" y="3017520"/>
+            <a:ext cx="457200" cy="457200"/>
+          </a:xfrm>
+          <a:prstGeom prst="ellipse">
+            <a:avLst/>
+          </a:prstGeom>
+          <a:solidFill>
+            <a:schemeClr val="accent1"/>
+          </a:solidFill>
+          <a:ln w="12700">
+            <a:solidFill>
+              <a:schemeClr val="accent1"/>
+            </a:solidFill>
+            <a:prstDash val="solid"/>
+          </a:ln>
+        </p:spPr>
+      </p:sp>
+      <p:sp>
+        <p:nvSpPr>
+          <p:cNvPr id="24" name="open num 6"/>
+          <p:cNvSpPr txBox="1"/>
+          <p:nvPr/>
+        </p:nvSpPr>
+        <p:spPr>
+          <a:xfrm>
+            <a:off x="4709160" y="3017520"/>
+            <a:ext cx="457200" cy="457200"/>
+          </a:xfrm>
+          <a:prstGeom prst="rect">
+            <a:avLst/>
+          </a:prstGeom>
+          <a:noFill/>
+          <a:ln/>
+        </p:spPr>
+        <p:txBody>
+          <a:bodyPr wrap="square" lIns="0" tIns="0" rIns="0" bIns="0" rtlCol="0" anchor="ctr"/>
+          <a:lstStyle/>
+          <a:p>
+            <a:pPr algn="ctr" indent="0" marL="0">
+              <a:buNone/>
+            </a:pPr>
+            <a:r>
+              <a:rPr lang="en-US" sz="1600" b="1" dirty="0">
+                <a:solidFill>
+                  <a:schemeClr val="bg1"/>
+                </a:solidFill>
+              </a:rPr>
+              <a:t>6</a:t>
+            </a:r>
+            <a:endParaRPr lang="en-US" sz="1600" dirty="0"/>
+          </a:p>
+        </p:txBody>
+      </p:sp>
+      <p:sp>
+        <p:nvSpPr>
+          <p:cNvPr id="25" name="open head 6"/>
+          <p:cNvSpPr txBox="1"/>
+          <p:nvPr/>
+        </p:nvSpPr>
+        <p:spPr>
+          <a:xfrm>
+            <a:off x="5349240" y="2971800"/>
+            <a:ext cx="3337560" cy="301752"/>
+          </a:xfrm>
+          <a:prstGeom prst="rect">
+            <a:avLst/>
+          </a:prstGeom>
+          <a:noFill/>
+          <a:ln/>
+        </p:spPr>
+        <p:txBody>
+          <a:bodyPr wrap="square" lIns="0" tIns="0" rIns="0" bIns="0" rtlCol="0" anchor="ctr"/>
+          <a:lstStyle/>
+          <a:p>
+            <a:pPr indent="0" marL="0">
+              <a:buNone/>
+            </a:pPr>
+            <a:r>
+              <a:rPr lang="en-US" sz="1500" b="1" dirty="0">
+                <a:solidFill>
+                  <a:schemeClr val="tx1"/>
+                </a:solidFill>
+              </a:rPr>
+              <a:t>Children and fingers</a:t>
+            </a:r>
+            <a:endParaRPr lang="en-US" sz="1500" dirty="0"/>
+          </a:p>
+        </p:txBody>
+      </p:sp>
+      <p:sp>
+        <p:nvSpPr>
+          <p:cNvPr id="26" name="open body 6"/>
+          <p:cNvSpPr txBox="1"/>
+          <p:nvPr/>
+        </p:nvSpPr>
+        <p:spPr>
+          <a:xfrm>
+            <a:off x="5349240" y="3300984"/>
+            <a:ext cx="3337560" cy="548640"/>
+          </a:xfrm>
+          <a:prstGeom prst="rect">
+            <a:avLst/>
+          </a:prstGeom>
+          <a:noFill/>
+          <a:ln/>
+        </p:spPr>
+        <p:txBody>
+          <a:bodyPr wrap="square" lIns="0" tIns="0" rIns="0" bIns="0" rtlCol="0" anchor="t"/>
+          <a:lstStyle/>
+          <a:p>
+            <a:pPr indent="0" marL="0">
+              <a:buNone/>
+            </a:pPr>
+            <a:r>
+              <a:rPr lang="en-US" sz="1200" dirty="0">
+                <a:solidFill>
+                  <a:schemeClr val="tx2"/>
+                </a:solidFill>
+              </a:rPr>
+              <a:t>Children: measured on Relative Human (AUC 0.61, read as short adults); decision: limitation or weak labels. Fingers: bone-fix hands, then larger crops.</a:t>
+            </a:r>
+            <a:endParaRPr lang="en-US" sz="1200" dirty="0"/>
+          </a:p>
+        </p:txBody>
+      </p:sp>
+      <p:sp>
+        <p:nvSpPr>
+          <p:cNvPr id="27" name="open 7"/>
+          <p:cNvSpPr/>
+          <p:nvPr/>
+        </p:nvSpPr>
+        <p:spPr>
+          <a:xfrm>
+            <a:off x="457200" y="3931920"/>
+            <a:ext cx="457200" cy="457200"/>
+          </a:xfrm>
+          <a:prstGeom prst="ellipse">
+            <a:avLst/>
+          </a:prstGeom>
+          <a:solidFill>
+            <a:schemeClr val="accent3"/>
+          </a:solidFill>
+          <a:ln w="12700">
+            <a:solidFill>
+              <a:schemeClr val="accent3"/>
+            </a:solidFill>
+            <a:prstDash val="solid"/>
+          </a:ln>
+        </p:spPr>
+      </p:sp>
+      <p:sp>
+        <p:nvSpPr>
+          <p:cNvPr id="28" name="open num 7"/>
+          <p:cNvSpPr txBox="1"/>
+          <p:nvPr/>
+        </p:nvSpPr>
+        <p:spPr>
+          <a:xfrm>
+            <a:off x="457200" y="3931920"/>
+            <a:ext cx="457200" cy="457200"/>
+          </a:xfrm>
+          <a:prstGeom prst="rect">
+            <a:avLst/>
+          </a:prstGeom>
+          <a:noFill/>
+          <a:ln/>
+        </p:spPr>
+        <p:txBody>
+          <a:bodyPr wrap="square" lIns="0" tIns="0" rIns="0" bIns="0" rtlCol="0" anchor="ctr"/>
+          <a:lstStyle/>
+          <a:p>
+            <a:pPr algn="ctr" indent="0" marL="0">
+              <a:buNone/>
+            </a:pPr>
+            <a:r>
+              <a:rPr lang="en-US" sz="1600" b="1" dirty="0">
+                <a:solidFill>
+                  <a:schemeClr val="bg1"/>
+                </a:solidFill>
+              </a:rPr>
+              <a:t>7</a:t>
+            </a:r>
+            <a:endParaRPr lang="en-US" sz="1600" dirty="0"/>
+          </a:p>
+        </p:txBody>
+      </p:sp>
+      <p:sp>
+        <p:nvSpPr>
+          <p:cNvPr id="29" name="open head 7"/>
+          <p:cNvSpPr txBox="1"/>
+          <p:nvPr/>
+        </p:nvSpPr>
+        <p:spPr>
+          <a:xfrm>
+            <a:off x="1097280" y="3886200"/>
+            <a:ext cx="7589520" cy="301752"/>
+          </a:xfrm>
+          <a:prstGeom prst="rect">
+            <a:avLst/>
+          </a:prstGeom>
+          <a:noFill/>
+          <a:ln/>
+        </p:spPr>
+        <p:txBody>
+          <a:bodyPr wrap="square" lIns="0" tIns="0" rIns="0" bIns="0" rtlCol="0" anchor="ctr"/>
+          <a:lstStyle/>
+          <a:p>
+            <a:pPr indent="0" marL="0">
+              <a:buNone/>
+            </a:pPr>
+            <a:r>
+              <a:rPr lang="en-US" sz="1500" b="1" dirty="0">
+                <a:solidFill>
+                  <a:schemeClr val="tx1"/>
+                </a:solidFill>
+              </a:rPr>
+              <a:t>3DPW labels: three defects fixed (slide 6)</a:t>
+            </a:r>
+            <a:endParaRPr lang="en-US" sz="1500" dirty="0"/>
+          </a:p>
+        </p:txBody>
+      </p:sp>
+      <p:sp>
+        <p:nvSpPr>
+          <p:cNvPr id="30" name="open body 7"/>
+          <p:cNvSpPr txBox="1"/>
+          <p:nvPr/>
+        </p:nvSpPr>
+        <p:spPr>
+          <a:xfrm>
+            <a:off x="1097280" y="4215384"/>
+            <a:ext cx="7589520" cy="502920"/>
+          </a:xfrm>
+          <a:prstGeom prst="rect">
+            <a:avLst/>
+          </a:prstGeom>
+          <a:noFill/>
+          <a:ln/>
+        </p:spPr>
+        <p:txBody>
+          <a:bodyPr wrap="square" lIns="0" tIns="0" rIns="0" bIns="0" rtlCol="0" anchor="t"/>
+          <a:lstStyle/>
+          <a:p>
+            <a:pPr indent="0" marL="0">
+              <a:buNone/>
+            </a:pPr>
+            <a:r>
+              <a:rPr lang="en-US" sz="1200" dirty="0">
+                <a:solidFill>
+                  <a:schemeClr val="tx2"/>
+                </a:solidFill>
+              </a:rPr>
+              <a:t>Missing labels fixed 16 Oct (images re-extracted). Re-fit of all 87 tasks (gender m → 0, f → 1; one shared frame grid) and re-check done 18 Oct: WARN (was FAIL), no actor missing. In use: the final model trained on them (slide 16).</a:t>
+            </a:r>
+            <a:endParaRPr lang="en-US" sz="1200" dirty="0"/>
           </a:p>
         </p:txBody>
       </p:sp>
@@ -16031,8 +16241,162 @@
         </p:nvSpPr>
         <p:spPr>
           <a:xfrm>
-            <a:off x="457200" y="320040"/>
-            <a:ext cx="8229600" cy="731520"/>
+            <a:off x="548640" y="320040"/>
+            <a:ext cx="8046720" cy="731520"/>
+          </a:xfrm>
+          <a:prstGeom prst="rect">
+            <a:avLst/>
+          </a:prstGeom>
+          <a:noFill/>
+          <a:ln/>
+        </p:spPr>
+        <p:txBody>
+          <a:bodyPr wrap="square" lIns="0" tIns="0" rIns="0" bIns="0" rtlCol="0"/>
+          <a:lstStyle/>
+          <a:p>
+            <a:pPr algn="l" indent="0" marL="0">
+              <a:buNone/>
+            </a:pPr>
+            <a:r>
+              <a:rPr lang="en-US" sz="3600" b="1" dirty="0">
+                <a:solidFill>
+                  <a:schemeClr val="bg1"/>
+                </a:solidFill>
+              </a:rPr>
+              <a:t>What I claim today, and what I do not</a:t>
+            </a:r>
+            <a:endParaRPr lang="en-US" sz="3600" dirty="0"/>
+          </a:p>
+        </p:txBody>
+      </p:sp>
+      <p:sp>
+        <p:nvSpPr>
+          <p:cNvPr id="3" name="Text 0"/>
+          <p:cNvSpPr/>
+          <p:nvPr>
+            <p:ph idx="101" type="body" hasCustomPrompt="1"/>
+          </p:nvPr>
+        </p:nvSpPr>
+        <p:spPr>
+          <a:xfrm>
+            <a:off x="548640" y="1143000"/>
+            <a:ext cx="8046720" cy="2148840"/>
+          </a:xfrm>
+          <a:prstGeom prst="rect">
+            <a:avLst/>
+          </a:prstGeom>
+          <a:noFill/>
+          <a:ln/>
+        </p:spPr>
+        <p:txBody>
+          <a:bodyPr wrap="square" lIns="0" tIns="0" rIns="0" bIns="0" rtlCol="0" anchor="t"/>
+          <a:lstStyle/>
+          <a:p>
+            <a:pPr algn="l" indent="0" marL="0">
+              <a:buNone/>
+            </a:pPr>
+            <a:r>
+              <a:rPr lang="en-US" sz="1500" b="1" dirty="0">
+                <a:solidFill>
+                  <a:srgbClr val="F4C95D"/>
+                </a:solidFill>
+              </a:rPr>
+              <a:t>Claimed, measured: </a:t>
+            </a:r>
+            <a:r>
+              <a:rPr lang="en-US" sz="1500" dirty="0">
+                <a:solidFill>
+                  <a:schemeClr val="bg2"/>
+                </a:solidFill>
+              </a:rPr>
+              <a:t>the failures are not rig or decoding problems. A training-target bug puts people too far away in v5, v9 and v10. In all 8 v5-line checkpoints, neck02 and the head bone sit half a turn off; two flipped hand bones were half the finger error. 3DPW labels: three defects fixed by a re-fit (slide 6). The final model keeps every fix against its own control: root error −48%, neck02 4.8°, fingers 8.3°, PA-PVE 50.3 vs 56.4 mm, 3DPW test PVE 89.0 mm, best of all models (control 91.5, v9 95.5, v5 121.8; slide 16).</a:t>
+            </a:r>
+            <a:endParaRPr lang="en-US" sz="1500" dirty="0"/>
+          </a:p>
+          <a:p>
+            <a:pPr algn="l" indent="0" marL="0">
+              <a:buNone/>
+            </a:pPr>
+            <a:r>
+              <a:rPr lang="en-US" sz="1500" b="1" dirty="0">
+                <a:solidFill>
+                  <a:srgbClr val="F4C95D"/>
+                </a:solidFill>
+              </a:rPr>
+              <a:t>Not claimed: </a:t>
+            </a:r>
+            <a:r>
+              <a:rPr lang="en-US" sz="1500" dirty="0">
+                <a:solidFill>
+                  <a:schemeClr val="bg2"/>
+                </a:solidFill>
+              </a:rPr>
+              <a:t>results proven over seeds (one run each) or why the bones flipped; better children; correct near/far depths (slope 0.42); fixes without cost (recall −2 points vs the control, −3 vs v5); that the fixes made most of the 3DPW gain (3DPW training did); head turn, age or limb lengths in the 3DPW labels.</a:t>
+            </a:r>
+            <a:endParaRPr lang="en-US" sz="1500" dirty="0"/>
+          </a:p>
+        </p:txBody>
+      </p:sp>
+      <p:sp>
+        <p:nvSpPr>
+          <p:cNvPr id="4" name="question box"/>
+          <p:cNvSpPr/>
+          <p:nvPr/>
+        </p:nvSpPr>
+        <p:spPr>
+          <a:xfrm>
+            <a:off x="548640" y="3310128"/>
+            <a:ext cx="8046720" cy="1371600"/>
+          </a:xfrm>
+          <a:prstGeom prst="rect">
+            <a:avLst/>
+          </a:prstGeom>
+          <a:solidFill>
+            <a:srgbClr val="2B3550"/>
+          </a:solidFill>
+          <a:ln w="12700">
+            <a:solidFill>
+              <a:srgbClr val="2B3550"/>
+            </a:solidFill>
+            <a:prstDash val="solid"/>
+          </a:ln>
+        </p:spPr>
+      </p:sp>
+      <p:sp>
+        <p:nvSpPr>
+          <p:cNvPr id="5" name="question bar"/>
+          <p:cNvSpPr/>
+          <p:nvPr/>
+        </p:nvSpPr>
+        <p:spPr>
+          <a:xfrm>
+            <a:off x="548640" y="3310128"/>
+            <a:ext cx="73152" cy="1371600"/>
+          </a:xfrm>
+          <a:prstGeom prst="rect">
+            <a:avLst/>
+          </a:prstGeom>
+          <a:solidFill>
+            <a:srgbClr val="F4C95D"/>
+          </a:solidFill>
+          <a:ln w="12700">
+            <a:solidFill>
+              <a:srgbClr val="F4C95D"/>
+            </a:solidFill>
+            <a:prstDash val="solid"/>
+          </a:ln>
+        </p:spPr>
+      </p:sp>
+      <p:sp>
+        <p:nvSpPr>
+          <p:cNvPr id="6" name="question text"/>
+          <p:cNvSpPr txBox="1"/>
+          <p:nvPr/>
+        </p:nvSpPr>
+        <p:spPr>
+          <a:xfrm>
+            <a:off x="822960" y="3355848"/>
+            <a:ext cx="7635240" cy="1280160"/>
           </a:xfrm>
           <a:prstGeom prst="rect">
             <a:avLst/>
@@ -16044,194 +16408,52 @@
           <a:bodyPr wrap="square" lIns="0" tIns="0" rIns="0" bIns="0" rtlCol="0" anchor="ctr"/>
           <a:lstStyle/>
           <a:p>
-            <a:pPr algn="l" indent="0" marL="0">
+            <a:pPr indent="0" marL="0">
+              <a:spcAft>
+                <a:spcPts val="400"/>
+              </a:spcAft>
               <a:buNone/>
             </a:pPr>
             <a:r>
-              <a:rPr lang="en-US" sz="2700" b="1" dirty="0">
-                <a:solidFill>
-                  <a:schemeClr val="tx1"/>
-                </a:solidFill>
-              </a:rPr>
-              <a:t>Backup: before and after, holdout image 579860</a:t>
-            </a:r>
-            <a:endParaRPr lang="en-US" sz="2700" dirty="0"/>
-          </a:p>
-        </p:txBody>
-      </p:sp>
-      <p:pic>
-        <p:nvPicPr>
-          <p:cNvPr id="3" name="figure depth_before_after_579860.jpg" descr="Ground truth, before (v5) and after (fix) meshes on a synthetic holdout image">    </p:cNvPr>
-          <p:cNvPicPr>
-            <a:picLocks noChangeAspect="1"/>
-          </p:cNvPicPr>
-          <p:nvPr/>
-        </p:nvPicPr>
-        <p:blipFill>
-          <a:blip r:embed="rId1"/>
-          <a:stretch>
-            <a:fillRect/>
-          </a:stretch>
-        </p:blipFill>
-        <p:spPr>
-          <a:xfrm>
-            <a:off x="914400" y="1097280"/>
-            <a:ext cx="7315200" cy="2664517"/>
-          </a:xfrm>
-          <a:prstGeom prst="rect">
-            <a:avLst/>
-          </a:prstGeom>
-        </p:spPr>
-      </p:pic>
-      <p:sp>
-        <p:nvSpPr>
-          <p:cNvPr id="4" name="caption 0"/>
-          <p:cNvSpPr txBox="1"/>
-          <p:nvPr/>
-        </p:nvSpPr>
-        <p:spPr>
-          <a:xfrm>
-            <a:off x="914400" y="3816661"/>
-            <a:ext cx="2413955" cy="365760"/>
-          </a:xfrm>
-          <a:prstGeom prst="rect">
-            <a:avLst/>
-          </a:prstGeom>
-          <a:noFill/>
-          <a:ln/>
-        </p:spPr>
-        <p:txBody>
-          <a:bodyPr wrap="square" lIns="0" tIns="0" rIns="0" bIns="0" rtlCol="0" anchor="t"/>
-          <a:lstStyle/>
+              <a:rPr lang="en-US" sz="1300" b="1" dirty="0">
+                <a:solidFill>
+                  <a:srgbClr val="F4C95D"/>
+                </a:solidFill>
+              </a:rPr>
+              <a:t>Question for you</a:t>
+            </a:r>
+            <a:endParaRPr lang="en-US" sz="1300" dirty="0"/>
+          </a:p>
+          <a:p>
+            <a:pPr indent="0" marL="0">
+              <a:spcAft>
+                <a:spcPts val="400"/>
+              </a:spcAft>
+              <a:buNone/>
+            </a:pPr>
+            <a:r>
+              <a:rPr lang="en-US" sz="1300" b="1" dirty="0">
+                <a:solidFill>
+                  <a:srgbClr val="EEF2F7"/>
+                </a:solidFill>
+              </a:rPr>
+              <a:t>Chosen: fix gender and frame grid, re-fit all 3DPW tasks, then fine-tune v5 (done 18 Oct: slide 16). Next: write up, or also add weak age labels for children (1–2 weeks)?</a:t>
+            </a:r>
+            <a:endParaRPr lang="en-US" sz="1300" dirty="0"/>
+          </a:p>
           <a:p>
             <a:pPr indent="0" marL="0">
               <a:buNone/>
             </a:pPr>
             <a:r>
-              <a:rPr lang="en-US" sz="1100" dirty="0">
-                <a:solidFill>
-                  <a:schemeClr val="tx1"/>
-                </a:solidFill>
-              </a:rPr>
-              <a:t>Synthetic holdout image 579860. Predictions use the model's own depth.</a:t>
-            </a:r>
-            <a:endParaRPr lang="en-US" sz="1100" dirty="0"/>
-          </a:p>
-        </p:txBody>
-      </p:sp>
-      <p:sp>
-        <p:nvSpPr>
-          <p:cNvPr id="5" name="caption 1"/>
-          <p:cNvSpPr txBox="1"/>
-          <p:nvPr/>
-        </p:nvSpPr>
-        <p:spPr>
-          <a:xfrm>
-            <a:off x="3365023" y="3816661"/>
-            <a:ext cx="2413955" cy="365760"/>
-          </a:xfrm>
-          <a:prstGeom prst="rect">
-            <a:avLst/>
-          </a:prstGeom>
-          <a:noFill/>
-          <a:ln/>
-        </p:spPr>
-        <p:txBody>
-          <a:bodyPr wrap="square" lIns="0" tIns="0" rIns="0" bIns="0" rtlCol="0" anchor="t"/>
-          <a:lstStyle/>
-          <a:p>
-            <a:pPr indent="0" marL="0">
-              <a:buNone/>
-            </a:pPr>
-            <a:r>
-              <a:rPr lang="en-US" sz="1100" dirty="0">
-                <a:solidFill>
-                  <a:schemeClr val="tx1"/>
-                </a:solidFill>
-              </a:rPr>
-              <a:t>v5: the real head sticks out above a shrunken mesh</a:t>
-            </a:r>
-            <a:endParaRPr lang="en-US" sz="1100" dirty="0"/>
-          </a:p>
-        </p:txBody>
-      </p:sp>
-      <p:sp>
-        <p:nvSpPr>
-          <p:cNvPr id="6" name="caption 2"/>
-          <p:cNvSpPr txBox="1"/>
-          <p:nvPr/>
-        </p:nvSpPr>
-        <p:spPr>
-          <a:xfrm>
-            <a:off x="5815645" y="3816661"/>
-            <a:ext cx="2413955" cy="365760"/>
-          </a:xfrm>
-          <a:prstGeom prst="rect">
-            <a:avLst/>
-          </a:prstGeom>
-          <a:noFill/>
-          <a:ln/>
-        </p:spPr>
-        <p:txBody>
-          <a:bodyPr wrap="square" lIns="0" tIns="0" rIns="0" bIns="0" rtlCol="0" anchor="t"/>
-          <a:lstStyle/>
-          <a:p>
-            <a:pPr indent="0" marL="0">
-              <a:buNone/>
-            </a:pPr>
-            <a:r>
-              <a:rPr lang="en-US" sz="1100" dirty="0">
-                <a:solidFill>
-                  <a:schemeClr val="tx1"/>
-                </a:solidFill>
-              </a:rPr>
-              <a:t>Fix + depth ×5, 10 epochs: head level with the truth; mesh cut off at the image edge</a:t>
-            </a:r>
-            <a:endParaRPr lang="en-US" sz="1100" dirty="0"/>
-          </a:p>
-        </p:txBody>
-      </p:sp>
-      <p:sp>
-        <p:nvSpPr>
-          <p:cNvPr id="7" name="figure footnote"/>
-          <p:cNvSpPr txBox="1"/>
-          <p:nvPr/>
-        </p:nvSpPr>
-        <p:spPr>
-          <a:xfrm>
-            <a:off x="914400" y="4218997"/>
-            <a:ext cx="7315200" cy="365760"/>
-          </a:xfrm>
-          <a:prstGeom prst="rect">
-            <a:avLst/>
-          </a:prstGeom>
-          <a:noFill/>
-          <a:ln/>
-        </p:spPr>
-        <p:txBody>
-          <a:bodyPr wrap="square" lIns="0" tIns="0" rIns="0" bIns="0" rtlCol="0" anchor="t"/>
-          <a:lstStyle/>
-          <a:p>
-            <a:pPr indent="0" marL="0">
-              <a:buNone/>
-            </a:pPr>
-            <a:r>
-              <a:rPr lang="en-US" sz="1100" b="1" dirty="0">
-                <a:solidFill>
-                  <a:srgbClr val="1B2233"/>
-                </a:solidFill>
-              </a:rPr>
-              <a:t>Not an exact fit: </a:t>
-            </a:r>
-            <a:r>
-              <a:rPr lang="en-US" sz="1100" dirty="0">
-                <a:solidFill>
-                  <a:schemeClr val="tx2"/>
-                </a:solidFill>
-              </a:rPr>
-              <a:t>here the fixed mesh is a little larger and wider than the ground truth. The two people in front have no ground-truth mesh, so they are not counted as misses.</a:t>
-            </a:r>
-            <a:endParaRPr lang="en-US" sz="1100" dirty="0"/>
+              <a:rPr lang="en-US" sz="1300" dirty="0">
+                <a:solidFill>
+                  <a:srgbClr val="EEF2F7"/>
+                </a:solidFill>
+              </a:rPr>
+              <a:t>v9 also has the neck flip (measured at epoch 149) and needs its own bone fix; v10 has a similar left-arm flip.</a:t>
+            </a:r>
+            <a:endParaRPr lang="en-US" sz="1300" dirty="0"/>
           </a:p>
         </p:txBody>
       </p:sp>
@@ -16809,6 +17031,290 @@
             <a:fld id="{F7021451-1387-4CA6-816F-3879F97B5CBC}" type="slidenum">
               <a:rPr b="0" lang="en-US"/>
               <a:t>2</a:t>
+            </a:fld>
+            <a:endParaRPr lang="en-US"/>
+          </a:p>
+        </p:txBody>
+      </p:sp>
+    </p:spTree>
+  </p:cSld>
+  <p:clrMapOvr>
+    <a:masterClrMapping/>
+  </p:clrMapOvr>
+</p:sld>
+</file>
+
+<file path=ppt/slides/slide20.xml><?xml version="1.0" encoding="utf-8"?>
+<p:sld xmlns:a="http://schemas.openxmlformats.org/drawingml/2006/main" xmlns:r="http://schemas.openxmlformats.org/officeDocument/2006/relationships" xmlns:p="http://schemas.openxmlformats.org/presentationml/2006/main">
+  <p:cSld name="Slide 20">
+    <p:spTree>
+      <p:nvGrpSpPr>
+        <p:cNvPr id="1" name=""/>
+        <p:cNvGrpSpPr/>
+        <p:nvPr/>
+      </p:nvGrpSpPr>
+      <p:grpSpPr>
+        <a:xfrm>
+          <a:off x="0" y="0"/>
+          <a:ext cx="0" cy="0"/>
+          <a:chOff x="0" y="0"/>
+          <a:chExt cx="0" cy="0"/>
+        </a:xfrm>
+      </p:grpSpPr>
+      <p:sp>
+        <p:nvSpPr>
+          <p:cNvPr id="2" name="Text 0"/>
+          <p:cNvSpPr/>
+          <p:nvPr>
+            <p:ph idx="100" type="title" hasCustomPrompt="1"/>
+          </p:nvPr>
+        </p:nvSpPr>
+        <p:spPr>
+          <a:xfrm>
+            <a:off x="457200" y="320040"/>
+            <a:ext cx="8229600" cy="731520"/>
+          </a:xfrm>
+          <a:prstGeom prst="rect">
+            <a:avLst/>
+          </a:prstGeom>
+          <a:noFill/>
+          <a:ln/>
+        </p:spPr>
+        <p:txBody>
+          <a:bodyPr wrap="square" lIns="0" tIns="0" rIns="0" bIns="0" rtlCol="0" anchor="ctr"/>
+          <a:lstStyle/>
+          <a:p>
+            <a:pPr algn="l" indent="0" marL="0">
+              <a:buNone/>
+            </a:pPr>
+            <a:r>
+              <a:rPr lang="en-US" sz="2700" b="1" dirty="0">
+                <a:solidFill>
+                  <a:schemeClr val="tx1"/>
+                </a:solidFill>
+              </a:rPr>
+              <a:t>Backup: before and after, holdout image 579860</a:t>
+            </a:r>
+            <a:endParaRPr lang="en-US" sz="2700" dirty="0"/>
+          </a:p>
+        </p:txBody>
+      </p:sp>
+      <p:pic>
+        <p:nvPicPr>
+          <p:cNvPr id="3" name="figure depth_before_after_579860.jpg" descr="Ground truth, before (v5) and after (fix) meshes on a synthetic holdout image">    </p:cNvPr>
+          <p:cNvPicPr>
+            <a:picLocks noChangeAspect="1"/>
+          </p:cNvPicPr>
+          <p:nvPr/>
+        </p:nvPicPr>
+        <p:blipFill>
+          <a:blip r:embed="rId1"/>
+          <a:stretch>
+            <a:fillRect/>
+          </a:stretch>
+        </p:blipFill>
+        <p:spPr>
+          <a:xfrm>
+            <a:off x="914400" y="1097280"/>
+            <a:ext cx="7315200" cy="2664517"/>
+          </a:xfrm>
+          <a:prstGeom prst="rect">
+            <a:avLst/>
+          </a:prstGeom>
+        </p:spPr>
+      </p:pic>
+      <p:sp>
+        <p:nvSpPr>
+          <p:cNvPr id="4" name="caption 0"/>
+          <p:cNvSpPr txBox="1"/>
+          <p:nvPr/>
+        </p:nvSpPr>
+        <p:spPr>
+          <a:xfrm>
+            <a:off x="914400" y="3816661"/>
+            <a:ext cx="2413955" cy="365760"/>
+          </a:xfrm>
+          <a:prstGeom prst="rect">
+            <a:avLst/>
+          </a:prstGeom>
+          <a:noFill/>
+          <a:ln/>
+        </p:spPr>
+        <p:txBody>
+          <a:bodyPr wrap="square" lIns="0" tIns="0" rIns="0" bIns="0" rtlCol="0" anchor="t"/>
+          <a:lstStyle/>
+          <a:p>
+            <a:pPr indent="0" marL="0">
+              <a:buNone/>
+            </a:pPr>
+            <a:r>
+              <a:rPr lang="en-US" sz="1100" dirty="0">
+                <a:solidFill>
+                  <a:schemeClr val="tx1"/>
+                </a:solidFill>
+              </a:rPr>
+              <a:t>Synthetic holdout image 579860. Predictions use the model's own depth.</a:t>
+            </a:r>
+            <a:endParaRPr lang="en-US" sz="1100" dirty="0"/>
+          </a:p>
+        </p:txBody>
+      </p:sp>
+      <p:sp>
+        <p:nvSpPr>
+          <p:cNvPr id="5" name="caption 1"/>
+          <p:cNvSpPr txBox="1"/>
+          <p:nvPr/>
+        </p:nvSpPr>
+        <p:spPr>
+          <a:xfrm>
+            <a:off x="3365023" y="3816661"/>
+            <a:ext cx="2413955" cy="365760"/>
+          </a:xfrm>
+          <a:prstGeom prst="rect">
+            <a:avLst/>
+          </a:prstGeom>
+          <a:noFill/>
+          <a:ln/>
+        </p:spPr>
+        <p:txBody>
+          <a:bodyPr wrap="square" lIns="0" tIns="0" rIns="0" bIns="0" rtlCol="0" anchor="t"/>
+          <a:lstStyle/>
+          <a:p>
+            <a:pPr indent="0" marL="0">
+              <a:buNone/>
+            </a:pPr>
+            <a:r>
+              <a:rPr lang="en-US" sz="1100" dirty="0">
+                <a:solidFill>
+                  <a:schemeClr val="tx1"/>
+                </a:solidFill>
+              </a:rPr>
+              <a:t>v5: the real head sticks out above a shrunken mesh</a:t>
+            </a:r>
+            <a:endParaRPr lang="en-US" sz="1100" dirty="0"/>
+          </a:p>
+        </p:txBody>
+      </p:sp>
+      <p:sp>
+        <p:nvSpPr>
+          <p:cNvPr id="6" name="caption 2"/>
+          <p:cNvSpPr txBox="1"/>
+          <p:nvPr/>
+        </p:nvSpPr>
+        <p:spPr>
+          <a:xfrm>
+            <a:off x="5815645" y="3816661"/>
+            <a:ext cx="2413955" cy="365760"/>
+          </a:xfrm>
+          <a:prstGeom prst="rect">
+            <a:avLst/>
+          </a:prstGeom>
+          <a:noFill/>
+          <a:ln/>
+        </p:spPr>
+        <p:txBody>
+          <a:bodyPr wrap="square" lIns="0" tIns="0" rIns="0" bIns="0" rtlCol="0" anchor="t"/>
+          <a:lstStyle/>
+          <a:p>
+            <a:pPr indent="0" marL="0">
+              <a:buNone/>
+            </a:pPr>
+            <a:r>
+              <a:rPr lang="en-US" sz="1100" dirty="0">
+                <a:solidFill>
+                  <a:schemeClr val="tx1"/>
+                </a:solidFill>
+              </a:rPr>
+              <a:t>Fix + depth ×5, 10 epochs: head level with the truth; mesh cut off at the image edge</a:t>
+            </a:r>
+            <a:endParaRPr lang="en-US" sz="1100" dirty="0"/>
+          </a:p>
+        </p:txBody>
+      </p:sp>
+      <p:sp>
+        <p:nvSpPr>
+          <p:cNvPr id="7" name="figure footnote"/>
+          <p:cNvSpPr txBox="1"/>
+          <p:nvPr/>
+        </p:nvSpPr>
+        <p:spPr>
+          <a:xfrm>
+            <a:off x="914400" y="4218997"/>
+            <a:ext cx="7315200" cy="365760"/>
+          </a:xfrm>
+          <a:prstGeom prst="rect">
+            <a:avLst/>
+          </a:prstGeom>
+          <a:noFill/>
+          <a:ln/>
+        </p:spPr>
+        <p:txBody>
+          <a:bodyPr wrap="square" lIns="0" tIns="0" rIns="0" bIns="0" rtlCol="0" anchor="t"/>
+          <a:lstStyle/>
+          <a:p>
+            <a:pPr indent="0" marL="0">
+              <a:buNone/>
+            </a:pPr>
+            <a:r>
+              <a:rPr lang="en-US" sz="1100" b="1" dirty="0">
+                <a:solidFill>
+                  <a:srgbClr val="1B2233"/>
+                </a:solidFill>
+              </a:rPr>
+              <a:t>Not an exact fit: </a:t>
+            </a:r>
+            <a:r>
+              <a:rPr lang="en-US" sz="1100" dirty="0">
+                <a:solidFill>
+                  <a:schemeClr val="tx2"/>
+                </a:solidFill>
+              </a:rPr>
+              <a:t>here the fixed mesh is a little larger and wider than the ground truth. The two people in front have no ground-truth mesh, so they are not counted as misses.</a:t>
+            </a:r>
+            <a:endParaRPr lang="en-US" sz="1100" dirty="0"/>
+          </a:p>
+        </p:txBody>
+      </p:sp>
+      <p:sp>
+        <p:nvSpPr>
+          <p:cNvPr id="25" name="Slide Number Placeholder 0"/>
+          <p:cNvSpPr>
+            <a:spLocks noGrp="1"/>
+          </p:cNvSpPr>
+          <p:nvPr>
+            <p:ph type="sldNum" sz="quarter" idx="4294967295"/>
+          </p:nvPr>
+        </p:nvSpPr>
+        <p:spPr>
+          <a:xfrm>
+            <a:off x="8412480" y="4754880"/>
+            <a:ext cx="457200" cy="274320"/>
+          </a:xfrm>
+          <a:prstGeom prst="rect">
+            <a:avLst/>
+          </a:prstGeom>
+          <a:extLst>
+            <a:ext uri="{C572A759-6A51-4108-AA02-DFA0A04FC94B}">
+              <ma14:wrappingTextBoxFlag xmlns:ma14="http://schemas.microsoft.com/office/mac/drawingml/2011/main" val="0"/>
+            </a:ext>
+          </a:extLst>
+        </p:spPr>
+        <p:txBody>
+          <a:bodyPr lIns="91440" tIns="0" rIns="0" bIns="0" anchor="ctr"/>
+          <a:lstStyle>
+            <a:lvl1pPr>
+              <a:defRPr sz="1000">
+                <a:solidFill>
+                  <a:srgbClr val="7B8794"/>
+                </a:solidFill>
+              </a:defRPr>
+            </a:lvl1pPr>
+          </a:lstStyle>
+          <a:p>
+            <a:pPr algn="l"/>
+            <a:fld id="{F7021451-1387-4CA6-816F-3879F97B5CBC}" type="slidenum">
+              <a:rPr b="0" lang="en-US"/>
+              <a:t>20</a:t>
             </a:fld>
             <a:endParaRPr lang="en-US"/>
           </a:p>

</xml_diff>

<commit_message>
WIP docs: deck follow-up and requirements plan still in progress - not for main yet
Co-Authored-By: Claude Fable 5.1 <noreply@anthropic.com>
Claude-Session: https://claude.ai/code/session_016LhpG4kT7Z7ppxbG4TW5S9
</commit_message>
<xml_diff>
--- a/docs/supervisor_update_2026-10-16.pptx
+++ b/docs/supervisor_update_2026-10-16.pptx
@@ -126,7 +126,7 @@
   <p:extLst>
     <p:ext uri="{521415D9-36F7-43E2-AB2F-B90AF26B5E84}">
       <p14:sectionLst xmlns:p14="http://schemas.microsoft.com/office/powerpoint/2010/main">
-        <p14:section name="Overview" id="{da8d3304-9dd2-dc43-1253-d26814150d00}">
+        <p14:section name="Overview" id="{2b07acb2-fbef-7c11-8627-212d0ee6232c}">
           <p14:sldIdLst>
             <p14:sldId id="256"/>
             <p14:sldId id="257"/>
@@ -134,13 +134,13 @@
             <p14:sldId id="259"/>
           </p14:sldIdLst>
         </p14:section>
-        <p14:section name="3DPW labels" id="{7fa300ec-dded-754f-25b0-6b3dcc05fe7e}">
+        <p14:section name="3DPW labels" id="{0bef9bc5-6af8-9fd4-a54e-83ce77db526b}">
           <p14:sldIdLst>
             <p14:sldId id="260"/>
             <p14:sldId id="261"/>
           </p14:sldIdLst>
         </p14:section>
-        <p14:section name="Findings" id="{fb307fe4-d1f1-ab85-96f1-23d3c0b01362}">
+        <p14:section name="Findings" id="{9800d97a-407d-8132-ba4b-f32578afe57e}">
           <p14:sldIdLst>
             <p14:sldId id="262"/>
             <p14:sldId id="263"/>
@@ -148,14 +148,14 @@
             <p14:sldId id="265"/>
           </p14:sldIdLst>
         </p14:section>
-        <p14:section name="Bug" id="{8f29ea54-c4c1-bdcc-5681-2eb39299d43d}">
+        <p14:section name="Bug" id="{167ef500-bca9-d0db-9ede-91544302cbb5}">
           <p14:sldIdLst>
             <p14:sldId id="266"/>
             <p14:sldId id="267"/>
             <p14:sldId id="268"/>
           </p14:sldIdLst>
         </p14:section>
-        <p14:section name="Next" id="{0bd2bdb5-7dcb-a7b0-d0af-d6c7869db96a}">
+        <p14:section name="Next" id="{0ae66ecd-eb2f-6d27-7555-1ea6ca180f65}">
           <p14:sldIdLst>
             <p14:sldId id="269"/>
             <p14:sldId id="270"/>
@@ -165,7 +165,7 @@
             <p14:sldId id="274"/>
           </p14:sldIdLst>
         </p14:section>
-        <p14:section name="Appendix" id="{e5cd6953-a2e6-30c2-5ac0-318d62f98b00}">
+        <p14:section name="Appendix" id="{88fea5af-253f-5234-243e-0d7596aec0df}">
           <p14:sldIdLst>
             <p14:sldId id="275"/>
           </p14:sldIdLst>
@@ -1381,7 +1381,7 @@
           <a:p>
             <a:r>
               <a:rPr lang="en-US" dirty="0"/>
-              <a:t>- The log's predicted gender, over all 12 images: v5 0.32 to 0.76, median 0.59, close to the training median; the final model 0.05 to 0.99, median 0.90. So the shape head now gives clear values instead of the middle. The log does not settle the direction: zero is male in Anny, the man on the phone gets 0.05 to 0.16, but on the tennis photo, where the men look male, most values are above 0.7, and the log does not say which value belongs to which body. Other shape values moved too and likely add to the male look: muscle, median 0.28 to 0.48, and proportions, 0.81 to 0.57. Age: v5 0.50 to 0.77, the final model 0.42 to 0.65.</a:t>
+              <a:t>- The log's predicted gender, over all 12 images: v5 0.32 to 0.76, median 0.59, close to the training median; the final model 0.05 to 0.99, median 0.90. So the shape head now gives clear values instead of the middle. The log does not settle the direction: zero is male in Anny, and in the frame with the man on the phone every value is below 0.5, but on the tennis photo, where the men look male, most values are above 0.7, and the log does not say which value belongs to which body. Other shape values moved too and likely add to the male look: muscle, median 0.28 to 0.48, and proportions, 0.81 to 0.57. Age: v5 0.50 to 0.77, the final model 0.42 to 0.65.</a:t>
             </a:r>
           </a:p>
           <a:p>

</xml_diff>

<commit_message>
WIP docs: deck final pass in progress (RH final-model numbers, requirements slide) - not for main yet
Co-Authored-By: Claude Fable 5.1 <noreply@anthropic.com>
Claude-Session: https://claude.ai/code/session_016LhpG4kT7Z7ppxbG4TW5S9
</commit_message>
<xml_diff>
--- a/docs/supervisor_update_2026-10-16.pptx
+++ b/docs/supervisor_update_2026-10-16.pptx
@@ -25,9 +25,10 @@
     <p:sldId id="273" r:id="rId19"/>
     <p:sldId id="274" r:id="rId20"/>
     <p:sldId id="275" r:id="rId21"/>
+    <p:sldId id="276" r:id="rId22"/>
   </p:sldIdLst>
   <p:notesMasterIdLst>
-    <p:notesMasterId r:id="rId22"/>
+    <p:notesMasterId r:id="rId23"/>
   </p:notesMasterIdLst>
   <p:sldSz cx="9144000" cy="5143500"/>
   <p:notesSz cx="5143500" cy="9144000"/>
@@ -126,7 +127,7 @@
   <p:extLst>
     <p:ext uri="{521415D9-36F7-43E2-AB2F-B90AF26B5E84}">
       <p14:sectionLst xmlns:p14="http://schemas.microsoft.com/office/powerpoint/2010/main">
-        <p14:section name="Overview" id="{2b07acb2-fbef-7c11-8627-212d0ee6232c}">
+        <p14:section name="Overview" id="{f172acb4-51f9-0258-11bf-003e92a7f46f}">
           <p14:sldIdLst>
             <p14:sldId id="256"/>
             <p14:sldId id="257"/>
@@ -134,13 +135,13 @@
             <p14:sldId id="259"/>
           </p14:sldIdLst>
         </p14:section>
-        <p14:section name="3DPW labels" id="{0bef9bc5-6af8-9fd4-a54e-83ce77db526b}">
+        <p14:section name="3DPW labels" id="{2b1b0383-7d79-fef5-23e7-b85ea5140f22}">
           <p14:sldIdLst>
             <p14:sldId id="260"/>
             <p14:sldId id="261"/>
           </p14:sldIdLst>
         </p14:section>
-        <p14:section name="Findings" id="{9800d97a-407d-8132-ba4b-f32578afe57e}">
+        <p14:section name="Findings" id="{4aa6ada4-1260-7cdf-93ce-d587056a0ba1}">
           <p14:sldIdLst>
             <p14:sldId id="262"/>
             <p14:sldId id="263"/>
@@ -148,14 +149,14 @@
             <p14:sldId id="265"/>
           </p14:sldIdLst>
         </p14:section>
-        <p14:section name="Bug" id="{167ef500-bca9-d0db-9ede-91544302cbb5}">
+        <p14:section name="Bug" id="{49a00c42-7cf4-bbbd-e2ec-6b03b07f7895}">
           <p14:sldIdLst>
             <p14:sldId id="266"/>
             <p14:sldId id="267"/>
             <p14:sldId id="268"/>
           </p14:sldIdLst>
         </p14:section>
-        <p14:section name="Next" id="{0ae66ecd-eb2f-6d27-7555-1ea6ca180f65}">
+        <p14:section name="Next" id="{b6938dc3-a68b-5c6e-647f-a9ad990bb88b}">
           <p14:sldIdLst>
             <p14:sldId id="269"/>
             <p14:sldId id="270"/>
@@ -163,11 +164,12 @@
             <p14:sldId id="272"/>
             <p14:sldId id="273"/>
             <p14:sldId id="274"/>
+            <p14:sldId id="275"/>
           </p14:sldIdLst>
         </p14:section>
-        <p14:section name="Appendix" id="{88fea5af-253f-5234-243e-0d7596aec0df}">
+        <p14:section name="Appendix" id="{ecd477a9-3f36-9a60-8f31-054154dfeec8}">
           <p14:sldIdLst>
-            <p14:sldId id="275"/>
+            <p14:sldId id="276"/>
           </p14:sldIdLst>
         </p14:section>
       </p14:sectionLst>
@@ -574,7 +576,7 @@
           <a:p>
             <a:r>
               <a:rPr lang="en-US" dirty="0"/>
-              <a:t>Since last Friday I measured each stage of the pipeline separately. I will show what is not the cause, how the 3DPW labels are made, how well they match 3DPW, three defects I found in them and their fix, what I found in the neck and a first fix for it, what I measured about the fingers and the children, one depth bug nobody was looking for and its fix, the final model with all fixes together next to a control, how it looks on real photos, and what is still open. I will say clearly what is measured and what is only a guess.</a:t>
+              <a:t>Since last Friday I measured each stage of the pipeline separately. I will show what is not the cause, how the 3DPW labels are made, how well they match 3DPW, three defects I found in them and their fix, what I found in the neck and a first fix for it, what I measured about the fingers and the children, one depth bug nobody was looking for and its fix, the final model with all fixes together next to a control, how it looks on real photos, what is still open, and where we stand on your thesis requirements. I will say clearly what is measured and what is only a guess.</a:t>
             </a:r>
           </a:p>
         </p:txBody>
@@ -661,7 +663,7 @@
           <a:p>
             <a:r>
               <a:rPr lang="en-US" dirty="0"/>
-              <a:t>On training images the model can make child-like bodies, but on real photos it does not. I measured this on Relative Human, a public set of real photos with age-group labels: 635 validation images with 2,130 labelled people. The detected kids get a predicted age of 0.61 and the babies 0.62, against 0.63 for adults, so age barely separates them: the AUC is 0.61, where 0.5 is chance, and none of the 89 detected kids and only one of the 38 babies falls below our child threshold of 0.45. The model does see that they are small, but it puts that into height, not age: height goes from 0.51 for adults to 0.45 for kids and 0.39 for babies. So it reads children as short adults; in Anny, a low height at an adult age is a short, broad-shouldered adult. Gender carries no signal either: men get 0.535 on average and women 0.551, while Anny's male end is 0. This is the same pull to the training median we see on synthetic data, and it replaces my earlier by-eye reading of a few people in our own photos. The decision for today: write it up as a limitation, or add weak age labels from the Relative Human training set, as the BEV paper did, which is one to two weeks of code after the final model. Separately, a flag can stop the 3DPW labels from training every real person toward one fixed average body; it is off by default, and the final model, trained on 18 October, has it off (slide 16); a run with it on can follow.</a:t>
+              <a:t>On training images the model can make child-like bodies; on real photos v5 could not, and the final model does better, but children are not solved. I measured both models on Relative Human, a public set of real photos with age-group labels: 635 validation images with 2,130 labelled people. v5 reads children as short adults: kids get a predicted age of 0.61 and babies 0.62, against 0.63 for adults, so the separation AUC is only 0.61, where 0.5 is chance; the smallness goes into height instead, 0.45 for kids and 0.39 for babies against 0.51; and its gender accuracy is 46.5 percent, which is chance. The final model is better on every line: babies get 0.44 against 0.54 for adults, the AUC rises to 0.72, and half of the babies now fall below our child threshold of 0.45, against 3 percent with v5. Gender accuracy goes from 46 to 64 percent: women are now clearly recognised, at 0.86 on average, while men are still in the middle, at 0.55. It also finds more of the people, 65 percent instead of 47, and 62 percent of the babies instead of 33. I think part of the age shift comes from the 3DPW labels, which fix every real person's age at 0.55, because the adults dropped too, from 0.63 to 0.54; a run that masks those fixed 3DPW shape values is in progress, and it can go either way. So the decision for today stays: children as a stated limitation, or weak age labels from the Relative Human training set, which is one to two weeks of work.</a:t>
             </a:r>
           </a:p>
           <a:p>
@@ -670,7 +672,61 @@
           <a:p>
             <a:r>
               <a:rPr lang="en-US" dirty="0"/>
-              <a:t>If asked: Recall: the model detects only 47 percent of the labelled people, 33 percent of the babies and 43 percent of the kids; the photos are crowded and the model runs at 672 pixels. So every number covers detected people only. Matching: each detection is paired with a labelled box by overlap, IoU at least 0.3. In crowded scenes a few child labels may get an adult detection; that would blur the height drop and any age gap, but it cannot create the height drop, and the clear height drop says most matches are real children. The fine-tuned model with the neck and finger fix gives the same numbers within noise: AUC 0.613, kids 0.62, adults 0.64, gender 0.533 for men and 0.562 for women. That is expected: the fix turns bones, not the shape output. Teens get age 0.60 and height 0.49, between adults and kids in height. Our own photos agree: the one real child, a standing boy, gets age 0.60 and height 0.48; the five small people I quoted before were mostly crouching or seated adults, because the skeletal height I used is measured on the posed body. On synthetic data the same pull shows at both ends: holdout people with a true age of 0.6 to 0.8 come out at 0.57, and the youngest training people at 0.10 instead of 0.015. Showing about five times more synthetic children for two epochs was inconclusive, 48.5 against 53.1 millimetres on ten training children, and it has no mechanism for real photos. So I cannot yet say whether the cause is the gap between synthetic and real images, or the loss, an L1 through a sigmoid on rare values. In Anny a child is mainly narrow shoulders relative to the head, and only a low age gives that; a low height at age 0.6 gives a short, broad-shouldered adult, at least 1.22 metres tall. I do not convert ages to years: our code uses three different scales, and the dataset most likely does not follow Anny's own calibration. Relative Human has about 24,800 people with age-group labels, among them 2,720 children and 1,534 babies, plus gender; its training split is where weak labels would come from. The 3DPW labels fix age at 0.55 and seven more shape values at 0.5 for everyone; only height and proportions are fitted, and gender comes from 3DPW. With the flag on, the final model's 3DPW error can change for a reason unrelated to the depth and bone fixes, because the 3DPW ground-truth meshes keep that average body. Anny-Fit, from the group that made Anny, refits bodies at test time from a vision-language model's age and gender; it could give better figures, but it is not our model.</a:t>
+              <a:t>If asked:</a:t>
+            </a:r>
+          </a:p>
+          <a:p>
+            <a:r>
+              <a:rPr lang="en-US" dirty="0"/>
+              <a:t>- Caveats: every number covers detected people only. The final model matches more people, 1,305 children and adults against 948 for v5, so the two AUCs are over different sets of people. Detections are paired with labelled boxes by overlap, IoU at least 0.3; in crowded scenes a few child labels may get an adult detection, which would blur the gap, not create it. One run, the validation split.</a:t>
+            </a:r>
+          </a:p>
+          <a:p>
+            <a:r>
+              <a:rPr lang="en-US" dirty="0"/>
+              <a:t>- The 0.55 anchor: the AUC only ranks people, so moving everyone down by the same amount cannot raise it; the gain from 0.61 to 0.72 is real separation. But the adults' drop from 0.63 to 0.54 is most likely that anchor. With the mask, adult ages may go back toward 0.6 and the other shape values may spread out again, and the children's gain may shrink or stay. That is why I call the masked run an experiment with two outcomes, not a sure improvement. The 3DPW ground-truth meshes keep the average body, so its 3DPW error can also move for that reason alone.</a:t>
+            </a:r>
+          </a:p>
+          <a:p>
+            <a:r>
+              <a:rPr lang="en-US" dirty="0"/>
+              <a:t>- Height: v5 put the smallness into height; the final model puts more of it into age. Babies' height is 0.46 now, against 0.39 in v5; adults 0.50.</a:t>
+            </a:r>
+          </a:p>
+          <a:p>
+            <a:r>
+              <a:rPr lang="en-US" dirty="0"/>
+              <a:t>- The other shape values: on the 12 demo images the final model's muscle, weight, cup size and firmness sit near 0.5, the values the 3DPW labels fix. So “shape changes per person” is true for gender, partly for age and height, and not yet for those four.</a:t>
+            </a:r>
+          </a:p>
+          <a:p>
+            <a:r>
+              <a:rPr lang="en-US" dirty="0"/>
+              <a:t>- v5 in detail: none of its 89 detected kids and one of its 38 babies fall below 0.45; teens get age 0.60 and height 0.49. The neck and finger pilot gives the same as v5 within noise, AUC 0.613, gender 48 percent: the fix turns bones, not the shape output.</a:t>
+            </a:r>
+          </a:p>
+          <a:p>
+            <a:r>
+              <a:rPr lang="en-US" dirty="0"/>
+              <a:t>- Our own photos: the one real child, a standing boy, still gets an adult body with the final model, judged by eye. One child is not a measurement; Relative Human is.</a:t>
+            </a:r>
+          </a:p>
+          <a:p>
+            <a:r>
+              <a:rPr lang="en-US" dirty="0"/>
+              <a:t>- Synthetic data shows the same pull to the median at both ends: holdout people with a true age of 0.6 to 0.8 come out at 0.57, and the youngest training people at 0.10 instead of 0.015. Showing about five times more synthetic children for two epochs was inconclusive, 48.5 against 53.1 millimetres on ten training children. So I cannot yet say whether the cause is the gap between synthetic and real images, or the loss, an L1 through a sigmoid on rare values.</a:t>
+            </a:r>
+          </a:p>
+          <a:p>
+            <a:r>
+              <a:rPr lang="en-US" dirty="0"/>
+              <a:t>- Anny: a child is mainly narrow shoulders relative to the head, and only a low age gives that; a low height at age 0.6 gives a short, broad-shouldered adult, at least 1.22 metres tall. I do not convert ages to years: our code uses three different scales.</a:t>
+            </a:r>
+          </a:p>
+          <a:p>
+            <a:r>
+              <a:rPr lang="en-US" dirty="0"/>
+              <a:t>- Weak labels: Relative Human has about 24,800 people with age-group labels, among them 2,720 children and 1,534 babies, plus gender; its training split is where they would come from, as the BEV paper did. Anny-Fit, from the group that made Anny, refits bodies at test time from a vision-language model's age and gender; it could give better figures, but it is not our model.</a:t>
             </a:r>
           </a:p>
         </p:txBody>
@@ -1261,7 +1317,7 @@
           <a:p>
             <a:r>
               <a:rPr lang="en-US" dirty="0"/>
-              <a:t>- Children: unchanged; training has no child signal, so the Relative Human result on slide 10 stands. Gender is different: the shape mask was off, so the corrected 3DPW gender labels train the shape head, and on real photos most men now look male, judged by eye (next slide). The Relative Human number for the final model is not run yet.</a:t>
+              <a:t>- Children and gender: on Relative Human the final model separates children from adults better than v5, AUC 0.72 against 0.61, and gets gender right for 64 percent of the people against 46.5 (slide 10). Part of the age shift is likely the 3DPW age label of 0.55, and training has no child signal of its own, so I do not call children solved. The shape mask was off, so the corrected 3DPW gender labels train the shape head; on real photos most men now look male, judged by eye (next slide).</a:t>
             </a:r>
           </a:p>
           <a:p>
@@ -1354,7 +1410,7 @@
           <a:p>
             <a:r>
               <a:rPr lang="en-US" dirty="0"/>
-              <a:t>This is the final model on real photos, next to v5, judged by eye. These are three of the twelve demo images: a photo from our example set and two 3DPW test frames that no model trained on; v5 on the left, the final model on the right. The clearest change is the body shape of the men. v5 gave them breasts and wide hips; the final model gives most of them a flat chest and broader shoulders: three of the four men on the tennis photo, both men in the walking frame, the man on the phone, the guitar player and the seated man in the WhatsApp photo. Women stay female, and the bodies look a little larger, which fits the size ratio going from 0.63 to 0.78 on the synthetic holdout. What did not change: the boy in the garden photo still gets an adult body, some bodies still sit off their person, half-visible people still get ghost bodies, and hard poses like the guitar player or the seated man are poor in both models. All of this is by eye: the gender number on Relative Human for the final model is not run yet; for v5 it was 46.5 percent, which is chance.</a:t>
+              <a:t>This is the final model on real photos, next to v5, judged by eye. These are three of the twelve demo images: a photo from our example set and two 3DPW test frames that no model trained on; v5 on the left, the final model on the right. The clearest change is the body shape of the men. v5 gave them breasts and wide hips; the final model gives most of them a flat chest and broader shoulders: three of the four men on the tennis photo, both men in the walking frame, the man on the phone, the guitar player and the seated man in the WhatsApp photo. Women stay female, and the bodies look a little larger, which fits the size ratio going from 0.63 to 0.78 on the synthetic holdout. What did not change: the boy in the garden photo still gets an adult body, some bodies still sit off their person, half-visible people still get ghost bodies, and hard poses like the guitar player or the seated man are poor in both models. The pictures are judged by eye, but the gender change is now also measured: on Relative Human, gender accuracy goes from 46.5 percent for v5, which is chance, to 64 percent for the final model; women are recognised, men are still in the middle. The same run separates children from adults better, an AUC of 0.72 against 0.61, and finds 65 percent of the people instead of 47 (job 3612131, slide 10).</a:t>
             </a:r>
           </a:p>
           <a:p>
@@ -1381,13 +1437,13 @@
           <a:p>
             <a:r>
               <a:rPr lang="en-US" dirty="0"/>
-              <a:t>- The log's predicted gender, over all 12 images: v5 0.32 to 0.76, median 0.59, close to the training median; the final model 0.05 to 0.99, median 0.90. So the shape head now gives clear values instead of the middle. The log does not settle the direction: zero is male in Anny, and in the frame with the man on the phone every value is below 0.5, but on the tennis photo, where the men look male, most values are above 0.7, and the log does not say which value belongs to which body. Other shape values moved too and likely add to the male look: muscle, median 0.28 to 0.48, and proportions, 0.81 to 0.57. Age: v5 0.50 to 0.77, the final model 0.42 to 0.65.</a:t>
+              <a:t>- The log's predicted gender, over all 12 images: v5 0.32 to 0.76, median 0.59, close to the training median; the final model 0.05 to 0.99, median 0.90. So the shape head now gives clear values instead of the middle. The demo log alone does not settle the direction; Relative Human does, on average (next point): zero is male in Anny, and in the frame with the man on the phone every value is below 0.5, but on the tennis photo, where the men look male, most values are above 0.7, and the log does not say which value belongs to which body. Other shape values moved too and likely add to the male look: muscle, median 0.28 to 0.48, and proportions, 0.81 to 0.57. Age: v5 0.50 to 0.77, the final model 0.42 to 0.65.</a:t>
             </a:r>
           </a:p>
           <a:p>
             <a:r>
               <a:rPr lang="en-US" dirty="0"/>
-              <a:t>- The Relative Human run is one job with the final model's checkpoint, the same evaluation as slide 10; it gives gender accuracy, the children's age and recall. Until it has run, gender is by eye only.</a:t>
+              <a:t>- Relative Human, job 3612131: the final model's checkpoint, the same evaluation as slide 10. Gender accuracy is 0.642 over 1,308 people of known gender; the mean predicted gender is 0.86 for women and 0.55 for men. So on average the direction is right, high values are female as in Anny, and most of the errors are likely men in the middle. The pictures themselves stay a by-eye judgement.</a:t>
             </a:r>
           </a:p>
           <a:p>
@@ -1480,7 +1536,7 @@
           <a:p>
             <a:r>
               <a:rPr lang="en-US" dirty="0"/>
-              <a:t>Seven things are still open. First, the bone flips. The fix now holds in the 10-epoch final model, with real photos in training: neck02 4.8 degrees and fingers 8.3 (slide 16). The holdout renders of the correction alone show normal necks, and so, by eye, do the 8 real images I have seen so far from a first demo of the 2-epoch model; real images have no neck metric. v10's left arm has the same kind of flip, but a bone further down the arm undoes it, so it needs a two-sided correction, not built yet. Second, the depth slope: 0.42 in the final model, about as good as the best pilots but far from 1; cause unknown. Third, the cost of the depth fix: now measured in the final model against its control, PVE within the noise and recall 2 points lower; a comparison paired on the same people is still to do. Fourth, pilot noise: fix the seed or repeat key runs. Fifth, people very close to the camera. Sixth, children and fingers: children are now measured on real photos with age labels, the Relative Human dataset: the model reads them as short adults, and age separates them from adults with an AUC of only 0.61 (slide 10); the decision is a limitation or weak age labels. For fingers, a look at the hands with the bone fix. Seventh, 3DPW: the labels had three defects. The missing labels came back on 16 October, when I re-extracted the images of eight sequences; train went from 4,451 to 6,437 label images. The re-fit with the gender and frame-grid fixes finished on 18 October, and the check on the new labels passes with a warning, with no defect left (slide 6). They are in use: the final model and its control trained on them on 18 October, after a short smoke test of the whole recipe passed (slide 16).</a:t>
+              <a:t>Seven things are still open. First, the bone flips. The fix now holds in the 10-epoch final model, with real photos in training: neck02 4.8 degrees and fingers 8.3 (slide 16). The holdout renders of the correction alone show normal necks, and so, by eye, do the 8 real images I have seen so far from a first demo of the 2-epoch model; real images have no neck metric. v10's left arm has the same kind of flip, but a bone further down the arm undoes it, so it needs a two-sided correction, not built yet. Second, the depth slope: 0.42 in the final model, about as good as the best pilots but far from 1; cause unknown. Third, the cost of the depth fix: now measured in the final model against its control, PVE within the noise and recall 2 points lower; a comparison paired on the same people is still to do. Fourth, pilot noise: fix the seed or repeat key runs. Fifth, people very close to the camera. Sixth, children and fingers: children are now measured on real photos with age labels, the Relative Human dataset: v5 reads them as short adults, and age separates them from adults with an AUC of only 0.61; the final model does better, 0.72, but children still get near-adult ages (slide 10); the decision is a limitation or weak age labels. For fingers, a look at the hands with the bone fix. Seventh, 3DPW: the labels had three defects. The missing labels came back on 16 October, when I re-extracted the images of eight sequences; train went from 4,451 to 6,437 label images. The re-fit with the gender and frame-grid fixes finished on 18 October, and the check on the new labels passes with a warning, with no defect left (slide 6). They are in use: the final model and its control trained on them on 18 October, after a short smoke test of the whole recipe passed (slide 16).</a:t>
             </a:r>
           </a:p>
           <a:p>
@@ -1576,7 +1632,7 @@
           <a:p>
             <a:r>
               <a:rPr lang="en-US" dirty="0"/>
-              <a:t>What I claim, measured. The failures are not rig or decoding problems. A training-target bug puts people too far away in v5, v9 and v10; the fix draws bodies much closer to their true size. In the v5 line, neck02 and the head bone sit half a turn off, and two flipped hand bones were about half the finger error; a fixed correction turns them back. The 3DPW labels had three defects; a re-fit fixed them, and the new labels pass the check with a warning (slide 6). And the final model, with all fixes together, keeps every fix against its own control: the root error is 48 percent lower, neck02 is 4.8 degrees, the fingers 8.3, PA-PVE 50.3 against 56.4 millimetres, and on the 3DPW test the PVE is 89.0 against 91.5, against 95.5 for v9, the previous best, and 121.8 for v5 (slide 16). What I do not claim: results proven over several seeds, since each arm ran once; why the bones flipped; better children; correct depth for near and far people, since the slope is still 0.42; fixes without a cost, since recall is 2 points below the control and 3 below v5; that the fixes made most of the 3DPW gain, because training on 3DPW at all did most of it and the fixes add 2.5 millimetres; and a gender number for the final model: on real photos men now look male, but only by eye (slide 17). On last week's question, v9 now or the labels first: I went ahead with the labels first, then fine-tuned v5; that is the final model. My question now: do I write up, or also add weak age labels for children, which is one to two weeks of work?</a:t>
+              <a:t>What I claim, measured. The failures are not rig or decoding problems. A training-target bug puts people too far away in v5, v9 and v10; the fix draws bodies much closer to their true size. In the v5 line, neck02 and the head bone sit half a turn off, and two flipped hand bones were about half the finger error; a fixed correction turns them back. The 3DPW labels had three defects; a re-fit fixed them, and the new labels pass the check with a warning (slide 6). And the final model, with all fixes together, keeps every fix against its own control: the root error is 48 percent lower, neck02 is 4.8 degrees, the fingers 8.3, PA-PVE 50.3 against 56.4 millimetres, and on the 3DPW test the PVE is 89.0 against 91.5, against 95.5 for v9, the previous best, and 121.8 for v5 (slide 16). On Relative Human, the final model is better than v5 on every line: gender accuracy 46 to 64 percent, child-vs-adult AUC 0.61 to 0.72, recall 47 to 65 percent (slide 10). What I do not claim: results proven over several seeds, since each arm ran once; why the bones flipped; that children or gender are solved, since men are still in the middle and children still get near-adult ages; correct depth for near and far people, since the slope is still 0.42; fixes without a cost, since recall is 2 points below the control and 3 below v5; that the fixes made most of the 3DPW gain, because training on 3DPW at all did most of it and the fixes add 2.5 millimetres; and a model that is not Multi-HMR: that requirement is still open (next slide). On last week's question, v9 now or the labels first: I went ahead with the labels first, then fine-tuned v5; that is the final model. I have four questions now. First, for the smaller model: is the 95 percent bar against our ViT-L, against NAVER's, or both, and does a smaller Multi-HMR-style student count as not exactly Multi-HMR? Second, does a temporal refiner on frozen per-frame features count as understanding motion? Third, children: a stated limitation, or weak age labels from Relative Human, one to two weeks? Fourth, what is the submission date?</a:t>
             </a:r>
           </a:p>
           <a:p>
@@ -1639,7 +1695,7 @@
           <a:p>
             <a:r>
               <a:rPr lang="en-US" dirty="0"/>
-              <a:t>- Both options: either fine-tune should also mask the 3DPW finger labels, which are set to the rest pose, with mask_3dpw_hands; the final model does. A new flag can also leave out the eight 3DPW shape values that are constants, age 0.55 and seven at 0.5; it is off by default, and the final model has it off (slide 10). With it on, the 3DPW error can change for a reason unrelated to the two fixes.</a:t>
+              <a:t>- Both options: either fine-tune should also mask the 3DPW finger labels, which are set to the rest pose, with mask_3dpw_hands; the final model does. A new flag can also leave out the eight 3DPW shape values that are constants, age 0.55 and seven at 0.5; it is off by default and off in the final model; a run with it on is in progress (slide 10). With it on, the 3DPW error can change for a reason unrelated to the two fixes.</a:t>
             </a:r>
           </a:p>
         </p:txBody>
@@ -1813,7 +1869,58 @@
           <a:p>
             <a:r>
               <a:rPr lang="en-US" dirty="0"/>
-              <a:t>A second holdout example, in case there is a question. Before the fix the boy's real head sticks out above a shrunken mesh that floats. After the fix the top of the head is level with the truth; the after mesh is cut off at the bottom of the image, so I cannot measure its full height. Here the fixed mesh is a little larger and wider than the ground truth, so I do not call it an exact fit. The two large people in front have no ground-truth mesh, so they are not counted as misses.</a:t>
+              <a:t>This slide puts your list of requirements next to what we have today. Two are met: 3DPW is converted to Anny space with the corrected labels, which pass our own check on all 60 sequences and the independent check with a warning that comes from the differences between the two body models; and the 3DPW training set is used in training, as 30 percent of every batch of the final model. Pose is partly there: the neck and finger flips are fixed, and the final model is our best on the 3DPW test with 89.0 millimetres, but the depth slope is 0.42, some bodies sit off their person, hard poses are poor, and I have not yet shown predicted hands on real photos, because every real-photo demo so far relaxes the fingers. Shape is partly there and at risk: gender now changes per person, 64 percent correct on Relative Human, and age partly, but muscle, weight, cup size and firmness sit near 0.5, the values the 3DPW labels fix; the masked run tests that. Requirement 1b is not met, and I want to be clear about it: our model is the upstream Multi-HMR with its output layer resized for Anny and a bone correction that adds no parameters, and its backbone weights come from NAVER's Anny checkpoint. My proposed route is the smaller-model option: a ViT-B student distilled from the final model, about 101 million parameters and 603 GFLOPs against 318 million and 1,927 for our ViT-L, so 3.1 times fewer parameters and 3.2 times fewer FLOPs, with the milliseconds per image measured. The bar I set myself is at most 1.05 times the error of the larger model on both AnnyOne and 3DPW, reported against our ViT-L and against NAVER's ViT-L. The risk: NAVER's own ViT-B is about 15 percent worse than its ViT-L on synthetic BEDLAM data, so AnnyOne may miss the bar; it is one long job, I launch it on Tuesday, and the first result comes around 8 November. Temporal modelling has not started; my plan is a small refiner on top of the frozen per-frame model, in month two. The report has a draft, whose 74 millimetre headline must become 70.5, and the code needs a clean-up before you can check it: paths hard-coded to our cluster in 98 files, and no results or checkpoints committed.</a:t>
+            </a:r>
+          </a:p>
+          <a:p>
+            <a:endParaRPr lang="en-US" dirty="0"/>
+          </a:p>
+          <a:p>
+            <a:r>
+              <a:rPr lang="en-US" dirty="0"/>
+              <a:t>If asked:</a:t>
+            </a:r>
+          </a:p>
+          <a:p>
+            <a:r>
+              <a:rPr lang="en-US" dirty="0"/>
+              <a:t>- NAVER's checkpoint: multiHMR_672_L_anny has a different head, with eight layers, so it is a real baseline and not our weights under another name. I have written an adapter to evaluate it with our code, but it has not run yet; until it has, I do not know whether our model beats it.</a:t>
+            </a:r>
+          </a:p>
+          <a:p>
+            <a:r>
+              <a:rPr lang="en-US" dirty="0"/>
+              <a:t>- FLOPs: counted analytically from the layer shapes at 672 pixels, with one multiply-add counted as two FLOPs; the ViT-L backbone alone is about 1,917 of the 1,927 GFLOPs. NAVER's ViT-L at about 414 million parameters is a hand estimate. The milliseconds will be measured on one GPU, both models on the same GPU.</a:t>
+            </a:r>
+          </a:p>
+          <a:p>
+            <a:r>
+              <a:rPr lang="en-US" dirty="0"/>
+              <a:t>- Why ViT-B first: it is the smallest step with a fair chance at the bar; it reuses the distillation code that already ran four times; and NAVER's own ViT-B equals its ViT-L on 3DPW, 94.0 against 94.1. Our old ViT-S students had 1.17 to 1.54 times their teacher's error, on the old labels. A completely new architecture that beats Multi-HMR on both test sets is not realistic in four weeks.</a:t>
+            </a:r>
+          </a:p>
+          <a:p>
+            <a:r>
+              <a:rPr lang="en-US" dirty="0"/>
+              <a:t>- Whether a smaller Multi-HMR-style student counts as not exactly Multi-HMR is your call, because NAVER ships its own ViT-B; that is my first question on the previous slide.</a:t>
+            </a:r>
+          </a:p>
+          <a:p>
+            <a:r>
+              <a:rPr lang="en-US" dirty="0"/>
+              <a:t>- Temporal design, in one sentence: a two-layer transformer over 16-frame windows of the frozen per-person tokens, with the shape pooled over each track, trained on 3DPW-train tracks and judged by acceleration error and PVE against simple smoothing baselines.</a:t>
+            </a:r>
+          </a:p>
+          <a:p>
+            <a:r>
+              <a:rPr lang="en-US" dirty="0"/>
+              <a:t>- Timeline: part one closes around 15 November, with no buffer; temporal in weeks five and six; the last two weeks for writing, the release and a buffer.</a:t>
+            </a:r>
+          </a:p>
+          <a:p>
+            <a:r>
+              <a:rPr lang="en-US" dirty="0"/>
+              <a:t>- 3DPW in Anny space has limits I will state: hands, neck and head stay at rest in the converted labels, and eight shape values are constants, so 3DPW tests pose plus gender, height and proportions, not full shape; and our MPJPE averages all 163 Anny joints, so it does not compare with published 3DPW numbers.</a:t>
             </a:r>
           </a:p>
         </p:txBody>
@@ -1836,6 +1943,93 @@
             <a:fld id="{F7021451-1387-4CA6-816F-3879F97B5CBC}" type="slidenum">
               <a:rPr lang="en-US"/>
               <a:t>20</a:t>
+            </a:fld>
+            <a:endParaRPr lang="en-US"/>
+          </a:p>
+        </p:txBody>
+      </p:sp>
+    </p:spTree>
+    <p:extLst>
+      <p:ext uri="{BB962C8B-B14F-4D97-AF65-F5344CB8AC3E}">
+        <p14:creationId xmlns:p14="http://schemas.microsoft.com/office/powerpoint/2010/main" val="1024086991"/>
+      </p:ext>
+    </p:extLst>
+  </p:cSld>
+  <p:clrMapOvr>
+    <a:masterClrMapping/>
+  </p:clrMapOvr>
+</p:notes>
+</file>
+
+<file path=ppt/notesSlides/notesSlide21.xml><?xml version="1.0" encoding="utf-8"?>
+<p:notes xmlns:a="http://schemas.openxmlformats.org/drawingml/2006/main" xmlns:r="http://schemas.openxmlformats.org/officeDocument/2006/relationships" xmlns:p="http://schemas.openxmlformats.org/presentationml/2006/main">
+  <p:cSld>
+    <p:spTree>
+      <p:nvGrpSpPr>
+        <p:cNvPr id="1" name=""/>
+        <p:cNvGrpSpPr/>
+        <p:nvPr/>
+      </p:nvGrpSpPr>
+      <p:grpSpPr>
+        <a:xfrm>
+          <a:off x="0" y="0"/>
+          <a:ext cx="0" cy="0"/>
+          <a:chOff x="0" y="0"/>
+          <a:chExt cx="0" cy="0"/>
+        </a:xfrm>
+      </p:grpSpPr>
+      <p:sp>
+        <p:nvSpPr>
+          <p:cNvPr id="2" name="Slide Image Placeholder 1"/>
+          <p:cNvSpPr>
+            <a:spLocks noGrp="1" noRot="1" noChangeAspect="1"/>
+          </p:cNvSpPr>
+          <p:nvPr>
+            <p:ph type="sldImg"/>
+          </p:nvPr>
+        </p:nvSpPr>
+        <p:spPr/>
+      </p:sp>
+      <p:sp>
+        <p:nvSpPr>
+          <p:cNvPr id="3" name="Notes Placeholder 2"/>
+          <p:cNvSpPr>
+            <a:spLocks noGrp="1"/>
+          </p:cNvSpPr>
+          <p:nvPr>
+            <p:ph type="body" idx="1"/>
+          </p:nvPr>
+        </p:nvSpPr>
+        <p:spPr/>
+        <p:txBody>
+          <a:bodyPr/>
+          <a:lstStyle/>
+          <a:p>
+            <a:r>
+              <a:rPr lang="en-US" dirty="0"/>
+              <a:t>A second holdout example, in case there is a question. Before the fix the boy's real head sticks out above a shrunken mesh that floats. After the fix the top of the head is level with the truth; the after mesh is cut off at the bottom of the image, so I cannot measure its full height. Here the fixed mesh is a little larger and wider than the ground truth, so I do not call it an exact fit. The two large people in front have no ground-truth mesh, so they are not counted as misses.</a:t>
+            </a:r>
+          </a:p>
+        </p:txBody>
+      </p:sp>
+      <p:sp>
+        <p:nvSpPr>
+          <p:cNvPr id="4" name="Slide Number Placeholder 3"/>
+          <p:cNvSpPr>
+            <a:spLocks noGrp="1"/>
+          </p:cNvSpPr>
+          <p:nvPr>
+            <p:ph type="sldNum" sz="quarter" idx="10"/>
+          </p:nvPr>
+        </p:nvSpPr>
+        <p:spPr/>
+        <p:txBody>
+          <a:bodyPr/>
+          <a:lstStyle/>
+          <a:p>
+            <a:fld id="{F7021451-1387-4CA6-816F-3879F97B5CBC}" type="slidenum">
+              <a:rPr lang="en-US"/>
+              <a:t>21</a:t>
             </a:fld>
             <a:endParaRPr lang="en-US"/>
           </a:p>
@@ -2428,7 +2622,7 @@
           <a:p>
             <a:r>
               <a:rPr lang="en-US" dirty="0"/>
-              <a:t>- Men: in both models, adult men on real photos get female-looking bodies, with breasts and narrow shoulders, for example the male tennis players. v5 never saw 3DPW, so this is not the gender defect in our 3DPW labels. The demo log shows predicted gender near the training median, about 0.6, while Anny's male end is 0: the same pull to the median as for age (slide 10). On Relative Human, measured on 932 real people, men get 0.535 on average and women 0.551: no gender signal. Whether the gap between synthetic and real images or the loss causes it is not settled. The final model, trained with the corrected 3DPW gender labels, gives most men male bodies, judged by eye (slide 17).</a:t>
+              <a:t>- Men: in both models, adult men on real photos get female-looking bodies, with breasts and narrow shoulders, for example the male tennis players. v5 never saw 3DPW, so this is not the gender defect in our 3DPW labels. The demo log shows predicted gender near the training median, about 0.6, while Anny's male end is 0: the same pull to the median as for age (slide 10). On Relative Human, measured on 932 real people, men get 0.535 on average and women 0.551: no gender signal. Whether the gap between synthetic and real images or the loss causes it is not settled. The final model, trained with the corrected 3DPW gender labels, gives most men male bodies, judged by eye (slide 17); on Relative Human its gender accuracy is 64 percent, against 46.5 for v5 (slide 10).</a:t>
             </a:r>
           </a:p>
           <a:p>
@@ -3592,7 +3786,7 @@
                   <a:schemeClr val="tx1"/>
                 </a:solidFill>
               </a:rPr>
-              <a:t>Children: child-like in training, adult on real photos</a:t>
+              <a:t>Children and gender: v5 vs the final model on real photos</a:t>
             </a:r>
             <a:endParaRPr lang="en-US" sz="2700" dirty="0"/>
           </a:p>
@@ -3600,7 +3794,7 @@
       </p:sp>
       <p:sp>
         <p:nvSpPr>
-          <p:cNvPr id="3" name="stat children in supervised training with the balanced sampler: unproven after 2 epochs"/>
+          <p:cNvPr id="3" name="stat children per batch with the balanced sampler: unproven after 2 epochs"/>
           <p:cNvSpPr txBox="1"/>
           <p:nvPr/>
         </p:nvSpPr>
@@ -3636,7 +3830,7 @@
       </p:sp>
       <p:sp>
         <p:nvSpPr>
-          <p:cNvPr id="4" name="label children in supervised training with the balanced sampler: unproven after 2 epochs"/>
+          <p:cNvPr id="4" name="label children per batch with the balanced sampler: unproven after 2 epochs"/>
           <p:cNvSpPr txBox="1"/>
           <p:nvPr/>
         </p:nvSpPr>
@@ -3664,7 +3858,7 @@
                   <a:schemeClr val="tx2"/>
                 </a:solidFill>
               </a:rPr>
-              <a:t>children in supervised training with the balanced sampler: unproven after 2 epochs</a:t>
+              <a:t>children per batch with the balanced sampler: unproven after 2 epochs</a:t>
             </a:r>
             <a:endParaRPr lang="en-US" sz="1300" dirty="0"/>
           </a:p>
@@ -3744,7 +3938,7 @@
       </p:sp>
       <p:sp>
         <p:nvSpPr>
-          <p:cNvPr id="7" name="stat predicted age of 127 real children vs 821 adults (Relative Human val); separation AUC 0.61"/>
+          <p:cNvPr id="7" name="stat child-vs-adult separation (AUC), v5 → final model, Relative Human val"/>
           <p:cNvSpPr txBox="1"/>
           <p:nvPr/>
         </p:nvSpPr>
@@ -3769,10 +3963,10 @@
             <a:r>
               <a:rPr lang="en-US" sz="4000" b="1" dirty="0">
                 <a:solidFill>
-                  <a:schemeClr val="accent4"/>
+                  <a:schemeClr val="accent1"/>
                 </a:solidFill>
               </a:rPr>
-              <a:t>0.61 vs 0.63</a:t>
+              <a:t>0.61 → 0.72</a:t>
             </a:r>
             <a:endParaRPr lang="en-US" sz="4000" dirty="0"/>
           </a:p>
@@ -3780,7 +3974,7 @@
       </p:sp>
       <p:sp>
         <p:nvSpPr>
-          <p:cNvPr id="8" name="label predicted age of 127 real children vs 821 adults (Relative Human val); separation AUC 0.61"/>
+          <p:cNvPr id="8" name="label child-vs-adult separation (AUC), v5 → final model, Relative Human val"/>
           <p:cNvSpPr txBox="1"/>
           <p:nvPr/>
         </p:nvSpPr>
@@ -3808,7 +4002,7 @@
                   <a:schemeClr val="tx2"/>
                 </a:solidFill>
               </a:rPr>
-              <a:t>predicted age of 127 real children vs 821 adults (Relative Human val); separation AUC 0.61</a:t>
+              <a:t>child-vs-adult separation (AUC), v5 → final model, Relative Human val</a:t>
             </a:r>
             <a:endParaRPr lang="en-US" sz="1300" dirty="0"/>
           </a:p>
@@ -3875,7 +4069,7 @@
                   <a:schemeClr val="tx1"/>
                 </a:solidFill>
               </a:rPr>
-              <a:t>The model can make a child: </a:t>
+              <a:t>v5 reads children as short adults: </a:t>
             </a:r>
             <a:r>
               <a:rPr lang="en-US" sz="1200" dirty="0">
@@ -3883,7 +4077,7 @@
                   <a:schemeClr val="tx1"/>
                 </a:solidFill>
               </a:rPr>
-              <a:t>no shape output is clamped; training babies come out child-like, but too old. True shape: 10 training children 47.8 → 41.6 mm.</a:t>
+              <a:t>age 0.61 kid / 0.62 baby vs 0.63 adult; only height drops (0.45 / 0.39 vs 0.51). Gender 46.5%: chance.</a:t>
             </a:r>
             <a:endParaRPr lang="en-US" sz="1200" dirty="0"/>
           </a:p>
@@ -3901,7 +4095,7 @@
                   <a:schemeClr val="tx1"/>
                 </a:solidFill>
               </a:rPr>
-              <a:t>Children are read as short adults: </a:t>
+              <a:t>Final model: </a:t>
             </a:r>
             <a:r>
               <a:rPr lang="en-US" sz="1200" dirty="0">
@@ -3909,7 +4103,7 @@
                   <a:schemeClr val="tx1"/>
                 </a:solidFill>
               </a:rPr>
-              <a:t>height 0.45 kid / 0.39 baby vs 0.51 adult; age unchanged (Relative Human val).</a:t>
+              <a:t>gender accuracy 46 → 64% (women recognised, men still mid-range); babies 0.44 vs adults 0.54; recall 47 → 65%.</a:t>
             </a:r>
             <a:endParaRPr lang="en-US" sz="1200" dirty="0"/>
           </a:p>
@@ -3927,7 +4121,7 @@
                   <a:schemeClr val="tx1"/>
                 </a:solidFill>
               </a:rPr>
-              <a:t>Gender: </a:t>
+              <a:t>Why (v5): </a:t>
             </a:r>
             <a:r>
               <a:rPr lang="en-US" sz="1200" dirty="0">
@@ -3935,7 +4129,7 @@
                   <a:schemeClr val="tx1"/>
                 </a:solidFill>
               </a:rPr>
-              <a:t>men 0.535, women 0.551: no gender signal on real photos.</a:t>
+              <a:t>the shape head falls back to the training median, synthetic and real. Sampler pilot: inconclusive.</a:t>
             </a:r>
             <a:endParaRPr lang="en-US" sz="1200" dirty="0"/>
           </a:p>
@@ -3953,7 +4147,7 @@
                   <a:schemeClr val="tx1"/>
                 </a:solidFill>
               </a:rPr>
-              <a:t>Diagnosis: </a:t>
+              <a:t>3DPW labels fix age at 0.55: </a:t>
             </a:r>
             <a:r>
               <a:rPr lang="en-US" sz="1200" dirty="0">
@@ -3961,7 +4155,7 @@
                   <a:schemeClr val="tx1"/>
                 </a:solidFill>
               </a:rPr>
-              <a:t>the shape head falls back to the training median, in both synthetic tails and on real photos. 2-epoch sampler pilot: inconclusive. Domain gap or loss: not yet separable.</a:t>
+              <a:t>likely part of the shift (adults 0.63 → 0.54). Run with those values masked: in progress.</a:t>
             </a:r>
             <a:endParaRPr lang="en-US" sz="1200" dirty="0"/>
           </a:p>
@@ -3987,7 +4181,7 @@
                   <a:schemeClr val="tx1"/>
                 </a:solidFill>
               </a:rPr>
-              <a:t>synthetic child numbers are in-sample (no children in the holdout); real-photo numbers cover detected people only (47%). Ages are Anny's 0–1 value, not years.</a:t>
+              <a:t>detected people only (948 v5, 1,305 final: different sets); synthetic child numbers in-sample; ages are Anny's 0–1 value.</a:t>
             </a:r>
             <a:endParaRPr lang="en-US" sz="1200" dirty="0"/>
           </a:p>
@@ -15064,7 +15258,7 @@
                   <a:schemeClr val="tx1"/>
                 </a:solidFill>
               </a:rPr>
-              <a:t>Gender on Relative Human: </a:t>
+              <a:t>Relative Human: </a:t>
             </a:r>
             <a:r>
               <a:rPr lang="en-US" sz="1400" dirty="0">
@@ -15072,7 +15266,7 @@
                   <a:schemeClr val="tx1"/>
                 </a:solidFill>
               </a:rPr>
-              <a:t>pending (v5: 46.5%, chance).</a:t>
+              <a:t>gender 46 → 64%, children AUC 0.61 → 0.72, recall 47 → 65% (job 3612131).</a:t>
             </a:r>
             <a:endParaRPr lang="en-US" sz="1400" dirty="0"/>
           </a:p>
@@ -15116,7 +15310,7 @@
                   <a:schemeClr val="tx2"/>
                 </a:solidFill>
               </a:rPr>
-              <a:t>demo job 3612078, 4 photos + 8 3DPW-test frames, never trained on. Shown: the tennis photo, downtown_walking_00, downtown_runForBus_00. Judged by eye; no metric.</a:t>
+              <a:t>demo job 3612078, 4 photos + 8 3DPW-test frames, never trained on. Shown: the tennis photo, downtown_walking_00, downtown_runForBus_00. Pictures judged by eye; the Relative Human line is measured (val split).</a:t>
             </a:r>
             <a:endParaRPr lang="en-US" sz="1100" dirty="0"/>
           </a:p>
@@ -16022,7 +16216,7 @@
                   <a:schemeClr val="tx2"/>
                 </a:solidFill>
               </a:rPr>
-              <a:t>Children: measured on Relative Human (AUC 0.61, read as short adults); decision: limitation or weak labels. Fingers: bone-fix hands, then larger crops.</a:t>
+              <a:t>Children: Relative Human AUC 0.61 (v5) → 0.72 (final), not solved; limitation or weak labels? Fingers: bone-fix hands, then larger crops.</a:t>
             </a:r>
             <a:endParaRPr lang="en-US" sz="1200" dirty="0"/>
           </a:p>
@@ -16309,7 +16503,7 @@
                   <a:schemeClr val="bg2"/>
                 </a:solidFill>
               </a:rPr>
-              <a:t>the failures are not rig or decoding problems. A training-target bug puts people too far away in v5, v9 and v10. In all 8 v5-line checkpoints, neck02 and the head bone sit half a turn off; two flipped hand bones were half the finger error. 3DPW labels: three defects fixed by a re-fit (slide 6). The final model keeps every fix against its own control: root error −48%, neck02 4.8°, fingers 8.3°, PA-PVE 50.3 vs 56.4 mm, 3DPW test PVE 89.0 mm, best of all models (control 91.5, v9 95.5, v5 121.8; slide 16).</a:t>
+              <a:t>the failures are not rig or decoding problems. A training-target bug puts people too far away in v5, v9 and v10. In the v5 line, neck02 and the head bone sit half a turn off; two flipped hand bones were half the finger error. 3DPW labels: three defects fixed by a re-fit (slide 6). The final model keeps every fix against its control: root error −48%, neck02 4.8°, fingers 8.3°, PA-PVE 50.3 vs 56.4 mm; 3DPW test 89.0 mm, our best (v9 95.5, v5 121.8; slide 16). Relative Human, v5 → final: gender 46 → 64%, children AUC 0.61 → 0.72 (slide 10).</a:t>
             </a:r>
             <a:endParaRPr lang="en-US" sz="1500" dirty="0"/>
           </a:p>
@@ -16331,7 +16525,7 @@
                   <a:schemeClr val="bg2"/>
                 </a:solidFill>
               </a:rPr>
-              <a:t>results proven over seeds (one run each) or why the bones flipped; better children; correct near/far depths (slope 0.42); fixes without cost (recall −2 points vs the control, −3 vs v5); that the fixes made most of the 3DPW gain (3DPW training did); head turn, age or limb lengths in the 3DPW labels.</a:t>
+              <a:t>results proven over seeds (one run each) or why the bones flipped; children or gender solved (men still mid-range); correct near/far depths (slope 0.42); fixes without cost (recall −2 points vs the control); that the fixes made most of the 3DPW gain; a model that is not Multi-HMR (slide 20).</a:t>
             </a:r>
             <a:endParaRPr lang="en-US" sz="1500" dirty="0"/>
           </a:p>
@@ -16410,50 +16604,84 @@
           <a:p>
             <a:pPr indent="0" marL="0">
               <a:spcAft>
-                <a:spcPts val="400"/>
+                <a:spcPts val="300"/>
               </a:spcAft>
               <a:buNone/>
             </a:pPr>
             <a:r>
-              <a:rPr lang="en-US" sz="1300" b="1" dirty="0">
+              <a:rPr lang="en-US" sz="1200" b="1" dirty="0">
                 <a:solidFill>
                   <a:srgbClr val="F4C95D"/>
                 </a:solidFill>
               </a:rPr>
-              <a:t>Question for you</a:t>
-            </a:r>
-            <a:endParaRPr lang="en-US" sz="1300" dirty="0"/>
+              <a:t>Questions for you</a:t>
+            </a:r>
+            <a:endParaRPr lang="en-US" sz="1200" dirty="0"/>
           </a:p>
           <a:p>
             <a:pPr indent="0" marL="0">
               <a:spcAft>
-                <a:spcPts val="400"/>
+                <a:spcPts val="200"/>
               </a:spcAft>
               <a:buNone/>
             </a:pPr>
             <a:r>
-              <a:rPr lang="en-US" sz="1300" b="1" dirty="0">
+              <a:rPr lang="en-US" sz="1200" dirty="0">
                 <a:solidFill>
                   <a:srgbClr val="EEF2F7"/>
                 </a:solidFill>
               </a:rPr>
-              <a:t>Chosen: fix gender and frame grid, re-fit all 3DPW tasks, then fine-tune v5 (done 18 Oct: slide 16). Next: write up, or also add weak age labels for children (1–2 weeks)?</a:t>
-            </a:r>
-            <a:endParaRPr lang="en-US" sz="1300" dirty="0"/>
+              <a:t>1. (1b) Is the 95% bar against our ViT-L, NAVER's, or both? Does a smaller Multi-HMR-style student count as “not exactly Multi-HMR”?</a:t>
+            </a:r>
+            <a:endParaRPr lang="en-US" sz="1200" dirty="0"/>
+          </a:p>
+          <a:p>
+            <a:pPr indent="0" marL="0">
+              <a:spcAft>
+                <a:spcPts val="200"/>
+              </a:spcAft>
+              <a:buNone/>
+            </a:pPr>
+            <a:r>
+              <a:rPr lang="en-US" sz="1200" dirty="0">
+                <a:solidFill>
+                  <a:srgbClr val="EEF2F7"/>
+                </a:solidFill>
+              </a:rPr>
+              <a:t>2. (2b) Does a temporal refiner on frozen per-frame features count as “understands motion”?</a:t>
+            </a:r>
+            <a:endParaRPr lang="en-US" sz="1200" dirty="0"/>
+          </a:p>
+          <a:p>
+            <a:pPr indent="0" marL="0">
+              <a:spcAft>
+                <a:spcPts val="200"/>
+              </a:spcAft>
+              <a:buNone/>
+            </a:pPr>
+            <a:r>
+              <a:rPr lang="en-US" sz="1200" dirty="0">
+                <a:solidFill>
+                  <a:srgbClr val="EEF2F7"/>
+                </a:solidFill>
+              </a:rPr>
+              <a:t>3. Children: a stated limitation, or weak age labels from Relative Human (1–2 weeks)?</a:t>
+            </a:r>
+            <a:endParaRPr lang="en-US" sz="1200" dirty="0"/>
           </a:p>
           <a:p>
             <a:pPr indent="0" marL="0">
               <a:buNone/>
             </a:pPr>
             <a:r>
-              <a:rPr lang="en-US" sz="1300" dirty="0">
+              <a:rPr lang="en-US" sz="1200" dirty="0">
                 <a:solidFill>
                   <a:srgbClr val="EEF2F7"/>
                 </a:solidFill>
               </a:rPr>
-              <a:t>v9 also has the neck flip (measured at epoch 149) and needs its own bone fix; v10 has a similar left-arm flip.</a:t>
-            </a:r>
-            <a:endParaRPr lang="en-US" sz="1300" dirty="0"/>
+              <a:t>4. When is the submission date?</a:t>
+            </a:r>
+            <a:endParaRPr lang="en-US" sz="1200" dirty="0"/>
           </a:p>
         </p:txBody>
       </p:sp>
@@ -17093,6 +17321,2158 @@
                   <a:schemeClr val="tx1"/>
                 </a:solidFill>
               </a:rPr>
+              <a:t>Thesis requirements: where we stand, and the plan</a:t>
+            </a:r>
+            <a:endParaRPr lang="en-US" sz="2700" dirty="0"/>
+          </a:p>
+        </p:txBody>
+      </p:sp>
+      <p:graphicFrame>
+        <p:nvGraphicFramePr>
+          <p:cNvPr id="21" name="requirements table"/>
+          <p:cNvGraphicFramePr>
+            <a:graphicFrameLocks noGrp="1"/>
+          </p:cNvGraphicFramePr>
+          <p:nvPr>
+            <p:extLst>
+              <p:ext uri="{D42A27DB-BD31-4B8C-83A1-F6EECF244321}">
+                <p14:modId xmlns:p14="http://schemas.microsoft.com/office/powerpoint/2010/main" val="1579011935"/>
+              </p:ext>
+            </p:extLst>
+          </p:nvPr>
+        </p:nvGraphicFramePr>
+        <p:xfrm>
+          <a:off x="457200" y="1051560"/>
+          <a:ext cx="8229600" cy="914400"/>
+        </p:xfrm>
+        <a:graphic>
+          <a:graphicData uri="http://schemas.openxmlformats.org/drawingml/2006/table">
+            <a:tbl>
+              <a:tblPr/>
+              <a:tblGrid>
+                <a:gridCol w="1691640"/>
+                <a:gridCol w="868680"/>
+                <a:gridCol w="3383280"/>
+                <a:gridCol w="2286000"/>
+              </a:tblGrid>
+              <a:tr h="274320">
+                <a:tc>
+                  <a:txBody>
+                    <a:bodyPr/>
+                    <a:lstStyle/>
+                    <a:p>
+                      <a:pPr algn="l" indent="0" marL="0">
+                        <a:buNone/>
+                      </a:pPr>
+                      <a:r>
+                        <a:rPr lang="en-US" sz="1050" b="1" dirty="0">
+                          <a:solidFill>
+                            <a:srgbClr val="FFFFFF"/>
+                          </a:solidFill>
+                        </a:rPr>
+                        <a:t>requirement</a:t>
+                      </a:r>
+                      <a:endParaRPr lang="en-US" sz="1050" dirty="0"/>
+                    </a:p>
+                  </a:txBody>
+                  <a:tcPr marL="54864" marR="54864" marT="27432" marB="27432" anchor="ctr">
+                    <a:lnL w="12700" cap="flat" cmpd="sng" algn="ctr">
+                      <a:solidFill>
+                        <a:srgbClr val="FFFFFF"/>
+                      </a:solidFill>
+                      <a:prstDash val="solid"/>
+                      <a:round/>
+                      <a:headEnd type="none" w="med" len="med"/>
+                      <a:tailEnd type="none" w="med" len="med"/>
+                    </a:lnL>
+                    <a:lnR w="12700" cap="flat" cmpd="sng" algn="ctr">
+                      <a:solidFill>
+                        <a:srgbClr val="FFFFFF"/>
+                      </a:solidFill>
+                      <a:prstDash val="solid"/>
+                      <a:round/>
+                      <a:headEnd type="none" w="med" len="med"/>
+                      <a:tailEnd type="none" w="med" len="med"/>
+                    </a:lnR>
+                    <a:lnT w="12700" cap="flat" cmpd="sng" algn="ctr">
+                      <a:solidFill>
+                        <a:srgbClr val="FFFFFF"/>
+                      </a:solidFill>
+                      <a:prstDash val="solid"/>
+                      <a:round/>
+                      <a:headEnd type="none" w="med" len="med"/>
+                      <a:tailEnd type="none" w="med" len="med"/>
+                    </a:lnT>
+                    <a:lnB w="12700" cap="flat" cmpd="sng" algn="ctr">
+                      <a:solidFill>
+                        <a:srgbClr val="FFFFFF"/>
+                      </a:solidFill>
+                      <a:prstDash val="solid"/>
+                      <a:round/>
+                      <a:headEnd type="none" w="med" len="med"/>
+                      <a:tailEnd type="none" w="med" len="med"/>
+                    </a:lnB>
+                    <a:solidFill>
+                      <a:srgbClr val="1B2233"/>
+                    </a:solidFill>
+                  </a:tcPr>
+                </a:tc>
+                <a:tc>
+                  <a:txBody>
+                    <a:bodyPr/>
+                    <a:lstStyle/>
+                    <a:p>
+                      <a:pPr algn="l" indent="0" marL="0">
+                        <a:buNone/>
+                      </a:pPr>
+                      <a:r>
+                        <a:rPr lang="en-US" sz="1050" b="1" dirty="0">
+                          <a:solidFill>
+                            <a:srgbClr val="FFFFFF"/>
+                          </a:solidFill>
+                        </a:rPr>
+                        <a:t>status</a:t>
+                      </a:r>
+                      <a:endParaRPr lang="en-US" sz="1050" dirty="0"/>
+                    </a:p>
+                  </a:txBody>
+                  <a:tcPr marL="54864" marR="54864" marT="27432" marB="27432" anchor="ctr">
+                    <a:lnL w="12700" cap="flat" cmpd="sng" algn="ctr">
+                      <a:solidFill>
+                        <a:srgbClr val="FFFFFF"/>
+                      </a:solidFill>
+                      <a:prstDash val="solid"/>
+                      <a:round/>
+                      <a:headEnd type="none" w="med" len="med"/>
+                      <a:tailEnd type="none" w="med" len="med"/>
+                    </a:lnL>
+                    <a:lnR w="12700" cap="flat" cmpd="sng" algn="ctr">
+                      <a:solidFill>
+                        <a:srgbClr val="FFFFFF"/>
+                      </a:solidFill>
+                      <a:prstDash val="solid"/>
+                      <a:round/>
+                      <a:headEnd type="none" w="med" len="med"/>
+                      <a:tailEnd type="none" w="med" len="med"/>
+                    </a:lnR>
+                    <a:lnT w="12700" cap="flat" cmpd="sng" algn="ctr">
+                      <a:solidFill>
+                        <a:srgbClr val="FFFFFF"/>
+                      </a:solidFill>
+                      <a:prstDash val="solid"/>
+                      <a:round/>
+                      <a:headEnd type="none" w="med" len="med"/>
+                      <a:tailEnd type="none" w="med" len="med"/>
+                    </a:lnT>
+                    <a:lnB w="12700" cap="flat" cmpd="sng" algn="ctr">
+                      <a:solidFill>
+                        <a:srgbClr val="FFFFFF"/>
+                      </a:solidFill>
+                      <a:prstDash val="solid"/>
+                      <a:round/>
+                      <a:headEnd type="none" w="med" len="med"/>
+                      <a:tailEnd type="none" w="med" len="med"/>
+                    </a:lnB>
+                    <a:solidFill>
+                      <a:srgbClr val="1B2233"/>
+                    </a:solidFill>
+                  </a:tcPr>
+                </a:tc>
+                <a:tc>
+                  <a:txBody>
+                    <a:bodyPr/>
+                    <a:lstStyle/>
+                    <a:p>
+                      <a:pPr algn="l" indent="0" marL="0">
+                        <a:buNone/>
+                      </a:pPr>
+                      <a:r>
+                        <a:rPr lang="en-US" sz="1050" b="1" dirty="0">
+                          <a:solidFill>
+                            <a:srgbClr val="FFFFFF"/>
+                          </a:solidFill>
+                        </a:rPr>
+                        <a:t>evidence (18 Oct)</a:t>
+                      </a:r>
+                      <a:endParaRPr lang="en-US" sz="1050" dirty="0"/>
+                    </a:p>
+                  </a:txBody>
+                  <a:tcPr marL="54864" marR="54864" marT="27432" marB="27432" anchor="ctr">
+                    <a:lnL w="12700" cap="flat" cmpd="sng" algn="ctr">
+                      <a:solidFill>
+                        <a:srgbClr val="FFFFFF"/>
+                      </a:solidFill>
+                      <a:prstDash val="solid"/>
+                      <a:round/>
+                      <a:headEnd type="none" w="med" len="med"/>
+                      <a:tailEnd type="none" w="med" len="med"/>
+                    </a:lnL>
+                    <a:lnR w="12700" cap="flat" cmpd="sng" algn="ctr">
+                      <a:solidFill>
+                        <a:srgbClr val="FFFFFF"/>
+                      </a:solidFill>
+                      <a:prstDash val="solid"/>
+                      <a:round/>
+                      <a:headEnd type="none" w="med" len="med"/>
+                      <a:tailEnd type="none" w="med" len="med"/>
+                    </a:lnR>
+                    <a:lnT w="12700" cap="flat" cmpd="sng" algn="ctr">
+                      <a:solidFill>
+                        <a:srgbClr val="FFFFFF"/>
+                      </a:solidFill>
+                      <a:prstDash val="solid"/>
+                      <a:round/>
+                      <a:headEnd type="none" w="med" len="med"/>
+                      <a:tailEnd type="none" w="med" len="med"/>
+                    </a:lnT>
+                    <a:lnB w="12700" cap="flat" cmpd="sng" algn="ctr">
+                      <a:solidFill>
+                        <a:srgbClr val="FFFFFF"/>
+                      </a:solidFill>
+                      <a:prstDash val="solid"/>
+                      <a:round/>
+                      <a:headEnd type="none" w="med" len="med"/>
+                      <a:tailEnd type="none" w="med" len="med"/>
+                    </a:lnB>
+                    <a:solidFill>
+                      <a:srgbClr val="1B2233"/>
+                    </a:solidFill>
+                  </a:tcPr>
+                </a:tc>
+                <a:tc>
+                  <a:txBody>
+                    <a:bodyPr/>
+                    <a:lstStyle/>
+                    <a:p>
+                      <a:pPr algn="l" indent="0" marL="0">
+                        <a:buNone/>
+                      </a:pPr>
+                      <a:r>
+                        <a:rPr lang="en-US" sz="1050" b="1" dirty="0">
+                          <a:solidFill>
+                            <a:srgbClr val="FFFFFF"/>
+                          </a:solidFill>
+                        </a:rPr>
+                        <a:t>next</a:t>
+                      </a:r>
+                      <a:endParaRPr lang="en-US" sz="1050" dirty="0"/>
+                    </a:p>
+                  </a:txBody>
+                  <a:tcPr marL="54864" marR="54864" marT="27432" marB="27432" anchor="ctr">
+                    <a:lnL w="12700" cap="flat" cmpd="sng" algn="ctr">
+                      <a:solidFill>
+                        <a:srgbClr val="FFFFFF"/>
+                      </a:solidFill>
+                      <a:prstDash val="solid"/>
+                      <a:round/>
+                      <a:headEnd type="none" w="med" len="med"/>
+                      <a:tailEnd type="none" w="med" len="med"/>
+                    </a:lnL>
+                    <a:lnR w="12700" cap="flat" cmpd="sng" algn="ctr">
+                      <a:solidFill>
+                        <a:srgbClr val="FFFFFF"/>
+                      </a:solidFill>
+                      <a:prstDash val="solid"/>
+                      <a:round/>
+                      <a:headEnd type="none" w="med" len="med"/>
+                      <a:tailEnd type="none" w="med" len="med"/>
+                    </a:lnR>
+                    <a:lnT w="12700" cap="flat" cmpd="sng" algn="ctr">
+                      <a:solidFill>
+                        <a:srgbClr val="FFFFFF"/>
+                      </a:solidFill>
+                      <a:prstDash val="solid"/>
+                      <a:round/>
+                      <a:headEnd type="none" w="med" len="med"/>
+                      <a:tailEnd type="none" w="med" len="med"/>
+                    </a:lnT>
+                    <a:lnB w="12700" cap="flat" cmpd="sng" algn="ctr">
+                      <a:solidFill>
+                        <a:srgbClr val="FFFFFF"/>
+                      </a:solidFill>
+                      <a:prstDash val="solid"/>
+                      <a:round/>
+                      <a:headEnd type="none" w="med" len="med"/>
+                      <a:tailEnd type="none" w="med" len="med"/>
+                    </a:lnB>
+                    <a:solidFill>
+                      <a:srgbClr val="1B2233"/>
+                    </a:solidFill>
+                  </a:tcPr>
+                </a:tc>
+              </a:tr>
+              <a:tr h="384048">
+                <a:tc>
+                  <a:txBody>
+                    <a:bodyPr/>
+                    <a:lstStyle/>
+                    <a:p>
+                      <a:pPr algn="l" indent="0" marL="0">
+                        <a:buNone/>
+                      </a:pPr>
+                      <a:r>
+                        <a:rPr lang="en-US" sz="1050" b="1" dirty="0">
+                          <a:solidFill>
+                            <a:srgbClr val="1B2233"/>
+                          </a:solidFill>
+                        </a:rPr>
+                        <a:t>1c  3DPW in Anny space</a:t>
+                      </a:r>
+                      <a:endParaRPr lang="en-US" sz="1050" dirty="0"/>
+                    </a:p>
+                  </a:txBody>
+                  <a:tcPr marL="54864" marR="54864" marT="27432" marB="27432" anchor="ctr">
+                    <a:lnL w="12700" cap="flat" cmpd="sng" algn="ctr">
+                      <a:solidFill>
+                        <a:srgbClr val="FFFFFF"/>
+                      </a:solidFill>
+                      <a:prstDash val="solid"/>
+                      <a:round/>
+                      <a:headEnd type="none" w="med" len="med"/>
+                      <a:tailEnd type="none" w="med" len="med"/>
+                    </a:lnL>
+                    <a:lnR w="12700" cap="flat" cmpd="sng" algn="ctr">
+                      <a:solidFill>
+                        <a:srgbClr val="FFFFFF"/>
+                      </a:solidFill>
+                      <a:prstDash val="solid"/>
+                      <a:round/>
+                      <a:headEnd type="none" w="med" len="med"/>
+                      <a:tailEnd type="none" w="med" len="med"/>
+                    </a:lnR>
+                    <a:lnT w="12700" cap="flat" cmpd="sng" algn="ctr">
+                      <a:solidFill>
+                        <a:srgbClr val="FFFFFF"/>
+                      </a:solidFill>
+                      <a:prstDash val="solid"/>
+                      <a:round/>
+                      <a:headEnd type="none" w="med" len="med"/>
+                      <a:tailEnd type="none" w="med" len="med"/>
+                    </a:lnT>
+                    <a:lnB w="12700" cap="flat" cmpd="sng" algn="ctr">
+                      <a:solidFill>
+                        <a:srgbClr val="FFFFFF"/>
+                      </a:solidFill>
+                      <a:prstDash val="solid"/>
+                      <a:round/>
+                      <a:headEnd type="none" w="med" len="med"/>
+                      <a:tailEnd type="none" w="med" len="med"/>
+                    </a:lnB>
+                    <a:solidFill>
+                      <a:srgbClr val="FFFFFF"/>
+                    </a:solidFill>
+                  </a:tcPr>
+                </a:tc>
+                <a:tc>
+                  <a:txBody>
+                    <a:bodyPr/>
+                    <a:lstStyle/>
+                    <a:p>
+                      <a:pPr algn="l" indent="0" marL="0">
+                        <a:buNone/>
+                      </a:pPr>
+                      <a:r>
+                        <a:rPr lang="en-US" sz="1050" b="1" dirty="0">
+                          <a:solidFill>
+                            <a:srgbClr val="3BA55D"/>
+                          </a:solidFill>
+                        </a:rPr>
+                        <a:t>met</a:t>
+                      </a:r>
+                      <a:endParaRPr lang="en-US" sz="1050" dirty="0"/>
+                    </a:p>
+                  </a:txBody>
+                  <a:tcPr marL="54864" marR="54864" marT="27432" marB="27432" anchor="ctr">
+                    <a:lnL w="12700" cap="flat" cmpd="sng" algn="ctr">
+                      <a:solidFill>
+                        <a:srgbClr val="FFFFFF"/>
+                      </a:solidFill>
+                      <a:prstDash val="solid"/>
+                      <a:round/>
+                      <a:headEnd type="none" w="med" len="med"/>
+                      <a:tailEnd type="none" w="med" len="med"/>
+                    </a:lnL>
+                    <a:lnR w="12700" cap="flat" cmpd="sng" algn="ctr">
+                      <a:solidFill>
+                        <a:srgbClr val="FFFFFF"/>
+                      </a:solidFill>
+                      <a:prstDash val="solid"/>
+                      <a:round/>
+                      <a:headEnd type="none" w="med" len="med"/>
+                      <a:tailEnd type="none" w="med" len="med"/>
+                    </a:lnR>
+                    <a:lnT w="12700" cap="flat" cmpd="sng" algn="ctr">
+                      <a:solidFill>
+                        <a:srgbClr val="FFFFFF"/>
+                      </a:solidFill>
+                      <a:prstDash val="solid"/>
+                      <a:round/>
+                      <a:headEnd type="none" w="med" len="med"/>
+                      <a:tailEnd type="none" w="med" len="med"/>
+                    </a:lnT>
+                    <a:lnB w="12700" cap="flat" cmpd="sng" algn="ctr">
+                      <a:solidFill>
+                        <a:srgbClr val="FFFFFF"/>
+                      </a:solidFill>
+                      <a:prstDash val="solid"/>
+                      <a:round/>
+                      <a:headEnd type="none" w="med" len="med"/>
+                      <a:tailEnd type="none" w="med" len="med"/>
+                    </a:lnB>
+                    <a:solidFill>
+                      <a:srgbClr val="FFFFFF"/>
+                    </a:solidFill>
+                  </a:tcPr>
+                </a:tc>
+                <a:tc>
+                  <a:txBody>
+                    <a:bodyPr/>
+                    <a:lstStyle/>
+                    <a:p>
+                      <a:pPr algn="l" indent="0" marL="0">
+                        <a:buNone/>
+                      </a:pPr>
+                      <a:r>
+                        <a:rPr lang="en-US" sz="1050" dirty="0">
+                          <a:solidFill>
+                            <a:srgbClr val="1B2233"/>
+                          </a:solidFill>
+                        </a:rPr>
+                        <a:t>v23 labels: post-check PASS on 60 sequences; independent check WARN (body-model limits)</a:t>
+                      </a:r>
+                      <a:endParaRPr lang="en-US" sz="1050" dirty="0"/>
+                    </a:p>
+                  </a:txBody>
+                  <a:tcPr marL="54864" marR="54864" marT="27432" marB="27432" anchor="ctr">
+                    <a:lnL w="12700" cap="flat" cmpd="sng" algn="ctr">
+                      <a:solidFill>
+                        <a:srgbClr val="FFFFFF"/>
+                      </a:solidFill>
+                      <a:prstDash val="solid"/>
+                      <a:round/>
+                      <a:headEnd type="none" w="med" len="med"/>
+                      <a:tailEnd type="none" w="med" len="med"/>
+                    </a:lnL>
+                    <a:lnR w="12700" cap="flat" cmpd="sng" algn="ctr">
+                      <a:solidFill>
+                        <a:srgbClr val="FFFFFF"/>
+                      </a:solidFill>
+                      <a:prstDash val="solid"/>
+                      <a:round/>
+                      <a:headEnd type="none" w="med" len="med"/>
+                      <a:tailEnd type="none" w="med" len="med"/>
+                    </a:lnR>
+                    <a:lnT w="12700" cap="flat" cmpd="sng" algn="ctr">
+                      <a:solidFill>
+                        <a:srgbClr val="FFFFFF"/>
+                      </a:solidFill>
+                      <a:prstDash val="solid"/>
+                      <a:round/>
+                      <a:headEnd type="none" w="med" len="med"/>
+                      <a:tailEnd type="none" w="med" len="med"/>
+                    </a:lnT>
+                    <a:lnB w="12700" cap="flat" cmpd="sng" algn="ctr">
+                      <a:solidFill>
+                        <a:srgbClr val="FFFFFF"/>
+                      </a:solidFill>
+                      <a:prstDash val="solid"/>
+                      <a:round/>
+                      <a:headEnd type="none" w="med" len="med"/>
+                      <a:tailEnd type="none" w="med" len="med"/>
+                    </a:lnB>
+                    <a:solidFill>
+                      <a:srgbClr val="FFFFFF"/>
+                    </a:solidFill>
+                  </a:tcPr>
+                </a:tc>
+                <a:tc>
+                  <a:txBody>
+                    <a:bodyPr/>
+                    <a:lstStyle/>
+                    <a:p>
+                      <a:pPr algn="l" indent="0" marL="0">
+                        <a:buNone/>
+                      </a:pPr>
+                      <a:r>
+                        <a:rPr lang="en-US" sz="1050" dirty="0">
+                          <a:solidFill>
+                            <a:srgbClr val="1B2233"/>
+                          </a:solidFill>
+                        </a:rPr>
+                        <a:t>state the limits in the thesis</a:t>
+                      </a:r>
+                      <a:endParaRPr lang="en-US" sz="1050" dirty="0"/>
+                    </a:p>
+                  </a:txBody>
+                  <a:tcPr marL="54864" marR="54864" marT="27432" marB="27432" anchor="ctr">
+                    <a:lnL w="12700" cap="flat" cmpd="sng" algn="ctr">
+                      <a:solidFill>
+                        <a:srgbClr val="FFFFFF"/>
+                      </a:solidFill>
+                      <a:prstDash val="solid"/>
+                      <a:round/>
+                      <a:headEnd type="none" w="med" len="med"/>
+                      <a:tailEnd type="none" w="med" len="med"/>
+                    </a:lnL>
+                    <a:lnR w="12700" cap="flat" cmpd="sng" algn="ctr">
+                      <a:solidFill>
+                        <a:srgbClr val="FFFFFF"/>
+                      </a:solidFill>
+                      <a:prstDash val="solid"/>
+                      <a:round/>
+                      <a:headEnd type="none" w="med" len="med"/>
+                      <a:tailEnd type="none" w="med" len="med"/>
+                    </a:lnR>
+                    <a:lnT w="12700" cap="flat" cmpd="sng" algn="ctr">
+                      <a:solidFill>
+                        <a:srgbClr val="FFFFFF"/>
+                      </a:solidFill>
+                      <a:prstDash val="solid"/>
+                      <a:round/>
+                      <a:headEnd type="none" w="med" len="med"/>
+                      <a:tailEnd type="none" w="med" len="med"/>
+                    </a:lnT>
+                    <a:lnB w="12700" cap="flat" cmpd="sng" algn="ctr">
+                      <a:solidFill>
+                        <a:srgbClr val="FFFFFF"/>
+                      </a:solidFill>
+                      <a:prstDash val="solid"/>
+                      <a:round/>
+                      <a:headEnd type="none" w="med" len="med"/>
+                      <a:tailEnd type="none" w="med" len="med"/>
+                    </a:lnB>
+                    <a:solidFill>
+                      <a:srgbClr val="FFFFFF"/>
+                    </a:solidFill>
+                  </a:tcPr>
+                </a:tc>
+              </a:tr>
+              <a:tr h="384048">
+                <a:tc>
+                  <a:txBody>
+                    <a:bodyPr/>
+                    <a:lstStyle/>
+                    <a:p>
+                      <a:pPr algn="l" indent="0" marL="0">
+                        <a:buNone/>
+                      </a:pPr>
+                      <a:r>
+                        <a:rPr lang="en-US" sz="1050" b="1" dirty="0">
+                          <a:solidFill>
+                            <a:srgbClr val="1B2233"/>
+                          </a:solidFill>
+                        </a:rPr>
+                        <a:t>2a  3DPW-train used in training</a:t>
+                      </a:r>
+                      <a:endParaRPr lang="en-US" sz="1050" dirty="0"/>
+                    </a:p>
+                  </a:txBody>
+                  <a:tcPr marL="54864" marR="54864" marT="27432" marB="27432" anchor="ctr">
+                    <a:lnL w="12700" cap="flat" cmpd="sng" algn="ctr">
+                      <a:solidFill>
+                        <a:srgbClr val="FFFFFF"/>
+                      </a:solidFill>
+                      <a:prstDash val="solid"/>
+                      <a:round/>
+                      <a:headEnd type="none" w="med" len="med"/>
+                      <a:tailEnd type="none" w="med" len="med"/>
+                    </a:lnL>
+                    <a:lnR w="12700" cap="flat" cmpd="sng" algn="ctr">
+                      <a:solidFill>
+                        <a:srgbClr val="FFFFFF"/>
+                      </a:solidFill>
+                      <a:prstDash val="solid"/>
+                      <a:round/>
+                      <a:headEnd type="none" w="med" len="med"/>
+                      <a:tailEnd type="none" w="med" len="med"/>
+                    </a:lnR>
+                    <a:lnT w="12700" cap="flat" cmpd="sng" algn="ctr">
+                      <a:solidFill>
+                        <a:srgbClr val="FFFFFF"/>
+                      </a:solidFill>
+                      <a:prstDash val="solid"/>
+                      <a:round/>
+                      <a:headEnd type="none" w="med" len="med"/>
+                      <a:tailEnd type="none" w="med" len="med"/>
+                    </a:lnT>
+                    <a:lnB w="12700" cap="flat" cmpd="sng" algn="ctr">
+                      <a:solidFill>
+                        <a:srgbClr val="FFFFFF"/>
+                      </a:solidFill>
+                      <a:prstDash val="solid"/>
+                      <a:round/>
+                      <a:headEnd type="none" w="med" len="med"/>
+                      <a:tailEnd type="none" w="med" len="med"/>
+                    </a:lnB>
+                    <a:solidFill>
+                      <a:srgbClr val="EEF2F7"/>
+                    </a:solidFill>
+                  </a:tcPr>
+                </a:tc>
+                <a:tc>
+                  <a:txBody>
+                    <a:bodyPr/>
+                    <a:lstStyle/>
+                    <a:p>
+                      <a:pPr algn="l" indent="0" marL="0">
+                        <a:buNone/>
+                      </a:pPr>
+                      <a:r>
+                        <a:rPr lang="en-US" sz="1050" b="1" dirty="0">
+                          <a:solidFill>
+                            <a:srgbClr val="3BA55D"/>
+                          </a:solidFill>
+                        </a:rPr>
+                        <a:t>met</a:t>
+                      </a:r>
+                      <a:endParaRPr lang="en-US" sz="1050" dirty="0"/>
+                    </a:p>
+                  </a:txBody>
+                  <a:tcPr marL="54864" marR="54864" marT="27432" marB="27432" anchor="ctr">
+                    <a:lnL w="12700" cap="flat" cmpd="sng" algn="ctr">
+                      <a:solidFill>
+                        <a:srgbClr val="FFFFFF"/>
+                      </a:solidFill>
+                      <a:prstDash val="solid"/>
+                      <a:round/>
+                      <a:headEnd type="none" w="med" len="med"/>
+                      <a:tailEnd type="none" w="med" len="med"/>
+                    </a:lnL>
+                    <a:lnR w="12700" cap="flat" cmpd="sng" algn="ctr">
+                      <a:solidFill>
+                        <a:srgbClr val="FFFFFF"/>
+                      </a:solidFill>
+                      <a:prstDash val="solid"/>
+                      <a:round/>
+                      <a:headEnd type="none" w="med" len="med"/>
+                      <a:tailEnd type="none" w="med" len="med"/>
+                    </a:lnR>
+                    <a:lnT w="12700" cap="flat" cmpd="sng" algn="ctr">
+                      <a:solidFill>
+                        <a:srgbClr val="FFFFFF"/>
+                      </a:solidFill>
+                      <a:prstDash val="solid"/>
+                      <a:round/>
+                      <a:headEnd type="none" w="med" len="med"/>
+                      <a:tailEnd type="none" w="med" len="med"/>
+                    </a:lnT>
+                    <a:lnB w="12700" cap="flat" cmpd="sng" algn="ctr">
+                      <a:solidFill>
+                        <a:srgbClr val="FFFFFF"/>
+                      </a:solidFill>
+                      <a:prstDash val="solid"/>
+                      <a:round/>
+                      <a:headEnd type="none" w="med" len="med"/>
+                      <a:tailEnd type="none" w="med" len="med"/>
+                    </a:lnB>
+                    <a:solidFill>
+                      <a:srgbClr val="EEF2F7"/>
+                    </a:solidFill>
+                  </a:tcPr>
+                </a:tc>
+                <a:tc>
+                  <a:txBody>
+                    <a:bodyPr/>
+                    <a:lstStyle/>
+                    <a:p>
+                      <a:pPr algn="l" indent="0" marL="0">
+                        <a:buNone/>
+                      </a:pPr>
+                      <a:r>
+                        <a:rPr lang="en-US" sz="1050" dirty="0">
+                          <a:solidFill>
+                            <a:srgbClr val="1B2233"/>
+                          </a:solidFill>
+                        </a:rPr>
+                        <a:t>final model: 30% of every batch is 3DPW-train</a:t>
+                      </a:r>
+                      <a:endParaRPr lang="en-US" sz="1050" dirty="0"/>
+                    </a:p>
+                  </a:txBody>
+                  <a:tcPr marL="54864" marR="54864" marT="27432" marB="27432" anchor="ctr">
+                    <a:lnL w="12700" cap="flat" cmpd="sng" algn="ctr">
+                      <a:solidFill>
+                        <a:srgbClr val="FFFFFF"/>
+                      </a:solidFill>
+                      <a:prstDash val="solid"/>
+                      <a:round/>
+                      <a:headEnd type="none" w="med" len="med"/>
+                      <a:tailEnd type="none" w="med" len="med"/>
+                    </a:lnL>
+                    <a:lnR w="12700" cap="flat" cmpd="sng" algn="ctr">
+                      <a:solidFill>
+                        <a:srgbClr val="FFFFFF"/>
+                      </a:solidFill>
+                      <a:prstDash val="solid"/>
+                      <a:round/>
+                      <a:headEnd type="none" w="med" len="med"/>
+                      <a:tailEnd type="none" w="med" len="med"/>
+                    </a:lnR>
+                    <a:lnT w="12700" cap="flat" cmpd="sng" algn="ctr">
+                      <a:solidFill>
+                        <a:srgbClr val="FFFFFF"/>
+                      </a:solidFill>
+                      <a:prstDash val="solid"/>
+                      <a:round/>
+                      <a:headEnd type="none" w="med" len="med"/>
+                      <a:tailEnd type="none" w="med" len="med"/>
+                    </a:lnT>
+                    <a:lnB w="12700" cap="flat" cmpd="sng" algn="ctr">
+                      <a:solidFill>
+                        <a:srgbClr val="FFFFFF"/>
+                      </a:solidFill>
+                      <a:prstDash val="solid"/>
+                      <a:round/>
+                      <a:headEnd type="none" w="med" len="med"/>
+                      <a:tailEnd type="none" w="med" len="med"/>
+                    </a:lnB>
+                    <a:solidFill>
+                      <a:srgbClr val="EEF2F7"/>
+                    </a:solidFill>
+                  </a:tcPr>
+                </a:tc>
+                <a:tc>
+                  <a:txBody>
+                    <a:bodyPr/>
+                    <a:lstStyle/>
+                    <a:p>
+                      <a:pPr algn="l" indent="0" marL="0">
+                        <a:buNone/>
+                      </a:pPr>
+                      <a:r>
+                        <a:rPr lang="en-US" sz="1050" dirty="0">
+                          <a:solidFill>
+                            <a:srgbClr val="1B2233"/>
+                          </a:solidFill>
+                        </a:rPr>
+                        <a:t>–</a:t>
+                      </a:r>
+                      <a:endParaRPr lang="en-US" sz="1050" dirty="0"/>
+                    </a:p>
+                  </a:txBody>
+                  <a:tcPr marL="54864" marR="54864" marT="27432" marB="27432" anchor="ctr">
+                    <a:lnL w="12700" cap="flat" cmpd="sng" algn="ctr">
+                      <a:solidFill>
+                        <a:srgbClr val="FFFFFF"/>
+                      </a:solidFill>
+                      <a:prstDash val="solid"/>
+                      <a:round/>
+                      <a:headEnd type="none" w="med" len="med"/>
+                      <a:tailEnd type="none" w="med" len="med"/>
+                    </a:lnL>
+                    <a:lnR w="12700" cap="flat" cmpd="sng" algn="ctr">
+                      <a:solidFill>
+                        <a:srgbClr val="FFFFFF"/>
+                      </a:solidFill>
+                      <a:prstDash val="solid"/>
+                      <a:round/>
+                      <a:headEnd type="none" w="med" len="med"/>
+                      <a:tailEnd type="none" w="med" len="med"/>
+                    </a:lnR>
+                    <a:lnT w="12700" cap="flat" cmpd="sng" algn="ctr">
+                      <a:solidFill>
+                        <a:srgbClr val="FFFFFF"/>
+                      </a:solidFill>
+                      <a:prstDash val="solid"/>
+                      <a:round/>
+                      <a:headEnd type="none" w="med" len="med"/>
+                      <a:tailEnd type="none" w="med" len="med"/>
+                    </a:lnT>
+                    <a:lnB w="12700" cap="flat" cmpd="sng" algn="ctr">
+                      <a:solidFill>
+                        <a:srgbClr val="FFFFFF"/>
+                      </a:solidFill>
+                      <a:prstDash val="solid"/>
+                      <a:round/>
+                      <a:headEnd type="none" w="med" len="med"/>
+                      <a:tailEnd type="none" w="med" len="med"/>
+                    </a:lnB>
+                    <a:solidFill>
+                      <a:srgbClr val="EEF2F7"/>
+                    </a:solidFill>
+                  </a:tcPr>
+                </a:tc>
+              </a:tr>
+              <a:tr h="384048">
+                <a:tc>
+                  <a:txBody>
+                    <a:bodyPr/>
+                    <a:lstStyle/>
+                    <a:p>
+                      <a:pPr algn="l" indent="0" marL="0">
+                        <a:buNone/>
+                      </a:pPr>
+                      <a:r>
+                        <a:rPr lang="en-US" sz="1050" b="1" dirty="0">
+                          <a:solidFill>
+                            <a:srgbClr val="1B2233"/>
+                          </a:solidFill>
+                        </a:rPr>
+                        <a:t>1a  pose correct, 3DPW test and wild</a:t>
+                      </a:r>
+                      <a:endParaRPr lang="en-US" sz="1050" dirty="0"/>
+                    </a:p>
+                  </a:txBody>
+                  <a:tcPr marL="54864" marR="54864" marT="27432" marB="27432" anchor="ctr">
+                    <a:lnL w="12700" cap="flat" cmpd="sng" algn="ctr">
+                      <a:solidFill>
+                        <a:srgbClr val="FFFFFF"/>
+                      </a:solidFill>
+                      <a:prstDash val="solid"/>
+                      <a:round/>
+                      <a:headEnd type="none" w="med" len="med"/>
+                      <a:tailEnd type="none" w="med" len="med"/>
+                    </a:lnL>
+                    <a:lnR w="12700" cap="flat" cmpd="sng" algn="ctr">
+                      <a:solidFill>
+                        <a:srgbClr val="FFFFFF"/>
+                      </a:solidFill>
+                      <a:prstDash val="solid"/>
+                      <a:round/>
+                      <a:headEnd type="none" w="med" len="med"/>
+                      <a:tailEnd type="none" w="med" len="med"/>
+                    </a:lnR>
+                    <a:lnT w="12700" cap="flat" cmpd="sng" algn="ctr">
+                      <a:solidFill>
+                        <a:srgbClr val="FFFFFF"/>
+                      </a:solidFill>
+                      <a:prstDash val="solid"/>
+                      <a:round/>
+                      <a:headEnd type="none" w="med" len="med"/>
+                      <a:tailEnd type="none" w="med" len="med"/>
+                    </a:lnT>
+                    <a:lnB w="12700" cap="flat" cmpd="sng" algn="ctr">
+                      <a:solidFill>
+                        <a:srgbClr val="FFFFFF"/>
+                      </a:solidFill>
+                      <a:prstDash val="solid"/>
+                      <a:round/>
+                      <a:headEnd type="none" w="med" len="med"/>
+                      <a:tailEnd type="none" w="med" len="med"/>
+                    </a:lnB>
+                    <a:solidFill>
+                      <a:srgbClr val="FFFFFF"/>
+                    </a:solidFill>
+                  </a:tcPr>
+                </a:tc>
+                <a:tc>
+                  <a:txBody>
+                    <a:bodyPr/>
+                    <a:lstStyle/>
+                    <a:p>
+                      <a:pPr algn="l" indent="0" marL="0">
+                        <a:buNone/>
+                      </a:pPr>
+                      <a:r>
+                        <a:rPr lang="en-US" sz="1050" b="1" dirty="0">
+                          <a:solidFill>
+                            <a:srgbClr val="E8792B"/>
+                          </a:solidFill>
+                        </a:rPr>
+                        <a:t>partly</a:t>
+                      </a:r>
+                      <a:endParaRPr lang="en-US" sz="1050" dirty="0"/>
+                    </a:p>
+                  </a:txBody>
+                  <a:tcPr marL="54864" marR="54864" marT="27432" marB="27432" anchor="ctr">
+                    <a:lnL w="12700" cap="flat" cmpd="sng" algn="ctr">
+                      <a:solidFill>
+                        <a:srgbClr val="FFFFFF"/>
+                      </a:solidFill>
+                      <a:prstDash val="solid"/>
+                      <a:round/>
+                      <a:headEnd type="none" w="med" len="med"/>
+                      <a:tailEnd type="none" w="med" len="med"/>
+                    </a:lnL>
+                    <a:lnR w="12700" cap="flat" cmpd="sng" algn="ctr">
+                      <a:solidFill>
+                        <a:srgbClr val="FFFFFF"/>
+                      </a:solidFill>
+                      <a:prstDash val="solid"/>
+                      <a:round/>
+                      <a:headEnd type="none" w="med" len="med"/>
+                      <a:tailEnd type="none" w="med" len="med"/>
+                    </a:lnR>
+                    <a:lnT w="12700" cap="flat" cmpd="sng" algn="ctr">
+                      <a:solidFill>
+                        <a:srgbClr val="FFFFFF"/>
+                      </a:solidFill>
+                      <a:prstDash val="solid"/>
+                      <a:round/>
+                      <a:headEnd type="none" w="med" len="med"/>
+                      <a:tailEnd type="none" w="med" len="med"/>
+                    </a:lnT>
+                    <a:lnB w="12700" cap="flat" cmpd="sng" algn="ctr">
+                      <a:solidFill>
+                        <a:srgbClr val="FFFFFF"/>
+                      </a:solidFill>
+                      <a:prstDash val="solid"/>
+                      <a:round/>
+                      <a:headEnd type="none" w="med" len="med"/>
+                      <a:tailEnd type="none" w="med" len="med"/>
+                    </a:lnB>
+                    <a:solidFill>
+                      <a:srgbClr val="FFFFFF"/>
+                    </a:solidFill>
+                  </a:tcPr>
+                </a:tc>
+                <a:tc>
+                  <a:txBody>
+                    <a:bodyPr/>
+                    <a:lstStyle/>
+                    <a:p>
+                      <a:pPr algn="l" indent="0" marL="0">
+                        <a:buNone/>
+                      </a:pPr>
+                      <a:r>
+                        <a:rPr lang="en-US" sz="1050" dirty="0">
+                          <a:solidFill>
+                            <a:srgbClr val="1B2233"/>
+                          </a:solidFill>
+                        </a:rPr>
+                        <a:t>neck 4.8°, fingers 8.3°; 3DPW test 89.0 mm, our best so far</a:t>
+                      </a:r>
+                      <a:endParaRPr lang="en-US" sz="1050" dirty="0"/>
+                    </a:p>
+                  </a:txBody>
+                  <a:tcPr marL="54864" marR="54864" marT="27432" marB="27432" anchor="ctr">
+                    <a:lnL w="12700" cap="flat" cmpd="sng" algn="ctr">
+                      <a:solidFill>
+                        <a:srgbClr val="FFFFFF"/>
+                      </a:solidFill>
+                      <a:prstDash val="solid"/>
+                      <a:round/>
+                      <a:headEnd type="none" w="med" len="med"/>
+                      <a:tailEnd type="none" w="med" len="med"/>
+                    </a:lnL>
+                    <a:lnR w="12700" cap="flat" cmpd="sng" algn="ctr">
+                      <a:solidFill>
+                        <a:srgbClr val="FFFFFF"/>
+                      </a:solidFill>
+                      <a:prstDash val="solid"/>
+                      <a:round/>
+                      <a:headEnd type="none" w="med" len="med"/>
+                      <a:tailEnd type="none" w="med" len="med"/>
+                    </a:lnR>
+                    <a:lnT w="12700" cap="flat" cmpd="sng" algn="ctr">
+                      <a:solidFill>
+                        <a:srgbClr val="FFFFFF"/>
+                      </a:solidFill>
+                      <a:prstDash val="solid"/>
+                      <a:round/>
+                      <a:headEnd type="none" w="med" len="med"/>
+                      <a:tailEnd type="none" w="med" len="med"/>
+                    </a:lnT>
+                    <a:lnB w="12700" cap="flat" cmpd="sng" algn="ctr">
+                      <a:solidFill>
+                        <a:srgbClr val="FFFFFF"/>
+                      </a:solidFill>
+                      <a:prstDash val="solid"/>
+                      <a:round/>
+                      <a:headEnd type="none" w="med" len="med"/>
+                      <a:tailEnd type="none" w="med" len="med"/>
+                    </a:lnB>
+                    <a:solidFill>
+                      <a:srgbClr val="FFFFFF"/>
+                    </a:solidFill>
+                  </a:tcPr>
+                </a:tc>
+                <a:tc>
+                  <a:txBody>
+                    <a:bodyPr/>
+                    <a:lstStyle/>
+                    <a:p>
+                      <a:pPr algn="l" indent="0" marL="0">
+                        <a:buNone/>
+                      </a:pPr>
+                      <a:r>
+                        <a:rPr lang="en-US" sz="1050" dirty="0">
+                          <a:solidFill>
+                            <a:srgbClr val="1B2233"/>
+                          </a:solidFill>
+                        </a:rPr>
+                        <a:t>depth slope 0.42, placement, hard poses; real-photo hands unshown</a:t>
+                      </a:r>
+                      <a:endParaRPr lang="en-US" sz="1050" dirty="0"/>
+                    </a:p>
+                  </a:txBody>
+                  <a:tcPr marL="54864" marR="54864" marT="27432" marB="27432" anchor="ctr">
+                    <a:lnL w="12700" cap="flat" cmpd="sng" algn="ctr">
+                      <a:solidFill>
+                        <a:srgbClr val="FFFFFF"/>
+                      </a:solidFill>
+                      <a:prstDash val="solid"/>
+                      <a:round/>
+                      <a:headEnd type="none" w="med" len="med"/>
+                      <a:tailEnd type="none" w="med" len="med"/>
+                    </a:lnL>
+                    <a:lnR w="12700" cap="flat" cmpd="sng" algn="ctr">
+                      <a:solidFill>
+                        <a:srgbClr val="FFFFFF"/>
+                      </a:solidFill>
+                      <a:prstDash val="solid"/>
+                      <a:round/>
+                      <a:headEnd type="none" w="med" len="med"/>
+                      <a:tailEnd type="none" w="med" len="med"/>
+                    </a:lnR>
+                    <a:lnT w="12700" cap="flat" cmpd="sng" algn="ctr">
+                      <a:solidFill>
+                        <a:srgbClr val="FFFFFF"/>
+                      </a:solidFill>
+                      <a:prstDash val="solid"/>
+                      <a:round/>
+                      <a:headEnd type="none" w="med" len="med"/>
+                      <a:tailEnd type="none" w="med" len="med"/>
+                    </a:lnT>
+                    <a:lnB w="12700" cap="flat" cmpd="sng" algn="ctr">
+                      <a:solidFill>
+                        <a:srgbClr val="FFFFFF"/>
+                      </a:solidFill>
+                      <a:prstDash val="solid"/>
+                      <a:round/>
+                      <a:headEnd type="none" w="med" len="med"/>
+                      <a:tailEnd type="none" w="med" len="med"/>
+                    </a:lnB>
+                    <a:solidFill>
+                      <a:srgbClr val="FFFFFF"/>
+                    </a:solidFill>
+                  </a:tcPr>
+                </a:tc>
+              </a:tr>
+              <a:tr h="384048">
+                <a:tc>
+                  <a:txBody>
+                    <a:bodyPr/>
+                    <a:lstStyle/>
+                    <a:p>
+                      <a:pPr algn="l" indent="0" marL="0">
+                        <a:buNone/>
+                      </a:pPr>
+                      <a:r>
+                        <a:rPr lang="en-US" sz="1050" b="1" dirty="0">
+                          <a:solidFill>
+                            <a:srgbClr val="1B2233"/>
+                          </a:solidFill>
+                        </a:rPr>
+                        <a:t>1a  shape changes per person</a:t>
+                      </a:r>
+                      <a:endParaRPr lang="en-US" sz="1050" dirty="0"/>
+                    </a:p>
+                  </a:txBody>
+                  <a:tcPr marL="54864" marR="54864" marT="27432" marB="27432" anchor="ctr">
+                    <a:lnL w="12700" cap="flat" cmpd="sng" algn="ctr">
+                      <a:solidFill>
+                        <a:srgbClr val="FFFFFF"/>
+                      </a:solidFill>
+                      <a:prstDash val="solid"/>
+                      <a:round/>
+                      <a:headEnd type="none" w="med" len="med"/>
+                      <a:tailEnd type="none" w="med" len="med"/>
+                    </a:lnL>
+                    <a:lnR w="12700" cap="flat" cmpd="sng" algn="ctr">
+                      <a:solidFill>
+                        <a:srgbClr val="FFFFFF"/>
+                      </a:solidFill>
+                      <a:prstDash val="solid"/>
+                      <a:round/>
+                      <a:headEnd type="none" w="med" len="med"/>
+                      <a:tailEnd type="none" w="med" len="med"/>
+                    </a:lnR>
+                    <a:lnT w="12700" cap="flat" cmpd="sng" algn="ctr">
+                      <a:solidFill>
+                        <a:srgbClr val="FFFFFF"/>
+                      </a:solidFill>
+                      <a:prstDash val="solid"/>
+                      <a:round/>
+                      <a:headEnd type="none" w="med" len="med"/>
+                      <a:tailEnd type="none" w="med" len="med"/>
+                    </a:lnT>
+                    <a:lnB w="12700" cap="flat" cmpd="sng" algn="ctr">
+                      <a:solidFill>
+                        <a:srgbClr val="FFFFFF"/>
+                      </a:solidFill>
+                      <a:prstDash val="solid"/>
+                      <a:round/>
+                      <a:headEnd type="none" w="med" len="med"/>
+                      <a:tailEnd type="none" w="med" len="med"/>
+                    </a:lnB>
+                    <a:solidFill>
+                      <a:srgbClr val="EEF2F7"/>
+                    </a:solidFill>
+                  </a:tcPr>
+                </a:tc>
+                <a:tc>
+                  <a:txBody>
+                    <a:bodyPr/>
+                    <a:lstStyle/>
+                    <a:p>
+                      <a:pPr algn="l" indent="0" marL="0">
+                        <a:buNone/>
+                      </a:pPr>
+                      <a:r>
+                        <a:rPr lang="en-US" sz="1050" b="1" dirty="0">
+                          <a:solidFill>
+                            <a:srgbClr val="E8792B"/>
+                          </a:solidFill>
+                        </a:rPr>
+                        <a:t>partly, at risk</a:t>
+                      </a:r>
+                      <a:endParaRPr lang="en-US" sz="1050" dirty="0"/>
+                    </a:p>
+                  </a:txBody>
+                  <a:tcPr marL="54864" marR="54864" marT="27432" marB="27432" anchor="ctr">
+                    <a:lnL w="12700" cap="flat" cmpd="sng" algn="ctr">
+                      <a:solidFill>
+                        <a:srgbClr val="FFFFFF"/>
+                      </a:solidFill>
+                      <a:prstDash val="solid"/>
+                      <a:round/>
+                      <a:headEnd type="none" w="med" len="med"/>
+                      <a:tailEnd type="none" w="med" len="med"/>
+                    </a:lnL>
+                    <a:lnR w="12700" cap="flat" cmpd="sng" algn="ctr">
+                      <a:solidFill>
+                        <a:srgbClr val="FFFFFF"/>
+                      </a:solidFill>
+                      <a:prstDash val="solid"/>
+                      <a:round/>
+                      <a:headEnd type="none" w="med" len="med"/>
+                      <a:tailEnd type="none" w="med" len="med"/>
+                    </a:lnR>
+                    <a:lnT w="12700" cap="flat" cmpd="sng" algn="ctr">
+                      <a:solidFill>
+                        <a:srgbClr val="FFFFFF"/>
+                      </a:solidFill>
+                      <a:prstDash val="solid"/>
+                      <a:round/>
+                      <a:headEnd type="none" w="med" len="med"/>
+                      <a:tailEnd type="none" w="med" len="med"/>
+                    </a:lnT>
+                    <a:lnB w="12700" cap="flat" cmpd="sng" algn="ctr">
+                      <a:solidFill>
+                        <a:srgbClr val="FFFFFF"/>
+                      </a:solidFill>
+                      <a:prstDash val="solid"/>
+                      <a:round/>
+                      <a:headEnd type="none" w="med" len="med"/>
+                      <a:tailEnd type="none" w="med" len="med"/>
+                    </a:lnB>
+                    <a:solidFill>
+                      <a:srgbClr val="EEF2F7"/>
+                    </a:solidFill>
+                  </a:tcPr>
+                </a:tc>
+                <a:tc>
+                  <a:txBody>
+                    <a:bodyPr/>
+                    <a:lstStyle/>
+                    <a:p>
+                      <a:pPr algn="l" indent="0" marL="0">
+                        <a:buNone/>
+                      </a:pPr>
+                      <a:r>
+                        <a:rPr lang="en-US" sz="1050" dirty="0">
+                          <a:solidFill>
+                            <a:srgbClr val="1B2233"/>
+                          </a:solidFill>
+                        </a:rPr>
+                        <a:t>gender yes (Relative Human 64%); age partly (baby 0.44, adult 0.54); muscle, weight, cup, firmness ≈ 0.5</a:t>
+                      </a:r>
+                      <a:endParaRPr lang="en-US" sz="1050" dirty="0"/>
+                    </a:p>
+                  </a:txBody>
+                  <a:tcPr marL="54864" marR="54864" marT="27432" marB="27432" anchor="ctr">
+                    <a:lnL w="12700" cap="flat" cmpd="sng" algn="ctr">
+                      <a:solidFill>
+                        <a:srgbClr val="FFFFFF"/>
+                      </a:solidFill>
+                      <a:prstDash val="solid"/>
+                      <a:round/>
+                      <a:headEnd type="none" w="med" len="med"/>
+                      <a:tailEnd type="none" w="med" len="med"/>
+                    </a:lnL>
+                    <a:lnR w="12700" cap="flat" cmpd="sng" algn="ctr">
+                      <a:solidFill>
+                        <a:srgbClr val="FFFFFF"/>
+                      </a:solidFill>
+                      <a:prstDash val="solid"/>
+                      <a:round/>
+                      <a:headEnd type="none" w="med" len="med"/>
+                      <a:tailEnd type="none" w="med" len="med"/>
+                    </a:lnR>
+                    <a:lnT w="12700" cap="flat" cmpd="sng" algn="ctr">
+                      <a:solidFill>
+                        <a:srgbClr val="FFFFFF"/>
+                      </a:solidFill>
+                      <a:prstDash val="solid"/>
+                      <a:round/>
+                      <a:headEnd type="none" w="med" len="med"/>
+                      <a:tailEnd type="none" w="med" len="med"/>
+                    </a:lnT>
+                    <a:lnB w="12700" cap="flat" cmpd="sng" algn="ctr">
+                      <a:solidFill>
+                        <a:srgbClr val="FFFFFF"/>
+                      </a:solidFill>
+                      <a:prstDash val="solid"/>
+                      <a:round/>
+                      <a:headEnd type="none" w="med" len="med"/>
+                      <a:tailEnd type="none" w="med" len="med"/>
+                    </a:lnB>
+                    <a:solidFill>
+                      <a:srgbClr val="EEF2F7"/>
+                    </a:solidFill>
+                  </a:tcPr>
+                </a:tc>
+                <a:tc>
+                  <a:txBody>
+                    <a:bodyPr/>
+                    <a:lstStyle/>
+                    <a:p>
+                      <a:pPr algn="l" indent="0" marL="0">
+                        <a:buNone/>
+                      </a:pPr>
+                      <a:r>
+                        <a:rPr lang="en-US" sz="1050" dirty="0">
+                          <a:solidFill>
+                            <a:srgbClr val="1B2233"/>
+                          </a:solidFill>
+                        </a:rPr>
+                        <a:t>masked run (in progress); rest-pose lineup</a:t>
+                      </a:r>
+                      <a:endParaRPr lang="en-US" sz="1050" dirty="0"/>
+                    </a:p>
+                  </a:txBody>
+                  <a:tcPr marL="54864" marR="54864" marT="27432" marB="27432" anchor="ctr">
+                    <a:lnL w="12700" cap="flat" cmpd="sng" algn="ctr">
+                      <a:solidFill>
+                        <a:srgbClr val="FFFFFF"/>
+                      </a:solidFill>
+                      <a:prstDash val="solid"/>
+                      <a:round/>
+                      <a:headEnd type="none" w="med" len="med"/>
+                      <a:tailEnd type="none" w="med" len="med"/>
+                    </a:lnL>
+                    <a:lnR w="12700" cap="flat" cmpd="sng" algn="ctr">
+                      <a:solidFill>
+                        <a:srgbClr val="FFFFFF"/>
+                      </a:solidFill>
+                      <a:prstDash val="solid"/>
+                      <a:round/>
+                      <a:headEnd type="none" w="med" len="med"/>
+                      <a:tailEnd type="none" w="med" len="med"/>
+                    </a:lnR>
+                    <a:lnT w="12700" cap="flat" cmpd="sng" algn="ctr">
+                      <a:solidFill>
+                        <a:srgbClr val="FFFFFF"/>
+                      </a:solidFill>
+                      <a:prstDash val="solid"/>
+                      <a:round/>
+                      <a:headEnd type="none" w="med" len="med"/>
+                      <a:tailEnd type="none" w="med" len="med"/>
+                    </a:lnT>
+                    <a:lnB w="12700" cap="flat" cmpd="sng" algn="ctr">
+                      <a:solidFill>
+                        <a:srgbClr val="FFFFFF"/>
+                      </a:solidFill>
+                      <a:prstDash val="solid"/>
+                      <a:round/>
+                      <a:headEnd type="none" w="med" len="med"/>
+                      <a:tailEnd type="none" w="med" len="med"/>
+                    </a:lnB>
+                    <a:solidFill>
+                      <a:srgbClr val="EEF2F7"/>
+                    </a:solidFill>
+                  </a:tcPr>
+                </a:tc>
+              </a:tr>
+              <a:tr h="384048">
+                <a:tc>
+                  <a:txBody>
+                    <a:bodyPr/>
+                    <a:lstStyle/>
+                    <a:p>
+                      <a:pPr algn="l" indent="0" marL="0">
+                        <a:buNone/>
+                      </a:pPr>
+                      <a:r>
+                        <a:rPr lang="en-US" sz="1050" b="1" dirty="0">
+                          <a:solidFill>
+                            <a:srgbClr val="1B2233"/>
+                          </a:solidFill>
+                        </a:rPr>
+                        <a:t>1b  not the same model as Multi-HMR</a:t>
+                      </a:r>
+                      <a:endParaRPr lang="en-US" sz="1050" dirty="0"/>
+                    </a:p>
+                  </a:txBody>
+                  <a:tcPr marL="54864" marR="54864" marT="27432" marB="27432" anchor="ctr">
+                    <a:lnL w="12700" cap="flat" cmpd="sng" algn="ctr">
+                      <a:solidFill>
+                        <a:srgbClr val="FFFFFF"/>
+                      </a:solidFill>
+                      <a:prstDash val="solid"/>
+                      <a:round/>
+                      <a:headEnd type="none" w="med" len="med"/>
+                      <a:tailEnd type="none" w="med" len="med"/>
+                    </a:lnL>
+                    <a:lnR w="12700" cap="flat" cmpd="sng" algn="ctr">
+                      <a:solidFill>
+                        <a:srgbClr val="FFFFFF"/>
+                      </a:solidFill>
+                      <a:prstDash val="solid"/>
+                      <a:round/>
+                      <a:headEnd type="none" w="med" len="med"/>
+                      <a:tailEnd type="none" w="med" len="med"/>
+                    </a:lnR>
+                    <a:lnT w="12700" cap="flat" cmpd="sng" algn="ctr">
+                      <a:solidFill>
+                        <a:srgbClr val="FFFFFF"/>
+                      </a:solidFill>
+                      <a:prstDash val="solid"/>
+                      <a:round/>
+                      <a:headEnd type="none" w="med" len="med"/>
+                      <a:tailEnd type="none" w="med" len="med"/>
+                    </a:lnT>
+                    <a:lnB w="12700" cap="flat" cmpd="sng" algn="ctr">
+                      <a:solidFill>
+                        <a:srgbClr val="FFFFFF"/>
+                      </a:solidFill>
+                      <a:prstDash val="solid"/>
+                      <a:round/>
+                      <a:headEnd type="none" w="med" len="med"/>
+                      <a:tailEnd type="none" w="med" len="med"/>
+                    </a:lnB>
+                    <a:solidFill>
+                      <a:srgbClr val="FFFFFF"/>
+                    </a:solidFill>
+                  </a:tcPr>
+                </a:tc>
+                <a:tc>
+                  <a:txBody>
+                    <a:bodyPr/>
+                    <a:lstStyle/>
+                    <a:p>
+                      <a:pPr algn="l" indent="0" marL="0">
+                        <a:buNone/>
+                      </a:pPr>
+                      <a:r>
+                        <a:rPr lang="en-US" sz="1050" b="1" dirty="0">
+                          <a:solidFill>
+                            <a:srgbClr val="C0392B"/>
+                          </a:solidFill>
+                        </a:rPr>
+                        <a:t>not met</a:t>
+                      </a:r>
+                      <a:endParaRPr lang="en-US" sz="1050" dirty="0"/>
+                    </a:p>
+                  </a:txBody>
+                  <a:tcPr marL="54864" marR="54864" marT="27432" marB="27432" anchor="ctr">
+                    <a:lnL w="12700" cap="flat" cmpd="sng" algn="ctr">
+                      <a:solidFill>
+                        <a:srgbClr val="FFFFFF"/>
+                      </a:solidFill>
+                      <a:prstDash val="solid"/>
+                      <a:round/>
+                      <a:headEnd type="none" w="med" len="med"/>
+                      <a:tailEnd type="none" w="med" len="med"/>
+                    </a:lnL>
+                    <a:lnR w="12700" cap="flat" cmpd="sng" algn="ctr">
+                      <a:solidFill>
+                        <a:srgbClr val="FFFFFF"/>
+                      </a:solidFill>
+                      <a:prstDash val="solid"/>
+                      <a:round/>
+                      <a:headEnd type="none" w="med" len="med"/>
+                      <a:tailEnd type="none" w="med" len="med"/>
+                    </a:lnR>
+                    <a:lnT w="12700" cap="flat" cmpd="sng" algn="ctr">
+                      <a:solidFill>
+                        <a:srgbClr val="FFFFFF"/>
+                      </a:solidFill>
+                      <a:prstDash val="solid"/>
+                      <a:round/>
+                      <a:headEnd type="none" w="med" len="med"/>
+                      <a:tailEnd type="none" w="med" len="med"/>
+                    </a:lnT>
+                    <a:lnB w="12700" cap="flat" cmpd="sng" algn="ctr">
+                      <a:solidFill>
+                        <a:srgbClr val="FFFFFF"/>
+                      </a:solidFill>
+                      <a:prstDash val="solid"/>
+                      <a:round/>
+                      <a:headEnd type="none" w="med" len="med"/>
+                      <a:tailEnd type="none" w="med" len="med"/>
+                    </a:lnB>
+                    <a:solidFill>
+                      <a:srgbClr val="FFFFFF"/>
+                    </a:solidFill>
+                  </a:tcPr>
+                </a:tc>
+                <a:tc>
+                  <a:txBody>
+                    <a:bodyPr/>
+                    <a:lstStyle/>
+                    <a:p>
+                      <a:pPr algn="l" indent="0" marL="0">
+                        <a:buNone/>
+                      </a:pPr>
+                      <a:r>
+                        <a:rPr lang="en-US" sz="1050" dirty="0">
+                          <a:solidFill>
+                            <a:srgbClr val="1B2233"/>
+                          </a:solidFill>
+                        </a:rPr>
+                        <a:t>upstream Multi-HMR, output resized for Anny + 0-parameter bone fix; NAVER's Anny model not yet run</a:t>
+                      </a:r>
+                      <a:endParaRPr lang="en-US" sz="1050" dirty="0"/>
+                    </a:p>
+                  </a:txBody>
+                  <a:tcPr marL="54864" marR="54864" marT="27432" marB="27432" anchor="ctr">
+                    <a:lnL w="12700" cap="flat" cmpd="sng" algn="ctr">
+                      <a:solidFill>
+                        <a:srgbClr val="FFFFFF"/>
+                      </a:solidFill>
+                      <a:prstDash val="solid"/>
+                      <a:round/>
+                      <a:headEnd type="none" w="med" len="med"/>
+                      <a:tailEnd type="none" w="med" len="med"/>
+                    </a:lnL>
+                    <a:lnR w="12700" cap="flat" cmpd="sng" algn="ctr">
+                      <a:solidFill>
+                        <a:srgbClr val="FFFFFF"/>
+                      </a:solidFill>
+                      <a:prstDash val="solid"/>
+                      <a:round/>
+                      <a:headEnd type="none" w="med" len="med"/>
+                      <a:tailEnd type="none" w="med" len="med"/>
+                    </a:lnR>
+                    <a:lnT w="12700" cap="flat" cmpd="sng" algn="ctr">
+                      <a:solidFill>
+                        <a:srgbClr val="FFFFFF"/>
+                      </a:solidFill>
+                      <a:prstDash val="solid"/>
+                      <a:round/>
+                      <a:headEnd type="none" w="med" len="med"/>
+                      <a:tailEnd type="none" w="med" len="med"/>
+                    </a:lnT>
+                    <a:lnB w="12700" cap="flat" cmpd="sng" algn="ctr">
+                      <a:solidFill>
+                        <a:srgbClr val="FFFFFF"/>
+                      </a:solidFill>
+                      <a:prstDash val="solid"/>
+                      <a:round/>
+                      <a:headEnd type="none" w="med" len="med"/>
+                      <a:tailEnd type="none" w="med" len="med"/>
+                    </a:lnB>
+                    <a:solidFill>
+                      <a:srgbClr val="FFFFFF"/>
+                    </a:solidFill>
+                  </a:tcPr>
+                </a:tc>
+                <a:tc>
+                  <a:txBody>
+                    <a:bodyPr/>
+                    <a:lstStyle/>
+                    <a:p>
+                      <a:pPr algn="l" indent="0" marL="0">
+                        <a:buNone/>
+                      </a:pPr>
+                      <a:r>
+                        <a:rPr lang="en-US" sz="1050" dirty="0">
+                          <a:solidFill>
+                            <a:srgbClr val="1B2233"/>
+                          </a:solidFill>
+                        </a:rPr>
+                        <a:t>ViT-B student (below); needs your yes</a:t>
+                      </a:r>
+                      <a:endParaRPr lang="en-US" sz="1050" dirty="0"/>
+                    </a:p>
+                  </a:txBody>
+                  <a:tcPr marL="54864" marR="54864" marT="27432" marB="27432" anchor="ctr">
+                    <a:lnL w="12700" cap="flat" cmpd="sng" algn="ctr">
+                      <a:solidFill>
+                        <a:srgbClr val="FFFFFF"/>
+                      </a:solidFill>
+                      <a:prstDash val="solid"/>
+                      <a:round/>
+                      <a:headEnd type="none" w="med" len="med"/>
+                      <a:tailEnd type="none" w="med" len="med"/>
+                    </a:lnL>
+                    <a:lnR w="12700" cap="flat" cmpd="sng" algn="ctr">
+                      <a:solidFill>
+                        <a:srgbClr val="FFFFFF"/>
+                      </a:solidFill>
+                      <a:prstDash val="solid"/>
+                      <a:round/>
+                      <a:headEnd type="none" w="med" len="med"/>
+                      <a:tailEnd type="none" w="med" len="med"/>
+                    </a:lnR>
+                    <a:lnT w="12700" cap="flat" cmpd="sng" algn="ctr">
+                      <a:solidFill>
+                        <a:srgbClr val="FFFFFF"/>
+                      </a:solidFill>
+                      <a:prstDash val="solid"/>
+                      <a:round/>
+                      <a:headEnd type="none" w="med" len="med"/>
+                      <a:tailEnd type="none" w="med" len="med"/>
+                    </a:lnT>
+                    <a:lnB w="12700" cap="flat" cmpd="sng" algn="ctr">
+                      <a:solidFill>
+                        <a:srgbClr val="FFFFFF"/>
+                      </a:solidFill>
+                      <a:prstDash val="solid"/>
+                      <a:round/>
+                      <a:headEnd type="none" w="med" len="med"/>
+                      <a:tailEnd type="none" w="med" len="med"/>
+                    </a:lnB>
+                    <a:solidFill>
+                      <a:srgbClr val="FFFFFF"/>
+                    </a:solidFill>
+                  </a:tcPr>
+                </a:tc>
+              </a:tr>
+              <a:tr h="384048">
+                <a:tc>
+                  <a:txBody>
+                    <a:bodyPr/>
+                    <a:lstStyle/>
+                    <a:p>
+                      <a:pPr algn="l" indent="0" marL="0">
+                        <a:buNone/>
+                      </a:pPr>
+                      <a:r>
+                        <a:rPr lang="en-US" sz="1050" b="1" dirty="0">
+                          <a:solidFill>
+                            <a:srgbClr val="1B2233"/>
+                          </a:solidFill>
+                        </a:rPr>
+                        <a:t>2b  temporal (motion)</a:t>
+                      </a:r>
+                      <a:endParaRPr lang="en-US" sz="1050" dirty="0"/>
+                    </a:p>
+                  </a:txBody>
+                  <a:tcPr marL="54864" marR="54864" marT="27432" marB="27432" anchor="ctr">
+                    <a:lnL w="12700" cap="flat" cmpd="sng" algn="ctr">
+                      <a:solidFill>
+                        <a:srgbClr val="FFFFFF"/>
+                      </a:solidFill>
+                      <a:prstDash val="solid"/>
+                      <a:round/>
+                      <a:headEnd type="none" w="med" len="med"/>
+                      <a:tailEnd type="none" w="med" len="med"/>
+                    </a:lnL>
+                    <a:lnR w="12700" cap="flat" cmpd="sng" algn="ctr">
+                      <a:solidFill>
+                        <a:srgbClr val="FFFFFF"/>
+                      </a:solidFill>
+                      <a:prstDash val="solid"/>
+                      <a:round/>
+                      <a:headEnd type="none" w="med" len="med"/>
+                      <a:tailEnd type="none" w="med" len="med"/>
+                    </a:lnR>
+                    <a:lnT w="12700" cap="flat" cmpd="sng" algn="ctr">
+                      <a:solidFill>
+                        <a:srgbClr val="FFFFFF"/>
+                      </a:solidFill>
+                      <a:prstDash val="solid"/>
+                      <a:round/>
+                      <a:headEnd type="none" w="med" len="med"/>
+                      <a:tailEnd type="none" w="med" len="med"/>
+                    </a:lnT>
+                    <a:lnB w="12700" cap="flat" cmpd="sng" algn="ctr">
+                      <a:solidFill>
+                        <a:srgbClr val="FFFFFF"/>
+                      </a:solidFill>
+                      <a:prstDash val="solid"/>
+                      <a:round/>
+                      <a:headEnd type="none" w="med" len="med"/>
+                      <a:tailEnd type="none" w="med" len="med"/>
+                    </a:lnB>
+                    <a:solidFill>
+                      <a:srgbClr val="EEF2F7"/>
+                    </a:solidFill>
+                  </a:tcPr>
+                </a:tc>
+                <a:tc>
+                  <a:txBody>
+                    <a:bodyPr/>
+                    <a:lstStyle/>
+                    <a:p>
+                      <a:pPr algn="l" indent="0" marL="0">
+                        <a:buNone/>
+                      </a:pPr>
+                      <a:r>
+                        <a:rPr lang="en-US" sz="1050" b="1" dirty="0">
+                          <a:solidFill>
+                            <a:srgbClr val="7B8794"/>
+                          </a:solidFill>
+                        </a:rPr>
+                        <a:t>not started</a:t>
+                      </a:r>
+                      <a:endParaRPr lang="en-US" sz="1050" dirty="0"/>
+                    </a:p>
+                  </a:txBody>
+                  <a:tcPr marL="54864" marR="54864" marT="27432" marB="27432" anchor="ctr">
+                    <a:lnL w="12700" cap="flat" cmpd="sng" algn="ctr">
+                      <a:solidFill>
+                        <a:srgbClr val="FFFFFF"/>
+                      </a:solidFill>
+                      <a:prstDash val="solid"/>
+                      <a:round/>
+                      <a:headEnd type="none" w="med" len="med"/>
+                      <a:tailEnd type="none" w="med" len="med"/>
+                    </a:lnL>
+                    <a:lnR w="12700" cap="flat" cmpd="sng" algn="ctr">
+                      <a:solidFill>
+                        <a:srgbClr val="FFFFFF"/>
+                      </a:solidFill>
+                      <a:prstDash val="solid"/>
+                      <a:round/>
+                      <a:headEnd type="none" w="med" len="med"/>
+                      <a:tailEnd type="none" w="med" len="med"/>
+                    </a:lnR>
+                    <a:lnT w="12700" cap="flat" cmpd="sng" algn="ctr">
+                      <a:solidFill>
+                        <a:srgbClr val="FFFFFF"/>
+                      </a:solidFill>
+                      <a:prstDash val="solid"/>
+                      <a:round/>
+                      <a:headEnd type="none" w="med" len="med"/>
+                      <a:tailEnd type="none" w="med" len="med"/>
+                    </a:lnT>
+                    <a:lnB w="12700" cap="flat" cmpd="sng" algn="ctr">
+                      <a:solidFill>
+                        <a:srgbClr val="FFFFFF"/>
+                      </a:solidFill>
+                      <a:prstDash val="solid"/>
+                      <a:round/>
+                      <a:headEnd type="none" w="med" len="med"/>
+                      <a:tailEnd type="none" w="med" len="med"/>
+                    </a:lnB>
+                    <a:solidFill>
+                      <a:srgbClr val="EEF2F7"/>
+                    </a:solidFill>
+                  </a:tcPr>
+                </a:tc>
+                <a:tc>
+                  <a:txBody>
+                    <a:bodyPr/>
+                    <a:lstStyle/>
+                    <a:p>
+                      <a:pPr algn="l" indent="0" marL="0">
+                        <a:buNone/>
+                      </a:pPr>
+                      <a:r>
+                        <a:rPr lang="en-US" sz="1050" dirty="0">
+                          <a:solidFill>
+                            <a:srgbClr val="1B2233"/>
+                          </a:solidFill>
+                        </a:rPr>
+                        <a:t>per-frame model only</a:t>
+                      </a:r>
+                      <a:endParaRPr lang="en-US" sz="1050" dirty="0"/>
+                    </a:p>
+                  </a:txBody>
+                  <a:tcPr marL="54864" marR="54864" marT="27432" marB="27432" anchor="ctr">
+                    <a:lnL w="12700" cap="flat" cmpd="sng" algn="ctr">
+                      <a:solidFill>
+                        <a:srgbClr val="FFFFFF"/>
+                      </a:solidFill>
+                      <a:prstDash val="solid"/>
+                      <a:round/>
+                      <a:headEnd type="none" w="med" len="med"/>
+                      <a:tailEnd type="none" w="med" len="med"/>
+                    </a:lnL>
+                    <a:lnR w="12700" cap="flat" cmpd="sng" algn="ctr">
+                      <a:solidFill>
+                        <a:srgbClr val="FFFFFF"/>
+                      </a:solidFill>
+                      <a:prstDash val="solid"/>
+                      <a:round/>
+                      <a:headEnd type="none" w="med" len="med"/>
+                      <a:tailEnd type="none" w="med" len="med"/>
+                    </a:lnR>
+                    <a:lnT w="12700" cap="flat" cmpd="sng" algn="ctr">
+                      <a:solidFill>
+                        <a:srgbClr val="FFFFFF"/>
+                      </a:solidFill>
+                      <a:prstDash val="solid"/>
+                      <a:round/>
+                      <a:headEnd type="none" w="med" len="med"/>
+                      <a:tailEnd type="none" w="med" len="med"/>
+                    </a:lnT>
+                    <a:lnB w="12700" cap="flat" cmpd="sng" algn="ctr">
+                      <a:solidFill>
+                        <a:srgbClr val="FFFFFF"/>
+                      </a:solidFill>
+                      <a:prstDash val="solid"/>
+                      <a:round/>
+                      <a:headEnd type="none" w="med" len="med"/>
+                      <a:tailEnd type="none" w="med" len="med"/>
+                    </a:lnB>
+                    <a:solidFill>
+                      <a:srgbClr val="EEF2F7"/>
+                    </a:solidFill>
+                  </a:tcPr>
+                </a:tc>
+                <a:tc>
+                  <a:txBody>
+                    <a:bodyPr/>
+                    <a:lstStyle/>
+                    <a:p>
+                      <a:pPr algn="l" indent="0" marL="0">
+                        <a:buNone/>
+                      </a:pPr>
+                      <a:r>
+                        <a:rPr lang="en-US" sz="1050" dirty="0">
+                          <a:solidFill>
+                            <a:srgbClr val="1B2233"/>
+                          </a:solidFill>
+                        </a:rPr>
+                        <a:t>refiner on frozen per-frame tokens, 16-frame windows; month two</a:t>
+                      </a:r>
+                      <a:endParaRPr lang="en-US" sz="1050" dirty="0"/>
+                    </a:p>
+                  </a:txBody>
+                  <a:tcPr marL="54864" marR="54864" marT="27432" marB="27432" anchor="ctr">
+                    <a:lnL w="12700" cap="flat" cmpd="sng" algn="ctr">
+                      <a:solidFill>
+                        <a:srgbClr val="FFFFFF"/>
+                      </a:solidFill>
+                      <a:prstDash val="solid"/>
+                      <a:round/>
+                      <a:headEnd type="none" w="med" len="med"/>
+                      <a:tailEnd type="none" w="med" len="med"/>
+                    </a:lnL>
+                    <a:lnR w="12700" cap="flat" cmpd="sng" algn="ctr">
+                      <a:solidFill>
+                        <a:srgbClr val="FFFFFF"/>
+                      </a:solidFill>
+                      <a:prstDash val="solid"/>
+                      <a:round/>
+                      <a:headEnd type="none" w="med" len="med"/>
+                      <a:tailEnd type="none" w="med" len="med"/>
+                    </a:lnR>
+                    <a:lnT w="12700" cap="flat" cmpd="sng" algn="ctr">
+                      <a:solidFill>
+                        <a:srgbClr val="FFFFFF"/>
+                      </a:solidFill>
+                      <a:prstDash val="solid"/>
+                      <a:round/>
+                      <a:headEnd type="none" w="med" len="med"/>
+                      <a:tailEnd type="none" w="med" len="med"/>
+                    </a:lnT>
+                    <a:lnB w="12700" cap="flat" cmpd="sng" algn="ctr">
+                      <a:solidFill>
+                        <a:srgbClr val="FFFFFF"/>
+                      </a:solidFill>
+                      <a:prstDash val="solid"/>
+                      <a:round/>
+                      <a:headEnd type="none" w="med" len="med"/>
+                      <a:tailEnd type="none" w="med" len="med"/>
+                    </a:lnB>
+                    <a:solidFill>
+                      <a:srgbClr val="EEF2F7"/>
+                    </a:solidFill>
+                  </a:tcPr>
+                </a:tc>
+              </a:tr>
+              <a:tr h="384048">
+                <a:tc>
+                  <a:txBody>
+                    <a:bodyPr/>
+                    <a:lstStyle/>
+                    <a:p>
+                      <a:pPr algn="l" indent="0" marL="0">
+                        <a:buNone/>
+                      </a:pPr>
+                      <a:r>
+                        <a:rPr lang="en-US" sz="1050" b="1" dirty="0">
+                          <a:solidFill>
+                            <a:srgbClr val="1B2233"/>
+                          </a:solidFill>
+                        </a:rPr>
+                        <a:t>3   report and code</a:t>
+                      </a:r>
+                      <a:endParaRPr lang="en-US" sz="1050" dirty="0"/>
+                    </a:p>
+                  </a:txBody>
+                  <a:tcPr marL="54864" marR="54864" marT="27432" marB="27432" anchor="ctr">
+                    <a:lnL w="12700" cap="flat" cmpd="sng" algn="ctr">
+                      <a:solidFill>
+                        <a:srgbClr val="FFFFFF"/>
+                      </a:solidFill>
+                      <a:prstDash val="solid"/>
+                      <a:round/>
+                      <a:headEnd type="none" w="med" len="med"/>
+                      <a:tailEnd type="none" w="med" len="med"/>
+                    </a:lnL>
+                    <a:lnR w="12700" cap="flat" cmpd="sng" algn="ctr">
+                      <a:solidFill>
+                        <a:srgbClr val="FFFFFF"/>
+                      </a:solidFill>
+                      <a:prstDash val="solid"/>
+                      <a:round/>
+                      <a:headEnd type="none" w="med" len="med"/>
+                      <a:tailEnd type="none" w="med" len="med"/>
+                    </a:lnR>
+                    <a:lnT w="12700" cap="flat" cmpd="sng" algn="ctr">
+                      <a:solidFill>
+                        <a:srgbClr val="FFFFFF"/>
+                      </a:solidFill>
+                      <a:prstDash val="solid"/>
+                      <a:round/>
+                      <a:headEnd type="none" w="med" len="med"/>
+                      <a:tailEnd type="none" w="med" len="med"/>
+                    </a:lnT>
+                    <a:lnB w="12700" cap="flat" cmpd="sng" algn="ctr">
+                      <a:solidFill>
+                        <a:srgbClr val="FFFFFF"/>
+                      </a:solidFill>
+                      <a:prstDash val="solid"/>
+                      <a:round/>
+                      <a:headEnd type="none" w="med" len="med"/>
+                      <a:tailEnd type="none" w="med" len="med"/>
+                    </a:lnB>
+                    <a:solidFill>
+                      <a:srgbClr val="FFFFFF"/>
+                    </a:solidFill>
+                  </a:tcPr>
+                </a:tc>
+                <a:tc>
+                  <a:txBody>
+                    <a:bodyPr/>
+                    <a:lstStyle/>
+                    <a:p>
+                      <a:pPr algn="l" indent="0" marL="0">
+                        <a:buNone/>
+                      </a:pPr>
+                      <a:r>
+                        <a:rPr lang="en-US" sz="1050" b="1" dirty="0">
+                          <a:solidFill>
+                            <a:srgbClr val="E8792B"/>
+                          </a:solidFill>
+                        </a:rPr>
+                        <a:t>partly</a:t>
+                      </a:r>
+                      <a:endParaRPr lang="en-US" sz="1050" dirty="0"/>
+                    </a:p>
+                  </a:txBody>
+                  <a:tcPr marL="54864" marR="54864" marT="27432" marB="27432" anchor="ctr">
+                    <a:lnL w="12700" cap="flat" cmpd="sng" algn="ctr">
+                      <a:solidFill>
+                        <a:srgbClr val="FFFFFF"/>
+                      </a:solidFill>
+                      <a:prstDash val="solid"/>
+                      <a:round/>
+                      <a:headEnd type="none" w="med" len="med"/>
+                      <a:tailEnd type="none" w="med" len="med"/>
+                    </a:lnL>
+                    <a:lnR w="12700" cap="flat" cmpd="sng" algn="ctr">
+                      <a:solidFill>
+                        <a:srgbClr val="FFFFFF"/>
+                      </a:solidFill>
+                      <a:prstDash val="solid"/>
+                      <a:round/>
+                      <a:headEnd type="none" w="med" len="med"/>
+                      <a:tailEnd type="none" w="med" len="med"/>
+                    </a:lnR>
+                    <a:lnT w="12700" cap="flat" cmpd="sng" algn="ctr">
+                      <a:solidFill>
+                        <a:srgbClr val="FFFFFF"/>
+                      </a:solidFill>
+                      <a:prstDash val="solid"/>
+                      <a:round/>
+                      <a:headEnd type="none" w="med" len="med"/>
+                      <a:tailEnd type="none" w="med" len="med"/>
+                    </a:lnT>
+                    <a:lnB w="12700" cap="flat" cmpd="sng" algn="ctr">
+                      <a:solidFill>
+                        <a:srgbClr val="FFFFFF"/>
+                      </a:solidFill>
+                      <a:prstDash val="solid"/>
+                      <a:round/>
+                      <a:headEnd type="none" w="med" len="med"/>
+                      <a:tailEnd type="none" w="med" len="med"/>
+                    </a:lnB>
+                    <a:solidFill>
+                      <a:srgbClr val="FFFFFF"/>
+                    </a:solidFill>
+                  </a:tcPr>
+                </a:tc>
+                <a:tc>
+                  <a:txBody>
+                    <a:bodyPr/>
+                    <a:lstStyle/>
+                    <a:p>
+                      <a:pPr algn="l" indent="0" marL="0">
+                        <a:buNone/>
+                      </a:pPr>
+                      <a:r>
+                        <a:rPr lang="en-US" sz="1050" dirty="0">
+                          <a:solidFill>
+                            <a:srgbClr val="1B2233"/>
+                          </a:solidFill>
+                        </a:rPr>
+                        <a:t>draft exists (74 mm → 70.5); 98 files hard-code /netscratch; no results or models committed</a:t>
+                      </a:r>
+                      <a:endParaRPr lang="en-US" sz="1050" dirty="0"/>
+                    </a:p>
+                  </a:txBody>
+                  <a:tcPr marL="54864" marR="54864" marT="27432" marB="27432" anchor="ctr">
+                    <a:lnL w="12700" cap="flat" cmpd="sng" algn="ctr">
+                      <a:solidFill>
+                        <a:srgbClr val="FFFFFF"/>
+                      </a:solidFill>
+                      <a:prstDash val="solid"/>
+                      <a:round/>
+                      <a:headEnd type="none" w="med" len="med"/>
+                      <a:tailEnd type="none" w="med" len="med"/>
+                    </a:lnL>
+                    <a:lnR w="12700" cap="flat" cmpd="sng" algn="ctr">
+                      <a:solidFill>
+                        <a:srgbClr val="FFFFFF"/>
+                      </a:solidFill>
+                      <a:prstDash val="solid"/>
+                      <a:round/>
+                      <a:headEnd type="none" w="med" len="med"/>
+                      <a:tailEnd type="none" w="med" len="med"/>
+                    </a:lnR>
+                    <a:lnT w="12700" cap="flat" cmpd="sng" algn="ctr">
+                      <a:solidFill>
+                        <a:srgbClr val="FFFFFF"/>
+                      </a:solidFill>
+                      <a:prstDash val="solid"/>
+                      <a:round/>
+                      <a:headEnd type="none" w="med" len="med"/>
+                      <a:tailEnd type="none" w="med" len="med"/>
+                    </a:lnT>
+                    <a:lnB w="12700" cap="flat" cmpd="sng" algn="ctr">
+                      <a:solidFill>
+                        <a:srgbClr val="FFFFFF"/>
+                      </a:solidFill>
+                      <a:prstDash val="solid"/>
+                      <a:round/>
+                      <a:headEnd type="none" w="med" len="med"/>
+                      <a:tailEnd type="none" w="med" len="med"/>
+                    </a:lnB>
+                    <a:solidFill>
+                      <a:srgbClr val="FFFFFF"/>
+                    </a:solidFill>
+                  </a:tcPr>
+                </a:tc>
+                <a:tc>
+                  <a:txBody>
+                    <a:bodyPr/>
+                    <a:lstStyle/>
+                    <a:p>
+                      <a:pPr algn="l" indent="0" marL="0">
+                        <a:buNone/>
+                      </a:pPr>
+                      <a:r>
+                        <a:rPr lang="en-US" sz="1050" dirty="0">
+                          <a:solidFill>
+                            <a:srgbClr val="1B2233"/>
+                          </a:solidFill>
+                        </a:rPr>
+                        <a:t>clean-up list; release models with checksums</a:t>
+                      </a:r>
+                      <a:endParaRPr lang="en-US" sz="1050" dirty="0"/>
+                    </a:p>
+                  </a:txBody>
+                  <a:tcPr marL="54864" marR="54864" marT="27432" marB="27432" anchor="ctr">
+                    <a:lnL w="12700" cap="flat" cmpd="sng" algn="ctr">
+                      <a:solidFill>
+                        <a:srgbClr val="FFFFFF"/>
+                      </a:solidFill>
+                      <a:prstDash val="solid"/>
+                      <a:round/>
+                      <a:headEnd type="none" w="med" len="med"/>
+                      <a:tailEnd type="none" w="med" len="med"/>
+                    </a:lnL>
+                    <a:lnR w="12700" cap="flat" cmpd="sng" algn="ctr">
+                      <a:solidFill>
+                        <a:srgbClr val="FFFFFF"/>
+                      </a:solidFill>
+                      <a:prstDash val="solid"/>
+                      <a:round/>
+                      <a:headEnd type="none" w="med" len="med"/>
+                      <a:tailEnd type="none" w="med" len="med"/>
+                    </a:lnR>
+                    <a:lnT w="12700" cap="flat" cmpd="sng" algn="ctr">
+                      <a:solidFill>
+                        <a:srgbClr val="FFFFFF"/>
+                      </a:solidFill>
+                      <a:prstDash val="solid"/>
+                      <a:round/>
+                      <a:headEnd type="none" w="med" len="med"/>
+                      <a:tailEnd type="none" w="med" len="med"/>
+                    </a:lnT>
+                    <a:lnB w="12700" cap="flat" cmpd="sng" algn="ctr">
+                      <a:solidFill>
+                        <a:srgbClr val="FFFFFF"/>
+                      </a:solidFill>
+                      <a:prstDash val="solid"/>
+                      <a:round/>
+                      <a:headEnd type="none" w="med" len="med"/>
+                      <a:tailEnd type="none" w="med" len="med"/>
+                    </a:lnB>
+                    <a:solidFill>
+                      <a:srgbClr val="FFFFFF"/>
+                    </a:solidFill>
+                  </a:tcPr>
+                </a:tc>
+              </a:tr>
+            </a:tbl>
+          </a:graphicData>
+        </a:graphic>
+      </p:graphicFrame>
+      <p:sp>
+        <p:nvSpPr>
+          <p:cNvPr id="4" name="requirements route"/>
+          <p:cNvSpPr txBox="1"/>
+          <p:nvPr/>
+        </p:nvSpPr>
+        <p:spPr>
+          <a:xfrm>
+            <a:off x="457200" y="4224528"/>
+            <a:ext cx="8229600" cy="457200"/>
+          </a:xfrm>
+          <a:prstGeom prst="rect">
+            <a:avLst/>
+          </a:prstGeom>
+          <a:noFill/>
+          <a:ln/>
+        </p:spPr>
+        <p:txBody>
+          <a:bodyPr wrap="square" lIns="0" tIns="0" rIns="0" bIns="0" rtlCol="0" anchor="t"/>
+          <a:lstStyle/>
+          <a:p>
+            <a:pPr indent="0" marL="0">
+              <a:buNone/>
+            </a:pPr>
+            <a:r>
+              <a:rPr lang="en-US" sz="1200" b="1" dirty="0">
+                <a:solidFill>
+                  <a:srgbClr val="1B2233"/>
+                </a:solidFill>
+              </a:rPr>
+              <a:t>Route for (1b): </a:t>
+            </a:r>
+            <a:r>
+              <a:rPr lang="en-US" sz="1200" dirty="0">
+                <a:solidFill>
+                  <a:schemeClr val="tx1"/>
+                </a:solidFill>
+              </a:rPr>
+              <a:t>ViT-B student distilled from the final model, 3.1× fewer params, 3.2× fewer FLOPs, bar ≤ 1.05× error on both test sets; launch Tue 20 Oct, first result ~8 Nov.</a:t>
+            </a:r>
+            <a:endParaRPr lang="en-US" sz="1200" dirty="0"/>
+          </a:p>
+        </p:txBody>
+      </p:sp>
+      <p:sp>
+        <p:nvSpPr>
+          <p:cNvPr id="25" name="Slide Number Placeholder 0"/>
+          <p:cNvSpPr>
+            <a:spLocks noGrp="1"/>
+          </p:cNvSpPr>
+          <p:nvPr>
+            <p:ph type="sldNum" sz="quarter" idx="4294967295"/>
+          </p:nvPr>
+        </p:nvSpPr>
+        <p:spPr>
+          <a:xfrm>
+            <a:off x="8412480" y="4754880"/>
+            <a:ext cx="457200" cy="274320"/>
+          </a:xfrm>
+          <a:prstGeom prst="rect">
+            <a:avLst/>
+          </a:prstGeom>
+          <a:extLst>
+            <a:ext uri="{C572A759-6A51-4108-AA02-DFA0A04FC94B}">
+              <ma14:wrappingTextBoxFlag xmlns:ma14="http://schemas.microsoft.com/office/mac/drawingml/2011/main" val="0"/>
+            </a:ext>
+          </a:extLst>
+        </p:spPr>
+        <p:txBody>
+          <a:bodyPr lIns="91440" tIns="0" rIns="0" bIns="0" anchor="ctr"/>
+          <a:lstStyle>
+            <a:lvl1pPr>
+              <a:defRPr sz="1000">
+                <a:solidFill>
+                  <a:srgbClr val="7B8794"/>
+                </a:solidFill>
+              </a:defRPr>
+            </a:lvl1pPr>
+          </a:lstStyle>
+          <a:p>
+            <a:pPr algn="l"/>
+            <a:fld id="{F7021451-1387-4CA6-816F-3879F97B5CBC}" type="slidenum">
+              <a:rPr b="0" lang="en-US"/>
+              <a:t>20</a:t>
+            </a:fld>
+            <a:endParaRPr lang="en-US"/>
+          </a:p>
+        </p:txBody>
+      </p:sp>
+    </p:spTree>
+  </p:cSld>
+  <p:clrMapOvr>
+    <a:masterClrMapping/>
+  </p:clrMapOvr>
+</p:sld>
+</file>
+
+<file path=ppt/slides/slide21.xml><?xml version="1.0" encoding="utf-8"?>
+<p:sld xmlns:a="http://schemas.openxmlformats.org/drawingml/2006/main" xmlns:r="http://schemas.openxmlformats.org/officeDocument/2006/relationships" xmlns:p="http://schemas.openxmlformats.org/presentationml/2006/main">
+  <p:cSld name="Slide 21">
+    <p:spTree>
+      <p:nvGrpSpPr>
+        <p:cNvPr id="1" name=""/>
+        <p:cNvGrpSpPr/>
+        <p:nvPr/>
+      </p:nvGrpSpPr>
+      <p:grpSpPr>
+        <a:xfrm>
+          <a:off x="0" y="0"/>
+          <a:ext cx="0" cy="0"/>
+          <a:chOff x="0" y="0"/>
+          <a:chExt cx="0" cy="0"/>
+        </a:xfrm>
+      </p:grpSpPr>
+      <p:sp>
+        <p:nvSpPr>
+          <p:cNvPr id="2" name="Text 0"/>
+          <p:cNvSpPr/>
+          <p:nvPr>
+            <p:ph idx="100" type="title" hasCustomPrompt="1"/>
+          </p:nvPr>
+        </p:nvSpPr>
+        <p:spPr>
+          <a:xfrm>
+            <a:off x="457200" y="320040"/>
+            <a:ext cx="8229600" cy="731520"/>
+          </a:xfrm>
+          <a:prstGeom prst="rect">
+            <a:avLst/>
+          </a:prstGeom>
+          <a:noFill/>
+          <a:ln/>
+        </p:spPr>
+        <p:txBody>
+          <a:bodyPr wrap="square" lIns="0" tIns="0" rIns="0" bIns="0" rtlCol="0" anchor="ctr"/>
+          <a:lstStyle/>
+          <a:p>
+            <a:pPr algn="l" indent="0" marL="0">
+              <a:buNone/>
+            </a:pPr>
+            <a:r>
+              <a:rPr lang="en-US" sz="2700" b="1" dirty="0">
+                <a:solidFill>
+                  <a:schemeClr val="tx1"/>
+                </a:solidFill>
+              </a:rPr>
               <a:t>Backup: before and after, holdout image 579860</a:t>
             </a:r>
             <a:endParaRPr lang="en-US" sz="2700" dirty="0"/>
@@ -17314,7 +19694,7 @@
             <a:pPr algn="l"/>
             <a:fld id="{F7021451-1387-4CA6-816F-3879F97B5CBC}" type="slidenum">
               <a:rPr b="0" lang="en-US"/>
-              <a:t>20</a:t>
+              <a:t>21</a:t>
             </a:fld>
             <a:endParaRPr lang="en-US"/>
           </a:p>

</xml_diff>